<commit_message>
docs: show seven user messages through forwarding submission
</commit_message>
<xml_diff>
--- a/portfolio/crossborder-portfolio.pptx
+++ b/portfolio/crossborder-portfolio.pptx
@@ -2,27 +2,27 @@
 <file path=ppt/presentation.xml><?xml version="1.0" encoding="utf-8"?>
 <p:presentation xmlns:p="http://schemas.openxmlformats.org/presentationml/2006/main">
   <p:sldMasterIdLst>
-    <p:sldMasterId xmlns:r="http://schemas.openxmlformats.org/officeDocument/2006/relationships" id="2147483648" r:id="Rf6a77dd39ea54a5a"/>
+    <p:sldMasterId xmlns:r="http://schemas.openxmlformats.org/officeDocument/2006/relationships" id="2147483648" r:id="Rec3a7286720e4cbb"/>
   </p:sldMasterIdLst>
   <p:notesMasterIdLst>
-    <p:notesMasterId xmlns:r="http://schemas.openxmlformats.org/officeDocument/2006/relationships" r:id="R235e855da3b24f0e"/>
+    <p:notesMasterId xmlns:r="http://schemas.openxmlformats.org/officeDocument/2006/relationships" r:id="R5580f0fe99074d1e"/>
   </p:notesMasterIdLst>
   <p:sldIdLst>
-    <p:sldId xmlns:r="http://schemas.openxmlformats.org/officeDocument/2006/relationships" id="256" r:id="Rc878dbb7dc804cfe"/>
-    <p:sldId xmlns:r="http://schemas.openxmlformats.org/officeDocument/2006/relationships" id="257" r:id="Rb4898965b5904b0f"/>
-    <p:sldId xmlns:r="http://schemas.openxmlformats.org/officeDocument/2006/relationships" id="258" r:id="Ref38315cf6aa4648"/>
-    <p:sldId xmlns:r="http://schemas.openxmlformats.org/officeDocument/2006/relationships" id="259" r:id="R179ca90f4ee64db2"/>
-    <p:sldId xmlns:r="http://schemas.openxmlformats.org/officeDocument/2006/relationships" id="260" r:id="Rf9765ddf2066452a"/>
-    <p:sldId xmlns:r="http://schemas.openxmlformats.org/officeDocument/2006/relationships" id="261" r:id="R883ce6b4af624398"/>
-    <p:sldId xmlns:r="http://schemas.openxmlformats.org/officeDocument/2006/relationships" id="262" r:id="R053997220491421a"/>
-    <p:sldId xmlns:r="http://schemas.openxmlformats.org/officeDocument/2006/relationships" id="263" r:id="R0893137cc9934591"/>
-    <p:sldId xmlns:r="http://schemas.openxmlformats.org/officeDocument/2006/relationships" id="264" r:id="R9020e5073e5a44e5"/>
-    <p:sldId xmlns:r="http://schemas.openxmlformats.org/officeDocument/2006/relationships" id="265" r:id="R02bfb94498524d7d"/>
-    <p:sldId xmlns:r="http://schemas.openxmlformats.org/officeDocument/2006/relationships" id="266" r:id="R7959124963fc49b7"/>
-    <p:sldId xmlns:r="http://schemas.openxmlformats.org/officeDocument/2006/relationships" id="267" r:id="R12d0ea5d9b984258"/>
-    <p:sldId xmlns:r="http://schemas.openxmlformats.org/officeDocument/2006/relationships" id="268" r:id="R60c118b90c8144f6"/>
-    <p:sldId xmlns:r="http://schemas.openxmlformats.org/officeDocument/2006/relationships" id="269" r:id="Rfa5f0ae27f554751"/>
-    <p:sldId xmlns:r="http://schemas.openxmlformats.org/officeDocument/2006/relationships" id="270" r:id="R691dd550e88d4559"/>
+    <p:sldId xmlns:r="http://schemas.openxmlformats.org/officeDocument/2006/relationships" id="256" r:id="R7d2519d1259b4d9d"/>
+    <p:sldId xmlns:r="http://schemas.openxmlformats.org/officeDocument/2006/relationships" id="257" r:id="R26a0be585e674edf"/>
+    <p:sldId xmlns:r="http://schemas.openxmlformats.org/officeDocument/2006/relationships" id="258" r:id="R6fe64ba567c748d5"/>
+    <p:sldId xmlns:r="http://schemas.openxmlformats.org/officeDocument/2006/relationships" id="259" r:id="Rf73c24bd2a5a474f"/>
+    <p:sldId xmlns:r="http://schemas.openxmlformats.org/officeDocument/2006/relationships" id="260" r:id="Rba7751a71c9a4e5a"/>
+    <p:sldId xmlns:r="http://schemas.openxmlformats.org/officeDocument/2006/relationships" id="261" r:id="R415823e4ee174a8b"/>
+    <p:sldId xmlns:r="http://schemas.openxmlformats.org/officeDocument/2006/relationships" id="262" r:id="Red15072ab7004273"/>
+    <p:sldId xmlns:r="http://schemas.openxmlformats.org/officeDocument/2006/relationships" id="263" r:id="R4ebebd0e3a7e4108"/>
+    <p:sldId xmlns:r="http://schemas.openxmlformats.org/officeDocument/2006/relationships" id="264" r:id="R6c654364fa024a24"/>
+    <p:sldId xmlns:r="http://schemas.openxmlformats.org/officeDocument/2006/relationships" id="265" r:id="Ra89bf995026144de"/>
+    <p:sldId xmlns:r="http://schemas.openxmlformats.org/officeDocument/2006/relationships" id="266" r:id="Rf5ac29757d8142f0"/>
+    <p:sldId xmlns:r="http://schemas.openxmlformats.org/officeDocument/2006/relationships" id="267" r:id="R03263f1a96934bab"/>
+    <p:sldId xmlns:r="http://schemas.openxmlformats.org/officeDocument/2006/relationships" id="268" r:id="R7367dd74a4804e74"/>
+    <p:sldId xmlns:r="http://schemas.openxmlformats.org/officeDocument/2006/relationships" id="269" r:id="R2cd1fd4bf74840a1"/>
+    <p:sldId xmlns:r="http://schemas.openxmlformats.org/officeDocument/2006/relationships" id="270" r:id="R8dc9228078084719"/>
   </p:sldIdLst>
   <p:sldSz cx="15240000" cy="8572500"/>
   <p:notesSz cx="6858000" cy="9144000"/>
@@ -1436,7 +1436,7 @@
           <a:lstStyle xmlns:a="http://schemas.openxmlformats.org/drawingml/2006/main"/>
           <a:p xmlns:a="http://schemas.openxmlformats.org/drawingml/2006/main">
             <a:r>
-              <a:t>https://github.com/y00nZZang/crossborder-purchase-agent/blob/main/docs/experiment.md . 사용자 제공 접수 캡처는 개인정보 없는 부분만 사용, 원본 우측 잘림 유지.</a:t>
+              <a:t>https://github.com/y00nZZang/crossborder-purchase-agent/blob/main/docs/interaction-count.md ; https://github.com/y00nZZang/crossborder-purchase-agent/blob/main/docs/experiment.md . 2026-10-05 실험 전체 7개 사용자 메시지 대조. 대화 횟수이며 브라우저 클릭/입력 횟수와 다름.</a:t>
             </a:r>
           </a:p>
         </p:txBody>
@@ -1504,7 +1504,7 @@
   </p:cSld>
   <p:clrMap bg1="lt1" tx1="dk1" bg2="lt2" tx2="dk2" accent1="accent1" accent2="accent2" accent3="accent3" accent4="accent4" accent5="accent5" accent6="accent6" hlink="hlink" folHlink="folHlink"/>
   <p:sldLayoutIdLst>
-    <p:sldLayoutId xmlns:r="http://schemas.openxmlformats.org/officeDocument/2006/relationships" id="2147483649" r:id="R29e9ea77925545a5"/>
+    <p:sldLayoutId xmlns:r="http://schemas.openxmlformats.org/officeDocument/2006/relationships" id="2147483649" r:id="Rb0203e6b9fda4537"/>
   </p:sldLayoutIdLst>
   <p:txStyles>
     <p:titleStyle>
@@ -2055,7 +2055,7 @@
           <p:cNvPr id="7" name="">
             <a:extLst xmlns:a="http://schemas.openxmlformats.org/drawingml/2006/main">
               <a:ext uri="{FF2B5EF4-FFF2-40B4-BE49-F238E27FC236}">
-                <a16:creationId xmlns:a16="http://schemas.microsoft.com/office/drawing/2014/main" id="{33519701-A87A-40DA-9A80-69F7C4D5C45E}"/>
+                <a16:creationId xmlns:a16="http://schemas.microsoft.com/office/drawing/2014/main" id="{7DD0B419-3A2D-43A2-9D68-0B0946F2BAAC}"/>
               </a:ext>
             </a:extLst>
           </p:cNvPr>
@@ -2094,7 +2094,7 @@
           <p:cNvPr id="2" name="">
             <a:extLst xmlns:a="http://schemas.openxmlformats.org/drawingml/2006/main">
               <a:ext uri="{FF2B5EF4-FFF2-40B4-BE49-F238E27FC236}">
-                <a16:creationId xmlns:a16="http://schemas.microsoft.com/office/drawing/2014/main" id="{17A0A623-76DE-4DD2-A087-9F1766C990D2}"/>
+                <a16:creationId xmlns:a16="http://schemas.microsoft.com/office/drawing/2014/main" id="{AE4718F6-114F-4D2C-95C5-0B7402A9CBBF}"/>
               </a:ext>
             </a:extLst>
           </p:cNvPr>
@@ -2151,7 +2151,7 @@
           <p:cNvPr id="3" name="">
             <a:extLst xmlns:a="http://schemas.openxmlformats.org/drawingml/2006/main">
               <a:ext uri="{FF2B5EF4-FFF2-40B4-BE49-F238E27FC236}">
-                <a16:creationId xmlns:a16="http://schemas.microsoft.com/office/drawing/2014/main" id="{81115C5E-0149-47DC-948A-C107710BD2AF}"/>
+                <a16:creationId xmlns:a16="http://schemas.microsoft.com/office/drawing/2014/main" id="{5589577B-0197-4D94-BA8B-E9553AFA4894}"/>
               </a:ext>
             </a:extLst>
           </p:cNvPr>
@@ -2208,7 +2208,7 @@
           <p:cNvPr id="4" name="">
             <a:extLst xmlns:a="http://schemas.openxmlformats.org/drawingml/2006/main">
               <a:ext uri="{FF2B5EF4-FFF2-40B4-BE49-F238E27FC236}">
-                <a16:creationId xmlns:a16="http://schemas.microsoft.com/office/drawing/2014/main" id="{66AAD7BE-1774-4CFA-98B2-5E52F02307E2}"/>
+                <a16:creationId xmlns:a16="http://schemas.microsoft.com/office/drawing/2014/main" id="{2147DDF1-F063-4624-B8FA-3D4ACDD15B3C}"/>
               </a:ext>
             </a:extLst>
           </p:cNvPr>
@@ -2288,7 +2288,7 @@
           <p:cNvPr id="5" name="">
             <a:extLst xmlns:a="http://schemas.openxmlformats.org/drawingml/2006/main">
               <a:ext uri="{FF2B5EF4-FFF2-40B4-BE49-F238E27FC236}">
-                <a16:creationId xmlns:a16="http://schemas.microsoft.com/office/drawing/2014/main" id="{B6F48A62-1ACF-4365-AEE7-0B929DC2D1FB}"/>
+                <a16:creationId xmlns:a16="http://schemas.microsoft.com/office/drawing/2014/main" id="{5AB1F8F9-0EF8-476A-94C0-89BACC7C4DFD}"/>
               </a:ext>
             </a:extLst>
           </p:cNvPr>
@@ -2345,7 +2345,7 @@
           <p:cNvPr id="6" name="">
             <a:extLst xmlns:a="http://schemas.openxmlformats.org/drawingml/2006/main">
               <a:ext uri="{FF2B5EF4-FFF2-40B4-BE49-F238E27FC236}">
-                <a16:creationId xmlns:a16="http://schemas.microsoft.com/office/drawing/2014/main" id="{C1565007-935E-447D-BD1B-0564D7397EFE}"/>
+                <a16:creationId xmlns:a16="http://schemas.microsoft.com/office/drawing/2014/main" id="{B411EBA6-9887-4982-9648-2D362684C376}"/>
               </a:ext>
             </a:extLst>
           </p:cNvPr>
@@ -2400,7 +2400,7 @@
     </p:spTree>
     <p:extLst>
       <p:ext uri="{BB962C8B-B14F-4D97-AF65-F5344CB8AC3E}">
-        <p14:creationId xmlns:p14="http://schemas.microsoft.com/office/powerpoint/2010/main" val="1881182376"/>
+        <p14:creationId xmlns:p14="http://schemas.microsoft.com/office/powerpoint/2010/main" val="449387218"/>
       </p:ext>
     </p:extLst>
   </p:cSld>
@@ -2431,7 +2431,7 @@
           <p:cNvPr id="14" name="">
             <a:extLst xmlns:a="http://schemas.openxmlformats.org/drawingml/2006/main">
               <a:ext uri="{FF2B5EF4-FFF2-40B4-BE49-F238E27FC236}">
-                <a16:creationId xmlns:a16="http://schemas.microsoft.com/office/drawing/2014/main" id="{A928D55A-47D2-4209-B56D-CAB2CA6629F5}"/>
+                <a16:creationId xmlns:a16="http://schemas.microsoft.com/office/drawing/2014/main" id="{0B878EF3-093C-4A84-9880-4DCBC8E7ECED}"/>
               </a:ext>
             </a:extLst>
           </p:cNvPr>
@@ -2488,7 +2488,7 @@
           <p:cNvPr id="2" name="">
             <a:extLst xmlns:a="http://schemas.openxmlformats.org/drawingml/2006/main">
               <a:ext uri="{FF2B5EF4-FFF2-40B4-BE49-F238E27FC236}">
-                <a16:creationId xmlns:a16="http://schemas.microsoft.com/office/drawing/2014/main" id="{243A76A5-9037-473E-9DB7-72AD8BF2EDEF}"/>
+                <a16:creationId xmlns:a16="http://schemas.microsoft.com/office/drawing/2014/main" id="{AD2680A1-985D-495C-85E7-FD886581E543}"/>
               </a:ext>
             </a:extLst>
           </p:cNvPr>
@@ -2545,7 +2545,7 @@
           <p:cNvPr id="3" name="">
             <a:extLst xmlns:a="http://schemas.openxmlformats.org/drawingml/2006/main">
               <a:ext uri="{FF2B5EF4-FFF2-40B4-BE49-F238E27FC236}">
-                <a16:creationId xmlns:a16="http://schemas.microsoft.com/office/drawing/2014/main" id="{E47605EE-E15A-4C90-B578-4DFF0CE878D2}"/>
+                <a16:creationId xmlns:a16="http://schemas.microsoft.com/office/drawing/2014/main" id="{522DF855-7D6C-4B83-8ABC-63FF4656750F}"/>
               </a:ext>
             </a:extLst>
           </p:cNvPr>
@@ -2602,7 +2602,7 @@
           <p:cNvPr id="4" name="">
             <a:extLst xmlns:a="http://schemas.openxmlformats.org/drawingml/2006/main">
               <a:ext uri="{FF2B5EF4-FFF2-40B4-BE49-F238E27FC236}">
-                <a16:creationId xmlns:a16="http://schemas.microsoft.com/office/drawing/2014/main" id="{56CCCF8F-0E39-4FE8-A996-633B00910392}"/>
+                <a16:creationId xmlns:a16="http://schemas.microsoft.com/office/drawing/2014/main" id="{B70D97EB-7742-4294-B77A-89CEBDA2E79C}"/>
               </a:ext>
             </a:extLst>
           </p:cNvPr>
@@ -2661,7 +2661,7 @@
           <p:cNvPr id="5" name="">
             <a:extLst xmlns:a="http://schemas.openxmlformats.org/drawingml/2006/main">
               <a:ext uri="{FF2B5EF4-FFF2-40B4-BE49-F238E27FC236}">
-                <a16:creationId xmlns:a16="http://schemas.microsoft.com/office/drawing/2014/main" id="{F7CD80C0-2B46-43B2-9B97-FD5309B3A72D}"/>
+                <a16:creationId xmlns:a16="http://schemas.microsoft.com/office/drawing/2014/main" id="{6E2A6295-385F-47A8-AFCD-52429944B939}"/>
               </a:ext>
             </a:extLst>
           </p:cNvPr>
@@ -2745,7 +2745,7 @@
           <p:cNvPr id="7" name="">
             <a:extLst xmlns:a="http://schemas.openxmlformats.org/drawingml/2006/main">
               <a:ext uri="{FF2B5EF4-FFF2-40B4-BE49-F238E27FC236}">
-                <a16:creationId xmlns:a16="http://schemas.microsoft.com/office/drawing/2014/main" id="{1DDFD1E1-EB80-4CA1-9322-F7FEB70D1FC2}"/>
+                <a16:creationId xmlns:a16="http://schemas.microsoft.com/office/drawing/2014/main" id="{DCF07F4B-C2DA-48C2-9325-ACF63E0DC7F8}"/>
               </a:ext>
             </a:extLst>
           </p:cNvPr>
@@ -2829,7 +2829,7 @@
           <p:cNvPr id="9" name="">
             <a:extLst xmlns:a="http://schemas.openxmlformats.org/drawingml/2006/main">
               <a:ext uri="{FF2B5EF4-FFF2-40B4-BE49-F238E27FC236}">
-                <a16:creationId xmlns:a16="http://schemas.microsoft.com/office/drawing/2014/main" id="{11C5F305-E179-4329-9820-B0BA321F6453}"/>
+                <a16:creationId xmlns:a16="http://schemas.microsoft.com/office/drawing/2014/main" id="{4F033A5B-EAC2-4CA1-8BE1-E9AE6635D6EB}"/>
               </a:ext>
             </a:extLst>
           </p:cNvPr>
@@ -2909,7 +2909,7 @@
           <p:cNvPr id="10" name="">
             <a:extLst xmlns:a="http://schemas.openxmlformats.org/drawingml/2006/main">
               <a:ext uri="{FF2B5EF4-FFF2-40B4-BE49-F238E27FC236}">
-                <a16:creationId xmlns:a16="http://schemas.microsoft.com/office/drawing/2014/main" id="{BF09D088-24E0-41F7-BEC4-C624B7CFBE59}"/>
+                <a16:creationId xmlns:a16="http://schemas.microsoft.com/office/drawing/2014/main" id="{867DBF32-F81B-4629-812E-2798E9B24723}"/>
               </a:ext>
             </a:extLst>
           </p:cNvPr>
@@ -2989,7 +2989,7 @@
           <p:cNvPr id="11" name="">
             <a:extLst xmlns:a="http://schemas.openxmlformats.org/drawingml/2006/main">
               <a:ext uri="{FF2B5EF4-FFF2-40B4-BE49-F238E27FC236}">
-                <a16:creationId xmlns:a16="http://schemas.microsoft.com/office/drawing/2014/main" id="{EFA3A153-841F-4F7D-A567-D71C70D3F40A}"/>
+                <a16:creationId xmlns:a16="http://schemas.microsoft.com/office/drawing/2014/main" id="{C9702B20-0370-4F56-9ECF-BC458A3989E0}"/>
               </a:ext>
             </a:extLst>
           </p:cNvPr>
@@ -3069,7 +3069,7 @@
           <p:cNvPr id="12" name="">
             <a:extLst xmlns:a="http://schemas.openxmlformats.org/drawingml/2006/main">
               <a:ext uri="{FF2B5EF4-FFF2-40B4-BE49-F238E27FC236}">
-                <a16:creationId xmlns:a16="http://schemas.microsoft.com/office/drawing/2014/main" id="{027AA439-9149-480F-834C-DFC95B783A4B}"/>
+                <a16:creationId xmlns:a16="http://schemas.microsoft.com/office/drawing/2014/main" id="{FDE0E0AE-C5A9-4116-A25E-3E3427D722BF}"/>
               </a:ext>
             </a:extLst>
           </p:cNvPr>
@@ -3149,7 +3149,7 @@
           <p:cNvPr id="13" name="">
             <a:extLst xmlns:a="http://schemas.openxmlformats.org/drawingml/2006/main">
               <a:ext uri="{FF2B5EF4-FFF2-40B4-BE49-F238E27FC236}">
-                <a16:creationId xmlns:a16="http://schemas.microsoft.com/office/drawing/2014/main" id="{05C9249C-293D-4E41-8D22-FC1AA8D74DBB}"/>
+                <a16:creationId xmlns:a16="http://schemas.microsoft.com/office/drawing/2014/main" id="{A92853C2-CB17-4D47-9D8F-9110A1CE939D}"/>
               </a:ext>
             </a:extLst>
           </p:cNvPr>
@@ -3204,7 +3204,7 @@
     </p:spTree>
     <p:extLst>
       <p:ext uri="{BB962C8B-B14F-4D97-AF65-F5344CB8AC3E}">
-        <p14:creationId xmlns:p14="http://schemas.microsoft.com/office/powerpoint/2010/main" val="2009057287"/>
+        <p14:creationId xmlns:p14="http://schemas.microsoft.com/office/powerpoint/2010/main" val="1109217249"/>
       </p:ext>
     </p:extLst>
   </p:cSld>
@@ -3235,7 +3235,7 @@
           <p:cNvPr id="5" name="">
             <a:extLst xmlns:a="http://schemas.openxmlformats.org/drawingml/2006/main">
               <a:ext uri="{FF2B5EF4-FFF2-40B4-BE49-F238E27FC236}">
-                <a16:creationId xmlns:a16="http://schemas.microsoft.com/office/drawing/2014/main" id="{8AC9FD26-E16E-42B4-8A15-AF7C24A7844C}"/>
+                <a16:creationId xmlns:a16="http://schemas.microsoft.com/office/drawing/2014/main" id="{95D88611-0F21-425D-8D2D-F7C9668C499B}"/>
               </a:ext>
             </a:extLst>
           </p:cNvPr>
@@ -3292,7 +3292,7 @@
           <p:cNvPr id="2" name="">
             <a:extLst xmlns:a="http://schemas.openxmlformats.org/drawingml/2006/main">
               <a:ext uri="{FF2B5EF4-FFF2-40B4-BE49-F238E27FC236}">
-                <a16:creationId xmlns:a16="http://schemas.microsoft.com/office/drawing/2014/main" id="{5BD1AEBF-9D0E-4259-89DC-2CFA55A28FE4}"/>
+                <a16:creationId xmlns:a16="http://schemas.microsoft.com/office/drawing/2014/main" id="{0AAFE9F3-D2DD-4E87-A64B-11B6041F42BE}"/>
               </a:ext>
             </a:extLst>
           </p:cNvPr>
@@ -3349,7 +3349,7 @@
           <p:cNvPr id="3" name="">
             <a:extLst xmlns:a="http://schemas.openxmlformats.org/drawingml/2006/main">
               <a:ext uri="{FF2B5EF4-FFF2-40B4-BE49-F238E27FC236}">
-                <a16:creationId xmlns:a16="http://schemas.microsoft.com/office/drawing/2014/main" id="{1200C6D3-571E-4542-B97E-D0F373F0C8CE}"/>
+                <a16:creationId xmlns:a16="http://schemas.microsoft.com/office/drawing/2014/main" id="{29D91381-B611-471D-B8D3-6460B68F489D}"/>
               </a:ext>
             </a:extLst>
           </p:cNvPr>
@@ -3410,7 +3410,7 @@
           <p:nvPr/>
         </p:nvPicPr>
         <p:blipFill>
-          <a:blip xmlns:r="http://schemas.openxmlformats.org/officeDocument/2006/relationships" xmlns:a="http://schemas.openxmlformats.org/drawingml/2006/main" r:embed="Rccc9a69d07154604"/>
+          <a:blip xmlns:r="http://schemas.openxmlformats.org/officeDocument/2006/relationships" xmlns:a="http://schemas.openxmlformats.org/drawingml/2006/main" r:embed="Rfb4782024ea04491"/>
           <a:stretch xmlns:a="http://schemas.openxmlformats.org/drawingml/2006/main"/>
         </p:blipFill>
         <p:spPr>
@@ -3426,7 +3426,7 @@
     </p:spTree>
     <p:extLst>
       <p:ext uri="{BB962C8B-B14F-4D97-AF65-F5344CB8AC3E}">
-        <p14:creationId xmlns:p14="http://schemas.microsoft.com/office/powerpoint/2010/main" val="976556152"/>
+        <p14:creationId xmlns:p14="http://schemas.microsoft.com/office/powerpoint/2010/main" val="455565903"/>
       </p:ext>
     </p:extLst>
   </p:cSld>
@@ -3457,7 +3457,7 @@
           <p:cNvPr id="14" name="">
             <a:extLst xmlns:a="http://schemas.openxmlformats.org/drawingml/2006/main">
               <a:ext uri="{FF2B5EF4-FFF2-40B4-BE49-F238E27FC236}">
-                <a16:creationId xmlns:a16="http://schemas.microsoft.com/office/drawing/2014/main" id="{45F79BA2-0458-46BC-9C4C-234ABABD1EA4}"/>
+                <a16:creationId xmlns:a16="http://schemas.microsoft.com/office/drawing/2014/main" id="{165AAE43-C496-49D3-BCF0-11F20A058924}"/>
               </a:ext>
             </a:extLst>
           </p:cNvPr>
@@ -3514,7 +3514,7 @@
           <p:cNvPr id="2" name="">
             <a:extLst xmlns:a="http://schemas.openxmlformats.org/drawingml/2006/main">
               <a:ext uri="{FF2B5EF4-FFF2-40B4-BE49-F238E27FC236}">
-                <a16:creationId xmlns:a16="http://schemas.microsoft.com/office/drawing/2014/main" id="{40D7750D-C0B6-4B51-A6DA-026D18BE8831}"/>
+                <a16:creationId xmlns:a16="http://schemas.microsoft.com/office/drawing/2014/main" id="{311564C2-9FDD-4077-9349-59FCE4988BD4}"/>
               </a:ext>
             </a:extLst>
           </p:cNvPr>
@@ -3571,7 +3571,7 @@
           <p:cNvPr id="3" name="">
             <a:extLst xmlns:a="http://schemas.openxmlformats.org/drawingml/2006/main">
               <a:ext uri="{FF2B5EF4-FFF2-40B4-BE49-F238E27FC236}">
-                <a16:creationId xmlns:a16="http://schemas.microsoft.com/office/drawing/2014/main" id="{514D23D4-3466-4FDC-B847-BF5EAAB4135D}"/>
+                <a16:creationId xmlns:a16="http://schemas.microsoft.com/office/drawing/2014/main" id="{6B1F1F0D-A056-473C-9136-92D454668F94}"/>
               </a:ext>
             </a:extLst>
           </p:cNvPr>
@@ -3628,7 +3628,7 @@
           <p:cNvPr id="4" name="">
             <a:extLst xmlns:a="http://schemas.openxmlformats.org/drawingml/2006/main">
               <a:ext uri="{FF2B5EF4-FFF2-40B4-BE49-F238E27FC236}">
-                <a16:creationId xmlns:a16="http://schemas.microsoft.com/office/drawing/2014/main" id="{0EAE6C4F-206A-4CB9-ACF4-E2BA0C5E2A60}"/>
+                <a16:creationId xmlns:a16="http://schemas.microsoft.com/office/drawing/2014/main" id="{C08E0F51-BCDA-4D24-B4AC-59F1CA78EE4B}"/>
               </a:ext>
             </a:extLst>
           </p:cNvPr>
@@ -3687,7 +3687,7 @@
           <p:cNvPr id="5" name="">
             <a:extLst xmlns:a="http://schemas.openxmlformats.org/drawingml/2006/main">
               <a:ext uri="{FF2B5EF4-FFF2-40B4-BE49-F238E27FC236}">
-                <a16:creationId xmlns:a16="http://schemas.microsoft.com/office/drawing/2014/main" id="{8493D37F-6512-4CDC-964E-73CAD18F2DF2}"/>
+                <a16:creationId xmlns:a16="http://schemas.microsoft.com/office/drawing/2014/main" id="{73515030-1049-4663-99FD-B3481C35CF65}"/>
               </a:ext>
             </a:extLst>
           </p:cNvPr>
@@ -3771,7 +3771,7 @@
           <p:cNvPr id="7" name="">
             <a:extLst xmlns:a="http://schemas.openxmlformats.org/drawingml/2006/main">
               <a:ext uri="{FF2B5EF4-FFF2-40B4-BE49-F238E27FC236}">
-                <a16:creationId xmlns:a16="http://schemas.microsoft.com/office/drawing/2014/main" id="{A475AB62-E257-4961-8D70-6951442D5BB6}"/>
+                <a16:creationId xmlns:a16="http://schemas.microsoft.com/office/drawing/2014/main" id="{37AE88A0-6F54-4637-B311-1905D658CC91}"/>
               </a:ext>
             </a:extLst>
           </p:cNvPr>
@@ -3855,7 +3855,7 @@
           <p:cNvPr id="9" name="">
             <a:extLst xmlns:a="http://schemas.openxmlformats.org/drawingml/2006/main">
               <a:ext uri="{FF2B5EF4-FFF2-40B4-BE49-F238E27FC236}">
-                <a16:creationId xmlns:a16="http://schemas.microsoft.com/office/drawing/2014/main" id="{D07B0221-3D3A-4F39-9629-2A062D5C76DB}"/>
+                <a16:creationId xmlns:a16="http://schemas.microsoft.com/office/drawing/2014/main" id="{63532A6A-0142-4348-9A22-DDDED7E78E01}"/>
               </a:ext>
             </a:extLst>
           </p:cNvPr>
@@ -3935,7 +3935,7 @@
           <p:cNvPr id="10" name="">
             <a:extLst xmlns:a="http://schemas.openxmlformats.org/drawingml/2006/main">
               <a:ext uri="{FF2B5EF4-FFF2-40B4-BE49-F238E27FC236}">
-                <a16:creationId xmlns:a16="http://schemas.microsoft.com/office/drawing/2014/main" id="{71EA7306-E9AD-49F1-BFD0-F1AA11DA1945}"/>
+                <a16:creationId xmlns:a16="http://schemas.microsoft.com/office/drawing/2014/main" id="{DCFB9793-5FAC-4ACF-AB00-B54E77F33738}"/>
               </a:ext>
             </a:extLst>
           </p:cNvPr>
@@ -4015,7 +4015,7 @@
           <p:cNvPr id="11" name="">
             <a:extLst xmlns:a="http://schemas.openxmlformats.org/drawingml/2006/main">
               <a:ext uri="{FF2B5EF4-FFF2-40B4-BE49-F238E27FC236}">
-                <a16:creationId xmlns:a16="http://schemas.microsoft.com/office/drawing/2014/main" id="{6C0C479A-AA58-4A8B-BE5F-DB5B8FEFE50A}"/>
+                <a16:creationId xmlns:a16="http://schemas.microsoft.com/office/drawing/2014/main" id="{A14A0A87-42ED-479D-861E-F22906103DD3}"/>
               </a:ext>
             </a:extLst>
           </p:cNvPr>
@@ -4095,7 +4095,7 @@
           <p:cNvPr id="12" name="">
             <a:extLst xmlns:a="http://schemas.openxmlformats.org/drawingml/2006/main">
               <a:ext uri="{FF2B5EF4-FFF2-40B4-BE49-F238E27FC236}">
-                <a16:creationId xmlns:a16="http://schemas.microsoft.com/office/drawing/2014/main" id="{20F095D9-9F6E-4961-A16C-787ADC42B320}"/>
+                <a16:creationId xmlns:a16="http://schemas.microsoft.com/office/drawing/2014/main" id="{E593F05A-5EC0-4F24-9B70-BC72C6AB7EF5}"/>
               </a:ext>
             </a:extLst>
           </p:cNvPr>
@@ -4152,7 +4152,7 @@
           <p:cNvPr id="13" name="">
             <a:extLst xmlns:a="http://schemas.openxmlformats.org/drawingml/2006/main">
               <a:ext uri="{FF2B5EF4-FFF2-40B4-BE49-F238E27FC236}">
-                <a16:creationId xmlns:a16="http://schemas.microsoft.com/office/drawing/2014/main" id="{D86759CB-B32D-46D0-B3ED-1704532A938E}"/>
+                <a16:creationId xmlns:a16="http://schemas.microsoft.com/office/drawing/2014/main" id="{FA7234DE-C5FF-49A3-9001-4D39362DDB44}"/>
               </a:ext>
             </a:extLst>
           </p:cNvPr>
@@ -4207,7 +4207,7 @@
     </p:spTree>
     <p:extLst>
       <p:ext uri="{BB962C8B-B14F-4D97-AF65-F5344CB8AC3E}">
-        <p14:creationId xmlns:p14="http://schemas.microsoft.com/office/powerpoint/2010/main" val="1341919492"/>
+        <p14:creationId xmlns:p14="http://schemas.microsoft.com/office/powerpoint/2010/main" val="1236444448"/>
       </p:ext>
     </p:extLst>
   </p:cSld>
@@ -4238,7 +4238,7 @@
           <p:cNvPr id="7" name="">
             <a:extLst xmlns:a="http://schemas.openxmlformats.org/drawingml/2006/main">
               <a:ext uri="{FF2B5EF4-FFF2-40B4-BE49-F238E27FC236}">
-                <a16:creationId xmlns:a16="http://schemas.microsoft.com/office/drawing/2014/main" id="{C5A108F9-F470-44A0-8E81-435D3F0E92F4}"/>
+                <a16:creationId xmlns:a16="http://schemas.microsoft.com/office/drawing/2014/main" id="{C4B077D1-F806-43AE-A463-CAD8A8632846}"/>
               </a:ext>
             </a:extLst>
           </p:cNvPr>
@@ -4295,7 +4295,7 @@
           <p:cNvPr id="2" name="">
             <a:extLst xmlns:a="http://schemas.openxmlformats.org/drawingml/2006/main">
               <a:ext uri="{FF2B5EF4-FFF2-40B4-BE49-F238E27FC236}">
-                <a16:creationId xmlns:a16="http://schemas.microsoft.com/office/drawing/2014/main" id="{D80D3642-996A-4D65-ABA6-D824F5C64650}"/>
+                <a16:creationId xmlns:a16="http://schemas.microsoft.com/office/drawing/2014/main" id="{69B5D373-01EA-486F-84AA-E08B88C71973}"/>
               </a:ext>
             </a:extLst>
           </p:cNvPr>
@@ -4352,7 +4352,7 @@
           <p:cNvPr id="3" name="">
             <a:extLst xmlns:a="http://schemas.openxmlformats.org/drawingml/2006/main">
               <a:ext uri="{FF2B5EF4-FFF2-40B4-BE49-F238E27FC236}">
-                <a16:creationId xmlns:a16="http://schemas.microsoft.com/office/drawing/2014/main" id="{B930E1E3-320C-4C7B-AE06-FE5DE91A1E8F}"/>
+                <a16:creationId xmlns:a16="http://schemas.microsoft.com/office/drawing/2014/main" id="{A981201C-BFF7-4642-AA29-2780D59B700C}"/>
               </a:ext>
             </a:extLst>
           </p:cNvPr>
@@ -4728,7 +4728,7 @@
           <p:cNvPr id="5" name="">
             <a:extLst xmlns:a="http://schemas.openxmlformats.org/drawingml/2006/main">
               <a:ext uri="{FF2B5EF4-FFF2-40B4-BE49-F238E27FC236}">
-                <a16:creationId xmlns:a16="http://schemas.microsoft.com/office/drawing/2014/main" id="{C8F45D51-543A-4719-9A25-C5E016B90E28}"/>
+                <a16:creationId xmlns:a16="http://schemas.microsoft.com/office/drawing/2014/main" id="{F9D018D9-7781-4109-A6AF-B270144574D5}"/>
               </a:ext>
             </a:extLst>
           </p:cNvPr>
@@ -4808,7 +4808,7 @@
           <p:cNvPr id="6" name="">
             <a:extLst xmlns:a="http://schemas.openxmlformats.org/drawingml/2006/main">
               <a:ext uri="{FF2B5EF4-FFF2-40B4-BE49-F238E27FC236}">
-                <a16:creationId xmlns:a16="http://schemas.microsoft.com/office/drawing/2014/main" id="{7A0BD913-CE43-4A5C-8FCA-43FBD4E1DA43}"/>
+                <a16:creationId xmlns:a16="http://schemas.microsoft.com/office/drawing/2014/main" id="{D1ADE3CF-4E5E-42B8-9983-B535B93C389F}"/>
               </a:ext>
             </a:extLst>
           </p:cNvPr>
@@ -4863,7 +4863,7 @@
     </p:spTree>
     <p:extLst>
       <p:ext uri="{BB962C8B-B14F-4D97-AF65-F5344CB8AC3E}">
-        <p14:creationId xmlns:p14="http://schemas.microsoft.com/office/powerpoint/2010/main" val="1746554938"/>
+        <p14:creationId xmlns:p14="http://schemas.microsoft.com/office/powerpoint/2010/main" val="1224195892"/>
       </p:ext>
     </p:extLst>
   </p:cSld>
@@ -4894,7 +4894,7 @@
           <p:cNvPr id="6" name="">
             <a:extLst xmlns:a="http://schemas.openxmlformats.org/drawingml/2006/main">
               <a:ext uri="{FF2B5EF4-FFF2-40B4-BE49-F238E27FC236}">
-                <a16:creationId xmlns:a16="http://schemas.microsoft.com/office/drawing/2014/main" id="{9C368E21-BD03-4A76-87F7-E65062D2E45E}"/>
+                <a16:creationId xmlns:a16="http://schemas.microsoft.com/office/drawing/2014/main" id="{F1073803-2602-4A22-B148-851AC33DFAF0}"/>
               </a:ext>
             </a:extLst>
           </p:cNvPr>
@@ -4951,7 +4951,7 @@
           <p:cNvPr id="2" name="">
             <a:extLst xmlns:a="http://schemas.openxmlformats.org/drawingml/2006/main">
               <a:ext uri="{FF2B5EF4-FFF2-40B4-BE49-F238E27FC236}">
-                <a16:creationId xmlns:a16="http://schemas.microsoft.com/office/drawing/2014/main" id="{813991E8-E284-4C04-B52E-802A68FA72A9}"/>
+                <a16:creationId xmlns:a16="http://schemas.microsoft.com/office/drawing/2014/main" id="{5DCB9DF9-3E98-450E-A761-7D51FE1139E1}"/>
               </a:ext>
             </a:extLst>
           </p:cNvPr>
@@ -5008,7 +5008,7 @@
           <p:cNvPr id="3" name="">
             <a:extLst xmlns:a="http://schemas.openxmlformats.org/drawingml/2006/main">
               <a:ext uri="{FF2B5EF4-FFF2-40B4-BE49-F238E27FC236}">
-                <a16:creationId xmlns:a16="http://schemas.microsoft.com/office/drawing/2014/main" id="{35D793A3-E57D-424B-88A4-97E47C23A097}"/>
+                <a16:creationId xmlns:a16="http://schemas.microsoft.com/office/drawing/2014/main" id="{56B08480-DA9F-4E59-BA77-D63B13747533}"/>
               </a:ext>
             </a:extLst>
           </p:cNvPr>
@@ -5384,7 +5384,7 @@
           <p:cNvPr id="5" name="">
             <a:extLst xmlns:a="http://schemas.openxmlformats.org/drawingml/2006/main">
               <a:ext uri="{FF2B5EF4-FFF2-40B4-BE49-F238E27FC236}">
-                <a16:creationId xmlns:a16="http://schemas.microsoft.com/office/drawing/2014/main" id="{9E4131E0-D0B9-4AA8-89B0-A7DE073D93BE}"/>
+                <a16:creationId xmlns:a16="http://schemas.microsoft.com/office/drawing/2014/main" id="{64498969-DB5D-4DCB-A79D-1849BFB202D7}"/>
               </a:ext>
             </a:extLst>
           </p:cNvPr>
@@ -5462,7 +5462,7 @@
     </p:spTree>
     <p:extLst>
       <p:ext uri="{BB962C8B-B14F-4D97-AF65-F5344CB8AC3E}">
-        <p14:creationId xmlns:p14="http://schemas.microsoft.com/office/powerpoint/2010/main" val="69609799"/>
+        <p14:creationId xmlns:p14="http://schemas.microsoft.com/office/powerpoint/2010/main" val="117059855"/>
       </p:ext>
     </p:extLst>
   </p:cSld>
@@ -5493,7 +5493,7 @@
           <p:cNvPr id="11" name="">
             <a:extLst xmlns:a="http://schemas.openxmlformats.org/drawingml/2006/main">
               <a:ext uri="{FF2B5EF4-FFF2-40B4-BE49-F238E27FC236}">
-                <a16:creationId xmlns:a16="http://schemas.microsoft.com/office/drawing/2014/main" id="{DDC547B1-C10B-4C6E-8EDE-29715794DF11}"/>
+                <a16:creationId xmlns:a16="http://schemas.microsoft.com/office/drawing/2014/main" id="{49017FAE-4DF1-4C0E-9DED-0EE3FF4FE476}"/>
               </a:ext>
             </a:extLst>
           </p:cNvPr>
@@ -5550,7 +5550,7 @@
           <p:cNvPr id="2" name="">
             <a:extLst xmlns:a="http://schemas.openxmlformats.org/drawingml/2006/main">
               <a:ext uri="{FF2B5EF4-FFF2-40B4-BE49-F238E27FC236}">
-                <a16:creationId xmlns:a16="http://schemas.microsoft.com/office/drawing/2014/main" id="{2FB5806B-F40D-4267-8B83-2E36CD2026CD}"/>
+                <a16:creationId xmlns:a16="http://schemas.microsoft.com/office/drawing/2014/main" id="{035C05D0-2B2F-4808-8184-450A281064AE}"/>
               </a:ext>
             </a:extLst>
           </p:cNvPr>
@@ -5607,7 +5607,7 @@
           <p:cNvPr id="3" name="">
             <a:extLst xmlns:a="http://schemas.openxmlformats.org/drawingml/2006/main">
               <a:ext uri="{FF2B5EF4-FFF2-40B4-BE49-F238E27FC236}">
-                <a16:creationId xmlns:a16="http://schemas.microsoft.com/office/drawing/2014/main" id="{9BCAD822-E03E-4D63-9193-A5F2890E10AB}"/>
+                <a16:creationId xmlns:a16="http://schemas.microsoft.com/office/drawing/2014/main" id="{FF394BAC-8B3F-4FA4-9278-222A7E30B33D}"/>
               </a:ext>
             </a:extLst>
           </p:cNvPr>
@@ -5664,7 +5664,7 @@
           <p:cNvPr id="4" name="">
             <a:extLst xmlns:a="http://schemas.openxmlformats.org/drawingml/2006/main">
               <a:ext uri="{FF2B5EF4-FFF2-40B4-BE49-F238E27FC236}">
-                <a16:creationId xmlns:a16="http://schemas.microsoft.com/office/drawing/2014/main" id="{615BDA2B-35F4-4356-836E-F2F370BA2C07}"/>
+                <a16:creationId xmlns:a16="http://schemas.microsoft.com/office/drawing/2014/main" id="{C2FC4F45-0E59-47C5-AC3E-C973B9F23CA7}"/>
               </a:ext>
             </a:extLst>
           </p:cNvPr>
@@ -5721,7 +5721,7 @@
           <p:cNvPr id="5" name="">
             <a:extLst xmlns:a="http://schemas.openxmlformats.org/drawingml/2006/main">
               <a:ext uri="{FF2B5EF4-FFF2-40B4-BE49-F238E27FC236}">
-                <a16:creationId xmlns:a16="http://schemas.microsoft.com/office/drawing/2014/main" id="{A747F7CB-E510-4510-BD44-0A4776CD5390}"/>
+                <a16:creationId xmlns:a16="http://schemas.microsoft.com/office/drawing/2014/main" id="{A70B62A2-B636-4B7B-B214-81A88CB5FE6C}"/>
               </a:ext>
             </a:extLst>
           </p:cNvPr>
@@ -5852,7 +5852,7 @@
           <p:cNvPr id="6" name="">
             <a:extLst xmlns:a="http://schemas.openxmlformats.org/drawingml/2006/main">
               <a:ext uri="{FF2B5EF4-FFF2-40B4-BE49-F238E27FC236}">
-                <a16:creationId xmlns:a16="http://schemas.microsoft.com/office/drawing/2014/main" id="{9063A12F-3304-466E-8192-F06FEFB6967F}"/>
+                <a16:creationId xmlns:a16="http://schemas.microsoft.com/office/drawing/2014/main" id="{6A11AF8C-2D39-4D44-A2EC-6D86123AE9DB}"/>
               </a:ext>
             </a:extLst>
           </p:cNvPr>
@@ -5909,7 +5909,7 @@
           <p:cNvPr id="7" name="">
             <a:extLst xmlns:a="http://schemas.openxmlformats.org/drawingml/2006/main">
               <a:ext uri="{FF2B5EF4-FFF2-40B4-BE49-F238E27FC236}">
-                <a16:creationId xmlns:a16="http://schemas.microsoft.com/office/drawing/2014/main" id="{1E239CBB-3F95-464C-BC08-3334F841F29F}"/>
+                <a16:creationId xmlns:a16="http://schemas.microsoft.com/office/drawing/2014/main" id="{6B9D858F-53A6-4F0A-B368-2A8545FA9812}"/>
               </a:ext>
             </a:extLst>
           </p:cNvPr>
@@ -6040,7 +6040,7 @@
           <p:cNvPr id="8" name="">
             <a:extLst xmlns:a="http://schemas.openxmlformats.org/drawingml/2006/main">
               <a:ext uri="{FF2B5EF4-FFF2-40B4-BE49-F238E27FC236}">
-                <a16:creationId xmlns:a16="http://schemas.microsoft.com/office/drawing/2014/main" id="{33925922-E70F-4954-ACF5-28CF5E0E5CFB}"/>
+                <a16:creationId xmlns:a16="http://schemas.microsoft.com/office/drawing/2014/main" id="{596407B7-7146-4C69-96DD-7B0B101E3B96}"/>
               </a:ext>
             </a:extLst>
           </p:cNvPr>
@@ -6097,7 +6097,7 @@
           <p:cNvPr id="9" name="">
             <a:extLst xmlns:a="http://schemas.openxmlformats.org/drawingml/2006/main">
               <a:ext uri="{FF2B5EF4-FFF2-40B4-BE49-F238E27FC236}">
-                <a16:creationId xmlns:a16="http://schemas.microsoft.com/office/drawing/2014/main" id="{400B46FB-C49D-4A5D-8A93-47F216CA8B45}"/>
+                <a16:creationId xmlns:a16="http://schemas.microsoft.com/office/drawing/2014/main" id="{4D362911-8F15-45ED-AE90-DFB97D4A8714}"/>
               </a:ext>
             </a:extLst>
           </p:cNvPr>
@@ -6154,7 +6154,7 @@
           <p:cNvPr id="10" name="">
             <a:extLst xmlns:a="http://schemas.openxmlformats.org/drawingml/2006/main">
               <a:ext uri="{FF2B5EF4-FFF2-40B4-BE49-F238E27FC236}">
-                <a16:creationId xmlns:a16="http://schemas.microsoft.com/office/drawing/2014/main" id="{EED00AAC-60A8-4164-9EF6-977A6742E623}"/>
+                <a16:creationId xmlns:a16="http://schemas.microsoft.com/office/drawing/2014/main" id="{F42D9EB5-026A-4DA6-A3C6-F1651324FD92}"/>
               </a:ext>
             </a:extLst>
           </p:cNvPr>
@@ -6209,7 +6209,7 @@
     </p:spTree>
     <p:extLst>
       <p:ext uri="{BB962C8B-B14F-4D97-AF65-F5344CB8AC3E}">
-        <p14:creationId xmlns:p14="http://schemas.microsoft.com/office/powerpoint/2010/main" val="945275560"/>
+        <p14:creationId xmlns:p14="http://schemas.microsoft.com/office/powerpoint/2010/main" val="244832897"/>
       </p:ext>
     </p:extLst>
   </p:cSld>
@@ -6240,7 +6240,7 @@
           <p:cNvPr id="9" name="">
             <a:extLst xmlns:a="http://schemas.openxmlformats.org/drawingml/2006/main">
               <a:ext uri="{FF2B5EF4-FFF2-40B4-BE49-F238E27FC236}">
-                <a16:creationId xmlns:a16="http://schemas.microsoft.com/office/drawing/2014/main" id="{59FC53A8-9603-42B7-87FE-A6B588D78E3A}"/>
+                <a16:creationId xmlns:a16="http://schemas.microsoft.com/office/drawing/2014/main" id="{9CFD9667-D5DE-4351-9C40-0611E921E574}"/>
               </a:ext>
             </a:extLst>
           </p:cNvPr>
@@ -6297,7 +6297,7 @@
           <p:cNvPr id="2" name="">
             <a:extLst xmlns:a="http://schemas.openxmlformats.org/drawingml/2006/main">
               <a:ext uri="{FF2B5EF4-FFF2-40B4-BE49-F238E27FC236}">
-                <a16:creationId xmlns:a16="http://schemas.microsoft.com/office/drawing/2014/main" id="{FE45C29D-439C-4F92-9446-520BD1FF3611}"/>
+                <a16:creationId xmlns:a16="http://schemas.microsoft.com/office/drawing/2014/main" id="{A43FDB3A-D358-4DB4-BE7C-AF18D3773A6A}"/>
               </a:ext>
             </a:extLst>
           </p:cNvPr>
@@ -6354,7 +6354,7 @@
           <p:cNvPr id="3" name="">
             <a:extLst xmlns:a="http://schemas.openxmlformats.org/drawingml/2006/main">
               <a:ext uri="{FF2B5EF4-FFF2-40B4-BE49-F238E27FC236}">
-                <a16:creationId xmlns:a16="http://schemas.microsoft.com/office/drawing/2014/main" id="{002F9B71-E754-4B22-A1BA-B4D1B50396A7}"/>
+                <a16:creationId xmlns:a16="http://schemas.microsoft.com/office/drawing/2014/main" id="{A0A5FF60-DDD2-4BA1-A041-BDCF5DE1E942}"/>
               </a:ext>
             </a:extLst>
           </p:cNvPr>
@@ -6411,7 +6411,7 @@
           <p:cNvPr id="4" name="">
             <a:extLst xmlns:a="http://schemas.openxmlformats.org/drawingml/2006/main">
               <a:ext uri="{FF2B5EF4-FFF2-40B4-BE49-F238E27FC236}">
-                <a16:creationId xmlns:a16="http://schemas.microsoft.com/office/drawing/2014/main" id="{618E3736-5D15-4BD1-B109-62BF12160E7B}"/>
+                <a16:creationId xmlns:a16="http://schemas.microsoft.com/office/drawing/2014/main" id="{F9CD7007-6A3D-4FF5-82BA-F03973DB1CEF}"/>
               </a:ext>
             </a:extLst>
           </p:cNvPr>
@@ -6468,7 +6468,7 @@
           <p:cNvPr id="5" name="">
             <a:extLst xmlns:a="http://schemas.openxmlformats.org/drawingml/2006/main">
               <a:ext uri="{FF2B5EF4-FFF2-40B4-BE49-F238E27FC236}">
-                <a16:creationId xmlns:a16="http://schemas.microsoft.com/office/drawing/2014/main" id="{638D4845-44F7-405E-830A-9D3BFA8536CB}"/>
+                <a16:creationId xmlns:a16="http://schemas.microsoft.com/office/drawing/2014/main" id="{731E0907-6E41-4500-8A35-430E68E5DC0B}"/>
               </a:ext>
             </a:extLst>
           </p:cNvPr>
@@ -6571,7 +6571,7 @@
           <p:cNvPr id="6" name="">
             <a:extLst xmlns:a="http://schemas.openxmlformats.org/drawingml/2006/main">
               <a:ext uri="{FF2B5EF4-FFF2-40B4-BE49-F238E27FC236}">
-                <a16:creationId xmlns:a16="http://schemas.microsoft.com/office/drawing/2014/main" id="{C9516AF7-E614-4898-B19A-36F50EB2D336}"/>
+                <a16:creationId xmlns:a16="http://schemas.microsoft.com/office/drawing/2014/main" id="{CF001192-8A59-4D67-9CC2-1F8CAB5B5EAA}"/>
               </a:ext>
             </a:extLst>
           </p:cNvPr>
@@ -6628,7 +6628,7 @@
           <p:cNvPr id="7" name="">
             <a:extLst xmlns:a="http://schemas.openxmlformats.org/drawingml/2006/main">
               <a:ext uri="{FF2B5EF4-FFF2-40B4-BE49-F238E27FC236}">
-                <a16:creationId xmlns:a16="http://schemas.microsoft.com/office/drawing/2014/main" id="{8AC349B4-1086-497F-8479-304465A7BBEC}"/>
+                <a16:creationId xmlns:a16="http://schemas.microsoft.com/office/drawing/2014/main" id="{E31407D0-749F-4DF4-A308-A93FF4028703}"/>
               </a:ext>
             </a:extLst>
           </p:cNvPr>
@@ -6731,7 +6731,7 @@
           <p:cNvPr id="8" name="">
             <a:extLst xmlns:a="http://schemas.openxmlformats.org/drawingml/2006/main">
               <a:ext uri="{FF2B5EF4-FFF2-40B4-BE49-F238E27FC236}">
-                <a16:creationId xmlns:a16="http://schemas.microsoft.com/office/drawing/2014/main" id="{E675354B-F5CE-4D7F-B19A-623BC0A0A03B}"/>
+                <a16:creationId xmlns:a16="http://schemas.microsoft.com/office/drawing/2014/main" id="{34D83A6A-0927-4D46-86D1-8993906DD5DA}"/>
               </a:ext>
             </a:extLst>
           </p:cNvPr>
@@ -6786,7 +6786,7 @@
     </p:spTree>
     <p:extLst>
       <p:ext uri="{BB962C8B-B14F-4D97-AF65-F5344CB8AC3E}">
-        <p14:creationId xmlns:p14="http://schemas.microsoft.com/office/powerpoint/2010/main" val="1587078770"/>
+        <p14:creationId xmlns:p14="http://schemas.microsoft.com/office/powerpoint/2010/main" val="1071246957"/>
       </p:ext>
     </p:extLst>
   </p:cSld>
@@ -6817,7 +6817,7 @@
           <p:cNvPr id="6" name="">
             <a:extLst xmlns:a="http://schemas.openxmlformats.org/drawingml/2006/main">
               <a:ext uri="{FF2B5EF4-FFF2-40B4-BE49-F238E27FC236}">
-                <a16:creationId xmlns:a16="http://schemas.microsoft.com/office/drawing/2014/main" id="{68E90DB2-A99D-409A-920A-15011805F246}"/>
+                <a16:creationId xmlns:a16="http://schemas.microsoft.com/office/drawing/2014/main" id="{741CD59B-A746-4C89-B152-64E549521398}"/>
               </a:ext>
             </a:extLst>
           </p:cNvPr>
@@ -6874,7 +6874,7 @@
           <p:cNvPr id="2" name="">
             <a:extLst xmlns:a="http://schemas.openxmlformats.org/drawingml/2006/main">
               <a:ext uri="{FF2B5EF4-FFF2-40B4-BE49-F238E27FC236}">
-                <a16:creationId xmlns:a16="http://schemas.microsoft.com/office/drawing/2014/main" id="{1124D8CE-7964-4CB2-8854-06386A780168}"/>
+                <a16:creationId xmlns:a16="http://schemas.microsoft.com/office/drawing/2014/main" id="{E4DCA511-C9A5-4480-9828-AC341F911D9A}"/>
               </a:ext>
             </a:extLst>
           </p:cNvPr>
@@ -6931,7 +6931,7 @@
           <p:cNvPr id="3" name="">
             <a:extLst xmlns:a="http://schemas.openxmlformats.org/drawingml/2006/main">
               <a:ext uri="{FF2B5EF4-FFF2-40B4-BE49-F238E27FC236}">
-                <a16:creationId xmlns:a16="http://schemas.microsoft.com/office/drawing/2014/main" id="{893D6392-FBBE-417E-9094-2D09CFC9AD4C}"/>
+                <a16:creationId xmlns:a16="http://schemas.microsoft.com/office/drawing/2014/main" id="{0A98405E-137F-4FD3-A7EF-98827C27586E}"/>
               </a:ext>
             </a:extLst>
           </p:cNvPr>
@@ -7381,7 +7381,7 @@
           <p:cNvPr id="5" name="">
             <a:extLst xmlns:a="http://schemas.openxmlformats.org/drawingml/2006/main">
               <a:ext uri="{FF2B5EF4-FFF2-40B4-BE49-F238E27FC236}">
-                <a16:creationId xmlns:a16="http://schemas.microsoft.com/office/drawing/2014/main" id="{81E89861-30DB-4B01-A636-AFDD50976045}"/>
+                <a16:creationId xmlns:a16="http://schemas.microsoft.com/office/drawing/2014/main" id="{0BE40FEB-F574-406A-A004-11CB9A5B6273}"/>
               </a:ext>
             </a:extLst>
           </p:cNvPr>
@@ -7436,7 +7436,7 @@
     </p:spTree>
     <p:extLst>
       <p:ext uri="{BB962C8B-B14F-4D97-AF65-F5344CB8AC3E}">
-        <p14:creationId xmlns:p14="http://schemas.microsoft.com/office/powerpoint/2010/main" val="1905177789"/>
+        <p14:creationId xmlns:p14="http://schemas.microsoft.com/office/powerpoint/2010/main" val="18588488"/>
       </p:ext>
     </p:extLst>
   </p:cSld>
@@ -7467,7 +7467,7 @@
           <p:cNvPr id="11" name="">
             <a:extLst xmlns:a="http://schemas.openxmlformats.org/drawingml/2006/main">
               <a:ext uri="{FF2B5EF4-FFF2-40B4-BE49-F238E27FC236}">
-                <a16:creationId xmlns:a16="http://schemas.microsoft.com/office/drawing/2014/main" id="{F627121B-E41E-4EC7-83AF-8D7E9F4FFE57}"/>
+                <a16:creationId xmlns:a16="http://schemas.microsoft.com/office/drawing/2014/main" id="{87719B23-EED9-4DF8-A258-4BC673C40DC3}"/>
               </a:ext>
             </a:extLst>
           </p:cNvPr>
@@ -7524,7 +7524,7 @@
           <p:cNvPr id="2" name="">
             <a:extLst xmlns:a="http://schemas.openxmlformats.org/drawingml/2006/main">
               <a:ext uri="{FF2B5EF4-FFF2-40B4-BE49-F238E27FC236}">
-                <a16:creationId xmlns:a16="http://schemas.microsoft.com/office/drawing/2014/main" id="{6D4E9868-5A16-43A2-B42A-24430DBFA128}"/>
+                <a16:creationId xmlns:a16="http://schemas.microsoft.com/office/drawing/2014/main" id="{A313BE7C-3A19-4DC3-8028-CFF742BF212E}"/>
               </a:ext>
             </a:extLst>
           </p:cNvPr>
@@ -7581,7 +7581,7 @@
           <p:cNvPr id="3" name="">
             <a:extLst xmlns:a="http://schemas.openxmlformats.org/drawingml/2006/main">
               <a:ext uri="{FF2B5EF4-FFF2-40B4-BE49-F238E27FC236}">
-                <a16:creationId xmlns:a16="http://schemas.microsoft.com/office/drawing/2014/main" id="{919C7A9F-9178-4203-A54C-2426C43BDFFD}"/>
+                <a16:creationId xmlns:a16="http://schemas.microsoft.com/office/drawing/2014/main" id="{CD370F25-550C-4EDE-AD78-945DE490D43A}"/>
               </a:ext>
             </a:extLst>
           </p:cNvPr>
@@ -7638,7 +7638,7 @@
           <p:cNvPr id="4" name="">
             <a:extLst xmlns:a="http://schemas.openxmlformats.org/drawingml/2006/main">
               <a:ext uri="{FF2B5EF4-FFF2-40B4-BE49-F238E27FC236}">
-                <a16:creationId xmlns:a16="http://schemas.microsoft.com/office/drawing/2014/main" id="{D50231B8-4DB6-454B-930E-A75FD50950CB}"/>
+                <a16:creationId xmlns:a16="http://schemas.microsoft.com/office/drawing/2014/main" id="{FAEBF935-5CDF-4EFB-A0F5-C34887D55783}"/>
               </a:ext>
             </a:extLst>
           </p:cNvPr>
@@ -7695,7 +7695,7 @@
           <p:cNvPr id="5" name="">
             <a:extLst xmlns:a="http://schemas.openxmlformats.org/drawingml/2006/main">
               <a:ext uri="{FF2B5EF4-FFF2-40B4-BE49-F238E27FC236}">
-                <a16:creationId xmlns:a16="http://schemas.microsoft.com/office/drawing/2014/main" id="{EC0CC5B4-8D8B-4DD6-B65B-A1A3003481F8}"/>
+                <a16:creationId xmlns:a16="http://schemas.microsoft.com/office/drawing/2014/main" id="{3F11C7EC-AB7A-4C32-B402-DC2477C9D627}"/>
               </a:ext>
             </a:extLst>
           </p:cNvPr>
@@ -7775,7 +7775,7 @@
           <p:cNvPr id="6" name="">
             <a:extLst xmlns:a="http://schemas.openxmlformats.org/drawingml/2006/main">
               <a:ext uri="{FF2B5EF4-FFF2-40B4-BE49-F238E27FC236}">
-                <a16:creationId xmlns:a16="http://schemas.microsoft.com/office/drawing/2014/main" id="{9E8D08AD-11B6-4487-94C2-EC0528277F00}"/>
+                <a16:creationId xmlns:a16="http://schemas.microsoft.com/office/drawing/2014/main" id="{8612ADC1-6FDA-45DA-929E-99FD6945285E}"/>
               </a:ext>
             </a:extLst>
           </p:cNvPr>
@@ -7855,7 +7855,7 @@
           <p:cNvPr id="7" name="">
             <a:extLst xmlns:a="http://schemas.openxmlformats.org/drawingml/2006/main">
               <a:ext uri="{FF2B5EF4-FFF2-40B4-BE49-F238E27FC236}">
-                <a16:creationId xmlns:a16="http://schemas.microsoft.com/office/drawing/2014/main" id="{241413CB-0D05-48FC-AE86-3F21E293EF8B}"/>
+                <a16:creationId xmlns:a16="http://schemas.microsoft.com/office/drawing/2014/main" id="{CCB90D91-8082-4542-90AD-2DBBB6AFE760}"/>
               </a:ext>
             </a:extLst>
           </p:cNvPr>
@@ -7912,7 +7912,7 @@
           <p:cNvPr id="8" name="">
             <a:extLst xmlns:a="http://schemas.openxmlformats.org/drawingml/2006/main">
               <a:ext uri="{FF2B5EF4-FFF2-40B4-BE49-F238E27FC236}">
-                <a16:creationId xmlns:a16="http://schemas.microsoft.com/office/drawing/2014/main" id="{013C5529-814B-492C-9E25-98B0CF88AEF3}"/>
+                <a16:creationId xmlns:a16="http://schemas.microsoft.com/office/drawing/2014/main" id="{2CDF36FB-4083-4B12-957C-1CD71E4EDB9A}"/>
               </a:ext>
             </a:extLst>
           </p:cNvPr>
@@ -7992,7 +7992,7 @@
           <p:cNvPr id="9" name="">
             <a:extLst xmlns:a="http://schemas.openxmlformats.org/drawingml/2006/main">
               <a:ext uri="{FF2B5EF4-FFF2-40B4-BE49-F238E27FC236}">
-                <a16:creationId xmlns:a16="http://schemas.microsoft.com/office/drawing/2014/main" id="{DDBCD63D-B263-471D-80FF-27843BF69380}"/>
+                <a16:creationId xmlns:a16="http://schemas.microsoft.com/office/drawing/2014/main" id="{65ECEDB6-5625-45D0-8C63-6CE58C4FD2EF}"/>
               </a:ext>
             </a:extLst>
           </p:cNvPr>
@@ -8072,7 +8072,7 @@
           <p:cNvPr id="10" name="">
             <a:extLst xmlns:a="http://schemas.openxmlformats.org/drawingml/2006/main">
               <a:ext uri="{FF2B5EF4-FFF2-40B4-BE49-F238E27FC236}">
-                <a16:creationId xmlns:a16="http://schemas.microsoft.com/office/drawing/2014/main" id="{6409F885-BC31-42F8-8E8F-000C9FA54F72}"/>
+                <a16:creationId xmlns:a16="http://schemas.microsoft.com/office/drawing/2014/main" id="{23046B6C-9A99-4D2C-89F1-27AEAF62E986}"/>
               </a:ext>
             </a:extLst>
           </p:cNvPr>
@@ -8127,7 +8127,7 @@
     </p:spTree>
     <p:extLst>
       <p:ext uri="{BB962C8B-B14F-4D97-AF65-F5344CB8AC3E}">
-        <p14:creationId xmlns:p14="http://schemas.microsoft.com/office/powerpoint/2010/main" val="607654934"/>
+        <p14:creationId xmlns:p14="http://schemas.microsoft.com/office/powerpoint/2010/main" val="554101567"/>
       </p:ext>
     </p:extLst>
   </p:cSld>
@@ -8158,7 +8158,7 @@
           <p:cNvPr id="7" name="">
             <a:extLst xmlns:a="http://schemas.openxmlformats.org/drawingml/2006/main">
               <a:ext uri="{FF2B5EF4-FFF2-40B4-BE49-F238E27FC236}">
-                <a16:creationId xmlns:a16="http://schemas.microsoft.com/office/drawing/2014/main" id="{77934056-121B-4384-BEB2-8C03915AA109}"/>
+                <a16:creationId xmlns:a16="http://schemas.microsoft.com/office/drawing/2014/main" id="{88A4C3A1-63B2-4CB2-BBCC-8EE2000C1CB9}"/>
               </a:ext>
             </a:extLst>
           </p:cNvPr>
@@ -8215,7 +8215,7 @@
           <p:cNvPr id="2" name="">
             <a:extLst xmlns:a="http://schemas.openxmlformats.org/drawingml/2006/main">
               <a:ext uri="{FF2B5EF4-FFF2-40B4-BE49-F238E27FC236}">
-                <a16:creationId xmlns:a16="http://schemas.microsoft.com/office/drawing/2014/main" id="{F3F998CA-9306-4F95-AF53-3E3D68F28EF8}"/>
+                <a16:creationId xmlns:a16="http://schemas.microsoft.com/office/drawing/2014/main" id="{CAC55DB0-BB2B-45F1-BAD3-0F45CAED2822}"/>
               </a:ext>
             </a:extLst>
           </p:cNvPr>
@@ -8272,7 +8272,7 @@
           <p:cNvPr id="3" name="">
             <a:extLst xmlns:a="http://schemas.openxmlformats.org/drawingml/2006/main">
               <a:ext uri="{FF2B5EF4-FFF2-40B4-BE49-F238E27FC236}">
-                <a16:creationId xmlns:a16="http://schemas.microsoft.com/office/drawing/2014/main" id="{60D05259-BCF3-4DA0-A409-082D93765809}"/>
+                <a16:creationId xmlns:a16="http://schemas.microsoft.com/office/drawing/2014/main" id="{0CD20265-B5DD-4CB2-900C-9857EAD27249}"/>
               </a:ext>
             </a:extLst>
           </p:cNvPr>
@@ -8722,7 +8722,7 @@
           <p:cNvPr id="5" name="">
             <a:extLst xmlns:a="http://schemas.openxmlformats.org/drawingml/2006/main">
               <a:ext uri="{FF2B5EF4-FFF2-40B4-BE49-F238E27FC236}">
-                <a16:creationId xmlns:a16="http://schemas.microsoft.com/office/drawing/2014/main" id="{FA6675DB-293B-454E-B5C9-21196F173E4D}"/>
+                <a16:creationId xmlns:a16="http://schemas.microsoft.com/office/drawing/2014/main" id="{FDACBDB9-A2F7-4AE6-AC2E-9E67F9342B3D}"/>
               </a:ext>
             </a:extLst>
           </p:cNvPr>
@@ -8779,7 +8779,7 @@
           <p:cNvPr id="6" name="">
             <a:extLst xmlns:a="http://schemas.openxmlformats.org/drawingml/2006/main">
               <a:ext uri="{FF2B5EF4-FFF2-40B4-BE49-F238E27FC236}">
-                <a16:creationId xmlns:a16="http://schemas.microsoft.com/office/drawing/2014/main" id="{EEB81DDD-0A94-4E18-AF1A-83237BDA6CC5}"/>
+                <a16:creationId xmlns:a16="http://schemas.microsoft.com/office/drawing/2014/main" id="{EA0D4A9B-B417-42D6-9856-ECAD55DB2666}"/>
               </a:ext>
             </a:extLst>
           </p:cNvPr>
@@ -8834,7 +8834,7 @@
     </p:spTree>
     <p:extLst>
       <p:ext uri="{BB962C8B-B14F-4D97-AF65-F5344CB8AC3E}">
-        <p14:creationId xmlns:p14="http://schemas.microsoft.com/office/powerpoint/2010/main" val="1464390149"/>
+        <p14:creationId xmlns:p14="http://schemas.microsoft.com/office/powerpoint/2010/main" val="2680128"/>
       </p:ext>
     </p:extLst>
   </p:cSld>
@@ -8865,7 +8865,7 @@
           <p:cNvPr id="11" name="">
             <a:extLst xmlns:a="http://schemas.openxmlformats.org/drawingml/2006/main">
               <a:ext uri="{FF2B5EF4-FFF2-40B4-BE49-F238E27FC236}">
-                <a16:creationId xmlns:a16="http://schemas.microsoft.com/office/drawing/2014/main" id="{FF1A03C0-7DB2-49BC-9814-CA7D13AFD9BE}"/>
+                <a16:creationId xmlns:a16="http://schemas.microsoft.com/office/drawing/2014/main" id="{0036A89A-5C67-4BE3-A886-F405FA32A78C}"/>
               </a:ext>
             </a:extLst>
           </p:cNvPr>
@@ -8922,7 +8922,7 @@
           <p:cNvPr id="2" name="">
             <a:extLst xmlns:a="http://schemas.openxmlformats.org/drawingml/2006/main">
               <a:ext uri="{FF2B5EF4-FFF2-40B4-BE49-F238E27FC236}">
-                <a16:creationId xmlns:a16="http://schemas.microsoft.com/office/drawing/2014/main" id="{B41E63BC-0DAE-4922-BDB2-EE8F5765DDA6}"/>
+                <a16:creationId xmlns:a16="http://schemas.microsoft.com/office/drawing/2014/main" id="{B1C35F07-84FB-4876-99A6-AB54CF5A5896}"/>
               </a:ext>
             </a:extLst>
           </p:cNvPr>
@@ -8979,7 +8979,7 @@
           <p:cNvPr id="3" name="">
             <a:extLst xmlns:a="http://schemas.openxmlformats.org/drawingml/2006/main">
               <a:ext uri="{FF2B5EF4-FFF2-40B4-BE49-F238E27FC236}">
-                <a16:creationId xmlns:a16="http://schemas.microsoft.com/office/drawing/2014/main" id="{87A3DB68-F108-46E0-A2ED-5769F6D16F64}"/>
+                <a16:creationId xmlns:a16="http://schemas.microsoft.com/office/drawing/2014/main" id="{4994656C-F368-4682-9509-BBC745E1DCB5}"/>
               </a:ext>
             </a:extLst>
           </p:cNvPr>
@@ -9036,7 +9036,7 @@
           <p:cNvPr id="4" name="">
             <a:extLst xmlns:a="http://schemas.openxmlformats.org/drawingml/2006/main">
               <a:ext uri="{FF2B5EF4-FFF2-40B4-BE49-F238E27FC236}">
-                <a16:creationId xmlns:a16="http://schemas.microsoft.com/office/drawing/2014/main" id="{87BE5EB7-A4C5-4209-8991-44023675F2AC}"/>
+                <a16:creationId xmlns:a16="http://schemas.microsoft.com/office/drawing/2014/main" id="{C345C3ED-272F-4B83-B0CC-F338AFCF5B39}"/>
               </a:ext>
             </a:extLst>
           </p:cNvPr>
@@ -9093,7 +9093,7 @@
           <p:cNvPr id="5" name="">
             <a:extLst xmlns:a="http://schemas.openxmlformats.org/drawingml/2006/main">
               <a:ext uri="{FF2B5EF4-FFF2-40B4-BE49-F238E27FC236}">
-                <a16:creationId xmlns:a16="http://schemas.microsoft.com/office/drawing/2014/main" id="{6F9ECB6F-6148-4619-8A26-989D63FFEBAB}"/>
+                <a16:creationId xmlns:a16="http://schemas.microsoft.com/office/drawing/2014/main" id="{53052B4D-F6B8-4E12-B4CA-317394A5216F}"/>
               </a:ext>
             </a:extLst>
           </p:cNvPr>
@@ -9196,7 +9196,7 @@
           <p:cNvPr id="6" name="">
             <a:extLst xmlns:a="http://schemas.openxmlformats.org/drawingml/2006/main">
               <a:ext uri="{FF2B5EF4-FFF2-40B4-BE49-F238E27FC236}">
-                <a16:creationId xmlns:a16="http://schemas.microsoft.com/office/drawing/2014/main" id="{CFD56326-7442-4FD4-9619-4A3DF28E516E}"/>
+                <a16:creationId xmlns:a16="http://schemas.microsoft.com/office/drawing/2014/main" id="{0810512D-0502-48F6-8111-3168D88AE053}"/>
               </a:ext>
             </a:extLst>
           </p:cNvPr>
@@ -9276,7 +9276,7 @@
           <p:cNvPr id="7" name="">
             <a:extLst xmlns:a="http://schemas.openxmlformats.org/drawingml/2006/main">
               <a:ext uri="{FF2B5EF4-FFF2-40B4-BE49-F238E27FC236}">
-                <a16:creationId xmlns:a16="http://schemas.microsoft.com/office/drawing/2014/main" id="{3C3C2A5C-4544-4C35-AF54-4E134AB58881}"/>
+                <a16:creationId xmlns:a16="http://schemas.microsoft.com/office/drawing/2014/main" id="{C0238CCC-D1EC-43A2-A15C-095B1B4256A3}"/>
               </a:ext>
             </a:extLst>
           </p:cNvPr>
@@ -9333,7 +9333,7 @@
           <p:cNvPr id="8" name="">
             <a:extLst xmlns:a="http://schemas.openxmlformats.org/drawingml/2006/main">
               <a:ext uri="{FF2B5EF4-FFF2-40B4-BE49-F238E27FC236}">
-                <a16:creationId xmlns:a16="http://schemas.microsoft.com/office/drawing/2014/main" id="{39C453CB-3E69-4055-8381-179AC9A97F37}"/>
+                <a16:creationId xmlns:a16="http://schemas.microsoft.com/office/drawing/2014/main" id="{63F963EA-02AC-4E65-BCF7-9BC68780EC75}"/>
               </a:ext>
             </a:extLst>
           </p:cNvPr>
@@ -9436,7 +9436,7 @@
           <p:cNvPr id="9" name="">
             <a:extLst xmlns:a="http://schemas.openxmlformats.org/drawingml/2006/main">
               <a:ext uri="{FF2B5EF4-FFF2-40B4-BE49-F238E27FC236}">
-                <a16:creationId xmlns:a16="http://schemas.microsoft.com/office/drawing/2014/main" id="{A0A95CC9-BBD8-4805-AF1A-048EC407564F}"/>
+                <a16:creationId xmlns:a16="http://schemas.microsoft.com/office/drawing/2014/main" id="{53F21F38-F119-4894-843A-B61392F4756A}"/>
               </a:ext>
             </a:extLst>
           </p:cNvPr>
@@ -9516,7 +9516,7 @@
           <p:cNvPr id="10" name="">
             <a:extLst xmlns:a="http://schemas.openxmlformats.org/drawingml/2006/main">
               <a:ext uri="{FF2B5EF4-FFF2-40B4-BE49-F238E27FC236}">
-                <a16:creationId xmlns:a16="http://schemas.microsoft.com/office/drawing/2014/main" id="{A89B8C9C-1BCB-4AD0-B8C5-7FE2C007D66C}"/>
+                <a16:creationId xmlns:a16="http://schemas.microsoft.com/office/drawing/2014/main" id="{8604747E-0DEE-43E6-8F46-9C9FE885171F}"/>
               </a:ext>
             </a:extLst>
           </p:cNvPr>
@@ -9571,7 +9571,7 @@
     </p:spTree>
     <p:extLst>
       <p:ext uri="{BB962C8B-B14F-4D97-AF65-F5344CB8AC3E}">
-        <p14:creationId xmlns:p14="http://schemas.microsoft.com/office/powerpoint/2010/main" val="1417601869"/>
+        <p14:creationId xmlns:p14="http://schemas.microsoft.com/office/powerpoint/2010/main" val="951041074"/>
       </p:ext>
     </p:extLst>
   </p:cSld>
@@ -9602,7 +9602,7 @@
           <p:cNvPr id="11" name="">
             <a:extLst xmlns:a="http://schemas.openxmlformats.org/drawingml/2006/main">
               <a:ext uri="{FF2B5EF4-FFF2-40B4-BE49-F238E27FC236}">
-                <a16:creationId xmlns:a16="http://schemas.microsoft.com/office/drawing/2014/main" id="{8A969162-2D8A-4A71-A444-7F997D99DB20}"/>
+                <a16:creationId xmlns:a16="http://schemas.microsoft.com/office/drawing/2014/main" id="{6087C2F5-0194-40A3-A829-08C2CDDBED64}"/>
               </a:ext>
             </a:extLst>
           </p:cNvPr>
@@ -9659,7 +9659,7 @@
           <p:cNvPr id="2" name="">
             <a:extLst xmlns:a="http://schemas.openxmlformats.org/drawingml/2006/main">
               <a:ext uri="{FF2B5EF4-FFF2-40B4-BE49-F238E27FC236}">
-                <a16:creationId xmlns:a16="http://schemas.microsoft.com/office/drawing/2014/main" id="{F79A3520-6EDB-4A5D-BEC4-310B6C3FA1B3}"/>
+                <a16:creationId xmlns:a16="http://schemas.microsoft.com/office/drawing/2014/main" id="{43A93C9A-906C-4187-919D-ED3C8A7D8D42}"/>
               </a:ext>
             </a:extLst>
           </p:cNvPr>
@@ -9716,7 +9716,7 @@
           <p:cNvPr id="3" name="">
             <a:extLst xmlns:a="http://schemas.openxmlformats.org/drawingml/2006/main">
               <a:ext uri="{FF2B5EF4-FFF2-40B4-BE49-F238E27FC236}">
-                <a16:creationId xmlns:a16="http://schemas.microsoft.com/office/drawing/2014/main" id="{9F33AF10-82F8-4613-8DB6-79C23061F99D}"/>
+                <a16:creationId xmlns:a16="http://schemas.microsoft.com/office/drawing/2014/main" id="{48582C55-93C4-45E6-B55D-C0525687BDB4}"/>
               </a:ext>
             </a:extLst>
           </p:cNvPr>
@@ -9773,7 +9773,7 @@
           <p:cNvPr id="4" name="">
             <a:extLst xmlns:a="http://schemas.openxmlformats.org/drawingml/2006/main">
               <a:ext uri="{FF2B5EF4-FFF2-40B4-BE49-F238E27FC236}">
-                <a16:creationId xmlns:a16="http://schemas.microsoft.com/office/drawing/2014/main" id="{D49BD03B-92AD-4B8F-BCF5-DC09A594CB88}"/>
+                <a16:creationId xmlns:a16="http://schemas.microsoft.com/office/drawing/2014/main" id="{84184565-C27C-43AF-8021-DA26E6B9F207}"/>
               </a:ext>
             </a:extLst>
           </p:cNvPr>
@@ -9830,7 +9830,7 @@
           <p:cNvPr id="5" name="">
             <a:extLst xmlns:a="http://schemas.openxmlformats.org/drawingml/2006/main">
               <a:ext uri="{FF2B5EF4-FFF2-40B4-BE49-F238E27FC236}">
-                <a16:creationId xmlns:a16="http://schemas.microsoft.com/office/drawing/2014/main" id="{CF79C920-B2AE-4DA3-B0B0-6BA8A836B958}"/>
+                <a16:creationId xmlns:a16="http://schemas.microsoft.com/office/drawing/2014/main" id="{A3BC31A0-09C8-48E1-B445-F14AC8F76866}"/>
               </a:ext>
             </a:extLst>
           </p:cNvPr>
@@ -9887,7 +9887,7 @@
           <p:cNvPr id="6" name="">
             <a:extLst xmlns:a="http://schemas.openxmlformats.org/drawingml/2006/main">
               <a:ext uri="{FF2B5EF4-FFF2-40B4-BE49-F238E27FC236}">
-                <a16:creationId xmlns:a16="http://schemas.microsoft.com/office/drawing/2014/main" id="{4F2F5743-329F-48B5-BC55-0BC342F1AE28}"/>
+                <a16:creationId xmlns:a16="http://schemas.microsoft.com/office/drawing/2014/main" id="{ACED879D-D5D8-48A4-80A7-1F6106A96176}"/>
               </a:ext>
             </a:extLst>
           </p:cNvPr>
@@ -9990,7 +9990,7 @@
           <p:cNvPr id="7" name="">
             <a:extLst xmlns:a="http://schemas.openxmlformats.org/drawingml/2006/main">
               <a:ext uri="{FF2B5EF4-FFF2-40B4-BE49-F238E27FC236}">
-                <a16:creationId xmlns:a16="http://schemas.microsoft.com/office/drawing/2014/main" id="{403FC0C2-4FC3-45C5-A442-350577B97634}"/>
+                <a16:creationId xmlns:a16="http://schemas.microsoft.com/office/drawing/2014/main" id="{B9544EBC-1CCF-45DD-BD2E-4DDBD150EB36}"/>
               </a:ext>
             </a:extLst>
           </p:cNvPr>
@@ -10047,7 +10047,7 @@
           <p:cNvPr id="8" name="">
             <a:extLst xmlns:a="http://schemas.openxmlformats.org/drawingml/2006/main">
               <a:ext uri="{FF2B5EF4-FFF2-40B4-BE49-F238E27FC236}">
-                <a16:creationId xmlns:a16="http://schemas.microsoft.com/office/drawing/2014/main" id="{74466F67-7967-4CBD-BA5C-55B4BA276FF6}"/>
+                <a16:creationId xmlns:a16="http://schemas.microsoft.com/office/drawing/2014/main" id="{236A0C6A-3DAD-4A1E-97E2-B42F95F67354}"/>
               </a:ext>
             </a:extLst>
           </p:cNvPr>
@@ -10104,7 +10104,7 @@
           <p:cNvPr id="9" name="">
             <a:extLst xmlns:a="http://schemas.openxmlformats.org/drawingml/2006/main">
               <a:ext uri="{FF2B5EF4-FFF2-40B4-BE49-F238E27FC236}">
-                <a16:creationId xmlns:a16="http://schemas.microsoft.com/office/drawing/2014/main" id="{7ACB5E4B-01FC-48BA-9146-0CF4E6A2F2D6}"/>
+                <a16:creationId xmlns:a16="http://schemas.microsoft.com/office/drawing/2014/main" id="{7796CAF0-6524-41F6-B31D-674D8705AC2B}"/>
               </a:ext>
             </a:extLst>
           </p:cNvPr>
@@ -10207,7 +10207,7 @@
           <p:cNvPr id="10" name="">
             <a:extLst xmlns:a="http://schemas.openxmlformats.org/drawingml/2006/main">
               <a:ext uri="{FF2B5EF4-FFF2-40B4-BE49-F238E27FC236}">
-                <a16:creationId xmlns:a16="http://schemas.microsoft.com/office/drawing/2014/main" id="{9660915D-2E95-4020-8687-07AB3A0747DB}"/>
+                <a16:creationId xmlns:a16="http://schemas.microsoft.com/office/drawing/2014/main" id="{F813AA47-E266-4AA0-A94E-B9CC7CA76279}"/>
               </a:ext>
             </a:extLst>
           </p:cNvPr>
@@ -10262,7 +10262,7 @@
     </p:spTree>
     <p:extLst>
       <p:ext uri="{BB962C8B-B14F-4D97-AF65-F5344CB8AC3E}">
-        <p14:creationId xmlns:p14="http://schemas.microsoft.com/office/powerpoint/2010/main" val="772118874"/>
+        <p14:creationId xmlns:p14="http://schemas.microsoft.com/office/powerpoint/2010/main" val="1301324521"/>
       </p:ext>
     </p:extLst>
   </p:cSld>
@@ -10293,7 +10293,7 @@
           <p:cNvPr id="20" name="">
             <a:extLst xmlns:a="http://schemas.openxmlformats.org/drawingml/2006/main">
               <a:ext uri="{FF2B5EF4-FFF2-40B4-BE49-F238E27FC236}">
-                <a16:creationId xmlns:a16="http://schemas.microsoft.com/office/drawing/2014/main" id="{9A8DC25A-5D74-418F-80AC-C67AF6891BDF}"/>
+                <a16:creationId xmlns:a16="http://schemas.microsoft.com/office/drawing/2014/main" id="{C52C1C5D-21F5-4DF5-A542-30183F496180}"/>
               </a:ext>
             </a:extLst>
           </p:cNvPr>
@@ -10350,7 +10350,7 @@
           <p:cNvPr id="2" name="">
             <a:extLst xmlns:a="http://schemas.openxmlformats.org/drawingml/2006/main">
               <a:ext uri="{FF2B5EF4-FFF2-40B4-BE49-F238E27FC236}">
-                <a16:creationId xmlns:a16="http://schemas.microsoft.com/office/drawing/2014/main" id="{6E4084A4-D609-4A61-8082-BC5023FC0459}"/>
+                <a16:creationId xmlns:a16="http://schemas.microsoft.com/office/drawing/2014/main" id="{C958BA67-512F-4F62-91BF-1F4EB76C62FB}"/>
               </a:ext>
             </a:extLst>
           </p:cNvPr>
@@ -10407,7 +10407,7 @@
           <p:cNvPr id="3" name="">
             <a:extLst xmlns:a="http://schemas.openxmlformats.org/drawingml/2006/main">
               <a:ext uri="{FF2B5EF4-FFF2-40B4-BE49-F238E27FC236}">
-                <a16:creationId xmlns:a16="http://schemas.microsoft.com/office/drawing/2014/main" id="{285F436F-8035-42BB-88D0-1D590D903BE7}"/>
+                <a16:creationId xmlns:a16="http://schemas.microsoft.com/office/drawing/2014/main" id="{429CBF48-52DF-4444-AA6C-F223EC711EAB}"/>
               </a:ext>
             </a:extLst>
           </p:cNvPr>
@@ -10464,7 +10464,7 @@
           <p:cNvPr id="4" name="">
             <a:extLst xmlns:a="http://schemas.openxmlformats.org/drawingml/2006/main">
               <a:ext uri="{FF2B5EF4-FFF2-40B4-BE49-F238E27FC236}">
-                <a16:creationId xmlns:a16="http://schemas.microsoft.com/office/drawing/2014/main" id="{E8187F59-562F-4867-B70B-1C29C00EB88A}"/>
+                <a16:creationId xmlns:a16="http://schemas.microsoft.com/office/drawing/2014/main" id="{75DB787B-4316-435A-B4FD-FE4D20D9DF39}"/>
               </a:ext>
             </a:extLst>
           </p:cNvPr>
@@ -10523,7 +10523,7 @@
           <p:cNvPr id="5" name="">
             <a:extLst xmlns:a="http://schemas.openxmlformats.org/drawingml/2006/main">
               <a:ext uri="{FF2B5EF4-FFF2-40B4-BE49-F238E27FC236}">
-                <a16:creationId xmlns:a16="http://schemas.microsoft.com/office/drawing/2014/main" id="{DC5323C7-63B5-4A95-AC59-0675BABF65B9}"/>
+                <a16:creationId xmlns:a16="http://schemas.microsoft.com/office/drawing/2014/main" id="{B8562FEE-8166-40E8-88FA-664F0B036313}"/>
               </a:ext>
             </a:extLst>
           </p:cNvPr>
@@ -10607,7 +10607,7 @@
           <p:cNvPr id="7" name="">
             <a:extLst xmlns:a="http://schemas.openxmlformats.org/drawingml/2006/main">
               <a:ext uri="{FF2B5EF4-FFF2-40B4-BE49-F238E27FC236}">
-                <a16:creationId xmlns:a16="http://schemas.microsoft.com/office/drawing/2014/main" id="{98752290-CC51-4E3C-BC38-6977420E747A}"/>
+                <a16:creationId xmlns:a16="http://schemas.microsoft.com/office/drawing/2014/main" id="{984CEA2F-6775-4039-9F60-4449830F606D}"/>
               </a:ext>
             </a:extLst>
           </p:cNvPr>
@@ -10691,7 +10691,7 @@
           <p:cNvPr id="9" name="">
             <a:extLst xmlns:a="http://schemas.openxmlformats.org/drawingml/2006/main">
               <a:ext uri="{FF2B5EF4-FFF2-40B4-BE49-F238E27FC236}">
-                <a16:creationId xmlns:a16="http://schemas.microsoft.com/office/drawing/2014/main" id="{ABEA7565-A0A4-40A5-887F-77E78911802C}"/>
+                <a16:creationId xmlns:a16="http://schemas.microsoft.com/office/drawing/2014/main" id="{59023DD2-3D0A-4E4C-B7E7-DC2D02A4E6F8}"/>
               </a:ext>
             </a:extLst>
           </p:cNvPr>
@@ -10775,7 +10775,7 @@
           <p:cNvPr id="11" name="">
             <a:extLst xmlns:a="http://schemas.openxmlformats.org/drawingml/2006/main">
               <a:ext uri="{FF2B5EF4-FFF2-40B4-BE49-F238E27FC236}">
-                <a16:creationId xmlns:a16="http://schemas.microsoft.com/office/drawing/2014/main" id="{D5B2AF85-E7D5-4ED7-8378-9F8280BE1D4E}"/>
+                <a16:creationId xmlns:a16="http://schemas.microsoft.com/office/drawing/2014/main" id="{CAF41D78-4363-4641-BCF8-BECF3B0FBB1F}"/>
               </a:ext>
             </a:extLst>
           </p:cNvPr>
@@ -10859,7 +10859,7 @@
           <p:cNvPr id="13" name="">
             <a:extLst xmlns:a="http://schemas.openxmlformats.org/drawingml/2006/main">
               <a:ext uri="{FF2B5EF4-FFF2-40B4-BE49-F238E27FC236}">
-                <a16:creationId xmlns:a16="http://schemas.microsoft.com/office/drawing/2014/main" id="{2290D5CD-CCDD-4343-BD94-95DE70069891}"/>
+                <a16:creationId xmlns:a16="http://schemas.microsoft.com/office/drawing/2014/main" id="{E2DE8FE8-C082-478E-AC21-82EBA52720C7}"/>
               </a:ext>
             </a:extLst>
           </p:cNvPr>
@@ -10916,7 +10916,7 @@
           <p:cNvPr id="14" name="">
             <a:extLst xmlns:a="http://schemas.openxmlformats.org/drawingml/2006/main">
               <a:ext uri="{FF2B5EF4-FFF2-40B4-BE49-F238E27FC236}">
-                <a16:creationId xmlns:a16="http://schemas.microsoft.com/office/drawing/2014/main" id="{159280BA-16B6-44D6-ADCB-AA3269746A65}"/>
+                <a16:creationId xmlns:a16="http://schemas.microsoft.com/office/drawing/2014/main" id="{0FCDA89F-B39F-4C3E-BDCB-F95836F49018}"/>
               </a:ext>
             </a:extLst>
           </p:cNvPr>
@@ -10973,7 +10973,7 @@
           <p:cNvPr id="15" name="">
             <a:extLst xmlns:a="http://schemas.openxmlformats.org/drawingml/2006/main">
               <a:ext uri="{FF2B5EF4-FFF2-40B4-BE49-F238E27FC236}">
-                <a16:creationId xmlns:a16="http://schemas.microsoft.com/office/drawing/2014/main" id="{A7C25C98-E5A4-454C-9127-B244BF8783C0}"/>
+                <a16:creationId xmlns:a16="http://schemas.microsoft.com/office/drawing/2014/main" id="{3EA542A3-20E0-43B3-90C7-385AA16634CE}"/>
               </a:ext>
             </a:extLst>
           </p:cNvPr>
@@ -11030,7 +11030,7 @@
           <p:cNvPr id="16" name="">
             <a:extLst xmlns:a="http://schemas.openxmlformats.org/drawingml/2006/main">
               <a:ext uri="{FF2B5EF4-FFF2-40B4-BE49-F238E27FC236}">
-                <a16:creationId xmlns:a16="http://schemas.microsoft.com/office/drawing/2014/main" id="{34E190F7-358E-4E64-A311-63F5A657DAED}"/>
+                <a16:creationId xmlns:a16="http://schemas.microsoft.com/office/drawing/2014/main" id="{7B21A50E-83A1-4CFB-B89A-B66620B99EC9}"/>
               </a:ext>
             </a:extLst>
           </p:cNvPr>
@@ -11087,7 +11087,7 @@
           <p:cNvPr id="17" name="">
             <a:extLst xmlns:a="http://schemas.openxmlformats.org/drawingml/2006/main">
               <a:ext uri="{FF2B5EF4-FFF2-40B4-BE49-F238E27FC236}">
-                <a16:creationId xmlns:a16="http://schemas.microsoft.com/office/drawing/2014/main" id="{DE402CDA-F7C4-4C22-8AB6-1D812B39F0AF}"/>
+                <a16:creationId xmlns:a16="http://schemas.microsoft.com/office/drawing/2014/main" id="{3CA49735-1727-48CC-808B-F3044342A96C}"/>
               </a:ext>
             </a:extLst>
           </p:cNvPr>
@@ -11144,7 +11144,7 @@
           <p:cNvPr id="18" name="">
             <a:extLst xmlns:a="http://schemas.openxmlformats.org/drawingml/2006/main">
               <a:ext uri="{FF2B5EF4-FFF2-40B4-BE49-F238E27FC236}">
-                <a16:creationId xmlns:a16="http://schemas.microsoft.com/office/drawing/2014/main" id="{E58132B9-E38E-41E0-B5E7-676D9CE89BDA}"/>
+                <a16:creationId xmlns:a16="http://schemas.microsoft.com/office/drawing/2014/main" id="{06A56093-B859-4C3E-A27F-1ECBE41D4E92}"/>
               </a:ext>
             </a:extLst>
           </p:cNvPr>
@@ -11201,7 +11201,7 @@
           <p:cNvPr id="19" name="">
             <a:extLst xmlns:a="http://schemas.openxmlformats.org/drawingml/2006/main">
               <a:ext uri="{FF2B5EF4-FFF2-40B4-BE49-F238E27FC236}">
-                <a16:creationId xmlns:a16="http://schemas.microsoft.com/office/drawing/2014/main" id="{B909197A-5159-4ABD-BB9F-04C5DCDD025A}"/>
+                <a16:creationId xmlns:a16="http://schemas.microsoft.com/office/drawing/2014/main" id="{45B95DEC-71CC-41FF-9EE3-A6AE1F696586}"/>
               </a:ext>
             </a:extLst>
           </p:cNvPr>
@@ -11256,7 +11256,7 @@
     </p:spTree>
     <p:extLst>
       <p:ext uri="{BB962C8B-B14F-4D97-AF65-F5344CB8AC3E}">
-        <p14:creationId xmlns:p14="http://schemas.microsoft.com/office/powerpoint/2010/main" val="34253296"/>
+        <p14:creationId xmlns:p14="http://schemas.microsoft.com/office/powerpoint/2010/main" val="1303691376"/>
       </p:ext>
     </p:extLst>
   </p:cSld>
@@ -11284,10 +11284,10 @@
       </p:grpSpPr>
       <p:sp>
         <p:nvSpPr>
-          <p:cNvPr id="10" name="">
-            <a:extLst xmlns:a="http://schemas.openxmlformats.org/drawingml/2006/main">
-              <a:ext uri="{FF2B5EF4-FFF2-40B4-BE49-F238E27FC236}">
-                <a16:creationId xmlns:a16="http://schemas.microsoft.com/office/drawing/2014/main" id="{53ADC019-1FE7-4A20-BA76-6C0979F16E48}"/>
+          <p:cNvPr id="15" name="">
+            <a:extLst xmlns:a="http://schemas.openxmlformats.org/drawingml/2006/main">
+              <a:ext uri="{FF2B5EF4-FFF2-40B4-BE49-F238E27FC236}">
+                <a16:creationId xmlns:a16="http://schemas.microsoft.com/office/drawing/2014/main" id="{5D71A6E7-2934-4479-A07A-8C4ABA162AA3}"/>
               </a:ext>
             </a:extLst>
           </p:cNvPr>
@@ -11344,7 +11344,7 @@
           <p:cNvPr id="2" name="">
             <a:extLst xmlns:a="http://schemas.openxmlformats.org/drawingml/2006/main">
               <a:ext uri="{FF2B5EF4-FFF2-40B4-BE49-F238E27FC236}">
-                <a16:creationId xmlns:a16="http://schemas.microsoft.com/office/drawing/2014/main" id="{3FC8116F-E496-43FE-9EE3-56808F0DCA0E}"/>
+                <a16:creationId xmlns:a16="http://schemas.microsoft.com/office/drawing/2014/main" id="{85E21225-C7C7-45A2-9998-55EEDD2CB27A}"/>
               </a:ext>
             </a:extLst>
           </p:cNvPr>
@@ -11391,7 +11391,7 @@
                 <a:ea typeface="Apple SD Gothic Neo"/>
                 <a:cs typeface="Apple SD Gothic Neo"/>
               </a:rPr>
-              <a:t>2026-10-05 · 별도 세션에서 라쿠텐 북스 구매와 몰테일 신청을 진행했습니다.</a:t>
+              <a:t>상품 URL과 구매 목적을 전달한 뒤, 확인·승인 중심의 대화로 배송대행 접수까지 진행했습니다.</a:t>
             </a:r>
           </a:p>
         </p:txBody>
@@ -11401,7 +11401,7 @@
           <p:cNvPr id="3" name="">
             <a:extLst xmlns:a="http://schemas.openxmlformats.org/drawingml/2006/main">
               <a:ext uri="{FF2B5EF4-FFF2-40B4-BE49-F238E27FC236}">
-                <a16:creationId xmlns:a16="http://schemas.microsoft.com/office/drawing/2014/main" id="{72AE1014-994F-4E46-ACF1-57CD55839166}"/>
+                <a16:creationId xmlns:a16="http://schemas.microsoft.com/office/drawing/2014/main" id="{747C5DCB-828E-4DC3-9BDD-9B5482B82362}"/>
               </a:ext>
             </a:extLst>
           </p:cNvPr>
@@ -11458,19 +11458,19 @@
           <p:cNvPr id="4" name="">
             <a:extLst xmlns:a="http://schemas.openxmlformats.org/drawingml/2006/main">
               <a:ext uri="{FF2B5EF4-FFF2-40B4-BE49-F238E27FC236}">
-                <a16:creationId xmlns:a16="http://schemas.microsoft.com/office/drawing/2014/main" id="{E9D26C90-6020-41E4-B3D5-1BD353257601}"/>
-              </a:ext>
-            </a:extLst>
-          </p:cNvPr>
-          <p:cNvSpPr>
-            <a:spLocks xmlns:a="http://schemas.openxmlformats.org/drawingml/2006/main" noGrp="1"/>
-          </p:cNvSpPr>
-          <p:nvPr/>
-        </p:nvSpPr>
-        <p:spPr>
-          <a:xfrm xmlns:a="http://schemas.openxmlformats.org/drawingml/2006/main">
-            <a:off x="819150" y="2667000"/>
-            <a:ext cx="6905625" cy="476250"/>
+                <a16:creationId xmlns:a16="http://schemas.microsoft.com/office/drawing/2014/main" id="{C7A3107A-8BD3-46A8-858E-37819BDA7199}"/>
+              </a:ext>
+            </a:extLst>
+          </p:cNvPr>
+          <p:cNvSpPr>
+            <a:spLocks xmlns:a="http://schemas.openxmlformats.org/drawingml/2006/main" noGrp="1"/>
+          </p:cNvSpPr>
+          <p:nvPr/>
+        </p:nvSpPr>
+        <p:spPr>
+          <a:xfrm xmlns:a="http://schemas.openxmlformats.org/drawingml/2006/main">
+            <a:off x="819150" y="2571750"/>
+            <a:ext cx="13525500" cy="752475"/>
           </a:xfrm>
           <a:prstGeom xmlns:a="http://schemas.openxmlformats.org/drawingml/2006/main" prst="rect">
             <a:avLst/>
@@ -11487,7 +11487,7 @@
           <a:lstStyle xmlns:a="http://schemas.openxmlformats.org/drawingml/2006/main"/>
           <a:p xmlns:a="http://schemas.openxmlformats.org/drawingml/2006/main">
             <a:pPr>
-              <a:defRPr sz="2700" b="1">
+              <a:defRPr sz="3975" b="1">
                 <a:solidFill>
                   <a:srgbClr val="156E58"/>
                 </a:solidFill>
@@ -11497,7 +11497,7 @@
               </a:defRPr>
             </a:pPr>
             <a:r>
-              <a:rPr sz="2700" b="1">
+              <a:rPr sz="3975" b="1">
                 <a:solidFill>
                   <a:srgbClr val="156E58"/>
                 </a:solidFill>
@@ -11505,7 +11505,7 @@
                 <a:ea typeface="Apple SD Gothic Neo"/>
                 <a:cs typeface="Apple SD Gothic Neo"/>
               </a:rPr>
-              <a:t>확인한 결과</a:t>
+              <a:t>첫 요청 1회 + 후속 응답 6회</a:t>
             </a:r>
           </a:p>
         </p:txBody>
@@ -11515,19 +11515,19 @@
           <p:cNvPr id="5" name="">
             <a:extLst xmlns:a="http://schemas.openxmlformats.org/drawingml/2006/main">
               <a:ext uri="{FF2B5EF4-FFF2-40B4-BE49-F238E27FC236}">
-                <a16:creationId xmlns:a16="http://schemas.microsoft.com/office/drawing/2014/main" id="{7BF6965D-A6D5-49AD-ADA1-D6AC1D531945}"/>
-              </a:ext>
-            </a:extLst>
-          </p:cNvPr>
-          <p:cNvSpPr>
-            <a:spLocks xmlns:a="http://schemas.openxmlformats.org/drawingml/2006/main" noGrp="1"/>
-          </p:cNvSpPr>
-          <p:nvPr/>
-        </p:nvSpPr>
-        <p:spPr>
-          <a:xfrm xmlns:a="http://schemas.openxmlformats.org/drawingml/2006/main">
-            <a:off x="819150" y="3486150"/>
-            <a:ext cx="7000875" cy="1638300"/>
+                <a16:creationId xmlns:a16="http://schemas.microsoft.com/office/drawing/2014/main" id="{2DC4997E-C3BB-431B-ABB7-947450C7AAA4}"/>
+              </a:ext>
+            </a:extLst>
+          </p:cNvPr>
+          <p:cNvSpPr>
+            <a:spLocks xmlns:a="http://schemas.openxmlformats.org/drawingml/2006/main" noGrp="1"/>
+          </p:cNvSpPr>
+          <p:nvPr/>
+        </p:nvSpPr>
+        <p:spPr>
+          <a:xfrm xmlns:a="http://schemas.openxmlformats.org/drawingml/2006/main">
+            <a:off x="819150" y="3705225"/>
+            <a:ext cx="6858000" cy="428625"/>
           </a:xfrm>
           <a:prstGeom xmlns:a="http://schemas.openxmlformats.org/drawingml/2006/main" prst="rect">
             <a:avLst/>
@@ -11544,71 +11544,25 @@
           <a:lstStyle xmlns:a="http://schemas.openxmlformats.org/drawingml/2006/main"/>
           <a:p xmlns:a="http://schemas.openxmlformats.org/drawingml/2006/main">
             <a:pPr>
-              <a:defRPr sz="2550" b="0">
-                <a:solidFill>
-                  <a:srgbClr val="182C29"/>
-                </a:solidFill>
-                <a:latin typeface="Apple SD Gothic Neo"/>
-                <a:ea typeface="Apple SD Gothic Neo"/>
-                <a:cs typeface="Apple SD Gothic Neo"/>
-              </a:defRPr>
-            </a:pPr>
-            <a:r>
-              <a:rPr sz="2550" b="0">
-                <a:solidFill>
-                  <a:srgbClr val="182C29"/>
-                </a:solidFill>
-                <a:latin typeface="Apple SD Gothic Neo"/>
-                <a:ea typeface="Apple SD Gothic Neo"/>
-                <a:cs typeface="Apple SD Gothic Neo"/>
-              </a:rPr>
-              <a:t>Blu-ray 1개 주문 결과 대조</a:t>
-            </a:r>
-          </a:p>
-          <a:p xmlns:a="http://schemas.openxmlformats.org/drawingml/2006/main">
-            <a:pPr>
-              <a:defRPr sz="2550" b="0">
-                <a:solidFill>
-                  <a:srgbClr val="182C29"/>
-                </a:solidFill>
-                <a:latin typeface="Apple SD Gothic Neo"/>
-                <a:ea typeface="Apple SD Gothic Neo"/>
-                <a:cs typeface="Apple SD Gothic Neo"/>
-              </a:defRPr>
-            </a:pPr>
-            <a:r>
-              <a:rPr sz="2550" b="0">
-                <a:solidFill>
-                  <a:srgbClr val="182C29"/>
-                </a:solidFill>
-                <a:latin typeface="Apple SD Gothic Neo"/>
-                <a:ea typeface="Apple SD Gothic Neo"/>
-                <a:cs typeface="Apple SD Gothic Neo"/>
-              </a:rPr>
-              <a:t>몰테일 접수 화면과 저장 목록 확인</a:t>
-            </a:r>
-          </a:p>
-          <a:p xmlns:a="http://schemas.openxmlformats.org/drawingml/2006/main">
-            <a:pPr>
-              <a:defRPr sz="2550" b="0">
-                <a:solidFill>
-                  <a:srgbClr val="182C29"/>
-                </a:solidFill>
-                <a:latin typeface="Apple SD Gothic Neo"/>
-                <a:ea typeface="Apple SD Gothic Neo"/>
-                <a:cs typeface="Apple SD Gothic Neo"/>
-              </a:defRPr>
-            </a:pPr>
-            <a:r>
-              <a:rPr sz="2550" b="0">
-                <a:solidFill>
-                  <a:srgbClr val="182C29"/>
-                </a:solidFill>
-                <a:latin typeface="Apple SD Gothic Neo"/>
-                <a:ea typeface="Apple SD Gothic Neo"/>
-                <a:cs typeface="Apple SD Gothic Neo"/>
-              </a:rPr>
-              <a:t>주문 합계 5,616엔</a:t>
+              <a:defRPr sz="2250" b="1">
+                <a:solidFill>
+                  <a:srgbClr val="182C29"/>
+                </a:solidFill>
+                <a:latin typeface="Apple SD Gothic Neo"/>
+                <a:ea typeface="Apple SD Gothic Neo"/>
+                <a:cs typeface="Apple SD Gothic Neo"/>
+              </a:defRPr>
+            </a:pPr>
+            <a:r>
+              <a:rPr sz="2250" b="1">
+                <a:solidFill>
+                  <a:srgbClr val="182C29"/>
+                </a:solidFill>
+                <a:latin typeface="Apple SD Gothic Neo"/>
+                <a:ea typeface="Apple SD Gothic Neo"/>
+                <a:cs typeface="Apple SD Gothic Neo"/>
+              </a:rPr>
+              <a:t>후속 응답의 구성</a:t>
             </a:r>
           </a:p>
         </p:txBody>
@@ -11618,19 +11572,19 @@
           <p:cNvPr id="6" name="">
             <a:extLst xmlns:a="http://schemas.openxmlformats.org/drawingml/2006/main">
               <a:ext uri="{FF2B5EF4-FFF2-40B4-BE49-F238E27FC236}">
-                <a16:creationId xmlns:a16="http://schemas.microsoft.com/office/drawing/2014/main" id="{91042D60-028D-41BC-BC42-51618D129109}"/>
-              </a:ext>
-            </a:extLst>
-          </p:cNvPr>
-          <p:cNvSpPr>
-            <a:spLocks xmlns:a="http://schemas.openxmlformats.org/drawingml/2006/main" noGrp="1"/>
-          </p:cNvSpPr>
-          <p:nvPr/>
-        </p:nvSpPr>
-        <p:spPr>
-          <a:xfrm xmlns:a="http://schemas.openxmlformats.org/drawingml/2006/main">
-            <a:off x="819150" y="5572125"/>
-            <a:ext cx="7000875" cy="476250"/>
+                <a16:creationId xmlns:a16="http://schemas.microsoft.com/office/drawing/2014/main" id="{36B9FD9E-D4B8-4E06-9394-468868762BF6}"/>
+              </a:ext>
+            </a:extLst>
+          </p:cNvPr>
+          <p:cNvSpPr>
+            <a:spLocks xmlns:a="http://schemas.openxmlformats.org/drawingml/2006/main" noGrp="1"/>
+          </p:cNvSpPr>
+          <p:nvPr/>
+        </p:nvSpPr>
+        <p:spPr>
+          <a:xfrm xmlns:a="http://schemas.openxmlformats.org/drawingml/2006/main">
+            <a:off x="819150" y="4429125"/>
+            <a:ext cx="5238750" cy="409575"/>
           </a:xfrm>
           <a:prstGeom xmlns:a="http://schemas.openxmlformats.org/drawingml/2006/main" prst="rect">
             <a:avLst/>
@@ -11647,25 +11601,25 @@
           <a:lstStyle xmlns:a="http://schemas.openxmlformats.org/drawingml/2006/main"/>
           <a:p xmlns:a="http://schemas.openxmlformats.org/drawingml/2006/main">
             <a:pPr>
-              <a:defRPr sz="2400" b="1">
-                <a:solidFill>
-                  <a:srgbClr val="182C29"/>
-                </a:solidFill>
-                <a:latin typeface="Apple SD Gothic Neo"/>
-                <a:ea typeface="Apple SD Gothic Neo"/>
-                <a:cs typeface="Apple SD Gothic Neo"/>
-              </a:defRPr>
-            </a:pPr>
-            <a:r>
-              <a:rPr sz="2400" b="1">
-                <a:solidFill>
-                  <a:srgbClr val="182C29"/>
-                </a:solidFill>
-                <a:latin typeface="Apple SD Gothic Neo"/>
-                <a:ea typeface="Apple SD Gothic Neo"/>
-                <a:cs typeface="Apple SD Gothic Neo"/>
-              </a:rPr>
-              <a:t>과정에서 확인한 보완점</a:t>
+              <a:defRPr sz="2250" b="0">
+                <a:solidFill>
+                  <a:srgbClr val="182C29"/>
+                </a:solidFill>
+                <a:latin typeface="Apple SD Gothic Neo"/>
+                <a:ea typeface="Apple SD Gothic Neo"/>
+                <a:cs typeface="Apple SD Gothic Neo"/>
+              </a:defRPr>
+            </a:pPr>
+            <a:r>
+              <a:rPr sz="2250" b="0">
+                <a:solidFill>
+                  <a:srgbClr val="182C29"/>
+                </a:solidFill>
+                <a:latin typeface="Apple SD Gothic Neo"/>
+                <a:ea typeface="Apple SD Gothic Neo"/>
+                <a:cs typeface="Apple SD Gothic Neo"/>
+              </a:rPr>
+              <a:t>로그인 완료 알림</a:t>
             </a:r>
           </a:p>
         </p:txBody>
@@ -11675,19 +11629,19 @@
           <p:cNvPr id="7" name="">
             <a:extLst xmlns:a="http://schemas.openxmlformats.org/drawingml/2006/main">
               <a:ext uri="{FF2B5EF4-FFF2-40B4-BE49-F238E27FC236}">
-                <a16:creationId xmlns:a16="http://schemas.microsoft.com/office/drawing/2014/main" id="{8DAA4FCE-B064-4398-80D7-DE0CB2588BFA}"/>
-              </a:ext>
-            </a:extLst>
-          </p:cNvPr>
-          <p:cNvSpPr>
-            <a:spLocks xmlns:a="http://schemas.openxmlformats.org/drawingml/2006/main" noGrp="1"/>
-          </p:cNvSpPr>
-          <p:nvPr/>
-        </p:nvSpPr>
-        <p:spPr>
-          <a:xfrm xmlns:a="http://schemas.openxmlformats.org/drawingml/2006/main">
-            <a:off x="819150" y="6267450"/>
-            <a:ext cx="7000875" cy="1000125"/>
+                <a16:creationId xmlns:a16="http://schemas.microsoft.com/office/drawing/2014/main" id="{5F4B69D8-0741-4827-B2B2-AD2791EAEE27}"/>
+              </a:ext>
+            </a:extLst>
+          </p:cNvPr>
+          <p:cNvSpPr>
+            <a:spLocks xmlns:a="http://schemas.openxmlformats.org/drawingml/2006/main" noGrp="1"/>
+          </p:cNvSpPr>
+          <p:nvPr/>
+        </p:nvSpPr>
+        <p:spPr>
+          <a:xfrm xmlns:a="http://schemas.openxmlformats.org/drawingml/2006/main">
+            <a:off x="6381750" y="4429125"/>
+            <a:ext cx="1095375" cy="409575"/>
           </a:xfrm>
           <a:prstGeom xmlns:a="http://schemas.openxmlformats.org/drawingml/2006/main" prst="rect">
             <a:avLst/>
@@ -11704,68 +11658,273 @@
           <a:lstStyle xmlns:a="http://schemas.openxmlformats.org/drawingml/2006/main"/>
           <a:p xmlns:a="http://schemas.openxmlformats.org/drawingml/2006/main">
             <a:pPr>
-              <a:defRPr sz="2175" b="0">
-                <a:solidFill>
-                  <a:srgbClr val="182C29"/>
-                </a:solidFill>
-                <a:latin typeface="Apple SD Gothic Neo"/>
-                <a:ea typeface="Apple SD Gothic Neo"/>
-                <a:cs typeface="Apple SD Gothic Neo"/>
-              </a:defRPr>
-            </a:pPr>
-            <a:r>
-              <a:rPr sz="2175" b="0">
-                <a:solidFill>
-                  <a:srgbClr val="182C29"/>
-                </a:solidFill>
-                <a:latin typeface="Apple SD Gothic Neo"/>
-                <a:ea typeface="Apple SD Gothic Neo"/>
-                <a:cs typeface="Apple SD Gothic Neo"/>
-              </a:rPr>
-              <a:t>치수 없는 견적·USD 환산 처리</a:t>
-            </a:r>
-          </a:p>
-          <a:p xmlns:a="http://schemas.openxmlformats.org/drawingml/2006/main">
-            <a:pPr>
-              <a:defRPr sz="2175" b="0">
-                <a:solidFill>
-                  <a:srgbClr val="182C29"/>
-                </a:solidFill>
-                <a:latin typeface="Apple SD Gothic Neo"/>
-                <a:ea typeface="Apple SD Gothic Neo"/>
-                <a:cs typeface="Apple SD Gothic Neo"/>
-              </a:defRPr>
-            </a:pPr>
-            <a:r>
-              <a:rPr sz="2175" b="0">
-                <a:solidFill>
-                  <a:srgbClr val="182C29"/>
-                </a:solidFill>
-                <a:latin typeface="Apple SD Gothic Neo"/>
-                <a:ea typeface="Apple SD Gothic Neo"/>
-                <a:cs typeface="Apple SD Gothic Neo"/>
-              </a:rPr>
-              <a:t>사용자 직접 주문의 상태 가져오기</a:t>
+              <a:defRPr sz="2475" b="1">
+                <a:solidFill>
+                  <a:srgbClr val="182C29"/>
+                </a:solidFill>
+                <a:latin typeface="Apple SD Gothic Neo"/>
+                <a:ea typeface="Apple SD Gothic Neo"/>
+                <a:cs typeface="Apple SD Gothic Neo"/>
+              </a:defRPr>
+            </a:pPr>
+            <a:r>
+              <a:rPr sz="2475" b="1">
+                <a:solidFill>
+                  <a:srgbClr val="182C29"/>
+                </a:solidFill>
+                <a:latin typeface="Apple SD Gothic Neo"/>
+                <a:ea typeface="Apple SD Gothic Neo"/>
+                <a:cs typeface="Apple SD Gothic Neo"/>
+              </a:rPr>
+              <a:t>2회</a:t>
+            </a:r>
+          </a:p>
+        </p:txBody>
+      </p:sp>
+      <p:sp>
+        <p:nvSpPr>
+          <p:cNvPr id="8" name="">
+            <a:extLst xmlns:a="http://schemas.openxmlformats.org/drawingml/2006/main">
+              <a:ext uri="{FF2B5EF4-FFF2-40B4-BE49-F238E27FC236}">
+                <a16:creationId xmlns:a16="http://schemas.microsoft.com/office/drawing/2014/main" id="{0879CC88-FF89-4A56-9D8F-B81FF3A38F2C}"/>
+              </a:ext>
+            </a:extLst>
+          </p:cNvPr>
+          <p:cNvSpPr>
+            <a:spLocks xmlns:a="http://schemas.openxmlformats.org/drawingml/2006/main" noGrp="1"/>
+          </p:cNvSpPr>
+          <p:nvPr/>
+        </p:nvSpPr>
+        <p:spPr>
+          <a:xfrm xmlns:a="http://schemas.openxmlformats.org/drawingml/2006/main">
+            <a:off x="819150" y="5038725"/>
+            <a:ext cx="5238750" cy="409575"/>
+          </a:xfrm>
+          <a:prstGeom xmlns:a="http://schemas.openxmlformats.org/drawingml/2006/main" prst="rect">
+            <a:avLst/>
+          </a:prstGeom>
+          <a:noFill xmlns:a="http://schemas.openxmlformats.org/drawingml/2006/main"/>
+          <a:ln xmlns:a="http://schemas.openxmlformats.org/drawingml/2006/main" w="0">
+            <a:noFill/>
+          </a:ln>
+        </p:spPr>
+        <p:txBody>
+          <a:bodyPr xmlns:a="http://schemas.openxmlformats.org/drawingml/2006/main" wrap="square" lIns="0" tIns="0" rIns="0" bIns="0">
+            <a:noAutofit/>
+          </a:bodyPr>
+          <a:lstStyle xmlns:a="http://schemas.openxmlformats.org/drawingml/2006/main"/>
+          <a:p xmlns:a="http://schemas.openxmlformats.org/drawingml/2006/main">
+            <a:pPr>
+              <a:defRPr sz="2250" b="0">
+                <a:solidFill>
+                  <a:srgbClr val="182C29"/>
+                </a:solidFill>
+                <a:latin typeface="Apple SD Gothic Neo"/>
+                <a:ea typeface="Apple SD Gothic Neo"/>
+                <a:cs typeface="Apple SD Gothic Neo"/>
+              </a:defRPr>
+            </a:pPr>
+            <a:r>
+              <a:rPr sz="2250" b="0">
+                <a:solidFill>
+                  <a:srgbClr val="182C29"/>
+                </a:solidFill>
+                <a:latin typeface="Apple SD Gothic Neo"/>
+                <a:ea typeface="Apple SD Gothic Neo"/>
+                <a:cs typeface="Apple SD Gothic Neo"/>
+              </a:rPr>
+              <a:t>입력·제출 승인</a:t>
+            </a:r>
+          </a:p>
+        </p:txBody>
+      </p:sp>
+      <p:sp>
+        <p:nvSpPr>
+          <p:cNvPr id="9" name="">
+            <a:extLst xmlns:a="http://schemas.openxmlformats.org/drawingml/2006/main">
+              <a:ext uri="{FF2B5EF4-FFF2-40B4-BE49-F238E27FC236}">
+                <a16:creationId xmlns:a16="http://schemas.microsoft.com/office/drawing/2014/main" id="{AA19C455-9852-45B6-A8E1-1B99C3A7863A}"/>
+              </a:ext>
+            </a:extLst>
+          </p:cNvPr>
+          <p:cNvSpPr>
+            <a:spLocks xmlns:a="http://schemas.openxmlformats.org/drawingml/2006/main" noGrp="1"/>
+          </p:cNvSpPr>
+          <p:nvPr/>
+        </p:nvSpPr>
+        <p:spPr>
+          <a:xfrm xmlns:a="http://schemas.openxmlformats.org/drawingml/2006/main">
+            <a:off x="6381750" y="5038725"/>
+            <a:ext cx="1095375" cy="409575"/>
+          </a:xfrm>
+          <a:prstGeom xmlns:a="http://schemas.openxmlformats.org/drawingml/2006/main" prst="rect">
+            <a:avLst/>
+          </a:prstGeom>
+          <a:noFill xmlns:a="http://schemas.openxmlformats.org/drawingml/2006/main"/>
+          <a:ln xmlns:a="http://schemas.openxmlformats.org/drawingml/2006/main" w="0">
+            <a:noFill/>
+          </a:ln>
+        </p:spPr>
+        <p:txBody>
+          <a:bodyPr xmlns:a="http://schemas.openxmlformats.org/drawingml/2006/main" wrap="square" lIns="0" tIns="0" rIns="0" bIns="0">
+            <a:noAutofit/>
+          </a:bodyPr>
+          <a:lstStyle xmlns:a="http://schemas.openxmlformats.org/drawingml/2006/main"/>
+          <a:p xmlns:a="http://schemas.openxmlformats.org/drawingml/2006/main">
+            <a:pPr>
+              <a:defRPr sz="2475" b="1">
+                <a:solidFill>
+                  <a:srgbClr val="182C29"/>
+                </a:solidFill>
+                <a:latin typeface="Apple SD Gothic Neo"/>
+                <a:ea typeface="Apple SD Gothic Neo"/>
+                <a:cs typeface="Apple SD Gothic Neo"/>
+              </a:defRPr>
+            </a:pPr>
+            <a:r>
+              <a:rPr sz="2475" b="1">
+                <a:solidFill>
+                  <a:srgbClr val="182C29"/>
+                </a:solidFill>
+                <a:latin typeface="Apple SD Gothic Neo"/>
+                <a:ea typeface="Apple SD Gothic Neo"/>
+                <a:cs typeface="Apple SD Gothic Neo"/>
+              </a:rPr>
+              <a:t>2회</a:t>
+            </a:r>
+          </a:p>
+        </p:txBody>
+      </p:sp>
+      <p:sp>
+        <p:nvSpPr>
+          <p:cNvPr id="10" name="">
+            <a:extLst xmlns:a="http://schemas.openxmlformats.org/drawingml/2006/main">
+              <a:ext uri="{FF2B5EF4-FFF2-40B4-BE49-F238E27FC236}">
+                <a16:creationId xmlns:a16="http://schemas.microsoft.com/office/drawing/2014/main" id="{104DFF5F-0547-425A-9625-9CD9C62BF04F}"/>
+              </a:ext>
+            </a:extLst>
+          </p:cNvPr>
+          <p:cNvSpPr>
+            <a:spLocks xmlns:a="http://schemas.openxmlformats.org/drawingml/2006/main" noGrp="1"/>
+          </p:cNvSpPr>
+          <p:nvPr/>
+        </p:nvSpPr>
+        <p:spPr>
+          <a:xfrm xmlns:a="http://schemas.openxmlformats.org/drawingml/2006/main">
+            <a:off x="819150" y="5648325"/>
+            <a:ext cx="5238750" cy="409575"/>
+          </a:xfrm>
+          <a:prstGeom xmlns:a="http://schemas.openxmlformats.org/drawingml/2006/main" prst="rect">
+            <a:avLst/>
+          </a:prstGeom>
+          <a:noFill xmlns:a="http://schemas.openxmlformats.org/drawingml/2006/main"/>
+          <a:ln xmlns:a="http://schemas.openxmlformats.org/drawingml/2006/main" w="0">
+            <a:noFill/>
+          </a:ln>
+        </p:spPr>
+        <p:txBody>
+          <a:bodyPr xmlns:a="http://schemas.openxmlformats.org/drawingml/2006/main" wrap="square" lIns="0" tIns="0" rIns="0" bIns="0">
+            <a:noAutofit/>
+          </a:bodyPr>
+          <a:lstStyle xmlns:a="http://schemas.openxmlformats.org/drawingml/2006/main"/>
+          <a:p xmlns:a="http://schemas.openxmlformats.org/drawingml/2006/main">
+            <a:pPr>
+              <a:defRPr sz="2250" b="0">
+                <a:solidFill>
+                  <a:srgbClr val="182C29"/>
+                </a:solidFill>
+                <a:latin typeface="Apple SD Gothic Neo"/>
+                <a:ea typeface="Apple SD Gothic Neo"/>
+                <a:cs typeface="Apple SD Gothic Neo"/>
+              </a:defRPr>
+            </a:pPr>
+            <a:r>
+              <a:rPr sz="2250" b="0">
+                <a:solidFill>
+                  <a:srgbClr val="182C29"/>
+                </a:solidFill>
+                <a:latin typeface="Apple SD Gothic Neo"/>
+                <a:ea typeface="Apple SD Gothic Neo"/>
+                <a:cs typeface="Apple SD Gothic Neo"/>
+              </a:rPr>
+              <a:t>구매·인증 완료 알림</a:t>
+            </a:r>
+          </a:p>
+        </p:txBody>
+      </p:sp>
+      <p:sp>
+        <p:nvSpPr>
+          <p:cNvPr id="11" name="">
+            <a:extLst xmlns:a="http://schemas.openxmlformats.org/drawingml/2006/main">
+              <a:ext uri="{FF2B5EF4-FFF2-40B4-BE49-F238E27FC236}">
+                <a16:creationId xmlns:a16="http://schemas.microsoft.com/office/drawing/2014/main" id="{27191E77-8FE3-447E-936B-1F621C556414}"/>
+              </a:ext>
+            </a:extLst>
+          </p:cNvPr>
+          <p:cNvSpPr>
+            <a:spLocks xmlns:a="http://schemas.openxmlformats.org/drawingml/2006/main" noGrp="1"/>
+          </p:cNvSpPr>
+          <p:nvPr/>
+        </p:nvSpPr>
+        <p:spPr>
+          <a:xfrm xmlns:a="http://schemas.openxmlformats.org/drawingml/2006/main">
+            <a:off x="6381750" y="5648325"/>
+            <a:ext cx="1095375" cy="409575"/>
+          </a:xfrm>
+          <a:prstGeom xmlns:a="http://schemas.openxmlformats.org/drawingml/2006/main" prst="rect">
+            <a:avLst/>
+          </a:prstGeom>
+          <a:noFill xmlns:a="http://schemas.openxmlformats.org/drawingml/2006/main"/>
+          <a:ln xmlns:a="http://schemas.openxmlformats.org/drawingml/2006/main" w="0">
+            <a:noFill/>
+          </a:ln>
+        </p:spPr>
+        <p:txBody>
+          <a:bodyPr xmlns:a="http://schemas.openxmlformats.org/drawingml/2006/main" wrap="square" lIns="0" tIns="0" rIns="0" bIns="0">
+            <a:noAutofit/>
+          </a:bodyPr>
+          <a:lstStyle xmlns:a="http://schemas.openxmlformats.org/drawingml/2006/main"/>
+          <a:p xmlns:a="http://schemas.openxmlformats.org/drawingml/2006/main">
+            <a:pPr>
+              <a:defRPr sz="2475" b="1">
+                <a:solidFill>
+                  <a:srgbClr val="182C29"/>
+                </a:solidFill>
+                <a:latin typeface="Apple SD Gothic Neo"/>
+                <a:ea typeface="Apple SD Gothic Neo"/>
+                <a:cs typeface="Apple SD Gothic Neo"/>
+              </a:defRPr>
+            </a:pPr>
+            <a:r>
+              <a:rPr sz="2475" b="1">
+                <a:solidFill>
+                  <a:srgbClr val="182C29"/>
+                </a:solidFill>
+                <a:latin typeface="Apple SD Gothic Neo"/>
+                <a:ea typeface="Apple SD Gothic Neo"/>
+                <a:cs typeface="Apple SD Gothic Neo"/>
+              </a:rPr>
+              <a:t>2회</a:t>
             </a:r>
           </a:p>
         </p:txBody>
       </p:sp>
       <p:pic>
         <p:nvPicPr>
-          <p:cNvPr id="17" name=""/>
+          <p:cNvPr id="26" name=""/>
           <p:cNvPicPr>
             <a:picLocks xmlns:a="http://schemas.openxmlformats.org/drawingml/2006/main" noChangeAspect="1"/>
           </p:cNvPicPr>
           <p:nvPr/>
         </p:nvPicPr>
         <p:blipFill>
-          <a:blip xmlns:r="http://schemas.openxmlformats.org/officeDocument/2006/relationships" xmlns:a="http://schemas.openxmlformats.org/drawingml/2006/main" r:embed="R04b17245d6bc4fee"/>
+          <a:blip xmlns:r="http://schemas.openxmlformats.org/officeDocument/2006/relationships" xmlns:a="http://schemas.openxmlformats.org/drawingml/2006/main" r:embed="R41afe7e037a44ba4"/>
           <a:stretch xmlns:a="http://schemas.openxmlformats.org/drawingml/2006/main"/>
         </p:blipFill>
         <p:spPr>
           <a:xfrm xmlns:a="http://schemas.openxmlformats.org/drawingml/2006/main">
-            <a:off x="8959255" y="2724150"/>
-            <a:ext cx="5093891" cy="4048125"/>
+            <a:off x="9636125" y="3667125"/>
+            <a:ext cx="3835400" cy="3048000"/>
           </a:xfrm>
           <a:prstGeom xmlns:a="http://schemas.openxmlformats.org/drawingml/2006/main" prst="rect">
             <a:avLst/>
@@ -11774,22 +11933,22 @@
       </p:pic>
       <p:sp>
         <p:nvSpPr>
-          <p:cNvPr id="9" name="">
-            <a:extLst xmlns:a="http://schemas.openxmlformats.org/drawingml/2006/main">
-              <a:ext uri="{FF2B5EF4-FFF2-40B4-BE49-F238E27FC236}">
-                <a16:creationId xmlns:a16="http://schemas.microsoft.com/office/drawing/2014/main" id="{3F8C857E-7EC8-43C0-97CB-2AD3679BF13B}"/>
-              </a:ext>
-            </a:extLst>
-          </p:cNvPr>
-          <p:cNvSpPr>
-            <a:spLocks xmlns:a="http://schemas.openxmlformats.org/drawingml/2006/main" noGrp="1"/>
-          </p:cNvSpPr>
-          <p:nvPr/>
-        </p:nvSpPr>
-        <p:spPr>
-          <a:xfrm xmlns:a="http://schemas.openxmlformats.org/drawingml/2006/main">
-            <a:off x="819150" y="7572375"/>
-            <a:ext cx="13525500" cy="333375"/>
+          <p:cNvPr id="13" name="">
+            <a:extLst xmlns:a="http://schemas.openxmlformats.org/drawingml/2006/main">
+              <a:ext uri="{FF2B5EF4-FFF2-40B4-BE49-F238E27FC236}">
+                <a16:creationId xmlns:a16="http://schemas.microsoft.com/office/drawing/2014/main" id="{8021B688-5EC8-482B-9018-4288EF213868}"/>
+              </a:ext>
+            </a:extLst>
+          </p:cNvPr>
+          <p:cNvSpPr>
+            <a:spLocks xmlns:a="http://schemas.openxmlformats.org/drawingml/2006/main" noGrp="1"/>
+          </p:cNvSpPr>
+          <p:nvPr/>
+        </p:nvSpPr>
+        <p:spPr>
+          <a:xfrm xmlns:a="http://schemas.openxmlformats.org/drawingml/2006/main">
+            <a:off x="819150" y="6819900"/>
+            <a:ext cx="13525500" cy="561975"/>
           </a:xfrm>
           <a:prstGeom xmlns:a="http://schemas.openxmlformats.org/drawingml/2006/main" prst="rect">
             <a:avLst/>
@@ -11806,6 +11965,63 @@
           <a:lstStyle xmlns:a="http://schemas.openxmlformats.org/drawingml/2006/main"/>
           <a:p xmlns:a="http://schemas.openxmlformats.org/drawingml/2006/main">
             <a:pPr>
+              <a:defRPr sz="2175" b="0">
+                <a:solidFill>
+                  <a:srgbClr val="182C29"/>
+                </a:solidFill>
+                <a:latin typeface="Apple SD Gothic Neo"/>
+                <a:ea typeface="Apple SD Gothic Neo"/>
+                <a:cs typeface="Apple SD Gothic Neo"/>
+              </a:defRPr>
+            </a:pPr>
+            <a:r>
+              <a:rPr sz="2175" b="0">
+                <a:solidFill>
+                  <a:srgbClr val="182C29"/>
+                </a:solidFill>
+                <a:latin typeface="Apple SD Gothic Neo"/>
+                <a:ea typeface="Apple SD Gothic Neo"/>
+                <a:cs typeface="Apple SD Gothic Neo"/>
+              </a:rPr>
+              <a:t>에이전트가 상품·배송지 확인, 주문 정보 입력과 신청 결과 대조를 수행했습니다.</a:t>
+            </a:r>
+          </a:p>
+        </p:txBody>
+      </p:sp>
+      <p:sp>
+        <p:nvSpPr>
+          <p:cNvPr id="14" name="">
+            <a:extLst xmlns:a="http://schemas.openxmlformats.org/drawingml/2006/main">
+              <a:ext uri="{FF2B5EF4-FFF2-40B4-BE49-F238E27FC236}">
+                <a16:creationId xmlns:a16="http://schemas.microsoft.com/office/drawing/2014/main" id="{FED6F85D-0776-4731-99E4-C4FD45F1B936}"/>
+              </a:ext>
+            </a:extLst>
+          </p:cNvPr>
+          <p:cNvSpPr>
+            <a:spLocks xmlns:a="http://schemas.openxmlformats.org/drawingml/2006/main" noGrp="1"/>
+          </p:cNvSpPr>
+          <p:nvPr/>
+        </p:nvSpPr>
+        <p:spPr>
+          <a:xfrm xmlns:a="http://schemas.openxmlformats.org/drawingml/2006/main">
+            <a:off x="819150" y="7505700"/>
+            <a:ext cx="13525500" cy="400050"/>
+          </a:xfrm>
+          <a:prstGeom xmlns:a="http://schemas.openxmlformats.org/drawingml/2006/main" prst="rect">
+            <a:avLst/>
+          </a:prstGeom>
+          <a:noFill xmlns:a="http://schemas.openxmlformats.org/drawingml/2006/main"/>
+          <a:ln xmlns:a="http://schemas.openxmlformats.org/drawingml/2006/main" w="0">
+            <a:noFill/>
+          </a:ln>
+        </p:spPr>
+        <p:txBody>
+          <a:bodyPr xmlns:a="http://schemas.openxmlformats.org/drawingml/2006/main" wrap="square" lIns="0" tIns="0" rIns="0" bIns="0">
+            <a:noAutofit/>
+          </a:bodyPr>
+          <a:lstStyle xmlns:a="http://schemas.openxmlformats.org/drawingml/2006/main"/>
+          <a:p xmlns:a="http://schemas.openxmlformats.org/drawingml/2006/main">
+            <a:pPr>
               <a:defRPr sz="1725" b="0">
                 <a:solidFill>
                   <a:srgbClr val="5E706B"/>
@@ -11824,7 +12040,7 @@
                 <a:ea typeface="Apple SD Gothic Neo"/>
                 <a:cs typeface="Apple SD Gothic Neo"/>
               </a:rPr>
-              <a:t>최종 구매·인증은 사용자 수행. 1건의 시험이며 국제운임·수령·시간 절감은 미검증입니다.</a:t>
+              <a:t>단일 사례 · 사용자 메시지 7회 기준. 로그인·직접 구매·통관 인증의 화면 조작 횟수는 미측정입니다.</a:t>
             </a:r>
           </a:p>
         </p:txBody>
@@ -11832,7 +12048,7 @@
     </p:spTree>
     <p:extLst>
       <p:ext uri="{BB962C8B-B14F-4D97-AF65-F5344CB8AC3E}">
-        <p14:creationId xmlns:p14="http://schemas.microsoft.com/office/powerpoint/2010/main" val="1912135611"/>
+        <p14:creationId xmlns:p14="http://schemas.microsoft.com/office/powerpoint/2010/main" val="2122948604"/>
       </p:ext>
     </p:extLst>
   </p:cSld>

</xml_diff>

<commit_message>
docs: clarify dialogue and align customs result comparison
</commit_message>
<xml_diff>
--- a/portfolio/crossborder-portfolio.pptx
+++ b/portfolio/crossborder-portfolio.pptx
@@ -2,27 +2,27 @@
 <file path=ppt/presentation.xml><?xml version="1.0" encoding="utf-8"?>
 <p:presentation xmlns:p="http://schemas.openxmlformats.org/presentationml/2006/main">
   <p:sldMasterIdLst>
-    <p:sldMasterId xmlns:r="http://schemas.openxmlformats.org/officeDocument/2006/relationships" id="2147483648" r:id="Rad8a6779f1e44967"/>
+    <p:sldMasterId xmlns:r="http://schemas.openxmlformats.org/officeDocument/2006/relationships" id="2147483648" r:id="R88170057f71b4b63"/>
   </p:sldMasterIdLst>
   <p:notesMasterIdLst>
-    <p:notesMasterId xmlns:r="http://schemas.openxmlformats.org/officeDocument/2006/relationships" r:id="Re66d74b6ce18407b"/>
+    <p:notesMasterId xmlns:r="http://schemas.openxmlformats.org/officeDocument/2006/relationships" r:id="Rfb2b528ceff84fba"/>
   </p:notesMasterIdLst>
   <p:sldIdLst>
-    <p:sldId xmlns:r="http://schemas.openxmlformats.org/officeDocument/2006/relationships" id="256" r:id="R8b466ccba2b44cee"/>
-    <p:sldId xmlns:r="http://schemas.openxmlformats.org/officeDocument/2006/relationships" id="257" r:id="R351d582ff7dc4433"/>
-    <p:sldId xmlns:r="http://schemas.openxmlformats.org/officeDocument/2006/relationships" id="258" r:id="R250395586d3c4ec2"/>
-    <p:sldId xmlns:r="http://schemas.openxmlformats.org/officeDocument/2006/relationships" id="259" r:id="Rf2ed4dc6729e4fb8"/>
-    <p:sldId xmlns:r="http://schemas.openxmlformats.org/officeDocument/2006/relationships" id="260" r:id="Rb1afa4d48b4040eb"/>
-    <p:sldId xmlns:r="http://schemas.openxmlformats.org/officeDocument/2006/relationships" id="261" r:id="Rcd72e8ed1cf34fcb"/>
-    <p:sldId xmlns:r="http://schemas.openxmlformats.org/officeDocument/2006/relationships" id="262" r:id="R3ed6c5fac48b4430"/>
-    <p:sldId xmlns:r="http://schemas.openxmlformats.org/officeDocument/2006/relationships" id="263" r:id="R1d85c9dca2e54b67"/>
-    <p:sldId xmlns:r="http://schemas.openxmlformats.org/officeDocument/2006/relationships" id="264" r:id="R5d7b63fc76284acd"/>
-    <p:sldId xmlns:r="http://schemas.openxmlformats.org/officeDocument/2006/relationships" id="265" r:id="R50539a2b91374dfe"/>
-    <p:sldId xmlns:r="http://schemas.openxmlformats.org/officeDocument/2006/relationships" id="266" r:id="R67e5f2ce2f034873"/>
-    <p:sldId xmlns:r="http://schemas.openxmlformats.org/officeDocument/2006/relationships" id="267" r:id="R8a98edd65a194c54"/>
-    <p:sldId xmlns:r="http://schemas.openxmlformats.org/officeDocument/2006/relationships" id="268" r:id="R2e151335386b4809"/>
-    <p:sldId xmlns:r="http://schemas.openxmlformats.org/officeDocument/2006/relationships" id="269" r:id="Rdcb44e1371bc4c91"/>
-    <p:sldId xmlns:r="http://schemas.openxmlformats.org/officeDocument/2006/relationships" id="270" r:id="R7afbc7bb12804a58"/>
+    <p:sldId xmlns:r="http://schemas.openxmlformats.org/officeDocument/2006/relationships" id="256" r:id="Rb078ae17c36c47c2"/>
+    <p:sldId xmlns:r="http://schemas.openxmlformats.org/officeDocument/2006/relationships" id="257" r:id="R4efa3a5b21894e11"/>
+    <p:sldId xmlns:r="http://schemas.openxmlformats.org/officeDocument/2006/relationships" id="258" r:id="R4d4a45447acc4418"/>
+    <p:sldId xmlns:r="http://schemas.openxmlformats.org/officeDocument/2006/relationships" id="259" r:id="R1e8331fce1d14121"/>
+    <p:sldId xmlns:r="http://schemas.openxmlformats.org/officeDocument/2006/relationships" id="260" r:id="Rdcce53d1ec184046"/>
+    <p:sldId xmlns:r="http://schemas.openxmlformats.org/officeDocument/2006/relationships" id="261" r:id="R1c3ba589ed7749f1"/>
+    <p:sldId xmlns:r="http://schemas.openxmlformats.org/officeDocument/2006/relationships" id="262" r:id="Ra864fac0329344fd"/>
+    <p:sldId xmlns:r="http://schemas.openxmlformats.org/officeDocument/2006/relationships" id="263" r:id="R9b5066aa80c74c98"/>
+    <p:sldId xmlns:r="http://schemas.openxmlformats.org/officeDocument/2006/relationships" id="264" r:id="R799bc67a15614b69"/>
+    <p:sldId xmlns:r="http://schemas.openxmlformats.org/officeDocument/2006/relationships" id="265" r:id="Rcc7bce014304441b"/>
+    <p:sldId xmlns:r="http://schemas.openxmlformats.org/officeDocument/2006/relationships" id="266" r:id="R058cc943fa3c46fa"/>
+    <p:sldId xmlns:r="http://schemas.openxmlformats.org/officeDocument/2006/relationships" id="267" r:id="R2e33d6c9e9aa4a0b"/>
+    <p:sldId xmlns:r="http://schemas.openxmlformats.org/officeDocument/2006/relationships" id="268" r:id="R4a57b205a4db4908"/>
+    <p:sldId xmlns:r="http://schemas.openxmlformats.org/officeDocument/2006/relationships" id="269" r:id="R443ec0e932fb427d"/>
+    <p:sldId xmlns:r="http://schemas.openxmlformats.org/officeDocument/2006/relationships" id="270" r:id="R8177942159d643da"/>
   </p:sldIdLst>
   <p:sldSz cx="15240000" cy="8572500"/>
   <p:notesSz cx="6858000" cy="9144000"/>
@@ -666,7 +666,7 @@
           <a:lstStyle xmlns:a="http://schemas.openxmlformats.org/drawingml/2006/main"/>
           <a:p xmlns:a="http://schemas.openxmlformats.org/drawingml/2006/main">
             <a:r>
-              <a:t>https://github.com/y00nZZang/product-catalog/blob/main/docs/alcohol-test-evidence.md ; https://github.com/y00nZZang/product-catalog/blob/main/docs/verification.md . TCG 10/5 운영 결과. 주류 9/30 제조사 사양 LLM1회와 오프라인 회귀.</a:t>
+              <a:t>https://github.com/y00nZZang/product-catalog/blob/main/docs/alcohol-test-evidence.md ; https://github.com/y00nZZang/product-catalog/blob/main/docs/verification.md . TCG 10/5 운영 결과와 주류9/30 제조사 사양 추출/합성 계산은 별도 시험.</a:t>
             </a:r>
           </a:p>
         </p:txBody>
@@ -1366,7 +1366,7 @@
           <a:lstStyle xmlns:a="http://schemas.openxmlformats.org/drawingml/2006/main"/>
           <a:p xmlns:a="http://schemas.openxmlformats.org/drawingml/2006/main">
             <a:r>
-              <a:t>https://github.com/y00nZZang/crossborder-purchase-agent/blob/main/docs/interaction-count.md ; https://github.com/y00nZZang/crossborder-purchase-agent/blob/main/docs/experiment.md . 2026-10-05 실험 전체 7개 사용자 메시지 대조. 대화 횟수이며 브라우저 클릭/입력 횟수와 다름.</a:t>
+              <a:t>https://github.com/y00nZZang/crossborder-purchase-agent/blob/main/docs/interaction-count.md ; https://github.com/y00nZZang/crossborder-purchase-agent/blob/main/docs/experiment.md . 사용자 메시지7개. 로그인 두 번을 한 행으로 묶은 요약이며 실제 원문 대화 캡처가 아님.</a:t>
             </a:r>
           </a:p>
         </p:txBody>
@@ -1504,7 +1504,7 @@
   </p:cSld>
   <p:clrMap bg1="lt1" tx1="dk1" bg2="lt2" tx2="dk2" accent1="accent1" accent2="accent2" accent3="accent3" accent4="accent4" accent5="accent5" accent6="accent6" hlink="hlink" folHlink="folHlink"/>
   <p:sldLayoutIdLst>
-    <p:sldLayoutId xmlns:r="http://schemas.openxmlformats.org/officeDocument/2006/relationships" id="2147483649" r:id="R7a8e6f2d8f44499a"/>
+    <p:sldLayoutId xmlns:r="http://schemas.openxmlformats.org/officeDocument/2006/relationships" id="2147483649" r:id="R7a6763684817432a"/>
   </p:sldLayoutIdLst>
   <p:txStyles>
     <p:titleStyle>
@@ -2055,7 +2055,7 @@
           <p:cNvPr id="7" name="">
             <a:extLst xmlns:a="http://schemas.openxmlformats.org/drawingml/2006/main">
               <a:ext uri="{FF2B5EF4-FFF2-40B4-BE49-F238E27FC236}">
-                <a16:creationId xmlns:a16="http://schemas.microsoft.com/office/drawing/2014/main" id="{D1E2D394-5817-494E-B2F6-B2B27495BEDA}"/>
+                <a16:creationId xmlns:a16="http://schemas.microsoft.com/office/drawing/2014/main" id="{C1A13495-24BC-4326-884E-5561931F9E7C}"/>
               </a:ext>
             </a:extLst>
           </p:cNvPr>
@@ -2094,7 +2094,7 @@
           <p:cNvPr id="2" name="">
             <a:extLst xmlns:a="http://schemas.openxmlformats.org/drawingml/2006/main">
               <a:ext uri="{FF2B5EF4-FFF2-40B4-BE49-F238E27FC236}">
-                <a16:creationId xmlns:a16="http://schemas.microsoft.com/office/drawing/2014/main" id="{766EA3CD-D2D1-4832-9681-67EDDA0C70BA}"/>
+                <a16:creationId xmlns:a16="http://schemas.microsoft.com/office/drawing/2014/main" id="{2BA9C37F-FE50-4180-8173-593FC38A8DD9}"/>
               </a:ext>
             </a:extLst>
           </p:cNvPr>
@@ -2151,7 +2151,7 @@
           <p:cNvPr id="3" name="">
             <a:extLst xmlns:a="http://schemas.openxmlformats.org/drawingml/2006/main">
               <a:ext uri="{FF2B5EF4-FFF2-40B4-BE49-F238E27FC236}">
-                <a16:creationId xmlns:a16="http://schemas.microsoft.com/office/drawing/2014/main" id="{C37BD8AA-D88B-44AD-BA94-112E8121ED29}"/>
+                <a16:creationId xmlns:a16="http://schemas.microsoft.com/office/drawing/2014/main" id="{8BBF4A73-51A1-4E3A-AEEA-308CC2B39E0A}"/>
               </a:ext>
             </a:extLst>
           </p:cNvPr>
@@ -2208,7 +2208,7 @@
           <p:cNvPr id="4" name="">
             <a:extLst xmlns:a="http://schemas.openxmlformats.org/drawingml/2006/main">
               <a:ext uri="{FF2B5EF4-FFF2-40B4-BE49-F238E27FC236}">
-                <a16:creationId xmlns:a16="http://schemas.microsoft.com/office/drawing/2014/main" id="{D03C889F-601B-4B80-889A-592E5234A7BA}"/>
+                <a16:creationId xmlns:a16="http://schemas.microsoft.com/office/drawing/2014/main" id="{BDAA9150-9D33-4C22-B844-28C986CB82C9}"/>
               </a:ext>
             </a:extLst>
           </p:cNvPr>
@@ -2288,7 +2288,7 @@
           <p:cNvPr id="5" name="">
             <a:extLst xmlns:a="http://schemas.openxmlformats.org/drawingml/2006/main">
               <a:ext uri="{FF2B5EF4-FFF2-40B4-BE49-F238E27FC236}">
-                <a16:creationId xmlns:a16="http://schemas.microsoft.com/office/drawing/2014/main" id="{403937C7-6345-42AF-9435-F75962ADD1FE}"/>
+                <a16:creationId xmlns:a16="http://schemas.microsoft.com/office/drawing/2014/main" id="{6CB7E093-F230-41D7-A23A-3631D52B2482}"/>
               </a:ext>
             </a:extLst>
           </p:cNvPr>
@@ -2345,7 +2345,7 @@
           <p:cNvPr id="6" name="">
             <a:extLst xmlns:a="http://schemas.openxmlformats.org/drawingml/2006/main">
               <a:ext uri="{FF2B5EF4-FFF2-40B4-BE49-F238E27FC236}">
-                <a16:creationId xmlns:a16="http://schemas.microsoft.com/office/drawing/2014/main" id="{6D063543-1FFE-4EA6-8248-AB8B226F3E59}"/>
+                <a16:creationId xmlns:a16="http://schemas.microsoft.com/office/drawing/2014/main" id="{78EC895B-B5DB-4D0F-9A4D-ADA619005EEA}"/>
               </a:ext>
             </a:extLst>
           </p:cNvPr>
@@ -2400,7 +2400,7 @@
     </p:spTree>
     <p:extLst>
       <p:ext uri="{BB962C8B-B14F-4D97-AF65-F5344CB8AC3E}">
-        <p14:creationId xmlns:p14="http://schemas.microsoft.com/office/powerpoint/2010/main" val="1006096488"/>
+        <p14:creationId xmlns:p14="http://schemas.microsoft.com/office/powerpoint/2010/main" val="1633945496"/>
       </p:ext>
     </p:extLst>
   </p:cSld>
@@ -2431,7 +2431,7 @@
           <p:cNvPr id="7" name="">
             <a:extLst xmlns:a="http://schemas.openxmlformats.org/drawingml/2006/main">
               <a:ext uri="{FF2B5EF4-FFF2-40B4-BE49-F238E27FC236}">
-                <a16:creationId xmlns:a16="http://schemas.microsoft.com/office/drawing/2014/main" id="{5F749867-58A9-4FE1-8143-9ED1F19055BE}"/>
+                <a16:creationId xmlns:a16="http://schemas.microsoft.com/office/drawing/2014/main" id="{A687D841-B9C1-4C64-B13D-00DCD7DE9034}"/>
               </a:ext>
             </a:extLst>
           </p:cNvPr>
@@ -2488,7 +2488,7 @@
           <p:cNvPr id="2" name="">
             <a:extLst xmlns:a="http://schemas.openxmlformats.org/drawingml/2006/main">
               <a:ext uri="{FF2B5EF4-FFF2-40B4-BE49-F238E27FC236}">
-                <a16:creationId xmlns:a16="http://schemas.microsoft.com/office/drawing/2014/main" id="{C7CDA230-4F14-40C9-A0D7-70D3E372CD5D}"/>
+                <a16:creationId xmlns:a16="http://schemas.microsoft.com/office/drawing/2014/main" id="{BE77992E-91AE-4A97-BF80-278106B92ACF}"/>
               </a:ext>
             </a:extLst>
           </p:cNvPr>
@@ -2545,7 +2545,7 @@
           <p:cNvPr id="3" name="">
             <a:extLst xmlns:a="http://schemas.openxmlformats.org/drawingml/2006/main">
               <a:ext uri="{FF2B5EF4-FFF2-40B4-BE49-F238E27FC236}">
-                <a16:creationId xmlns:a16="http://schemas.microsoft.com/office/drawing/2014/main" id="{264A0EB7-CA4D-4A14-A59D-11104E263E2E}"/>
+                <a16:creationId xmlns:a16="http://schemas.microsoft.com/office/drawing/2014/main" id="{65FCCF5B-7084-44C6-AA13-5AD339F87DD6}"/>
               </a:ext>
             </a:extLst>
           </p:cNvPr>
@@ -2602,7 +2602,7 @@
           <p:cNvPr id="4" name="">
             <a:extLst xmlns:a="http://schemas.openxmlformats.org/drawingml/2006/main">
               <a:ext uri="{FF2B5EF4-FFF2-40B4-BE49-F238E27FC236}">
-                <a16:creationId xmlns:a16="http://schemas.microsoft.com/office/drawing/2014/main" id="{1B76EDAD-505A-40BB-9891-54FED5A5C44E}"/>
+                <a16:creationId xmlns:a16="http://schemas.microsoft.com/office/drawing/2014/main" id="{EEBFE163-11C1-4C0C-B10C-4F94BBBEB6BF}"/>
               </a:ext>
             </a:extLst>
           </p:cNvPr>
@@ -2620,7 +2620,7 @@
             <a:avLst/>
           </a:prstGeom>
           <a:solidFill xmlns:a="http://schemas.openxmlformats.org/drawingml/2006/main">
-            <a:srgbClr val="DCE6E1"/>
+            <a:srgbClr val="FFFFFF"/>
           </a:solidFill>
           <a:ln xmlns:a="http://schemas.openxmlformats.org/drawingml/2006/main" w="19050">
             <a:solidFill>
@@ -2638,7 +2638,7 @@
           <p:nvPr/>
         </p:nvPicPr>
         <p:blipFill>
-          <a:blip xmlns:r="http://schemas.openxmlformats.org/officeDocument/2006/relationships" xmlns:a="http://schemas.openxmlformats.org/drawingml/2006/main" r:embed="R78c7359b2722432e"/>
+          <a:blip xmlns:r="http://schemas.openxmlformats.org/officeDocument/2006/relationships" xmlns:a="http://schemas.openxmlformats.org/drawingml/2006/main" r:embed="R36450fd99bda488a"/>
           <a:stretch xmlns:a="http://schemas.openxmlformats.org/drawingml/2006/main"/>
         </p:blipFill>
         <p:spPr>
@@ -2660,7 +2660,7 @@
           <p:nvPr/>
         </p:nvPicPr>
         <p:blipFill>
-          <a:blip xmlns:r="http://schemas.openxmlformats.org/officeDocument/2006/relationships" xmlns:a="http://schemas.openxmlformats.org/drawingml/2006/main" r:embed="R2bba87df5957485c"/>
+          <a:blip xmlns:r="http://schemas.openxmlformats.org/officeDocument/2006/relationships" xmlns:a="http://schemas.openxmlformats.org/drawingml/2006/main" r:embed="R0bdf459289334bf1"/>
           <a:stretch xmlns:a="http://schemas.openxmlformats.org/drawingml/2006/main"/>
         </p:blipFill>
         <p:spPr>
@@ -2676,7 +2676,7 @@
     </p:spTree>
     <p:extLst>
       <p:ext uri="{BB962C8B-B14F-4D97-AF65-F5344CB8AC3E}">
-        <p14:creationId xmlns:p14="http://schemas.microsoft.com/office/powerpoint/2010/main" val="932914740"/>
+        <p14:creationId xmlns:p14="http://schemas.microsoft.com/office/powerpoint/2010/main" val="699896095"/>
       </p:ext>
     </p:extLst>
   </p:cSld>
@@ -2707,7 +2707,7 @@
           <p:cNvPr id="14" name="">
             <a:extLst xmlns:a="http://schemas.openxmlformats.org/drawingml/2006/main">
               <a:ext uri="{FF2B5EF4-FFF2-40B4-BE49-F238E27FC236}">
-                <a16:creationId xmlns:a16="http://schemas.microsoft.com/office/drawing/2014/main" id="{3D0E81D3-042B-4EFD-B4C4-5ABF81AECCA7}"/>
+                <a16:creationId xmlns:a16="http://schemas.microsoft.com/office/drawing/2014/main" id="{517FB652-4021-4692-920D-E112EF002DC8}"/>
               </a:ext>
             </a:extLst>
           </p:cNvPr>
@@ -2764,7 +2764,7 @@
           <p:cNvPr id="2" name="">
             <a:extLst xmlns:a="http://schemas.openxmlformats.org/drawingml/2006/main">
               <a:ext uri="{FF2B5EF4-FFF2-40B4-BE49-F238E27FC236}">
-                <a16:creationId xmlns:a16="http://schemas.microsoft.com/office/drawing/2014/main" id="{F266B5F9-0D96-44CC-960C-238F8A7BB2CA}"/>
+                <a16:creationId xmlns:a16="http://schemas.microsoft.com/office/drawing/2014/main" id="{D0938892-0B96-473D-BAFC-BF9C80780B51}"/>
               </a:ext>
             </a:extLst>
           </p:cNvPr>
@@ -2821,7 +2821,7 @@
           <p:cNvPr id="3" name="">
             <a:extLst xmlns:a="http://schemas.openxmlformats.org/drawingml/2006/main">
               <a:ext uri="{FF2B5EF4-FFF2-40B4-BE49-F238E27FC236}">
-                <a16:creationId xmlns:a16="http://schemas.microsoft.com/office/drawing/2014/main" id="{574EFE79-6C30-41F3-BD78-DCF1E8533735}"/>
+                <a16:creationId xmlns:a16="http://schemas.microsoft.com/office/drawing/2014/main" id="{9A7783CE-BA5B-4E4E-9220-E6BBAB2CF720}"/>
               </a:ext>
             </a:extLst>
           </p:cNvPr>
@@ -2878,7 +2878,7 @@
           <p:cNvPr id="4" name="">
             <a:extLst xmlns:a="http://schemas.openxmlformats.org/drawingml/2006/main">
               <a:ext uri="{FF2B5EF4-FFF2-40B4-BE49-F238E27FC236}">
-                <a16:creationId xmlns:a16="http://schemas.microsoft.com/office/drawing/2014/main" id="{1B1C2E8A-684B-42E9-8057-A3FCDD511294}"/>
+                <a16:creationId xmlns:a16="http://schemas.microsoft.com/office/drawing/2014/main" id="{3E4E9F05-5B3D-4DE1-AEA2-4CC9B7E80D9B}"/>
               </a:ext>
             </a:extLst>
           </p:cNvPr>
@@ -2937,7 +2937,7 @@
           <p:cNvPr id="5" name="">
             <a:extLst xmlns:a="http://schemas.openxmlformats.org/drawingml/2006/main">
               <a:ext uri="{FF2B5EF4-FFF2-40B4-BE49-F238E27FC236}">
-                <a16:creationId xmlns:a16="http://schemas.microsoft.com/office/drawing/2014/main" id="{69CBB4B2-45BE-446A-9858-A095CC94EFC5}"/>
+                <a16:creationId xmlns:a16="http://schemas.microsoft.com/office/drawing/2014/main" id="{57D94D3B-317F-49BF-A2B7-57168A506247}"/>
               </a:ext>
             </a:extLst>
           </p:cNvPr>
@@ -3021,7 +3021,7 @@
           <p:cNvPr id="7" name="">
             <a:extLst xmlns:a="http://schemas.openxmlformats.org/drawingml/2006/main">
               <a:ext uri="{FF2B5EF4-FFF2-40B4-BE49-F238E27FC236}">
-                <a16:creationId xmlns:a16="http://schemas.microsoft.com/office/drawing/2014/main" id="{A6EDBFDB-FCB2-4C81-BD65-043C90B1DAA0}"/>
+                <a16:creationId xmlns:a16="http://schemas.microsoft.com/office/drawing/2014/main" id="{4E9E70B2-E3E6-4382-8607-2737DF47B61E}"/>
               </a:ext>
             </a:extLst>
           </p:cNvPr>
@@ -3105,7 +3105,7 @@
           <p:cNvPr id="9" name="">
             <a:extLst xmlns:a="http://schemas.openxmlformats.org/drawingml/2006/main">
               <a:ext uri="{FF2B5EF4-FFF2-40B4-BE49-F238E27FC236}">
-                <a16:creationId xmlns:a16="http://schemas.microsoft.com/office/drawing/2014/main" id="{5DB569DE-B65F-4898-8381-F7FCBC4EF9C1}"/>
+                <a16:creationId xmlns:a16="http://schemas.microsoft.com/office/drawing/2014/main" id="{2873444E-DE83-4626-89A9-196F524C5E5E}"/>
               </a:ext>
             </a:extLst>
           </p:cNvPr>
@@ -3185,7 +3185,7 @@
           <p:cNvPr id="10" name="">
             <a:extLst xmlns:a="http://schemas.openxmlformats.org/drawingml/2006/main">
               <a:ext uri="{FF2B5EF4-FFF2-40B4-BE49-F238E27FC236}">
-                <a16:creationId xmlns:a16="http://schemas.microsoft.com/office/drawing/2014/main" id="{5D4E812E-AA76-448A-8412-A196E2BC7F30}"/>
+                <a16:creationId xmlns:a16="http://schemas.microsoft.com/office/drawing/2014/main" id="{CCCEB5A9-60D8-47E7-BD7B-D6439F031050}"/>
               </a:ext>
             </a:extLst>
           </p:cNvPr>
@@ -3265,7 +3265,7 @@
           <p:cNvPr id="11" name="">
             <a:extLst xmlns:a="http://schemas.openxmlformats.org/drawingml/2006/main">
               <a:ext uri="{FF2B5EF4-FFF2-40B4-BE49-F238E27FC236}">
-                <a16:creationId xmlns:a16="http://schemas.microsoft.com/office/drawing/2014/main" id="{ED1324CE-A342-4D6F-9A2E-E8A1DEAA8248}"/>
+                <a16:creationId xmlns:a16="http://schemas.microsoft.com/office/drawing/2014/main" id="{3A1AD1E1-77BD-4BB3-9AAB-B0875C728899}"/>
               </a:ext>
             </a:extLst>
           </p:cNvPr>
@@ -3345,7 +3345,7 @@
           <p:cNvPr id="12" name="">
             <a:extLst xmlns:a="http://schemas.openxmlformats.org/drawingml/2006/main">
               <a:ext uri="{FF2B5EF4-FFF2-40B4-BE49-F238E27FC236}">
-                <a16:creationId xmlns:a16="http://schemas.microsoft.com/office/drawing/2014/main" id="{C7C74877-B5F3-43ED-AD39-073EE8877806}"/>
+                <a16:creationId xmlns:a16="http://schemas.microsoft.com/office/drawing/2014/main" id="{17108BE5-2FDA-4CA1-BDC1-B43C3A41C8F5}"/>
               </a:ext>
             </a:extLst>
           </p:cNvPr>
@@ -3402,7 +3402,7 @@
           <p:cNvPr id="13" name="">
             <a:extLst xmlns:a="http://schemas.openxmlformats.org/drawingml/2006/main">
               <a:ext uri="{FF2B5EF4-FFF2-40B4-BE49-F238E27FC236}">
-                <a16:creationId xmlns:a16="http://schemas.microsoft.com/office/drawing/2014/main" id="{7655C9D8-3723-420E-8C59-25B29FA44181}"/>
+                <a16:creationId xmlns:a16="http://schemas.microsoft.com/office/drawing/2014/main" id="{0A870FA5-7101-4D2E-9E7B-6B5B737E46CF}"/>
               </a:ext>
             </a:extLst>
           </p:cNvPr>
@@ -3457,7 +3457,7 @@
     </p:spTree>
     <p:extLst>
       <p:ext uri="{BB962C8B-B14F-4D97-AF65-F5344CB8AC3E}">
-        <p14:creationId xmlns:p14="http://schemas.microsoft.com/office/powerpoint/2010/main" val="939753022"/>
+        <p14:creationId xmlns:p14="http://schemas.microsoft.com/office/powerpoint/2010/main" val="971267627"/>
       </p:ext>
     </p:extLst>
   </p:cSld>
@@ -3485,10 +3485,10 @@
       </p:grpSpPr>
       <p:sp>
         <p:nvSpPr>
-          <p:cNvPr id="11" name="">
-            <a:extLst xmlns:a="http://schemas.openxmlformats.org/drawingml/2006/main">
-              <a:ext uri="{FF2B5EF4-FFF2-40B4-BE49-F238E27FC236}">
-                <a16:creationId xmlns:a16="http://schemas.microsoft.com/office/drawing/2014/main" id="{66DA9113-B5CB-4CC9-9C6E-C839A8C77031}"/>
+          <p:cNvPr id="6" name="">
+            <a:extLst xmlns:a="http://schemas.openxmlformats.org/drawingml/2006/main">
+              <a:ext uri="{FF2B5EF4-FFF2-40B4-BE49-F238E27FC236}">
+                <a16:creationId xmlns:a16="http://schemas.microsoft.com/office/drawing/2014/main" id="{9C8F6AF3-E52B-49B6-8E50-57610BAEA11E}"/>
               </a:ext>
             </a:extLst>
           </p:cNvPr>
@@ -3535,7 +3535,7 @@
                 <a:ea typeface="Apple SD Gothic Neo"/>
                 <a:cs typeface="Apple SD Gothic Neo"/>
               </a:rPr>
-              <a:t>TCG 상품과 주류의 시험 결과</a:t>
+              <a:t>관세 실험 결과</a:t>
             </a:r>
           </a:p>
         </p:txBody>
@@ -3545,7 +3545,7 @@
           <p:cNvPr id="2" name="">
             <a:extLst xmlns:a="http://schemas.openxmlformats.org/drawingml/2006/main">
               <a:ext uri="{FF2B5EF4-FFF2-40B4-BE49-F238E27FC236}">
-                <a16:creationId xmlns:a16="http://schemas.microsoft.com/office/drawing/2014/main" id="{7647C5D8-4349-4368-9269-D8885606D469}"/>
+                <a16:creationId xmlns:a16="http://schemas.microsoft.com/office/drawing/2014/main" id="{EFACF744-A4D7-4DEE-A32C-0EF2B2E93EDF}"/>
               </a:ext>
             </a:extLst>
           </p:cNvPr>
@@ -3592,7 +3592,7 @@
                 <a:ea typeface="Apple SD Gothic Neo"/>
                 <a:cs typeface="Apple SD Gothic Neo"/>
               </a:rPr>
-              <a:t>라이브 분석 결과와 저장된 표본의 분류·계산 검증을 구분했습니다.</a:t>
+              <a:t>동일한 항목으로 정리하되, 실제 URL 분석과 합성 계산 표본의 차이는 구분했습니다.</a:t>
             </a:r>
           </a:p>
         </p:txBody>
@@ -3602,7 +3602,7 @@
           <p:cNvPr id="3" name="">
             <a:extLst xmlns:a="http://schemas.openxmlformats.org/drawingml/2006/main">
               <a:ext uri="{FF2B5EF4-FFF2-40B4-BE49-F238E27FC236}">
-                <a16:creationId xmlns:a16="http://schemas.microsoft.com/office/drawing/2014/main" id="{E830850D-0C93-409C-92CD-063B480D8449}"/>
+                <a16:creationId xmlns:a16="http://schemas.microsoft.com/office/drawing/2014/main" id="{1BEECC56-242C-4A76-8802-4A684CC98A63}"/>
               </a:ext>
             </a:extLst>
           </p:cNvPr>
@@ -3654,24 +3654,569 @@
           </a:p>
         </p:txBody>
       </p:sp>
-      <p:sp>
-        <p:nvSpPr>
-          <p:cNvPr id="4" name="">
-            <a:extLst xmlns:a="http://schemas.openxmlformats.org/drawingml/2006/main">
-              <a:ext uri="{FF2B5EF4-FFF2-40B4-BE49-F238E27FC236}">
-                <a16:creationId xmlns:a16="http://schemas.microsoft.com/office/drawing/2014/main" id="{E7094402-DD44-4EB3-A7AA-FB9AA44DAE98}"/>
-              </a:ext>
-            </a:extLst>
-          </p:cNvPr>
-          <p:cNvSpPr>
-            <a:spLocks xmlns:a="http://schemas.openxmlformats.org/drawingml/2006/main" noGrp="1"/>
-          </p:cNvSpPr>
-          <p:nvPr/>
-        </p:nvSpPr>
-        <p:spPr>
-          <a:xfrm xmlns:a="http://schemas.openxmlformats.org/drawingml/2006/main">
-            <a:off x="819150" y="2714625"/>
-            <a:ext cx="6334125" cy="533400"/>
+      <p:graphicFrame>
+        <p:nvGraphicFramePr>
+          <p:cNvPr id="9" name=""/>
+          <p:cNvGraphicFramePr/>
+          <p:nvPr/>
+        </p:nvGraphicFramePr>
+        <p:xfrm>
+          <a:off xmlns:a="http://schemas.openxmlformats.org/drawingml/2006/main" x="819150" y="2505075"/>
+          <a:ext xmlns:a="http://schemas.openxmlformats.org/drawingml/2006/main" cx="13601700" cy="4619625"/>
+        </p:xfrm>
+        <a:graphic xmlns:a="http://schemas.openxmlformats.org/drawingml/2006/main">
+          <a:graphicData uri="http://schemas.openxmlformats.org/drawingml/2006/table">
+            <a:tbl>
+              <a:tblPr/>
+              <a:tblGrid>
+                <a:gridCol w="2333625"/>
+                <a:gridCol w="5629275"/>
+                <a:gridCol w="5638800"/>
+              </a:tblGrid>
+              <a:tr h="769938">
+                <a:tc>
+                  <a:txBody>
+                    <a:bodyPr/>
+                    <a:lstStyle/>
+                    <a:p>
+                      <a:r>
+                        <a:rPr sz="1950" b="1">
+                          <a:solidFill>
+                            <a:srgbClr val="FFFFFF"/>
+                          </a:solidFill>
+                          <a:latin typeface="Apple SD Gothic Neo"/>
+                          <a:ea typeface="Apple SD Gothic Neo"/>
+                          <a:cs typeface="Apple SD Gothic Neo"/>
+                        </a:rPr>
+                        <a:t>항목</a:t>
+                      </a:r>
+                    </a:p>
+                  </a:txBody>
+                  <a:tcPr marL="91440" marR="91440" marT="45720" marB="45720">
+                    <a:solidFill>
+                      <a:srgbClr val="182C29"/>
+                    </a:solidFill>
+                  </a:tcPr>
+                </a:tc>
+                <a:tc>
+                  <a:txBody>
+                    <a:bodyPr/>
+                    <a:lstStyle/>
+                    <a:p>
+                      <a:r>
+                        <a:rPr sz="1950" b="1">
+                          <a:solidFill>
+                            <a:srgbClr val="FFFFFF"/>
+                          </a:solidFill>
+                          <a:latin typeface="Apple SD Gothic Neo"/>
+                          <a:ea typeface="Apple SD Gothic Neo"/>
+                          <a:cs typeface="Apple SD Gothic Neo"/>
+                        </a:rPr>
+                        <a:t>TCG 상품</a:t>
+                      </a:r>
+                    </a:p>
+                  </a:txBody>
+                  <a:tcPr marL="91440" marR="91440" marT="45720" marB="45720">
+                    <a:solidFill>
+                      <a:srgbClr val="182C29"/>
+                    </a:solidFill>
+                  </a:tcPr>
+                </a:tc>
+                <a:tc>
+                  <a:txBody>
+                    <a:bodyPr/>
+                    <a:lstStyle/>
+                    <a:p>
+                      <a:r>
+                        <a:rPr sz="1950" b="1">
+                          <a:solidFill>
+                            <a:srgbClr val="FFFFFF"/>
+                          </a:solidFill>
+                          <a:latin typeface="Apple SD Gothic Neo"/>
+                          <a:ea typeface="Apple SD Gothic Neo"/>
+                          <a:cs typeface="Apple SD Gothic Neo"/>
+                        </a:rPr>
+                        <a:t>주류(위스키)</a:t>
+                      </a:r>
+                    </a:p>
+                  </a:txBody>
+                  <a:tcPr marL="91440" marR="91440" marT="45720" marB="45720">
+                    <a:solidFill>
+                      <a:srgbClr val="182C29"/>
+                    </a:solidFill>
+                  </a:tcPr>
+                </a:tc>
+              </a:tr>
+              <a:tr h="769938">
+                <a:tc>
+                  <a:txBody>
+                    <a:bodyPr/>
+                    <a:lstStyle/>
+                    <a:p>
+                      <a:r>
+                        <a:rPr sz="2025" b="0">
+                          <a:solidFill>
+                            <a:srgbClr val="182C29"/>
+                          </a:solidFill>
+                          <a:latin typeface="Apple SD Gothic Neo"/>
+                          <a:ea typeface="Apple SD Gothic Neo"/>
+                          <a:cs typeface="Apple SD Gothic Neo"/>
+                        </a:rPr>
+                        <a:t>검증 자료</a:t>
+                      </a:r>
+                    </a:p>
+                  </a:txBody>
+                  <a:tcPr marL="91440" marR="91440" marT="45720" marB="45720">
+                    <a:solidFill>
+                      <a:srgbClr val="FFFFFF"/>
+                    </a:solidFill>
+                  </a:tcPr>
+                </a:tc>
+                <a:tc>
+                  <a:txBody>
+                    <a:bodyPr/>
+                    <a:lstStyle/>
+                    <a:p>
+                      <a:r>
+                        <a:rPr sz="2025" b="0">
+                          <a:solidFill>
+                            <a:srgbClr val="182C29"/>
+                          </a:solidFill>
+                          <a:latin typeface="Apple SD Gothic Neo"/>
+                          <a:ea typeface="Apple SD Gothic Neo"/>
+                          <a:cs typeface="Apple SD Gothic Neo"/>
+                        </a:rPr>
+                        <a:t>메루카리 실제 판매글</a:t>
+                      </a:r>
+                    </a:p>
+                    <a:p>
+                      <a:r>
+                        <a:rPr sz="2025" b="0">
+                          <a:solidFill>
+                            <a:srgbClr val="182C29"/>
+                          </a:solidFill>
+                          <a:latin typeface="Apple SD Gothic Neo"/>
+                          <a:ea typeface="Apple SD Gothic Neo"/>
+                          <a:cs typeface="Apple SD Gothic Neo"/>
+                        </a:rPr>
+                        <a:t>2026-10-05 운영 분석</a:t>
+                      </a:r>
+                    </a:p>
+                  </a:txBody>
+                  <a:tcPr marL="91440" marR="91440" marT="45720" marB="45720">
+                    <a:solidFill>
+                      <a:srgbClr val="FFFFFF"/>
+                    </a:solidFill>
+                  </a:tcPr>
+                </a:tc>
+                <a:tc>
+                  <a:txBody>
+                    <a:bodyPr/>
+                    <a:lstStyle/>
+                    <a:p>
+                      <a:r>
+                        <a:rPr sz="2025" b="0">
+                          <a:solidFill>
+                            <a:srgbClr val="182C29"/>
+                          </a:solidFill>
+                          <a:latin typeface="Apple SD Gothic Neo"/>
+                          <a:ea typeface="Apple SD Gothic Neo"/>
+                          <a:cs typeface="Apple SD Gothic Neo"/>
+                        </a:rPr>
+                        <a:t>제조사 사양 + 합성 계산 입력</a:t>
+                      </a:r>
+                    </a:p>
+                    <a:p>
+                      <a:r>
+                        <a:rPr sz="2025" b="0">
+                          <a:solidFill>
+                            <a:srgbClr val="182C29"/>
+                          </a:solidFill>
+                          <a:latin typeface="Apple SD Gothic Neo"/>
+                          <a:ea typeface="Apple SD Gothic Neo"/>
+                          <a:cs typeface="Apple SD Gothic Neo"/>
+                        </a:rPr>
+                        <a:t>2026-09-30 저장 시험</a:t>
+                      </a:r>
+                    </a:p>
+                  </a:txBody>
+                  <a:tcPr marL="91440" marR="91440" marT="45720" marB="45720">
+                    <a:solidFill>
+                      <a:srgbClr val="FFFFFF"/>
+                    </a:solidFill>
+                  </a:tcPr>
+                </a:tc>
+              </a:tr>
+              <a:tr h="769938">
+                <a:tc>
+                  <a:txBody>
+                    <a:bodyPr/>
+                    <a:lstStyle/>
+                    <a:p>
+                      <a:r>
+                        <a:rPr sz="2025" b="0">
+                          <a:solidFill>
+                            <a:srgbClr val="182C29"/>
+                          </a:solidFill>
+                          <a:latin typeface="Apple SD Gothic Neo"/>
+                          <a:ea typeface="Apple SD Gothic Neo"/>
+                          <a:cs typeface="Apple SD Gothic Neo"/>
+                        </a:rPr>
+                        <a:t>분류·추출 결과</a:t>
+                      </a:r>
+                    </a:p>
+                  </a:txBody>
+                  <a:tcPr marL="91440" marR="91440" marT="45720" marB="45720">
+                    <a:solidFill>
+                      <a:srgbClr val="F8F8F3"/>
+                    </a:solidFill>
+                  </a:tcPr>
+                </a:tc>
+                <a:tc>
+                  <a:txBody>
+                    <a:bodyPr/>
+                    <a:lstStyle/>
+                    <a:p>
+                      <a:r>
+                        <a:rPr sz="2025" b="0">
+                          <a:solidFill>
+                            <a:srgbClr val="182C29"/>
+                          </a:solidFill>
+                          <a:latin typeface="Apple SD Gothic Neo"/>
+                          <a:ea typeface="Apple SD Gothic Neo"/>
+                          <a:cs typeface="Apple SD Gothic Neo"/>
+                        </a:rPr>
+                        <a:t>HSK 9504400000 후보</a:t>
+                      </a:r>
+                    </a:p>
+                  </a:txBody>
+                  <a:tcPr marL="91440" marR="91440" marT="45720" marB="45720">
+                    <a:solidFill>
+                      <a:srgbClr val="F8F8F3"/>
+                    </a:solidFill>
+                  </a:tcPr>
+                </a:tc>
+                <a:tc>
+                  <a:txBody>
+                    <a:bodyPr/>
+                    <a:lstStyle/>
+                    <a:p>
+                      <a:r>
+                        <a:rPr sz="2025" b="0">
+                          <a:solidFill>
+                            <a:srgbClr val="182C29"/>
+                          </a:solidFill>
+                          <a:latin typeface="Apple SD Gothic Neo"/>
+                          <a:ea typeface="Apple SD Gothic Neo"/>
+                          <a:cs typeface="Apple SD Gothic Neo"/>
+                        </a:rPr>
+                        <a:t>whisky 후보 · 700ml·43% 추출</a:t>
+                      </a:r>
+                    </a:p>
+                    <a:p>
+                      <a:r>
+                        <a:rPr sz="2025" b="0">
+                          <a:solidFill>
+                            <a:srgbClr val="182C29"/>
+                          </a:solidFill>
+                          <a:latin typeface="Apple SD Gothic Neo"/>
+                          <a:ea typeface="Apple SD Gothic Neo"/>
+                          <a:cs typeface="Apple SD Gothic Neo"/>
+                        </a:rPr>
+                        <a:t>병 수는 미확인</a:t>
+                      </a:r>
+                    </a:p>
+                  </a:txBody>
+                  <a:tcPr marL="91440" marR="91440" marT="45720" marB="45720">
+                    <a:solidFill>
+                      <a:srgbClr val="F8F8F3"/>
+                    </a:solidFill>
+                  </a:tcPr>
+                </a:tc>
+              </a:tr>
+              <a:tr h="769938">
+                <a:tc>
+                  <a:txBody>
+                    <a:bodyPr/>
+                    <a:lstStyle/>
+                    <a:p>
+                      <a:r>
+                        <a:rPr sz="2025" b="0">
+                          <a:solidFill>
+                            <a:srgbClr val="182C29"/>
+                          </a:solidFill>
+                          <a:latin typeface="Apple SD Gothic Neo"/>
+                          <a:ea typeface="Apple SD Gothic Neo"/>
+                          <a:cs typeface="Apple SD Gothic Neo"/>
+                        </a:rPr>
+                        <a:t>계산 조건</a:t>
+                      </a:r>
+                    </a:p>
+                  </a:txBody>
+                  <a:tcPr marL="91440" marR="91440" marT="45720" marB="45720">
+                    <a:solidFill>
+                      <a:srgbClr val="FFFFFF"/>
+                    </a:solidFill>
+                  </a:tcPr>
+                </a:tc>
+                <a:tc>
+                  <a:txBody>
+                    <a:bodyPr/>
+                    <a:lstStyle/>
+                    <a:p>
+                      <a:r>
+                        <a:rPr sz="2025" b="0">
+                          <a:solidFill>
+                            <a:srgbClr val="182C29"/>
+                          </a:solidFill>
+                          <a:latin typeface="Apple SD Gothic Neo"/>
+                          <a:ea typeface="Apple SD Gothic Neo"/>
+                          <a:cs typeface="Apple SD Gothic Neo"/>
+                        </a:rPr>
+                        <a:t>관측 판매가70,000JPY</a:t>
+                      </a:r>
+                    </a:p>
+                    <a:p>
+                      <a:r>
+                        <a:rPr sz="2025" b="0">
+                          <a:solidFill>
+                            <a:srgbClr val="182C29"/>
+                          </a:solidFill>
+                          <a:latin typeface="Apple SD Gothic Neo"/>
+                          <a:ea typeface="Apple SD Gothic Neo"/>
+                          <a:cs typeface="Apple SD Gothic Neo"/>
+                        </a:rPr>
+                        <a:t>기본관세8%·일반 부가세10% 가정</a:t>
+                      </a:r>
+                    </a:p>
+                  </a:txBody>
+                  <a:tcPr marL="91440" marR="91440" marT="45720" marB="45720">
+                    <a:solidFill>
+                      <a:srgbClr val="FFFFFF"/>
+                    </a:solidFill>
+                  </a:tcPr>
+                </a:tc>
+                <a:tc>
+                  <a:txBody>
+                    <a:bodyPr/>
+                    <a:lstStyle/>
+                    <a:p>
+                      <a:r>
+                        <a:rPr sz="2025" b="0">
+                          <a:solidFill>
+                            <a:srgbClr val="182C29"/>
+                          </a:solidFill>
+                          <a:latin typeface="Apple SD Gothic Neo"/>
+                          <a:ea typeface="Apple SD Gothic Neo"/>
+                          <a:cs typeface="Apple SD Gothic Neo"/>
+                        </a:rPr>
+                        <a:t>별도 합성 입력: $200·750ml 1병·40%</a:t>
+                      </a:r>
+                    </a:p>
+                    <a:p>
+                      <a:r>
+                        <a:rPr sz="2025" b="0">
+                          <a:solidFill>
+                            <a:srgbClr val="182C29"/>
+                          </a:solidFill>
+                          <a:latin typeface="Apple SD Gothic Neo"/>
+                          <a:ea typeface="Apple SD Gothic Neo"/>
+                          <a:cs typeface="Apple SD Gothic Neo"/>
+                        </a:rPr>
+                        <a:t>환율1,000원/$·운임0 가정</a:t>
+                      </a:r>
+                    </a:p>
+                  </a:txBody>
+                  <a:tcPr marL="91440" marR="91440" marT="45720" marB="45720">
+                    <a:solidFill>
+                      <a:srgbClr val="FFFFFF"/>
+                    </a:solidFill>
+                  </a:tcPr>
+                </a:tc>
+              </a:tr>
+              <a:tr h="769938">
+                <a:tc>
+                  <a:txBody>
+                    <a:bodyPr/>
+                    <a:lstStyle/>
+                    <a:p>
+                      <a:r>
+                        <a:rPr sz="2025" b="0">
+                          <a:solidFill>
+                            <a:srgbClr val="182C29"/>
+                          </a:solidFill>
+                          <a:latin typeface="Apple SD Gothic Neo"/>
+                          <a:ea typeface="Apple SD Gothic Neo"/>
+                          <a:cs typeface="Apple SD Gothic Neo"/>
+                        </a:rPr>
+                        <a:t>예상 세금</a:t>
+                      </a:r>
+                    </a:p>
+                  </a:txBody>
+                  <a:tcPr marL="91440" marR="91440" marT="45720" marB="45720">
+                    <a:solidFill>
+                      <a:srgbClr val="F8F8F3"/>
+                    </a:solidFill>
+                  </a:tcPr>
+                </a:tc>
+                <a:tc>
+                  <a:txBody>
+                    <a:bodyPr/>
+                    <a:lstStyle/>
+                    <a:p>
+                      <a:r>
+                        <a:rPr sz="2025" b="0">
+                          <a:solidFill>
+                            <a:srgbClr val="182C29"/>
+                          </a:solidFill>
+                          <a:latin typeface="Apple SD Gothic Neo"/>
+                          <a:ea typeface="Apple SD Gothic Neo"/>
+                          <a:cs typeface="Apple SD Gothic Neo"/>
+                        </a:rPr>
+                        <a:t>115,776 ~ 117,335원</a:t>
+                      </a:r>
+                    </a:p>
+                  </a:txBody>
+                  <a:tcPr marL="91440" marR="91440" marT="45720" marB="45720">
+                    <a:solidFill>
+                      <a:srgbClr val="F8F8F3"/>
+                    </a:solidFill>
+                  </a:tcPr>
+                </a:tc>
+                <a:tc>
+                  <a:txBody>
+                    <a:bodyPr/>
+                    <a:lstStyle/>
+                    <a:p>
+                      <a:r>
+                        <a:rPr sz="2025" b="0">
+                          <a:solidFill>
+                            <a:srgbClr val="182C29"/>
+                          </a:solidFill>
+                          <a:latin typeface="Apple SD Gothic Neo"/>
+                          <a:ea typeface="Apple SD Gothic Neo"/>
+                          <a:cs typeface="Apple SD Gothic Neo"/>
+                        </a:rPr>
+                        <a:t>353,696원</a:t>
+                      </a:r>
+                    </a:p>
+                  </a:txBody>
+                  <a:tcPr marL="91440" marR="91440" marT="45720" marB="45720">
+                    <a:solidFill>
+                      <a:srgbClr val="F8F8F3"/>
+                    </a:solidFill>
+                  </a:tcPr>
+                </a:tc>
+              </a:tr>
+              <a:tr h="769938">
+                <a:tc>
+                  <a:txBody>
+                    <a:bodyPr/>
+                    <a:lstStyle/>
+                    <a:p>
+                      <a:r>
+                        <a:rPr sz="2025" b="0">
+                          <a:solidFill>
+                            <a:srgbClr val="182C29"/>
+                          </a:solidFill>
+                          <a:latin typeface="Apple SD Gothic Neo"/>
+                          <a:ea typeface="Apple SD Gothic Neo"/>
+                          <a:cs typeface="Apple SD Gothic Neo"/>
+                        </a:rPr>
+                        <a:t>확인한 범위</a:t>
+                      </a:r>
+                    </a:p>
+                  </a:txBody>
+                  <a:tcPr marL="91440" marR="91440" marT="45720" marB="45720">
+                    <a:solidFill>
+                      <a:srgbClr val="FFFFFF"/>
+                    </a:solidFill>
+                  </a:tcPr>
+                </a:tc>
+                <a:tc>
+                  <a:txBody>
+                    <a:bodyPr/>
+                    <a:lstStyle/>
+                    <a:p>
+                      <a:r>
+                        <a:rPr sz="2025" b="0">
+                          <a:solidFill>
+                            <a:srgbClr val="182C29"/>
+                          </a:solidFill>
+                          <a:latin typeface="Apple SD Gothic Neo"/>
+                          <a:ea typeface="Apple SD Gothic Neo"/>
+                          <a:cs typeface="Apple SD Gothic Neo"/>
+                        </a:rPr>
+                        <a:t>상품 분류→공개 세율→계산 연결</a:t>
+                      </a:r>
+                    </a:p>
+                  </a:txBody>
+                  <a:tcPr marL="91440" marR="91440" marT="45720" marB="45720">
+                    <a:solidFill>
+                      <a:srgbClr val="FFFFFF"/>
+                    </a:solidFill>
+                  </a:tcPr>
+                </a:tc>
+                <a:tc>
+                  <a:txBody>
+                    <a:bodyPr/>
+                    <a:lstStyle/>
+                    <a:p>
+                      <a:r>
+                        <a:rPr sz="2025" b="0">
+                          <a:solidFill>
+                            <a:srgbClr val="182C29"/>
+                          </a:solidFill>
+                          <a:latin typeface="Apple SD Gothic Neo"/>
+                          <a:ea typeface="Apple SD Gothic Neo"/>
+                          <a:cs typeface="Apple SD Gothic Neo"/>
+                        </a:rPr>
+                        <a:t>사양 추출과 계산 회귀</a:t>
+                      </a:r>
+                    </a:p>
+                    <a:p>
+                      <a:r>
+                        <a:rPr sz="2025" b="0">
+                          <a:solidFill>
+                            <a:srgbClr val="182C29"/>
+                          </a:solidFill>
+                          <a:latin typeface="Apple SD Gothic Neo"/>
+                          <a:ea typeface="Apple SD Gothic Neo"/>
+                          <a:cs typeface="Apple SD Gothic Neo"/>
+                        </a:rPr>
+                        <a:t>용량·병 수 경계 및 누락 입력 검사</a:t>
+                      </a:r>
+                    </a:p>
+                  </a:txBody>
+                  <a:tcPr marL="91440" marR="91440" marT="45720" marB="45720">
+                    <a:solidFill>
+                      <a:srgbClr val="FFFFFF"/>
+                    </a:solidFill>
+                  </a:tcPr>
+                </a:tc>
+              </a:tr>
+            </a:tbl>
+          </a:graphicData>
+        </a:graphic>
+      </p:graphicFrame>
+      <p:sp>
+        <p:nvSpPr>
+          <p:cNvPr id="5" name="">
+            <a:extLst xmlns:a="http://schemas.openxmlformats.org/drawingml/2006/main">
+              <a:ext uri="{FF2B5EF4-FFF2-40B4-BE49-F238E27FC236}">
+                <a16:creationId xmlns:a16="http://schemas.microsoft.com/office/drawing/2014/main" id="{F2217FB4-3948-43AF-94A3-E851F3AADBD6}"/>
+              </a:ext>
+            </a:extLst>
+          </p:cNvPr>
+          <p:cNvSpPr>
+            <a:spLocks xmlns:a="http://schemas.openxmlformats.org/drawingml/2006/main" noGrp="1"/>
+          </p:cNvSpPr>
+          <p:nvPr/>
+        </p:nvSpPr>
+        <p:spPr>
+          <a:xfrm xmlns:a="http://schemas.openxmlformats.org/drawingml/2006/main">
+            <a:off x="819150" y="7505700"/>
+            <a:ext cx="13525500" cy="361950"/>
           </a:xfrm>
           <a:prstGeom xmlns:a="http://schemas.openxmlformats.org/drawingml/2006/main" prst="rect">
             <a:avLst/>
@@ -3688,509 +4233,6 @@
           <a:lstStyle xmlns:a="http://schemas.openxmlformats.org/drawingml/2006/main"/>
           <a:p xmlns:a="http://schemas.openxmlformats.org/drawingml/2006/main">
             <a:pPr>
-              <a:defRPr sz="2625" b="1">
-                <a:solidFill>
-                  <a:srgbClr val="156E58"/>
-                </a:solidFill>
-                <a:latin typeface="Apple SD Gothic Neo"/>
-                <a:ea typeface="Apple SD Gothic Neo"/>
-                <a:cs typeface="Apple SD Gothic Neo"/>
-              </a:defRPr>
-            </a:pPr>
-            <a:r>
-              <a:rPr sz="2625" b="1">
-                <a:solidFill>
-                  <a:srgbClr val="156E58"/>
-                </a:solidFill>
-                <a:latin typeface="Apple SD Gothic Neo"/>
-                <a:ea typeface="Apple SD Gothic Neo"/>
-                <a:cs typeface="Apple SD Gothic Neo"/>
-              </a:rPr>
-              <a:t>TCG 상품 · 실제 URL 분석</a:t>
-            </a:r>
-          </a:p>
-        </p:txBody>
-      </p:sp>
-      <p:sp>
-        <p:nvSpPr>
-          <p:cNvPr id="5" name="">
-            <a:extLst xmlns:a="http://schemas.openxmlformats.org/drawingml/2006/main">
-              <a:ext uri="{FF2B5EF4-FFF2-40B4-BE49-F238E27FC236}">
-                <a16:creationId xmlns:a16="http://schemas.microsoft.com/office/drawing/2014/main" id="{401A4EC7-F52A-4B8F-9B69-BBF7C6134461}"/>
-              </a:ext>
-            </a:extLst>
-          </p:cNvPr>
-          <p:cNvSpPr>
-            <a:spLocks xmlns:a="http://schemas.openxmlformats.org/drawingml/2006/main" noGrp="1"/>
-          </p:cNvSpPr>
-          <p:nvPr/>
-        </p:nvSpPr>
-        <p:spPr>
-          <a:xfrm xmlns:a="http://schemas.openxmlformats.org/drawingml/2006/main">
-            <a:off x="819150" y="3657600"/>
-            <a:ext cx="6286500" cy="1495425"/>
-          </a:xfrm>
-          <a:prstGeom xmlns:a="http://schemas.openxmlformats.org/drawingml/2006/main" prst="rect">
-            <a:avLst/>
-          </a:prstGeom>
-          <a:noFill xmlns:a="http://schemas.openxmlformats.org/drawingml/2006/main"/>
-          <a:ln xmlns:a="http://schemas.openxmlformats.org/drawingml/2006/main" w="0">
-            <a:noFill/>
-          </a:ln>
-        </p:spPr>
-        <p:txBody>
-          <a:bodyPr xmlns:a="http://schemas.openxmlformats.org/drawingml/2006/main" wrap="square" lIns="0" tIns="0" rIns="0" bIns="0">
-            <a:noAutofit/>
-          </a:bodyPr>
-          <a:lstStyle xmlns:a="http://schemas.openxmlformats.org/drawingml/2006/main"/>
-          <a:p xmlns:a="http://schemas.openxmlformats.org/drawingml/2006/main">
-            <a:pPr>
-              <a:defRPr sz="2475" b="0">
-                <a:solidFill>
-                  <a:srgbClr val="182C29"/>
-                </a:solidFill>
-                <a:latin typeface="Apple SD Gothic Neo"/>
-                <a:ea typeface="Apple SD Gothic Neo"/>
-                <a:cs typeface="Apple SD Gothic Neo"/>
-              </a:defRPr>
-            </a:pPr>
-            <a:r>
-              <a:rPr sz="2475" b="0">
-                <a:solidFill>
-                  <a:srgbClr val="182C29"/>
-                </a:solidFill>
-                <a:latin typeface="Apple SD Gothic Neo"/>
-                <a:ea typeface="Apple SD Gothic Neo"/>
-                <a:cs typeface="Apple SD Gothic Neo"/>
-              </a:rPr>
-              <a:t>HSK 9504400000 후보</a:t>
-            </a:r>
-          </a:p>
-          <a:p xmlns:a="http://schemas.openxmlformats.org/drawingml/2006/main">
-            <a:pPr>
-              <a:defRPr sz="2475" b="0">
-                <a:solidFill>
-                  <a:srgbClr val="182C29"/>
-                </a:solidFill>
-                <a:latin typeface="Apple SD Gothic Neo"/>
-                <a:ea typeface="Apple SD Gothic Neo"/>
-                <a:cs typeface="Apple SD Gothic Neo"/>
-              </a:defRPr>
-            </a:pPr>
-            <a:r>
-              <a:rPr sz="2475" b="0">
-                <a:solidFill>
-                  <a:srgbClr val="182C29"/>
-                </a:solidFill>
-                <a:latin typeface="Apple SD Gothic Neo"/>
-                <a:ea typeface="Apple SD Gothic Neo"/>
-                <a:cs typeface="Apple SD Gothic Neo"/>
-              </a:rPr>
-              <a:t>공개 기본관세 8%</a:t>
-            </a:r>
-          </a:p>
-          <a:p xmlns:a="http://schemas.openxmlformats.org/drawingml/2006/main">
-            <a:pPr>
-              <a:defRPr sz="2475" b="0">
-                <a:solidFill>
-                  <a:srgbClr val="182C29"/>
-                </a:solidFill>
-                <a:latin typeface="Apple SD Gothic Neo"/>
-                <a:ea typeface="Apple SD Gothic Neo"/>
-                <a:cs typeface="Apple SD Gothic Neo"/>
-              </a:defRPr>
-            </a:pPr>
-            <a:r>
-              <a:rPr sz="2475" b="0">
-                <a:solidFill>
-                  <a:srgbClr val="182C29"/>
-                </a:solidFill>
-                <a:latin typeface="Apple SD Gothic Neo"/>
-                <a:ea typeface="Apple SD Gothic Neo"/>
-                <a:cs typeface="Apple SD Gothic Neo"/>
-              </a:rPr>
-              <a:t>일반 부가세 10% 가정</a:t>
-            </a:r>
-          </a:p>
-        </p:txBody>
-      </p:sp>
-      <p:sp>
-        <p:nvSpPr>
-          <p:cNvPr id="6" name="">
-            <a:extLst xmlns:a="http://schemas.openxmlformats.org/drawingml/2006/main">
-              <a:ext uri="{FF2B5EF4-FFF2-40B4-BE49-F238E27FC236}">
-                <a16:creationId xmlns:a16="http://schemas.microsoft.com/office/drawing/2014/main" id="{0F0E53D2-5EC3-41C1-803C-47B47FB015B3}"/>
-              </a:ext>
-            </a:extLst>
-          </p:cNvPr>
-          <p:cNvSpPr>
-            <a:spLocks xmlns:a="http://schemas.openxmlformats.org/drawingml/2006/main" noGrp="1"/>
-          </p:cNvSpPr>
-          <p:nvPr/>
-        </p:nvSpPr>
-        <p:spPr>
-          <a:xfrm xmlns:a="http://schemas.openxmlformats.org/drawingml/2006/main">
-            <a:off x="819150" y="5724525"/>
-            <a:ext cx="6286500" cy="1009650"/>
-          </a:xfrm>
-          <a:prstGeom xmlns:a="http://schemas.openxmlformats.org/drawingml/2006/main" prst="rect">
-            <a:avLst/>
-          </a:prstGeom>
-          <a:noFill xmlns:a="http://schemas.openxmlformats.org/drawingml/2006/main"/>
-          <a:ln xmlns:a="http://schemas.openxmlformats.org/drawingml/2006/main" w="0">
-            <a:noFill/>
-          </a:ln>
-        </p:spPr>
-        <p:txBody>
-          <a:bodyPr xmlns:a="http://schemas.openxmlformats.org/drawingml/2006/main" wrap="square" lIns="0" tIns="0" rIns="0" bIns="0">
-            <a:noAutofit/>
-          </a:bodyPr>
-          <a:lstStyle xmlns:a="http://schemas.openxmlformats.org/drawingml/2006/main"/>
-          <a:p xmlns:a="http://schemas.openxmlformats.org/drawingml/2006/main">
-            <a:pPr>
-              <a:defRPr sz="2700" b="1">
-                <a:solidFill>
-                  <a:srgbClr val="182C29"/>
-                </a:solidFill>
-                <a:latin typeface="Apple SD Gothic Neo"/>
-                <a:ea typeface="Apple SD Gothic Neo"/>
-                <a:cs typeface="Apple SD Gothic Neo"/>
-              </a:defRPr>
-            </a:pPr>
-            <a:r>
-              <a:rPr sz="2700" b="1">
-                <a:solidFill>
-                  <a:srgbClr val="182C29"/>
-                </a:solidFill>
-                <a:latin typeface="Apple SD Gothic Neo"/>
-                <a:ea typeface="Apple SD Gothic Neo"/>
-                <a:cs typeface="Apple SD Gothic Neo"/>
-              </a:rPr>
-              <a:t>예상 세금</a:t>
-            </a:r>
-          </a:p>
-          <a:p xmlns:a="http://schemas.openxmlformats.org/drawingml/2006/main">
-            <a:pPr>
-              <a:defRPr sz="2700" b="1">
-                <a:solidFill>
-                  <a:srgbClr val="182C29"/>
-                </a:solidFill>
-                <a:latin typeface="Apple SD Gothic Neo"/>
-                <a:ea typeface="Apple SD Gothic Neo"/>
-                <a:cs typeface="Apple SD Gothic Neo"/>
-              </a:defRPr>
-            </a:pPr>
-            <a:r>
-              <a:rPr sz="2700" b="1">
-                <a:solidFill>
-                  <a:srgbClr val="182C29"/>
-                </a:solidFill>
-                <a:latin typeface="Apple SD Gothic Neo"/>
-                <a:ea typeface="Apple SD Gothic Neo"/>
-                <a:cs typeface="Apple SD Gothic Neo"/>
-              </a:rPr>
-              <a:t>115,776 ~ 117,335원</a:t>
-            </a:r>
-          </a:p>
-        </p:txBody>
-      </p:sp>
-      <p:sp>
-        <p:nvSpPr>
-          <p:cNvPr id="7" name="">
-            <a:extLst xmlns:a="http://schemas.openxmlformats.org/drawingml/2006/main">
-              <a:ext uri="{FF2B5EF4-FFF2-40B4-BE49-F238E27FC236}">
-                <a16:creationId xmlns:a16="http://schemas.microsoft.com/office/drawing/2014/main" id="{44851334-661D-4BA5-8B46-CD084B5D7AAF}"/>
-              </a:ext>
-            </a:extLst>
-          </p:cNvPr>
-          <p:cNvSpPr>
-            <a:spLocks xmlns:a="http://schemas.openxmlformats.org/drawingml/2006/main" noGrp="1"/>
-          </p:cNvSpPr>
-          <p:nvPr/>
-        </p:nvSpPr>
-        <p:spPr>
-          <a:xfrm xmlns:a="http://schemas.openxmlformats.org/drawingml/2006/main">
-            <a:off x="7962900" y="2714625"/>
-            <a:ext cx="6334125" cy="533400"/>
-          </a:xfrm>
-          <a:prstGeom xmlns:a="http://schemas.openxmlformats.org/drawingml/2006/main" prst="rect">
-            <a:avLst/>
-          </a:prstGeom>
-          <a:noFill xmlns:a="http://schemas.openxmlformats.org/drawingml/2006/main"/>
-          <a:ln xmlns:a="http://schemas.openxmlformats.org/drawingml/2006/main" w="0">
-            <a:noFill/>
-          </a:ln>
-        </p:spPr>
-        <p:txBody>
-          <a:bodyPr xmlns:a="http://schemas.openxmlformats.org/drawingml/2006/main" wrap="square" lIns="0" tIns="0" rIns="0" bIns="0">
-            <a:noAutofit/>
-          </a:bodyPr>
-          <a:lstStyle xmlns:a="http://schemas.openxmlformats.org/drawingml/2006/main"/>
-          <a:p xmlns:a="http://schemas.openxmlformats.org/drawingml/2006/main">
-            <a:pPr>
-              <a:defRPr sz="2625" b="1">
-                <a:solidFill>
-                  <a:srgbClr val="156E58"/>
-                </a:solidFill>
-                <a:latin typeface="Apple SD Gothic Neo"/>
-                <a:ea typeface="Apple SD Gothic Neo"/>
-                <a:cs typeface="Apple SD Gothic Neo"/>
-              </a:defRPr>
-            </a:pPr>
-            <a:r>
-              <a:rPr sz="2625" b="1">
-                <a:solidFill>
-                  <a:srgbClr val="156E58"/>
-                </a:solidFill>
-                <a:latin typeface="Apple SD Gothic Neo"/>
-                <a:ea typeface="Apple SD Gothic Neo"/>
-                <a:cs typeface="Apple SD Gothic Neo"/>
-              </a:rPr>
-              <a:t>주류 · 사양·계산 표본</a:t>
-            </a:r>
-          </a:p>
-        </p:txBody>
-      </p:sp>
-      <p:sp>
-        <p:nvSpPr>
-          <p:cNvPr id="8" name="">
-            <a:extLst xmlns:a="http://schemas.openxmlformats.org/drawingml/2006/main">
-              <a:ext uri="{FF2B5EF4-FFF2-40B4-BE49-F238E27FC236}">
-                <a16:creationId xmlns:a16="http://schemas.microsoft.com/office/drawing/2014/main" id="{2794AF89-4F7F-4382-B00F-7591E447C783}"/>
-              </a:ext>
-            </a:extLst>
-          </p:cNvPr>
-          <p:cNvSpPr>
-            <a:spLocks xmlns:a="http://schemas.openxmlformats.org/drawingml/2006/main" noGrp="1"/>
-          </p:cNvSpPr>
-          <p:nvPr/>
-        </p:nvSpPr>
-        <p:spPr>
-          <a:xfrm xmlns:a="http://schemas.openxmlformats.org/drawingml/2006/main">
-            <a:off x="7962900" y="3657600"/>
-            <a:ext cx="6334125" cy="1495425"/>
-          </a:xfrm>
-          <a:prstGeom xmlns:a="http://schemas.openxmlformats.org/drawingml/2006/main" prst="rect">
-            <a:avLst/>
-          </a:prstGeom>
-          <a:noFill xmlns:a="http://schemas.openxmlformats.org/drawingml/2006/main"/>
-          <a:ln xmlns:a="http://schemas.openxmlformats.org/drawingml/2006/main" w="0">
-            <a:noFill/>
-          </a:ln>
-        </p:spPr>
-        <p:txBody>
-          <a:bodyPr xmlns:a="http://schemas.openxmlformats.org/drawingml/2006/main" wrap="square" lIns="0" tIns="0" rIns="0" bIns="0">
-            <a:noAutofit/>
-          </a:bodyPr>
-          <a:lstStyle xmlns:a="http://schemas.openxmlformats.org/drawingml/2006/main"/>
-          <a:p xmlns:a="http://schemas.openxmlformats.org/drawingml/2006/main">
-            <a:pPr>
-              <a:defRPr sz="2250" b="0">
-                <a:solidFill>
-                  <a:srgbClr val="182C29"/>
-                </a:solidFill>
-                <a:latin typeface="Apple SD Gothic Neo"/>
-                <a:ea typeface="Apple SD Gothic Neo"/>
-                <a:cs typeface="Apple SD Gothic Neo"/>
-              </a:defRPr>
-            </a:pPr>
-            <a:r>
-              <a:rPr sz="2250" b="0">
-                <a:solidFill>
-                  <a:srgbClr val="182C29"/>
-                </a:solidFill>
-                <a:latin typeface="Apple SD Gothic Neo"/>
-                <a:ea typeface="Apple SD Gothic Neo"/>
-                <a:cs typeface="Apple SD Gothic Neo"/>
-              </a:rPr>
-              <a:t>위스키 사양에서 700ml·43% 추출</a:t>
-            </a:r>
-          </a:p>
-          <a:p xmlns:a="http://schemas.openxmlformats.org/drawingml/2006/main">
-            <a:pPr>
-              <a:defRPr sz="2250" b="0">
-                <a:solidFill>
-                  <a:srgbClr val="182C29"/>
-                </a:solidFill>
-                <a:latin typeface="Apple SD Gothic Neo"/>
-                <a:ea typeface="Apple SD Gothic Neo"/>
-                <a:cs typeface="Apple SD Gothic Neo"/>
-              </a:defRPr>
-            </a:pPr>
-            <a:r>
-              <a:rPr sz="2250" b="0">
-                <a:solidFill>
-                  <a:srgbClr val="182C29"/>
-                </a:solidFill>
-                <a:latin typeface="Apple SD Gothic Neo"/>
-                <a:ea typeface="Apple SD Gothic Neo"/>
-                <a:cs typeface="Apple SD Gothic Neo"/>
-              </a:rPr>
-              <a:t>위스키·와인·사케 분류 회귀 통과</a:t>
-            </a:r>
-          </a:p>
-          <a:p xmlns:a="http://schemas.openxmlformats.org/drawingml/2006/main">
-            <a:pPr>
-              <a:defRPr sz="2250" b="0">
-                <a:solidFill>
-                  <a:srgbClr val="182C29"/>
-                </a:solidFill>
-                <a:latin typeface="Apple SD Gothic Neo"/>
-                <a:ea typeface="Apple SD Gothic Neo"/>
-                <a:cs typeface="Apple SD Gothic Neo"/>
-              </a:defRPr>
-            </a:pPr>
-            <a:r>
-              <a:rPr sz="2250" b="0">
-                <a:solidFill>
-                  <a:srgbClr val="182C29"/>
-                </a:solidFill>
-                <a:latin typeface="Apple SD Gothic Neo"/>
-                <a:ea typeface="Apple SD Gothic Neo"/>
-                <a:cs typeface="Apple SD Gothic Neo"/>
-              </a:rPr>
-              <a:t>병 수·용량 경계와 누락 입력 검사</a:t>
-            </a:r>
-          </a:p>
-        </p:txBody>
-      </p:sp>
-      <p:sp>
-        <p:nvSpPr>
-          <p:cNvPr id="9" name="">
-            <a:extLst xmlns:a="http://schemas.openxmlformats.org/drawingml/2006/main">
-              <a:ext uri="{FF2B5EF4-FFF2-40B4-BE49-F238E27FC236}">
-                <a16:creationId xmlns:a16="http://schemas.microsoft.com/office/drawing/2014/main" id="{AE174B49-3D3A-4B6A-8CAD-08436565F26B}"/>
-              </a:ext>
-            </a:extLst>
-          </p:cNvPr>
-          <p:cNvSpPr>
-            <a:spLocks xmlns:a="http://schemas.openxmlformats.org/drawingml/2006/main" noGrp="1"/>
-          </p:cNvSpPr>
-          <p:nvPr/>
-        </p:nvSpPr>
-        <p:spPr>
-          <a:xfrm xmlns:a="http://schemas.openxmlformats.org/drawingml/2006/main">
-            <a:off x="7962900" y="5715000"/>
-            <a:ext cx="6334125" cy="1171575"/>
-          </a:xfrm>
-          <a:prstGeom xmlns:a="http://schemas.openxmlformats.org/drawingml/2006/main" prst="rect">
-            <a:avLst/>
-          </a:prstGeom>
-          <a:noFill xmlns:a="http://schemas.openxmlformats.org/drawingml/2006/main"/>
-          <a:ln xmlns:a="http://schemas.openxmlformats.org/drawingml/2006/main" w="0">
-            <a:noFill/>
-          </a:ln>
-        </p:spPr>
-        <p:txBody>
-          <a:bodyPr xmlns:a="http://schemas.openxmlformats.org/drawingml/2006/main" wrap="square" lIns="0" tIns="0" rIns="0" bIns="0">
-            <a:noAutofit/>
-          </a:bodyPr>
-          <a:lstStyle xmlns:a="http://schemas.openxmlformats.org/drawingml/2006/main"/>
-          <a:p xmlns:a="http://schemas.openxmlformats.org/drawingml/2006/main">
-            <a:pPr>
-              <a:defRPr sz="2025" b="0">
-                <a:solidFill>
-                  <a:srgbClr val="182C29"/>
-                </a:solidFill>
-                <a:latin typeface="Apple SD Gothic Neo"/>
-                <a:ea typeface="Apple SD Gothic Neo"/>
-                <a:cs typeface="Apple SD Gothic Neo"/>
-              </a:defRPr>
-            </a:pPr>
-            <a:r>
-              <a:rPr sz="2025" b="0">
-                <a:solidFill>
-                  <a:srgbClr val="182C29"/>
-                </a:solidFill>
-                <a:latin typeface="Apple SD Gothic Neo"/>
-                <a:ea typeface="Apple SD Gothic Neo"/>
-                <a:cs typeface="Apple SD Gothic Neo"/>
-              </a:rPr>
-              <a:t>위스키 합성 계산 예: 353,696원</a:t>
-            </a:r>
-          </a:p>
-          <a:p xmlns:a="http://schemas.openxmlformats.org/drawingml/2006/main">
-            <a:pPr>
-              <a:defRPr sz="2025" b="0">
-                <a:solidFill>
-                  <a:srgbClr val="182C29"/>
-                </a:solidFill>
-                <a:latin typeface="Apple SD Gothic Neo"/>
-                <a:ea typeface="Apple SD Gothic Neo"/>
-                <a:cs typeface="Apple SD Gothic Neo"/>
-              </a:defRPr>
-            </a:pPr>
-            <a:r>
-              <a:rPr sz="2025" b="0">
-                <a:solidFill>
-                  <a:srgbClr val="182C29"/>
-                </a:solidFill>
-                <a:latin typeface="Apple SD Gothic Neo"/>
-                <a:ea typeface="Apple SD Gothic Neo"/>
-                <a:cs typeface="Apple SD Gothic Neo"/>
-              </a:rPr>
-              <a:t>상품 $200 · 750ml 1병 · 40%</a:t>
-            </a:r>
-          </a:p>
-          <a:p xmlns:a="http://schemas.openxmlformats.org/drawingml/2006/main">
-            <a:pPr>
-              <a:defRPr sz="2025" b="0">
-                <a:solidFill>
-                  <a:srgbClr val="182C29"/>
-                </a:solidFill>
-                <a:latin typeface="Apple SD Gothic Neo"/>
-                <a:ea typeface="Apple SD Gothic Neo"/>
-                <a:cs typeface="Apple SD Gothic Neo"/>
-              </a:defRPr>
-            </a:pPr>
-            <a:r>
-              <a:rPr sz="2025" b="0">
-                <a:solidFill>
-                  <a:srgbClr val="182C29"/>
-                </a:solidFill>
-                <a:latin typeface="Apple SD Gothic Neo"/>
-                <a:ea typeface="Apple SD Gothic Neo"/>
-                <a:cs typeface="Apple SD Gothic Neo"/>
-              </a:rPr>
-              <a:t>환율 1,000원/$ · 운임 0 가정</a:t>
-            </a:r>
-          </a:p>
-        </p:txBody>
-      </p:sp>
-      <p:sp>
-        <p:nvSpPr>
-          <p:cNvPr id="10" name="">
-            <a:extLst xmlns:a="http://schemas.openxmlformats.org/drawingml/2006/main">
-              <a:ext uri="{FF2B5EF4-FFF2-40B4-BE49-F238E27FC236}">
-                <a16:creationId xmlns:a16="http://schemas.microsoft.com/office/drawing/2014/main" id="{9F608329-4105-4DA6-9FBB-8F9800605E76}"/>
-              </a:ext>
-            </a:extLst>
-          </p:cNvPr>
-          <p:cNvSpPr>
-            <a:spLocks xmlns:a="http://schemas.openxmlformats.org/drawingml/2006/main" noGrp="1"/>
-          </p:cNvSpPr>
-          <p:nvPr/>
-        </p:nvSpPr>
-        <p:spPr>
-          <a:xfrm xmlns:a="http://schemas.openxmlformats.org/drawingml/2006/main">
-            <a:off x="819150" y="7524750"/>
-            <a:ext cx="13525500" cy="371475"/>
-          </a:xfrm>
-          <a:prstGeom xmlns:a="http://schemas.openxmlformats.org/drawingml/2006/main" prst="rect">
-            <a:avLst/>
-          </a:prstGeom>
-          <a:noFill xmlns:a="http://schemas.openxmlformats.org/drawingml/2006/main"/>
-          <a:ln xmlns:a="http://schemas.openxmlformats.org/drawingml/2006/main" w="0">
-            <a:noFill/>
-          </a:ln>
-        </p:spPr>
-        <p:txBody>
-          <a:bodyPr xmlns:a="http://schemas.openxmlformats.org/drawingml/2006/main" wrap="square" lIns="0" tIns="0" rIns="0" bIns="0">
-            <a:noAutofit/>
-          </a:bodyPr>
-          <a:lstStyle xmlns:a="http://schemas.openxmlformats.org/drawingml/2006/main"/>
-          <a:p xmlns:a="http://schemas.openxmlformats.org/drawingml/2006/main">
-            <a:pPr>
               <a:defRPr sz="1725" b="0">
                 <a:solidFill>
                   <a:srgbClr val="5E706B"/>
@@ -4209,7 +4251,7 @@
                 <a:ea typeface="Apple SD Gothic Neo"/>
                 <a:cs typeface="Apple SD Gothic Neo"/>
               </a:rPr>
-              <a:t>실제 납부세액의 정답 검증은 아닙니다. 주류 사양 추출은9/30 당시 모델, TCG는10/5 운영 결과입니다.</a:t>
+              <a:t>실제 납부세액과 대조한 정확도 검증은 아닙니다. 주류의 사양 추출 표본과 산술 표본은 서로 다릅니다.</a:t>
             </a:r>
           </a:p>
         </p:txBody>
@@ -4217,7 +4259,7 @@
     </p:spTree>
     <p:extLst>
       <p:ext uri="{BB962C8B-B14F-4D97-AF65-F5344CB8AC3E}">
-        <p14:creationId xmlns:p14="http://schemas.microsoft.com/office/powerpoint/2010/main" val="1392590264"/>
+        <p14:creationId xmlns:p14="http://schemas.microsoft.com/office/powerpoint/2010/main" val="1325063100"/>
       </p:ext>
     </p:extLst>
   </p:cSld>
@@ -4248,7 +4290,7 @@
           <p:cNvPr id="6" name="">
             <a:extLst xmlns:a="http://schemas.openxmlformats.org/drawingml/2006/main">
               <a:ext uri="{FF2B5EF4-FFF2-40B4-BE49-F238E27FC236}">
-                <a16:creationId xmlns:a16="http://schemas.microsoft.com/office/drawing/2014/main" id="{1A80E304-0300-4F14-9828-3CEE45718595}"/>
+                <a16:creationId xmlns:a16="http://schemas.microsoft.com/office/drawing/2014/main" id="{28C853B4-E666-4E60-BB37-956CC1D2E7A8}"/>
               </a:ext>
             </a:extLst>
           </p:cNvPr>
@@ -4305,7 +4347,7 @@
           <p:cNvPr id="2" name="">
             <a:extLst xmlns:a="http://schemas.openxmlformats.org/drawingml/2006/main">
               <a:ext uri="{FF2B5EF4-FFF2-40B4-BE49-F238E27FC236}">
-                <a16:creationId xmlns:a16="http://schemas.microsoft.com/office/drawing/2014/main" id="{C6D936C4-86F9-4A15-9486-A4B311966ABF}"/>
+                <a16:creationId xmlns:a16="http://schemas.microsoft.com/office/drawing/2014/main" id="{2207DB3A-8018-45FF-9B49-448849C828E7}"/>
               </a:ext>
             </a:extLst>
           </p:cNvPr>
@@ -4362,7 +4404,7 @@
           <p:cNvPr id="3" name="">
             <a:extLst xmlns:a="http://schemas.openxmlformats.org/drawingml/2006/main">
               <a:ext uri="{FF2B5EF4-FFF2-40B4-BE49-F238E27FC236}">
-                <a16:creationId xmlns:a16="http://schemas.microsoft.com/office/drawing/2014/main" id="{2607ADB6-1845-411F-BB45-E483A68B52EA}"/>
+                <a16:creationId xmlns:a16="http://schemas.microsoft.com/office/drawing/2014/main" id="{06BCA441-3264-4701-A25C-C297AC31996C}"/>
               </a:ext>
             </a:extLst>
           </p:cNvPr>
@@ -4617,7 +4659,7 @@
           <p:cNvPr id="5" name="">
             <a:extLst xmlns:a="http://schemas.openxmlformats.org/drawingml/2006/main">
               <a:ext uri="{FF2B5EF4-FFF2-40B4-BE49-F238E27FC236}">
-                <a16:creationId xmlns:a16="http://schemas.microsoft.com/office/drawing/2014/main" id="{7B24264B-A6C6-4B7B-8D1E-321D1F24A02D}"/>
+                <a16:creationId xmlns:a16="http://schemas.microsoft.com/office/drawing/2014/main" id="{736A9A7B-3B9C-4F2F-9990-4A86DD2FCD18}"/>
               </a:ext>
             </a:extLst>
           </p:cNvPr>
@@ -4664,7 +4706,7 @@
                 <a:ea typeface="Apple SD Gothic Neo"/>
                 <a:cs typeface="Apple SD Gothic Neo"/>
               </a:rPr>
-              <a:t>라쿠텐은 API로 접근했습니다. 메루카리는 공식 파트너 API 연동 사례가 있지만,</a:t>
+              <a:t>라쿠텐은 API로 상품 정보를 가져왔습니다.</a:t>
             </a:r>
           </a:p>
           <a:p xmlns:a="http://schemas.openxmlformats.org/drawingml/2006/main">
@@ -4687,7 +4729,7 @@
                 <a:ea typeface="Apple SD Gothic Neo"/>
                 <a:cs typeface="Apple SD Gothic Neo"/>
               </a:rPr>
-              <a:t>이번 구현은 해당 API 권한을 사용하지 않았습니다.</a:t>
+              <a:t>메루카리는 웹페이지를 크롤링하고 HTML을 파싱했습니다.</a:t>
             </a:r>
           </a:p>
         </p:txBody>
@@ -4695,7 +4737,7 @@
     </p:spTree>
     <p:extLst>
       <p:ext uri="{BB962C8B-B14F-4D97-AF65-F5344CB8AC3E}">
-        <p14:creationId xmlns:p14="http://schemas.microsoft.com/office/powerpoint/2010/main" val="1717833498"/>
+        <p14:creationId xmlns:p14="http://schemas.microsoft.com/office/powerpoint/2010/main" val="1156799079"/>
       </p:ext>
     </p:extLst>
   </p:cSld>
@@ -4726,7 +4768,7 @@
           <p:cNvPr id="10" name="">
             <a:extLst xmlns:a="http://schemas.openxmlformats.org/drawingml/2006/main">
               <a:ext uri="{FF2B5EF4-FFF2-40B4-BE49-F238E27FC236}">
-                <a16:creationId xmlns:a16="http://schemas.microsoft.com/office/drawing/2014/main" id="{C0DB98E6-620C-4434-BABC-85DE15269ADB}"/>
+                <a16:creationId xmlns:a16="http://schemas.microsoft.com/office/drawing/2014/main" id="{4A91C320-A551-49C6-BACB-BF1D59C5F397}"/>
               </a:ext>
             </a:extLst>
           </p:cNvPr>
@@ -4783,7 +4825,7 @@
           <p:cNvPr id="2" name="">
             <a:extLst xmlns:a="http://schemas.openxmlformats.org/drawingml/2006/main">
               <a:ext uri="{FF2B5EF4-FFF2-40B4-BE49-F238E27FC236}">
-                <a16:creationId xmlns:a16="http://schemas.microsoft.com/office/drawing/2014/main" id="{4137D27F-0793-4648-A2AC-530AFCD0866A}"/>
+                <a16:creationId xmlns:a16="http://schemas.microsoft.com/office/drawing/2014/main" id="{04220C71-F1E2-4331-A3DB-1F87E91E7800}"/>
               </a:ext>
             </a:extLst>
           </p:cNvPr>
@@ -4840,7 +4882,7 @@
           <p:cNvPr id="3" name="">
             <a:extLst xmlns:a="http://schemas.openxmlformats.org/drawingml/2006/main">
               <a:ext uri="{FF2B5EF4-FFF2-40B4-BE49-F238E27FC236}">
-                <a16:creationId xmlns:a16="http://schemas.microsoft.com/office/drawing/2014/main" id="{DBAD3A84-40A4-41D3-AFEB-CAE18618589A}"/>
+                <a16:creationId xmlns:a16="http://schemas.microsoft.com/office/drawing/2014/main" id="{E06F7CBF-4D02-436D-BC04-B7552F552264}"/>
               </a:ext>
             </a:extLst>
           </p:cNvPr>
@@ -4897,7 +4939,7 @@
           <p:cNvPr id="4" name="">
             <a:extLst xmlns:a="http://schemas.openxmlformats.org/drawingml/2006/main">
               <a:ext uri="{FF2B5EF4-FFF2-40B4-BE49-F238E27FC236}">
-                <a16:creationId xmlns:a16="http://schemas.microsoft.com/office/drawing/2014/main" id="{0AA8F23A-762A-465A-8063-0901CE6F69F4}"/>
+                <a16:creationId xmlns:a16="http://schemas.microsoft.com/office/drawing/2014/main" id="{CCE6F7FB-D172-4971-A4C9-B2C0F4B75D5A}"/>
               </a:ext>
             </a:extLst>
           </p:cNvPr>
@@ -4954,7 +4996,7 @@
           <p:cNvPr id="5" name="">
             <a:extLst xmlns:a="http://schemas.openxmlformats.org/drawingml/2006/main">
               <a:ext uri="{FF2B5EF4-FFF2-40B4-BE49-F238E27FC236}">
-                <a16:creationId xmlns:a16="http://schemas.microsoft.com/office/drawing/2014/main" id="{57C588A4-4867-4661-93AA-2969A3BABA52}"/>
+                <a16:creationId xmlns:a16="http://schemas.microsoft.com/office/drawing/2014/main" id="{56F055E8-09F3-4AF7-8423-83BBF1D0BA5C}"/>
               </a:ext>
             </a:extLst>
           </p:cNvPr>
@@ -5085,7 +5127,7 @@
           <p:cNvPr id="6" name="">
             <a:extLst xmlns:a="http://schemas.openxmlformats.org/drawingml/2006/main">
               <a:ext uri="{FF2B5EF4-FFF2-40B4-BE49-F238E27FC236}">
-                <a16:creationId xmlns:a16="http://schemas.microsoft.com/office/drawing/2014/main" id="{02D81E10-5805-40CB-B0C5-238448C0D2B5}"/>
+                <a16:creationId xmlns:a16="http://schemas.microsoft.com/office/drawing/2014/main" id="{DAE847F7-75B9-4D87-8DC0-26B2EF6BD14C}"/>
               </a:ext>
             </a:extLst>
           </p:cNvPr>
@@ -5142,7 +5184,7 @@
           <p:cNvPr id="7" name="">
             <a:extLst xmlns:a="http://schemas.openxmlformats.org/drawingml/2006/main">
               <a:ext uri="{FF2B5EF4-FFF2-40B4-BE49-F238E27FC236}">
-                <a16:creationId xmlns:a16="http://schemas.microsoft.com/office/drawing/2014/main" id="{51B10609-06F5-4EE1-AB59-D187162FB80F}"/>
+                <a16:creationId xmlns:a16="http://schemas.microsoft.com/office/drawing/2014/main" id="{BAFF3D53-0FDD-4CF9-9F74-F706EAA262E9}"/>
               </a:ext>
             </a:extLst>
           </p:cNvPr>
@@ -5273,7 +5315,7 @@
           <p:cNvPr id="8" name="">
             <a:extLst xmlns:a="http://schemas.openxmlformats.org/drawingml/2006/main">
               <a:ext uri="{FF2B5EF4-FFF2-40B4-BE49-F238E27FC236}">
-                <a16:creationId xmlns:a16="http://schemas.microsoft.com/office/drawing/2014/main" id="{C3F1D3F9-3D35-4B90-827F-4E211B2DBC02}"/>
+                <a16:creationId xmlns:a16="http://schemas.microsoft.com/office/drawing/2014/main" id="{D4FE2287-CA90-4C1B-AF77-7DC0220EDAE7}"/>
               </a:ext>
             </a:extLst>
           </p:cNvPr>
@@ -5353,7 +5395,7 @@
           <p:cNvPr id="9" name="">
             <a:extLst xmlns:a="http://schemas.openxmlformats.org/drawingml/2006/main">
               <a:ext uri="{FF2B5EF4-FFF2-40B4-BE49-F238E27FC236}">
-                <a16:creationId xmlns:a16="http://schemas.microsoft.com/office/drawing/2014/main" id="{8BD4EB68-0806-4D09-96F1-87BEB30A211D}"/>
+                <a16:creationId xmlns:a16="http://schemas.microsoft.com/office/drawing/2014/main" id="{73F9EB4A-8BCC-4D05-A6CF-273E287A5DBB}"/>
               </a:ext>
             </a:extLst>
           </p:cNvPr>
@@ -5408,7 +5450,7 @@
     </p:spTree>
     <p:extLst>
       <p:ext uri="{BB962C8B-B14F-4D97-AF65-F5344CB8AC3E}">
-        <p14:creationId xmlns:p14="http://schemas.microsoft.com/office/powerpoint/2010/main" val="1657057454"/>
+        <p14:creationId xmlns:p14="http://schemas.microsoft.com/office/powerpoint/2010/main" val="1150575772"/>
       </p:ext>
     </p:extLst>
   </p:cSld>
@@ -5439,7 +5481,7 @@
           <p:cNvPr id="12" name="">
             <a:extLst xmlns:a="http://schemas.openxmlformats.org/drawingml/2006/main">
               <a:ext uri="{FF2B5EF4-FFF2-40B4-BE49-F238E27FC236}">
-                <a16:creationId xmlns:a16="http://schemas.microsoft.com/office/drawing/2014/main" id="{1FF39CE6-0658-4A0D-B2F7-7430B4AF0F62}"/>
+                <a16:creationId xmlns:a16="http://schemas.microsoft.com/office/drawing/2014/main" id="{21F3B2D2-DC9C-4E7E-8DBF-B1B3812095F9}"/>
               </a:ext>
             </a:extLst>
           </p:cNvPr>
@@ -5496,7 +5538,7 @@
           <p:cNvPr id="2" name="">
             <a:extLst xmlns:a="http://schemas.openxmlformats.org/drawingml/2006/main">
               <a:ext uri="{FF2B5EF4-FFF2-40B4-BE49-F238E27FC236}">
-                <a16:creationId xmlns:a16="http://schemas.microsoft.com/office/drawing/2014/main" id="{A790ED21-7096-47CB-82BD-B444CC3C1AB9}"/>
+                <a16:creationId xmlns:a16="http://schemas.microsoft.com/office/drawing/2014/main" id="{71F404E7-7DD1-4DB3-96F6-9FBA1F0CF924}"/>
               </a:ext>
             </a:extLst>
           </p:cNvPr>
@@ -5553,7 +5595,7 @@
           <p:cNvPr id="3" name="">
             <a:extLst xmlns:a="http://schemas.openxmlformats.org/drawingml/2006/main">
               <a:ext uri="{FF2B5EF4-FFF2-40B4-BE49-F238E27FC236}">
-                <a16:creationId xmlns:a16="http://schemas.microsoft.com/office/drawing/2014/main" id="{8E2E6846-367B-4940-A1B6-7A934F90C584}"/>
+                <a16:creationId xmlns:a16="http://schemas.microsoft.com/office/drawing/2014/main" id="{DC891B68-C334-43FE-8FAD-08DB719AE8FF}"/>
               </a:ext>
             </a:extLst>
           </p:cNvPr>
@@ -5610,7 +5652,7 @@
           <p:cNvPr id="4" name="">
             <a:extLst xmlns:a="http://schemas.openxmlformats.org/drawingml/2006/main">
               <a:ext uri="{FF2B5EF4-FFF2-40B4-BE49-F238E27FC236}">
-                <a16:creationId xmlns:a16="http://schemas.microsoft.com/office/drawing/2014/main" id="{90780CEF-1C9F-438A-9272-B10E2D5AB07B}"/>
+                <a16:creationId xmlns:a16="http://schemas.microsoft.com/office/drawing/2014/main" id="{9A5C8ACA-A625-4520-83B8-5DD7ADB91F20}"/>
               </a:ext>
             </a:extLst>
           </p:cNvPr>
@@ -5690,7 +5732,7 @@
           <p:cNvPr id="5" name="">
             <a:extLst xmlns:a="http://schemas.openxmlformats.org/drawingml/2006/main">
               <a:ext uri="{FF2B5EF4-FFF2-40B4-BE49-F238E27FC236}">
-                <a16:creationId xmlns:a16="http://schemas.microsoft.com/office/drawing/2014/main" id="{D792C459-A925-40B3-9D9C-E4C78C6ED14E}"/>
+                <a16:creationId xmlns:a16="http://schemas.microsoft.com/office/drawing/2014/main" id="{AF5F1826-4A87-47D0-B36D-C870BB4AC778}"/>
               </a:ext>
             </a:extLst>
           </p:cNvPr>
@@ -5749,7 +5791,7 @@
           <p:cNvPr id="6" name="">
             <a:extLst xmlns:a="http://schemas.openxmlformats.org/drawingml/2006/main">
               <a:ext uri="{FF2B5EF4-FFF2-40B4-BE49-F238E27FC236}">
-                <a16:creationId xmlns:a16="http://schemas.microsoft.com/office/drawing/2014/main" id="{999F013E-6272-43C3-82C2-BC4C59E5643C}"/>
+                <a16:creationId xmlns:a16="http://schemas.microsoft.com/office/drawing/2014/main" id="{01E48FAC-6A4D-42C5-ADA1-4776A4FFAAEF}"/>
               </a:ext>
             </a:extLst>
           </p:cNvPr>
@@ -5833,7 +5875,7 @@
           <p:cNvPr id="8" name="">
             <a:extLst xmlns:a="http://schemas.openxmlformats.org/drawingml/2006/main">
               <a:ext uri="{FF2B5EF4-FFF2-40B4-BE49-F238E27FC236}">
-                <a16:creationId xmlns:a16="http://schemas.microsoft.com/office/drawing/2014/main" id="{EA4C2E24-7A16-44A1-8C52-84E7136376F5}"/>
+                <a16:creationId xmlns:a16="http://schemas.microsoft.com/office/drawing/2014/main" id="{29E1FEB9-4F05-4F58-8E61-16E39F5710AD}"/>
               </a:ext>
             </a:extLst>
           </p:cNvPr>
@@ -5917,7 +5959,7 @@
           <p:cNvPr id="10" name="">
             <a:extLst xmlns:a="http://schemas.openxmlformats.org/drawingml/2006/main">
               <a:ext uri="{FF2B5EF4-FFF2-40B4-BE49-F238E27FC236}">
-                <a16:creationId xmlns:a16="http://schemas.microsoft.com/office/drawing/2014/main" id="{27704AD6-A9E2-4C99-B950-D3F8A79E81B0}"/>
+                <a16:creationId xmlns:a16="http://schemas.microsoft.com/office/drawing/2014/main" id="{78F0FA87-A967-403A-9222-9FAD52B6BAE9}"/>
               </a:ext>
             </a:extLst>
           </p:cNvPr>
@@ -6020,7 +6062,7 @@
           <p:cNvPr id="11" name="">
             <a:extLst xmlns:a="http://schemas.openxmlformats.org/drawingml/2006/main">
               <a:ext uri="{FF2B5EF4-FFF2-40B4-BE49-F238E27FC236}">
-                <a16:creationId xmlns:a16="http://schemas.microsoft.com/office/drawing/2014/main" id="{5057C7E8-F9FF-44C7-981E-0C75020DD85C}"/>
+                <a16:creationId xmlns:a16="http://schemas.microsoft.com/office/drawing/2014/main" id="{FEC8054B-81E1-46F9-AA44-0527AE152656}"/>
               </a:ext>
             </a:extLst>
           </p:cNvPr>
@@ -6075,7 +6117,7 @@
     </p:spTree>
     <p:extLst>
       <p:ext uri="{BB962C8B-B14F-4D97-AF65-F5344CB8AC3E}">
-        <p14:creationId xmlns:p14="http://schemas.microsoft.com/office/powerpoint/2010/main" val="195409181"/>
+        <p14:creationId xmlns:p14="http://schemas.microsoft.com/office/powerpoint/2010/main" val="853696612"/>
       </p:ext>
     </p:extLst>
   </p:cSld>
@@ -6106,7 +6148,7 @@
           <p:cNvPr id="9" name="">
             <a:extLst xmlns:a="http://schemas.openxmlformats.org/drawingml/2006/main">
               <a:ext uri="{FF2B5EF4-FFF2-40B4-BE49-F238E27FC236}">
-                <a16:creationId xmlns:a16="http://schemas.microsoft.com/office/drawing/2014/main" id="{10EDCC25-F2FF-4E94-B058-4B0DEE63CEB7}"/>
+                <a16:creationId xmlns:a16="http://schemas.microsoft.com/office/drawing/2014/main" id="{F5D5D352-4493-4AA8-BF89-C764A1107939}"/>
               </a:ext>
             </a:extLst>
           </p:cNvPr>
@@ -6163,7 +6205,7 @@
           <p:cNvPr id="2" name="">
             <a:extLst xmlns:a="http://schemas.openxmlformats.org/drawingml/2006/main">
               <a:ext uri="{FF2B5EF4-FFF2-40B4-BE49-F238E27FC236}">
-                <a16:creationId xmlns:a16="http://schemas.microsoft.com/office/drawing/2014/main" id="{91D7B011-4526-4582-A5CE-8ED630B3273B}"/>
+                <a16:creationId xmlns:a16="http://schemas.microsoft.com/office/drawing/2014/main" id="{5C481E78-38AD-4C1A-9D51-D3CB16A8F39B}"/>
               </a:ext>
             </a:extLst>
           </p:cNvPr>
@@ -6220,7 +6262,7 @@
           <p:cNvPr id="3" name="">
             <a:extLst xmlns:a="http://schemas.openxmlformats.org/drawingml/2006/main">
               <a:ext uri="{FF2B5EF4-FFF2-40B4-BE49-F238E27FC236}">
-                <a16:creationId xmlns:a16="http://schemas.microsoft.com/office/drawing/2014/main" id="{52E67FD1-B721-4593-94C5-2AC3AAF9FE8C}"/>
+                <a16:creationId xmlns:a16="http://schemas.microsoft.com/office/drawing/2014/main" id="{90DBFF93-C493-4DDA-B2EE-26380CD8076C}"/>
               </a:ext>
             </a:extLst>
           </p:cNvPr>
@@ -6277,7 +6319,7 @@
           <p:cNvPr id="4" name="">
             <a:extLst xmlns:a="http://schemas.openxmlformats.org/drawingml/2006/main">
               <a:ext uri="{FF2B5EF4-FFF2-40B4-BE49-F238E27FC236}">
-                <a16:creationId xmlns:a16="http://schemas.microsoft.com/office/drawing/2014/main" id="{F1736CEE-4F54-4915-9873-11869E90D9B8}"/>
+                <a16:creationId xmlns:a16="http://schemas.microsoft.com/office/drawing/2014/main" id="{598BD0DA-13F6-47B5-A2F4-FB57851B561B}"/>
               </a:ext>
             </a:extLst>
           </p:cNvPr>
@@ -6334,7 +6376,7 @@
           <p:cNvPr id="5" name="">
             <a:extLst xmlns:a="http://schemas.openxmlformats.org/drawingml/2006/main">
               <a:ext uri="{FF2B5EF4-FFF2-40B4-BE49-F238E27FC236}">
-                <a16:creationId xmlns:a16="http://schemas.microsoft.com/office/drawing/2014/main" id="{E2DCC701-EAA4-43B1-8FC4-9086BE820E9E}"/>
+                <a16:creationId xmlns:a16="http://schemas.microsoft.com/office/drawing/2014/main" id="{A316CC9D-FD54-42B9-AA54-566D29EEF668}"/>
               </a:ext>
             </a:extLst>
           </p:cNvPr>
@@ -6437,7 +6479,7 @@
           <p:cNvPr id="6" name="">
             <a:extLst xmlns:a="http://schemas.openxmlformats.org/drawingml/2006/main">
               <a:ext uri="{FF2B5EF4-FFF2-40B4-BE49-F238E27FC236}">
-                <a16:creationId xmlns:a16="http://schemas.microsoft.com/office/drawing/2014/main" id="{906464F4-68CD-42C6-A040-259219A7FBAB}"/>
+                <a16:creationId xmlns:a16="http://schemas.microsoft.com/office/drawing/2014/main" id="{946F3D10-DDAC-44AA-8096-40AD6A099BD0}"/>
               </a:ext>
             </a:extLst>
           </p:cNvPr>
@@ -6494,7 +6536,7 @@
           <p:cNvPr id="7" name="">
             <a:extLst xmlns:a="http://schemas.openxmlformats.org/drawingml/2006/main">
               <a:ext uri="{FF2B5EF4-FFF2-40B4-BE49-F238E27FC236}">
-                <a16:creationId xmlns:a16="http://schemas.microsoft.com/office/drawing/2014/main" id="{8A1ED267-9446-4394-9195-04898BB37C03}"/>
+                <a16:creationId xmlns:a16="http://schemas.microsoft.com/office/drawing/2014/main" id="{108AA8DE-803A-423C-A737-880B8FA929A6}"/>
               </a:ext>
             </a:extLst>
           </p:cNvPr>
@@ -6597,7 +6639,7 @@
           <p:cNvPr id="8" name="">
             <a:extLst xmlns:a="http://schemas.openxmlformats.org/drawingml/2006/main">
               <a:ext uri="{FF2B5EF4-FFF2-40B4-BE49-F238E27FC236}">
-                <a16:creationId xmlns:a16="http://schemas.microsoft.com/office/drawing/2014/main" id="{8BCCF681-4AE2-43EA-BF66-0AE6B05B3A41}"/>
+                <a16:creationId xmlns:a16="http://schemas.microsoft.com/office/drawing/2014/main" id="{D9A82072-1CF4-4B12-A061-C4DEC4136A10}"/>
               </a:ext>
             </a:extLst>
           </p:cNvPr>
@@ -6652,7 +6694,7 @@
     </p:spTree>
     <p:extLst>
       <p:ext uri="{BB962C8B-B14F-4D97-AF65-F5344CB8AC3E}">
-        <p14:creationId xmlns:p14="http://schemas.microsoft.com/office/powerpoint/2010/main" val="120576730"/>
+        <p14:creationId xmlns:p14="http://schemas.microsoft.com/office/powerpoint/2010/main" val="1222798734"/>
       </p:ext>
     </p:extLst>
   </p:cSld>
@@ -6683,7 +6725,7 @@
           <p:cNvPr id="6" name="">
             <a:extLst xmlns:a="http://schemas.openxmlformats.org/drawingml/2006/main">
               <a:ext uri="{FF2B5EF4-FFF2-40B4-BE49-F238E27FC236}">
-                <a16:creationId xmlns:a16="http://schemas.microsoft.com/office/drawing/2014/main" id="{AD94ABEB-A1CB-4EC5-84D4-6FAC4EA19B77}"/>
+                <a16:creationId xmlns:a16="http://schemas.microsoft.com/office/drawing/2014/main" id="{CF95F803-E23C-41A0-A578-6FE6C93140A3}"/>
               </a:ext>
             </a:extLst>
           </p:cNvPr>
@@ -6740,7 +6782,7 @@
           <p:cNvPr id="2" name="">
             <a:extLst xmlns:a="http://schemas.openxmlformats.org/drawingml/2006/main">
               <a:ext uri="{FF2B5EF4-FFF2-40B4-BE49-F238E27FC236}">
-                <a16:creationId xmlns:a16="http://schemas.microsoft.com/office/drawing/2014/main" id="{4D537B2B-A8EA-482E-9B5C-32CEA48D72A3}"/>
+                <a16:creationId xmlns:a16="http://schemas.microsoft.com/office/drawing/2014/main" id="{5F223DEE-EC3B-4B41-AB5C-A7314BA3947C}"/>
               </a:ext>
             </a:extLst>
           </p:cNvPr>
@@ -6797,7 +6839,7 @@
           <p:cNvPr id="3" name="">
             <a:extLst xmlns:a="http://schemas.openxmlformats.org/drawingml/2006/main">
               <a:ext uri="{FF2B5EF4-FFF2-40B4-BE49-F238E27FC236}">
-                <a16:creationId xmlns:a16="http://schemas.microsoft.com/office/drawing/2014/main" id="{6D5F82DB-F4CF-4292-93C3-32AD26F2CAA9}"/>
+                <a16:creationId xmlns:a16="http://schemas.microsoft.com/office/drawing/2014/main" id="{7E3DA974-9A86-4E19-B69C-E5206092B456}"/>
               </a:ext>
             </a:extLst>
           </p:cNvPr>
@@ -7139,7 +7181,7 @@
           <p:cNvPr id="5" name="">
             <a:extLst xmlns:a="http://schemas.openxmlformats.org/drawingml/2006/main">
               <a:ext uri="{FF2B5EF4-FFF2-40B4-BE49-F238E27FC236}">
-                <a16:creationId xmlns:a16="http://schemas.microsoft.com/office/drawing/2014/main" id="{9E62041B-0FF6-4A66-B6C3-FBD6F5FCB591}"/>
+                <a16:creationId xmlns:a16="http://schemas.microsoft.com/office/drawing/2014/main" id="{B16CCCF5-ABC6-4ACA-8864-927EC36FBEE7}"/>
               </a:ext>
             </a:extLst>
           </p:cNvPr>
@@ -7194,7 +7236,7 @@
     </p:spTree>
     <p:extLst>
       <p:ext uri="{BB962C8B-B14F-4D97-AF65-F5344CB8AC3E}">
-        <p14:creationId xmlns:p14="http://schemas.microsoft.com/office/powerpoint/2010/main" val="1621930168"/>
+        <p14:creationId xmlns:p14="http://schemas.microsoft.com/office/powerpoint/2010/main" val="1888627377"/>
       </p:ext>
     </p:extLst>
   </p:cSld>
@@ -7225,7 +7267,7 @@
           <p:cNvPr id="7" name="">
             <a:extLst xmlns:a="http://schemas.openxmlformats.org/drawingml/2006/main">
               <a:ext uri="{FF2B5EF4-FFF2-40B4-BE49-F238E27FC236}">
-                <a16:creationId xmlns:a16="http://schemas.microsoft.com/office/drawing/2014/main" id="{3EDDE0B0-D2A6-42A2-957B-319968D2A53A}"/>
+                <a16:creationId xmlns:a16="http://schemas.microsoft.com/office/drawing/2014/main" id="{D28E63C5-9ADD-4B6A-8B19-8A1AC4C742AA}"/>
               </a:ext>
             </a:extLst>
           </p:cNvPr>
@@ -7282,7 +7324,7 @@
           <p:cNvPr id="2" name="">
             <a:extLst xmlns:a="http://schemas.openxmlformats.org/drawingml/2006/main">
               <a:ext uri="{FF2B5EF4-FFF2-40B4-BE49-F238E27FC236}">
-                <a16:creationId xmlns:a16="http://schemas.microsoft.com/office/drawing/2014/main" id="{96A27F29-43B4-4596-80A0-F1C53A0BBC7B}"/>
+                <a16:creationId xmlns:a16="http://schemas.microsoft.com/office/drawing/2014/main" id="{B390CFE5-EB58-4D91-B544-2C842516601F}"/>
               </a:ext>
             </a:extLst>
           </p:cNvPr>
@@ -7339,7 +7381,7 @@
           <p:cNvPr id="3" name="">
             <a:extLst xmlns:a="http://schemas.openxmlformats.org/drawingml/2006/main">
               <a:ext uri="{FF2B5EF4-FFF2-40B4-BE49-F238E27FC236}">
-                <a16:creationId xmlns:a16="http://schemas.microsoft.com/office/drawing/2014/main" id="{4011F222-653B-4B89-A07F-3388D739ED1C}"/>
+                <a16:creationId xmlns:a16="http://schemas.microsoft.com/office/drawing/2014/main" id="{09A29B86-692F-48CC-92A3-536F5AE54D6D}"/>
               </a:ext>
             </a:extLst>
           </p:cNvPr>
@@ -7789,7 +7831,7 @@
           <p:cNvPr id="5" name="">
             <a:extLst xmlns:a="http://schemas.openxmlformats.org/drawingml/2006/main">
               <a:ext uri="{FF2B5EF4-FFF2-40B4-BE49-F238E27FC236}">
-                <a16:creationId xmlns:a16="http://schemas.microsoft.com/office/drawing/2014/main" id="{D4038E80-96EB-4567-97BD-CBF20A3B3084}"/>
+                <a16:creationId xmlns:a16="http://schemas.microsoft.com/office/drawing/2014/main" id="{B7985078-AB27-44EB-BF14-786D28726FE7}"/>
               </a:ext>
             </a:extLst>
           </p:cNvPr>
@@ -7846,7 +7888,7 @@
           <p:cNvPr id="6" name="">
             <a:extLst xmlns:a="http://schemas.openxmlformats.org/drawingml/2006/main">
               <a:ext uri="{FF2B5EF4-FFF2-40B4-BE49-F238E27FC236}">
-                <a16:creationId xmlns:a16="http://schemas.microsoft.com/office/drawing/2014/main" id="{3A7F7811-949B-4C38-9968-C7AAFAADB9AA}"/>
+                <a16:creationId xmlns:a16="http://schemas.microsoft.com/office/drawing/2014/main" id="{9B6675B2-F7B6-4288-8BD6-4623D9D0405A}"/>
               </a:ext>
             </a:extLst>
           </p:cNvPr>
@@ -7901,7 +7943,7 @@
     </p:spTree>
     <p:extLst>
       <p:ext uri="{BB962C8B-B14F-4D97-AF65-F5344CB8AC3E}">
-        <p14:creationId xmlns:p14="http://schemas.microsoft.com/office/powerpoint/2010/main" val="1397717864"/>
+        <p14:creationId xmlns:p14="http://schemas.microsoft.com/office/powerpoint/2010/main" val="1984717979"/>
       </p:ext>
     </p:extLst>
   </p:cSld>
@@ -7932,7 +7974,7 @@
           <p:cNvPr id="11" name="">
             <a:extLst xmlns:a="http://schemas.openxmlformats.org/drawingml/2006/main">
               <a:ext uri="{FF2B5EF4-FFF2-40B4-BE49-F238E27FC236}">
-                <a16:creationId xmlns:a16="http://schemas.microsoft.com/office/drawing/2014/main" id="{6FB471D5-C6C2-44F4-BFED-03E16A544145}"/>
+                <a16:creationId xmlns:a16="http://schemas.microsoft.com/office/drawing/2014/main" id="{53083F18-9D98-41AF-852E-8E68069D49CB}"/>
               </a:ext>
             </a:extLst>
           </p:cNvPr>
@@ -7989,7 +8031,7 @@
           <p:cNvPr id="2" name="">
             <a:extLst xmlns:a="http://schemas.openxmlformats.org/drawingml/2006/main">
               <a:ext uri="{FF2B5EF4-FFF2-40B4-BE49-F238E27FC236}">
-                <a16:creationId xmlns:a16="http://schemas.microsoft.com/office/drawing/2014/main" id="{0D397AF0-0D3A-418C-86C7-EBA6239FD967}"/>
+                <a16:creationId xmlns:a16="http://schemas.microsoft.com/office/drawing/2014/main" id="{259BBD3F-7936-4CB1-96EC-E0A3C9E20F9B}"/>
               </a:ext>
             </a:extLst>
           </p:cNvPr>
@@ -8046,7 +8088,7 @@
           <p:cNvPr id="3" name="">
             <a:extLst xmlns:a="http://schemas.openxmlformats.org/drawingml/2006/main">
               <a:ext uri="{FF2B5EF4-FFF2-40B4-BE49-F238E27FC236}">
-                <a16:creationId xmlns:a16="http://schemas.microsoft.com/office/drawing/2014/main" id="{B61AEB6C-701D-443E-9994-19B21697D019}"/>
+                <a16:creationId xmlns:a16="http://schemas.microsoft.com/office/drawing/2014/main" id="{AA7D181E-7E2B-4E88-9007-2779779F56C1}"/>
               </a:ext>
             </a:extLst>
           </p:cNvPr>
@@ -8103,7 +8145,7 @@
           <p:cNvPr id="4" name="">
             <a:extLst xmlns:a="http://schemas.openxmlformats.org/drawingml/2006/main">
               <a:ext uri="{FF2B5EF4-FFF2-40B4-BE49-F238E27FC236}">
-                <a16:creationId xmlns:a16="http://schemas.microsoft.com/office/drawing/2014/main" id="{5514B6D9-5D74-4A92-85CF-2717841229BF}"/>
+                <a16:creationId xmlns:a16="http://schemas.microsoft.com/office/drawing/2014/main" id="{64433E76-3415-401E-9021-CF96C1BD8138}"/>
               </a:ext>
             </a:extLst>
           </p:cNvPr>
@@ -8160,7 +8202,7 @@
           <p:cNvPr id="5" name="">
             <a:extLst xmlns:a="http://schemas.openxmlformats.org/drawingml/2006/main">
               <a:ext uri="{FF2B5EF4-FFF2-40B4-BE49-F238E27FC236}">
-                <a16:creationId xmlns:a16="http://schemas.microsoft.com/office/drawing/2014/main" id="{217D9096-C936-4D25-BF2D-1244B8769451}"/>
+                <a16:creationId xmlns:a16="http://schemas.microsoft.com/office/drawing/2014/main" id="{4671CE0C-05DF-4633-BA86-E24DE25B8DF9}"/>
               </a:ext>
             </a:extLst>
           </p:cNvPr>
@@ -8263,7 +8305,7 @@
           <p:cNvPr id="6" name="">
             <a:extLst xmlns:a="http://schemas.openxmlformats.org/drawingml/2006/main">
               <a:ext uri="{FF2B5EF4-FFF2-40B4-BE49-F238E27FC236}">
-                <a16:creationId xmlns:a16="http://schemas.microsoft.com/office/drawing/2014/main" id="{926A635D-B9AB-4A50-8F94-DBE404AE835E}"/>
+                <a16:creationId xmlns:a16="http://schemas.microsoft.com/office/drawing/2014/main" id="{28CB2F9C-A1B9-4193-9019-3680690D2717}"/>
               </a:ext>
             </a:extLst>
           </p:cNvPr>
@@ -8343,7 +8385,7 @@
           <p:cNvPr id="7" name="">
             <a:extLst xmlns:a="http://schemas.openxmlformats.org/drawingml/2006/main">
               <a:ext uri="{FF2B5EF4-FFF2-40B4-BE49-F238E27FC236}">
-                <a16:creationId xmlns:a16="http://schemas.microsoft.com/office/drawing/2014/main" id="{68D324C2-48E7-4BF0-B945-C991DEE9E4C4}"/>
+                <a16:creationId xmlns:a16="http://schemas.microsoft.com/office/drawing/2014/main" id="{566F0C79-B0D2-4132-A828-68712189B195}"/>
               </a:ext>
             </a:extLst>
           </p:cNvPr>
@@ -8400,7 +8442,7 @@
           <p:cNvPr id="8" name="">
             <a:extLst xmlns:a="http://schemas.openxmlformats.org/drawingml/2006/main">
               <a:ext uri="{FF2B5EF4-FFF2-40B4-BE49-F238E27FC236}">
-                <a16:creationId xmlns:a16="http://schemas.microsoft.com/office/drawing/2014/main" id="{846D52CC-8AA2-445F-A193-4C4027EBB1C9}"/>
+                <a16:creationId xmlns:a16="http://schemas.microsoft.com/office/drawing/2014/main" id="{4F76F714-A453-4A80-9365-5CB4821B4EEA}"/>
               </a:ext>
             </a:extLst>
           </p:cNvPr>
@@ -8503,7 +8545,7 @@
           <p:cNvPr id="9" name="">
             <a:extLst xmlns:a="http://schemas.openxmlformats.org/drawingml/2006/main">
               <a:ext uri="{FF2B5EF4-FFF2-40B4-BE49-F238E27FC236}">
-                <a16:creationId xmlns:a16="http://schemas.microsoft.com/office/drawing/2014/main" id="{437788BC-C2E7-4785-A0B2-B3D698E0EC0A}"/>
+                <a16:creationId xmlns:a16="http://schemas.microsoft.com/office/drawing/2014/main" id="{3796DADF-C00B-4362-AEA4-6B0D939B8DCD}"/>
               </a:ext>
             </a:extLst>
           </p:cNvPr>
@@ -8583,7 +8625,7 @@
           <p:cNvPr id="10" name="">
             <a:extLst xmlns:a="http://schemas.openxmlformats.org/drawingml/2006/main">
               <a:ext uri="{FF2B5EF4-FFF2-40B4-BE49-F238E27FC236}">
-                <a16:creationId xmlns:a16="http://schemas.microsoft.com/office/drawing/2014/main" id="{7735BD61-E266-4923-848D-03BE2C961C74}"/>
+                <a16:creationId xmlns:a16="http://schemas.microsoft.com/office/drawing/2014/main" id="{40A77243-2323-4097-80CB-46C1E51B49D9}"/>
               </a:ext>
             </a:extLst>
           </p:cNvPr>
@@ -8638,7 +8680,7 @@
     </p:spTree>
     <p:extLst>
       <p:ext uri="{BB962C8B-B14F-4D97-AF65-F5344CB8AC3E}">
-        <p14:creationId xmlns:p14="http://schemas.microsoft.com/office/powerpoint/2010/main" val="1281087230"/>
+        <p14:creationId xmlns:p14="http://schemas.microsoft.com/office/powerpoint/2010/main" val="96009478"/>
       </p:ext>
     </p:extLst>
   </p:cSld>
@@ -8669,7 +8711,7 @@
           <p:cNvPr id="11" name="">
             <a:extLst xmlns:a="http://schemas.openxmlformats.org/drawingml/2006/main">
               <a:ext uri="{FF2B5EF4-FFF2-40B4-BE49-F238E27FC236}">
-                <a16:creationId xmlns:a16="http://schemas.microsoft.com/office/drawing/2014/main" id="{B5BD1123-B8F4-4A91-8280-B2F7F726B1DC}"/>
+                <a16:creationId xmlns:a16="http://schemas.microsoft.com/office/drawing/2014/main" id="{681A985C-25FA-48EB-98AF-50B20B292950}"/>
               </a:ext>
             </a:extLst>
           </p:cNvPr>
@@ -8726,7 +8768,7 @@
           <p:cNvPr id="2" name="">
             <a:extLst xmlns:a="http://schemas.openxmlformats.org/drawingml/2006/main">
               <a:ext uri="{FF2B5EF4-FFF2-40B4-BE49-F238E27FC236}">
-                <a16:creationId xmlns:a16="http://schemas.microsoft.com/office/drawing/2014/main" id="{6A4E4D6B-62E8-4F67-BBFF-7721FF55D8F8}"/>
+                <a16:creationId xmlns:a16="http://schemas.microsoft.com/office/drawing/2014/main" id="{3B3A0AF7-ADFE-4033-BCBE-9A92B44516F2}"/>
               </a:ext>
             </a:extLst>
           </p:cNvPr>
@@ -8783,7 +8825,7 @@
           <p:cNvPr id="3" name="">
             <a:extLst xmlns:a="http://schemas.openxmlformats.org/drawingml/2006/main">
               <a:ext uri="{FF2B5EF4-FFF2-40B4-BE49-F238E27FC236}">
-                <a16:creationId xmlns:a16="http://schemas.microsoft.com/office/drawing/2014/main" id="{57C21F0A-9884-4DDB-9330-E7BB04987667}"/>
+                <a16:creationId xmlns:a16="http://schemas.microsoft.com/office/drawing/2014/main" id="{7B110A09-B542-4FC9-B034-C7CC2BA3B3BA}"/>
               </a:ext>
             </a:extLst>
           </p:cNvPr>
@@ -8840,7 +8882,7 @@
           <p:cNvPr id="4" name="">
             <a:extLst xmlns:a="http://schemas.openxmlformats.org/drawingml/2006/main">
               <a:ext uri="{FF2B5EF4-FFF2-40B4-BE49-F238E27FC236}">
-                <a16:creationId xmlns:a16="http://schemas.microsoft.com/office/drawing/2014/main" id="{FDC62865-4E72-442C-B98C-83E4B0939FC9}"/>
+                <a16:creationId xmlns:a16="http://schemas.microsoft.com/office/drawing/2014/main" id="{0ED7836B-0C11-4B3F-BC47-9ABC0297678F}"/>
               </a:ext>
             </a:extLst>
           </p:cNvPr>
@@ -8897,7 +8939,7 @@
           <p:cNvPr id="5" name="">
             <a:extLst xmlns:a="http://schemas.openxmlformats.org/drawingml/2006/main">
               <a:ext uri="{FF2B5EF4-FFF2-40B4-BE49-F238E27FC236}">
-                <a16:creationId xmlns:a16="http://schemas.microsoft.com/office/drawing/2014/main" id="{F34EE686-37E5-4DA5-B4DE-B12B9A630780}"/>
+                <a16:creationId xmlns:a16="http://schemas.microsoft.com/office/drawing/2014/main" id="{D044C08D-EC62-4BCC-8F18-F4B2AF8D3C71}"/>
               </a:ext>
             </a:extLst>
           </p:cNvPr>
@@ -8954,7 +8996,7 @@
           <p:cNvPr id="6" name="">
             <a:extLst xmlns:a="http://schemas.openxmlformats.org/drawingml/2006/main">
               <a:ext uri="{FF2B5EF4-FFF2-40B4-BE49-F238E27FC236}">
-                <a16:creationId xmlns:a16="http://schemas.microsoft.com/office/drawing/2014/main" id="{08216169-7BCE-49CD-97DE-2BE6AA336254}"/>
+                <a16:creationId xmlns:a16="http://schemas.microsoft.com/office/drawing/2014/main" id="{7B17C608-D3EF-4530-B62E-A0CEB2492DC1}"/>
               </a:ext>
             </a:extLst>
           </p:cNvPr>
@@ -9057,7 +9099,7 @@
           <p:cNvPr id="7" name="">
             <a:extLst xmlns:a="http://schemas.openxmlformats.org/drawingml/2006/main">
               <a:ext uri="{FF2B5EF4-FFF2-40B4-BE49-F238E27FC236}">
-                <a16:creationId xmlns:a16="http://schemas.microsoft.com/office/drawing/2014/main" id="{D90CCF88-3F3B-4672-85FE-2A362DE9E6B1}"/>
+                <a16:creationId xmlns:a16="http://schemas.microsoft.com/office/drawing/2014/main" id="{3CB2CE1A-F2E0-4269-8F4A-4E188F320ACF}"/>
               </a:ext>
             </a:extLst>
           </p:cNvPr>
@@ -9114,7 +9156,7 @@
           <p:cNvPr id="8" name="">
             <a:extLst xmlns:a="http://schemas.openxmlformats.org/drawingml/2006/main">
               <a:ext uri="{FF2B5EF4-FFF2-40B4-BE49-F238E27FC236}">
-                <a16:creationId xmlns:a16="http://schemas.microsoft.com/office/drawing/2014/main" id="{D20D2CD5-E304-432B-8203-3AF8820C5BAF}"/>
+                <a16:creationId xmlns:a16="http://schemas.microsoft.com/office/drawing/2014/main" id="{EC841C23-13C3-4C04-AB0D-97A2A50DBC92}"/>
               </a:ext>
             </a:extLst>
           </p:cNvPr>
@@ -9171,7 +9213,7 @@
           <p:cNvPr id="9" name="">
             <a:extLst xmlns:a="http://schemas.openxmlformats.org/drawingml/2006/main">
               <a:ext uri="{FF2B5EF4-FFF2-40B4-BE49-F238E27FC236}">
-                <a16:creationId xmlns:a16="http://schemas.microsoft.com/office/drawing/2014/main" id="{AC3256CF-A5B3-41A2-B75E-5FF017C002DF}"/>
+                <a16:creationId xmlns:a16="http://schemas.microsoft.com/office/drawing/2014/main" id="{1B6FE848-451E-4FF1-93CB-57CBC664CB62}"/>
               </a:ext>
             </a:extLst>
           </p:cNvPr>
@@ -9274,7 +9316,7 @@
           <p:cNvPr id="10" name="">
             <a:extLst xmlns:a="http://schemas.openxmlformats.org/drawingml/2006/main">
               <a:ext uri="{FF2B5EF4-FFF2-40B4-BE49-F238E27FC236}">
-                <a16:creationId xmlns:a16="http://schemas.microsoft.com/office/drawing/2014/main" id="{21EC2535-2960-47B6-BCDE-6C211A18D3A3}"/>
+                <a16:creationId xmlns:a16="http://schemas.microsoft.com/office/drawing/2014/main" id="{AF9FE24B-02A6-46E6-A920-14A68EE20315}"/>
               </a:ext>
             </a:extLst>
           </p:cNvPr>
@@ -9329,7 +9371,7 @@
     </p:spTree>
     <p:extLst>
       <p:ext uri="{BB962C8B-B14F-4D97-AF65-F5344CB8AC3E}">
-        <p14:creationId xmlns:p14="http://schemas.microsoft.com/office/powerpoint/2010/main" val="242933026"/>
+        <p14:creationId xmlns:p14="http://schemas.microsoft.com/office/powerpoint/2010/main" val="1302186108"/>
       </p:ext>
     </p:extLst>
   </p:cSld>
@@ -9360,7 +9402,7 @@
           <p:cNvPr id="20" name="">
             <a:extLst xmlns:a="http://schemas.openxmlformats.org/drawingml/2006/main">
               <a:ext uri="{FF2B5EF4-FFF2-40B4-BE49-F238E27FC236}">
-                <a16:creationId xmlns:a16="http://schemas.microsoft.com/office/drawing/2014/main" id="{833C03D2-E1F0-4067-9559-A1D894885682}"/>
+                <a16:creationId xmlns:a16="http://schemas.microsoft.com/office/drawing/2014/main" id="{8CB55F84-2442-4EC4-A045-15187347DC90}"/>
               </a:ext>
             </a:extLst>
           </p:cNvPr>
@@ -9417,7 +9459,7 @@
           <p:cNvPr id="2" name="">
             <a:extLst xmlns:a="http://schemas.openxmlformats.org/drawingml/2006/main">
               <a:ext uri="{FF2B5EF4-FFF2-40B4-BE49-F238E27FC236}">
-                <a16:creationId xmlns:a16="http://schemas.microsoft.com/office/drawing/2014/main" id="{E436BBB6-A5C6-47DF-9E9D-24D5ABB9D6B3}"/>
+                <a16:creationId xmlns:a16="http://schemas.microsoft.com/office/drawing/2014/main" id="{D24DCC48-0DAF-4547-824D-76ACF5C1698A}"/>
               </a:ext>
             </a:extLst>
           </p:cNvPr>
@@ -9474,7 +9516,7 @@
           <p:cNvPr id="3" name="">
             <a:extLst xmlns:a="http://schemas.openxmlformats.org/drawingml/2006/main">
               <a:ext uri="{FF2B5EF4-FFF2-40B4-BE49-F238E27FC236}">
-                <a16:creationId xmlns:a16="http://schemas.microsoft.com/office/drawing/2014/main" id="{BD68437D-D4E4-408D-80A4-C31E99B852D7}"/>
+                <a16:creationId xmlns:a16="http://schemas.microsoft.com/office/drawing/2014/main" id="{A9ACC63C-220B-49FC-9FCC-EA9189E3232D}"/>
               </a:ext>
             </a:extLst>
           </p:cNvPr>
@@ -9531,7 +9573,7 @@
           <p:cNvPr id="4" name="">
             <a:extLst xmlns:a="http://schemas.openxmlformats.org/drawingml/2006/main">
               <a:ext uri="{FF2B5EF4-FFF2-40B4-BE49-F238E27FC236}">
-                <a16:creationId xmlns:a16="http://schemas.microsoft.com/office/drawing/2014/main" id="{22FA39DC-7D53-47F3-B893-779B552CAF31}"/>
+                <a16:creationId xmlns:a16="http://schemas.microsoft.com/office/drawing/2014/main" id="{8E2D93C3-2636-4EDD-A57F-E8E922DA3ED9}"/>
               </a:ext>
             </a:extLst>
           </p:cNvPr>
@@ -9590,7 +9632,7 @@
           <p:cNvPr id="5" name="">
             <a:extLst xmlns:a="http://schemas.openxmlformats.org/drawingml/2006/main">
               <a:ext uri="{FF2B5EF4-FFF2-40B4-BE49-F238E27FC236}">
-                <a16:creationId xmlns:a16="http://schemas.microsoft.com/office/drawing/2014/main" id="{E2DBB137-312A-40D7-BB6E-FED37D1EBD1C}"/>
+                <a16:creationId xmlns:a16="http://schemas.microsoft.com/office/drawing/2014/main" id="{D6A04DD3-38A1-4731-8AA0-44C389785D89}"/>
               </a:ext>
             </a:extLst>
           </p:cNvPr>
@@ -9674,7 +9716,7 @@
           <p:cNvPr id="7" name="">
             <a:extLst xmlns:a="http://schemas.openxmlformats.org/drawingml/2006/main">
               <a:ext uri="{FF2B5EF4-FFF2-40B4-BE49-F238E27FC236}">
-                <a16:creationId xmlns:a16="http://schemas.microsoft.com/office/drawing/2014/main" id="{6DAA0788-CA8A-4812-A22D-6355226815E7}"/>
+                <a16:creationId xmlns:a16="http://schemas.microsoft.com/office/drawing/2014/main" id="{A79445A1-05DC-4155-993D-39AA39D2367F}"/>
               </a:ext>
             </a:extLst>
           </p:cNvPr>
@@ -9758,7 +9800,7 @@
           <p:cNvPr id="9" name="">
             <a:extLst xmlns:a="http://schemas.openxmlformats.org/drawingml/2006/main">
               <a:ext uri="{FF2B5EF4-FFF2-40B4-BE49-F238E27FC236}">
-                <a16:creationId xmlns:a16="http://schemas.microsoft.com/office/drawing/2014/main" id="{7480BD3F-F6DD-468F-BD8A-D93122BA2058}"/>
+                <a16:creationId xmlns:a16="http://schemas.microsoft.com/office/drawing/2014/main" id="{84894945-623C-4FDD-88FB-7327A2DB01E7}"/>
               </a:ext>
             </a:extLst>
           </p:cNvPr>
@@ -9842,7 +9884,7 @@
           <p:cNvPr id="11" name="">
             <a:extLst xmlns:a="http://schemas.openxmlformats.org/drawingml/2006/main">
               <a:ext uri="{FF2B5EF4-FFF2-40B4-BE49-F238E27FC236}">
-                <a16:creationId xmlns:a16="http://schemas.microsoft.com/office/drawing/2014/main" id="{B12F4752-6A7E-45EF-AD51-063A35323513}"/>
+                <a16:creationId xmlns:a16="http://schemas.microsoft.com/office/drawing/2014/main" id="{79172E1D-344B-497B-8021-E201881D77C7}"/>
               </a:ext>
             </a:extLst>
           </p:cNvPr>
@@ -9926,7 +9968,7 @@
           <p:cNvPr id="13" name="">
             <a:extLst xmlns:a="http://schemas.openxmlformats.org/drawingml/2006/main">
               <a:ext uri="{FF2B5EF4-FFF2-40B4-BE49-F238E27FC236}">
-                <a16:creationId xmlns:a16="http://schemas.microsoft.com/office/drawing/2014/main" id="{FC560C66-EF9C-415C-B38A-695C52ADBAEC}"/>
+                <a16:creationId xmlns:a16="http://schemas.microsoft.com/office/drawing/2014/main" id="{918685E2-0E99-4F1C-B4CB-2F91C3F0038B}"/>
               </a:ext>
             </a:extLst>
           </p:cNvPr>
@@ -9983,7 +10025,7 @@
           <p:cNvPr id="14" name="">
             <a:extLst xmlns:a="http://schemas.openxmlformats.org/drawingml/2006/main">
               <a:ext uri="{FF2B5EF4-FFF2-40B4-BE49-F238E27FC236}">
-                <a16:creationId xmlns:a16="http://schemas.microsoft.com/office/drawing/2014/main" id="{B163E2CD-6196-4F66-A627-B90162DE2CEF}"/>
+                <a16:creationId xmlns:a16="http://schemas.microsoft.com/office/drawing/2014/main" id="{39BDB39D-76C2-4C52-8FB5-5BC9A79553DF}"/>
               </a:ext>
             </a:extLst>
           </p:cNvPr>
@@ -10040,7 +10082,7 @@
           <p:cNvPr id="15" name="">
             <a:extLst xmlns:a="http://schemas.openxmlformats.org/drawingml/2006/main">
               <a:ext uri="{FF2B5EF4-FFF2-40B4-BE49-F238E27FC236}">
-                <a16:creationId xmlns:a16="http://schemas.microsoft.com/office/drawing/2014/main" id="{597DEBDC-8F07-43BF-B16B-9E065F59B3A4}"/>
+                <a16:creationId xmlns:a16="http://schemas.microsoft.com/office/drawing/2014/main" id="{39A0457C-064C-41F4-8B43-165C4E5A4208}"/>
               </a:ext>
             </a:extLst>
           </p:cNvPr>
@@ -10097,7 +10139,7 @@
           <p:cNvPr id="16" name="">
             <a:extLst xmlns:a="http://schemas.openxmlformats.org/drawingml/2006/main">
               <a:ext uri="{FF2B5EF4-FFF2-40B4-BE49-F238E27FC236}">
-                <a16:creationId xmlns:a16="http://schemas.microsoft.com/office/drawing/2014/main" id="{DA8BE6BB-B18F-4467-BE74-BD3851820D2F}"/>
+                <a16:creationId xmlns:a16="http://schemas.microsoft.com/office/drawing/2014/main" id="{58C21EBD-B6D7-4655-99AF-3497DD9B8534}"/>
               </a:ext>
             </a:extLst>
           </p:cNvPr>
@@ -10154,7 +10196,7 @@
           <p:cNvPr id="17" name="">
             <a:extLst xmlns:a="http://schemas.openxmlformats.org/drawingml/2006/main">
               <a:ext uri="{FF2B5EF4-FFF2-40B4-BE49-F238E27FC236}">
-                <a16:creationId xmlns:a16="http://schemas.microsoft.com/office/drawing/2014/main" id="{B9E46E4E-7B2B-43FD-BEEC-524AB23590DB}"/>
+                <a16:creationId xmlns:a16="http://schemas.microsoft.com/office/drawing/2014/main" id="{486A6719-C85E-4058-8F84-CA301C521B31}"/>
               </a:ext>
             </a:extLst>
           </p:cNvPr>
@@ -10211,7 +10253,7 @@
           <p:cNvPr id="18" name="">
             <a:extLst xmlns:a="http://schemas.openxmlformats.org/drawingml/2006/main">
               <a:ext uri="{FF2B5EF4-FFF2-40B4-BE49-F238E27FC236}">
-                <a16:creationId xmlns:a16="http://schemas.microsoft.com/office/drawing/2014/main" id="{9A1BB1E3-BEA9-4527-910C-BA9AA9DB0C1B}"/>
+                <a16:creationId xmlns:a16="http://schemas.microsoft.com/office/drawing/2014/main" id="{24AAD3DE-208A-4E22-BE74-450C08B2A331}"/>
               </a:ext>
             </a:extLst>
           </p:cNvPr>
@@ -10268,7 +10310,7 @@
           <p:cNvPr id="19" name="">
             <a:extLst xmlns:a="http://schemas.openxmlformats.org/drawingml/2006/main">
               <a:ext uri="{FF2B5EF4-FFF2-40B4-BE49-F238E27FC236}">
-                <a16:creationId xmlns:a16="http://schemas.microsoft.com/office/drawing/2014/main" id="{8F05F920-9BBC-4473-9331-CC58A6A4B534}"/>
+                <a16:creationId xmlns:a16="http://schemas.microsoft.com/office/drawing/2014/main" id="{F951BC33-6710-4B23-90CA-D9BB35831669}"/>
               </a:ext>
             </a:extLst>
           </p:cNvPr>
@@ -10323,7 +10365,7 @@
     </p:spTree>
     <p:extLst>
       <p:ext uri="{BB962C8B-B14F-4D97-AF65-F5344CB8AC3E}">
-        <p14:creationId xmlns:p14="http://schemas.microsoft.com/office/powerpoint/2010/main" val="1352653092"/>
+        <p14:creationId xmlns:p14="http://schemas.microsoft.com/office/powerpoint/2010/main" val="799477454"/>
       </p:ext>
     </p:extLst>
   </p:cSld>
@@ -10351,10 +10393,10 @@
       </p:grpSpPr>
       <p:sp>
         <p:nvSpPr>
-          <p:cNvPr id="15" name="">
-            <a:extLst xmlns:a="http://schemas.openxmlformats.org/drawingml/2006/main">
-              <a:ext uri="{FF2B5EF4-FFF2-40B4-BE49-F238E27FC236}">
-                <a16:creationId xmlns:a16="http://schemas.microsoft.com/office/drawing/2014/main" id="{A1DC6608-29F6-4360-8548-2B0EB78A8EC0}"/>
+          <p:cNvPr id="20" name="">
+            <a:extLst xmlns:a="http://schemas.openxmlformats.org/drawingml/2006/main">
+              <a:ext uri="{FF2B5EF4-FFF2-40B4-BE49-F238E27FC236}">
+                <a16:creationId xmlns:a16="http://schemas.microsoft.com/office/drawing/2014/main" id="{A3815BE1-D283-4FA5-85EE-D0224DB163CB}"/>
               </a:ext>
             </a:extLst>
           </p:cNvPr>
@@ -10411,7 +10453,7 @@
           <p:cNvPr id="2" name="">
             <a:extLst xmlns:a="http://schemas.openxmlformats.org/drawingml/2006/main">
               <a:ext uri="{FF2B5EF4-FFF2-40B4-BE49-F238E27FC236}">
-                <a16:creationId xmlns:a16="http://schemas.microsoft.com/office/drawing/2014/main" id="{9ACF41FF-7650-407E-B190-D0588A849DBD}"/>
+                <a16:creationId xmlns:a16="http://schemas.microsoft.com/office/drawing/2014/main" id="{0CBB2FBF-FA45-4FEB-8B9B-AEBEF94EDE3D}"/>
               </a:ext>
             </a:extLst>
           </p:cNvPr>
@@ -10458,7 +10500,7 @@
                 <a:ea typeface="Apple SD Gothic Neo"/>
                 <a:cs typeface="Apple SD Gothic Neo"/>
               </a:rPr>
-              <a:t>상품 URL과 구매 목적을 전달한 뒤, 확인·승인 중심의 대화로 배송대행 접수까지 진행했습니다.</a:t>
+              <a:t>상품 URL과 목적을 전달한 뒤 확인·승인 중심으로 진행했습니다. 아래 대화는 실제 기록을 축약했습니다.</a:t>
             </a:r>
           </a:p>
         </p:txBody>
@@ -10468,7 +10510,7 @@
           <p:cNvPr id="3" name="">
             <a:extLst xmlns:a="http://schemas.openxmlformats.org/drawingml/2006/main">
               <a:ext uri="{FF2B5EF4-FFF2-40B4-BE49-F238E27FC236}">
-                <a16:creationId xmlns:a16="http://schemas.microsoft.com/office/drawing/2014/main" id="{7A142107-0578-43E2-9A88-89D529892F36}"/>
+                <a16:creationId xmlns:a16="http://schemas.microsoft.com/office/drawing/2014/main" id="{CCFBBAA8-5608-494F-91EC-25A6912BF6A7}"/>
               </a:ext>
             </a:extLst>
           </p:cNvPr>
@@ -10525,19 +10567,19 @@
           <p:cNvPr id="4" name="">
             <a:extLst xmlns:a="http://schemas.openxmlformats.org/drawingml/2006/main">
               <a:ext uri="{FF2B5EF4-FFF2-40B4-BE49-F238E27FC236}">
-                <a16:creationId xmlns:a16="http://schemas.microsoft.com/office/drawing/2014/main" id="{777A047F-8F7E-4FD8-BF39-D841AF33E7E5}"/>
-              </a:ext>
-            </a:extLst>
-          </p:cNvPr>
-          <p:cNvSpPr>
-            <a:spLocks xmlns:a="http://schemas.openxmlformats.org/drawingml/2006/main" noGrp="1"/>
-          </p:cNvSpPr>
-          <p:nvPr/>
-        </p:nvSpPr>
-        <p:spPr>
-          <a:xfrm xmlns:a="http://schemas.openxmlformats.org/drawingml/2006/main">
-            <a:off x="819150" y="2571750"/>
-            <a:ext cx="13525500" cy="752475"/>
+                <a16:creationId xmlns:a16="http://schemas.microsoft.com/office/drawing/2014/main" id="{08B537D5-090F-4439-A6BB-537FF93394E3}"/>
+              </a:ext>
+            </a:extLst>
+          </p:cNvPr>
+          <p:cNvSpPr>
+            <a:spLocks xmlns:a="http://schemas.openxmlformats.org/drawingml/2006/main" noGrp="1"/>
+          </p:cNvSpPr>
+          <p:nvPr/>
+        </p:nvSpPr>
+        <p:spPr>
+          <a:xfrm xmlns:a="http://schemas.openxmlformats.org/drawingml/2006/main">
+            <a:off x="819150" y="2371725"/>
+            <a:ext cx="13525500" cy="666750"/>
           </a:xfrm>
           <a:prstGeom xmlns:a="http://schemas.openxmlformats.org/drawingml/2006/main" prst="rect">
             <a:avLst/>
@@ -10554,7 +10596,7 @@
           <a:lstStyle xmlns:a="http://schemas.openxmlformats.org/drawingml/2006/main"/>
           <a:p xmlns:a="http://schemas.openxmlformats.org/drawingml/2006/main">
             <a:pPr>
-              <a:defRPr sz="3975" b="1">
+              <a:defRPr sz="3675" b="1">
                 <a:solidFill>
                   <a:srgbClr val="156E58"/>
                 </a:solidFill>
@@ -10564,7 +10606,7 @@
               </a:defRPr>
             </a:pPr>
             <a:r>
-              <a:rPr sz="3975" b="1">
+              <a:rPr sz="3675" b="1">
                 <a:solidFill>
                   <a:srgbClr val="156E58"/>
                 </a:solidFill>
@@ -10582,19 +10624,19 @@
           <p:cNvPr id="5" name="">
             <a:extLst xmlns:a="http://schemas.openxmlformats.org/drawingml/2006/main">
               <a:ext uri="{FF2B5EF4-FFF2-40B4-BE49-F238E27FC236}">
-                <a16:creationId xmlns:a16="http://schemas.microsoft.com/office/drawing/2014/main" id="{05F4373F-050C-49A4-835F-F407F706C3F0}"/>
-              </a:ext>
-            </a:extLst>
-          </p:cNvPr>
-          <p:cNvSpPr>
-            <a:spLocks xmlns:a="http://schemas.openxmlformats.org/drawingml/2006/main" noGrp="1"/>
-          </p:cNvSpPr>
-          <p:nvPr/>
-        </p:nvSpPr>
-        <p:spPr>
-          <a:xfrm xmlns:a="http://schemas.openxmlformats.org/drawingml/2006/main">
-            <a:off x="819150" y="3705225"/>
-            <a:ext cx="6858000" cy="428625"/>
+                <a16:creationId xmlns:a16="http://schemas.microsoft.com/office/drawing/2014/main" id="{4F2D4D05-3F35-416C-B62C-64DC51197B18}"/>
+              </a:ext>
+            </a:extLst>
+          </p:cNvPr>
+          <p:cNvSpPr>
+            <a:spLocks xmlns:a="http://schemas.openxmlformats.org/drawingml/2006/main" noGrp="1"/>
+          </p:cNvSpPr>
+          <p:nvPr/>
+        </p:nvSpPr>
+        <p:spPr>
+          <a:xfrm xmlns:a="http://schemas.openxmlformats.org/drawingml/2006/main">
+            <a:off x="819150" y="3171825"/>
+            <a:ext cx="6191250" cy="323850"/>
           </a:xfrm>
           <a:prstGeom xmlns:a="http://schemas.openxmlformats.org/drawingml/2006/main" prst="rect">
             <a:avLst/>
@@ -10611,25 +10653,25 @@
           <a:lstStyle xmlns:a="http://schemas.openxmlformats.org/drawingml/2006/main"/>
           <a:p xmlns:a="http://schemas.openxmlformats.org/drawingml/2006/main">
             <a:pPr>
-              <a:defRPr sz="2250" b="1">
-                <a:solidFill>
-                  <a:srgbClr val="182C29"/>
-                </a:solidFill>
-                <a:latin typeface="Apple SD Gothic Neo"/>
-                <a:ea typeface="Apple SD Gothic Neo"/>
-                <a:cs typeface="Apple SD Gothic Neo"/>
-              </a:defRPr>
-            </a:pPr>
-            <a:r>
-              <a:rPr sz="2250" b="1">
-                <a:solidFill>
-                  <a:srgbClr val="182C29"/>
-                </a:solidFill>
-                <a:latin typeface="Apple SD Gothic Neo"/>
-                <a:ea typeface="Apple SD Gothic Neo"/>
-                <a:cs typeface="Apple SD Gothic Neo"/>
-              </a:rPr>
-              <a:t>후속 입력의 구성</a:t>
+              <a:defRPr sz="1950" b="1">
+                <a:solidFill>
+                  <a:srgbClr val="182C29"/>
+                </a:solidFill>
+                <a:latin typeface="Apple SD Gothic Neo"/>
+                <a:ea typeface="Apple SD Gothic Neo"/>
+                <a:cs typeface="Apple SD Gothic Neo"/>
+              </a:defRPr>
+            </a:pPr>
+            <a:r>
+              <a:rPr sz="1950" b="1">
+                <a:solidFill>
+                  <a:srgbClr val="182C29"/>
+                </a:solidFill>
+                <a:latin typeface="Apple SD Gothic Neo"/>
+                <a:ea typeface="Apple SD Gothic Neo"/>
+                <a:cs typeface="Apple SD Gothic Neo"/>
+              </a:rPr>
+              <a:t>나 · 입력 순서</a:t>
             </a:r>
           </a:p>
         </p:txBody>
@@ -10639,19 +10681,19 @@
           <p:cNvPr id="6" name="">
             <a:extLst xmlns:a="http://schemas.openxmlformats.org/drawingml/2006/main">
               <a:ext uri="{FF2B5EF4-FFF2-40B4-BE49-F238E27FC236}">
-                <a16:creationId xmlns:a16="http://schemas.microsoft.com/office/drawing/2014/main" id="{CE43CF40-8B64-4D4B-9C04-3BA57BAD08E2}"/>
-              </a:ext>
-            </a:extLst>
-          </p:cNvPr>
-          <p:cNvSpPr>
-            <a:spLocks xmlns:a="http://schemas.openxmlformats.org/drawingml/2006/main" noGrp="1"/>
-          </p:cNvSpPr>
-          <p:nvPr/>
-        </p:nvSpPr>
-        <p:spPr>
-          <a:xfrm xmlns:a="http://schemas.openxmlformats.org/drawingml/2006/main">
-            <a:off x="819150" y="4429125"/>
-            <a:ext cx="5238750" cy="409575"/>
+                <a16:creationId xmlns:a16="http://schemas.microsoft.com/office/drawing/2014/main" id="{E253919B-7F74-4BCA-A412-A242DE389DBE}"/>
+              </a:ext>
+            </a:extLst>
+          </p:cNvPr>
+          <p:cNvSpPr>
+            <a:spLocks xmlns:a="http://schemas.openxmlformats.org/drawingml/2006/main" noGrp="1"/>
+          </p:cNvSpPr>
+          <p:nvPr/>
+        </p:nvSpPr>
+        <p:spPr>
+          <a:xfrm xmlns:a="http://schemas.openxmlformats.org/drawingml/2006/main">
+            <a:off x="7858125" y="3171825"/>
+            <a:ext cx="6524625" cy="323850"/>
           </a:xfrm>
           <a:prstGeom xmlns:a="http://schemas.openxmlformats.org/drawingml/2006/main" prst="rect">
             <a:avLst/>
@@ -10668,25 +10710,25 @@
           <a:lstStyle xmlns:a="http://schemas.openxmlformats.org/drawingml/2006/main"/>
           <a:p xmlns:a="http://schemas.openxmlformats.org/drawingml/2006/main">
             <a:pPr>
-              <a:defRPr sz="2250" b="0">
-                <a:solidFill>
-                  <a:srgbClr val="182C29"/>
-                </a:solidFill>
-                <a:latin typeface="Apple SD Gothic Neo"/>
-                <a:ea typeface="Apple SD Gothic Neo"/>
-                <a:cs typeface="Apple SD Gothic Neo"/>
-              </a:defRPr>
-            </a:pPr>
-            <a:r>
-              <a:rPr sz="2250" b="0">
-                <a:solidFill>
-                  <a:srgbClr val="182C29"/>
-                </a:solidFill>
-                <a:latin typeface="Apple SD Gothic Neo"/>
-                <a:ea typeface="Apple SD Gothic Neo"/>
-                <a:cs typeface="Apple SD Gothic Neo"/>
-              </a:rPr>
-              <a:t>로그인 완료 알림</a:t>
+              <a:defRPr sz="1950" b="1">
+                <a:solidFill>
+                  <a:srgbClr val="182C29"/>
+                </a:solidFill>
+                <a:latin typeface="Apple SD Gothic Neo"/>
+                <a:ea typeface="Apple SD Gothic Neo"/>
+                <a:cs typeface="Apple SD Gothic Neo"/>
+              </a:defRPr>
+            </a:pPr>
+            <a:r>
+              <a:rPr sz="1950" b="1">
+                <a:solidFill>
+                  <a:srgbClr val="182C29"/>
+                </a:solidFill>
+                <a:latin typeface="Apple SD Gothic Neo"/>
+                <a:ea typeface="Apple SD Gothic Neo"/>
+                <a:cs typeface="Apple SD Gothic Neo"/>
+              </a:rPr>
+              <a:t>에이전트 · 안내와 처리 결과</a:t>
             </a:r>
           </a:p>
         </p:txBody>
@@ -10696,19 +10738,751 @@
           <p:cNvPr id="7" name="">
             <a:extLst xmlns:a="http://schemas.openxmlformats.org/drawingml/2006/main">
               <a:ext uri="{FF2B5EF4-FFF2-40B4-BE49-F238E27FC236}">
-                <a16:creationId xmlns:a16="http://schemas.microsoft.com/office/drawing/2014/main" id="{939BE806-E831-4895-8AF8-1706F3A7A242}"/>
-              </a:ext>
-            </a:extLst>
-          </p:cNvPr>
-          <p:cNvSpPr>
-            <a:spLocks xmlns:a="http://schemas.openxmlformats.org/drawingml/2006/main" noGrp="1"/>
-          </p:cNvSpPr>
-          <p:nvPr/>
-        </p:nvSpPr>
-        <p:spPr>
-          <a:xfrm xmlns:a="http://schemas.openxmlformats.org/drawingml/2006/main">
-            <a:off x="6381750" y="4429125"/>
-            <a:ext cx="1095375" cy="409575"/>
+                <a16:creationId xmlns:a16="http://schemas.microsoft.com/office/drawing/2014/main" id="{DF1FE83E-BF0C-4F13-991B-15B108233373}"/>
+              </a:ext>
+            </a:extLst>
+          </p:cNvPr>
+          <p:cNvSpPr>
+            <a:spLocks xmlns:a="http://schemas.openxmlformats.org/drawingml/2006/main" noGrp="1"/>
+          </p:cNvSpPr>
+          <p:nvPr/>
+        </p:nvSpPr>
+        <p:spPr>
+          <a:xfrm xmlns:a="http://schemas.openxmlformats.org/drawingml/2006/main">
+            <a:off x="819150" y="3600450"/>
+            <a:ext cx="6191250" cy="533400"/>
+          </a:xfrm>
+          <a:prstGeom xmlns:a="http://schemas.openxmlformats.org/drawingml/2006/main" prst="roundRect">
+            <a:avLst>
+              <a:gd name="adj" fmla="val 14286"/>
+            </a:avLst>
+          </a:prstGeom>
+          <a:solidFill xmlns:a="http://schemas.openxmlformats.org/drawingml/2006/main">
+            <a:srgbClr val="E7F0E9"/>
+          </a:solidFill>
+          <a:ln xmlns:a="http://schemas.openxmlformats.org/drawingml/2006/main" w="9525">
+            <a:solidFill>
+              <a:srgbClr val="BACBC1"/>
+            </a:solidFill>
+          </a:ln>
+        </p:spPr>
+        <p:txBody>
+          <a:bodyPr xmlns:a="http://schemas.openxmlformats.org/drawingml/2006/main" lIns="171450" tIns="76200" rIns="133350" bIns="76200" anchor="ctr"/>
+          <a:lstStyle xmlns:a="http://schemas.openxmlformats.org/drawingml/2006/main"/>
+          <a:p xmlns:a="http://schemas.openxmlformats.org/drawingml/2006/main">
+            <a:pPr>
+              <a:defRPr sz="1950">
+                <a:solidFill>
+                  <a:srgbClr val="182C29"/>
+                </a:solidFill>
+                <a:latin typeface="Apple SD Gothic Neo"/>
+                <a:ea typeface="Apple SD Gothic Neo"/>
+                <a:cs typeface="Apple SD Gothic Neo"/>
+              </a:defRPr>
+            </a:pPr>
+            <a:r>
+              <a:rPr sz="1950">
+                <a:solidFill>
+                  <a:srgbClr val="182C29"/>
+                </a:solidFill>
+                <a:latin typeface="Apple SD Gothic Neo"/>
+                <a:ea typeface="Apple SD Gothic Neo"/>
+                <a:cs typeface="Apple SD Gothic Neo"/>
+              </a:rPr>
+              <a:t>① URL + 구매·배송신청 요청</a:t>
+            </a:r>
+          </a:p>
+        </p:txBody>
+      </p:sp>
+      <p:sp>
+        <p:nvSpPr>
+          <p:cNvPr id="8" name="">
+            <a:extLst xmlns:a="http://schemas.openxmlformats.org/drawingml/2006/main">
+              <a:ext uri="{FF2B5EF4-FFF2-40B4-BE49-F238E27FC236}">
+                <a16:creationId xmlns:a16="http://schemas.microsoft.com/office/drawing/2014/main" id="{449F87A0-CA49-4593-B940-9F532FFCFBFC}"/>
+              </a:ext>
+            </a:extLst>
+          </p:cNvPr>
+          <p:cNvSpPr>
+            <a:spLocks xmlns:a="http://schemas.openxmlformats.org/drawingml/2006/main" noGrp="1"/>
+          </p:cNvSpPr>
+          <p:nvPr/>
+        </p:nvSpPr>
+        <p:spPr>
+          <a:xfrm xmlns:a="http://schemas.openxmlformats.org/drawingml/2006/main">
+            <a:off x="7858125" y="3600450"/>
+            <a:ext cx="6562725" cy="533400"/>
+          </a:xfrm>
+          <a:prstGeom xmlns:a="http://schemas.openxmlformats.org/drawingml/2006/main" prst="roundRect">
+            <a:avLst>
+              <a:gd name="adj" fmla="val 14286"/>
+            </a:avLst>
+          </a:prstGeom>
+          <a:solidFill xmlns:a="http://schemas.openxmlformats.org/drawingml/2006/main">
+            <a:srgbClr val="FFFFFF"/>
+          </a:solidFill>
+          <a:ln xmlns:a="http://schemas.openxmlformats.org/drawingml/2006/main" w="9525">
+            <a:solidFill>
+              <a:srgbClr val="BACBC1"/>
+            </a:solidFill>
+          </a:ln>
+        </p:spPr>
+        <p:txBody>
+          <a:bodyPr xmlns:a="http://schemas.openxmlformats.org/drawingml/2006/main" lIns="171450" tIns="76200" rIns="133350" bIns="76200" anchor="ctr"/>
+          <a:lstStyle xmlns:a="http://schemas.openxmlformats.org/drawingml/2006/main"/>
+          <a:p xmlns:a="http://schemas.openxmlformats.org/drawingml/2006/main">
+            <a:pPr>
+              <a:defRPr sz="1950">
+                <a:solidFill>
+                  <a:srgbClr val="182C29"/>
+                </a:solidFill>
+                <a:latin typeface="Apple SD Gothic Neo"/>
+                <a:ea typeface="Apple SD Gothic Neo"/>
+                <a:cs typeface="Apple SD Gothic Neo"/>
+              </a:defRPr>
+            </a:pPr>
+            <a:r>
+              <a:rPr sz="1950">
+                <a:solidFill>
+                  <a:srgbClr val="182C29"/>
+                </a:solidFill>
+                <a:latin typeface="Apple SD Gothic Neo"/>
+                <a:ea typeface="Apple SD Gothic Neo"/>
+                <a:cs typeface="Apple SD Gothic Neo"/>
+              </a:rPr>
+              <a:t>상품 확인 → 로그인 안내</a:t>
+            </a:r>
+          </a:p>
+        </p:txBody>
+      </p:sp>
+      <p:sp>
+        <p:nvSpPr>
+          <p:cNvPr id="9" name="">
+            <a:extLst xmlns:a="http://schemas.openxmlformats.org/drawingml/2006/main">
+              <a:ext uri="{FF2B5EF4-FFF2-40B4-BE49-F238E27FC236}">
+                <a16:creationId xmlns:a16="http://schemas.microsoft.com/office/drawing/2014/main" id="{6DCA3919-EF80-4ECC-9EE8-3F04DF62EE7B}"/>
+              </a:ext>
+            </a:extLst>
+          </p:cNvPr>
+          <p:cNvSpPr>
+            <a:spLocks xmlns:a="http://schemas.openxmlformats.org/drawingml/2006/main" noGrp="1"/>
+          </p:cNvSpPr>
+          <p:nvPr/>
+        </p:nvSpPr>
+        <p:spPr>
+          <a:xfrm xmlns:a="http://schemas.openxmlformats.org/drawingml/2006/main">
+            <a:off x="819150" y="4219575"/>
+            <a:ext cx="6191250" cy="533400"/>
+          </a:xfrm>
+          <a:prstGeom xmlns:a="http://schemas.openxmlformats.org/drawingml/2006/main" prst="roundRect">
+            <a:avLst>
+              <a:gd name="adj" fmla="val 14286"/>
+            </a:avLst>
+          </a:prstGeom>
+          <a:solidFill xmlns:a="http://schemas.openxmlformats.org/drawingml/2006/main">
+            <a:srgbClr val="E7F0E9"/>
+          </a:solidFill>
+          <a:ln xmlns:a="http://schemas.openxmlformats.org/drawingml/2006/main" w="9525">
+            <a:solidFill>
+              <a:srgbClr val="BACBC1"/>
+            </a:solidFill>
+          </a:ln>
+        </p:spPr>
+        <p:txBody>
+          <a:bodyPr xmlns:a="http://schemas.openxmlformats.org/drawingml/2006/main" lIns="171450" tIns="76200" rIns="133350" bIns="76200" anchor="ctr"/>
+          <a:lstStyle xmlns:a="http://schemas.openxmlformats.org/drawingml/2006/main"/>
+          <a:p xmlns:a="http://schemas.openxmlformats.org/drawingml/2006/main">
+            <a:pPr>
+              <a:defRPr sz="1950">
+                <a:solidFill>
+                  <a:srgbClr val="182C29"/>
+                </a:solidFill>
+                <a:latin typeface="Apple SD Gothic Neo"/>
+                <a:ea typeface="Apple SD Gothic Neo"/>
+                <a:cs typeface="Apple SD Gothic Neo"/>
+              </a:defRPr>
+            </a:pPr>
+            <a:r>
+              <a:rPr sz="1950">
+                <a:solidFill>
+                  <a:srgbClr val="182C29"/>
+                </a:solidFill>
+                <a:latin typeface="Apple SD Gothic Neo"/>
+                <a:ea typeface="Apple SD Gothic Neo"/>
+                <a:cs typeface="Apple SD Gothic Neo"/>
+              </a:rPr>
+              <a:t>②·③ 각 사이트 로그인 완료</a:t>
+            </a:r>
+          </a:p>
+        </p:txBody>
+      </p:sp>
+      <p:sp>
+        <p:nvSpPr>
+          <p:cNvPr id="10" name="">
+            <a:extLst xmlns:a="http://schemas.openxmlformats.org/drawingml/2006/main">
+              <a:ext uri="{FF2B5EF4-FFF2-40B4-BE49-F238E27FC236}">
+                <a16:creationId xmlns:a16="http://schemas.microsoft.com/office/drawing/2014/main" id="{4BF29A7A-4E5E-450E-A766-3ECF356C718E}"/>
+              </a:ext>
+            </a:extLst>
+          </p:cNvPr>
+          <p:cNvSpPr>
+            <a:spLocks xmlns:a="http://schemas.openxmlformats.org/drawingml/2006/main" noGrp="1"/>
+          </p:cNvSpPr>
+          <p:nvPr/>
+        </p:nvSpPr>
+        <p:spPr>
+          <a:xfrm xmlns:a="http://schemas.openxmlformats.org/drawingml/2006/main">
+            <a:off x="7858125" y="4219575"/>
+            <a:ext cx="6562725" cy="533400"/>
+          </a:xfrm>
+          <a:prstGeom xmlns:a="http://schemas.openxmlformats.org/drawingml/2006/main" prst="roundRect">
+            <a:avLst>
+              <a:gd name="adj" fmla="val 14286"/>
+            </a:avLst>
+          </a:prstGeom>
+          <a:solidFill xmlns:a="http://schemas.openxmlformats.org/drawingml/2006/main">
+            <a:srgbClr val="FFFFFF"/>
+          </a:solidFill>
+          <a:ln xmlns:a="http://schemas.openxmlformats.org/drawingml/2006/main" w="9525">
+            <a:solidFill>
+              <a:srgbClr val="BACBC1"/>
+            </a:solidFill>
+          </a:ln>
+        </p:spPr>
+        <p:txBody>
+          <a:bodyPr xmlns:a="http://schemas.openxmlformats.org/drawingml/2006/main" lIns="171450" tIns="76200" rIns="133350" bIns="76200" anchor="ctr"/>
+          <a:lstStyle xmlns:a="http://schemas.openxmlformats.org/drawingml/2006/main"/>
+          <a:p xmlns:a="http://schemas.openxmlformats.org/drawingml/2006/main">
+            <a:pPr>
+              <a:defRPr sz="1950">
+                <a:solidFill>
+                  <a:srgbClr val="182C29"/>
+                </a:solidFill>
+                <a:latin typeface="Apple SD Gothic Neo"/>
+                <a:ea typeface="Apple SD Gothic Neo"/>
+                <a:cs typeface="Apple SD Gothic Neo"/>
+              </a:defRPr>
+            </a:pPr>
+            <a:r>
+              <a:rPr sz="1950">
+                <a:solidFill>
+                  <a:srgbClr val="182C29"/>
+                </a:solidFill>
+                <a:latin typeface="Apple SD Gothic Neo"/>
+                <a:ea typeface="Apple SD Gothic Neo"/>
+                <a:cs typeface="Apple SD Gothic Neo"/>
+              </a:rPr>
+              <a:t>배송지 확인 → 정보 입력 승인 요청</a:t>
+            </a:r>
+          </a:p>
+        </p:txBody>
+      </p:sp>
+      <p:sp>
+        <p:nvSpPr>
+          <p:cNvPr id="11" name="">
+            <a:extLst xmlns:a="http://schemas.openxmlformats.org/drawingml/2006/main">
+              <a:ext uri="{FF2B5EF4-FFF2-40B4-BE49-F238E27FC236}">
+                <a16:creationId xmlns:a16="http://schemas.microsoft.com/office/drawing/2014/main" id="{258CA54B-4FE5-4C6A-A2B1-727FF4E6D282}"/>
+              </a:ext>
+            </a:extLst>
+          </p:cNvPr>
+          <p:cNvSpPr>
+            <a:spLocks xmlns:a="http://schemas.openxmlformats.org/drawingml/2006/main" noGrp="1"/>
+          </p:cNvSpPr>
+          <p:nvPr/>
+        </p:nvSpPr>
+        <p:spPr>
+          <a:xfrm xmlns:a="http://schemas.openxmlformats.org/drawingml/2006/main">
+            <a:off x="819150" y="4838700"/>
+            <a:ext cx="6191250" cy="533400"/>
+          </a:xfrm>
+          <a:prstGeom xmlns:a="http://schemas.openxmlformats.org/drawingml/2006/main" prst="roundRect">
+            <a:avLst>
+              <a:gd name="adj" fmla="val 14286"/>
+            </a:avLst>
+          </a:prstGeom>
+          <a:solidFill xmlns:a="http://schemas.openxmlformats.org/drawingml/2006/main">
+            <a:srgbClr val="E7F0E9"/>
+          </a:solidFill>
+          <a:ln xmlns:a="http://schemas.openxmlformats.org/drawingml/2006/main" w="9525">
+            <a:solidFill>
+              <a:srgbClr val="BACBC1"/>
+            </a:solidFill>
+          </a:ln>
+        </p:spPr>
+        <p:txBody>
+          <a:bodyPr xmlns:a="http://schemas.openxmlformats.org/drawingml/2006/main" lIns="171450" tIns="76200" rIns="133350" bIns="76200" anchor="ctr"/>
+          <a:lstStyle xmlns:a="http://schemas.openxmlformats.org/drawingml/2006/main"/>
+          <a:p xmlns:a="http://schemas.openxmlformats.org/drawingml/2006/main">
+            <a:pPr>
+              <a:defRPr sz="1950">
+                <a:solidFill>
+                  <a:srgbClr val="182C29"/>
+                </a:solidFill>
+                <a:latin typeface="Apple SD Gothic Neo"/>
+                <a:ea typeface="Apple SD Gothic Neo"/>
+                <a:cs typeface="Apple SD Gothic Neo"/>
+              </a:defRPr>
+            </a:pPr>
+            <a:r>
+              <a:rPr sz="1950">
+                <a:solidFill>
+                  <a:srgbClr val="182C29"/>
+                </a:solidFill>
+                <a:latin typeface="Apple SD Gothic Neo"/>
+                <a:ea typeface="Apple SD Gothic Neo"/>
+                <a:cs typeface="Apple SD Gothic Neo"/>
+              </a:rPr>
+              <a:t>④ 주소 입력 승인 + 무게 조건 보완</a:t>
+            </a:r>
+          </a:p>
+        </p:txBody>
+      </p:sp>
+      <p:sp>
+        <p:nvSpPr>
+          <p:cNvPr id="12" name="">
+            <a:extLst xmlns:a="http://schemas.openxmlformats.org/drawingml/2006/main">
+              <a:ext uri="{FF2B5EF4-FFF2-40B4-BE49-F238E27FC236}">
+                <a16:creationId xmlns:a16="http://schemas.microsoft.com/office/drawing/2014/main" id="{6703FE29-B042-42C1-8A37-0AA351D0D43E}"/>
+              </a:ext>
+            </a:extLst>
+          </p:cNvPr>
+          <p:cNvSpPr>
+            <a:spLocks xmlns:a="http://schemas.openxmlformats.org/drawingml/2006/main" noGrp="1"/>
+          </p:cNvSpPr>
+          <p:nvPr/>
+        </p:nvSpPr>
+        <p:spPr>
+          <a:xfrm xmlns:a="http://schemas.openxmlformats.org/drawingml/2006/main">
+            <a:off x="7858125" y="4838700"/>
+            <a:ext cx="6562725" cy="533400"/>
+          </a:xfrm>
+          <a:prstGeom xmlns:a="http://schemas.openxmlformats.org/drawingml/2006/main" prst="roundRect">
+            <a:avLst>
+              <a:gd name="adj" fmla="val 14286"/>
+            </a:avLst>
+          </a:prstGeom>
+          <a:solidFill xmlns:a="http://schemas.openxmlformats.org/drawingml/2006/main">
+            <a:srgbClr val="FFFFFF"/>
+          </a:solidFill>
+          <a:ln xmlns:a="http://schemas.openxmlformats.org/drawingml/2006/main" w="9525">
+            <a:solidFill>
+              <a:srgbClr val="BACBC1"/>
+            </a:solidFill>
+          </a:ln>
+        </p:spPr>
+        <p:txBody>
+          <a:bodyPr xmlns:a="http://schemas.openxmlformats.org/drawingml/2006/main" lIns="171450" tIns="76200" rIns="133350" bIns="76200" anchor="ctr"/>
+          <a:lstStyle xmlns:a="http://schemas.openxmlformats.org/drawingml/2006/main"/>
+          <a:p xmlns:a="http://schemas.openxmlformats.org/drawingml/2006/main">
+            <a:pPr>
+              <a:defRPr sz="1950">
+                <a:solidFill>
+                  <a:srgbClr val="182C29"/>
+                </a:solidFill>
+                <a:latin typeface="Apple SD Gothic Neo"/>
+                <a:ea typeface="Apple SD Gothic Neo"/>
+                <a:cs typeface="Apple SD Gothic Neo"/>
+              </a:defRPr>
+            </a:pPr>
+            <a:r>
+              <a:rPr sz="1950">
+                <a:solidFill>
+                  <a:srgbClr val="182C29"/>
+                </a:solidFill>
+                <a:latin typeface="Apple SD Gothic Neo"/>
+                <a:ea typeface="Apple SD Gothic Neo"/>
+                <a:cs typeface="Apple SD Gothic Neo"/>
+              </a:rPr>
+              <a:t>주소 입력·견적 비교 → 구매 확정 안내</a:t>
+            </a:r>
+          </a:p>
+        </p:txBody>
+      </p:sp>
+      <p:sp>
+        <p:nvSpPr>
+          <p:cNvPr id="13" name="">
+            <a:extLst xmlns:a="http://schemas.openxmlformats.org/drawingml/2006/main">
+              <a:ext uri="{FF2B5EF4-FFF2-40B4-BE49-F238E27FC236}">
+                <a16:creationId xmlns:a16="http://schemas.microsoft.com/office/drawing/2014/main" id="{E1C32957-A014-484B-BF7F-42D93636D5A0}"/>
+              </a:ext>
+            </a:extLst>
+          </p:cNvPr>
+          <p:cNvSpPr>
+            <a:spLocks xmlns:a="http://schemas.openxmlformats.org/drawingml/2006/main" noGrp="1"/>
+          </p:cNvSpPr>
+          <p:nvPr/>
+        </p:nvSpPr>
+        <p:spPr>
+          <a:xfrm xmlns:a="http://schemas.openxmlformats.org/drawingml/2006/main">
+            <a:off x="819150" y="5457825"/>
+            <a:ext cx="6191250" cy="533400"/>
+          </a:xfrm>
+          <a:prstGeom xmlns:a="http://schemas.openxmlformats.org/drawingml/2006/main" prst="roundRect">
+            <a:avLst>
+              <a:gd name="adj" fmla="val 14286"/>
+            </a:avLst>
+          </a:prstGeom>
+          <a:solidFill xmlns:a="http://schemas.openxmlformats.org/drawingml/2006/main">
+            <a:srgbClr val="E7F0E9"/>
+          </a:solidFill>
+          <a:ln xmlns:a="http://schemas.openxmlformats.org/drawingml/2006/main" w="9525">
+            <a:solidFill>
+              <a:srgbClr val="BACBC1"/>
+            </a:solidFill>
+          </a:ln>
+        </p:spPr>
+        <p:txBody>
+          <a:bodyPr xmlns:a="http://schemas.openxmlformats.org/drawingml/2006/main" lIns="171450" tIns="76200" rIns="133350" bIns="76200" anchor="ctr"/>
+          <a:lstStyle xmlns:a="http://schemas.openxmlformats.org/drawingml/2006/main"/>
+          <a:p xmlns:a="http://schemas.openxmlformats.org/drawingml/2006/main">
+            <a:pPr>
+              <a:defRPr sz="1950">
+                <a:solidFill>
+                  <a:srgbClr val="182C29"/>
+                </a:solidFill>
+                <a:latin typeface="Apple SD Gothic Neo"/>
+                <a:ea typeface="Apple SD Gothic Neo"/>
+                <a:cs typeface="Apple SD Gothic Neo"/>
+              </a:defRPr>
+            </a:pPr>
+            <a:r>
+              <a:rPr sz="1950">
+                <a:solidFill>
+                  <a:srgbClr val="182C29"/>
+                </a:solidFill>
+                <a:latin typeface="Apple SD Gothic Neo"/>
+                <a:ea typeface="Apple SD Gothic Neo"/>
+                <a:cs typeface="Apple SD Gothic Neo"/>
+              </a:rPr>
+              <a:t>⑤ 직접 구매 완료 알림</a:t>
+            </a:r>
+          </a:p>
+        </p:txBody>
+      </p:sp>
+      <p:sp>
+        <p:nvSpPr>
+          <p:cNvPr id="14" name="">
+            <a:extLst xmlns:a="http://schemas.openxmlformats.org/drawingml/2006/main">
+              <a:ext uri="{FF2B5EF4-FFF2-40B4-BE49-F238E27FC236}">
+                <a16:creationId xmlns:a16="http://schemas.microsoft.com/office/drawing/2014/main" id="{9044F2ED-9429-45FA-833F-9827C05CF22F}"/>
+              </a:ext>
+            </a:extLst>
+          </p:cNvPr>
+          <p:cNvSpPr>
+            <a:spLocks xmlns:a="http://schemas.openxmlformats.org/drawingml/2006/main" noGrp="1"/>
+          </p:cNvSpPr>
+          <p:nvPr/>
+        </p:nvSpPr>
+        <p:spPr>
+          <a:xfrm xmlns:a="http://schemas.openxmlformats.org/drawingml/2006/main">
+            <a:off x="7858125" y="5457825"/>
+            <a:ext cx="6562725" cy="533400"/>
+          </a:xfrm>
+          <a:prstGeom xmlns:a="http://schemas.openxmlformats.org/drawingml/2006/main" prst="roundRect">
+            <a:avLst>
+              <a:gd name="adj" fmla="val 14286"/>
+            </a:avLst>
+          </a:prstGeom>
+          <a:solidFill xmlns:a="http://schemas.openxmlformats.org/drawingml/2006/main">
+            <a:srgbClr val="FFFFFF"/>
+          </a:solidFill>
+          <a:ln xmlns:a="http://schemas.openxmlformats.org/drawingml/2006/main" w="9525">
+            <a:solidFill>
+              <a:srgbClr val="BACBC1"/>
+            </a:solidFill>
+          </a:ln>
+        </p:spPr>
+        <p:txBody>
+          <a:bodyPr xmlns:a="http://schemas.openxmlformats.org/drawingml/2006/main" lIns="171450" tIns="76200" rIns="133350" bIns="76200" anchor="ctr"/>
+          <a:lstStyle xmlns:a="http://schemas.openxmlformats.org/drawingml/2006/main"/>
+          <a:p xmlns:a="http://schemas.openxmlformats.org/drawingml/2006/main">
+            <a:pPr>
+              <a:defRPr sz="1950">
+                <a:solidFill>
+                  <a:srgbClr val="182C29"/>
+                </a:solidFill>
+                <a:latin typeface="Apple SD Gothic Neo"/>
+                <a:ea typeface="Apple SD Gothic Neo"/>
+                <a:cs typeface="Apple SD Gothic Neo"/>
+              </a:defRPr>
+            </a:pPr>
+            <a:r>
+              <a:rPr sz="1950">
+                <a:solidFill>
+                  <a:srgbClr val="182C29"/>
+                </a:solidFill>
+                <a:latin typeface="Apple SD Gothic Neo"/>
+                <a:ea typeface="Apple SD Gothic Neo"/>
+                <a:cs typeface="Apple SD Gothic Neo"/>
+              </a:rPr>
+              <a:t>주문 대조·신청서 작성 → 제출 확인</a:t>
+            </a:r>
+          </a:p>
+        </p:txBody>
+      </p:sp>
+      <p:sp>
+        <p:nvSpPr>
+          <p:cNvPr id="15" name="">
+            <a:extLst xmlns:a="http://schemas.openxmlformats.org/drawingml/2006/main">
+              <a:ext uri="{FF2B5EF4-FFF2-40B4-BE49-F238E27FC236}">
+                <a16:creationId xmlns:a16="http://schemas.microsoft.com/office/drawing/2014/main" id="{7D463F1E-7FFE-4869-8244-943EC2F9D35B}"/>
+              </a:ext>
+            </a:extLst>
+          </p:cNvPr>
+          <p:cNvSpPr>
+            <a:spLocks xmlns:a="http://schemas.openxmlformats.org/drawingml/2006/main" noGrp="1"/>
+          </p:cNvSpPr>
+          <p:nvPr/>
+        </p:nvSpPr>
+        <p:spPr>
+          <a:xfrm xmlns:a="http://schemas.openxmlformats.org/drawingml/2006/main">
+            <a:off x="819150" y="6076950"/>
+            <a:ext cx="6191250" cy="533400"/>
+          </a:xfrm>
+          <a:prstGeom xmlns:a="http://schemas.openxmlformats.org/drawingml/2006/main" prst="roundRect">
+            <a:avLst>
+              <a:gd name="adj" fmla="val 14286"/>
+            </a:avLst>
+          </a:prstGeom>
+          <a:solidFill xmlns:a="http://schemas.openxmlformats.org/drawingml/2006/main">
+            <a:srgbClr val="E7F0E9"/>
+          </a:solidFill>
+          <a:ln xmlns:a="http://schemas.openxmlformats.org/drawingml/2006/main" w="9525">
+            <a:solidFill>
+              <a:srgbClr val="BACBC1"/>
+            </a:solidFill>
+          </a:ln>
+        </p:spPr>
+        <p:txBody>
+          <a:bodyPr xmlns:a="http://schemas.openxmlformats.org/drawingml/2006/main" lIns="171450" tIns="76200" rIns="133350" bIns="76200" anchor="ctr"/>
+          <a:lstStyle xmlns:a="http://schemas.openxmlformats.org/drawingml/2006/main"/>
+          <a:p xmlns:a="http://schemas.openxmlformats.org/drawingml/2006/main">
+            <a:pPr>
+              <a:defRPr sz="1950">
+                <a:solidFill>
+                  <a:srgbClr val="182C29"/>
+                </a:solidFill>
+                <a:latin typeface="Apple SD Gothic Neo"/>
+                <a:ea typeface="Apple SD Gothic Neo"/>
+                <a:cs typeface="Apple SD Gothic Neo"/>
+              </a:defRPr>
+            </a:pPr>
+            <a:r>
+              <a:rPr sz="1950">
+                <a:solidFill>
+                  <a:srgbClr val="182C29"/>
+                </a:solidFill>
+                <a:latin typeface="Apple SD Gothic Neo"/>
+                <a:ea typeface="Apple SD Gothic Neo"/>
+                <a:cs typeface="Apple SD Gothic Neo"/>
+              </a:rPr>
+              <a:t>⑥ 제출 진행 승인</a:t>
+            </a:r>
+          </a:p>
+        </p:txBody>
+      </p:sp>
+      <p:sp>
+        <p:nvSpPr>
+          <p:cNvPr id="16" name="">
+            <a:extLst xmlns:a="http://schemas.openxmlformats.org/drawingml/2006/main">
+              <a:ext uri="{FF2B5EF4-FFF2-40B4-BE49-F238E27FC236}">
+                <a16:creationId xmlns:a16="http://schemas.microsoft.com/office/drawing/2014/main" id="{6FF7B044-74D0-440F-9CF4-ABBF5AFE8639}"/>
+              </a:ext>
+            </a:extLst>
+          </p:cNvPr>
+          <p:cNvSpPr>
+            <a:spLocks xmlns:a="http://schemas.openxmlformats.org/drawingml/2006/main" noGrp="1"/>
+          </p:cNvSpPr>
+          <p:nvPr/>
+        </p:nvSpPr>
+        <p:spPr>
+          <a:xfrm xmlns:a="http://schemas.openxmlformats.org/drawingml/2006/main">
+            <a:off x="7858125" y="6076950"/>
+            <a:ext cx="6562725" cy="533400"/>
+          </a:xfrm>
+          <a:prstGeom xmlns:a="http://schemas.openxmlformats.org/drawingml/2006/main" prst="roundRect">
+            <a:avLst>
+              <a:gd name="adj" fmla="val 14286"/>
+            </a:avLst>
+          </a:prstGeom>
+          <a:solidFill xmlns:a="http://schemas.openxmlformats.org/drawingml/2006/main">
+            <a:srgbClr val="FFFFFF"/>
+          </a:solidFill>
+          <a:ln xmlns:a="http://schemas.openxmlformats.org/drawingml/2006/main" w="9525">
+            <a:solidFill>
+              <a:srgbClr val="BACBC1"/>
+            </a:solidFill>
+          </a:ln>
+        </p:spPr>
+        <p:txBody>
+          <a:bodyPr xmlns:a="http://schemas.openxmlformats.org/drawingml/2006/main" lIns="171450" tIns="76200" rIns="133350" bIns="76200" anchor="ctr"/>
+          <a:lstStyle xmlns:a="http://schemas.openxmlformats.org/drawingml/2006/main"/>
+          <a:p xmlns:a="http://schemas.openxmlformats.org/drawingml/2006/main">
+            <a:pPr>
+              <a:defRPr sz="1950">
+                <a:solidFill>
+                  <a:srgbClr val="182C29"/>
+                </a:solidFill>
+                <a:latin typeface="Apple SD Gothic Neo"/>
+                <a:ea typeface="Apple SD Gothic Neo"/>
+                <a:cs typeface="Apple SD Gothic Neo"/>
+              </a:defRPr>
+            </a:pPr>
+            <a:r>
+              <a:rPr sz="1950">
+                <a:solidFill>
+                  <a:srgbClr val="182C29"/>
+                </a:solidFill>
+                <a:latin typeface="Apple SD Gothic Neo"/>
+                <a:ea typeface="Apple SD Gothic Neo"/>
+                <a:cs typeface="Apple SD Gothic Neo"/>
+              </a:rPr>
+              <a:t>제출 시도 → 통관 인증 안내</a:t>
+            </a:r>
+          </a:p>
+        </p:txBody>
+      </p:sp>
+      <p:sp>
+        <p:nvSpPr>
+          <p:cNvPr id="17" name="">
+            <a:extLst xmlns:a="http://schemas.openxmlformats.org/drawingml/2006/main">
+              <a:ext uri="{FF2B5EF4-FFF2-40B4-BE49-F238E27FC236}">
+                <a16:creationId xmlns:a16="http://schemas.microsoft.com/office/drawing/2014/main" id="{BAA57B47-FCF4-4CF1-9849-C9216973A38D}"/>
+              </a:ext>
+            </a:extLst>
+          </p:cNvPr>
+          <p:cNvSpPr>
+            <a:spLocks xmlns:a="http://schemas.openxmlformats.org/drawingml/2006/main" noGrp="1"/>
+          </p:cNvSpPr>
+          <p:nvPr/>
+        </p:nvSpPr>
+        <p:spPr>
+          <a:xfrm xmlns:a="http://schemas.openxmlformats.org/drawingml/2006/main">
+            <a:off x="819150" y="6696075"/>
+            <a:ext cx="6191250" cy="533400"/>
+          </a:xfrm>
+          <a:prstGeom xmlns:a="http://schemas.openxmlformats.org/drawingml/2006/main" prst="roundRect">
+            <a:avLst>
+              <a:gd name="adj" fmla="val 14286"/>
+            </a:avLst>
+          </a:prstGeom>
+          <a:solidFill xmlns:a="http://schemas.openxmlformats.org/drawingml/2006/main">
+            <a:srgbClr val="E7F0E9"/>
+          </a:solidFill>
+          <a:ln xmlns:a="http://schemas.openxmlformats.org/drawingml/2006/main" w="9525">
+            <a:solidFill>
+              <a:srgbClr val="BACBC1"/>
+            </a:solidFill>
+          </a:ln>
+        </p:spPr>
+        <p:txBody>
+          <a:bodyPr xmlns:a="http://schemas.openxmlformats.org/drawingml/2006/main" lIns="171450" tIns="76200" rIns="133350" bIns="76200" anchor="ctr"/>
+          <a:lstStyle xmlns:a="http://schemas.openxmlformats.org/drawingml/2006/main"/>
+          <a:p xmlns:a="http://schemas.openxmlformats.org/drawingml/2006/main">
+            <a:pPr>
+              <a:defRPr sz="1950">
+                <a:solidFill>
+                  <a:srgbClr val="182C29"/>
+                </a:solidFill>
+                <a:latin typeface="Apple SD Gothic Neo"/>
+                <a:ea typeface="Apple SD Gothic Neo"/>
+                <a:cs typeface="Apple SD Gothic Neo"/>
+              </a:defRPr>
+            </a:pPr>
+            <a:r>
+              <a:rPr sz="1950">
+                <a:solidFill>
+                  <a:srgbClr val="182C29"/>
+                </a:solidFill>
+                <a:latin typeface="Apple SD Gothic Neo"/>
+                <a:ea typeface="Apple SD Gothic Neo"/>
+                <a:cs typeface="Apple SD Gothic Neo"/>
+              </a:rPr>
+              <a:t>⑦ 인증 완료 알림</a:t>
+            </a:r>
+          </a:p>
+        </p:txBody>
+      </p:sp>
+      <p:sp>
+        <p:nvSpPr>
+          <p:cNvPr id="18" name="">
+            <a:extLst xmlns:a="http://schemas.openxmlformats.org/drawingml/2006/main">
+              <a:ext uri="{FF2B5EF4-FFF2-40B4-BE49-F238E27FC236}">
+                <a16:creationId xmlns:a16="http://schemas.microsoft.com/office/drawing/2014/main" id="{2F6799A4-6D49-4CF6-BE8B-71DA9190A10D}"/>
+              </a:ext>
+            </a:extLst>
+          </p:cNvPr>
+          <p:cNvSpPr>
+            <a:spLocks xmlns:a="http://schemas.openxmlformats.org/drawingml/2006/main" noGrp="1"/>
+          </p:cNvSpPr>
+          <p:nvPr/>
+        </p:nvSpPr>
+        <p:spPr>
+          <a:xfrm xmlns:a="http://schemas.openxmlformats.org/drawingml/2006/main">
+            <a:off x="7858125" y="6696075"/>
+            <a:ext cx="6562725" cy="533400"/>
+          </a:xfrm>
+          <a:prstGeom xmlns:a="http://schemas.openxmlformats.org/drawingml/2006/main" prst="roundRect">
+            <a:avLst>
+              <a:gd name="adj" fmla="val 14286"/>
+            </a:avLst>
+          </a:prstGeom>
+          <a:solidFill xmlns:a="http://schemas.openxmlformats.org/drawingml/2006/main">
+            <a:srgbClr val="FFFFFF"/>
+          </a:solidFill>
+          <a:ln xmlns:a="http://schemas.openxmlformats.org/drawingml/2006/main" w="9525">
+            <a:solidFill>
+              <a:srgbClr val="BACBC1"/>
+            </a:solidFill>
+          </a:ln>
+        </p:spPr>
+        <p:txBody>
+          <a:bodyPr xmlns:a="http://schemas.openxmlformats.org/drawingml/2006/main" lIns="171450" tIns="76200" rIns="133350" bIns="76200" anchor="ctr"/>
+          <a:lstStyle xmlns:a="http://schemas.openxmlformats.org/drawingml/2006/main"/>
+          <a:p xmlns:a="http://schemas.openxmlformats.org/drawingml/2006/main">
+            <a:pPr>
+              <a:defRPr sz="1950">
+                <a:solidFill>
+                  <a:srgbClr val="182C29"/>
+                </a:solidFill>
+                <a:latin typeface="Apple SD Gothic Neo"/>
+                <a:ea typeface="Apple SD Gothic Neo"/>
+                <a:cs typeface="Apple SD Gothic Neo"/>
+              </a:defRPr>
+            </a:pPr>
+            <a:r>
+              <a:rPr sz="1950">
+                <a:solidFill>
+                  <a:srgbClr val="182C29"/>
+                </a:solidFill>
+                <a:latin typeface="Apple SD Gothic Neo"/>
+                <a:ea typeface="Apple SD Gothic Neo"/>
+                <a:cs typeface="Apple SD Gothic Neo"/>
+              </a:rPr>
+              <a:t>동일 신청서 제출 → 접수 완료 확인</a:t>
+            </a:r>
+          </a:p>
+        </p:txBody>
+      </p:sp>
+      <p:sp>
+        <p:nvSpPr>
+          <p:cNvPr id="19" name="">
+            <a:extLst xmlns:a="http://schemas.openxmlformats.org/drawingml/2006/main">
+              <a:ext uri="{FF2B5EF4-FFF2-40B4-BE49-F238E27FC236}">
+                <a16:creationId xmlns:a16="http://schemas.microsoft.com/office/drawing/2014/main" id="{23155AFE-A472-4056-8AE3-C8D64678BE8C}"/>
+              </a:ext>
+            </a:extLst>
+          </p:cNvPr>
+          <p:cNvSpPr>
+            <a:spLocks xmlns:a="http://schemas.openxmlformats.org/drawingml/2006/main" noGrp="1"/>
+          </p:cNvSpPr>
+          <p:nvPr/>
+        </p:nvSpPr>
+        <p:spPr>
+          <a:xfrm xmlns:a="http://schemas.openxmlformats.org/drawingml/2006/main">
+            <a:off x="819150" y="7572375"/>
+            <a:ext cx="13525500" cy="323850"/>
           </a:xfrm>
           <a:prstGeom xmlns:a="http://schemas.openxmlformats.org/drawingml/2006/main" prst="rect">
             <a:avLst/>
@@ -10725,371 +11499,7 @@
           <a:lstStyle xmlns:a="http://schemas.openxmlformats.org/drawingml/2006/main"/>
           <a:p xmlns:a="http://schemas.openxmlformats.org/drawingml/2006/main">
             <a:pPr>
-              <a:defRPr sz="2475" b="1">
-                <a:solidFill>
-                  <a:srgbClr val="182C29"/>
-                </a:solidFill>
-                <a:latin typeface="Apple SD Gothic Neo"/>
-                <a:ea typeface="Apple SD Gothic Neo"/>
-                <a:cs typeface="Apple SD Gothic Neo"/>
-              </a:defRPr>
-            </a:pPr>
-            <a:r>
-              <a:rPr sz="2475" b="1">
-                <a:solidFill>
-                  <a:srgbClr val="182C29"/>
-                </a:solidFill>
-                <a:latin typeface="Apple SD Gothic Neo"/>
-                <a:ea typeface="Apple SD Gothic Neo"/>
-                <a:cs typeface="Apple SD Gothic Neo"/>
-              </a:rPr>
-              <a:t>2회</a:t>
-            </a:r>
-          </a:p>
-        </p:txBody>
-      </p:sp>
-      <p:sp>
-        <p:nvSpPr>
-          <p:cNvPr id="8" name="">
-            <a:extLst xmlns:a="http://schemas.openxmlformats.org/drawingml/2006/main">
-              <a:ext uri="{FF2B5EF4-FFF2-40B4-BE49-F238E27FC236}">
-                <a16:creationId xmlns:a16="http://schemas.microsoft.com/office/drawing/2014/main" id="{6C0010F7-6940-43F4-919D-4E919E64B258}"/>
-              </a:ext>
-            </a:extLst>
-          </p:cNvPr>
-          <p:cNvSpPr>
-            <a:spLocks xmlns:a="http://schemas.openxmlformats.org/drawingml/2006/main" noGrp="1"/>
-          </p:cNvSpPr>
-          <p:nvPr/>
-        </p:nvSpPr>
-        <p:spPr>
-          <a:xfrm xmlns:a="http://schemas.openxmlformats.org/drawingml/2006/main">
-            <a:off x="819150" y="5038725"/>
-            <a:ext cx="5238750" cy="409575"/>
-          </a:xfrm>
-          <a:prstGeom xmlns:a="http://schemas.openxmlformats.org/drawingml/2006/main" prst="rect">
-            <a:avLst/>
-          </a:prstGeom>
-          <a:noFill xmlns:a="http://schemas.openxmlformats.org/drawingml/2006/main"/>
-          <a:ln xmlns:a="http://schemas.openxmlformats.org/drawingml/2006/main" w="0">
-            <a:noFill/>
-          </a:ln>
-        </p:spPr>
-        <p:txBody>
-          <a:bodyPr xmlns:a="http://schemas.openxmlformats.org/drawingml/2006/main" wrap="square" lIns="0" tIns="0" rIns="0" bIns="0">
-            <a:noAutofit/>
-          </a:bodyPr>
-          <a:lstStyle xmlns:a="http://schemas.openxmlformats.org/drawingml/2006/main"/>
-          <a:p xmlns:a="http://schemas.openxmlformats.org/drawingml/2006/main">
-            <a:pPr>
-              <a:defRPr sz="2250" b="0">
-                <a:solidFill>
-                  <a:srgbClr val="182C29"/>
-                </a:solidFill>
-                <a:latin typeface="Apple SD Gothic Neo"/>
-                <a:ea typeface="Apple SD Gothic Neo"/>
-                <a:cs typeface="Apple SD Gothic Neo"/>
-              </a:defRPr>
-            </a:pPr>
-            <a:r>
-              <a:rPr sz="2250" b="0">
-                <a:solidFill>
-                  <a:srgbClr val="182C29"/>
-                </a:solidFill>
-                <a:latin typeface="Apple SD Gothic Neo"/>
-                <a:ea typeface="Apple SD Gothic Neo"/>
-                <a:cs typeface="Apple SD Gothic Neo"/>
-              </a:rPr>
-              <a:t>입력·제출 승인</a:t>
-            </a:r>
-          </a:p>
-        </p:txBody>
-      </p:sp>
-      <p:sp>
-        <p:nvSpPr>
-          <p:cNvPr id="9" name="">
-            <a:extLst xmlns:a="http://schemas.openxmlformats.org/drawingml/2006/main">
-              <a:ext uri="{FF2B5EF4-FFF2-40B4-BE49-F238E27FC236}">
-                <a16:creationId xmlns:a16="http://schemas.microsoft.com/office/drawing/2014/main" id="{64AD563D-1331-40BF-8BA9-CA67801C6E7D}"/>
-              </a:ext>
-            </a:extLst>
-          </p:cNvPr>
-          <p:cNvSpPr>
-            <a:spLocks xmlns:a="http://schemas.openxmlformats.org/drawingml/2006/main" noGrp="1"/>
-          </p:cNvSpPr>
-          <p:nvPr/>
-        </p:nvSpPr>
-        <p:spPr>
-          <a:xfrm xmlns:a="http://schemas.openxmlformats.org/drawingml/2006/main">
-            <a:off x="6381750" y="5038725"/>
-            <a:ext cx="1095375" cy="409575"/>
-          </a:xfrm>
-          <a:prstGeom xmlns:a="http://schemas.openxmlformats.org/drawingml/2006/main" prst="rect">
-            <a:avLst/>
-          </a:prstGeom>
-          <a:noFill xmlns:a="http://schemas.openxmlformats.org/drawingml/2006/main"/>
-          <a:ln xmlns:a="http://schemas.openxmlformats.org/drawingml/2006/main" w="0">
-            <a:noFill/>
-          </a:ln>
-        </p:spPr>
-        <p:txBody>
-          <a:bodyPr xmlns:a="http://schemas.openxmlformats.org/drawingml/2006/main" wrap="square" lIns="0" tIns="0" rIns="0" bIns="0">
-            <a:noAutofit/>
-          </a:bodyPr>
-          <a:lstStyle xmlns:a="http://schemas.openxmlformats.org/drawingml/2006/main"/>
-          <a:p xmlns:a="http://schemas.openxmlformats.org/drawingml/2006/main">
-            <a:pPr>
-              <a:defRPr sz="2475" b="1">
-                <a:solidFill>
-                  <a:srgbClr val="182C29"/>
-                </a:solidFill>
-                <a:latin typeface="Apple SD Gothic Neo"/>
-                <a:ea typeface="Apple SD Gothic Neo"/>
-                <a:cs typeface="Apple SD Gothic Neo"/>
-              </a:defRPr>
-            </a:pPr>
-            <a:r>
-              <a:rPr sz="2475" b="1">
-                <a:solidFill>
-                  <a:srgbClr val="182C29"/>
-                </a:solidFill>
-                <a:latin typeface="Apple SD Gothic Neo"/>
-                <a:ea typeface="Apple SD Gothic Neo"/>
-                <a:cs typeface="Apple SD Gothic Neo"/>
-              </a:rPr>
-              <a:t>2회</a:t>
-            </a:r>
-          </a:p>
-        </p:txBody>
-      </p:sp>
-      <p:sp>
-        <p:nvSpPr>
-          <p:cNvPr id="10" name="">
-            <a:extLst xmlns:a="http://schemas.openxmlformats.org/drawingml/2006/main">
-              <a:ext uri="{FF2B5EF4-FFF2-40B4-BE49-F238E27FC236}">
-                <a16:creationId xmlns:a16="http://schemas.microsoft.com/office/drawing/2014/main" id="{795FFC9D-86E3-4DC9-AF7B-ECEA13C977C2}"/>
-              </a:ext>
-            </a:extLst>
-          </p:cNvPr>
-          <p:cNvSpPr>
-            <a:spLocks xmlns:a="http://schemas.openxmlformats.org/drawingml/2006/main" noGrp="1"/>
-          </p:cNvSpPr>
-          <p:nvPr/>
-        </p:nvSpPr>
-        <p:spPr>
-          <a:xfrm xmlns:a="http://schemas.openxmlformats.org/drawingml/2006/main">
-            <a:off x="819150" y="5648325"/>
-            <a:ext cx="5238750" cy="409575"/>
-          </a:xfrm>
-          <a:prstGeom xmlns:a="http://schemas.openxmlformats.org/drawingml/2006/main" prst="rect">
-            <a:avLst/>
-          </a:prstGeom>
-          <a:noFill xmlns:a="http://schemas.openxmlformats.org/drawingml/2006/main"/>
-          <a:ln xmlns:a="http://schemas.openxmlformats.org/drawingml/2006/main" w="0">
-            <a:noFill/>
-          </a:ln>
-        </p:spPr>
-        <p:txBody>
-          <a:bodyPr xmlns:a="http://schemas.openxmlformats.org/drawingml/2006/main" wrap="square" lIns="0" tIns="0" rIns="0" bIns="0">
-            <a:noAutofit/>
-          </a:bodyPr>
-          <a:lstStyle xmlns:a="http://schemas.openxmlformats.org/drawingml/2006/main"/>
-          <a:p xmlns:a="http://schemas.openxmlformats.org/drawingml/2006/main">
-            <a:pPr>
-              <a:defRPr sz="2250" b="0">
-                <a:solidFill>
-                  <a:srgbClr val="182C29"/>
-                </a:solidFill>
-                <a:latin typeface="Apple SD Gothic Neo"/>
-                <a:ea typeface="Apple SD Gothic Neo"/>
-                <a:cs typeface="Apple SD Gothic Neo"/>
-              </a:defRPr>
-            </a:pPr>
-            <a:r>
-              <a:rPr sz="2250" b="0">
-                <a:solidFill>
-                  <a:srgbClr val="182C29"/>
-                </a:solidFill>
-                <a:latin typeface="Apple SD Gothic Neo"/>
-                <a:ea typeface="Apple SD Gothic Neo"/>
-                <a:cs typeface="Apple SD Gothic Neo"/>
-              </a:rPr>
-              <a:t>구매·인증 완료 알림</a:t>
-            </a:r>
-          </a:p>
-        </p:txBody>
-      </p:sp>
-      <p:sp>
-        <p:nvSpPr>
-          <p:cNvPr id="11" name="">
-            <a:extLst xmlns:a="http://schemas.openxmlformats.org/drawingml/2006/main">
-              <a:ext uri="{FF2B5EF4-FFF2-40B4-BE49-F238E27FC236}">
-                <a16:creationId xmlns:a16="http://schemas.microsoft.com/office/drawing/2014/main" id="{6AA0F6B7-791D-4C51-B920-75730FB7394B}"/>
-              </a:ext>
-            </a:extLst>
-          </p:cNvPr>
-          <p:cNvSpPr>
-            <a:spLocks xmlns:a="http://schemas.openxmlformats.org/drawingml/2006/main" noGrp="1"/>
-          </p:cNvSpPr>
-          <p:nvPr/>
-        </p:nvSpPr>
-        <p:spPr>
-          <a:xfrm xmlns:a="http://schemas.openxmlformats.org/drawingml/2006/main">
-            <a:off x="6381750" y="5648325"/>
-            <a:ext cx="1095375" cy="409575"/>
-          </a:xfrm>
-          <a:prstGeom xmlns:a="http://schemas.openxmlformats.org/drawingml/2006/main" prst="rect">
-            <a:avLst/>
-          </a:prstGeom>
-          <a:noFill xmlns:a="http://schemas.openxmlformats.org/drawingml/2006/main"/>
-          <a:ln xmlns:a="http://schemas.openxmlformats.org/drawingml/2006/main" w="0">
-            <a:noFill/>
-          </a:ln>
-        </p:spPr>
-        <p:txBody>
-          <a:bodyPr xmlns:a="http://schemas.openxmlformats.org/drawingml/2006/main" wrap="square" lIns="0" tIns="0" rIns="0" bIns="0">
-            <a:noAutofit/>
-          </a:bodyPr>
-          <a:lstStyle xmlns:a="http://schemas.openxmlformats.org/drawingml/2006/main"/>
-          <a:p xmlns:a="http://schemas.openxmlformats.org/drawingml/2006/main">
-            <a:pPr>
-              <a:defRPr sz="2475" b="1">
-                <a:solidFill>
-                  <a:srgbClr val="182C29"/>
-                </a:solidFill>
-                <a:latin typeface="Apple SD Gothic Neo"/>
-                <a:ea typeface="Apple SD Gothic Neo"/>
-                <a:cs typeface="Apple SD Gothic Neo"/>
-              </a:defRPr>
-            </a:pPr>
-            <a:r>
-              <a:rPr sz="2475" b="1">
-                <a:solidFill>
-                  <a:srgbClr val="182C29"/>
-                </a:solidFill>
-                <a:latin typeface="Apple SD Gothic Neo"/>
-                <a:ea typeface="Apple SD Gothic Neo"/>
-                <a:cs typeface="Apple SD Gothic Neo"/>
-              </a:rPr>
-              <a:t>2회</a:t>
-            </a:r>
-          </a:p>
-        </p:txBody>
-      </p:sp>
-      <p:pic>
-        <p:nvPicPr>
-          <p:cNvPr id="26" name=""/>
-          <p:cNvPicPr>
-            <a:picLocks xmlns:a="http://schemas.openxmlformats.org/drawingml/2006/main" noChangeAspect="1"/>
-          </p:cNvPicPr>
-          <p:nvPr/>
-        </p:nvPicPr>
-        <p:blipFill>
-          <a:blip xmlns:r="http://schemas.openxmlformats.org/officeDocument/2006/relationships" xmlns:a="http://schemas.openxmlformats.org/drawingml/2006/main" r:embed="Re63828790903424e"/>
-          <a:stretch xmlns:a="http://schemas.openxmlformats.org/drawingml/2006/main"/>
-        </p:blipFill>
-        <p:spPr>
-          <a:xfrm xmlns:a="http://schemas.openxmlformats.org/drawingml/2006/main">
-            <a:off x="9636125" y="3667125"/>
-            <a:ext cx="3835400" cy="3048000"/>
-          </a:xfrm>
-          <a:prstGeom xmlns:a="http://schemas.openxmlformats.org/drawingml/2006/main" prst="rect">
-            <a:avLst/>
-          </a:prstGeom>
-        </p:spPr>
-      </p:pic>
-      <p:sp>
-        <p:nvSpPr>
-          <p:cNvPr id="13" name="">
-            <a:extLst xmlns:a="http://schemas.openxmlformats.org/drawingml/2006/main">
-              <a:ext uri="{FF2B5EF4-FFF2-40B4-BE49-F238E27FC236}">
-                <a16:creationId xmlns:a16="http://schemas.microsoft.com/office/drawing/2014/main" id="{60DD0BFC-E55A-484E-B213-DFA6E543A884}"/>
-              </a:ext>
-            </a:extLst>
-          </p:cNvPr>
-          <p:cNvSpPr>
-            <a:spLocks xmlns:a="http://schemas.openxmlformats.org/drawingml/2006/main" noGrp="1"/>
-          </p:cNvSpPr>
-          <p:nvPr/>
-        </p:nvSpPr>
-        <p:spPr>
-          <a:xfrm xmlns:a="http://schemas.openxmlformats.org/drawingml/2006/main">
-            <a:off x="819150" y="6819900"/>
-            <a:ext cx="13525500" cy="561975"/>
-          </a:xfrm>
-          <a:prstGeom xmlns:a="http://schemas.openxmlformats.org/drawingml/2006/main" prst="rect">
-            <a:avLst/>
-          </a:prstGeom>
-          <a:noFill xmlns:a="http://schemas.openxmlformats.org/drawingml/2006/main"/>
-          <a:ln xmlns:a="http://schemas.openxmlformats.org/drawingml/2006/main" w="0">
-            <a:noFill/>
-          </a:ln>
-        </p:spPr>
-        <p:txBody>
-          <a:bodyPr xmlns:a="http://schemas.openxmlformats.org/drawingml/2006/main" wrap="square" lIns="0" tIns="0" rIns="0" bIns="0">
-            <a:noAutofit/>
-          </a:bodyPr>
-          <a:lstStyle xmlns:a="http://schemas.openxmlformats.org/drawingml/2006/main"/>
-          <a:p xmlns:a="http://schemas.openxmlformats.org/drawingml/2006/main">
-            <a:pPr>
-              <a:defRPr sz="2175" b="0">
-                <a:solidFill>
-                  <a:srgbClr val="182C29"/>
-                </a:solidFill>
-                <a:latin typeface="Apple SD Gothic Neo"/>
-                <a:ea typeface="Apple SD Gothic Neo"/>
-                <a:cs typeface="Apple SD Gothic Neo"/>
-              </a:defRPr>
-            </a:pPr>
-            <a:r>
-              <a:rPr sz="2175" b="0">
-                <a:solidFill>
-                  <a:srgbClr val="182C29"/>
-                </a:solidFill>
-                <a:latin typeface="Apple SD Gothic Neo"/>
-                <a:ea typeface="Apple SD Gothic Neo"/>
-                <a:cs typeface="Apple SD Gothic Neo"/>
-              </a:rPr>
-              <a:t>에이전트가 상품·배송지 확인, 주문 정보 입력과 신청 결과 대조를 수행했습니다.</a:t>
-            </a:r>
-          </a:p>
-        </p:txBody>
-      </p:sp>
-      <p:sp>
-        <p:nvSpPr>
-          <p:cNvPr id="14" name="">
-            <a:extLst xmlns:a="http://schemas.openxmlformats.org/drawingml/2006/main">
-              <a:ext uri="{FF2B5EF4-FFF2-40B4-BE49-F238E27FC236}">
-                <a16:creationId xmlns:a16="http://schemas.microsoft.com/office/drawing/2014/main" id="{824DF1CD-6494-4FF3-83C0-291C2BEC2E8E}"/>
-              </a:ext>
-            </a:extLst>
-          </p:cNvPr>
-          <p:cNvSpPr>
-            <a:spLocks xmlns:a="http://schemas.openxmlformats.org/drawingml/2006/main" noGrp="1"/>
-          </p:cNvSpPr>
-          <p:nvPr/>
-        </p:nvSpPr>
-        <p:spPr>
-          <a:xfrm xmlns:a="http://schemas.openxmlformats.org/drawingml/2006/main">
-            <a:off x="819150" y="7505700"/>
-            <a:ext cx="13525500" cy="400050"/>
-          </a:xfrm>
-          <a:prstGeom xmlns:a="http://schemas.openxmlformats.org/drawingml/2006/main" prst="rect">
-            <a:avLst/>
-          </a:prstGeom>
-          <a:noFill xmlns:a="http://schemas.openxmlformats.org/drawingml/2006/main"/>
-          <a:ln xmlns:a="http://schemas.openxmlformats.org/drawingml/2006/main" w="0">
-            <a:noFill/>
-          </a:ln>
-        </p:spPr>
-        <p:txBody>
-          <a:bodyPr xmlns:a="http://schemas.openxmlformats.org/drawingml/2006/main" wrap="square" lIns="0" tIns="0" rIns="0" bIns="0">
-            <a:noAutofit/>
-          </a:bodyPr>
-          <a:lstStyle xmlns:a="http://schemas.openxmlformats.org/drawingml/2006/main"/>
-          <a:p xmlns:a="http://schemas.openxmlformats.org/drawingml/2006/main">
-            <a:pPr>
-              <a:defRPr sz="1725" b="0">
+              <a:defRPr sz="1650" b="0">
                 <a:solidFill>
                   <a:srgbClr val="5E706B"/>
                 </a:solidFill>
@@ -11099,7 +11509,7 @@
               </a:defRPr>
             </a:pPr>
             <a:r>
-              <a:rPr sz="1725" b="0">
+              <a:rPr sz="1650" b="0">
                 <a:solidFill>
                   <a:srgbClr val="5E706B"/>
                 </a:solidFill>
@@ -11107,7 +11517,7 @@
                 <a:ea typeface="Apple SD Gothic Neo"/>
                 <a:cs typeface="Apple SD Gothic Neo"/>
               </a:rPr>
-              <a:t>단일 사례 · 사용자 메시지 7회 기준. 로그인·직접 구매·통관 인증의 화면 조작 횟수는 미측정입니다.</a:t>
+              <a:t>사용자 메시지 기준의 단일 사례입니다. 로그인·구매·인증 화면의 클릭·입력 횟수는 별도이며 미측정입니다.</a:t>
             </a:r>
           </a:p>
         </p:txBody>
@@ -11115,7 +11525,7 @@
     </p:spTree>
     <p:extLst>
       <p:ext uri="{BB962C8B-B14F-4D97-AF65-F5344CB8AC3E}">
-        <p14:creationId xmlns:p14="http://schemas.microsoft.com/office/powerpoint/2010/main" val="1023698119"/>
+        <p14:creationId xmlns:p14="http://schemas.microsoft.com/office/powerpoint/2010/main" val="539084931"/>
       </p:ext>
     </p:extLst>
   </p:cSld>
@@ -11143,10 +11553,10 @@
       </p:grpSpPr>
       <p:sp>
         <p:nvSpPr>
-          <p:cNvPr id="14" name="">
-            <a:extLst xmlns:a="http://schemas.openxmlformats.org/drawingml/2006/main">
-              <a:ext uri="{FF2B5EF4-FFF2-40B4-BE49-F238E27FC236}">
-                <a16:creationId xmlns:a16="http://schemas.microsoft.com/office/drawing/2014/main" id="{20BEA505-1BEB-4F74-9CA9-ADE2BF529FF7}"/>
+          <p:cNvPr id="13" name="">
+            <a:extLst xmlns:a="http://schemas.openxmlformats.org/drawingml/2006/main">
+              <a:ext uri="{FF2B5EF4-FFF2-40B4-BE49-F238E27FC236}">
+                <a16:creationId xmlns:a16="http://schemas.microsoft.com/office/drawing/2014/main" id="{A947EEB6-BDEC-4D5B-A39D-962FDCE65323}"/>
               </a:ext>
             </a:extLst>
           </p:cNvPr>
@@ -11203,7 +11613,7 @@
           <p:cNvPr id="2" name="">
             <a:extLst xmlns:a="http://schemas.openxmlformats.org/drawingml/2006/main">
               <a:ext uri="{FF2B5EF4-FFF2-40B4-BE49-F238E27FC236}">
-                <a16:creationId xmlns:a16="http://schemas.microsoft.com/office/drawing/2014/main" id="{2732BEE3-0289-4333-A103-D39445616A3E}"/>
+                <a16:creationId xmlns:a16="http://schemas.microsoft.com/office/drawing/2014/main" id="{BA732B5A-4FAF-4B92-BD8E-3378A73954F6}"/>
               </a:ext>
             </a:extLst>
           </p:cNvPr>
@@ -11260,7 +11670,7 @@
           <p:cNvPr id="3" name="">
             <a:extLst xmlns:a="http://schemas.openxmlformats.org/drawingml/2006/main">
               <a:ext uri="{FF2B5EF4-FFF2-40B4-BE49-F238E27FC236}">
-                <a16:creationId xmlns:a16="http://schemas.microsoft.com/office/drawing/2014/main" id="{BB8FFCF4-C6BD-44AD-BC55-C152CED3A020}"/>
+                <a16:creationId xmlns:a16="http://schemas.microsoft.com/office/drawing/2014/main" id="{A7CDCFBC-BC4B-4389-8F3F-03FC9A9D8FF4}"/>
               </a:ext>
             </a:extLst>
           </p:cNvPr>
@@ -11317,7 +11727,7 @@
           <p:cNvPr id="4" name="">
             <a:extLst xmlns:a="http://schemas.openxmlformats.org/drawingml/2006/main">
               <a:ext uri="{FF2B5EF4-FFF2-40B4-BE49-F238E27FC236}">
-                <a16:creationId xmlns:a16="http://schemas.microsoft.com/office/drawing/2014/main" id="{3522B3D1-F422-449A-B695-BB3B5F4A5844}"/>
+                <a16:creationId xmlns:a16="http://schemas.microsoft.com/office/drawing/2014/main" id="{CCB9F8BE-30EF-4813-8F0C-9806D503DF76}"/>
               </a:ext>
             </a:extLst>
           </p:cNvPr>
@@ -11376,7 +11786,7 @@
           <p:cNvPr id="5" name="">
             <a:extLst xmlns:a="http://schemas.openxmlformats.org/drawingml/2006/main">
               <a:ext uri="{FF2B5EF4-FFF2-40B4-BE49-F238E27FC236}">
-                <a16:creationId xmlns:a16="http://schemas.microsoft.com/office/drawing/2014/main" id="{798BB3DA-2527-4694-B9EF-4FD82B597763}"/>
+                <a16:creationId xmlns:a16="http://schemas.microsoft.com/office/drawing/2014/main" id="{E6C0C10A-A7A3-4639-A59D-F8C57435BBE0}"/>
               </a:ext>
             </a:extLst>
           </p:cNvPr>
@@ -11432,7 +11842,7 @@
       </p:sp>
       <p:cxnSp>
         <p:nvCxnSpPr>
-          <p:cNvPr id="19" name=""/>
+          <p:cNvPr id="18" name=""/>
           <p:cNvCxnSpPr>
             <a:stCxn xmlns:a="http://schemas.openxmlformats.org/drawingml/2006/main" id="4" idx="3"/>
             <a:endCxn xmlns:a="http://schemas.openxmlformats.org/drawingml/2006/main" id="5" idx="1"/>
@@ -11460,7 +11870,7 @@
           <p:cNvPr id="7" name="">
             <a:extLst xmlns:a="http://schemas.openxmlformats.org/drawingml/2006/main">
               <a:ext uri="{FF2B5EF4-FFF2-40B4-BE49-F238E27FC236}">
-                <a16:creationId xmlns:a16="http://schemas.microsoft.com/office/drawing/2014/main" id="{7D3AE5F0-94B9-405F-ADB1-677E6824207F}"/>
+                <a16:creationId xmlns:a16="http://schemas.microsoft.com/office/drawing/2014/main" id="{944B7B9C-0DD6-460C-BA08-D8C9DD8491D5}"/>
               </a:ext>
             </a:extLst>
           </p:cNvPr>
@@ -11516,7 +11926,7 @@
       </p:sp>
       <p:cxnSp>
         <p:nvCxnSpPr>
-          <p:cNvPr id="21" name=""/>
+          <p:cNvPr id="20" name=""/>
           <p:cNvCxnSpPr>
             <a:stCxn xmlns:a="http://schemas.openxmlformats.org/drawingml/2006/main" id="5" idx="3"/>
             <a:endCxn xmlns:a="http://schemas.openxmlformats.org/drawingml/2006/main" id="7" idx="1"/>
@@ -11544,7 +11954,7 @@
           <p:cNvPr id="9" name="">
             <a:extLst xmlns:a="http://schemas.openxmlformats.org/drawingml/2006/main">
               <a:ext uri="{FF2B5EF4-FFF2-40B4-BE49-F238E27FC236}">
-                <a16:creationId xmlns:a16="http://schemas.microsoft.com/office/drawing/2014/main" id="{4C6530D9-DE3B-4C00-AE7E-568B931B9EBF}"/>
+                <a16:creationId xmlns:a16="http://schemas.microsoft.com/office/drawing/2014/main" id="{B89874C5-E5FC-46C4-B2F8-7AF49BF1AA0F}"/>
               </a:ext>
             </a:extLst>
           </p:cNvPr>
@@ -11624,7 +12034,7 @@
           <p:cNvPr id="10" name="">
             <a:extLst xmlns:a="http://schemas.openxmlformats.org/drawingml/2006/main">
               <a:ext uri="{FF2B5EF4-FFF2-40B4-BE49-F238E27FC236}">
-                <a16:creationId xmlns:a16="http://schemas.microsoft.com/office/drawing/2014/main" id="{7157C9FB-828A-4D2A-824F-88A6800FC098}"/>
+                <a16:creationId xmlns:a16="http://schemas.microsoft.com/office/drawing/2014/main" id="{F53027AA-3F72-4CA8-9A1E-0A6A4FAB6C9D}"/>
               </a:ext>
             </a:extLst>
           </p:cNvPr>
@@ -11704,7 +12114,7 @@
           <p:cNvPr id="11" name="">
             <a:extLst xmlns:a="http://schemas.openxmlformats.org/drawingml/2006/main">
               <a:ext uri="{FF2B5EF4-FFF2-40B4-BE49-F238E27FC236}">
-                <a16:creationId xmlns:a16="http://schemas.microsoft.com/office/drawing/2014/main" id="{2458ECA4-79E1-4C91-AD3F-DC70527A9C45}"/>
+                <a16:creationId xmlns:a16="http://schemas.microsoft.com/office/drawing/2014/main" id="{283F401D-7E53-47E6-83E2-38F06F94820C}"/>
               </a:ext>
             </a:extLst>
           </p:cNvPr>
@@ -11784,7 +12194,7 @@
           <p:cNvPr id="12" name="">
             <a:extLst xmlns:a="http://schemas.openxmlformats.org/drawingml/2006/main">
               <a:ext uri="{FF2B5EF4-FFF2-40B4-BE49-F238E27FC236}">
-                <a16:creationId xmlns:a16="http://schemas.microsoft.com/office/drawing/2014/main" id="{487F1873-0BCC-4F3C-AF30-B46988BE62FF}"/>
+                <a16:creationId xmlns:a16="http://schemas.microsoft.com/office/drawing/2014/main" id="{1DC2104E-9E2C-489B-BB51-C2D9F060B722}"/>
               </a:ext>
             </a:extLst>
           </p:cNvPr>
@@ -11859,67 +12269,10 @@
           </a:p>
         </p:txBody>
       </p:sp>
-      <p:sp>
-        <p:nvSpPr>
-          <p:cNvPr id="13" name="">
-            <a:extLst xmlns:a="http://schemas.openxmlformats.org/drawingml/2006/main">
-              <a:ext uri="{FF2B5EF4-FFF2-40B4-BE49-F238E27FC236}">
-                <a16:creationId xmlns:a16="http://schemas.microsoft.com/office/drawing/2014/main" id="{97FD359B-E5EB-4676-9B89-E1F5BF86CDD3}"/>
-              </a:ext>
-            </a:extLst>
-          </p:cNvPr>
-          <p:cNvSpPr>
-            <a:spLocks xmlns:a="http://schemas.openxmlformats.org/drawingml/2006/main" noGrp="1"/>
-          </p:cNvSpPr>
-          <p:nvPr/>
-        </p:nvSpPr>
-        <p:spPr>
-          <a:xfrm xmlns:a="http://schemas.openxmlformats.org/drawingml/2006/main">
-            <a:off x="819150" y="7524750"/>
-            <a:ext cx="13525500" cy="361950"/>
-          </a:xfrm>
-          <a:prstGeom xmlns:a="http://schemas.openxmlformats.org/drawingml/2006/main" prst="rect">
-            <a:avLst/>
-          </a:prstGeom>
-          <a:noFill xmlns:a="http://schemas.openxmlformats.org/drawingml/2006/main"/>
-          <a:ln xmlns:a="http://schemas.openxmlformats.org/drawingml/2006/main" w="0">
-            <a:noFill/>
-          </a:ln>
-        </p:spPr>
-        <p:txBody>
-          <a:bodyPr xmlns:a="http://schemas.openxmlformats.org/drawingml/2006/main" wrap="square" lIns="0" tIns="0" rIns="0" bIns="0">
-            <a:noAutofit/>
-          </a:bodyPr>
-          <a:lstStyle xmlns:a="http://schemas.openxmlformats.org/drawingml/2006/main"/>
-          <a:p xmlns:a="http://schemas.openxmlformats.org/drawingml/2006/main">
-            <a:pPr>
-              <a:defRPr sz="1725" b="0">
-                <a:solidFill>
-                  <a:srgbClr val="5E706B"/>
-                </a:solidFill>
-                <a:latin typeface="Apple SD Gothic Neo"/>
-                <a:ea typeface="Apple SD Gothic Neo"/>
-                <a:cs typeface="Apple SD Gothic Neo"/>
-              </a:defRPr>
-            </a:pPr>
-            <a:r>
-              <a:rPr sz="1725" b="0">
-                <a:solidFill>
-                  <a:srgbClr val="5E706B"/>
-                </a:solidFill>
-                <a:latin typeface="Apple SD Gothic Neo"/>
-                <a:ea typeface="Apple SD Gothic Neo"/>
-                <a:cs typeface="Apple SD Gothic Neo"/>
-              </a:rPr>
-              <a:t>10/6 플러그인 동작 개정. 메일·예약 도구 연결이 필요하며, 실제 예약의 장기 실행 결과는 없습니다.</a:t>
-            </a:r>
-          </a:p>
-        </p:txBody>
-      </p:sp>
     </p:spTree>
     <p:extLst>
       <p:ext uri="{BB962C8B-B14F-4D97-AF65-F5344CB8AC3E}">
-        <p14:creationId xmlns:p14="http://schemas.microsoft.com/office/powerpoint/2010/main" val="268563451"/>
+        <p14:creationId xmlns:p14="http://schemas.microsoft.com/office/powerpoint/2010/main" val="108386323"/>
       </p:ext>
     </p:extLst>
   </p:cSld>

</xml_diff>

<commit_message>
docs: refresh dialogue visual and catalog screenshot
</commit_message>
<xml_diff>
--- a/portfolio/crossborder-portfolio.pptx
+++ b/portfolio/crossborder-portfolio.pptx
@@ -2,27 +2,27 @@
 <file path=ppt/presentation.xml><?xml version="1.0" encoding="utf-8"?>
 <p:presentation xmlns:p="http://schemas.openxmlformats.org/presentationml/2006/main">
   <p:sldMasterIdLst>
-    <p:sldMasterId xmlns:r="http://schemas.openxmlformats.org/officeDocument/2006/relationships" id="2147483648" r:id="R88170057f71b4b63"/>
+    <p:sldMasterId xmlns:r="http://schemas.openxmlformats.org/officeDocument/2006/relationships" id="2147483648" r:id="R43e693a103bf4a56"/>
   </p:sldMasterIdLst>
   <p:notesMasterIdLst>
-    <p:notesMasterId xmlns:r="http://schemas.openxmlformats.org/officeDocument/2006/relationships" r:id="Rfb2b528ceff84fba"/>
+    <p:notesMasterId xmlns:r="http://schemas.openxmlformats.org/officeDocument/2006/relationships" r:id="Rc16d5bca86a04270"/>
   </p:notesMasterIdLst>
   <p:sldIdLst>
-    <p:sldId xmlns:r="http://schemas.openxmlformats.org/officeDocument/2006/relationships" id="256" r:id="Rb078ae17c36c47c2"/>
-    <p:sldId xmlns:r="http://schemas.openxmlformats.org/officeDocument/2006/relationships" id="257" r:id="R4efa3a5b21894e11"/>
-    <p:sldId xmlns:r="http://schemas.openxmlformats.org/officeDocument/2006/relationships" id="258" r:id="R4d4a45447acc4418"/>
-    <p:sldId xmlns:r="http://schemas.openxmlformats.org/officeDocument/2006/relationships" id="259" r:id="R1e8331fce1d14121"/>
-    <p:sldId xmlns:r="http://schemas.openxmlformats.org/officeDocument/2006/relationships" id="260" r:id="Rdcce53d1ec184046"/>
-    <p:sldId xmlns:r="http://schemas.openxmlformats.org/officeDocument/2006/relationships" id="261" r:id="R1c3ba589ed7749f1"/>
-    <p:sldId xmlns:r="http://schemas.openxmlformats.org/officeDocument/2006/relationships" id="262" r:id="Ra864fac0329344fd"/>
-    <p:sldId xmlns:r="http://schemas.openxmlformats.org/officeDocument/2006/relationships" id="263" r:id="R9b5066aa80c74c98"/>
-    <p:sldId xmlns:r="http://schemas.openxmlformats.org/officeDocument/2006/relationships" id="264" r:id="R799bc67a15614b69"/>
-    <p:sldId xmlns:r="http://schemas.openxmlformats.org/officeDocument/2006/relationships" id="265" r:id="Rcc7bce014304441b"/>
-    <p:sldId xmlns:r="http://schemas.openxmlformats.org/officeDocument/2006/relationships" id="266" r:id="R058cc943fa3c46fa"/>
-    <p:sldId xmlns:r="http://schemas.openxmlformats.org/officeDocument/2006/relationships" id="267" r:id="R2e33d6c9e9aa4a0b"/>
-    <p:sldId xmlns:r="http://schemas.openxmlformats.org/officeDocument/2006/relationships" id="268" r:id="R4a57b205a4db4908"/>
-    <p:sldId xmlns:r="http://schemas.openxmlformats.org/officeDocument/2006/relationships" id="269" r:id="R443ec0e932fb427d"/>
-    <p:sldId xmlns:r="http://schemas.openxmlformats.org/officeDocument/2006/relationships" id="270" r:id="R8177942159d643da"/>
+    <p:sldId xmlns:r="http://schemas.openxmlformats.org/officeDocument/2006/relationships" id="256" r:id="R0259e4d8ef2f42b3"/>
+    <p:sldId xmlns:r="http://schemas.openxmlformats.org/officeDocument/2006/relationships" id="257" r:id="Ra262b92973a7458a"/>
+    <p:sldId xmlns:r="http://schemas.openxmlformats.org/officeDocument/2006/relationships" id="258" r:id="R5e42f404ba2247ec"/>
+    <p:sldId xmlns:r="http://schemas.openxmlformats.org/officeDocument/2006/relationships" id="259" r:id="Rdf18d1b67d9c418b"/>
+    <p:sldId xmlns:r="http://schemas.openxmlformats.org/officeDocument/2006/relationships" id="260" r:id="R6ce09d5456e84bfc"/>
+    <p:sldId xmlns:r="http://schemas.openxmlformats.org/officeDocument/2006/relationships" id="261" r:id="R9086e00e48f944ba"/>
+    <p:sldId xmlns:r="http://schemas.openxmlformats.org/officeDocument/2006/relationships" id="262" r:id="R6d139a452aa74155"/>
+    <p:sldId xmlns:r="http://schemas.openxmlformats.org/officeDocument/2006/relationships" id="263" r:id="Rd59173873b66481d"/>
+    <p:sldId xmlns:r="http://schemas.openxmlformats.org/officeDocument/2006/relationships" id="264" r:id="Rabf646e332924388"/>
+    <p:sldId xmlns:r="http://schemas.openxmlformats.org/officeDocument/2006/relationships" id="265" r:id="Rfdddb30c728c44c1"/>
+    <p:sldId xmlns:r="http://schemas.openxmlformats.org/officeDocument/2006/relationships" id="266" r:id="R79c1c7d6a7e54ccb"/>
+    <p:sldId xmlns:r="http://schemas.openxmlformats.org/officeDocument/2006/relationships" id="267" r:id="R65c42c6e6e594b64"/>
+    <p:sldId xmlns:r="http://schemas.openxmlformats.org/officeDocument/2006/relationships" id="268" r:id="R7cb3f0bfbc804853"/>
+    <p:sldId xmlns:r="http://schemas.openxmlformats.org/officeDocument/2006/relationships" id="269" r:id="R6e1b531223694c8d"/>
+    <p:sldId xmlns:r="http://schemas.openxmlformats.org/officeDocument/2006/relationships" id="270" r:id="R02f616cfaccc43bc"/>
   </p:sldIdLst>
   <p:sldSz cx="15240000" cy="8572500"/>
   <p:notesSz cx="6858000" cy="9144000"/>
@@ -526,7 +526,7 @@
           <a:lstStyle xmlns:a="http://schemas.openxmlformats.org/drawingml/2006/main"/>
           <a:p xmlns:a="http://schemas.openxmlformats.org/drawingml/2006/main">
             <a:r>
-              <a:t>https://github.com/y00nZZang/product-catalog/blob/main/docs/verification.md ; https://catalog.janghan.dev/ . 2026-10-06 캡처, 10/5 저장 관측 결과. 동일 페이지의 입력·결과 영역을 나누어 배치.</a:t>
+              <a:t>https://github.com/y00nZZang/product-catalog/blob/main/docs/verification.md . 사용자 제공 상품 분석 캡처 원본을 자르지 않고 삽입. 관측·추정값이며 실제 결제액 아님.</a:t>
             </a:r>
           </a:p>
         </p:txBody>
@@ -1366,7 +1366,7 @@
           <a:lstStyle xmlns:a="http://schemas.openxmlformats.org/drawingml/2006/main"/>
           <a:p xmlns:a="http://schemas.openxmlformats.org/drawingml/2006/main">
             <a:r>
-              <a:t>https://github.com/y00nZZang/crossborder-purchase-agent/blob/main/docs/interaction-count.md ; https://github.com/y00nZZang/crossborder-purchase-agent/blob/main/docs/experiment.md . 사용자 메시지7개. 로그인 두 번을 한 행으로 묶은 요약이며 실제 원문 대화 캡처가 아님.</a:t>
+              <a:t>https://github.com/y00nZZang/crossborder-purchase-agent/blob/main/docs/interaction-count.md ; https://github.com/y00nZZang/crossborder-purchase-agent/blob/main/docs/experiment.md . 실제 대화 요약. 로그인2회·승인2회·구매/인증 완료2회를 묶어 표현. 사용자 첨부 대화 스타일 참고, 실제 접수 캡처 유지.</a:t>
             </a:r>
           </a:p>
         </p:txBody>
@@ -1504,7 +1504,7 @@
   </p:cSld>
   <p:clrMap bg1="lt1" tx1="dk1" bg2="lt2" tx2="dk2" accent1="accent1" accent2="accent2" accent3="accent3" accent4="accent4" accent5="accent5" accent6="accent6" hlink="hlink" folHlink="folHlink"/>
   <p:sldLayoutIdLst>
-    <p:sldLayoutId xmlns:r="http://schemas.openxmlformats.org/officeDocument/2006/relationships" id="2147483649" r:id="R7a6763684817432a"/>
+    <p:sldLayoutId xmlns:r="http://schemas.openxmlformats.org/officeDocument/2006/relationships" id="2147483649" r:id="R5f6ed23fa0b545a8"/>
   </p:sldLayoutIdLst>
   <p:txStyles>
     <p:titleStyle>
@@ -2055,7 +2055,7 @@
           <p:cNvPr id="7" name="">
             <a:extLst xmlns:a="http://schemas.openxmlformats.org/drawingml/2006/main">
               <a:ext uri="{FF2B5EF4-FFF2-40B4-BE49-F238E27FC236}">
-                <a16:creationId xmlns:a16="http://schemas.microsoft.com/office/drawing/2014/main" id="{C1A13495-24BC-4326-884E-5561931F9E7C}"/>
+                <a16:creationId xmlns:a16="http://schemas.microsoft.com/office/drawing/2014/main" id="{98C251FD-1D1C-4BDE-8C26-C0F1C7033B56}"/>
               </a:ext>
             </a:extLst>
           </p:cNvPr>
@@ -2094,7 +2094,7 @@
           <p:cNvPr id="2" name="">
             <a:extLst xmlns:a="http://schemas.openxmlformats.org/drawingml/2006/main">
               <a:ext uri="{FF2B5EF4-FFF2-40B4-BE49-F238E27FC236}">
-                <a16:creationId xmlns:a16="http://schemas.microsoft.com/office/drawing/2014/main" id="{2BA9C37F-FE50-4180-8173-593FC38A8DD9}"/>
+                <a16:creationId xmlns:a16="http://schemas.microsoft.com/office/drawing/2014/main" id="{03698436-8D1C-4D57-9CC0-66AD3FE6FF8D}"/>
               </a:ext>
             </a:extLst>
           </p:cNvPr>
@@ -2151,7 +2151,7 @@
           <p:cNvPr id="3" name="">
             <a:extLst xmlns:a="http://schemas.openxmlformats.org/drawingml/2006/main">
               <a:ext uri="{FF2B5EF4-FFF2-40B4-BE49-F238E27FC236}">
-                <a16:creationId xmlns:a16="http://schemas.microsoft.com/office/drawing/2014/main" id="{8BBF4A73-51A1-4E3A-AEEA-308CC2B39E0A}"/>
+                <a16:creationId xmlns:a16="http://schemas.microsoft.com/office/drawing/2014/main" id="{65548D7D-D452-454D-BA08-77860DC5B5C4}"/>
               </a:ext>
             </a:extLst>
           </p:cNvPr>
@@ -2208,7 +2208,7 @@
           <p:cNvPr id="4" name="">
             <a:extLst xmlns:a="http://schemas.openxmlformats.org/drawingml/2006/main">
               <a:ext uri="{FF2B5EF4-FFF2-40B4-BE49-F238E27FC236}">
-                <a16:creationId xmlns:a16="http://schemas.microsoft.com/office/drawing/2014/main" id="{BDAA9150-9D33-4C22-B844-28C986CB82C9}"/>
+                <a16:creationId xmlns:a16="http://schemas.microsoft.com/office/drawing/2014/main" id="{4070B090-A2B0-4B01-89CB-A9C712472182}"/>
               </a:ext>
             </a:extLst>
           </p:cNvPr>
@@ -2288,7 +2288,7 @@
           <p:cNvPr id="5" name="">
             <a:extLst xmlns:a="http://schemas.openxmlformats.org/drawingml/2006/main">
               <a:ext uri="{FF2B5EF4-FFF2-40B4-BE49-F238E27FC236}">
-                <a16:creationId xmlns:a16="http://schemas.microsoft.com/office/drawing/2014/main" id="{6CB7E093-F230-41D7-A23A-3631D52B2482}"/>
+                <a16:creationId xmlns:a16="http://schemas.microsoft.com/office/drawing/2014/main" id="{CB1E646F-555D-4237-BF67-1DF60DBE41FE}"/>
               </a:ext>
             </a:extLst>
           </p:cNvPr>
@@ -2345,7 +2345,7 @@
           <p:cNvPr id="6" name="">
             <a:extLst xmlns:a="http://schemas.openxmlformats.org/drawingml/2006/main">
               <a:ext uri="{FF2B5EF4-FFF2-40B4-BE49-F238E27FC236}">
-                <a16:creationId xmlns:a16="http://schemas.microsoft.com/office/drawing/2014/main" id="{78EC895B-B5DB-4D0F-9A4D-ADA619005EEA}"/>
+                <a16:creationId xmlns:a16="http://schemas.microsoft.com/office/drawing/2014/main" id="{FEE0E9EE-F721-4CF5-AD9B-F6C91E3A1772}"/>
               </a:ext>
             </a:extLst>
           </p:cNvPr>
@@ -2400,7 +2400,7 @@
     </p:spTree>
     <p:extLst>
       <p:ext uri="{BB962C8B-B14F-4D97-AF65-F5344CB8AC3E}">
-        <p14:creationId xmlns:p14="http://schemas.microsoft.com/office/powerpoint/2010/main" val="1633945496"/>
+        <p14:creationId xmlns:p14="http://schemas.microsoft.com/office/powerpoint/2010/main" val="985119153"/>
       </p:ext>
     </p:extLst>
   </p:cSld>
@@ -2428,10 +2428,10 @@
       </p:grpSpPr>
       <p:sp>
         <p:nvSpPr>
-          <p:cNvPr id="7" name="">
-            <a:extLst xmlns:a="http://schemas.openxmlformats.org/drawingml/2006/main">
-              <a:ext uri="{FF2B5EF4-FFF2-40B4-BE49-F238E27FC236}">
-                <a16:creationId xmlns:a16="http://schemas.microsoft.com/office/drawing/2014/main" id="{A687D841-B9C1-4C64-B13D-00DCD7DE9034}"/>
+          <p:cNvPr id="10" name="">
+            <a:extLst xmlns:a="http://schemas.openxmlformats.org/drawingml/2006/main">
+              <a:ext uri="{FF2B5EF4-FFF2-40B4-BE49-F238E27FC236}">
+                <a16:creationId xmlns:a16="http://schemas.microsoft.com/office/drawing/2014/main" id="{A884774B-789F-48C3-955A-AB277820B4A0}"/>
               </a:ext>
             </a:extLst>
           </p:cNvPr>
@@ -2488,7 +2488,7 @@
           <p:cNvPr id="2" name="">
             <a:extLst xmlns:a="http://schemas.openxmlformats.org/drawingml/2006/main">
               <a:ext uri="{FF2B5EF4-FFF2-40B4-BE49-F238E27FC236}">
-                <a16:creationId xmlns:a16="http://schemas.microsoft.com/office/drawing/2014/main" id="{BE77992E-91AE-4A97-BF80-278106B92ACF}"/>
+                <a16:creationId xmlns:a16="http://schemas.microsoft.com/office/drawing/2014/main" id="{78E1F7FC-D67C-4CA5-9F73-5AC330D62621}"/>
               </a:ext>
             </a:extLst>
           </p:cNvPr>
@@ -2535,7 +2535,7 @@
                 <a:ea typeface="Apple SD Gothic Neo"/>
                 <a:cs typeface="Apple SD Gothic Neo"/>
               </a:rPr>
-              <a:t>https://catalog.janghan.dev/  ·  URL 입력 → 상품 수집 → 배송·관세 추정</a:t>
+              <a:t>https://catalog.janghan.dev/</a:t>
             </a:r>
           </a:p>
         </p:txBody>
@@ -2545,7 +2545,7 @@
           <p:cNvPr id="3" name="">
             <a:extLst xmlns:a="http://schemas.openxmlformats.org/drawingml/2006/main">
               <a:ext uri="{FF2B5EF4-FFF2-40B4-BE49-F238E27FC236}">
-                <a16:creationId xmlns:a16="http://schemas.microsoft.com/office/drawing/2014/main" id="{65FCCF5B-7084-44C6-AA13-5AD339F87DD6}"/>
+                <a16:creationId xmlns:a16="http://schemas.microsoft.com/office/drawing/2014/main" id="{C63E1A42-2578-426E-8D4C-28E2F8185185}"/>
               </a:ext>
             </a:extLst>
           </p:cNvPr>
@@ -2602,19 +2602,19 @@
           <p:cNvPr id="4" name="">
             <a:extLst xmlns:a="http://schemas.openxmlformats.org/drawingml/2006/main">
               <a:ext uri="{FF2B5EF4-FFF2-40B4-BE49-F238E27FC236}">
-                <a16:creationId xmlns:a16="http://schemas.microsoft.com/office/drawing/2014/main" id="{EEBFE163-11C1-4C0C-B10C-4F94BBBEB6BF}"/>
-              </a:ext>
-            </a:extLst>
-          </p:cNvPr>
-          <p:cNvSpPr>
-            <a:spLocks xmlns:a="http://schemas.openxmlformats.org/drawingml/2006/main" noGrp="1"/>
-          </p:cNvSpPr>
-          <p:nvPr/>
-        </p:nvSpPr>
-        <p:spPr>
-          <a:xfrm xmlns:a="http://schemas.openxmlformats.org/drawingml/2006/main">
-            <a:off x="1571625" y="2333625"/>
-            <a:ext cx="12096750" cy="5314950"/>
+                <a16:creationId xmlns:a16="http://schemas.microsoft.com/office/drawing/2014/main" id="{DFEABA4D-E1BB-44B5-A68A-434F4BC501AE}"/>
+              </a:ext>
+            </a:extLst>
+          </p:cNvPr>
+          <p:cNvSpPr>
+            <a:spLocks xmlns:a="http://schemas.openxmlformats.org/drawingml/2006/main" noGrp="1"/>
+          </p:cNvSpPr>
+          <p:nvPr/>
+        </p:nvSpPr>
+        <p:spPr>
+          <a:xfrm xmlns:a="http://schemas.openxmlformats.org/drawingml/2006/main">
+            <a:off x="4810125" y="2124075"/>
+            <a:ext cx="5619750" cy="5734050"/>
           </a:xfrm>
           <a:prstGeom xmlns:a="http://schemas.openxmlformats.org/drawingml/2006/main" prst="rect">
             <a:avLst/>
@@ -2622,61 +2622,336 @@
           <a:solidFill xmlns:a="http://schemas.openxmlformats.org/drawingml/2006/main">
             <a:srgbClr val="FFFFFF"/>
           </a:solidFill>
-          <a:ln xmlns:a="http://schemas.openxmlformats.org/drawingml/2006/main" w="19050">
+          <a:ln xmlns:a="http://schemas.openxmlformats.org/drawingml/2006/main" w="9525">
             <a:solidFill>
-              <a:srgbClr val="7D968A"/>
+              <a:srgbClr val="98ACA2"/>
             </a:solidFill>
           </a:ln>
         </p:spPr>
       </p:sp>
       <p:pic>
         <p:nvPicPr>
-          <p:cNvPr id="11" name=""/>
+          <p:cNvPr id="14" name=""/>
           <p:cNvPicPr>
             <a:picLocks xmlns:a="http://schemas.openxmlformats.org/drawingml/2006/main" noChangeAspect="1"/>
           </p:cNvPicPr>
           <p:nvPr/>
         </p:nvPicPr>
         <p:blipFill>
-          <a:blip xmlns:r="http://schemas.openxmlformats.org/officeDocument/2006/relationships" xmlns:a="http://schemas.openxmlformats.org/drawingml/2006/main" r:embed="R36450fd99bda488a"/>
+          <a:blip xmlns:r="http://schemas.openxmlformats.org/officeDocument/2006/relationships" xmlns:a="http://schemas.openxmlformats.org/drawingml/2006/main" r:embed="R3dbc396ccd89477c"/>
           <a:stretch xmlns:a="http://schemas.openxmlformats.org/drawingml/2006/main"/>
         </p:blipFill>
         <p:spPr>
           <a:xfrm xmlns:a="http://schemas.openxmlformats.org/drawingml/2006/main">
-            <a:off x="2958193" y="2476500"/>
-            <a:ext cx="9323614" cy="1428750"/>
+            <a:off x="5059326" y="2238375"/>
+            <a:ext cx="5121349" cy="5505450"/>
           </a:xfrm>
           <a:prstGeom xmlns:a="http://schemas.openxmlformats.org/drawingml/2006/main" prst="rect">
             <a:avLst/>
           </a:prstGeom>
         </p:spPr>
       </p:pic>
-      <p:pic>
-        <p:nvPicPr>
-          <p:cNvPr id="12" name=""/>
-          <p:cNvPicPr>
-            <a:picLocks xmlns:a="http://schemas.openxmlformats.org/drawingml/2006/main" noChangeAspect="1"/>
-          </p:cNvPicPr>
-          <p:nvPr/>
-        </p:nvPicPr>
-        <p:blipFill>
-          <a:blip xmlns:r="http://schemas.openxmlformats.org/officeDocument/2006/relationships" xmlns:a="http://schemas.openxmlformats.org/drawingml/2006/main" r:embed="R0bdf459289334bf1"/>
-          <a:stretch xmlns:a="http://schemas.openxmlformats.org/drawingml/2006/main"/>
-        </p:blipFill>
-        <p:spPr>
-          <a:xfrm xmlns:a="http://schemas.openxmlformats.org/drawingml/2006/main">
-            <a:off x="4303239" y="3981450"/>
-            <a:ext cx="6633522" cy="3543300"/>
-          </a:xfrm>
-          <a:prstGeom xmlns:a="http://schemas.openxmlformats.org/drawingml/2006/main" prst="rect">
-            <a:avLst/>
-          </a:prstGeom>
-        </p:spPr>
-      </p:pic>
+      <p:sp>
+        <p:nvSpPr>
+          <p:cNvPr id="6" name="">
+            <a:extLst xmlns:a="http://schemas.openxmlformats.org/drawingml/2006/main">
+              <a:ext uri="{FF2B5EF4-FFF2-40B4-BE49-F238E27FC236}">
+                <a16:creationId xmlns:a16="http://schemas.microsoft.com/office/drawing/2014/main" id="{A62DE21F-3F3F-418A-8685-52A6B7713FFD}"/>
+              </a:ext>
+            </a:extLst>
+          </p:cNvPr>
+          <p:cNvSpPr>
+            <a:spLocks xmlns:a="http://schemas.openxmlformats.org/drawingml/2006/main" noGrp="1"/>
+          </p:cNvSpPr>
+          <p:nvPr/>
+        </p:nvSpPr>
+        <p:spPr>
+          <a:xfrm xmlns:a="http://schemas.openxmlformats.org/drawingml/2006/main">
+            <a:off x="828675" y="2933700"/>
+            <a:ext cx="3333750" cy="514350"/>
+          </a:xfrm>
+          <a:prstGeom xmlns:a="http://schemas.openxmlformats.org/drawingml/2006/main" prst="rect">
+            <a:avLst/>
+          </a:prstGeom>
+          <a:noFill xmlns:a="http://schemas.openxmlformats.org/drawingml/2006/main"/>
+          <a:ln xmlns:a="http://schemas.openxmlformats.org/drawingml/2006/main" w="0">
+            <a:noFill/>
+          </a:ln>
+        </p:spPr>
+        <p:txBody>
+          <a:bodyPr xmlns:a="http://schemas.openxmlformats.org/drawingml/2006/main" wrap="square" lIns="0" tIns="0" rIns="0" bIns="0">
+            <a:noAutofit/>
+          </a:bodyPr>
+          <a:lstStyle xmlns:a="http://schemas.openxmlformats.org/drawingml/2006/main"/>
+          <a:p xmlns:a="http://schemas.openxmlformats.org/drawingml/2006/main">
+            <a:pPr>
+              <a:defRPr sz="2550" b="1">
+                <a:solidFill>
+                  <a:srgbClr val="156E58"/>
+                </a:solidFill>
+                <a:latin typeface="Apple SD Gothic Neo"/>
+                <a:ea typeface="Apple SD Gothic Neo"/>
+                <a:cs typeface="Apple SD Gothic Neo"/>
+              </a:defRPr>
+            </a:pPr>
+            <a:r>
+              <a:rPr sz="2550" b="1">
+                <a:solidFill>
+                  <a:srgbClr val="156E58"/>
+                </a:solidFill>
+                <a:latin typeface="Apple SD Gothic Neo"/>
+                <a:ea typeface="Apple SD Gothic Neo"/>
+                <a:cs typeface="Apple SD Gothic Neo"/>
+              </a:rPr>
+              <a:t>URL 입력</a:t>
+            </a:r>
+          </a:p>
+        </p:txBody>
+      </p:sp>
+      <p:sp>
+        <p:nvSpPr>
+          <p:cNvPr id="7" name="">
+            <a:extLst xmlns:a="http://schemas.openxmlformats.org/drawingml/2006/main">
+              <a:ext uri="{FF2B5EF4-FFF2-40B4-BE49-F238E27FC236}">
+                <a16:creationId xmlns:a16="http://schemas.microsoft.com/office/drawing/2014/main" id="{C3509B7B-505E-46A4-9F51-C0D95A575031}"/>
+              </a:ext>
+            </a:extLst>
+          </p:cNvPr>
+          <p:cNvSpPr>
+            <a:spLocks xmlns:a="http://schemas.openxmlformats.org/drawingml/2006/main" noGrp="1"/>
+          </p:cNvSpPr>
+          <p:nvPr/>
+        </p:nvSpPr>
+        <p:spPr>
+          <a:xfrm xmlns:a="http://schemas.openxmlformats.org/drawingml/2006/main">
+            <a:off x="828675" y="3676650"/>
+            <a:ext cx="3333750" cy="1066800"/>
+          </a:xfrm>
+          <a:prstGeom xmlns:a="http://schemas.openxmlformats.org/drawingml/2006/main" prst="rect">
+            <a:avLst/>
+          </a:prstGeom>
+          <a:noFill xmlns:a="http://schemas.openxmlformats.org/drawingml/2006/main"/>
+          <a:ln xmlns:a="http://schemas.openxmlformats.org/drawingml/2006/main" w="0">
+            <a:noFill/>
+          </a:ln>
+        </p:spPr>
+        <p:txBody>
+          <a:bodyPr xmlns:a="http://schemas.openxmlformats.org/drawingml/2006/main" wrap="square" lIns="0" tIns="0" rIns="0" bIns="0">
+            <a:noAutofit/>
+          </a:bodyPr>
+          <a:lstStyle xmlns:a="http://schemas.openxmlformats.org/drawingml/2006/main"/>
+          <a:p xmlns:a="http://schemas.openxmlformats.org/drawingml/2006/main">
+            <a:pPr>
+              <a:defRPr sz="2250" b="0">
+                <a:solidFill>
+                  <a:srgbClr val="182C29"/>
+                </a:solidFill>
+                <a:latin typeface="Apple SD Gothic Neo"/>
+                <a:ea typeface="Apple SD Gothic Neo"/>
+                <a:cs typeface="Apple SD Gothic Neo"/>
+              </a:defRPr>
+            </a:pPr>
+            <a:r>
+              <a:rPr sz="2250" b="0">
+                <a:solidFill>
+                  <a:srgbClr val="182C29"/>
+                </a:solidFill>
+                <a:latin typeface="Apple SD Gothic Neo"/>
+                <a:ea typeface="Apple SD Gothic Neo"/>
+                <a:cs typeface="Apple SD Gothic Neo"/>
+              </a:rPr>
+              <a:t>상품 링크 하나로</a:t>
+            </a:r>
+          </a:p>
+          <a:p xmlns:a="http://schemas.openxmlformats.org/drawingml/2006/main">
+            <a:pPr>
+              <a:defRPr sz="2250" b="0">
+                <a:solidFill>
+                  <a:srgbClr val="182C29"/>
+                </a:solidFill>
+                <a:latin typeface="Apple SD Gothic Neo"/>
+                <a:ea typeface="Apple SD Gothic Neo"/>
+                <a:cs typeface="Apple SD Gothic Neo"/>
+              </a:defRPr>
+            </a:pPr>
+            <a:r>
+              <a:rPr sz="2250" b="0">
+                <a:solidFill>
+                  <a:srgbClr val="182C29"/>
+                </a:solidFill>
+                <a:latin typeface="Apple SD Gothic Neo"/>
+                <a:ea typeface="Apple SD Gothic Neo"/>
+                <a:cs typeface="Apple SD Gothic Neo"/>
+              </a:rPr>
+              <a:t>분석을 시작합니다.</a:t>
+            </a:r>
+          </a:p>
+        </p:txBody>
+      </p:sp>
+      <p:sp>
+        <p:nvSpPr>
+          <p:cNvPr id="8" name="">
+            <a:extLst xmlns:a="http://schemas.openxmlformats.org/drawingml/2006/main">
+              <a:ext uri="{FF2B5EF4-FFF2-40B4-BE49-F238E27FC236}">
+                <a16:creationId xmlns:a16="http://schemas.microsoft.com/office/drawing/2014/main" id="{A19C1BBF-AF54-4FA8-A18A-93A7268FBC4E}"/>
+              </a:ext>
+            </a:extLst>
+          </p:cNvPr>
+          <p:cNvSpPr>
+            <a:spLocks xmlns:a="http://schemas.openxmlformats.org/drawingml/2006/main" noGrp="1"/>
+          </p:cNvSpPr>
+          <p:nvPr/>
+        </p:nvSpPr>
+        <p:spPr>
+          <a:xfrm xmlns:a="http://schemas.openxmlformats.org/drawingml/2006/main">
+            <a:off x="10953750" y="4810125"/>
+            <a:ext cx="3333750" cy="514350"/>
+          </a:xfrm>
+          <a:prstGeom xmlns:a="http://schemas.openxmlformats.org/drawingml/2006/main" prst="rect">
+            <a:avLst/>
+          </a:prstGeom>
+          <a:noFill xmlns:a="http://schemas.openxmlformats.org/drawingml/2006/main"/>
+          <a:ln xmlns:a="http://schemas.openxmlformats.org/drawingml/2006/main" w="0">
+            <a:noFill/>
+          </a:ln>
+        </p:spPr>
+        <p:txBody>
+          <a:bodyPr xmlns:a="http://schemas.openxmlformats.org/drawingml/2006/main" wrap="square" lIns="0" tIns="0" rIns="0" bIns="0">
+            <a:noAutofit/>
+          </a:bodyPr>
+          <a:lstStyle xmlns:a="http://schemas.openxmlformats.org/drawingml/2006/main"/>
+          <a:p xmlns:a="http://schemas.openxmlformats.org/drawingml/2006/main">
+            <a:pPr>
+              <a:defRPr sz="2550" b="1">
+                <a:solidFill>
+                  <a:srgbClr val="156E58"/>
+                </a:solidFill>
+                <a:latin typeface="Apple SD Gothic Neo"/>
+                <a:ea typeface="Apple SD Gothic Neo"/>
+                <a:cs typeface="Apple SD Gothic Neo"/>
+              </a:defRPr>
+            </a:pPr>
+            <a:r>
+              <a:rPr sz="2550" b="1">
+                <a:solidFill>
+                  <a:srgbClr val="156E58"/>
+                </a:solidFill>
+                <a:latin typeface="Apple SD Gothic Neo"/>
+                <a:ea typeface="Apple SD Gothic Neo"/>
+                <a:cs typeface="Apple SD Gothic Neo"/>
+              </a:rPr>
+              <a:t>결과 확인</a:t>
+            </a:r>
+          </a:p>
+        </p:txBody>
+      </p:sp>
+      <p:sp>
+        <p:nvSpPr>
+          <p:cNvPr id="9" name="">
+            <a:extLst xmlns:a="http://schemas.openxmlformats.org/drawingml/2006/main">
+              <a:ext uri="{FF2B5EF4-FFF2-40B4-BE49-F238E27FC236}">
+                <a16:creationId xmlns:a16="http://schemas.microsoft.com/office/drawing/2014/main" id="{8E9C0905-2326-45CD-A339-86F0687C8062}"/>
+              </a:ext>
+            </a:extLst>
+          </p:cNvPr>
+          <p:cNvSpPr>
+            <a:spLocks xmlns:a="http://schemas.openxmlformats.org/drawingml/2006/main" noGrp="1"/>
+          </p:cNvSpPr>
+          <p:nvPr/>
+        </p:nvSpPr>
+        <p:spPr>
+          <a:xfrm xmlns:a="http://schemas.openxmlformats.org/drawingml/2006/main">
+            <a:off x="10953750" y="5562600"/>
+            <a:ext cx="3333750" cy="1362075"/>
+          </a:xfrm>
+          <a:prstGeom xmlns:a="http://schemas.openxmlformats.org/drawingml/2006/main" prst="rect">
+            <a:avLst/>
+          </a:prstGeom>
+          <a:noFill xmlns:a="http://schemas.openxmlformats.org/drawingml/2006/main"/>
+          <a:ln xmlns:a="http://schemas.openxmlformats.org/drawingml/2006/main" w="0">
+            <a:noFill/>
+          </a:ln>
+        </p:spPr>
+        <p:txBody>
+          <a:bodyPr xmlns:a="http://schemas.openxmlformats.org/drawingml/2006/main" wrap="square" lIns="0" tIns="0" rIns="0" bIns="0">
+            <a:noAutofit/>
+          </a:bodyPr>
+          <a:lstStyle xmlns:a="http://schemas.openxmlformats.org/drawingml/2006/main"/>
+          <a:p xmlns:a="http://schemas.openxmlformats.org/drawingml/2006/main">
+            <a:pPr>
+              <a:defRPr sz="2250" b="0">
+                <a:solidFill>
+                  <a:srgbClr val="182C29"/>
+                </a:solidFill>
+                <a:latin typeface="Apple SD Gothic Neo"/>
+                <a:ea typeface="Apple SD Gothic Neo"/>
+                <a:cs typeface="Apple SD Gothic Neo"/>
+              </a:defRPr>
+            </a:pPr>
+            <a:r>
+              <a:rPr sz="2250" b="0">
+                <a:solidFill>
+                  <a:srgbClr val="182C29"/>
+                </a:solidFill>
+                <a:latin typeface="Apple SD Gothic Neo"/>
+                <a:ea typeface="Apple SD Gothic Neo"/>
+                <a:cs typeface="Apple SD Gothic Neo"/>
+              </a:rPr>
+              <a:t>상품·배송·세금과</a:t>
+            </a:r>
+          </a:p>
+          <a:p xmlns:a="http://schemas.openxmlformats.org/drawingml/2006/main">
+            <a:pPr>
+              <a:defRPr sz="2250" b="0">
+                <a:solidFill>
+                  <a:srgbClr val="182C29"/>
+                </a:solidFill>
+                <a:latin typeface="Apple SD Gothic Neo"/>
+                <a:ea typeface="Apple SD Gothic Neo"/>
+                <a:cs typeface="Apple SD Gothic Neo"/>
+              </a:defRPr>
+            </a:pPr>
+            <a:r>
+              <a:rPr sz="2250" b="0">
+                <a:solidFill>
+                  <a:srgbClr val="182C29"/>
+                </a:solidFill>
+                <a:latin typeface="Apple SD Gothic Neo"/>
+                <a:ea typeface="Apple SD Gothic Neo"/>
+                <a:cs typeface="Apple SD Gothic Neo"/>
+              </a:rPr>
+              <a:t>미확인 조건을</a:t>
+            </a:r>
+          </a:p>
+          <a:p xmlns:a="http://schemas.openxmlformats.org/drawingml/2006/main">
+            <a:pPr>
+              <a:defRPr sz="2250" b="0">
+                <a:solidFill>
+                  <a:srgbClr val="182C29"/>
+                </a:solidFill>
+                <a:latin typeface="Apple SD Gothic Neo"/>
+                <a:ea typeface="Apple SD Gothic Neo"/>
+                <a:cs typeface="Apple SD Gothic Neo"/>
+              </a:defRPr>
+            </a:pPr>
+            <a:r>
+              <a:rPr sz="2250" b="0">
+                <a:solidFill>
+                  <a:srgbClr val="182C29"/>
+                </a:solidFill>
+                <a:latin typeface="Apple SD Gothic Neo"/>
+                <a:ea typeface="Apple SD Gothic Neo"/>
+                <a:cs typeface="Apple SD Gothic Neo"/>
+              </a:rPr>
+              <a:t>함께 표시합니다.</a:t>
+            </a:r>
+          </a:p>
+        </p:txBody>
+      </p:sp>
     </p:spTree>
     <p:extLst>
       <p:ext uri="{BB962C8B-B14F-4D97-AF65-F5344CB8AC3E}">
-        <p14:creationId xmlns:p14="http://schemas.microsoft.com/office/powerpoint/2010/main" val="699896095"/>
+        <p14:creationId xmlns:p14="http://schemas.microsoft.com/office/powerpoint/2010/main" val="439513403"/>
       </p:ext>
     </p:extLst>
   </p:cSld>
@@ -2707,7 +2982,7 @@
           <p:cNvPr id="14" name="">
             <a:extLst xmlns:a="http://schemas.openxmlformats.org/drawingml/2006/main">
               <a:ext uri="{FF2B5EF4-FFF2-40B4-BE49-F238E27FC236}">
-                <a16:creationId xmlns:a16="http://schemas.microsoft.com/office/drawing/2014/main" id="{517FB652-4021-4692-920D-E112EF002DC8}"/>
+                <a16:creationId xmlns:a16="http://schemas.microsoft.com/office/drawing/2014/main" id="{22CD7D1D-B87F-48C5-9567-AC5A944D56EA}"/>
               </a:ext>
             </a:extLst>
           </p:cNvPr>
@@ -2764,7 +3039,7 @@
           <p:cNvPr id="2" name="">
             <a:extLst xmlns:a="http://schemas.openxmlformats.org/drawingml/2006/main">
               <a:ext uri="{FF2B5EF4-FFF2-40B4-BE49-F238E27FC236}">
-                <a16:creationId xmlns:a16="http://schemas.microsoft.com/office/drawing/2014/main" id="{D0938892-0B96-473D-BAFC-BF9C80780B51}"/>
+                <a16:creationId xmlns:a16="http://schemas.microsoft.com/office/drawing/2014/main" id="{5D6F607C-8858-4F98-8905-BFBFCDDE6F03}"/>
               </a:ext>
             </a:extLst>
           </p:cNvPr>
@@ -2821,7 +3096,7 @@
           <p:cNvPr id="3" name="">
             <a:extLst xmlns:a="http://schemas.openxmlformats.org/drawingml/2006/main">
               <a:ext uri="{FF2B5EF4-FFF2-40B4-BE49-F238E27FC236}">
-                <a16:creationId xmlns:a16="http://schemas.microsoft.com/office/drawing/2014/main" id="{9A7783CE-BA5B-4E4E-9220-E6BBAB2CF720}"/>
+                <a16:creationId xmlns:a16="http://schemas.microsoft.com/office/drawing/2014/main" id="{8B7DD3A4-60A9-4D63-B010-C300D77E046D}"/>
               </a:ext>
             </a:extLst>
           </p:cNvPr>
@@ -2878,7 +3153,7 @@
           <p:cNvPr id="4" name="">
             <a:extLst xmlns:a="http://schemas.openxmlformats.org/drawingml/2006/main">
               <a:ext uri="{FF2B5EF4-FFF2-40B4-BE49-F238E27FC236}">
-                <a16:creationId xmlns:a16="http://schemas.microsoft.com/office/drawing/2014/main" id="{3E4E9F05-5B3D-4DE1-AEA2-4CC9B7E80D9B}"/>
+                <a16:creationId xmlns:a16="http://schemas.microsoft.com/office/drawing/2014/main" id="{5832C99F-4237-4A7E-94DB-DEF6CA992FD9}"/>
               </a:ext>
             </a:extLst>
           </p:cNvPr>
@@ -2937,7 +3212,7 @@
           <p:cNvPr id="5" name="">
             <a:extLst xmlns:a="http://schemas.openxmlformats.org/drawingml/2006/main">
               <a:ext uri="{FF2B5EF4-FFF2-40B4-BE49-F238E27FC236}">
-                <a16:creationId xmlns:a16="http://schemas.microsoft.com/office/drawing/2014/main" id="{57D94D3B-317F-49BF-A2B7-57168A506247}"/>
+                <a16:creationId xmlns:a16="http://schemas.microsoft.com/office/drawing/2014/main" id="{9F3EF542-6523-47EC-BF32-F2E3C86A6544}"/>
               </a:ext>
             </a:extLst>
           </p:cNvPr>
@@ -3021,7 +3296,7 @@
           <p:cNvPr id="7" name="">
             <a:extLst xmlns:a="http://schemas.openxmlformats.org/drawingml/2006/main">
               <a:ext uri="{FF2B5EF4-FFF2-40B4-BE49-F238E27FC236}">
-                <a16:creationId xmlns:a16="http://schemas.microsoft.com/office/drawing/2014/main" id="{4E9E70B2-E3E6-4382-8607-2737DF47B61E}"/>
+                <a16:creationId xmlns:a16="http://schemas.microsoft.com/office/drawing/2014/main" id="{556CEF83-C72E-42F0-A7D4-9FD0AA7500CB}"/>
               </a:ext>
             </a:extLst>
           </p:cNvPr>
@@ -3105,7 +3380,7 @@
           <p:cNvPr id="9" name="">
             <a:extLst xmlns:a="http://schemas.openxmlformats.org/drawingml/2006/main">
               <a:ext uri="{FF2B5EF4-FFF2-40B4-BE49-F238E27FC236}">
-                <a16:creationId xmlns:a16="http://schemas.microsoft.com/office/drawing/2014/main" id="{2873444E-DE83-4626-89A9-196F524C5E5E}"/>
+                <a16:creationId xmlns:a16="http://schemas.microsoft.com/office/drawing/2014/main" id="{833234B9-F916-43DE-A879-5CD6AD3A67D1}"/>
               </a:ext>
             </a:extLst>
           </p:cNvPr>
@@ -3185,7 +3460,7 @@
           <p:cNvPr id="10" name="">
             <a:extLst xmlns:a="http://schemas.openxmlformats.org/drawingml/2006/main">
               <a:ext uri="{FF2B5EF4-FFF2-40B4-BE49-F238E27FC236}">
-                <a16:creationId xmlns:a16="http://schemas.microsoft.com/office/drawing/2014/main" id="{CCCEB5A9-60D8-47E7-BD7B-D6439F031050}"/>
+                <a16:creationId xmlns:a16="http://schemas.microsoft.com/office/drawing/2014/main" id="{2FD47B4E-2EB2-4DF2-B34F-D3A732CC3867}"/>
               </a:ext>
             </a:extLst>
           </p:cNvPr>
@@ -3265,7 +3540,7 @@
           <p:cNvPr id="11" name="">
             <a:extLst xmlns:a="http://schemas.openxmlformats.org/drawingml/2006/main">
               <a:ext uri="{FF2B5EF4-FFF2-40B4-BE49-F238E27FC236}">
-                <a16:creationId xmlns:a16="http://schemas.microsoft.com/office/drawing/2014/main" id="{3A1AD1E1-77BD-4BB3-9AAB-B0875C728899}"/>
+                <a16:creationId xmlns:a16="http://schemas.microsoft.com/office/drawing/2014/main" id="{472F6539-54B9-4DFF-9A03-43E5F41BD507}"/>
               </a:ext>
             </a:extLst>
           </p:cNvPr>
@@ -3345,7 +3620,7 @@
           <p:cNvPr id="12" name="">
             <a:extLst xmlns:a="http://schemas.openxmlformats.org/drawingml/2006/main">
               <a:ext uri="{FF2B5EF4-FFF2-40B4-BE49-F238E27FC236}">
-                <a16:creationId xmlns:a16="http://schemas.microsoft.com/office/drawing/2014/main" id="{17108BE5-2FDA-4CA1-BDC1-B43C3A41C8F5}"/>
+                <a16:creationId xmlns:a16="http://schemas.microsoft.com/office/drawing/2014/main" id="{0D932CE2-BC60-4AAE-AEAB-BB33682CA33E}"/>
               </a:ext>
             </a:extLst>
           </p:cNvPr>
@@ -3402,7 +3677,7 @@
           <p:cNvPr id="13" name="">
             <a:extLst xmlns:a="http://schemas.openxmlformats.org/drawingml/2006/main">
               <a:ext uri="{FF2B5EF4-FFF2-40B4-BE49-F238E27FC236}">
-                <a16:creationId xmlns:a16="http://schemas.microsoft.com/office/drawing/2014/main" id="{0A870FA5-7101-4D2E-9E7B-6B5B737E46CF}"/>
+                <a16:creationId xmlns:a16="http://schemas.microsoft.com/office/drawing/2014/main" id="{2C6793FD-A75A-4F07-9AF1-6AF68957C4F0}"/>
               </a:ext>
             </a:extLst>
           </p:cNvPr>
@@ -3457,7 +3732,7 @@
     </p:spTree>
     <p:extLst>
       <p:ext uri="{BB962C8B-B14F-4D97-AF65-F5344CB8AC3E}">
-        <p14:creationId xmlns:p14="http://schemas.microsoft.com/office/powerpoint/2010/main" val="971267627"/>
+        <p14:creationId xmlns:p14="http://schemas.microsoft.com/office/powerpoint/2010/main" val="1131018429"/>
       </p:ext>
     </p:extLst>
   </p:cSld>
@@ -3488,7 +3763,7 @@
           <p:cNvPr id="6" name="">
             <a:extLst xmlns:a="http://schemas.openxmlformats.org/drawingml/2006/main">
               <a:ext uri="{FF2B5EF4-FFF2-40B4-BE49-F238E27FC236}">
-                <a16:creationId xmlns:a16="http://schemas.microsoft.com/office/drawing/2014/main" id="{9C8F6AF3-E52B-49B6-8E50-57610BAEA11E}"/>
+                <a16:creationId xmlns:a16="http://schemas.microsoft.com/office/drawing/2014/main" id="{6C979A08-2890-4EA9-8B31-911AAA3968F6}"/>
               </a:ext>
             </a:extLst>
           </p:cNvPr>
@@ -3545,7 +3820,7 @@
           <p:cNvPr id="2" name="">
             <a:extLst xmlns:a="http://schemas.openxmlformats.org/drawingml/2006/main">
               <a:ext uri="{FF2B5EF4-FFF2-40B4-BE49-F238E27FC236}">
-                <a16:creationId xmlns:a16="http://schemas.microsoft.com/office/drawing/2014/main" id="{EFACF744-A4D7-4DEE-A32C-0EF2B2E93EDF}"/>
+                <a16:creationId xmlns:a16="http://schemas.microsoft.com/office/drawing/2014/main" id="{C5E0A375-9BAB-4C4C-A210-5F264E490623}"/>
               </a:ext>
             </a:extLst>
           </p:cNvPr>
@@ -3602,7 +3877,7 @@
           <p:cNvPr id="3" name="">
             <a:extLst xmlns:a="http://schemas.openxmlformats.org/drawingml/2006/main">
               <a:ext uri="{FF2B5EF4-FFF2-40B4-BE49-F238E27FC236}">
-                <a16:creationId xmlns:a16="http://schemas.microsoft.com/office/drawing/2014/main" id="{1BEECC56-242C-4A76-8802-4A684CC98A63}"/>
+                <a16:creationId xmlns:a16="http://schemas.microsoft.com/office/drawing/2014/main" id="{F5611793-AF7D-4AB7-B2FF-09EF7D15704B}"/>
               </a:ext>
             </a:extLst>
           </p:cNvPr>
@@ -4204,7 +4479,7 @@
           <p:cNvPr id="5" name="">
             <a:extLst xmlns:a="http://schemas.openxmlformats.org/drawingml/2006/main">
               <a:ext uri="{FF2B5EF4-FFF2-40B4-BE49-F238E27FC236}">
-                <a16:creationId xmlns:a16="http://schemas.microsoft.com/office/drawing/2014/main" id="{F2217FB4-3948-43AF-94A3-E851F3AADBD6}"/>
+                <a16:creationId xmlns:a16="http://schemas.microsoft.com/office/drawing/2014/main" id="{4B4D02A1-2DD4-4CDC-9A03-47E8D7955656}"/>
               </a:ext>
             </a:extLst>
           </p:cNvPr>
@@ -4259,7 +4534,7 @@
     </p:spTree>
     <p:extLst>
       <p:ext uri="{BB962C8B-B14F-4D97-AF65-F5344CB8AC3E}">
-        <p14:creationId xmlns:p14="http://schemas.microsoft.com/office/powerpoint/2010/main" val="1325063100"/>
+        <p14:creationId xmlns:p14="http://schemas.microsoft.com/office/powerpoint/2010/main" val="876471258"/>
       </p:ext>
     </p:extLst>
   </p:cSld>
@@ -4290,7 +4565,7 @@
           <p:cNvPr id="6" name="">
             <a:extLst xmlns:a="http://schemas.openxmlformats.org/drawingml/2006/main">
               <a:ext uri="{FF2B5EF4-FFF2-40B4-BE49-F238E27FC236}">
-                <a16:creationId xmlns:a16="http://schemas.microsoft.com/office/drawing/2014/main" id="{28C853B4-E666-4E60-BB37-956CC1D2E7A8}"/>
+                <a16:creationId xmlns:a16="http://schemas.microsoft.com/office/drawing/2014/main" id="{FFFD57E0-6F10-4CCC-999A-5124BB5002EC}"/>
               </a:ext>
             </a:extLst>
           </p:cNvPr>
@@ -4347,7 +4622,7 @@
           <p:cNvPr id="2" name="">
             <a:extLst xmlns:a="http://schemas.openxmlformats.org/drawingml/2006/main">
               <a:ext uri="{FF2B5EF4-FFF2-40B4-BE49-F238E27FC236}">
-                <a16:creationId xmlns:a16="http://schemas.microsoft.com/office/drawing/2014/main" id="{2207DB3A-8018-45FF-9B49-448849C828E7}"/>
+                <a16:creationId xmlns:a16="http://schemas.microsoft.com/office/drawing/2014/main" id="{F3BD82A9-1E03-429E-959C-B3F8DC4A91B2}"/>
               </a:ext>
             </a:extLst>
           </p:cNvPr>
@@ -4404,7 +4679,7 @@
           <p:cNvPr id="3" name="">
             <a:extLst xmlns:a="http://schemas.openxmlformats.org/drawingml/2006/main">
               <a:ext uri="{FF2B5EF4-FFF2-40B4-BE49-F238E27FC236}">
-                <a16:creationId xmlns:a16="http://schemas.microsoft.com/office/drawing/2014/main" id="{06BCA441-3264-4701-A25C-C297AC31996C}"/>
+                <a16:creationId xmlns:a16="http://schemas.microsoft.com/office/drawing/2014/main" id="{2A96673B-429A-4B2D-BD77-889ADB23A012}"/>
               </a:ext>
             </a:extLst>
           </p:cNvPr>
@@ -4659,7 +4934,7 @@
           <p:cNvPr id="5" name="">
             <a:extLst xmlns:a="http://schemas.openxmlformats.org/drawingml/2006/main">
               <a:ext uri="{FF2B5EF4-FFF2-40B4-BE49-F238E27FC236}">
-                <a16:creationId xmlns:a16="http://schemas.microsoft.com/office/drawing/2014/main" id="{736A9A7B-3B9C-4F2F-9990-4A86DD2FCD18}"/>
+                <a16:creationId xmlns:a16="http://schemas.microsoft.com/office/drawing/2014/main" id="{E5639BFD-1763-47E8-93F4-D8F54E855102}"/>
               </a:ext>
             </a:extLst>
           </p:cNvPr>
@@ -4737,7 +5012,7 @@
     </p:spTree>
     <p:extLst>
       <p:ext uri="{BB962C8B-B14F-4D97-AF65-F5344CB8AC3E}">
-        <p14:creationId xmlns:p14="http://schemas.microsoft.com/office/powerpoint/2010/main" val="1156799079"/>
+        <p14:creationId xmlns:p14="http://schemas.microsoft.com/office/powerpoint/2010/main" val="91174372"/>
       </p:ext>
     </p:extLst>
   </p:cSld>
@@ -4768,7 +5043,7 @@
           <p:cNvPr id="10" name="">
             <a:extLst xmlns:a="http://schemas.openxmlformats.org/drawingml/2006/main">
               <a:ext uri="{FF2B5EF4-FFF2-40B4-BE49-F238E27FC236}">
-                <a16:creationId xmlns:a16="http://schemas.microsoft.com/office/drawing/2014/main" id="{4A91C320-A551-49C6-BACB-BF1D59C5F397}"/>
+                <a16:creationId xmlns:a16="http://schemas.microsoft.com/office/drawing/2014/main" id="{C95226CF-0C1F-40E4-B646-8EFFA88A9ACC}"/>
               </a:ext>
             </a:extLst>
           </p:cNvPr>
@@ -4825,7 +5100,7 @@
           <p:cNvPr id="2" name="">
             <a:extLst xmlns:a="http://schemas.openxmlformats.org/drawingml/2006/main">
               <a:ext uri="{FF2B5EF4-FFF2-40B4-BE49-F238E27FC236}">
-                <a16:creationId xmlns:a16="http://schemas.microsoft.com/office/drawing/2014/main" id="{04220C71-F1E2-4331-A3DB-1F87E91E7800}"/>
+                <a16:creationId xmlns:a16="http://schemas.microsoft.com/office/drawing/2014/main" id="{85C4CF2B-ECD4-4131-8D0A-38412187103A}"/>
               </a:ext>
             </a:extLst>
           </p:cNvPr>
@@ -4882,7 +5157,7 @@
           <p:cNvPr id="3" name="">
             <a:extLst xmlns:a="http://schemas.openxmlformats.org/drawingml/2006/main">
               <a:ext uri="{FF2B5EF4-FFF2-40B4-BE49-F238E27FC236}">
-                <a16:creationId xmlns:a16="http://schemas.microsoft.com/office/drawing/2014/main" id="{E06F7CBF-4D02-436D-BC04-B7552F552264}"/>
+                <a16:creationId xmlns:a16="http://schemas.microsoft.com/office/drawing/2014/main" id="{56E285A0-7249-4BAC-9802-B718FDBA55D0}"/>
               </a:ext>
             </a:extLst>
           </p:cNvPr>
@@ -4939,7 +5214,7 @@
           <p:cNvPr id="4" name="">
             <a:extLst xmlns:a="http://schemas.openxmlformats.org/drawingml/2006/main">
               <a:ext uri="{FF2B5EF4-FFF2-40B4-BE49-F238E27FC236}">
-                <a16:creationId xmlns:a16="http://schemas.microsoft.com/office/drawing/2014/main" id="{CCE6F7FB-D172-4971-A4C9-B2C0F4B75D5A}"/>
+                <a16:creationId xmlns:a16="http://schemas.microsoft.com/office/drawing/2014/main" id="{ACCDE519-14A1-4108-9B51-2926B4037D38}"/>
               </a:ext>
             </a:extLst>
           </p:cNvPr>
@@ -4996,7 +5271,7 @@
           <p:cNvPr id="5" name="">
             <a:extLst xmlns:a="http://schemas.openxmlformats.org/drawingml/2006/main">
               <a:ext uri="{FF2B5EF4-FFF2-40B4-BE49-F238E27FC236}">
-                <a16:creationId xmlns:a16="http://schemas.microsoft.com/office/drawing/2014/main" id="{56F055E8-09F3-4AF7-8423-83BBF1D0BA5C}"/>
+                <a16:creationId xmlns:a16="http://schemas.microsoft.com/office/drawing/2014/main" id="{3DBFC4D8-C4A5-4A6C-A088-C8C4902EA747}"/>
               </a:ext>
             </a:extLst>
           </p:cNvPr>
@@ -5127,7 +5402,7 @@
           <p:cNvPr id="6" name="">
             <a:extLst xmlns:a="http://schemas.openxmlformats.org/drawingml/2006/main">
               <a:ext uri="{FF2B5EF4-FFF2-40B4-BE49-F238E27FC236}">
-                <a16:creationId xmlns:a16="http://schemas.microsoft.com/office/drawing/2014/main" id="{DAE847F7-75B9-4D87-8DC0-26B2EF6BD14C}"/>
+                <a16:creationId xmlns:a16="http://schemas.microsoft.com/office/drawing/2014/main" id="{78BEE8D0-DBFB-4B26-A5B7-DAF1A5368745}"/>
               </a:ext>
             </a:extLst>
           </p:cNvPr>
@@ -5184,7 +5459,7 @@
           <p:cNvPr id="7" name="">
             <a:extLst xmlns:a="http://schemas.openxmlformats.org/drawingml/2006/main">
               <a:ext uri="{FF2B5EF4-FFF2-40B4-BE49-F238E27FC236}">
-                <a16:creationId xmlns:a16="http://schemas.microsoft.com/office/drawing/2014/main" id="{BAFF3D53-0FDD-4CF9-9F74-F706EAA262E9}"/>
+                <a16:creationId xmlns:a16="http://schemas.microsoft.com/office/drawing/2014/main" id="{901D5840-2241-4F37-B3AB-87C9A827086F}"/>
               </a:ext>
             </a:extLst>
           </p:cNvPr>
@@ -5315,7 +5590,7 @@
           <p:cNvPr id="8" name="">
             <a:extLst xmlns:a="http://schemas.openxmlformats.org/drawingml/2006/main">
               <a:ext uri="{FF2B5EF4-FFF2-40B4-BE49-F238E27FC236}">
-                <a16:creationId xmlns:a16="http://schemas.microsoft.com/office/drawing/2014/main" id="{D4FE2287-CA90-4C1B-AF77-7DC0220EDAE7}"/>
+                <a16:creationId xmlns:a16="http://schemas.microsoft.com/office/drawing/2014/main" id="{971292D4-7E6C-448E-BF0B-136D44C0F6A6}"/>
               </a:ext>
             </a:extLst>
           </p:cNvPr>
@@ -5395,7 +5670,7 @@
           <p:cNvPr id="9" name="">
             <a:extLst xmlns:a="http://schemas.openxmlformats.org/drawingml/2006/main">
               <a:ext uri="{FF2B5EF4-FFF2-40B4-BE49-F238E27FC236}">
-                <a16:creationId xmlns:a16="http://schemas.microsoft.com/office/drawing/2014/main" id="{73F9EB4A-8BCC-4D05-A6CF-273E287A5DBB}"/>
+                <a16:creationId xmlns:a16="http://schemas.microsoft.com/office/drawing/2014/main" id="{DCE36CC2-DA7F-4BE2-B8B7-64852677E5A2}"/>
               </a:ext>
             </a:extLst>
           </p:cNvPr>
@@ -5450,7 +5725,7 @@
     </p:spTree>
     <p:extLst>
       <p:ext uri="{BB962C8B-B14F-4D97-AF65-F5344CB8AC3E}">
-        <p14:creationId xmlns:p14="http://schemas.microsoft.com/office/powerpoint/2010/main" val="1150575772"/>
+        <p14:creationId xmlns:p14="http://schemas.microsoft.com/office/powerpoint/2010/main" val="369958478"/>
       </p:ext>
     </p:extLst>
   </p:cSld>
@@ -5481,7 +5756,7 @@
           <p:cNvPr id="12" name="">
             <a:extLst xmlns:a="http://schemas.openxmlformats.org/drawingml/2006/main">
               <a:ext uri="{FF2B5EF4-FFF2-40B4-BE49-F238E27FC236}">
-                <a16:creationId xmlns:a16="http://schemas.microsoft.com/office/drawing/2014/main" id="{21F3B2D2-DC9C-4E7E-8DBF-B1B3812095F9}"/>
+                <a16:creationId xmlns:a16="http://schemas.microsoft.com/office/drawing/2014/main" id="{F9DAD197-03A8-4C57-87DE-A97DFC199D78}"/>
               </a:ext>
             </a:extLst>
           </p:cNvPr>
@@ -5538,7 +5813,7 @@
           <p:cNvPr id="2" name="">
             <a:extLst xmlns:a="http://schemas.openxmlformats.org/drawingml/2006/main">
               <a:ext uri="{FF2B5EF4-FFF2-40B4-BE49-F238E27FC236}">
-                <a16:creationId xmlns:a16="http://schemas.microsoft.com/office/drawing/2014/main" id="{71F404E7-7DD1-4DB3-96F6-9FBA1F0CF924}"/>
+                <a16:creationId xmlns:a16="http://schemas.microsoft.com/office/drawing/2014/main" id="{60906E02-A0C5-430A-B17B-54B07ED767BD}"/>
               </a:ext>
             </a:extLst>
           </p:cNvPr>
@@ -5595,7 +5870,7 @@
           <p:cNvPr id="3" name="">
             <a:extLst xmlns:a="http://schemas.openxmlformats.org/drawingml/2006/main">
               <a:ext uri="{FF2B5EF4-FFF2-40B4-BE49-F238E27FC236}">
-                <a16:creationId xmlns:a16="http://schemas.microsoft.com/office/drawing/2014/main" id="{DC891B68-C334-43FE-8FAD-08DB719AE8FF}"/>
+                <a16:creationId xmlns:a16="http://schemas.microsoft.com/office/drawing/2014/main" id="{6EFF224B-9734-46C6-B47B-F0A844F92293}"/>
               </a:ext>
             </a:extLst>
           </p:cNvPr>
@@ -5652,7 +5927,7 @@
           <p:cNvPr id="4" name="">
             <a:extLst xmlns:a="http://schemas.openxmlformats.org/drawingml/2006/main">
               <a:ext uri="{FF2B5EF4-FFF2-40B4-BE49-F238E27FC236}">
-                <a16:creationId xmlns:a16="http://schemas.microsoft.com/office/drawing/2014/main" id="{9A5C8ACA-A625-4520-83B8-5DD7ADB91F20}"/>
+                <a16:creationId xmlns:a16="http://schemas.microsoft.com/office/drawing/2014/main" id="{4EA24EF9-B957-44C6-8CCE-B359ECC06221}"/>
               </a:ext>
             </a:extLst>
           </p:cNvPr>
@@ -5732,7 +6007,7 @@
           <p:cNvPr id="5" name="">
             <a:extLst xmlns:a="http://schemas.openxmlformats.org/drawingml/2006/main">
               <a:ext uri="{FF2B5EF4-FFF2-40B4-BE49-F238E27FC236}">
-                <a16:creationId xmlns:a16="http://schemas.microsoft.com/office/drawing/2014/main" id="{AF5F1826-4A87-47D0-B36D-C870BB4AC778}"/>
+                <a16:creationId xmlns:a16="http://schemas.microsoft.com/office/drawing/2014/main" id="{B6D85511-AD2A-497A-88EF-90626904BE3B}"/>
               </a:ext>
             </a:extLst>
           </p:cNvPr>
@@ -5791,7 +6066,7 @@
           <p:cNvPr id="6" name="">
             <a:extLst xmlns:a="http://schemas.openxmlformats.org/drawingml/2006/main">
               <a:ext uri="{FF2B5EF4-FFF2-40B4-BE49-F238E27FC236}">
-                <a16:creationId xmlns:a16="http://schemas.microsoft.com/office/drawing/2014/main" id="{01E48FAC-6A4D-42C5-ADA1-4776A4FFAAEF}"/>
+                <a16:creationId xmlns:a16="http://schemas.microsoft.com/office/drawing/2014/main" id="{58842B3A-25CC-45D8-B811-CC10566AD5AD}"/>
               </a:ext>
             </a:extLst>
           </p:cNvPr>
@@ -5875,7 +6150,7 @@
           <p:cNvPr id="8" name="">
             <a:extLst xmlns:a="http://schemas.openxmlformats.org/drawingml/2006/main">
               <a:ext uri="{FF2B5EF4-FFF2-40B4-BE49-F238E27FC236}">
-                <a16:creationId xmlns:a16="http://schemas.microsoft.com/office/drawing/2014/main" id="{29E1FEB9-4F05-4F58-8E61-16E39F5710AD}"/>
+                <a16:creationId xmlns:a16="http://schemas.microsoft.com/office/drawing/2014/main" id="{0BF86D05-63E7-42DC-85A7-3B6A6B78B813}"/>
               </a:ext>
             </a:extLst>
           </p:cNvPr>
@@ -5959,7 +6234,7 @@
           <p:cNvPr id="10" name="">
             <a:extLst xmlns:a="http://schemas.openxmlformats.org/drawingml/2006/main">
               <a:ext uri="{FF2B5EF4-FFF2-40B4-BE49-F238E27FC236}">
-                <a16:creationId xmlns:a16="http://schemas.microsoft.com/office/drawing/2014/main" id="{78F0FA87-A967-403A-9222-9FAD52B6BAE9}"/>
+                <a16:creationId xmlns:a16="http://schemas.microsoft.com/office/drawing/2014/main" id="{53AF1013-B976-4C95-8B81-E4297613DE4E}"/>
               </a:ext>
             </a:extLst>
           </p:cNvPr>
@@ -6062,7 +6337,7 @@
           <p:cNvPr id="11" name="">
             <a:extLst xmlns:a="http://schemas.openxmlformats.org/drawingml/2006/main">
               <a:ext uri="{FF2B5EF4-FFF2-40B4-BE49-F238E27FC236}">
-                <a16:creationId xmlns:a16="http://schemas.microsoft.com/office/drawing/2014/main" id="{FEC8054B-81E1-46F9-AA44-0527AE152656}"/>
+                <a16:creationId xmlns:a16="http://schemas.microsoft.com/office/drawing/2014/main" id="{5BEACE2D-1122-4767-B05A-1440CBAA5CD4}"/>
               </a:ext>
             </a:extLst>
           </p:cNvPr>
@@ -6117,7 +6392,7 @@
     </p:spTree>
     <p:extLst>
       <p:ext uri="{BB962C8B-B14F-4D97-AF65-F5344CB8AC3E}">
-        <p14:creationId xmlns:p14="http://schemas.microsoft.com/office/powerpoint/2010/main" val="853696612"/>
+        <p14:creationId xmlns:p14="http://schemas.microsoft.com/office/powerpoint/2010/main" val="1275888574"/>
       </p:ext>
     </p:extLst>
   </p:cSld>
@@ -6148,7 +6423,7 @@
           <p:cNvPr id="9" name="">
             <a:extLst xmlns:a="http://schemas.openxmlformats.org/drawingml/2006/main">
               <a:ext uri="{FF2B5EF4-FFF2-40B4-BE49-F238E27FC236}">
-                <a16:creationId xmlns:a16="http://schemas.microsoft.com/office/drawing/2014/main" id="{F5D5D352-4493-4AA8-BF89-C764A1107939}"/>
+                <a16:creationId xmlns:a16="http://schemas.microsoft.com/office/drawing/2014/main" id="{BEC5C470-6702-4762-A7DB-AEE2D9051B4C}"/>
               </a:ext>
             </a:extLst>
           </p:cNvPr>
@@ -6205,7 +6480,7 @@
           <p:cNvPr id="2" name="">
             <a:extLst xmlns:a="http://schemas.openxmlformats.org/drawingml/2006/main">
               <a:ext uri="{FF2B5EF4-FFF2-40B4-BE49-F238E27FC236}">
-                <a16:creationId xmlns:a16="http://schemas.microsoft.com/office/drawing/2014/main" id="{5C481E78-38AD-4C1A-9D51-D3CB16A8F39B}"/>
+                <a16:creationId xmlns:a16="http://schemas.microsoft.com/office/drawing/2014/main" id="{DADF22E1-BE84-4CBE-9701-845143390288}"/>
               </a:ext>
             </a:extLst>
           </p:cNvPr>
@@ -6262,7 +6537,7 @@
           <p:cNvPr id="3" name="">
             <a:extLst xmlns:a="http://schemas.openxmlformats.org/drawingml/2006/main">
               <a:ext uri="{FF2B5EF4-FFF2-40B4-BE49-F238E27FC236}">
-                <a16:creationId xmlns:a16="http://schemas.microsoft.com/office/drawing/2014/main" id="{90DBFF93-C493-4DDA-B2EE-26380CD8076C}"/>
+                <a16:creationId xmlns:a16="http://schemas.microsoft.com/office/drawing/2014/main" id="{AA60264B-6638-4905-AA41-D2BAEB538400}"/>
               </a:ext>
             </a:extLst>
           </p:cNvPr>
@@ -6319,7 +6594,7 @@
           <p:cNvPr id="4" name="">
             <a:extLst xmlns:a="http://schemas.openxmlformats.org/drawingml/2006/main">
               <a:ext uri="{FF2B5EF4-FFF2-40B4-BE49-F238E27FC236}">
-                <a16:creationId xmlns:a16="http://schemas.microsoft.com/office/drawing/2014/main" id="{598BD0DA-13F6-47B5-A2F4-FB57851B561B}"/>
+                <a16:creationId xmlns:a16="http://schemas.microsoft.com/office/drawing/2014/main" id="{1030DB95-3856-439E-B6F2-5092A62D16D5}"/>
               </a:ext>
             </a:extLst>
           </p:cNvPr>
@@ -6376,7 +6651,7 @@
           <p:cNvPr id="5" name="">
             <a:extLst xmlns:a="http://schemas.openxmlformats.org/drawingml/2006/main">
               <a:ext uri="{FF2B5EF4-FFF2-40B4-BE49-F238E27FC236}">
-                <a16:creationId xmlns:a16="http://schemas.microsoft.com/office/drawing/2014/main" id="{A316CC9D-FD54-42B9-AA54-566D29EEF668}"/>
+                <a16:creationId xmlns:a16="http://schemas.microsoft.com/office/drawing/2014/main" id="{AEC16256-A9E3-4E97-9E53-2BF4E7E17E9B}"/>
               </a:ext>
             </a:extLst>
           </p:cNvPr>
@@ -6479,7 +6754,7 @@
           <p:cNvPr id="6" name="">
             <a:extLst xmlns:a="http://schemas.openxmlformats.org/drawingml/2006/main">
               <a:ext uri="{FF2B5EF4-FFF2-40B4-BE49-F238E27FC236}">
-                <a16:creationId xmlns:a16="http://schemas.microsoft.com/office/drawing/2014/main" id="{946F3D10-DDAC-44AA-8096-40AD6A099BD0}"/>
+                <a16:creationId xmlns:a16="http://schemas.microsoft.com/office/drawing/2014/main" id="{ACA4726E-2D24-44C5-BF92-D9B6B3877AB9}"/>
               </a:ext>
             </a:extLst>
           </p:cNvPr>
@@ -6536,7 +6811,7 @@
           <p:cNvPr id="7" name="">
             <a:extLst xmlns:a="http://schemas.openxmlformats.org/drawingml/2006/main">
               <a:ext uri="{FF2B5EF4-FFF2-40B4-BE49-F238E27FC236}">
-                <a16:creationId xmlns:a16="http://schemas.microsoft.com/office/drawing/2014/main" id="{108AA8DE-803A-423C-A737-880B8FA929A6}"/>
+                <a16:creationId xmlns:a16="http://schemas.microsoft.com/office/drawing/2014/main" id="{988C246A-89ED-4339-90D5-16EC40BE3A09}"/>
               </a:ext>
             </a:extLst>
           </p:cNvPr>
@@ -6639,7 +6914,7 @@
           <p:cNvPr id="8" name="">
             <a:extLst xmlns:a="http://schemas.openxmlformats.org/drawingml/2006/main">
               <a:ext uri="{FF2B5EF4-FFF2-40B4-BE49-F238E27FC236}">
-                <a16:creationId xmlns:a16="http://schemas.microsoft.com/office/drawing/2014/main" id="{D9A82072-1CF4-4B12-A061-C4DEC4136A10}"/>
+                <a16:creationId xmlns:a16="http://schemas.microsoft.com/office/drawing/2014/main" id="{083F8BB1-C249-4579-AF3D-06AD9046FD9F}"/>
               </a:ext>
             </a:extLst>
           </p:cNvPr>
@@ -6694,7 +6969,7 @@
     </p:spTree>
     <p:extLst>
       <p:ext uri="{BB962C8B-B14F-4D97-AF65-F5344CB8AC3E}">
-        <p14:creationId xmlns:p14="http://schemas.microsoft.com/office/powerpoint/2010/main" val="1222798734"/>
+        <p14:creationId xmlns:p14="http://schemas.microsoft.com/office/powerpoint/2010/main" val="291904468"/>
       </p:ext>
     </p:extLst>
   </p:cSld>
@@ -6725,7 +7000,7 @@
           <p:cNvPr id="6" name="">
             <a:extLst xmlns:a="http://schemas.openxmlformats.org/drawingml/2006/main">
               <a:ext uri="{FF2B5EF4-FFF2-40B4-BE49-F238E27FC236}">
-                <a16:creationId xmlns:a16="http://schemas.microsoft.com/office/drawing/2014/main" id="{CF95F803-E23C-41A0-A578-6FE6C93140A3}"/>
+                <a16:creationId xmlns:a16="http://schemas.microsoft.com/office/drawing/2014/main" id="{6EB83094-D456-4E4C-BE7A-E056D6F995B1}"/>
               </a:ext>
             </a:extLst>
           </p:cNvPr>
@@ -6782,7 +7057,7 @@
           <p:cNvPr id="2" name="">
             <a:extLst xmlns:a="http://schemas.openxmlformats.org/drawingml/2006/main">
               <a:ext uri="{FF2B5EF4-FFF2-40B4-BE49-F238E27FC236}">
-                <a16:creationId xmlns:a16="http://schemas.microsoft.com/office/drawing/2014/main" id="{5F223DEE-EC3B-4B41-AB5C-A7314BA3947C}"/>
+                <a16:creationId xmlns:a16="http://schemas.microsoft.com/office/drawing/2014/main" id="{B7FC84E2-1E50-4E7F-A5B0-B9DAD54BFE93}"/>
               </a:ext>
             </a:extLst>
           </p:cNvPr>
@@ -6839,7 +7114,7 @@
           <p:cNvPr id="3" name="">
             <a:extLst xmlns:a="http://schemas.openxmlformats.org/drawingml/2006/main">
               <a:ext uri="{FF2B5EF4-FFF2-40B4-BE49-F238E27FC236}">
-                <a16:creationId xmlns:a16="http://schemas.microsoft.com/office/drawing/2014/main" id="{7E3DA974-9A86-4E19-B69C-E5206092B456}"/>
+                <a16:creationId xmlns:a16="http://schemas.microsoft.com/office/drawing/2014/main" id="{82395CE2-7EB6-4D45-BADA-2A372134C827}"/>
               </a:ext>
             </a:extLst>
           </p:cNvPr>
@@ -7181,7 +7456,7 @@
           <p:cNvPr id="5" name="">
             <a:extLst xmlns:a="http://schemas.openxmlformats.org/drawingml/2006/main">
               <a:ext uri="{FF2B5EF4-FFF2-40B4-BE49-F238E27FC236}">
-                <a16:creationId xmlns:a16="http://schemas.microsoft.com/office/drawing/2014/main" id="{B16CCCF5-ABC6-4ACA-8864-927EC36FBEE7}"/>
+                <a16:creationId xmlns:a16="http://schemas.microsoft.com/office/drawing/2014/main" id="{EDB2AAAA-C857-455E-9AB2-B3BE183E7E88}"/>
               </a:ext>
             </a:extLst>
           </p:cNvPr>
@@ -7236,7 +7511,7 @@
     </p:spTree>
     <p:extLst>
       <p:ext uri="{BB962C8B-B14F-4D97-AF65-F5344CB8AC3E}">
-        <p14:creationId xmlns:p14="http://schemas.microsoft.com/office/powerpoint/2010/main" val="1888627377"/>
+        <p14:creationId xmlns:p14="http://schemas.microsoft.com/office/powerpoint/2010/main" val="290541428"/>
       </p:ext>
     </p:extLst>
   </p:cSld>
@@ -7267,7 +7542,7 @@
           <p:cNvPr id="7" name="">
             <a:extLst xmlns:a="http://schemas.openxmlformats.org/drawingml/2006/main">
               <a:ext uri="{FF2B5EF4-FFF2-40B4-BE49-F238E27FC236}">
-                <a16:creationId xmlns:a16="http://schemas.microsoft.com/office/drawing/2014/main" id="{D28E63C5-9ADD-4B6A-8B19-8A1AC4C742AA}"/>
+                <a16:creationId xmlns:a16="http://schemas.microsoft.com/office/drawing/2014/main" id="{B12AEF62-E37D-456D-B640-038CDAB8CAC0}"/>
               </a:ext>
             </a:extLst>
           </p:cNvPr>
@@ -7324,7 +7599,7 @@
           <p:cNvPr id="2" name="">
             <a:extLst xmlns:a="http://schemas.openxmlformats.org/drawingml/2006/main">
               <a:ext uri="{FF2B5EF4-FFF2-40B4-BE49-F238E27FC236}">
-                <a16:creationId xmlns:a16="http://schemas.microsoft.com/office/drawing/2014/main" id="{B390CFE5-EB58-4D91-B544-2C842516601F}"/>
+                <a16:creationId xmlns:a16="http://schemas.microsoft.com/office/drawing/2014/main" id="{BBB00839-939E-4B69-BE02-EEF30EF9D60D}"/>
               </a:ext>
             </a:extLst>
           </p:cNvPr>
@@ -7381,7 +7656,7 @@
           <p:cNvPr id="3" name="">
             <a:extLst xmlns:a="http://schemas.openxmlformats.org/drawingml/2006/main">
               <a:ext uri="{FF2B5EF4-FFF2-40B4-BE49-F238E27FC236}">
-                <a16:creationId xmlns:a16="http://schemas.microsoft.com/office/drawing/2014/main" id="{09A29B86-692F-48CC-92A3-536F5AE54D6D}"/>
+                <a16:creationId xmlns:a16="http://schemas.microsoft.com/office/drawing/2014/main" id="{B3E0DFA1-08E6-4194-A7B0-CFECB7E4926D}"/>
               </a:ext>
             </a:extLst>
           </p:cNvPr>
@@ -7831,7 +8106,7 @@
           <p:cNvPr id="5" name="">
             <a:extLst xmlns:a="http://schemas.openxmlformats.org/drawingml/2006/main">
               <a:ext uri="{FF2B5EF4-FFF2-40B4-BE49-F238E27FC236}">
-                <a16:creationId xmlns:a16="http://schemas.microsoft.com/office/drawing/2014/main" id="{B7985078-AB27-44EB-BF14-786D28726FE7}"/>
+                <a16:creationId xmlns:a16="http://schemas.microsoft.com/office/drawing/2014/main" id="{E3291CC1-3124-4BFD-A243-43D3C2E70372}"/>
               </a:ext>
             </a:extLst>
           </p:cNvPr>
@@ -7888,7 +8163,7 @@
           <p:cNvPr id="6" name="">
             <a:extLst xmlns:a="http://schemas.openxmlformats.org/drawingml/2006/main">
               <a:ext uri="{FF2B5EF4-FFF2-40B4-BE49-F238E27FC236}">
-                <a16:creationId xmlns:a16="http://schemas.microsoft.com/office/drawing/2014/main" id="{9B6675B2-F7B6-4288-8BD6-4623D9D0405A}"/>
+                <a16:creationId xmlns:a16="http://schemas.microsoft.com/office/drawing/2014/main" id="{2675EABD-DED2-40AB-B900-A9C0BC46A784}"/>
               </a:ext>
             </a:extLst>
           </p:cNvPr>
@@ -7943,7 +8218,7 @@
     </p:spTree>
     <p:extLst>
       <p:ext uri="{BB962C8B-B14F-4D97-AF65-F5344CB8AC3E}">
-        <p14:creationId xmlns:p14="http://schemas.microsoft.com/office/powerpoint/2010/main" val="1984717979"/>
+        <p14:creationId xmlns:p14="http://schemas.microsoft.com/office/powerpoint/2010/main" val="1152281224"/>
       </p:ext>
     </p:extLst>
   </p:cSld>
@@ -7974,7 +8249,7 @@
           <p:cNvPr id="11" name="">
             <a:extLst xmlns:a="http://schemas.openxmlformats.org/drawingml/2006/main">
               <a:ext uri="{FF2B5EF4-FFF2-40B4-BE49-F238E27FC236}">
-                <a16:creationId xmlns:a16="http://schemas.microsoft.com/office/drawing/2014/main" id="{53083F18-9D98-41AF-852E-8E68069D49CB}"/>
+                <a16:creationId xmlns:a16="http://schemas.microsoft.com/office/drawing/2014/main" id="{79A1C037-7E49-45C7-9C6E-A54E47D2C6C5}"/>
               </a:ext>
             </a:extLst>
           </p:cNvPr>
@@ -8031,7 +8306,7 @@
           <p:cNvPr id="2" name="">
             <a:extLst xmlns:a="http://schemas.openxmlformats.org/drawingml/2006/main">
               <a:ext uri="{FF2B5EF4-FFF2-40B4-BE49-F238E27FC236}">
-                <a16:creationId xmlns:a16="http://schemas.microsoft.com/office/drawing/2014/main" id="{259BBD3F-7936-4CB1-96EC-E0A3C9E20F9B}"/>
+                <a16:creationId xmlns:a16="http://schemas.microsoft.com/office/drawing/2014/main" id="{E780916E-030F-4256-89FA-4187E5C6ED87}"/>
               </a:ext>
             </a:extLst>
           </p:cNvPr>
@@ -8088,7 +8363,7 @@
           <p:cNvPr id="3" name="">
             <a:extLst xmlns:a="http://schemas.openxmlformats.org/drawingml/2006/main">
               <a:ext uri="{FF2B5EF4-FFF2-40B4-BE49-F238E27FC236}">
-                <a16:creationId xmlns:a16="http://schemas.microsoft.com/office/drawing/2014/main" id="{AA7D181E-7E2B-4E88-9007-2779779F56C1}"/>
+                <a16:creationId xmlns:a16="http://schemas.microsoft.com/office/drawing/2014/main" id="{4B2B89BD-AFC7-46BE-9395-16C58AEA413D}"/>
               </a:ext>
             </a:extLst>
           </p:cNvPr>
@@ -8145,7 +8420,7 @@
           <p:cNvPr id="4" name="">
             <a:extLst xmlns:a="http://schemas.openxmlformats.org/drawingml/2006/main">
               <a:ext uri="{FF2B5EF4-FFF2-40B4-BE49-F238E27FC236}">
-                <a16:creationId xmlns:a16="http://schemas.microsoft.com/office/drawing/2014/main" id="{64433E76-3415-401E-9021-CF96C1BD8138}"/>
+                <a16:creationId xmlns:a16="http://schemas.microsoft.com/office/drawing/2014/main" id="{E9639473-58F4-4694-8831-1BBB16F048A3}"/>
               </a:ext>
             </a:extLst>
           </p:cNvPr>
@@ -8202,7 +8477,7 @@
           <p:cNvPr id="5" name="">
             <a:extLst xmlns:a="http://schemas.openxmlformats.org/drawingml/2006/main">
               <a:ext uri="{FF2B5EF4-FFF2-40B4-BE49-F238E27FC236}">
-                <a16:creationId xmlns:a16="http://schemas.microsoft.com/office/drawing/2014/main" id="{4671CE0C-05DF-4633-BA86-E24DE25B8DF9}"/>
+                <a16:creationId xmlns:a16="http://schemas.microsoft.com/office/drawing/2014/main" id="{2FD0F615-C8EF-42EA-901C-6BEE1D8977AC}"/>
               </a:ext>
             </a:extLst>
           </p:cNvPr>
@@ -8305,7 +8580,7 @@
           <p:cNvPr id="6" name="">
             <a:extLst xmlns:a="http://schemas.openxmlformats.org/drawingml/2006/main">
               <a:ext uri="{FF2B5EF4-FFF2-40B4-BE49-F238E27FC236}">
-                <a16:creationId xmlns:a16="http://schemas.microsoft.com/office/drawing/2014/main" id="{28CB2F9C-A1B9-4193-9019-3680690D2717}"/>
+                <a16:creationId xmlns:a16="http://schemas.microsoft.com/office/drawing/2014/main" id="{45EFE935-7CBD-4B44-8F00-12365F345630}"/>
               </a:ext>
             </a:extLst>
           </p:cNvPr>
@@ -8385,7 +8660,7 @@
           <p:cNvPr id="7" name="">
             <a:extLst xmlns:a="http://schemas.openxmlformats.org/drawingml/2006/main">
               <a:ext uri="{FF2B5EF4-FFF2-40B4-BE49-F238E27FC236}">
-                <a16:creationId xmlns:a16="http://schemas.microsoft.com/office/drawing/2014/main" id="{566F0C79-B0D2-4132-A828-68712189B195}"/>
+                <a16:creationId xmlns:a16="http://schemas.microsoft.com/office/drawing/2014/main" id="{F8BDC7F8-02C5-44E6-9567-1442CC3E5C2F}"/>
               </a:ext>
             </a:extLst>
           </p:cNvPr>
@@ -8442,7 +8717,7 @@
           <p:cNvPr id="8" name="">
             <a:extLst xmlns:a="http://schemas.openxmlformats.org/drawingml/2006/main">
               <a:ext uri="{FF2B5EF4-FFF2-40B4-BE49-F238E27FC236}">
-                <a16:creationId xmlns:a16="http://schemas.microsoft.com/office/drawing/2014/main" id="{4F76F714-A453-4A80-9365-5CB4821B4EEA}"/>
+                <a16:creationId xmlns:a16="http://schemas.microsoft.com/office/drawing/2014/main" id="{FD5A7353-67DC-4A44-8485-235CE64D3378}"/>
               </a:ext>
             </a:extLst>
           </p:cNvPr>
@@ -8545,7 +8820,7 @@
           <p:cNvPr id="9" name="">
             <a:extLst xmlns:a="http://schemas.openxmlformats.org/drawingml/2006/main">
               <a:ext uri="{FF2B5EF4-FFF2-40B4-BE49-F238E27FC236}">
-                <a16:creationId xmlns:a16="http://schemas.microsoft.com/office/drawing/2014/main" id="{3796DADF-C00B-4362-AEA4-6B0D939B8DCD}"/>
+                <a16:creationId xmlns:a16="http://schemas.microsoft.com/office/drawing/2014/main" id="{4E6505A5-0C63-4785-9149-BB6512EFA6BC}"/>
               </a:ext>
             </a:extLst>
           </p:cNvPr>
@@ -8625,7 +8900,7 @@
           <p:cNvPr id="10" name="">
             <a:extLst xmlns:a="http://schemas.openxmlformats.org/drawingml/2006/main">
               <a:ext uri="{FF2B5EF4-FFF2-40B4-BE49-F238E27FC236}">
-                <a16:creationId xmlns:a16="http://schemas.microsoft.com/office/drawing/2014/main" id="{40A77243-2323-4097-80CB-46C1E51B49D9}"/>
+                <a16:creationId xmlns:a16="http://schemas.microsoft.com/office/drawing/2014/main" id="{8E62E44F-85DF-413D-929B-21B6F2F13E0D}"/>
               </a:ext>
             </a:extLst>
           </p:cNvPr>
@@ -8680,7 +8955,7 @@
     </p:spTree>
     <p:extLst>
       <p:ext uri="{BB962C8B-B14F-4D97-AF65-F5344CB8AC3E}">
-        <p14:creationId xmlns:p14="http://schemas.microsoft.com/office/powerpoint/2010/main" val="96009478"/>
+        <p14:creationId xmlns:p14="http://schemas.microsoft.com/office/powerpoint/2010/main" val="1111449646"/>
       </p:ext>
     </p:extLst>
   </p:cSld>
@@ -8711,7 +8986,7 @@
           <p:cNvPr id="11" name="">
             <a:extLst xmlns:a="http://schemas.openxmlformats.org/drawingml/2006/main">
               <a:ext uri="{FF2B5EF4-FFF2-40B4-BE49-F238E27FC236}">
-                <a16:creationId xmlns:a16="http://schemas.microsoft.com/office/drawing/2014/main" id="{681A985C-25FA-48EB-98AF-50B20B292950}"/>
+                <a16:creationId xmlns:a16="http://schemas.microsoft.com/office/drawing/2014/main" id="{91BBA79D-C77E-4BA7-A70C-673B418AA075}"/>
               </a:ext>
             </a:extLst>
           </p:cNvPr>
@@ -8768,7 +9043,7 @@
           <p:cNvPr id="2" name="">
             <a:extLst xmlns:a="http://schemas.openxmlformats.org/drawingml/2006/main">
               <a:ext uri="{FF2B5EF4-FFF2-40B4-BE49-F238E27FC236}">
-                <a16:creationId xmlns:a16="http://schemas.microsoft.com/office/drawing/2014/main" id="{3B3A0AF7-ADFE-4033-BCBE-9A92B44516F2}"/>
+                <a16:creationId xmlns:a16="http://schemas.microsoft.com/office/drawing/2014/main" id="{05F9A2B9-6A05-4082-A597-45C94F33F02C}"/>
               </a:ext>
             </a:extLst>
           </p:cNvPr>
@@ -8825,7 +9100,7 @@
           <p:cNvPr id="3" name="">
             <a:extLst xmlns:a="http://schemas.openxmlformats.org/drawingml/2006/main">
               <a:ext uri="{FF2B5EF4-FFF2-40B4-BE49-F238E27FC236}">
-                <a16:creationId xmlns:a16="http://schemas.microsoft.com/office/drawing/2014/main" id="{7B110A09-B542-4FC9-B034-C7CC2BA3B3BA}"/>
+                <a16:creationId xmlns:a16="http://schemas.microsoft.com/office/drawing/2014/main" id="{6BA6CA1A-3838-4565-898A-66BE0448329C}"/>
               </a:ext>
             </a:extLst>
           </p:cNvPr>
@@ -8882,7 +9157,7 @@
           <p:cNvPr id="4" name="">
             <a:extLst xmlns:a="http://schemas.openxmlformats.org/drawingml/2006/main">
               <a:ext uri="{FF2B5EF4-FFF2-40B4-BE49-F238E27FC236}">
-                <a16:creationId xmlns:a16="http://schemas.microsoft.com/office/drawing/2014/main" id="{0ED7836B-0C11-4B3F-BC47-9ABC0297678F}"/>
+                <a16:creationId xmlns:a16="http://schemas.microsoft.com/office/drawing/2014/main" id="{DC613265-AAD8-4414-80AB-829C57B8343D}"/>
               </a:ext>
             </a:extLst>
           </p:cNvPr>
@@ -8939,7 +9214,7 @@
           <p:cNvPr id="5" name="">
             <a:extLst xmlns:a="http://schemas.openxmlformats.org/drawingml/2006/main">
               <a:ext uri="{FF2B5EF4-FFF2-40B4-BE49-F238E27FC236}">
-                <a16:creationId xmlns:a16="http://schemas.microsoft.com/office/drawing/2014/main" id="{D044C08D-EC62-4BCC-8F18-F4B2AF8D3C71}"/>
+                <a16:creationId xmlns:a16="http://schemas.microsoft.com/office/drawing/2014/main" id="{04525C09-EAC7-4C2B-A8CD-4E8DC6BFBE7A}"/>
               </a:ext>
             </a:extLst>
           </p:cNvPr>
@@ -8996,7 +9271,7 @@
           <p:cNvPr id="6" name="">
             <a:extLst xmlns:a="http://schemas.openxmlformats.org/drawingml/2006/main">
               <a:ext uri="{FF2B5EF4-FFF2-40B4-BE49-F238E27FC236}">
-                <a16:creationId xmlns:a16="http://schemas.microsoft.com/office/drawing/2014/main" id="{7B17C608-D3EF-4530-B62E-A0CEB2492DC1}"/>
+                <a16:creationId xmlns:a16="http://schemas.microsoft.com/office/drawing/2014/main" id="{1BBC1B61-BD1A-4884-8DD1-1087F2CD1CBE}"/>
               </a:ext>
             </a:extLst>
           </p:cNvPr>
@@ -9099,7 +9374,7 @@
           <p:cNvPr id="7" name="">
             <a:extLst xmlns:a="http://schemas.openxmlformats.org/drawingml/2006/main">
               <a:ext uri="{FF2B5EF4-FFF2-40B4-BE49-F238E27FC236}">
-                <a16:creationId xmlns:a16="http://schemas.microsoft.com/office/drawing/2014/main" id="{3CB2CE1A-F2E0-4269-8F4A-4E188F320ACF}"/>
+                <a16:creationId xmlns:a16="http://schemas.microsoft.com/office/drawing/2014/main" id="{2A3FBCC7-D349-42AA-8D0D-20C8AD9A497E}"/>
               </a:ext>
             </a:extLst>
           </p:cNvPr>
@@ -9156,7 +9431,7 @@
           <p:cNvPr id="8" name="">
             <a:extLst xmlns:a="http://schemas.openxmlformats.org/drawingml/2006/main">
               <a:ext uri="{FF2B5EF4-FFF2-40B4-BE49-F238E27FC236}">
-                <a16:creationId xmlns:a16="http://schemas.microsoft.com/office/drawing/2014/main" id="{EC841C23-13C3-4C04-AB0D-97A2A50DBC92}"/>
+                <a16:creationId xmlns:a16="http://schemas.microsoft.com/office/drawing/2014/main" id="{212512A9-3E82-4559-A832-2500EFD8619B}"/>
               </a:ext>
             </a:extLst>
           </p:cNvPr>
@@ -9213,7 +9488,7 @@
           <p:cNvPr id="9" name="">
             <a:extLst xmlns:a="http://schemas.openxmlformats.org/drawingml/2006/main">
               <a:ext uri="{FF2B5EF4-FFF2-40B4-BE49-F238E27FC236}">
-                <a16:creationId xmlns:a16="http://schemas.microsoft.com/office/drawing/2014/main" id="{1B6FE848-451E-4FF1-93CB-57CBC664CB62}"/>
+                <a16:creationId xmlns:a16="http://schemas.microsoft.com/office/drawing/2014/main" id="{5A1382D6-3877-4416-83FD-C7A9611E4225}"/>
               </a:ext>
             </a:extLst>
           </p:cNvPr>
@@ -9316,7 +9591,7 @@
           <p:cNvPr id="10" name="">
             <a:extLst xmlns:a="http://schemas.openxmlformats.org/drawingml/2006/main">
               <a:ext uri="{FF2B5EF4-FFF2-40B4-BE49-F238E27FC236}">
-                <a16:creationId xmlns:a16="http://schemas.microsoft.com/office/drawing/2014/main" id="{AF9FE24B-02A6-46E6-A920-14A68EE20315}"/>
+                <a16:creationId xmlns:a16="http://schemas.microsoft.com/office/drawing/2014/main" id="{6CB40835-4049-4B8A-8780-68F7D91EA14B}"/>
               </a:ext>
             </a:extLst>
           </p:cNvPr>
@@ -9371,7 +9646,7 @@
     </p:spTree>
     <p:extLst>
       <p:ext uri="{BB962C8B-B14F-4D97-AF65-F5344CB8AC3E}">
-        <p14:creationId xmlns:p14="http://schemas.microsoft.com/office/powerpoint/2010/main" val="1302186108"/>
+        <p14:creationId xmlns:p14="http://schemas.microsoft.com/office/powerpoint/2010/main" val="693308255"/>
       </p:ext>
     </p:extLst>
   </p:cSld>
@@ -9402,7 +9677,7 @@
           <p:cNvPr id="20" name="">
             <a:extLst xmlns:a="http://schemas.openxmlformats.org/drawingml/2006/main">
               <a:ext uri="{FF2B5EF4-FFF2-40B4-BE49-F238E27FC236}">
-                <a16:creationId xmlns:a16="http://schemas.microsoft.com/office/drawing/2014/main" id="{8CB55F84-2442-4EC4-A045-15187347DC90}"/>
+                <a16:creationId xmlns:a16="http://schemas.microsoft.com/office/drawing/2014/main" id="{1F9C0459-131F-43E6-A682-9F54720B5F1C}"/>
               </a:ext>
             </a:extLst>
           </p:cNvPr>
@@ -9459,7 +9734,7 @@
           <p:cNvPr id="2" name="">
             <a:extLst xmlns:a="http://schemas.openxmlformats.org/drawingml/2006/main">
               <a:ext uri="{FF2B5EF4-FFF2-40B4-BE49-F238E27FC236}">
-                <a16:creationId xmlns:a16="http://schemas.microsoft.com/office/drawing/2014/main" id="{D24DCC48-0DAF-4547-824D-76ACF5C1698A}"/>
+                <a16:creationId xmlns:a16="http://schemas.microsoft.com/office/drawing/2014/main" id="{7D96DAD4-BBCB-4523-871A-2A08FFEE4C7F}"/>
               </a:ext>
             </a:extLst>
           </p:cNvPr>
@@ -9516,7 +9791,7 @@
           <p:cNvPr id="3" name="">
             <a:extLst xmlns:a="http://schemas.openxmlformats.org/drawingml/2006/main">
               <a:ext uri="{FF2B5EF4-FFF2-40B4-BE49-F238E27FC236}">
-                <a16:creationId xmlns:a16="http://schemas.microsoft.com/office/drawing/2014/main" id="{A9ACC63C-220B-49FC-9FCC-EA9189E3232D}"/>
+                <a16:creationId xmlns:a16="http://schemas.microsoft.com/office/drawing/2014/main" id="{9984F0F0-4397-458B-A682-60CCB7679B8D}"/>
               </a:ext>
             </a:extLst>
           </p:cNvPr>
@@ -9573,7 +9848,7 @@
           <p:cNvPr id="4" name="">
             <a:extLst xmlns:a="http://schemas.openxmlformats.org/drawingml/2006/main">
               <a:ext uri="{FF2B5EF4-FFF2-40B4-BE49-F238E27FC236}">
-                <a16:creationId xmlns:a16="http://schemas.microsoft.com/office/drawing/2014/main" id="{8E2D93C3-2636-4EDD-A57F-E8E922DA3ED9}"/>
+                <a16:creationId xmlns:a16="http://schemas.microsoft.com/office/drawing/2014/main" id="{B6BF19B4-B71E-4E87-B477-313BCAFC6FE3}"/>
               </a:ext>
             </a:extLst>
           </p:cNvPr>
@@ -9632,7 +9907,7 @@
           <p:cNvPr id="5" name="">
             <a:extLst xmlns:a="http://schemas.openxmlformats.org/drawingml/2006/main">
               <a:ext uri="{FF2B5EF4-FFF2-40B4-BE49-F238E27FC236}">
-                <a16:creationId xmlns:a16="http://schemas.microsoft.com/office/drawing/2014/main" id="{D6A04DD3-38A1-4731-8AA0-44C389785D89}"/>
+                <a16:creationId xmlns:a16="http://schemas.microsoft.com/office/drawing/2014/main" id="{8338CFE5-0E20-4CDF-996D-95DDB6C573D1}"/>
               </a:ext>
             </a:extLst>
           </p:cNvPr>
@@ -9716,7 +9991,7 @@
           <p:cNvPr id="7" name="">
             <a:extLst xmlns:a="http://schemas.openxmlformats.org/drawingml/2006/main">
               <a:ext uri="{FF2B5EF4-FFF2-40B4-BE49-F238E27FC236}">
-                <a16:creationId xmlns:a16="http://schemas.microsoft.com/office/drawing/2014/main" id="{A79445A1-05DC-4155-993D-39AA39D2367F}"/>
+                <a16:creationId xmlns:a16="http://schemas.microsoft.com/office/drawing/2014/main" id="{AE756101-E7E1-46E3-83A9-1D8030A3728C}"/>
               </a:ext>
             </a:extLst>
           </p:cNvPr>
@@ -9800,7 +10075,7 @@
           <p:cNvPr id="9" name="">
             <a:extLst xmlns:a="http://schemas.openxmlformats.org/drawingml/2006/main">
               <a:ext uri="{FF2B5EF4-FFF2-40B4-BE49-F238E27FC236}">
-                <a16:creationId xmlns:a16="http://schemas.microsoft.com/office/drawing/2014/main" id="{84894945-623C-4FDD-88FB-7327A2DB01E7}"/>
+                <a16:creationId xmlns:a16="http://schemas.microsoft.com/office/drawing/2014/main" id="{FC73DD3C-3E47-475A-8EFD-19DEDF98CF59}"/>
               </a:ext>
             </a:extLst>
           </p:cNvPr>
@@ -9884,7 +10159,7 @@
           <p:cNvPr id="11" name="">
             <a:extLst xmlns:a="http://schemas.openxmlformats.org/drawingml/2006/main">
               <a:ext uri="{FF2B5EF4-FFF2-40B4-BE49-F238E27FC236}">
-                <a16:creationId xmlns:a16="http://schemas.microsoft.com/office/drawing/2014/main" id="{79172E1D-344B-497B-8021-E201881D77C7}"/>
+                <a16:creationId xmlns:a16="http://schemas.microsoft.com/office/drawing/2014/main" id="{66E699C2-E3C0-48DD-A9E2-2F030FE6A076}"/>
               </a:ext>
             </a:extLst>
           </p:cNvPr>
@@ -9968,7 +10243,7 @@
           <p:cNvPr id="13" name="">
             <a:extLst xmlns:a="http://schemas.openxmlformats.org/drawingml/2006/main">
               <a:ext uri="{FF2B5EF4-FFF2-40B4-BE49-F238E27FC236}">
-                <a16:creationId xmlns:a16="http://schemas.microsoft.com/office/drawing/2014/main" id="{918685E2-0E99-4F1C-B4CB-2F91C3F0038B}"/>
+                <a16:creationId xmlns:a16="http://schemas.microsoft.com/office/drawing/2014/main" id="{1D02818C-7344-42FE-8A8C-79E8E5F2C647}"/>
               </a:ext>
             </a:extLst>
           </p:cNvPr>
@@ -10025,7 +10300,7 @@
           <p:cNvPr id="14" name="">
             <a:extLst xmlns:a="http://schemas.openxmlformats.org/drawingml/2006/main">
               <a:ext uri="{FF2B5EF4-FFF2-40B4-BE49-F238E27FC236}">
-                <a16:creationId xmlns:a16="http://schemas.microsoft.com/office/drawing/2014/main" id="{39BDB39D-76C2-4C52-8FB5-5BC9A79553DF}"/>
+                <a16:creationId xmlns:a16="http://schemas.microsoft.com/office/drawing/2014/main" id="{61D3E080-AD5F-4EA3-8DFB-C55EB9760E39}"/>
               </a:ext>
             </a:extLst>
           </p:cNvPr>
@@ -10082,7 +10357,7 @@
           <p:cNvPr id="15" name="">
             <a:extLst xmlns:a="http://schemas.openxmlformats.org/drawingml/2006/main">
               <a:ext uri="{FF2B5EF4-FFF2-40B4-BE49-F238E27FC236}">
-                <a16:creationId xmlns:a16="http://schemas.microsoft.com/office/drawing/2014/main" id="{39A0457C-064C-41F4-8B43-165C4E5A4208}"/>
+                <a16:creationId xmlns:a16="http://schemas.microsoft.com/office/drawing/2014/main" id="{267EDFA0-0BBE-47EE-B46E-D937C50FA9A0}"/>
               </a:ext>
             </a:extLst>
           </p:cNvPr>
@@ -10139,7 +10414,7 @@
           <p:cNvPr id="16" name="">
             <a:extLst xmlns:a="http://schemas.openxmlformats.org/drawingml/2006/main">
               <a:ext uri="{FF2B5EF4-FFF2-40B4-BE49-F238E27FC236}">
-                <a16:creationId xmlns:a16="http://schemas.microsoft.com/office/drawing/2014/main" id="{58C21EBD-B6D7-4655-99AF-3497DD9B8534}"/>
+                <a16:creationId xmlns:a16="http://schemas.microsoft.com/office/drawing/2014/main" id="{6347C9E9-4480-4AE7-B9F9-2F75BA18764A}"/>
               </a:ext>
             </a:extLst>
           </p:cNvPr>
@@ -10196,7 +10471,7 @@
           <p:cNvPr id="17" name="">
             <a:extLst xmlns:a="http://schemas.openxmlformats.org/drawingml/2006/main">
               <a:ext uri="{FF2B5EF4-FFF2-40B4-BE49-F238E27FC236}">
-                <a16:creationId xmlns:a16="http://schemas.microsoft.com/office/drawing/2014/main" id="{486A6719-C85E-4058-8F84-CA301C521B31}"/>
+                <a16:creationId xmlns:a16="http://schemas.microsoft.com/office/drawing/2014/main" id="{ED2C9DF2-E2CD-4961-9F9F-0B41AF12C897}"/>
               </a:ext>
             </a:extLst>
           </p:cNvPr>
@@ -10253,7 +10528,7 @@
           <p:cNvPr id="18" name="">
             <a:extLst xmlns:a="http://schemas.openxmlformats.org/drawingml/2006/main">
               <a:ext uri="{FF2B5EF4-FFF2-40B4-BE49-F238E27FC236}">
-                <a16:creationId xmlns:a16="http://schemas.microsoft.com/office/drawing/2014/main" id="{24AAD3DE-208A-4E22-BE74-450C08B2A331}"/>
+                <a16:creationId xmlns:a16="http://schemas.microsoft.com/office/drawing/2014/main" id="{6B03FA2C-016F-496D-8994-557A1C5E85E6}"/>
               </a:ext>
             </a:extLst>
           </p:cNvPr>
@@ -10310,7 +10585,7 @@
           <p:cNvPr id="19" name="">
             <a:extLst xmlns:a="http://schemas.openxmlformats.org/drawingml/2006/main">
               <a:ext uri="{FF2B5EF4-FFF2-40B4-BE49-F238E27FC236}">
-                <a16:creationId xmlns:a16="http://schemas.microsoft.com/office/drawing/2014/main" id="{F951BC33-6710-4B23-90CA-D9BB35831669}"/>
+                <a16:creationId xmlns:a16="http://schemas.microsoft.com/office/drawing/2014/main" id="{AAEC3AEE-2284-45B1-961D-D9F6029FDDAC}"/>
               </a:ext>
             </a:extLst>
           </p:cNvPr>
@@ -10365,7 +10640,7 @@
     </p:spTree>
     <p:extLst>
       <p:ext uri="{BB962C8B-B14F-4D97-AF65-F5344CB8AC3E}">
-        <p14:creationId xmlns:p14="http://schemas.microsoft.com/office/powerpoint/2010/main" val="799477454"/>
+        <p14:creationId xmlns:p14="http://schemas.microsoft.com/office/powerpoint/2010/main" val="2035622179"/>
       </p:ext>
     </p:extLst>
   </p:cSld>
@@ -10393,10 +10668,10 @@
       </p:grpSpPr>
       <p:sp>
         <p:nvSpPr>
-          <p:cNvPr id="20" name="">
-            <a:extLst xmlns:a="http://schemas.openxmlformats.org/drawingml/2006/main">
-              <a:ext uri="{FF2B5EF4-FFF2-40B4-BE49-F238E27FC236}">
-                <a16:creationId xmlns:a16="http://schemas.microsoft.com/office/drawing/2014/main" id="{A3815BE1-D283-4FA5-85EE-D0224DB163CB}"/>
+          <p:cNvPr id="16" name="">
+            <a:extLst xmlns:a="http://schemas.openxmlformats.org/drawingml/2006/main">
+              <a:ext uri="{FF2B5EF4-FFF2-40B4-BE49-F238E27FC236}">
+                <a16:creationId xmlns:a16="http://schemas.microsoft.com/office/drawing/2014/main" id="{C8BF9139-E842-4027-B28B-72F0D512A990}"/>
               </a:ext>
             </a:extLst>
           </p:cNvPr>
@@ -10453,7 +10728,7 @@
           <p:cNvPr id="2" name="">
             <a:extLst xmlns:a="http://schemas.openxmlformats.org/drawingml/2006/main">
               <a:ext uri="{FF2B5EF4-FFF2-40B4-BE49-F238E27FC236}">
-                <a16:creationId xmlns:a16="http://schemas.microsoft.com/office/drawing/2014/main" id="{0CBB2FBF-FA45-4FEB-8B9B-AEBEF94EDE3D}"/>
+                <a16:creationId xmlns:a16="http://schemas.microsoft.com/office/drawing/2014/main" id="{7CD649E5-04F6-4870-856A-20D8C60284DF}"/>
               </a:ext>
             </a:extLst>
           </p:cNvPr>
@@ -10500,7 +10775,7 @@
                 <a:ea typeface="Apple SD Gothic Neo"/>
                 <a:cs typeface="Apple SD Gothic Neo"/>
               </a:rPr>
-              <a:t>상품 URL과 목적을 전달한 뒤 확인·승인 중심으로 진행했습니다. 아래 대화는 실제 기록을 축약했습니다.</a:t>
+              <a:t>첫 요청 1회 + 후속 입력 6회로 배송대행 접수까지 진행했습니다.</a:t>
             </a:r>
           </a:p>
         </p:txBody>
@@ -10510,7 +10785,7 @@
           <p:cNvPr id="3" name="">
             <a:extLst xmlns:a="http://schemas.openxmlformats.org/drawingml/2006/main">
               <a:ext uri="{FF2B5EF4-FFF2-40B4-BE49-F238E27FC236}">
-                <a16:creationId xmlns:a16="http://schemas.microsoft.com/office/drawing/2014/main" id="{CCFBBAA8-5608-494F-91EC-25A6912BF6A7}"/>
+                <a16:creationId xmlns:a16="http://schemas.microsoft.com/office/drawing/2014/main" id="{545DDE90-5006-4E6C-B87E-BD00B062F023}"/>
               </a:ext>
             </a:extLst>
           </p:cNvPr>
@@ -10567,19 +10842,103 @@
           <p:cNvPr id="4" name="">
             <a:extLst xmlns:a="http://schemas.openxmlformats.org/drawingml/2006/main">
               <a:ext uri="{FF2B5EF4-FFF2-40B4-BE49-F238E27FC236}">
-                <a16:creationId xmlns:a16="http://schemas.microsoft.com/office/drawing/2014/main" id="{08B537D5-090F-4439-A6BB-537FF93394E3}"/>
-              </a:ext>
-            </a:extLst>
-          </p:cNvPr>
-          <p:cNvSpPr>
-            <a:spLocks xmlns:a="http://schemas.openxmlformats.org/drawingml/2006/main" noGrp="1"/>
-          </p:cNvSpPr>
-          <p:nvPr/>
-        </p:nvSpPr>
-        <p:spPr>
-          <a:xfrm xmlns:a="http://schemas.openxmlformats.org/drawingml/2006/main">
-            <a:off x="819150" y="2371725"/>
-            <a:ext cx="13525500" cy="666750"/>
+                <a16:creationId xmlns:a16="http://schemas.microsoft.com/office/drawing/2014/main" id="{ECA6B866-6C80-459F-B909-6F94AEC76066}"/>
+              </a:ext>
+            </a:extLst>
+          </p:cNvPr>
+          <p:cNvSpPr>
+            <a:spLocks xmlns:a="http://schemas.openxmlformats.org/drawingml/2006/main" noGrp="1"/>
+          </p:cNvSpPr>
+          <p:nvPr/>
+        </p:nvSpPr>
+        <p:spPr>
+          <a:xfrm xmlns:a="http://schemas.openxmlformats.org/drawingml/2006/main">
+            <a:off x="3219450" y="2609850"/>
+            <a:ext cx="5429250" cy="857250"/>
+          </a:xfrm>
+          <a:prstGeom xmlns:a="http://schemas.openxmlformats.org/drawingml/2006/main" prst="roundRect">
+            <a:avLst>
+              <a:gd name="adj" fmla="val 8889"/>
+            </a:avLst>
+          </a:prstGeom>
+          <a:solidFill xmlns:a="http://schemas.openxmlformats.org/drawingml/2006/main">
+            <a:srgbClr val="183E34"/>
+          </a:solidFill>
+          <a:ln xmlns:a="http://schemas.openxmlformats.org/drawingml/2006/main" w="19050">
+            <a:solidFill>
+              <a:srgbClr val="183E34"/>
+            </a:solidFill>
+          </a:ln>
+        </p:spPr>
+        <p:txBody>
+          <a:bodyPr xmlns:a="http://schemas.openxmlformats.org/drawingml/2006/main" lIns="228600" tIns="114300" rIns="209550" bIns="114300" anchor="ctr"/>
+          <a:lstStyle xmlns:a="http://schemas.openxmlformats.org/drawingml/2006/main"/>
+          <a:p xmlns:a="http://schemas.openxmlformats.org/drawingml/2006/main">
+            <a:pPr>
+              <a:defRPr sz="2100">
+                <a:solidFill>
+                  <a:srgbClr val="FFFFFF"/>
+                </a:solidFill>
+                <a:latin typeface="Apple SD Gothic Neo"/>
+                <a:ea typeface="Apple SD Gothic Neo"/>
+                <a:cs typeface="Apple SD Gothic Neo"/>
+              </a:defRPr>
+            </a:pPr>
+            <a:r>
+              <a:rPr sz="2100">
+                <a:solidFill>
+                  <a:srgbClr val="FFFFFF"/>
+                </a:solidFill>
+                <a:latin typeface="Apple SD Gothic Neo"/>
+                <a:ea typeface="Apple SD Gothic Neo"/>
+                <a:cs typeface="Apple SD Gothic Neo"/>
+              </a:rPr>
+              <a:t>이 상품을 구매하고</a:t>
+            </a:r>
+          </a:p>
+          <a:p xmlns:a="http://schemas.openxmlformats.org/drawingml/2006/main">
+            <a:pPr>
+              <a:defRPr sz="2100">
+                <a:solidFill>
+                  <a:srgbClr val="FFFFFF"/>
+                </a:solidFill>
+                <a:latin typeface="Apple SD Gothic Neo"/>
+                <a:ea typeface="Apple SD Gothic Neo"/>
+                <a:cs typeface="Apple SD Gothic Neo"/>
+              </a:defRPr>
+            </a:pPr>
+            <a:r>
+              <a:rPr sz="2100">
+                <a:solidFill>
+                  <a:srgbClr val="FFFFFF"/>
+                </a:solidFill>
+                <a:latin typeface="Apple SD Gothic Neo"/>
+                <a:ea typeface="Apple SD Gothic Neo"/>
+                <a:cs typeface="Apple SD Gothic Neo"/>
+              </a:rPr>
+              <a:t>배송대행 신청까지 진행해줘</a:t>
+            </a:r>
+          </a:p>
+        </p:txBody>
+      </p:sp>
+      <p:sp>
+        <p:nvSpPr>
+          <p:cNvPr id="5" name="">
+            <a:extLst xmlns:a="http://schemas.openxmlformats.org/drawingml/2006/main">
+              <a:ext uri="{FF2B5EF4-FFF2-40B4-BE49-F238E27FC236}">
+                <a16:creationId xmlns:a16="http://schemas.microsoft.com/office/drawing/2014/main" id="{80EE7EA3-0695-492A-9A48-AC7A343E3F10}"/>
+              </a:ext>
+            </a:extLst>
+          </p:cNvPr>
+          <p:cNvSpPr>
+            <a:spLocks xmlns:a="http://schemas.openxmlformats.org/drawingml/2006/main" noGrp="1"/>
+          </p:cNvSpPr>
+          <p:nvPr/>
+        </p:nvSpPr>
+        <p:spPr>
+          <a:xfrm xmlns:a="http://schemas.openxmlformats.org/drawingml/2006/main">
+            <a:off x="8801100" y="2857500"/>
+            <a:ext cx="1095375" cy="381000"/>
           </a:xfrm>
           <a:prstGeom xmlns:a="http://schemas.openxmlformats.org/drawingml/2006/main" prst="rect">
             <a:avLst/>
@@ -10596,7 +10955,7 @@
           <a:lstStyle xmlns:a="http://schemas.openxmlformats.org/drawingml/2006/main"/>
           <a:p xmlns:a="http://schemas.openxmlformats.org/drawingml/2006/main">
             <a:pPr>
-              <a:defRPr sz="3675" b="1">
+              <a:defRPr sz="1800" b="1">
                 <a:solidFill>
                   <a:srgbClr val="156E58"/>
                 </a:solidFill>
@@ -10606,7 +10965,7 @@
               </a:defRPr>
             </a:pPr>
             <a:r>
-              <a:rPr sz="3675" b="1">
+              <a:rPr sz="1800" b="1">
                 <a:solidFill>
                   <a:srgbClr val="156E58"/>
                 </a:solidFill>
@@ -10614,29 +10973,113 @@
                 <a:ea typeface="Apple SD Gothic Neo"/>
                 <a:cs typeface="Apple SD Gothic Neo"/>
               </a:rPr>
-              <a:t>첫 요청 1회 + 후속 입력 6회</a:t>
-            </a:r>
-          </a:p>
-        </p:txBody>
-      </p:sp>
-      <p:sp>
-        <p:nvSpPr>
-          <p:cNvPr id="5" name="">
-            <a:extLst xmlns:a="http://schemas.openxmlformats.org/drawingml/2006/main">
-              <a:ext uri="{FF2B5EF4-FFF2-40B4-BE49-F238E27FC236}">
-                <a16:creationId xmlns:a16="http://schemas.microsoft.com/office/drawing/2014/main" id="{4F2D4D05-3F35-416C-B62C-64DC51197B18}"/>
-              </a:ext>
-            </a:extLst>
-          </p:cNvPr>
-          <p:cNvSpPr>
-            <a:spLocks xmlns:a="http://schemas.openxmlformats.org/drawingml/2006/main" noGrp="1"/>
-          </p:cNvSpPr>
-          <p:nvPr/>
-        </p:nvSpPr>
-        <p:spPr>
-          <a:xfrm xmlns:a="http://schemas.openxmlformats.org/drawingml/2006/main">
-            <a:off x="819150" y="3171825"/>
-            <a:ext cx="6191250" cy="323850"/>
+              <a:t>나</a:t>
+            </a:r>
+          </a:p>
+        </p:txBody>
+      </p:sp>
+      <p:sp>
+        <p:nvSpPr>
+          <p:cNvPr id="6" name="">
+            <a:extLst xmlns:a="http://schemas.openxmlformats.org/drawingml/2006/main">
+              <a:ext uri="{FF2B5EF4-FFF2-40B4-BE49-F238E27FC236}">
+                <a16:creationId xmlns:a16="http://schemas.microsoft.com/office/drawing/2014/main" id="{67F5A090-C351-4036-BB77-C54F0BD0D4E7}"/>
+              </a:ext>
+            </a:extLst>
+          </p:cNvPr>
+          <p:cNvSpPr>
+            <a:spLocks xmlns:a="http://schemas.openxmlformats.org/drawingml/2006/main" noGrp="1"/>
+          </p:cNvSpPr>
+          <p:nvPr/>
+        </p:nvSpPr>
+        <p:spPr>
+          <a:xfrm xmlns:a="http://schemas.openxmlformats.org/drawingml/2006/main">
+            <a:off x="2000250" y="3724275"/>
+            <a:ext cx="5810250" cy="857250"/>
+          </a:xfrm>
+          <a:prstGeom xmlns:a="http://schemas.openxmlformats.org/drawingml/2006/main" prst="roundRect">
+            <a:avLst>
+              <a:gd name="adj" fmla="val 8889"/>
+            </a:avLst>
+          </a:prstGeom>
+          <a:solidFill xmlns:a="http://schemas.openxmlformats.org/drawingml/2006/main">
+            <a:srgbClr val="FFFFFF"/>
+          </a:solidFill>
+          <a:ln xmlns:a="http://schemas.openxmlformats.org/drawingml/2006/main" w="19050">
+            <a:solidFill>
+              <a:srgbClr val="183E34"/>
+            </a:solidFill>
+          </a:ln>
+        </p:spPr>
+        <p:txBody>
+          <a:bodyPr xmlns:a="http://schemas.openxmlformats.org/drawingml/2006/main" lIns="228600" tIns="114300" rIns="209550" bIns="114300" anchor="ctr"/>
+          <a:lstStyle xmlns:a="http://schemas.openxmlformats.org/drawingml/2006/main"/>
+          <a:p xmlns:a="http://schemas.openxmlformats.org/drawingml/2006/main">
+            <a:pPr>
+              <a:defRPr sz="2100">
+                <a:solidFill>
+                  <a:srgbClr val="182C29"/>
+                </a:solidFill>
+                <a:latin typeface="Apple SD Gothic Neo"/>
+                <a:ea typeface="Apple SD Gothic Neo"/>
+                <a:cs typeface="Apple SD Gothic Neo"/>
+              </a:defRPr>
+            </a:pPr>
+            <a:r>
+              <a:rPr sz="2100">
+                <a:solidFill>
+                  <a:srgbClr val="182C29"/>
+                </a:solidFill>
+                <a:latin typeface="Apple SD Gothic Neo"/>
+                <a:ea typeface="Apple SD Gothic Neo"/>
+                <a:cs typeface="Apple SD Gothic Neo"/>
+              </a:rPr>
+              <a:t>상품·배송 조건 확인 후</a:t>
+            </a:r>
+          </a:p>
+          <a:p xmlns:a="http://schemas.openxmlformats.org/drawingml/2006/main">
+            <a:pPr>
+              <a:defRPr sz="2100">
+                <a:solidFill>
+                  <a:srgbClr val="182C29"/>
+                </a:solidFill>
+                <a:latin typeface="Apple SD Gothic Neo"/>
+                <a:ea typeface="Apple SD Gothic Neo"/>
+                <a:cs typeface="Apple SD Gothic Neo"/>
+              </a:defRPr>
+            </a:pPr>
+            <a:r>
+              <a:rPr sz="2100">
+                <a:solidFill>
+                  <a:srgbClr val="182C29"/>
+                </a:solidFill>
+                <a:latin typeface="Apple SD Gothic Neo"/>
+                <a:ea typeface="Apple SD Gothic Neo"/>
+                <a:cs typeface="Apple SD Gothic Neo"/>
+              </a:rPr>
+              <a:t>로그인과 정보 입력 승인을 요청</a:t>
+            </a:r>
+          </a:p>
+        </p:txBody>
+      </p:sp>
+      <p:sp>
+        <p:nvSpPr>
+          <p:cNvPr id="7" name="">
+            <a:extLst xmlns:a="http://schemas.openxmlformats.org/drawingml/2006/main">
+              <a:ext uri="{FF2B5EF4-FFF2-40B4-BE49-F238E27FC236}">
+                <a16:creationId xmlns:a16="http://schemas.microsoft.com/office/drawing/2014/main" id="{3056F7DA-8A10-47E8-984E-3BF5E2B23243}"/>
+              </a:ext>
+            </a:extLst>
+          </p:cNvPr>
+          <p:cNvSpPr>
+            <a:spLocks xmlns:a="http://schemas.openxmlformats.org/drawingml/2006/main" noGrp="1"/>
+          </p:cNvSpPr>
+          <p:nvPr/>
+        </p:nvSpPr>
+        <p:spPr>
+          <a:xfrm xmlns:a="http://schemas.openxmlformats.org/drawingml/2006/main">
+            <a:off x="809625" y="3971925"/>
+            <a:ext cx="1095375" cy="381000"/>
           </a:xfrm>
           <a:prstGeom xmlns:a="http://schemas.openxmlformats.org/drawingml/2006/main" prst="rect">
             <a:avLst/>
@@ -10653,47 +11096,131 @@
           <a:lstStyle xmlns:a="http://schemas.openxmlformats.org/drawingml/2006/main"/>
           <a:p xmlns:a="http://schemas.openxmlformats.org/drawingml/2006/main">
             <a:pPr>
-              <a:defRPr sz="1950" b="1">
-                <a:solidFill>
-                  <a:srgbClr val="182C29"/>
-                </a:solidFill>
-                <a:latin typeface="Apple SD Gothic Neo"/>
-                <a:ea typeface="Apple SD Gothic Neo"/>
-                <a:cs typeface="Apple SD Gothic Neo"/>
-              </a:defRPr>
-            </a:pPr>
-            <a:r>
-              <a:rPr sz="1950" b="1">
-                <a:solidFill>
-                  <a:srgbClr val="182C29"/>
-                </a:solidFill>
-                <a:latin typeface="Apple SD Gothic Neo"/>
-                <a:ea typeface="Apple SD Gothic Neo"/>
-                <a:cs typeface="Apple SD Gothic Neo"/>
-              </a:rPr>
-              <a:t>나 · 입력 순서</a:t>
-            </a:r>
-          </a:p>
-        </p:txBody>
-      </p:sp>
-      <p:sp>
-        <p:nvSpPr>
-          <p:cNvPr id="6" name="">
-            <a:extLst xmlns:a="http://schemas.openxmlformats.org/drawingml/2006/main">
-              <a:ext uri="{FF2B5EF4-FFF2-40B4-BE49-F238E27FC236}">
-                <a16:creationId xmlns:a16="http://schemas.microsoft.com/office/drawing/2014/main" id="{E253919B-7F74-4BCA-A412-A242DE389DBE}"/>
-              </a:ext>
-            </a:extLst>
-          </p:cNvPr>
-          <p:cNvSpPr>
-            <a:spLocks xmlns:a="http://schemas.openxmlformats.org/drawingml/2006/main" noGrp="1"/>
-          </p:cNvSpPr>
-          <p:nvPr/>
-        </p:nvSpPr>
-        <p:spPr>
-          <a:xfrm xmlns:a="http://schemas.openxmlformats.org/drawingml/2006/main">
-            <a:off x="7858125" y="3171825"/>
-            <a:ext cx="6524625" cy="323850"/>
+              <a:defRPr sz="1800" b="1">
+                <a:solidFill>
+                  <a:srgbClr val="156E58"/>
+                </a:solidFill>
+                <a:latin typeface="Apple SD Gothic Neo"/>
+                <a:ea typeface="Apple SD Gothic Neo"/>
+                <a:cs typeface="Apple SD Gothic Neo"/>
+              </a:defRPr>
+            </a:pPr>
+            <a:r>
+              <a:rPr sz="1800" b="1">
+                <a:solidFill>
+                  <a:srgbClr val="156E58"/>
+                </a:solidFill>
+                <a:latin typeface="Apple SD Gothic Neo"/>
+                <a:ea typeface="Apple SD Gothic Neo"/>
+                <a:cs typeface="Apple SD Gothic Neo"/>
+              </a:rPr>
+              <a:t>에이전트</a:t>
+            </a:r>
+          </a:p>
+        </p:txBody>
+      </p:sp>
+      <p:sp>
+        <p:nvSpPr>
+          <p:cNvPr id="8" name="">
+            <a:extLst xmlns:a="http://schemas.openxmlformats.org/drawingml/2006/main">
+              <a:ext uri="{FF2B5EF4-FFF2-40B4-BE49-F238E27FC236}">
+                <a16:creationId xmlns:a16="http://schemas.microsoft.com/office/drawing/2014/main" id="{7837E47E-F2DE-414E-8B85-B80BCBCFE5B8}"/>
+              </a:ext>
+            </a:extLst>
+          </p:cNvPr>
+          <p:cNvSpPr>
+            <a:spLocks xmlns:a="http://schemas.openxmlformats.org/drawingml/2006/main" noGrp="1"/>
+          </p:cNvSpPr>
+          <p:nvPr/>
+        </p:nvSpPr>
+        <p:spPr>
+          <a:xfrm xmlns:a="http://schemas.openxmlformats.org/drawingml/2006/main">
+            <a:off x="3219450" y="4838700"/>
+            <a:ext cx="5429250" cy="857250"/>
+          </a:xfrm>
+          <a:prstGeom xmlns:a="http://schemas.openxmlformats.org/drawingml/2006/main" prst="roundRect">
+            <a:avLst>
+              <a:gd name="adj" fmla="val 8889"/>
+            </a:avLst>
+          </a:prstGeom>
+          <a:solidFill xmlns:a="http://schemas.openxmlformats.org/drawingml/2006/main">
+            <a:srgbClr val="183E34"/>
+          </a:solidFill>
+          <a:ln xmlns:a="http://schemas.openxmlformats.org/drawingml/2006/main" w="19050">
+            <a:solidFill>
+              <a:srgbClr val="183E34"/>
+            </a:solidFill>
+          </a:ln>
+        </p:spPr>
+        <p:txBody>
+          <a:bodyPr xmlns:a="http://schemas.openxmlformats.org/drawingml/2006/main" lIns="228600" tIns="114300" rIns="209550" bIns="114300" anchor="ctr"/>
+          <a:lstStyle xmlns:a="http://schemas.openxmlformats.org/drawingml/2006/main"/>
+          <a:p xmlns:a="http://schemas.openxmlformats.org/drawingml/2006/main">
+            <a:pPr>
+              <a:defRPr sz="2100">
+                <a:solidFill>
+                  <a:srgbClr val="FFFFFF"/>
+                </a:solidFill>
+                <a:latin typeface="Apple SD Gothic Neo"/>
+                <a:ea typeface="Apple SD Gothic Neo"/>
+                <a:cs typeface="Apple SD Gothic Neo"/>
+              </a:defRPr>
+            </a:pPr>
+            <a:r>
+              <a:rPr sz="2100">
+                <a:solidFill>
+                  <a:srgbClr val="FFFFFF"/>
+                </a:solidFill>
+                <a:latin typeface="Apple SD Gothic Neo"/>
+                <a:ea typeface="Apple SD Gothic Neo"/>
+                <a:cs typeface="Apple SD Gothic Neo"/>
+              </a:rPr>
+              <a:t>로그인 완료 · 입력/제출 승인</a:t>
+            </a:r>
+          </a:p>
+          <a:p xmlns:a="http://schemas.openxmlformats.org/drawingml/2006/main">
+            <a:pPr>
+              <a:defRPr sz="2100">
+                <a:solidFill>
+                  <a:srgbClr val="FFFFFF"/>
+                </a:solidFill>
+                <a:latin typeface="Apple SD Gothic Neo"/>
+                <a:ea typeface="Apple SD Gothic Neo"/>
+                <a:cs typeface="Apple SD Gothic Neo"/>
+              </a:defRPr>
+            </a:pPr>
+            <a:r>
+              <a:rPr sz="2100">
+                <a:solidFill>
+                  <a:srgbClr val="FFFFFF"/>
+                </a:solidFill>
+                <a:latin typeface="Apple SD Gothic Neo"/>
+                <a:ea typeface="Apple SD Gothic Neo"/>
+                <a:cs typeface="Apple SD Gothic Neo"/>
+              </a:rPr>
+              <a:t>구매/인증 완료 알림</a:t>
+            </a:r>
+          </a:p>
+        </p:txBody>
+      </p:sp>
+      <p:sp>
+        <p:nvSpPr>
+          <p:cNvPr id="9" name="">
+            <a:extLst xmlns:a="http://schemas.openxmlformats.org/drawingml/2006/main">
+              <a:ext uri="{FF2B5EF4-FFF2-40B4-BE49-F238E27FC236}">
+                <a16:creationId xmlns:a16="http://schemas.microsoft.com/office/drawing/2014/main" id="{019EA250-8078-464C-B07B-2FB16C9C29E6}"/>
+              </a:ext>
+            </a:extLst>
+          </p:cNvPr>
+          <p:cNvSpPr>
+            <a:spLocks xmlns:a="http://schemas.openxmlformats.org/drawingml/2006/main" noGrp="1"/>
+          </p:cNvSpPr>
+          <p:nvPr/>
+        </p:nvSpPr>
+        <p:spPr>
+          <a:xfrm xmlns:a="http://schemas.openxmlformats.org/drawingml/2006/main">
+            <a:off x="8801100" y="5086350"/>
+            <a:ext cx="1095375" cy="381000"/>
           </a:xfrm>
           <a:prstGeom xmlns:a="http://schemas.openxmlformats.org/drawingml/2006/main" prst="rect">
             <a:avLst/>
@@ -10710,269 +11237,109 @@
           <a:lstStyle xmlns:a="http://schemas.openxmlformats.org/drawingml/2006/main"/>
           <a:p xmlns:a="http://schemas.openxmlformats.org/drawingml/2006/main">
             <a:pPr>
-              <a:defRPr sz="1950" b="1">
-                <a:solidFill>
-                  <a:srgbClr val="182C29"/>
-                </a:solidFill>
-                <a:latin typeface="Apple SD Gothic Neo"/>
-                <a:ea typeface="Apple SD Gothic Neo"/>
-                <a:cs typeface="Apple SD Gothic Neo"/>
-              </a:defRPr>
-            </a:pPr>
-            <a:r>
-              <a:rPr sz="1950" b="1">
-                <a:solidFill>
-                  <a:srgbClr val="182C29"/>
-                </a:solidFill>
-                <a:latin typeface="Apple SD Gothic Neo"/>
-                <a:ea typeface="Apple SD Gothic Neo"/>
-                <a:cs typeface="Apple SD Gothic Neo"/>
-              </a:rPr>
-              <a:t>에이전트 · 안내와 처리 결과</a:t>
-            </a:r>
-          </a:p>
-        </p:txBody>
-      </p:sp>
-      <p:sp>
-        <p:nvSpPr>
-          <p:cNvPr id="7" name="">
-            <a:extLst xmlns:a="http://schemas.openxmlformats.org/drawingml/2006/main">
-              <a:ext uri="{FF2B5EF4-FFF2-40B4-BE49-F238E27FC236}">
-                <a16:creationId xmlns:a16="http://schemas.microsoft.com/office/drawing/2014/main" id="{DF1FE83E-BF0C-4F13-991B-15B108233373}"/>
-              </a:ext>
-            </a:extLst>
-          </p:cNvPr>
-          <p:cNvSpPr>
-            <a:spLocks xmlns:a="http://schemas.openxmlformats.org/drawingml/2006/main" noGrp="1"/>
-          </p:cNvSpPr>
-          <p:nvPr/>
-        </p:nvSpPr>
-        <p:spPr>
-          <a:xfrm xmlns:a="http://schemas.openxmlformats.org/drawingml/2006/main">
-            <a:off x="819150" y="3600450"/>
-            <a:ext cx="6191250" cy="533400"/>
+              <a:defRPr sz="1800" b="1">
+                <a:solidFill>
+                  <a:srgbClr val="156E58"/>
+                </a:solidFill>
+                <a:latin typeface="Apple SD Gothic Neo"/>
+                <a:ea typeface="Apple SD Gothic Neo"/>
+                <a:cs typeface="Apple SD Gothic Neo"/>
+              </a:defRPr>
+            </a:pPr>
+            <a:r>
+              <a:rPr sz="1800" b="1">
+                <a:solidFill>
+                  <a:srgbClr val="156E58"/>
+                </a:solidFill>
+                <a:latin typeface="Apple SD Gothic Neo"/>
+                <a:ea typeface="Apple SD Gothic Neo"/>
+                <a:cs typeface="Apple SD Gothic Neo"/>
+              </a:rPr>
+              <a:t>나</a:t>
+            </a:r>
+          </a:p>
+        </p:txBody>
+      </p:sp>
+      <p:sp>
+        <p:nvSpPr>
+          <p:cNvPr id="10" name="">
+            <a:extLst xmlns:a="http://schemas.openxmlformats.org/drawingml/2006/main">
+              <a:ext uri="{FF2B5EF4-FFF2-40B4-BE49-F238E27FC236}">
+                <a16:creationId xmlns:a16="http://schemas.microsoft.com/office/drawing/2014/main" id="{69B8FAF9-333F-479B-8B96-6AA5F042DA82}"/>
+              </a:ext>
+            </a:extLst>
+          </p:cNvPr>
+          <p:cNvSpPr>
+            <a:spLocks xmlns:a="http://schemas.openxmlformats.org/drawingml/2006/main" noGrp="1"/>
+          </p:cNvSpPr>
+          <p:nvPr/>
+        </p:nvSpPr>
+        <p:spPr>
+          <a:xfrm xmlns:a="http://schemas.openxmlformats.org/drawingml/2006/main">
+            <a:off x="2000250" y="5953125"/>
+            <a:ext cx="5810250" cy="857250"/>
           </a:xfrm>
           <a:prstGeom xmlns:a="http://schemas.openxmlformats.org/drawingml/2006/main" prst="roundRect">
             <a:avLst>
-              <a:gd name="adj" fmla="val 14286"/>
-            </a:avLst>
-          </a:prstGeom>
-          <a:solidFill xmlns:a="http://schemas.openxmlformats.org/drawingml/2006/main">
-            <a:srgbClr val="E7F0E9"/>
-          </a:solidFill>
-          <a:ln xmlns:a="http://schemas.openxmlformats.org/drawingml/2006/main" w="9525">
-            <a:solidFill>
-              <a:srgbClr val="BACBC1"/>
-            </a:solidFill>
-          </a:ln>
-        </p:spPr>
-        <p:txBody>
-          <a:bodyPr xmlns:a="http://schemas.openxmlformats.org/drawingml/2006/main" lIns="171450" tIns="76200" rIns="133350" bIns="76200" anchor="ctr"/>
-          <a:lstStyle xmlns:a="http://schemas.openxmlformats.org/drawingml/2006/main"/>
-          <a:p xmlns:a="http://schemas.openxmlformats.org/drawingml/2006/main">
-            <a:pPr>
-              <a:defRPr sz="1950">
-                <a:solidFill>
-                  <a:srgbClr val="182C29"/>
-                </a:solidFill>
-                <a:latin typeface="Apple SD Gothic Neo"/>
-                <a:ea typeface="Apple SD Gothic Neo"/>
-                <a:cs typeface="Apple SD Gothic Neo"/>
-              </a:defRPr>
-            </a:pPr>
-            <a:r>
-              <a:rPr sz="1950">
-                <a:solidFill>
-                  <a:srgbClr val="182C29"/>
-                </a:solidFill>
-                <a:latin typeface="Apple SD Gothic Neo"/>
-                <a:ea typeface="Apple SD Gothic Neo"/>
-                <a:cs typeface="Apple SD Gothic Neo"/>
-              </a:rPr>
-              <a:t>① URL + 구매·배송신청 요청</a:t>
-            </a:r>
-          </a:p>
-        </p:txBody>
-      </p:sp>
-      <p:sp>
-        <p:nvSpPr>
-          <p:cNvPr id="8" name="">
-            <a:extLst xmlns:a="http://schemas.openxmlformats.org/drawingml/2006/main">
-              <a:ext uri="{FF2B5EF4-FFF2-40B4-BE49-F238E27FC236}">
-                <a16:creationId xmlns:a16="http://schemas.microsoft.com/office/drawing/2014/main" id="{449F87A0-CA49-4593-B940-9F532FFCFBFC}"/>
-              </a:ext>
-            </a:extLst>
-          </p:cNvPr>
-          <p:cNvSpPr>
-            <a:spLocks xmlns:a="http://schemas.openxmlformats.org/drawingml/2006/main" noGrp="1"/>
-          </p:cNvSpPr>
-          <p:nvPr/>
-        </p:nvSpPr>
-        <p:spPr>
-          <a:xfrm xmlns:a="http://schemas.openxmlformats.org/drawingml/2006/main">
-            <a:off x="7858125" y="3600450"/>
-            <a:ext cx="6562725" cy="533400"/>
-          </a:xfrm>
-          <a:prstGeom xmlns:a="http://schemas.openxmlformats.org/drawingml/2006/main" prst="roundRect">
-            <a:avLst>
-              <a:gd name="adj" fmla="val 14286"/>
+              <a:gd name="adj" fmla="val 8889"/>
             </a:avLst>
           </a:prstGeom>
           <a:solidFill xmlns:a="http://schemas.openxmlformats.org/drawingml/2006/main">
             <a:srgbClr val="FFFFFF"/>
           </a:solidFill>
-          <a:ln xmlns:a="http://schemas.openxmlformats.org/drawingml/2006/main" w="9525">
+          <a:ln xmlns:a="http://schemas.openxmlformats.org/drawingml/2006/main" w="19050">
             <a:solidFill>
-              <a:srgbClr val="BACBC1"/>
+              <a:srgbClr val="183E34"/>
             </a:solidFill>
           </a:ln>
         </p:spPr>
         <p:txBody>
-          <a:bodyPr xmlns:a="http://schemas.openxmlformats.org/drawingml/2006/main" lIns="171450" tIns="76200" rIns="133350" bIns="76200" anchor="ctr"/>
-          <a:lstStyle xmlns:a="http://schemas.openxmlformats.org/drawingml/2006/main"/>
-          <a:p xmlns:a="http://schemas.openxmlformats.org/drawingml/2006/main">
-            <a:pPr>
-              <a:defRPr sz="1950">
-                <a:solidFill>
-                  <a:srgbClr val="182C29"/>
-                </a:solidFill>
-                <a:latin typeface="Apple SD Gothic Neo"/>
-                <a:ea typeface="Apple SD Gothic Neo"/>
-                <a:cs typeface="Apple SD Gothic Neo"/>
-              </a:defRPr>
-            </a:pPr>
-            <a:r>
-              <a:rPr sz="1950">
-                <a:solidFill>
-                  <a:srgbClr val="182C29"/>
-                </a:solidFill>
-                <a:latin typeface="Apple SD Gothic Neo"/>
-                <a:ea typeface="Apple SD Gothic Neo"/>
-                <a:cs typeface="Apple SD Gothic Neo"/>
-              </a:rPr>
-              <a:t>상품 확인 → 로그인 안내</a:t>
-            </a:r>
-          </a:p>
-        </p:txBody>
-      </p:sp>
-      <p:sp>
-        <p:nvSpPr>
-          <p:cNvPr id="9" name="">
-            <a:extLst xmlns:a="http://schemas.openxmlformats.org/drawingml/2006/main">
-              <a:ext uri="{FF2B5EF4-FFF2-40B4-BE49-F238E27FC236}">
-                <a16:creationId xmlns:a16="http://schemas.microsoft.com/office/drawing/2014/main" id="{6DCA3919-EF80-4ECC-9EE8-3F04DF62EE7B}"/>
-              </a:ext>
-            </a:extLst>
-          </p:cNvPr>
-          <p:cNvSpPr>
-            <a:spLocks xmlns:a="http://schemas.openxmlformats.org/drawingml/2006/main" noGrp="1"/>
-          </p:cNvSpPr>
-          <p:nvPr/>
-        </p:nvSpPr>
-        <p:spPr>
-          <a:xfrm xmlns:a="http://schemas.openxmlformats.org/drawingml/2006/main">
-            <a:off x="819150" y="4219575"/>
-            <a:ext cx="6191250" cy="533400"/>
-          </a:xfrm>
-          <a:prstGeom xmlns:a="http://schemas.openxmlformats.org/drawingml/2006/main" prst="roundRect">
-            <a:avLst>
-              <a:gd name="adj" fmla="val 14286"/>
-            </a:avLst>
-          </a:prstGeom>
-          <a:solidFill xmlns:a="http://schemas.openxmlformats.org/drawingml/2006/main">
-            <a:srgbClr val="E7F0E9"/>
-          </a:solidFill>
-          <a:ln xmlns:a="http://schemas.openxmlformats.org/drawingml/2006/main" w="9525">
-            <a:solidFill>
-              <a:srgbClr val="BACBC1"/>
-            </a:solidFill>
-          </a:ln>
-        </p:spPr>
-        <p:txBody>
-          <a:bodyPr xmlns:a="http://schemas.openxmlformats.org/drawingml/2006/main" lIns="171450" tIns="76200" rIns="133350" bIns="76200" anchor="ctr"/>
-          <a:lstStyle xmlns:a="http://schemas.openxmlformats.org/drawingml/2006/main"/>
-          <a:p xmlns:a="http://schemas.openxmlformats.org/drawingml/2006/main">
-            <a:pPr>
-              <a:defRPr sz="1950">
-                <a:solidFill>
-                  <a:srgbClr val="182C29"/>
-                </a:solidFill>
-                <a:latin typeface="Apple SD Gothic Neo"/>
-                <a:ea typeface="Apple SD Gothic Neo"/>
-                <a:cs typeface="Apple SD Gothic Neo"/>
-              </a:defRPr>
-            </a:pPr>
-            <a:r>
-              <a:rPr sz="1950">
-                <a:solidFill>
-                  <a:srgbClr val="182C29"/>
-                </a:solidFill>
-                <a:latin typeface="Apple SD Gothic Neo"/>
-                <a:ea typeface="Apple SD Gothic Neo"/>
-                <a:cs typeface="Apple SD Gothic Neo"/>
-              </a:rPr>
-              <a:t>②·③ 각 사이트 로그인 완료</a:t>
-            </a:r>
-          </a:p>
-        </p:txBody>
-      </p:sp>
-      <p:sp>
-        <p:nvSpPr>
-          <p:cNvPr id="10" name="">
-            <a:extLst xmlns:a="http://schemas.openxmlformats.org/drawingml/2006/main">
-              <a:ext uri="{FF2B5EF4-FFF2-40B4-BE49-F238E27FC236}">
-                <a16:creationId xmlns:a16="http://schemas.microsoft.com/office/drawing/2014/main" id="{4BF29A7A-4E5E-450E-A766-3ECF356C718E}"/>
-              </a:ext>
-            </a:extLst>
-          </p:cNvPr>
-          <p:cNvSpPr>
-            <a:spLocks xmlns:a="http://schemas.openxmlformats.org/drawingml/2006/main" noGrp="1"/>
-          </p:cNvSpPr>
-          <p:nvPr/>
-        </p:nvSpPr>
-        <p:spPr>
-          <a:xfrm xmlns:a="http://schemas.openxmlformats.org/drawingml/2006/main">
-            <a:off x="7858125" y="4219575"/>
-            <a:ext cx="6562725" cy="533400"/>
-          </a:xfrm>
-          <a:prstGeom xmlns:a="http://schemas.openxmlformats.org/drawingml/2006/main" prst="roundRect">
-            <a:avLst>
-              <a:gd name="adj" fmla="val 14286"/>
-            </a:avLst>
-          </a:prstGeom>
-          <a:solidFill xmlns:a="http://schemas.openxmlformats.org/drawingml/2006/main">
-            <a:srgbClr val="FFFFFF"/>
-          </a:solidFill>
-          <a:ln xmlns:a="http://schemas.openxmlformats.org/drawingml/2006/main" w="9525">
-            <a:solidFill>
-              <a:srgbClr val="BACBC1"/>
-            </a:solidFill>
-          </a:ln>
-        </p:spPr>
-        <p:txBody>
-          <a:bodyPr xmlns:a="http://schemas.openxmlformats.org/drawingml/2006/main" lIns="171450" tIns="76200" rIns="133350" bIns="76200" anchor="ctr"/>
-          <a:lstStyle xmlns:a="http://schemas.openxmlformats.org/drawingml/2006/main"/>
-          <a:p xmlns:a="http://schemas.openxmlformats.org/drawingml/2006/main">
-            <a:pPr>
-              <a:defRPr sz="1950">
-                <a:solidFill>
-                  <a:srgbClr val="182C29"/>
-                </a:solidFill>
-                <a:latin typeface="Apple SD Gothic Neo"/>
-                <a:ea typeface="Apple SD Gothic Neo"/>
-                <a:cs typeface="Apple SD Gothic Neo"/>
-              </a:defRPr>
-            </a:pPr>
-            <a:r>
-              <a:rPr sz="1950">
-                <a:solidFill>
-                  <a:srgbClr val="182C29"/>
-                </a:solidFill>
-                <a:latin typeface="Apple SD Gothic Neo"/>
-                <a:ea typeface="Apple SD Gothic Neo"/>
-                <a:cs typeface="Apple SD Gothic Neo"/>
-              </a:rPr>
-              <a:t>배송지 확인 → 정보 입력 승인 요청</a:t>
+          <a:bodyPr xmlns:a="http://schemas.openxmlformats.org/drawingml/2006/main" lIns="228600" tIns="114300" rIns="209550" bIns="114300" anchor="ctr"/>
+          <a:lstStyle xmlns:a="http://schemas.openxmlformats.org/drawingml/2006/main"/>
+          <a:p xmlns:a="http://schemas.openxmlformats.org/drawingml/2006/main">
+            <a:pPr>
+              <a:defRPr sz="2100">
+                <a:solidFill>
+                  <a:srgbClr val="182C29"/>
+                </a:solidFill>
+                <a:latin typeface="Apple SD Gothic Neo"/>
+                <a:ea typeface="Apple SD Gothic Neo"/>
+                <a:cs typeface="Apple SD Gothic Neo"/>
+              </a:defRPr>
+            </a:pPr>
+            <a:r>
+              <a:rPr sz="2100">
+                <a:solidFill>
+                  <a:srgbClr val="182C29"/>
+                </a:solidFill>
+                <a:latin typeface="Apple SD Gothic Neo"/>
+                <a:ea typeface="Apple SD Gothic Neo"/>
+                <a:cs typeface="Apple SD Gothic Neo"/>
+              </a:rPr>
+              <a:t>주문 정보를 대조하고 신청서 작성</a:t>
+            </a:r>
+          </a:p>
+          <a:p xmlns:a="http://schemas.openxmlformats.org/drawingml/2006/main">
+            <a:pPr>
+              <a:defRPr sz="2100">
+                <a:solidFill>
+                  <a:srgbClr val="182C29"/>
+                </a:solidFill>
+                <a:latin typeface="Apple SD Gothic Neo"/>
+                <a:ea typeface="Apple SD Gothic Neo"/>
+                <a:cs typeface="Apple SD Gothic Neo"/>
+              </a:defRPr>
+            </a:pPr>
+            <a:r>
+              <a:rPr sz="2100">
+                <a:solidFill>
+                  <a:srgbClr val="182C29"/>
+                </a:solidFill>
+                <a:latin typeface="Apple SD Gothic Neo"/>
+                <a:ea typeface="Apple SD Gothic Neo"/>
+                <a:cs typeface="Apple SD Gothic Neo"/>
+              </a:rPr>
+              <a:t>인증 후 같은 신청서로 접수 완료</a:t>
             </a:r>
           </a:p>
         </p:txBody>
@@ -10982,507 +11349,19 @@
           <p:cNvPr id="11" name="">
             <a:extLst xmlns:a="http://schemas.openxmlformats.org/drawingml/2006/main">
               <a:ext uri="{FF2B5EF4-FFF2-40B4-BE49-F238E27FC236}">
-                <a16:creationId xmlns:a16="http://schemas.microsoft.com/office/drawing/2014/main" id="{258CA54B-4FE5-4C6A-A2B1-727FF4E6D282}"/>
-              </a:ext>
-            </a:extLst>
-          </p:cNvPr>
-          <p:cNvSpPr>
-            <a:spLocks xmlns:a="http://schemas.openxmlformats.org/drawingml/2006/main" noGrp="1"/>
-          </p:cNvSpPr>
-          <p:nvPr/>
-        </p:nvSpPr>
-        <p:spPr>
-          <a:xfrm xmlns:a="http://schemas.openxmlformats.org/drawingml/2006/main">
-            <a:off x="819150" y="4838700"/>
-            <a:ext cx="6191250" cy="533400"/>
-          </a:xfrm>
-          <a:prstGeom xmlns:a="http://schemas.openxmlformats.org/drawingml/2006/main" prst="roundRect">
-            <a:avLst>
-              <a:gd name="adj" fmla="val 14286"/>
-            </a:avLst>
-          </a:prstGeom>
-          <a:solidFill xmlns:a="http://schemas.openxmlformats.org/drawingml/2006/main">
-            <a:srgbClr val="E7F0E9"/>
-          </a:solidFill>
-          <a:ln xmlns:a="http://schemas.openxmlformats.org/drawingml/2006/main" w="9525">
-            <a:solidFill>
-              <a:srgbClr val="BACBC1"/>
-            </a:solidFill>
-          </a:ln>
-        </p:spPr>
-        <p:txBody>
-          <a:bodyPr xmlns:a="http://schemas.openxmlformats.org/drawingml/2006/main" lIns="171450" tIns="76200" rIns="133350" bIns="76200" anchor="ctr"/>
-          <a:lstStyle xmlns:a="http://schemas.openxmlformats.org/drawingml/2006/main"/>
-          <a:p xmlns:a="http://schemas.openxmlformats.org/drawingml/2006/main">
-            <a:pPr>
-              <a:defRPr sz="1950">
-                <a:solidFill>
-                  <a:srgbClr val="182C29"/>
-                </a:solidFill>
-                <a:latin typeface="Apple SD Gothic Neo"/>
-                <a:ea typeface="Apple SD Gothic Neo"/>
-                <a:cs typeface="Apple SD Gothic Neo"/>
-              </a:defRPr>
-            </a:pPr>
-            <a:r>
-              <a:rPr sz="1950">
-                <a:solidFill>
-                  <a:srgbClr val="182C29"/>
-                </a:solidFill>
-                <a:latin typeface="Apple SD Gothic Neo"/>
-                <a:ea typeface="Apple SD Gothic Neo"/>
-                <a:cs typeface="Apple SD Gothic Neo"/>
-              </a:rPr>
-              <a:t>④ 주소 입력 승인 + 무게 조건 보완</a:t>
-            </a:r>
-          </a:p>
-        </p:txBody>
-      </p:sp>
-      <p:sp>
-        <p:nvSpPr>
-          <p:cNvPr id="12" name="">
-            <a:extLst xmlns:a="http://schemas.openxmlformats.org/drawingml/2006/main">
-              <a:ext uri="{FF2B5EF4-FFF2-40B4-BE49-F238E27FC236}">
-                <a16:creationId xmlns:a16="http://schemas.microsoft.com/office/drawing/2014/main" id="{6703FE29-B042-42C1-8A37-0AA351D0D43E}"/>
-              </a:ext>
-            </a:extLst>
-          </p:cNvPr>
-          <p:cNvSpPr>
-            <a:spLocks xmlns:a="http://schemas.openxmlformats.org/drawingml/2006/main" noGrp="1"/>
-          </p:cNvSpPr>
-          <p:nvPr/>
-        </p:nvSpPr>
-        <p:spPr>
-          <a:xfrm xmlns:a="http://schemas.openxmlformats.org/drawingml/2006/main">
-            <a:off x="7858125" y="4838700"/>
-            <a:ext cx="6562725" cy="533400"/>
-          </a:xfrm>
-          <a:prstGeom xmlns:a="http://schemas.openxmlformats.org/drawingml/2006/main" prst="roundRect">
-            <a:avLst>
-              <a:gd name="adj" fmla="val 14286"/>
-            </a:avLst>
-          </a:prstGeom>
-          <a:solidFill xmlns:a="http://schemas.openxmlformats.org/drawingml/2006/main">
-            <a:srgbClr val="FFFFFF"/>
-          </a:solidFill>
-          <a:ln xmlns:a="http://schemas.openxmlformats.org/drawingml/2006/main" w="9525">
-            <a:solidFill>
-              <a:srgbClr val="BACBC1"/>
-            </a:solidFill>
-          </a:ln>
-        </p:spPr>
-        <p:txBody>
-          <a:bodyPr xmlns:a="http://schemas.openxmlformats.org/drawingml/2006/main" lIns="171450" tIns="76200" rIns="133350" bIns="76200" anchor="ctr"/>
-          <a:lstStyle xmlns:a="http://schemas.openxmlformats.org/drawingml/2006/main"/>
-          <a:p xmlns:a="http://schemas.openxmlformats.org/drawingml/2006/main">
-            <a:pPr>
-              <a:defRPr sz="1950">
-                <a:solidFill>
-                  <a:srgbClr val="182C29"/>
-                </a:solidFill>
-                <a:latin typeface="Apple SD Gothic Neo"/>
-                <a:ea typeface="Apple SD Gothic Neo"/>
-                <a:cs typeface="Apple SD Gothic Neo"/>
-              </a:defRPr>
-            </a:pPr>
-            <a:r>
-              <a:rPr sz="1950">
-                <a:solidFill>
-                  <a:srgbClr val="182C29"/>
-                </a:solidFill>
-                <a:latin typeface="Apple SD Gothic Neo"/>
-                <a:ea typeface="Apple SD Gothic Neo"/>
-                <a:cs typeface="Apple SD Gothic Neo"/>
-              </a:rPr>
-              <a:t>주소 입력·견적 비교 → 구매 확정 안내</a:t>
-            </a:r>
-          </a:p>
-        </p:txBody>
-      </p:sp>
-      <p:sp>
-        <p:nvSpPr>
-          <p:cNvPr id="13" name="">
-            <a:extLst xmlns:a="http://schemas.openxmlformats.org/drawingml/2006/main">
-              <a:ext uri="{FF2B5EF4-FFF2-40B4-BE49-F238E27FC236}">
-                <a16:creationId xmlns:a16="http://schemas.microsoft.com/office/drawing/2014/main" id="{E1C32957-A014-484B-BF7F-42D93636D5A0}"/>
-              </a:ext>
-            </a:extLst>
-          </p:cNvPr>
-          <p:cNvSpPr>
-            <a:spLocks xmlns:a="http://schemas.openxmlformats.org/drawingml/2006/main" noGrp="1"/>
-          </p:cNvSpPr>
-          <p:nvPr/>
-        </p:nvSpPr>
-        <p:spPr>
-          <a:xfrm xmlns:a="http://schemas.openxmlformats.org/drawingml/2006/main">
-            <a:off x="819150" y="5457825"/>
-            <a:ext cx="6191250" cy="533400"/>
-          </a:xfrm>
-          <a:prstGeom xmlns:a="http://schemas.openxmlformats.org/drawingml/2006/main" prst="roundRect">
-            <a:avLst>
-              <a:gd name="adj" fmla="val 14286"/>
-            </a:avLst>
-          </a:prstGeom>
-          <a:solidFill xmlns:a="http://schemas.openxmlformats.org/drawingml/2006/main">
-            <a:srgbClr val="E7F0E9"/>
-          </a:solidFill>
-          <a:ln xmlns:a="http://schemas.openxmlformats.org/drawingml/2006/main" w="9525">
-            <a:solidFill>
-              <a:srgbClr val="BACBC1"/>
-            </a:solidFill>
-          </a:ln>
-        </p:spPr>
-        <p:txBody>
-          <a:bodyPr xmlns:a="http://schemas.openxmlformats.org/drawingml/2006/main" lIns="171450" tIns="76200" rIns="133350" bIns="76200" anchor="ctr"/>
-          <a:lstStyle xmlns:a="http://schemas.openxmlformats.org/drawingml/2006/main"/>
-          <a:p xmlns:a="http://schemas.openxmlformats.org/drawingml/2006/main">
-            <a:pPr>
-              <a:defRPr sz="1950">
-                <a:solidFill>
-                  <a:srgbClr val="182C29"/>
-                </a:solidFill>
-                <a:latin typeface="Apple SD Gothic Neo"/>
-                <a:ea typeface="Apple SD Gothic Neo"/>
-                <a:cs typeface="Apple SD Gothic Neo"/>
-              </a:defRPr>
-            </a:pPr>
-            <a:r>
-              <a:rPr sz="1950">
-                <a:solidFill>
-                  <a:srgbClr val="182C29"/>
-                </a:solidFill>
-                <a:latin typeface="Apple SD Gothic Neo"/>
-                <a:ea typeface="Apple SD Gothic Neo"/>
-                <a:cs typeface="Apple SD Gothic Neo"/>
-              </a:rPr>
-              <a:t>⑤ 직접 구매 완료 알림</a:t>
-            </a:r>
-          </a:p>
-        </p:txBody>
-      </p:sp>
-      <p:sp>
-        <p:nvSpPr>
-          <p:cNvPr id="14" name="">
-            <a:extLst xmlns:a="http://schemas.openxmlformats.org/drawingml/2006/main">
-              <a:ext uri="{FF2B5EF4-FFF2-40B4-BE49-F238E27FC236}">
-                <a16:creationId xmlns:a16="http://schemas.microsoft.com/office/drawing/2014/main" id="{9044F2ED-9429-45FA-833F-9827C05CF22F}"/>
-              </a:ext>
-            </a:extLst>
-          </p:cNvPr>
-          <p:cNvSpPr>
-            <a:spLocks xmlns:a="http://schemas.openxmlformats.org/drawingml/2006/main" noGrp="1"/>
-          </p:cNvSpPr>
-          <p:nvPr/>
-        </p:nvSpPr>
-        <p:spPr>
-          <a:xfrm xmlns:a="http://schemas.openxmlformats.org/drawingml/2006/main">
-            <a:off x="7858125" y="5457825"/>
-            <a:ext cx="6562725" cy="533400"/>
-          </a:xfrm>
-          <a:prstGeom xmlns:a="http://schemas.openxmlformats.org/drawingml/2006/main" prst="roundRect">
-            <a:avLst>
-              <a:gd name="adj" fmla="val 14286"/>
-            </a:avLst>
-          </a:prstGeom>
-          <a:solidFill xmlns:a="http://schemas.openxmlformats.org/drawingml/2006/main">
-            <a:srgbClr val="FFFFFF"/>
-          </a:solidFill>
-          <a:ln xmlns:a="http://schemas.openxmlformats.org/drawingml/2006/main" w="9525">
-            <a:solidFill>
-              <a:srgbClr val="BACBC1"/>
-            </a:solidFill>
-          </a:ln>
-        </p:spPr>
-        <p:txBody>
-          <a:bodyPr xmlns:a="http://schemas.openxmlformats.org/drawingml/2006/main" lIns="171450" tIns="76200" rIns="133350" bIns="76200" anchor="ctr"/>
-          <a:lstStyle xmlns:a="http://schemas.openxmlformats.org/drawingml/2006/main"/>
-          <a:p xmlns:a="http://schemas.openxmlformats.org/drawingml/2006/main">
-            <a:pPr>
-              <a:defRPr sz="1950">
-                <a:solidFill>
-                  <a:srgbClr val="182C29"/>
-                </a:solidFill>
-                <a:latin typeface="Apple SD Gothic Neo"/>
-                <a:ea typeface="Apple SD Gothic Neo"/>
-                <a:cs typeface="Apple SD Gothic Neo"/>
-              </a:defRPr>
-            </a:pPr>
-            <a:r>
-              <a:rPr sz="1950">
-                <a:solidFill>
-                  <a:srgbClr val="182C29"/>
-                </a:solidFill>
-                <a:latin typeface="Apple SD Gothic Neo"/>
-                <a:ea typeface="Apple SD Gothic Neo"/>
-                <a:cs typeface="Apple SD Gothic Neo"/>
-              </a:rPr>
-              <a:t>주문 대조·신청서 작성 → 제출 확인</a:t>
-            </a:r>
-          </a:p>
-        </p:txBody>
-      </p:sp>
-      <p:sp>
-        <p:nvSpPr>
-          <p:cNvPr id="15" name="">
-            <a:extLst xmlns:a="http://schemas.openxmlformats.org/drawingml/2006/main">
-              <a:ext uri="{FF2B5EF4-FFF2-40B4-BE49-F238E27FC236}">
-                <a16:creationId xmlns:a16="http://schemas.microsoft.com/office/drawing/2014/main" id="{7D463F1E-7FFE-4869-8244-943EC2F9D35B}"/>
-              </a:ext>
-            </a:extLst>
-          </p:cNvPr>
-          <p:cNvSpPr>
-            <a:spLocks xmlns:a="http://schemas.openxmlformats.org/drawingml/2006/main" noGrp="1"/>
-          </p:cNvSpPr>
-          <p:nvPr/>
-        </p:nvSpPr>
-        <p:spPr>
-          <a:xfrm xmlns:a="http://schemas.openxmlformats.org/drawingml/2006/main">
-            <a:off x="819150" y="6076950"/>
-            <a:ext cx="6191250" cy="533400"/>
-          </a:xfrm>
-          <a:prstGeom xmlns:a="http://schemas.openxmlformats.org/drawingml/2006/main" prst="roundRect">
-            <a:avLst>
-              <a:gd name="adj" fmla="val 14286"/>
-            </a:avLst>
-          </a:prstGeom>
-          <a:solidFill xmlns:a="http://schemas.openxmlformats.org/drawingml/2006/main">
-            <a:srgbClr val="E7F0E9"/>
-          </a:solidFill>
-          <a:ln xmlns:a="http://schemas.openxmlformats.org/drawingml/2006/main" w="9525">
-            <a:solidFill>
-              <a:srgbClr val="BACBC1"/>
-            </a:solidFill>
-          </a:ln>
-        </p:spPr>
-        <p:txBody>
-          <a:bodyPr xmlns:a="http://schemas.openxmlformats.org/drawingml/2006/main" lIns="171450" tIns="76200" rIns="133350" bIns="76200" anchor="ctr"/>
-          <a:lstStyle xmlns:a="http://schemas.openxmlformats.org/drawingml/2006/main"/>
-          <a:p xmlns:a="http://schemas.openxmlformats.org/drawingml/2006/main">
-            <a:pPr>
-              <a:defRPr sz="1950">
-                <a:solidFill>
-                  <a:srgbClr val="182C29"/>
-                </a:solidFill>
-                <a:latin typeface="Apple SD Gothic Neo"/>
-                <a:ea typeface="Apple SD Gothic Neo"/>
-                <a:cs typeface="Apple SD Gothic Neo"/>
-              </a:defRPr>
-            </a:pPr>
-            <a:r>
-              <a:rPr sz="1950">
-                <a:solidFill>
-                  <a:srgbClr val="182C29"/>
-                </a:solidFill>
-                <a:latin typeface="Apple SD Gothic Neo"/>
-                <a:ea typeface="Apple SD Gothic Neo"/>
-                <a:cs typeface="Apple SD Gothic Neo"/>
-              </a:rPr>
-              <a:t>⑥ 제출 진행 승인</a:t>
-            </a:r>
-          </a:p>
-        </p:txBody>
-      </p:sp>
-      <p:sp>
-        <p:nvSpPr>
-          <p:cNvPr id="16" name="">
-            <a:extLst xmlns:a="http://schemas.openxmlformats.org/drawingml/2006/main">
-              <a:ext uri="{FF2B5EF4-FFF2-40B4-BE49-F238E27FC236}">
-                <a16:creationId xmlns:a16="http://schemas.microsoft.com/office/drawing/2014/main" id="{6FF7B044-74D0-440F-9CF4-ABBF5AFE8639}"/>
-              </a:ext>
-            </a:extLst>
-          </p:cNvPr>
-          <p:cNvSpPr>
-            <a:spLocks xmlns:a="http://schemas.openxmlformats.org/drawingml/2006/main" noGrp="1"/>
-          </p:cNvSpPr>
-          <p:nvPr/>
-        </p:nvSpPr>
-        <p:spPr>
-          <a:xfrm xmlns:a="http://schemas.openxmlformats.org/drawingml/2006/main">
-            <a:off x="7858125" y="6076950"/>
-            <a:ext cx="6562725" cy="533400"/>
-          </a:xfrm>
-          <a:prstGeom xmlns:a="http://schemas.openxmlformats.org/drawingml/2006/main" prst="roundRect">
-            <a:avLst>
-              <a:gd name="adj" fmla="val 14286"/>
-            </a:avLst>
-          </a:prstGeom>
-          <a:solidFill xmlns:a="http://schemas.openxmlformats.org/drawingml/2006/main">
-            <a:srgbClr val="FFFFFF"/>
-          </a:solidFill>
-          <a:ln xmlns:a="http://schemas.openxmlformats.org/drawingml/2006/main" w="9525">
-            <a:solidFill>
-              <a:srgbClr val="BACBC1"/>
-            </a:solidFill>
-          </a:ln>
-        </p:spPr>
-        <p:txBody>
-          <a:bodyPr xmlns:a="http://schemas.openxmlformats.org/drawingml/2006/main" lIns="171450" tIns="76200" rIns="133350" bIns="76200" anchor="ctr"/>
-          <a:lstStyle xmlns:a="http://schemas.openxmlformats.org/drawingml/2006/main"/>
-          <a:p xmlns:a="http://schemas.openxmlformats.org/drawingml/2006/main">
-            <a:pPr>
-              <a:defRPr sz="1950">
-                <a:solidFill>
-                  <a:srgbClr val="182C29"/>
-                </a:solidFill>
-                <a:latin typeface="Apple SD Gothic Neo"/>
-                <a:ea typeface="Apple SD Gothic Neo"/>
-                <a:cs typeface="Apple SD Gothic Neo"/>
-              </a:defRPr>
-            </a:pPr>
-            <a:r>
-              <a:rPr sz="1950">
-                <a:solidFill>
-                  <a:srgbClr val="182C29"/>
-                </a:solidFill>
-                <a:latin typeface="Apple SD Gothic Neo"/>
-                <a:ea typeface="Apple SD Gothic Neo"/>
-                <a:cs typeface="Apple SD Gothic Neo"/>
-              </a:rPr>
-              <a:t>제출 시도 → 통관 인증 안내</a:t>
-            </a:r>
-          </a:p>
-        </p:txBody>
-      </p:sp>
-      <p:sp>
-        <p:nvSpPr>
-          <p:cNvPr id="17" name="">
-            <a:extLst xmlns:a="http://schemas.openxmlformats.org/drawingml/2006/main">
-              <a:ext uri="{FF2B5EF4-FFF2-40B4-BE49-F238E27FC236}">
-                <a16:creationId xmlns:a16="http://schemas.microsoft.com/office/drawing/2014/main" id="{BAA57B47-FCF4-4CF1-9849-C9216973A38D}"/>
-              </a:ext>
-            </a:extLst>
-          </p:cNvPr>
-          <p:cNvSpPr>
-            <a:spLocks xmlns:a="http://schemas.openxmlformats.org/drawingml/2006/main" noGrp="1"/>
-          </p:cNvSpPr>
-          <p:nvPr/>
-        </p:nvSpPr>
-        <p:spPr>
-          <a:xfrm xmlns:a="http://schemas.openxmlformats.org/drawingml/2006/main">
-            <a:off x="819150" y="6696075"/>
-            <a:ext cx="6191250" cy="533400"/>
-          </a:xfrm>
-          <a:prstGeom xmlns:a="http://schemas.openxmlformats.org/drawingml/2006/main" prst="roundRect">
-            <a:avLst>
-              <a:gd name="adj" fmla="val 14286"/>
-            </a:avLst>
-          </a:prstGeom>
-          <a:solidFill xmlns:a="http://schemas.openxmlformats.org/drawingml/2006/main">
-            <a:srgbClr val="E7F0E9"/>
-          </a:solidFill>
-          <a:ln xmlns:a="http://schemas.openxmlformats.org/drawingml/2006/main" w="9525">
-            <a:solidFill>
-              <a:srgbClr val="BACBC1"/>
-            </a:solidFill>
-          </a:ln>
-        </p:spPr>
-        <p:txBody>
-          <a:bodyPr xmlns:a="http://schemas.openxmlformats.org/drawingml/2006/main" lIns="171450" tIns="76200" rIns="133350" bIns="76200" anchor="ctr"/>
-          <a:lstStyle xmlns:a="http://schemas.openxmlformats.org/drawingml/2006/main"/>
-          <a:p xmlns:a="http://schemas.openxmlformats.org/drawingml/2006/main">
-            <a:pPr>
-              <a:defRPr sz="1950">
-                <a:solidFill>
-                  <a:srgbClr val="182C29"/>
-                </a:solidFill>
-                <a:latin typeface="Apple SD Gothic Neo"/>
-                <a:ea typeface="Apple SD Gothic Neo"/>
-                <a:cs typeface="Apple SD Gothic Neo"/>
-              </a:defRPr>
-            </a:pPr>
-            <a:r>
-              <a:rPr sz="1950">
-                <a:solidFill>
-                  <a:srgbClr val="182C29"/>
-                </a:solidFill>
-                <a:latin typeface="Apple SD Gothic Neo"/>
-                <a:ea typeface="Apple SD Gothic Neo"/>
-                <a:cs typeface="Apple SD Gothic Neo"/>
-              </a:rPr>
-              <a:t>⑦ 인증 완료 알림</a:t>
-            </a:r>
-          </a:p>
-        </p:txBody>
-      </p:sp>
-      <p:sp>
-        <p:nvSpPr>
-          <p:cNvPr id="18" name="">
-            <a:extLst xmlns:a="http://schemas.openxmlformats.org/drawingml/2006/main">
-              <a:ext uri="{FF2B5EF4-FFF2-40B4-BE49-F238E27FC236}">
-                <a16:creationId xmlns:a16="http://schemas.microsoft.com/office/drawing/2014/main" id="{2F6799A4-6D49-4CF6-BE8B-71DA9190A10D}"/>
-              </a:ext>
-            </a:extLst>
-          </p:cNvPr>
-          <p:cNvSpPr>
-            <a:spLocks xmlns:a="http://schemas.openxmlformats.org/drawingml/2006/main" noGrp="1"/>
-          </p:cNvSpPr>
-          <p:nvPr/>
-        </p:nvSpPr>
-        <p:spPr>
-          <a:xfrm xmlns:a="http://schemas.openxmlformats.org/drawingml/2006/main">
-            <a:off x="7858125" y="6696075"/>
-            <a:ext cx="6562725" cy="533400"/>
-          </a:xfrm>
-          <a:prstGeom xmlns:a="http://schemas.openxmlformats.org/drawingml/2006/main" prst="roundRect">
-            <a:avLst>
-              <a:gd name="adj" fmla="val 14286"/>
-            </a:avLst>
-          </a:prstGeom>
-          <a:solidFill xmlns:a="http://schemas.openxmlformats.org/drawingml/2006/main">
-            <a:srgbClr val="FFFFFF"/>
-          </a:solidFill>
-          <a:ln xmlns:a="http://schemas.openxmlformats.org/drawingml/2006/main" w="9525">
-            <a:solidFill>
-              <a:srgbClr val="BACBC1"/>
-            </a:solidFill>
-          </a:ln>
-        </p:spPr>
-        <p:txBody>
-          <a:bodyPr xmlns:a="http://schemas.openxmlformats.org/drawingml/2006/main" lIns="171450" tIns="76200" rIns="133350" bIns="76200" anchor="ctr"/>
-          <a:lstStyle xmlns:a="http://schemas.openxmlformats.org/drawingml/2006/main"/>
-          <a:p xmlns:a="http://schemas.openxmlformats.org/drawingml/2006/main">
-            <a:pPr>
-              <a:defRPr sz="1950">
-                <a:solidFill>
-                  <a:srgbClr val="182C29"/>
-                </a:solidFill>
-                <a:latin typeface="Apple SD Gothic Neo"/>
-                <a:ea typeface="Apple SD Gothic Neo"/>
-                <a:cs typeface="Apple SD Gothic Neo"/>
-              </a:defRPr>
-            </a:pPr>
-            <a:r>
-              <a:rPr sz="1950">
-                <a:solidFill>
-                  <a:srgbClr val="182C29"/>
-                </a:solidFill>
-                <a:latin typeface="Apple SD Gothic Neo"/>
-                <a:ea typeface="Apple SD Gothic Neo"/>
-                <a:cs typeface="Apple SD Gothic Neo"/>
-              </a:rPr>
-              <a:t>동일 신청서 제출 → 접수 완료 확인</a:t>
-            </a:r>
-          </a:p>
-        </p:txBody>
-      </p:sp>
-      <p:sp>
-        <p:nvSpPr>
-          <p:cNvPr id="19" name="">
-            <a:extLst xmlns:a="http://schemas.openxmlformats.org/drawingml/2006/main">
-              <a:ext uri="{FF2B5EF4-FFF2-40B4-BE49-F238E27FC236}">
-                <a16:creationId xmlns:a16="http://schemas.microsoft.com/office/drawing/2014/main" id="{23155AFE-A472-4056-8AE3-C8D64678BE8C}"/>
-              </a:ext>
-            </a:extLst>
-          </p:cNvPr>
-          <p:cNvSpPr>
-            <a:spLocks xmlns:a="http://schemas.openxmlformats.org/drawingml/2006/main" noGrp="1"/>
-          </p:cNvSpPr>
-          <p:nvPr/>
-        </p:nvSpPr>
-        <p:spPr>
-          <a:xfrm xmlns:a="http://schemas.openxmlformats.org/drawingml/2006/main">
-            <a:off x="819150" y="7572375"/>
-            <a:ext cx="13525500" cy="323850"/>
+                <a16:creationId xmlns:a16="http://schemas.microsoft.com/office/drawing/2014/main" id="{47127725-47F8-4BA2-B02E-62A57EA285D8}"/>
+              </a:ext>
+            </a:extLst>
+          </p:cNvPr>
+          <p:cNvSpPr>
+            <a:spLocks xmlns:a="http://schemas.openxmlformats.org/drawingml/2006/main" noGrp="1"/>
+          </p:cNvSpPr>
+          <p:nvPr/>
+        </p:nvSpPr>
+        <p:spPr>
+          <a:xfrm xmlns:a="http://schemas.openxmlformats.org/drawingml/2006/main">
+            <a:off x="809625" y="6200775"/>
+            <a:ext cx="1095375" cy="381000"/>
           </a:xfrm>
           <a:prstGeom xmlns:a="http://schemas.openxmlformats.org/drawingml/2006/main" prst="rect">
             <a:avLst/>
@@ -11499,7 +11378,143 @@
           <a:lstStyle xmlns:a="http://schemas.openxmlformats.org/drawingml/2006/main"/>
           <a:p xmlns:a="http://schemas.openxmlformats.org/drawingml/2006/main">
             <a:pPr>
-              <a:defRPr sz="1650" b="0">
+              <a:defRPr sz="1800" b="1">
+                <a:solidFill>
+                  <a:srgbClr val="156E58"/>
+                </a:solidFill>
+                <a:latin typeface="Apple SD Gothic Neo"/>
+                <a:ea typeface="Apple SD Gothic Neo"/>
+                <a:cs typeface="Apple SD Gothic Neo"/>
+              </a:defRPr>
+            </a:pPr>
+            <a:r>
+              <a:rPr sz="1800" b="1">
+                <a:solidFill>
+                  <a:srgbClr val="156E58"/>
+                </a:solidFill>
+                <a:latin typeface="Apple SD Gothic Neo"/>
+                <a:ea typeface="Apple SD Gothic Neo"/>
+                <a:cs typeface="Apple SD Gothic Neo"/>
+              </a:rPr>
+              <a:t>에이전트</a:t>
+            </a:r>
+          </a:p>
+        </p:txBody>
+      </p:sp>
+      <p:sp>
+        <p:nvSpPr>
+          <p:cNvPr id="12" name="">
+            <a:extLst xmlns:a="http://schemas.openxmlformats.org/drawingml/2006/main">
+              <a:ext uri="{FF2B5EF4-FFF2-40B4-BE49-F238E27FC236}">
+                <a16:creationId xmlns:a16="http://schemas.microsoft.com/office/drawing/2014/main" id="{195D72F1-2438-4F85-9E30-7162F716883C}"/>
+              </a:ext>
+            </a:extLst>
+          </p:cNvPr>
+          <p:cNvSpPr>
+            <a:spLocks xmlns:a="http://schemas.openxmlformats.org/drawingml/2006/main" noGrp="1"/>
+          </p:cNvSpPr>
+          <p:nvPr/>
+        </p:nvSpPr>
+        <p:spPr>
+          <a:xfrm xmlns:a="http://schemas.openxmlformats.org/drawingml/2006/main">
+            <a:off x="10001250" y="2667000"/>
+            <a:ext cx="4381500" cy="457200"/>
+          </a:xfrm>
+          <a:prstGeom xmlns:a="http://schemas.openxmlformats.org/drawingml/2006/main" prst="rect">
+            <a:avLst/>
+          </a:prstGeom>
+          <a:noFill xmlns:a="http://schemas.openxmlformats.org/drawingml/2006/main"/>
+          <a:ln xmlns:a="http://schemas.openxmlformats.org/drawingml/2006/main" w="0">
+            <a:noFill/>
+          </a:ln>
+        </p:spPr>
+        <p:txBody>
+          <a:bodyPr xmlns:a="http://schemas.openxmlformats.org/drawingml/2006/main" wrap="square" lIns="0" tIns="0" rIns="0" bIns="0">
+            <a:noAutofit/>
+          </a:bodyPr>
+          <a:lstStyle xmlns:a="http://schemas.openxmlformats.org/drawingml/2006/main"/>
+          <a:p xmlns:a="http://schemas.openxmlformats.org/drawingml/2006/main">
+            <a:pPr>
+              <a:defRPr sz="2400" b="1">
+                <a:solidFill>
+                  <a:srgbClr val="156E58"/>
+                </a:solidFill>
+                <a:latin typeface="Apple SD Gothic Neo"/>
+                <a:ea typeface="Apple SD Gothic Neo"/>
+                <a:cs typeface="Apple SD Gothic Neo"/>
+              </a:defRPr>
+            </a:pPr>
+            <a:r>
+              <a:rPr sz="2400" b="1">
+                <a:solidFill>
+                  <a:srgbClr val="156E58"/>
+                </a:solidFill>
+                <a:latin typeface="Apple SD Gothic Neo"/>
+                <a:ea typeface="Apple SD Gothic Neo"/>
+                <a:cs typeface="Apple SD Gothic Neo"/>
+              </a:rPr>
+              <a:t>실제 접수 결과</a:t>
+            </a:r>
+          </a:p>
+        </p:txBody>
+      </p:sp>
+      <p:pic>
+        <p:nvPicPr>
+          <p:cNvPr id="28" name=""/>
+          <p:cNvPicPr>
+            <a:picLocks xmlns:a="http://schemas.openxmlformats.org/drawingml/2006/main" noChangeAspect="1"/>
+          </p:cNvPicPr>
+          <p:nvPr/>
+        </p:nvPicPr>
+        <p:blipFill>
+          <a:blip xmlns:r="http://schemas.openxmlformats.org/officeDocument/2006/relationships" xmlns:a="http://schemas.openxmlformats.org/drawingml/2006/main" r:embed="Ra55d066e92aa4cde"/>
+          <a:stretch xmlns:a="http://schemas.openxmlformats.org/drawingml/2006/main"/>
+        </p:blipFill>
+        <p:spPr>
+          <a:xfrm xmlns:a="http://schemas.openxmlformats.org/drawingml/2006/main">
+            <a:off x="9858375" y="3422061"/>
+            <a:ext cx="4572000" cy="3633377"/>
+          </a:xfrm>
+          <a:prstGeom xmlns:a="http://schemas.openxmlformats.org/drawingml/2006/main" prst="rect">
+            <a:avLst/>
+          </a:prstGeom>
+        </p:spPr>
+      </p:pic>
+      <p:sp>
+        <p:nvSpPr>
+          <p:cNvPr id="14" name="">
+            <a:extLst xmlns:a="http://schemas.openxmlformats.org/drawingml/2006/main">
+              <a:ext uri="{FF2B5EF4-FFF2-40B4-BE49-F238E27FC236}">
+                <a16:creationId xmlns:a16="http://schemas.microsoft.com/office/drawing/2014/main" id="{78DD3D94-F2B9-4223-B81C-8736505C0134}"/>
+              </a:ext>
+            </a:extLst>
+          </p:cNvPr>
+          <p:cNvSpPr>
+            <a:spLocks xmlns:a="http://schemas.openxmlformats.org/drawingml/2006/main" noGrp="1"/>
+          </p:cNvSpPr>
+          <p:nvPr/>
+        </p:nvSpPr>
+        <p:spPr>
+          <a:xfrm xmlns:a="http://schemas.openxmlformats.org/drawingml/2006/main">
+            <a:off x="819150" y="7400925"/>
+            <a:ext cx="13525500" cy="342900"/>
+          </a:xfrm>
+          <a:prstGeom xmlns:a="http://schemas.openxmlformats.org/drawingml/2006/main" prst="rect">
+            <a:avLst/>
+          </a:prstGeom>
+          <a:noFill xmlns:a="http://schemas.openxmlformats.org/drawingml/2006/main"/>
+          <a:ln xmlns:a="http://schemas.openxmlformats.org/drawingml/2006/main" w="0">
+            <a:noFill/>
+          </a:ln>
+        </p:spPr>
+        <p:txBody>
+          <a:bodyPr xmlns:a="http://schemas.openxmlformats.org/drawingml/2006/main" wrap="square" lIns="0" tIns="0" rIns="0" bIns="0">
+            <a:noAutofit/>
+          </a:bodyPr>
+          <a:lstStyle xmlns:a="http://schemas.openxmlformats.org/drawingml/2006/main"/>
+          <a:p xmlns:a="http://schemas.openxmlformats.org/drawingml/2006/main">
+            <a:pPr>
+              <a:defRPr sz="1725" b="0">
                 <a:solidFill>
                   <a:srgbClr val="5E706B"/>
                 </a:solidFill>
@@ -11509,7 +11524,7 @@
               </a:defRPr>
             </a:pPr>
             <a:r>
-              <a:rPr sz="1650" b="0">
+              <a:rPr sz="1725" b="0">
                 <a:solidFill>
                   <a:srgbClr val="5E706B"/>
                 </a:solidFill>
@@ -11517,7 +11532,64 @@
                 <a:ea typeface="Apple SD Gothic Neo"/>
                 <a:cs typeface="Apple SD Gothic Neo"/>
               </a:rPr>
-              <a:t>사용자 메시지 기준의 단일 사례입니다. 로그인·구매·인증 화면의 클릭·입력 횟수는 별도이며 미측정입니다.</a:t>
+              <a:t>대화는 실제 기록의 요약입니다. 후속 입력은 로그인2회·승인2회·구매/인증 완료 알림2회입니다.</a:t>
+            </a:r>
+          </a:p>
+        </p:txBody>
+      </p:sp>
+      <p:sp>
+        <p:nvSpPr>
+          <p:cNvPr id="15" name="">
+            <a:extLst xmlns:a="http://schemas.openxmlformats.org/drawingml/2006/main">
+              <a:ext uri="{FF2B5EF4-FFF2-40B4-BE49-F238E27FC236}">
+                <a16:creationId xmlns:a16="http://schemas.microsoft.com/office/drawing/2014/main" id="{A73E2C92-922D-4278-8D39-B51912FEBB53}"/>
+              </a:ext>
+            </a:extLst>
+          </p:cNvPr>
+          <p:cNvSpPr>
+            <a:spLocks xmlns:a="http://schemas.openxmlformats.org/drawingml/2006/main" noGrp="1"/>
+          </p:cNvSpPr>
+          <p:nvPr/>
+        </p:nvSpPr>
+        <p:spPr>
+          <a:xfrm xmlns:a="http://schemas.openxmlformats.org/drawingml/2006/main">
+            <a:off x="819150" y="7781925"/>
+            <a:ext cx="13525500" cy="266700"/>
+          </a:xfrm>
+          <a:prstGeom xmlns:a="http://schemas.openxmlformats.org/drawingml/2006/main" prst="rect">
+            <a:avLst/>
+          </a:prstGeom>
+          <a:noFill xmlns:a="http://schemas.openxmlformats.org/drawingml/2006/main"/>
+          <a:ln xmlns:a="http://schemas.openxmlformats.org/drawingml/2006/main" w="0">
+            <a:noFill/>
+          </a:ln>
+        </p:spPr>
+        <p:txBody>
+          <a:bodyPr xmlns:a="http://schemas.openxmlformats.org/drawingml/2006/main" wrap="square" lIns="0" tIns="0" rIns="0" bIns="0">
+            <a:noAutofit/>
+          </a:bodyPr>
+          <a:lstStyle xmlns:a="http://schemas.openxmlformats.org/drawingml/2006/main"/>
+          <a:p xmlns:a="http://schemas.openxmlformats.org/drawingml/2006/main">
+            <a:pPr>
+              <a:defRPr sz="1500" b="0">
+                <a:solidFill>
+                  <a:srgbClr val="5E706B"/>
+                </a:solidFill>
+                <a:latin typeface="Apple SD Gothic Neo"/>
+                <a:ea typeface="Apple SD Gothic Neo"/>
+                <a:cs typeface="Apple SD Gothic Neo"/>
+              </a:defRPr>
+            </a:pPr>
+            <a:r>
+              <a:rPr sz="1500" b="0">
+                <a:solidFill>
+                  <a:srgbClr val="5E706B"/>
+                </a:solidFill>
+                <a:latin typeface="Apple SD Gothic Neo"/>
+                <a:ea typeface="Apple SD Gothic Neo"/>
+                <a:cs typeface="Apple SD Gothic Neo"/>
+              </a:rPr>
+              <a:t>메시지 수 기준이며, 로그인·구매·인증 화면의 클릭과 입력 횟수는 별도로 측정하지 않았습니다.</a:t>
             </a:r>
           </a:p>
         </p:txBody>
@@ -11525,7 +11597,7 @@
     </p:spTree>
     <p:extLst>
       <p:ext uri="{BB962C8B-B14F-4D97-AF65-F5344CB8AC3E}">
-        <p14:creationId xmlns:p14="http://schemas.microsoft.com/office/powerpoint/2010/main" val="539084931"/>
+        <p14:creationId xmlns:p14="http://schemas.microsoft.com/office/powerpoint/2010/main" val="30950051"/>
       </p:ext>
     </p:extLst>
   </p:cSld>
@@ -11556,7 +11628,7 @@
           <p:cNvPr id="13" name="">
             <a:extLst xmlns:a="http://schemas.openxmlformats.org/drawingml/2006/main">
               <a:ext uri="{FF2B5EF4-FFF2-40B4-BE49-F238E27FC236}">
-                <a16:creationId xmlns:a16="http://schemas.microsoft.com/office/drawing/2014/main" id="{A947EEB6-BDEC-4D5B-A39D-962FDCE65323}"/>
+                <a16:creationId xmlns:a16="http://schemas.microsoft.com/office/drawing/2014/main" id="{95825BA7-8985-43A2-BE88-CE07ECDC85F5}"/>
               </a:ext>
             </a:extLst>
           </p:cNvPr>
@@ -11613,7 +11685,7 @@
           <p:cNvPr id="2" name="">
             <a:extLst xmlns:a="http://schemas.openxmlformats.org/drawingml/2006/main">
               <a:ext uri="{FF2B5EF4-FFF2-40B4-BE49-F238E27FC236}">
-                <a16:creationId xmlns:a16="http://schemas.microsoft.com/office/drawing/2014/main" id="{BA732B5A-4FAF-4B92-BD8E-3378A73954F6}"/>
+                <a16:creationId xmlns:a16="http://schemas.microsoft.com/office/drawing/2014/main" id="{D4E3592A-677C-4281-8015-62F5BE6B78F7}"/>
               </a:ext>
             </a:extLst>
           </p:cNvPr>
@@ -11670,7 +11742,7 @@
           <p:cNvPr id="3" name="">
             <a:extLst xmlns:a="http://schemas.openxmlformats.org/drawingml/2006/main">
               <a:ext uri="{FF2B5EF4-FFF2-40B4-BE49-F238E27FC236}">
-                <a16:creationId xmlns:a16="http://schemas.microsoft.com/office/drawing/2014/main" id="{A7CDCFBC-BC4B-4389-8F3F-03FC9A9D8FF4}"/>
+                <a16:creationId xmlns:a16="http://schemas.microsoft.com/office/drawing/2014/main" id="{2716F421-0517-430C-BF98-9E1B82D8B89F}"/>
               </a:ext>
             </a:extLst>
           </p:cNvPr>
@@ -11727,7 +11799,7 @@
           <p:cNvPr id="4" name="">
             <a:extLst xmlns:a="http://schemas.openxmlformats.org/drawingml/2006/main">
               <a:ext uri="{FF2B5EF4-FFF2-40B4-BE49-F238E27FC236}">
-                <a16:creationId xmlns:a16="http://schemas.microsoft.com/office/drawing/2014/main" id="{CCB9F8BE-30EF-4813-8F0C-9806D503DF76}"/>
+                <a16:creationId xmlns:a16="http://schemas.microsoft.com/office/drawing/2014/main" id="{018DEDD6-F596-4BC9-814F-A36512CA94DA}"/>
               </a:ext>
             </a:extLst>
           </p:cNvPr>
@@ -11786,7 +11858,7 @@
           <p:cNvPr id="5" name="">
             <a:extLst xmlns:a="http://schemas.openxmlformats.org/drawingml/2006/main">
               <a:ext uri="{FF2B5EF4-FFF2-40B4-BE49-F238E27FC236}">
-                <a16:creationId xmlns:a16="http://schemas.microsoft.com/office/drawing/2014/main" id="{E6C0C10A-A7A3-4639-A59D-F8C57435BBE0}"/>
+                <a16:creationId xmlns:a16="http://schemas.microsoft.com/office/drawing/2014/main" id="{0AE60611-335F-4EA1-A8F6-6683C2509FAF}"/>
               </a:ext>
             </a:extLst>
           </p:cNvPr>
@@ -11870,7 +11942,7 @@
           <p:cNvPr id="7" name="">
             <a:extLst xmlns:a="http://schemas.openxmlformats.org/drawingml/2006/main">
               <a:ext uri="{FF2B5EF4-FFF2-40B4-BE49-F238E27FC236}">
-                <a16:creationId xmlns:a16="http://schemas.microsoft.com/office/drawing/2014/main" id="{944B7B9C-0DD6-460C-BA08-D8C9DD8491D5}"/>
+                <a16:creationId xmlns:a16="http://schemas.microsoft.com/office/drawing/2014/main" id="{800C996B-AF70-488F-80B1-5E0C8D6D2241}"/>
               </a:ext>
             </a:extLst>
           </p:cNvPr>
@@ -11954,7 +12026,7 @@
           <p:cNvPr id="9" name="">
             <a:extLst xmlns:a="http://schemas.openxmlformats.org/drawingml/2006/main">
               <a:ext uri="{FF2B5EF4-FFF2-40B4-BE49-F238E27FC236}">
-                <a16:creationId xmlns:a16="http://schemas.microsoft.com/office/drawing/2014/main" id="{B89874C5-E5FC-46C4-B2F8-7AF49BF1AA0F}"/>
+                <a16:creationId xmlns:a16="http://schemas.microsoft.com/office/drawing/2014/main" id="{217408AC-8C39-4686-9F7E-3A886726691B}"/>
               </a:ext>
             </a:extLst>
           </p:cNvPr>
@@ -12034,7 +12106,7 @@
           <p:cNvPr id="10" name="">
             <a:extLst xmlns:a="http://schemas.openxmlformats.org/drawingml/2006/main">
               <a:ext uri="{FF2B5EF4-FFF2-40B4-BE49-F238E27FC236}">
-                <a16:creationId xmlns:a16="http://schemas.microsoft.com/office/drawing/2014/main" id="{F53027AA-3F72-4CA8-9A1E-0A6A4FAB6C9D}"/>
+                <a16:creationId xmlns:a16="http://schemas.microsoft.com/office/drawing/2014/main" id="{5E091299-4683-4B7D-959E-05306FF0F892}"/>
               </a:ext>
             </a:extLst>
           </p:cNvPr>
@@ -12114,7 +12186,7 @@
           <p:cNvPr id="11" name="">
             <a:extLst xmlns:a="http://schemas.openxmlformats.org/drawingml/2006/main">
               <a:ext uri="{FF2B5EF4-FFF2-40B4-BE49-F238E27FC236}">
-                <a16:creationId xmlns:a16="http://schemas.microsoft.com/office/drawing/2014/main" id="{283F401D-7E53-47E6-83E2-38F06F94820C}"/>
+                <a16:creationId xmlns:a16="http://schemas.microsoft.com/office/drawing/2014/main" id="{8196F990-157F-4522-90F6-BDE43DEC5218}"/>
               </a:ext>
             </a:extLst>
           </p:cNvPr>
@@ -12194,7 +12266,7 @@
           <p:cNvPr id="12" name="">
             <a:extLst xmlns:a="http://schemas.openxmlformats.org/drawingml/2006/main">
               <a:ext uri="{FF2B5EF4-FFF2-40B4-BE49-F238E27FC236}">
-                <a16:creationId xmlns:a16="http://schemas.microsoft.com/office/drawing/2014/main" id="{1DC2104E-9E2C-489B-BB51-C2D9F060B722}"/>
+                <a16:creationId xmlns:a16="http://schemas.microsoft.com/office/drawing/2014/main" id="{50D1DEFD-3219-45C9-A9F8-0F58A41D52D0}"/>
               </a:ext>
             </a:extLst>
           </p:cNvPr>
@@ -12272,7 +12344,7 @@
     </p:spTree>
     <p:extLst>
       <p:ext uri="{BB962C8B-B14F-4D97-AF65-F5344CB8AC3E}">
-        <p14:creationId xmlns:p14="http://schemas.microsoft.com/office/powerpoint/2010/main" val="108386323"/>
+        <p14:creationId xmlns:p14="http://schemas.microsoft.com/office/powerpoint/2010/main" val="105208061"/>
       </p:ext>
     </p:extLst>
   </p:cSld>

</xml_diff>

<commit_message>
docs: separate current commerce shipping and extra costs
</commit_message>
<xml_diff>
--- a/portfolio/crossborder-portfolio.pptx
+++ b/portfolio/crossborder-portfolio.pptx
@@ -2,27 +2,27 @@
 <file path=ppt/presentation.xml><?xml version="1.0" encoding="utf-8"?>
 <p:presentation xmlns:p="http://schemas.openxmlformats.org/presentationml/2006/main">
   <p:sldMasterIdLst>
-    <p:sldMasterId xmlns:r="http://schemas.openxmlformats.org/officeDocument/2006/relationships" id="2147483648" r:id="R43e693a103bf4a56"/>
+    <p:sldMasterId xmlns:r="http://schemas.openxmlformats.org/officeDocument/2006/relationships" id="2147483648" r:id="R3eef06e516fd4b31"/>
   </p:sldMasterIdLst>
   <p:notesMasterIdLst>
-    <p:notesMasterId xmlns:r="http://schemas.openxmlformats.org/officeDocument/2006/relationships" r:id="Rc16d5bca86a04270"/>
+    <p:notesMasterId xmlns:r="http://schemas.openxmlformats.org/officeDocument/2006/relationships" r:id="Reeb47bd3e5c240b2"/>
   </p:notesMasterIdLst>
   <p:sldIdLst>
-    <p:sldId xmlns:r="http://schemas.openxmlformats.org/officeDocument/2006/relationships" id="256" r:id="R0259e4d8ef2f42b3"/>
-    <p:sldId xmlns:r="http://schemas.openxmlformats.org/officeDocument/2006/relationships" id="257" r:id="Ra262b92973a7458a"/>
-    <p:sldId xmlns:r="http://schemas.openxmlformats.org/officeDocument/2006/relationships" id="258" r:id="R5e42f404ba2247ec"/>
-    <p:sldId xmlns:r="http://schemas.openxmlformats.org/officeDocument/2006/relationships" id="259" r:id="Rdf18d1b67d9c418b"/>
-    <p:sldId xmlns:r="http://schemas.openxmlformats.org/officeDocument/2006/relationships" id="260" r:id="R6ce09d5456e84bfc"/>
-    <p:sldId xmlns:r="http://schemas.openxmlformats.org/officeDocument/2006/relationships" id="261" r:id="R9086e00e48f944ba"/>
-    <p:sldId xmlns:r="http://schemas.openxmlformats.org/officeDocument/2006/relationships" id="262" r:id="R6d139a452aa74155"/>
-    <p:sldId xmlns:r="http://schemas.openxmlformats.org/officeDocument/2006/relationships" id="263" r:id="Rd59173873b66481d"/>
-    <p:sldId xmlns:r="http://schemas.openxmlformats.org/officeDocument/2006/relationships" id="264" r:id="Rabf646e332924388"/>
-    <p:sldId xmlns:r="http://schemas.openxmlformats.org/officeDocument/2006/relationships" id="265" r:id="Rfdddb30c728c44c1"/>
-    <p:sldId xmlns:r="http://schemas.openxmlformats.org/officeDocument/2006/relationships" id="266" r:id="R79c1c7d6a7e54ccb"/>
-    <p:sldId xmlns:r="http://schemas.openxmlformats.org/officeDocument/2006/relationships" id="267" r:id="R65c42c6e6e594b64"/>
-    <p:sldId xmlns:r="http://schemas.openxmlformats.org/officeDocument/2006/relationships" id="268" r:id="R7cb3f0bfbc804853"/>
-    <p:sldId xmlns:r="http://schemas.openxmlformats.org/officeDocument/2006/relationships" id="269" r:id="R6e1b531223694c8d"/>
-    <p:sldId xmlns:r="http://schemas.openxmlformats.org/officeDocument/2006/relationships" id="270" r:id="R02f616cfaccc43bc"/>
+    <p:sldId xmlns:r="http://schemas.openxmlformats.org/officeDocument/2006/relationships" id="256" r:id="R23172851a2cd4aa2"/>
+    <p:sldId xmlns:r="http://schemas.openxmlformats.org/officeDocument/2006/relationships" id="257" r:id="Rcad3765695de462a"/>
+    <p:sldId xmlns:r="http://schemas.openxmlformats.org/officeDocument/2006/relationships" id="258" r:id="R8693631f82464c01"/>
+    <p:sldId xmlns:r="http://schemas.openxmlformats.org/officeDocument/2006/relationships" id="259" r:id="Rd2eda6f0e0fb4198"/>
+    <p:sldId xmlns:r="http://schemas.openxmlformats.org/officeDocument/2006/relationships" id="260" r:id="R1f3840cc4d034df2"/>
+    <p:sldId xmlns:r="http://schemas.openxmlformats.org/officeDocument/2006/relationships" id="261" r:id="R0ef7b146b4624635"/>
+    <p:sldId xmlns:r="http://schemas.openxmlformats.org/officeDocument/2006/relationships" id="262" r:id="R156b8dcd7e2b47ec"/>
+    <p:sldId xmlns:r="http://schemas.openxmlformats.org/officeDocument/2006/relationships" id="263" r:id="R96a3e5f9dcbf47a9"/>
+    <p:sldId xmlns:r="http://schemas.openxmlformats.org/officeDocument/2006/relationships" id="264" r:id="R2ec28832341f4940"/>
+    <p:sldId xmlns:r="http://schemas.openxmlformats.org/officeDocument/2006/relationships" id="265" r:id="Rbc4b679bb0584cac"/>
+    <p:sldId xmlns:r="http://schemas.openxmlformats.org/officeDocument/2006/relationships" id="266" r:id="R4ca18a9865274786"/>
+    <p:sldId xmlns:r="http://schemas.openxmlformats.org/officeDocument/2006/relationships" id="267" r:id="Rff4d19d975fe4873"/>
+    <p:sldId xmlns:r="http://schemas.openxmlformats.org/officeDocument/2006/relationships" id="268" r:id="Rbc509349d9544881"/>
+    <p:sldId xmlns:r="http://schemas.openxmlformats.org/officeDocument/2006/relationships" id="269" r:id="R6f75c481d24e4915"/>
+    <p:sldId xmlns:r="http://schemas.openxmlformats.org/officeDocument/2006/relationships" id="270" r:id="R4d5a51f2ba60420f"/>
   </p:sldIdLst>
   <p:sldSz cx="15240000" cy="8572500"/>
   <p:notesSz cx="6858000" cy="9144000"/>
@@ -1086,7 +1086,7 @@
           <a:lstStyle xmlns:a="http://schemas.openxmlformats.org/drawingml/2006/main"/>
           <a:p xmlns:a="http://schemas.openxmlformats.org/drawingml/2006/main">
             <a:r>
-              <a:t>https://github.com/y00nZZang/crossborder-purchase-agent/blob/main/docs/route-comparison.md ; https://www.tenso.com/jp/estimate ; https://www.worldshopping.global/simulator/ ; https://books.rakuten.co.jp/rb/18584086/ . SAZO 사용자 제공 캡처, 세부 운송·특전 조건 미확인.</a:t>
+              <a:t>https://github.com/y00nZZang/crossborder-purchase-agent/blob/main/docs/route-comparison-2026-10-06.md . 가격과 환율·가정은 동일 문서 참조. SAZO 결제 전 견적, 라쿠텐 상품페이지·주문메일, tenso/WorldShopping 계산기, 몰테일 공개요율을 대조. 공식스토어는 사용자 제공10/6 결제 전 캡처: 상품51,868원+배송14,419원=66,287원. 첨부에는 EMS 등 운송방식 미표기. 원화 환산은 카드 청구액 아님.</a:t>
             </a:r>
           </a:p>
         </p:txBody>
@@ -1504,7 +1504,7 @@
   </p:cSld>
   <p:clrMap bg1="lt1" tx1="dk1" bg2="lt2" tx2="dk2" accent1="accent1" accent2="accent2" accent3="accent3" accent4="accent4" accent5="accent5" accent6="accent6" hlink="hlink" folHlink="folHlink"/>
   <p:sldLayoutIdLst>
-    <p:sldLayoutId xmlns:r="http://schemas.openxmlformats.org/officeDocument/2006/relationships" id="2147483649" r:id="R5f6ed23fa0b545a8"/>
+    <p:sldLayoutId xmlns:r="http://schemas.openxmlformats.org/officeDocument/2006/relationships" id="2147483649" r:id="R0ba0212dbc844fbb"/>
   </p:sldLayoutIdLst>
   <p:txStyles>
     <p:titleStyle>
@@ -2055,7 +2055,7 @@
           <p:cNvPr id="7" name="">
             <a:extLst xmlns:a="http://schemas.openxmlformats.org/drawingml/2006/main">
               <a:ext uri="{FF2B5EF4-FFF2-40B4-BE49-F238E27FC236}">
-                <a16:creationId xmlns:a16="http://schemas.microsoft.com/office/drawing/2014/main" id="{98C251FD-1D1C-4BDE-8C26-C0F1C7033B56}"/>
+                <a16:creationId xmlns:a16="http://schemas.microsoft.com/office/drawing/2014/main" id="{40AE4F86-F687-43E4-A181-E8011620484C}"/>
               </a:ext>
             </a:extLst>
           </p:cNvPr>
@@ -2094,7 +2094,7 @@
           <p:cNvPr id="2" name="">
             <a:extLst xmlns:a="http://schemas.openxmlformats.org/drawingml/2006/main">
               <a:ext uri="{FF2B5EF4-FFF2-40B4-BE49-F238E27FC236}">
-                <a16:creationId xmlns:a16="http://schemas.microsoft.com/office/drawing/2014/main" id="{03698436-8D1C-4D57-9CC0-66AD3FE6FF8D}"/>
+                <a16:creationId xmlns:a16="http://schemas.microsoft.com/office/drawing/2014/main" id="{CD657213-3DB8-48A6-AE35-F3D38C116AA4}"/>
               </a:ext>
             </a:extLst>
           </p:cNvPr>
@@ -2151,7 +2151,7 @@
           <p:cNvPr id="3" name="">
             <a:extLst xmlns:a="http://schemas.openxmlformats.org/drawingml/2006/main">
               <a:ext uri="{FF2B5EF4-FFF2-40B4-BE49-F238E27FC236}">
-                <a16:creationId xmlns:a16="http://schemas.microsoft.com/office/drawing/2014/main" id="{65548D7D-D452-454D-BA08-77860DC5B5C4}"/>
+                <a16:creationId xmlns:a16="http://schemas.microsoft.com/office/drawing/2014/main" id="{8104BE70-8DB2-445B-984A-F5C3C3AC953A}"/>
               </a:ext>
             </a:extLst>
           </p:cNvPr>
@@ -2208,7 +2208,7 @@
           <p:cNvPr id="4" name="">
             <a:extLst xmlns:a="http://schemas.openxmlformats.org/drawingml/2006/main">
               <a:ext uri="{FF2B5EF4-FFF2-40B4-BE49-F238E27FC236}">
-                <a16:creationId xmlns:a16="http://schemas.microsoft.com/office/drawing/2014/main" id="{4070B090-A2B0-4B01-89CB-A9C712472182}"/>
+                <a16:creationId xmlns:a16="http://schemas.microsoft.com/office/drawing/2014/main" id="{B3380039-139B-4DA8-9C5A-D79EFF660C1C}"/>
               </a:ext>
             </a:extLst>
           </p:cNvPr>
@@ -2288,7 +2288,7 @@
           <p:cNvPr id="5" name="">
             <a:extLst xmlns:a="http://schemas.openxmlformats.org/drawingml/2006/main">
               <a:ext uri="{FF2B5EF4-FFF2-40B4-BE49-F238E27FC236}">
-                <a16:creationId xmlns:a16="http://schemas.microsoft.com/office/drawing/2014/main" id="{CB1E646F-555D-4237-BF67-1DF60DBE41FE}"/>
+                <a16:creationId xmlns:a16="http://schemas.microsoft.com/office/drawing/2014/main" id="{A5ED2A49-32B8-42C1-8D5D-A649403CB4C9}"/>
               </a:ext>
             </a:extLst>
           </p:cNvPr>
@@ -2345,7 +2345,7 @@
           <p:cNvPr id="6" name="">
             <a:extLst xmlns:a="http://schemas.openxmlformats.org/drawingml/2006/main">
               <a:ext uri="{FF2B5EF4-FFF2-40B4-BE49-F238E27FC236}">
-                <a16:creationId xmlns:a16="http://schemas.microsoft.com/office/drawing/2014/main" id="{FEE0E9EE-F721-4CF5-AD9B-F6C91E3A1772}"/>
+                <a16:creationId xmlns:a16="http://schemas.microsoft.com/office/drawing/2014/main" id="{2AB6B85A-023C-495E-8E9F-CB3E0DAA6B70}"/>
               </a:ext>
             </a:extLst>
           </p:cNvPr>
@@ -2400,7 +2400,7 @@
     </p:spTree>
     <p:extLst>
       <p:ext uri="{BB962C8B-B14F-4D97-AF65-F5344CB8AC3E}">
-        <p14:creationId xmlns:p14="http://schemas.microsoft.com/office/powerpoint/2010/main" val="985119153"/>
+        <p14:creationId xmlns:p14="http://schemas.microsoft.com/office/powerpoint/2010/main" val="960599097"/>
       </p:ext>
     </p:extLst>
   </p:cSld>
@@ -2431,7 +2431,7 @@
           <p:cNvPr id="10" name="">
             <a:extLst xmlns:a="http://schemas.openxmlformats.org/drawingml/2006/main">
               <a:ext uri="{FF2B5EF4-FFF2-40B4-BE49-F238E27FC236}">
-                <a16:creationId xmlns:a16="http://schemas.microsoft.com/office/drawing/2014/main" id="{A884774B-789F-48C3-955A-AB277820B4A0}"/>
+                <a16:creationId xmlns:a16="http://schemas.microsoft.com/office/drawing/2014/main" id="{77D54C67-149C-461B-B36F-F2E406CEA36C}"/>
               </a:ext>
             </a:extLst>
           </p:cNvPr>
@@ -2488,7 +2488,7 @@
           <p:cNvPr id="2" name="">
             <a:extLst xmlns:a="http://schemas.openxmlformats.org/drawingml/2006/main">
               <a:ext uri="{FF2B5EF4-FFF2-40B4-BE49-F238E27FC236}">
-                <a16:creationId xmlns:a16="http://schemas.microsoft.com/office/drawing/2014/main" id="{78E1F7FC-D67C-4CA5-9F73-5AC330D62621}"/>
+                <a16:creationId xmlns:a16="http://schemas.microsoft.com/office/drawing/2014/main" id="{D2F62A97-611E-4780-857E-2A44E34E6F46}"/>
               </a:ext>
             </a:extLst>
           </p:cNvPr>
@@ -2545,7 +2545,7 @@
           <p:cNvPr id="3" name="">
             <a:extLst xmlns:a="http://schemas.openxmlformats.org/drawingml/2006/main">
               <a:ext uri="{FF2B5EF4-FFF2-40B4-BE49-F238E27FC236}">
-                <a16:creationId xmlns:a16="http://schemas.microsoft.com/office/drawing/2014/main" id="{C63E1A42-2578-426E-8D4C-28E2F8185185}"/>
+                <a16:creationId xmlns:a16="http://schemas.microsoft.com/office/drawing/2014/main" id="{D3D770DD-491C-45F6-939E-1E8F33914C24}"/>
               </a:ext>
             </a:extLst>
           </p:cNvPr>
@@ -2602,7 +2602,7 @@
           <p:cNvPr id="4" name="">
             <a:extLst xmlns:a="http://schemas.openxmlformats.org/drawingml/2006/main">
               <a:ext uri="{FF2B5EF4-FFF2-40B4-BE49-F238E27FC236}">
-                <a16:creationId xmlns:a16="http://schemas.microsoft.com/office/drawing/2014/main" id="{DFEABA4D-E1BB-44B5-A68A-434F4BC501AE}"/>
+                <a16:creationId xmlns:a16="http://schemas.microsoft.com/office/drawing/2014/main" id="{DEFE2721-CC25-4C3E-AD1F-5AEFBDC588FB}"/>
               </a:ext>
             </a:extLst>
           </p:cNvPr>
@@ -2638,7 +2638,7 @@
           <p:nvPr/>
         </p:nvPicPr>
         <p:blipFill>
-          <a:blip xmlns:r="http://schemas.openxmlformats.org/officeDocument/2006/relationships" xmlns:a="http://schemas.openxmlformats.org/drawingml/2006/main" r:embed="R3dbc396ccd89477c"/>
+          <a:blip xmlns:r="http://schemas.openxmlformats.org/officeDocument/2006/relationships" xmlns:a="http://schemas.openxmlformats.org/drawingml/2006/main" r:embed="R8c6b1be854324325"/>
           <a:stretch xmlns:a="http://schemas.openxmlformats.org/drawingml/2006/main"/>
         </p:blipFill>
         <p:spPr>
@@ -2656,7 +2656,7 @@
           <p:cNvPr id="6" name="">
             <a:extLst xmlns:a="http://schemas.openxmlformats.org/drawingml/2006/main">
               <a:ext uri="{FF2B5EF4-FFF2-40B4-BE49-F238E27FC236}">
-                <a16:creationId xmlns:a16="http://schemas.microsoft.com/office/drawing/2014/main" id="{A62DE21F-3F3F-418A-8685-52A6B7713FFD}"/>
+                <a16:creationId xmlns:a16="http://schemas.microsoft.com/office/drawing/2014/main" id="{A0115995-CD4E-4ACE-9282-4A1EFA669D41}"/>
               </a:ext>
             </a:extLst>
           </p:cNvPr>
@@ -2713,7 +2713,7 @@
           <p:cNvPr id="7" name="">
             <a:extLst xmlns:a="http://schemas.openxmlformats.org/drawingml/2006/main">
               <a:ext uri="{FF2B5EF4-FFF2-40B4-BE49-F238E27FC236}">
-                <a16:creationId xmlns:a16="http://schemas.microsoft.com/office/drawing/2014/main" id="{C3509B7B-505E-46A4-9F51-C0D95A575031}"/>
+                <a16:creationId xmlns:a16="http://schemas.microsoft.com/office/drawing/2014/main" id="{4CF0D93B-6383-40F2-85AC-DFCA111EAF85}"/>
               </a:ext>
             </a:extLst>
           </p:cNvPr>
@@ -2793,7 +2793,7 @@
           <p:cNvPr id="8" name="">
             <a:extLst xmlns:a="http://schemas.openxmlformats.org/drawingml/2006/main">
               <a:ext uri="{FF2B5EF4-FFF2-40B4-BE49-F238E27FC236}">
-                <a16:creationId xmlns:a16="http://schemas.microsoft.com/office/drawing/2014/main" id="{A19C1BBF-AF54-4FA8-A18A-93A7268FBC4E}"/>
+                <a16:creationId xmlns:a16="http://schemas.microsoft.com/office/drawing/2014/main" id="{9778C2C6-1AD6-49FC-8D9B-CC5B0E761A4B}"/>
               </a:ext>
             </a:extLst>
           </p:cNvPr>
@@ -2850,7 +2850,7 @@
           <p:cNvPr id="9" name="">
             <a:extLst xmlns:a="http://schemas.openxmlformats.org/drawingml/2006/main">
               <a:ext uri="{FF2B5EF4-FFF2-40B4-BE49-F238E27FC236}">
-                <a16:creationId xmlns:a16="http://schemas.microsoft.com/office/drawing/2014/main" id="{8E9C0905-2326-45CD-A339-86F0687C8062}"/>
+                <a16:creationId xmlns:a16="http://schemas.microsoft.com/office/drawing/2014/main" id="{54262222-1D9F-4C9A-988F-72E630291FD7}"/>
               </a:ext>
             </a:extLst>
           </p:cNvPr>
@@ -2951,7 +2951,7 @@
     </p:spTree>
     <p:extLst>
       <p:ext uri="{BB962C8B-B14F-4D97-AF65-F5344CB8AC3E}">
-        <p14:creationId xmlns:p14="http://schemas.microsoft.com/office/powerpoint/2010/main" val="439513403"/>
+        <p14:creationId xmlns:p14="http://schemas.microsoft.com/office/powerpoint/2010/main" val="75573647"/>
       </p:ext>
     </p:extLst>
   </p:cSld>
@@ -2982,7 +2982,7 @@
           <p:cNvPr id="14" name="">
             <a:extLst xmlns:a="http://schemas.openxmlformats.org/drawingml/2006/main">
               <a:ext uri="{FF2B5EF4-FFF2-40B4-BE49-F238E27FC236}">
-                <a16:creationId xmlns:a16="http://schemas.microsoft.com/office/drawing/2014/main" id="{22CD7D1D-B87F-48C5-9567-AC5A944D56EA}"/>
+                <a16:creationId xmlns:a16="http://schemas.microsoft.com/office/drawing/2014/main" id="{AD28FC16-50E8-40A7-9F98-CF473474934B}"/>
               </a:ext>
             </a:extLst>
           </p:cNvPr>
@@ -3039,7 +3039,7 @@
           <p:cNvPr id="2" name="">
             <a:extLst xmlns:a="http://schemas.openxmlformats.org/drawingml/2006/main">
               <a:ext uri="{FF2B5EF4-FFF2-40B4-BE49-F238E27FC236}">
-                <a16:creationId xmlns:a16="http://schemas.microsoft.com/office/drawing/2014/main" id="{5D6F607C-8858-4F98-8905-BFBFCDDE6F03}"/>
+                <a16:creationId xmlns:a16="http://schemas.microsoft.com/office/drawing/2014/main" id="{EEE71BD6-A549-4DB3-A022-1F7126968CFC}"/>
               </a:ext>
             </a:extLst>
           </p:cNvPr>
@@ -3096,7 +3096,7 @@
           <p:cNvPr id="3" name="">
             <a:extLst xmlns:a="http://schemas.openxmlformats.org/drawingml/2006/main">
               <a:ext uri="{FF2B5EF4-FFF2-40B4-BE49-F238E27FC236}">
-                <a16:creationId xmlns:a16="http://schemas.microsoft.com/office/drawing/2014/main" id="{8B7DD3A4-60A9-4D63-B010-C300D77E046D}"/>
+                <a16:creationId xmlns:a16="http://schemas.microsoft.com/office/drawing/2014/main" id="{6F143D07-BA79-4F16-832B-41BE39E4BCC3}"/>
               </a:ext>
             </a:extLst>
           </p:cNvPr>
@@ -3153,7 +3153,7 @@
           <p:cNvPr id="4" name="">
             <a:extLst xmlns:a="http://schemas.openxmlformats.org/drawingml/2006/main">
               <a:ext uri="{FF2B5EF4-FFF2-40B4-BE49-F238E27FC236}">
-                <a16:creationId xmlns:a16="http://schemas.microsoft.com/office/drawing/2014/main" id="{5832C99F-4237-4A7E-94DB-DEF6CA992FD9}"/>
+                <a16:creationId xmlns:a16="http://schemas.microsoft.com/office/drawing/2014/main" id="{336CDBE3-406C-4B83-96A2-77DF3AA3F33D}"/>
               </a:ext>
             </a:extLst>
           </p:cNvPr>
@@ -3212,7 +3212,7 @@
           <p:cNvPr id="5" name="">
             <a:extLst xmlns:a="http://schemas.openxmlformats.org/drawingml/2006/main">
               <a:ext uri="{FF2B5EF4-FFF2-40B4-BE49-F238E27FC236}">
-                <a16:creationId xmlns:a16="http://schemas.microsoft.com/office/drawing/2014/main" id="{9F3EF542-6523-47EC-BF32-F2E3C86A6544}"/>
+                <a16:creationId xmlns:a16="http://schemas.microsoft.com/office/drawing/2014/main" id="{5FA179FB-80AE-4E5D-8720-9BF7189DE453}"/>
               </a:ext>
             </a:extLst>
           </p:cNvPr>
@@ -3296,7 +3296,7 @@
           <p:cNvPr id="7" name="">
             <a:extLst xmlns:a="http://schemas.openxmlformats.org/drawingml/2006/main">
               <a:ext uri="{FF2B5EF4-FFF2-40B4-BE49-F238E27FC236}">
-                <a16:creationId xmlns:a16="http://schemas.microsoft.com/office/drawing/2014/main" id="{556CEF83-C72E-42F0-A7D4-9FD0AA7500CB}"/>
+                <a16:creationId xmlns:a16="http://schemas.microsoft.com/office/drawing/2014/main" id="{AFC6A0D9-6598-4AC3-B3D5-5076FB1BC9E3}"/>
               </a:ext>
             </a:extLst>
           </p:cNvPr>
@@ -3380,7 +3380,7 @@
           <p:cNvPr id="9" name="">
             <a:extLst xmlns:a="http://schemas.openxmlformats.org/drawingml/2006/main">
               <a:ext uri="{FF2B5EF4-FFF2-40B4-BE49-F238E27FC236}">
-                <a16:creationId xmlns:a16="http://schemas.microsoft.com/office/drawing/2014/main" id="{833234B9-F916-43DE-A879-5CD6AD3A67D1}"/>
+                <a16:creationId xmlns:a16="http://schemas.microsoft.com/office/drawing/2014/main" id="{9D941AE7-8CF4-44E0-B5B8-58B17B349200}"/>
               </a:ext>
             </a:extLst>
           </p:cNvPr>
@@ -3460,7 +3460,7 @@
           <p:cNvPr id="10" name="">
             <a:extLst xmlns:a="http://schemas.openxmlformats.org/drawingml/2006/main">
               <a:ext uri="{FF2B5EF4-FFF2-40B4-BE49-F238E27FC236}">
-                <a16:creationId xmlns:a16="http://schemas.microsoft.com/office/drawing/2014/main" id="{2FD47B4E-2EB2-4DF2-B34F-D3A732CC3867}"/>
+                <a16:creationId xmlns:a16="http://schemas.microsoft.com/office/drawing/2014/main" id="{CABF2C24-963C-4CA8-9147-0F9D52E5AF0E}"/>
               </a:ext>
             </a:extLst>
           </p:cNvPr>
@@ -3540,7 +3540,7 @@
           <p:cNvPr id="11" name="">
             <a:extLst xmlns:a="http://schemas.openxmlformats.org/drawingml/2006/main">
               <a:ext uri="{FF2B5EF4-FFF2-40B4-BE49-F238E27FC236}">
-                <a16:creationId xmlns:a16="http://schemas.microsoft.com/office/drawing/2014/main" id="{472F6539-54B9-4DFF-9A03-43E5F41BD507}"/>
+                <a16:creationId xmlns:a16="http://schemas.microsoft.com/office/drawing/2014/main" id="{0467D310-6BDF-49D6-B5AC-2290B460D13B}"/>
               </a:ext>
             </a:extLst>
           </p:cNvPr>
@@ -3620,7 +3620,7 @@
           <p:cNvPr id="12" name="">
             <a:extLst xmlns:a="http://schemas.openxmlformats.org/drawingml/2006/main">
               <a:ext uri="{FF2B5EF4-FFF2-40B4-BE49-F238E27FC236}">
-                <a16:creationId xmlns:a16="http://schemas.microsoft.com/office/drawing/2014/main" id="{0D932CE2-BC60-4AAE-AEAB-BB33682CA33E}"/>
+                <a16:creationId xmlns:a16="http://schemas.microsoft.com/office/drawing/2014/main" id="{FE1CD27E-5301-44C7-B19A-5956678C327A}"/>
               </a:ext>
             </a:extLst>
           </p:cNvPr>
@@ -3677,7 +3677,7 @@
           <p:cNvPr id="13" name="">
             <a:extLst xmlns:a="http://schemas.openxmlformats.org/drawingml/2006/main">
               <a:ext uri="{FF2B5EF4-FFF2-40B4-BE49-F238E27FC236}">
-                <a16:creationId xmlns:a16="http://schemas.microsoft.com/office/drawing/2014/main" id="{2C6793FD-A75A-4F07-9AF1-6AF68957C4F0}"/>
+                <a16:creationId xmlns:a16="http://schemas.microsoft.com/office/drawing/2014/main" id="{DEA08C0F-B134-4B6E-87C1-C200EC8B6F0A}"/>
               </a:ext>
             </a:extLst>
           </p:cNvPr>
@@ -3732,7 +3732,7 @@
     </p:spTree>
     <p:extLst>
       <p:ext uri="{BB962C8B-B14F-4D97-AF65-F5344CB8AC3E}">
-        <p14:creationId xmlns:p14="http://schemas.microsoft.com/office/powerpoint/2010/main" val="1131018429"/>
+        <p14:creationId xmlns:p14="http://schemas.microsoft.com/office/powerpoint/2010/main" val="1648014521"/>
       </p:ext>
     </p:extLst>
   </p:cSld>
@@ -3763,7 +3763,7 @@
           <p:cNvPr id="6" name="">
             <a:extLst xmlns:a="http://schemas.openxmlformats.org/drawingml/2006/main">
               <a:ext uri="{FF2B5EF4-FFF2-40B4-BE49-F238E27FC236}">
-                <a16:creationId xmlns:a16="http://schemas.microsoft.com/office/drawing/2014/main" id="{6C979A08-2890-4EA9-8B31-911AAA3968F6}"/>
+                <a16:creationId xmlns:a16="http://schemas.microsoft.com/office/drawing/2014/main" id="{B8F22E74-4C60-4059-A86D-6863663D7FCC}"/>
               </a:ext>
             </a:extLst>
           </p:cNvPr>
@@ -3820,7 +3820,7 @@
           <p:cNvPr id="2" name="">
             <a:extLst xmlns:a="http://schemas.openxmlformats.org/drawingml/2006/main">
               <a:ext uri="{FF2B5EF4-FFF2-40B4-BE49-F238E27FC236}">
-                <a16:creationId xmlns:a16="http://schemas.microsoft.com/office/drawing/2014/main" id="{C5E0A375-9BAB-4C4C-A210-5F264E490623}"/>
+                <a16:creationId xmlns:a16="http://schemas.microsoft.com/office/drawing/2014/main" id="{3B2FEE7B-2BB4-4FE7-94B0-B569B7832436}"/>
               </a:ext>
             </a:extLst>
           </p:cNvPr>
@@ -3877,7 +3877,7 @@
           <p:cNvPr id="3" name="">
             <a:extLst xmlns:a="http://schemas.openxmlformats.org/drawingml/2006/main">
               <a:ext uri="{FF2B5EF4-FFF2-40B4-BE49-F238E27FC236}">
-                <a16:creationId xmlns:a16="http://schemas.microsoft.com/office/drawing/2014/main" id="{F5611793-AF7D-4AB7-B2FF-09EF7D15704B}"/>
+                <a16:creationId xmlns:a16="http://schemas.microsoft.com/office/drawing/2014/main" id="{DF1E12B8-736B-4826-BCBA-F439BC3DA77B}"/>
               </a:ext>
             </a:extLst>
           </p:cNvPr>
@@ -4479,7 +4479,7 @@
           <p:cNvPr id="5" name="">
             <a:extLst xmlns:a="http://schemas.openxmlformats.org/drawingml/2006/main">
               <a:ext uri="{FF2B5EF4-FFF2-40B4-BE49-F238E27FC236}">
-                <a16:creationId xmlns:a16="http://schemas.microsoft.com/office/drawing/2014/main" id="{4B4D02A1-2DD4-4CDC-9A03-47E8D7955656}"/>
+                <a16:creationId xmlns:a16="http://schemas.microsoft.com/office/drawing/2014/main" id="{16C6DA90-5FDA-4057-BD5F-B6BF13B6C1A3}"/>
               </a:ext>
             </a:extLst>
           </p:cNvPr>
@@ -4534,7 +4534,7 @@
     </p:spTree>
     <p:extLst>
       <p:ext uri="{BB962C8B-B14F-4D97-AF65-F5344CB8AC3E}">
-        <p14:creationId xmlns:p14="http://schemas.microsoft.com/office/powerpoint/2010/main" val="876471258"/>
+        <p14:creationId xmlns:p14="http://schemas.microsoft.com/office/powerpoint/2010/main" val="924315298"/>
       </p:ext>
     </p:extLst>
   </p:cSld>
@@ -4565,7 +4565,7 @@
           <p:cNvPr id="6" name="">
             <a:extLst xmlns:a="http://schemas.openxmlformats.org/drawingml/2006/main">
               <a:ext uri="{FF2B5EF4-FFF2-40B4-BE49-F238E27FC236}">
-                <a16:creationId xmlns:a16="http://schemas.microsoft.com/office/drawing/2014/main" id="{FFFD57E0-6F10-4CCC-999A-5124BB5002EC}"/>
+                <a16:creationId xmlns:a16="http://schemas.microsoft.com/office/drawing/2014/main" id="{9098FC11-7A89-49A1-9415-5F9E19910D9D}"/>
               </a:ext>
             </a:extLst>
           </p:cNvPr>
@@ -4622,7 +4622,7 @@
           <p:cNvPr id="2" name="">
             <a:extLst xmlns:a="http://schemas.openxmlformats.org/drawingml/2006/main">
               <a:ext uri="{FF2B5EF4-FFF2-40B4-BE49-F238E27FC236}">
-                <a16:creationId xmlns:a16="http://schemas.microsoft.com/office/drawing/2014/main" id="{F3BD82A9-1E03-429E-959C-B3F8DC4A91B2}"/>
+                <a16:creationId xmlns:a16="http://schemas.microsoft.com/office/drawing/2014/main" id="{0329C6C6-C04B-4E2C-9E9A-15FCCB86FBFA}"/>
               </a:ext>
             </a:extLst>
           </p:cNvPr>
@@ -4679,7 +4679,7 @@
           <p:cNvPr id="3" name="">
             <a:extLst xmlns:a="http://schemas.openxmlformats.org/drawingml/2006/main">
               <a:ext uri="{FF2B5EF4-FFF2-40B4-BE49-F238E27FC236}">
-                <a16:creationId xmlns:a16="http://schemas.microsoft.com/office/drawing/2014/main" id="{2A96673B-429A-4B2D-BD77-889ADB23A012}"/>
+                <a16:creationId xmlns:a16="http://schemas.microsoft.com/office/drawing/2014/main" id="{67D757A2-D1DE-4E62-9238-78BE5328B01C}"/>
               </a:ext>
             </a:extLst>
           </p:cNvPr>
@@ -4934,7 +4934,7 @@
           <p:cNvPr id="5" name="">
             <a:extLst xmlns:a="http://schemas.openxmlformats.org/drawingml/2006/main">
               <a:ext uri="{FF2B5EF4-FFF2-40B4-BE49-F238E27FC236}">
-                <a16:creationId xmlns:a16="http://schemas.microsoft.com/office/drawing/2014/main" id="{E5639BFD-1763-47E8-93F4-D8F54E855102}"/>
+                <a16:creationId xmlns:a16="http://schemas.microsoft.com/office/drawing/2014/main" id="{E652C7F5-31F3-4C29-991F-EC01E6684EEB}"/>
               </a:ext>
             </a:extLst>
           </p:cNvPr>
@@ -5012,7 +5012,7 @@
     </p:spTree>
     <p:extLst>
       <p:ext uri="{BB962C8B-B14F-4D97-AF65-F5344CB8AC3E}">
-        <p14:creationId xmlns:p14="http://schemas.microsoft.com/office/powerpoint/2010/main" val="91174372"/>
+        <p14:creationId xmlns:p14="http://schemas.microsoft.com/office/powerpoint/2010/main" val="1813916785"/>
       </p:ext>
     </p:extLst>
   </p:cSld>
@@ -5043,7 +5043,7 @@
           <p:cNvPr id="10" name="">
             <a:extLst xmlns:a="http://schemas.openxmlformats.org/drawingml/2006/main">
               <a:ext uri="{FF2B5EF4-FFF2-40B4-BE49-F238E27FC236}">
-                <a16:creationId xmlns:a16="http://schemas.microsoft.com/office/drawing/2014/main" id="{C95226CF-0C1F-40E4-B646-8EFFA88A9ACC}"/>
+                <a16:creationId xmlns:a16="http://schemas.microsoft.com/office/drawing/2014/main" id="{28C63C29-76F4-44AD-ADEB-BD9632F6EC92}"/>
               </a:ext>
             </a:extLst>
           </p:cNvPr>
@@ -5100,7 +5100,7 @@
           <p:cNvPr id="2" name="">
             <a:extLst xmlns:a="http://schemas.openxmlformats.org/drawingml/2006/main">
               <a:ext uri="{FF2B5EF4-FFF2-40B4-BE49-F238E27FC236}">
-                <a16:creationId xmlns:a16="http://schemas.microsoft.com/office/drawing/2014/main" id="{85C4CF2B-ECD4-4131-8D0A-38412187103A}"/>
+                <a16:creationId xmlns:a16="http://schemas.microsoft.com/office/drawing/2014/main" id="{7B2E600B-0D89-4E68-BF92-D5DFC21BCAA8}"/>
               </a:ext>
             </a:extLst>
           </p:cNvPr>
@@ -5157,7 +5157,7 @@
           <p:cNvPr id="3" name="">
             <a:extLst xmlns:a="http://schemas.openxmlformats.org/drawingml/2006/main">
               <a:ext uri="{FF2B5EF4-FFF2-40B4-BE49-F238E27FC236}">
-                <a16:creationId xmlns:a16="http://schemas.microsoft.com/office/drawing/2014/main" id="{56E285A0-7249-4BAC-9802-B718FDBA55D0}"/>
+                <a16:creationId xmlns:a16="http://schemas.microsoft.com/office/drawing/2014/main" id="{B83D731C-2CB5-4D69-BFCD-7F7C7BC6B038}"/>
               </a:ext>
             </a:extLst>
           </p:cNvPr>
@@ -5214,7 +5214,7 @@
           <p:cNvPr id="4" name="">
             <a:extLst xmlns:a="http://schemas.openxmlformats.org/drawingml/2006/main">
               <a:ext uri="{FF2B5EF4-FFF2-40B4-BE49-F238E27FC236}">
-                <a16:creationId xmlns:a16="http://schemas.microsoft.com/office/drawing/2014/main" id="{ACCDE519-14A1-4108-9B51-2926B4037D38}"/>
+                <a16:creationId xmlns:a16="http://schemas.microsoft.com/office/drawing/2014/main" id="{3CDFC332-F1BB-4EF4-8C5B-215000E2E107}"/>
               </a:ext>
             </a:extLst>
           </p:cNvPr>
@@ -5271,7 +5271,7 @@
           <p:cNvPr id="5" name="">
             <a:extLst xmlns:a="http://schemas.openxmlformats.org/drawingml/2006/main">
               <a:ext uri="{FF2B5EF4-FFF2-40B4-BE49-F238E27FC236}">
-                <a16:creationId xmlns:a16="http://schemas.microsoft.com/office/drawing/2014/main" id="{3DBFC4D8-C4A5-4A6C-A088-C8C4902EA747}"/>
+                <a16:creationId xmlns:a16="http://schemas.microsoft.com/office/drawing/2014/main" id="{4E800A99-44AA-488C-AB63-8C1AB2F6D57E}"/>
               </a:ext>
             </a:extLst>
           </p:cNvPr>
@@ -5402,7 +5402,7 @@
           <p:cNvPr id="6" name="">
             <a:extLst xmlns:a="http://schemas.openxmlformats.org/drawingml/2006/main">
               <a:ext uri="{FF2B5EF4-FFF2-40B4-BE49-F238E27FC236}">
-                <a16:creationId xmlns:a16="http://schemas.microsoft.com/office/drawing/2014/main" id="{78BEE8D0-DBFB-4B26-A5B7-DAF1A5368745}"/>
+                <a16:creationId xmlns:a16="http://schemas.microsoft.com/office/drawing/2014/main" id="{A6BB03F8-7A8C-4173-9A4C-2681FA82F3A2}"/>
               </a:ext>
             </a:extLst>
           </p:cNvPr>
@@ -5459,7 +5459,7 @@
           <p:cNvPr id="7" name="">
             <a:extLst xmlns:a="http://schemas.openxmlformats.org/drawingml/2006/main">
               <a:ext uri="{FF2B5EF4-FFF2-40B4-BE49-F238E27FC236}">
-                <a16:creationId xmlns:a16="http://schemas.microsoft.com/office/drawing/2014/main" id="{901D5840-2241-4F37-B3AB-87C9A827086F}"/>
+                <a16:creationId xmlns:a16="http://schemas.microsoft.com/office/drawing/2014/main" id="{0B197609-2BCE-4884-9080-F157B6C38C81}"/>
               </a:ext>
             </a:extLst>
           </p:cNvPr>
@@ -5590,7 +5590,7 @@
           <p:cNvPr id="8" name="">
             <a:extLst xmlns:a="http://schemas.openxmlformats.org/drawingml/2006/main">
               <a:ext uri="{FF2B5EF4-FFF2-40B4-BE49-F238E27FC236}">
-                <a16:creationId xmlns:a16="http://schemas.microsoft.com/office/drawing/2014/main" id="{971292D4-7E6C-448E-BF0B-136D44C0F6A6}"/>
+                <a16:creationId xmlns:a16="http://schemas.microsoft.com/office/drawing/2014/main" id="{852357C0-7EF6-4315-BDFC-32C00050FAAC}"/>
               </a:ext>
             </a:extLst>
           </p:cNvPr>
@@ -5637,7 +5637,7 @@
                 <a:ea typeface="Apple SD Gothic Neo"/>
                 <a:cs typeface="Apple SD Gothic Neo"/>
               </a:rPr>
-              <a:t>당시 확인 비용 합계는 SAZO 약7,228엔, 직접구매+tenso 7,472엔이었습니다.</a:t>
+              <a:t>10/6 확인 소계는 SAZO63,114원, 직접구매+tenso 약64,306원이었습니다.</a:t>
             </a:r>
           </a:p>
           <a:p xmlns:a="http://schemas.openxmlformats.org/drawingml/2006/main">
@@ -5660,7 +5660,7 @@
                 <a:ea typeface="Apple SD Gothic Neo"/>
                 <a:cs typeface="Apple SD Gothic Neo"/>
               </a:rPr>
-              <a:t>이 사례에서는 구매대행을 이용하는 편이 유리하다고 느꼈습니다.</a:t>
+              <a:t>이 조건에서는 구매대행을 이용하는 편이 유리하다고 느꼈습니다.</a:t>
             </a:r>
           </a:p>
         </p:txBody>
@@ -5670,7 +5670,7 @@
           <p:cNvPr id="9" name="">
             <a:extLst xmlns:a="http://schemas.openxmlformats.org/drawingml/2006/main">
               <a:ext uri="{FF2B5EF4-FFF2-40B4-BE49-F238E27FC236}">
-                <a16:creationId xmlns:a16="http://schemas.microsoft.com/office/drawing/2014/main" id="{DCE36CC2-DA7F-4BE2-B8B7-64852677E5A2}"/>
+                <a16:creationId xmlns:a16="http://schemas.microsoft.com/office/drawing/2014/main" id="{568B0238-BB3C-4472-921F-DF5561BEB8DB}"/>
               </a:ext>
             </a:extLst>
           </p:cNvPr>
@@ -5725,7 +5725,7 @@
     </p:spTree>
     <p:extLst>
       <p:ext uri="{BB962C8B-B14F-4D97-AF65-F5344CB8AC3E}">
-        <p14:creationId xmlns:p14="http://schemas.microsoft.com/office/powerpoint/2010/main" val="369958478"/>
+        <p14:creationId xmlns:p14="http://schemas.microsoft.com/office/powerpoint/2010/main" val="2091517262"/>
       </p:ext>
     </p:extLst>
   </p:cSld>
@@ -5756,7 +5756,7 @@
           <p:cNvPr id="12" name="">
             <a:extLst xmlns:a="http://schemas.openxmlformats.org/drawingml/2006/main">
               <a:ext uri="{FF2B5EF4-FFF2-40B4-BE49-F238E27FC236}">
-                <a16:creationId xmlns:a16="http://schemas.microsoft.com/office/drawing/2014/main" id="{F9DAD197-03A8-4C57-87DE-A97DFC199D78}"/>
+                <a16:creationId xmlns:a16="http://schemas.microsoft.com/office/drawing/2014/main" id="{8BFF3D43-F542-410E-9A75-2BD83D3F2A97}"/>
               </a:ext>
             </a:extLst>
           </p:cNvPr>
@@ -5813,7 +5813,7 @@
           <p:cNvPr id="2" name="">
             <a:extLst xmlns:a="http://schemas.openxmlformats.org/drawingml/2006/main">
               <a:ext uri="{FF2B5EF4-FFF2-40B4-BE49-F238E27FC236}">
-                <a16:creationId xmlns:a16="http://schemas.microsoft.com/office/drawing/2014/main" id="{60906E02-A0C5-430A-B17B-54B07ED767BD}"/>
+                <a16:creationId xmlns:a16="http://schemas.microsoft.com/office/drawing/2014/main" id="{9F014A55-0516-4234-87DE-78D217F249DC}"/>
               </a:ext>
             </a:extLst>
           </p:cNvPr>
@@ -5870,7 +5870,7 @@
           <p:cNvPr id="3" name="">
             <a:extLst xmlns:a="http://schemas.openxmlformats.org/drawingml/2006/main">
               <a:ext uri="{FF2B5EF4-FFF2-40B4-BE49-F238E27FC236}">
-                <a16:creationId xmlns:a16="http://schemas.microsoft.com/office/drawing/2014/main" id="{6EFF224B-9734-46C6-B47B-F0A844F92293}"/>
+                <a16:creationId xmlns:a16="http://schemas.microsoft.com/office/drawing/2014/main" id="{7B4702E4-CE0C-4AEF-94F6-284D90686BDE}"/>
               </a:ext>
             </a:extLst>
           </p:cNvPr>
@@ -5927,7 +5927,7 @@
           <p:cNvPr id="4" name="">
             <a:extLst xmlns:a="http://schemas.openxmlformats.org/drawingml/2006/main">
               <a:ext uri="{FF2B5EF4-FFF2-40B4-BE49-F238E27FC236}">
-                <a16:creationId xmlns:a16="http://schemas.microsoft.com/office/drawing/2014/main" id="{4EA24EF9-B957-44C6-8CCE-B359ECC06221}"/>
+                <a16:creationId xmlns:a16="http://schemas.microsoft.com/office/drawing/2014/main" id="{09A16573-233F-479C-8D51-A64FC701D1EF}"/>
               </a:ext>
             </a:extLst>
           </p:cNvPr>
@@ -6007,7 +6007,7 @@
           <p:cNvPr id="5" name="">
             <a:extLst xmlns:a="http://schemas.openxmlformats.org/drawingml/2006/main">
               <a:ext uri="{FF2B5EF4-FFF2-40B4-BE49-F238E27FC236}">
-                <a16:creationId xmlns:a16="http://schemas.microsoft.com/office/drawing/2014/main" id="{B6D85511-AD2A-497A-88EF-90626904BE3B}"/>
+                <a16:creationId xmlns:a16="http://schemas.microsoft.com/office/drawing/2014/main" id="{07B4BB0A-56B2-4CCD-AF43-CBAB5868C1AC}"/>
               </a:ext>
             </a:extLst>
           </p:cNvPr>
@@ -6066,7 +6066,7 @@
           <p:cNvPr id="6" name="">
             <a:extLst xmlns:a="http://schemas.openxmlformats.org/drawingml/2006/main">
               <a:ext uri="{FF2B5EF4-FFF2-40B4-BE49-F238E27FC236}">
-                <a16:creationId xmlns:a16="http://schemas.microsoft.com/office/drawing/2014/main" id="{58842B3A-25CC-45D8-B811-CC10566AD5AD}"/>
+                <a16:creationId xmlns:a16="http://schemas.microsoft.com/office/drawing/2014/main" id="{12ABD43A-1989-4E9C-B58A-F25E7ED253C8}"/>
               </a:ext>
             </a:extLst>
           </p:cNvPr>
@@ -6150,7 +6150,7 @@
           <p:cNvPr id="8" name="">
             <a:extLst xmlns:a="http://schemas.openxmlformats.org/drawingml/2006/main">
               <a:ext uri="{FF2B5EF4-FFF2-40B4-BE49-F238E27FC236}">
-                <a16:creationId xmlns:a16="http://schemas.microsoft.com/office/drawing/2014/main" id="{0BF86D05-63E7-42DC-85A7-3B6A6B78B813}"/>
+                <a16:creationId xmlns:a16="http://schemas.microsoft.com/office/drawing/2014/main" id="{DC88344C-3571-4F89-9787-092EB536222B}"/>
               </a:ext>
             </a:extLst>
           </p:cNvPr>
@@ -6234,7 +6234,7 @@
           <p:cNvPr id="10" name="">
             <a:extLst xmlns:a="http://schemas.openxmlformats.org/drawingml/2006/main">
               <a:ext uri="{FF2B5EF4-FFF2-40B4-BE49-F238E27FC236}">
-                <a16:creationId xmlns:a16="http://schemas.microsoft.com/office/drawing/2014/main" id="{53AF1013-B976-4C95-8B81-E4297613DE4E}"/>
+                <a16:creationId xmlns:a16="http://schemas.microsoft.com/office/drawing/2014/main" id="{DAEA9E9D-C41B-43EB-84CF-A45D6C2EBBA8}"/>
               </a:ext>
             </a:extLst>
           </p:cNvPr>
@@ -6337,7 +6337,7 @@
           <p:cNvPr id="11" name="">
             <a:extLst xmlns:a="http://schemas.openxmlformats.org/drawingml/2006/main">
               <a:ext uri="{FF2B5EF4-FFF2-40B4-BE49-F238E27FC236}">
-                <a16:creationId xmlns:a16="http://schemas.microsoft.com/office/drawing/2014/main" id="{5BEACE2D-1122-4767-B05A-1440CBAA5CD4}"/>
+                <a16:creationId xmlns:a16="http://schemas.microsoft.com/office/drawing/2014/main" id="{B44F6EEB-40DE-4581-B4E9-D63887851F11}"/>
               </a:ext>
             </a:extLst>
           </p:cNvPr>
@@ -6392,7 +6392,7 @@
     </p:spTree>
     <p:extLst>
       <p:ext uri="{BB962C8B-B14F-4D97-AF65-F5344CB8AC3E}">
-        <p14:creationId xmlns:p14="http://schemas.microsoft.com/office/powerpoint/2010/main" val="1275888574"/>
+        <p14:creationId xmlns:p14="http://schemas.microsoft.com/office/powerpoint/2010/main" val="65866022"/>
       </p:ext>
     </p:extLst>
   </p:cSld>
@@ -6423,7 +6423,7 @@
           <p:cNvPr id="9" name="">
             <a:extLst xmlns:a="http://schemas.openxmlformats.org/drawingml/2006/main">
               <a:ext uri="{FF2B5EF4-FFF2-40B4-BE49-F238E27FC236}">
-                <a16:creationId xmlns:a16="http://schemas.microsoft.com/office/drawing/2014/main" id="{BEC5C470-6702-4762-A7DB-AEE2D9051B4C}"/>
+                <a16:creationId xmlns:a16="http://schemas.microsoft.com/office/drawing/2014/main" id="{48DCFF89-58ED-4229-9D86-BDA82A0BD32C}"/>
               </a:ext>
             </a:extLst>
           </p:cNvPr>
@@ -6480,7 +6480,7 @@
           <p:cNvPr id="2" name="">
             <a:extLst xmlns:a="http://schemas.openxmlformats.org/drawingml/2006/main">
               <a:ext uri="{FF2B5EF4-FFF2-40B4-BE49-F238E27FC236}">
-                <a16:creationId xmlns:a16="http://schemas.microsoft.com/office/drawing/2014/main" id="{DADF22E1-BE84-4CBE-9701-845143390288}"/>
+                <a16:creationId xmlns:a16="http://schemas.microsoft.com/office/drawing/2014/main" id="{20C577E2-16E5-4715-9D41-347C42114A92}"/>
               </a:ext>
             </a:extLst>
           </p:cNvPr>
@@ -6537,7 +6537,7 @@
           <p:cNvPr id="3" name="">
             <a:extLst xmlns:a="http://schemas.openxmlformats.org/drawingml/2006/main">
               <a:ext uri="{FF2B5EF4-FFF2-40B4-BE49-F238E27FC236}">
-                <a16:creationId xmlns:a16="http://schemas.microsoft.com/office/drawing/2014/main" id="{AA60264B-6638-4905-AA41-D2BAEB538400}"/>
+                <a16:creationId xmlns:a16="http://schemas.microsoft.com/office/drawing/2014/main" id="{CE4C7D6D-7AFC-4FBF-86E3-F7758A50F1BF}"/>
               </a:ext>
             </a:extLst>
           </p:cNvPr>
@@ -6594,7 +6594,7 @@
           <p:cNvPr id="4" name="">
             <a:extLst xmlns:a="http://schemas.openxmlformats.org/drawingml/2006/main">
               <a:ext uri="{FF2B5EF4-FFF2-40B4-BE49-F238E27FC236}">
-                <a16:creationId xmlns:a16="http://schemas.microsoft.com/office/drawing/2014/main" id="{1030DB95-3856-439E-B6F2-5092A62D16D5}"/>
+                <a16:creationId xmlns:a16="http://schemas.microsoft.com/office/drawing/2014/main" id="{EE36FC36-77EE-46F6-B912-DD39C2C936E6}"/>
               </a:ext>
             </a:extLst>
           </p:cNvPr>
@@ -6651,7 +6651,7 @@
           <p:cNvPr id="5" name="">
             <a:extLst xmlns:a="http://schemas.openxmlformats.org/drawingml/2006/main">
               <a:ext uri="{FF2B5EF4-FFF2-40B4-BE49-F238E27FC236}">
-                <a16:creationId xmlns:a16="http://schemas.microsoft.com/office/drawing/2014/main" id="{AEC16256-A9E3-4E97-9E53-2BF4E7E17E9B}"/>
+                <a16:creationId xmlns:a16="http://schemas.microsoft.com/office/drawing/2014/main" id="{1F652D0B-73D8-4890-8A38-C821BDD1DE19}"/>
               </a:ext>
             </a:extLst>
           </p:cNvPr>
@@ -6754,7 +6754,7 @@
           <p:cNvPr id="6" name="">
             <a:extLst xmlns:a="http://schemas.openxmlformats.org/drawingml/2006/main">
               <a:ext uri="{FF2B5EF4-FFF2-40B4-BE49-F238E27FC236}">
-                <a16:creationId xmlns:a16="http://schemas.microsoft.com/office/drawing/2014/main" id="{ACA4726E-2D24-44C5-BF92-D9B6B3877AB9}"/>
+                <a16:creationId xmlns:a16="http://schemas.microsoft.com/office/drawing/2014/main" id="{EFB52A63-3FAC-4CC9-88A9-2FD9AA5F80FA}"/>
               </a:ext>
             </a:extLst>
           </p:cNvPr>
@@ -6811,7 +6811,7 @@
           <p:cNvPr id="7" name="">
             <a:extLst xmlns:a="http://schemas.openxmlformats.org/drawingml/2006/main">
               <a:ext uri="{FF2B5EF4-FFF2-40B4-BE49-F238E27FC236}">
-                <a16:creationId xmlns:a16="http://schemas.microsoft.com/office/drawing/2014/main" id="{988C246A-89ED-4339-90D5-16EC40BE3A09}"/>
+                <a16:creationId xmlns:a16="http://schemas.microsoft.com/office/drawing/2014/main" id="{D134CDDB-E98A-4573-8D64-0C8CF59AA818}"/>
               </a:ext>
             </a:extLst>
           </p:cNvPr>
@@ -6914,7 +6914,7 @@
           <p:cNvPr id="8" name="">
             <a:extLst xmlns:a="http://schemas.openxmlformats.org/drawingml/2006/main">
               <a:ext uri="{FF2B5EF4-FFF2-40B4-BE49-F238E27FC236}">
-                <a16:creationId xmlns:a16="http://schemas.microsoft.com/office/drawing/2014/main" id="{083F8BB1-C249-4579-AF3D-06AD9046FD9F}"/>
+                <a16:creationId xmlns:a16="http://schemas.microsoft.com/office/drawing/2014/main" id="{81C6806A-D177-47FF-9728-DBCCCC1E6630}"/>
               </a:ext>
             </a:extLst>
           </p:cNvPr>
@@ -6969,7 +6969,7 @@
     </p:spTree>
     <p:extLst>
       <p:ext uri="{BB962C8B-B14F-4D97-AF65-F5344CB8AC3E}">
-        <p14:creationId xmlns:p14="http://schemas.microsoft.com/office/powerpoint/2010/main" val="291904468"/>
+        <p14:creationId xmlns:p14="http://schemas.microsoft.com/office/powerpoint/2010/main" val="1995457026"/>
       </p:ext>
     </p:extLst>
   </p:cSld>
@@ -7000,7 +7000,7 @@
           <p:cNvPr id="6" name="">
             <a:extLst xmlns:a="http://schemas.openxmlformats.org/drawingml/2006/main">
               <a:ext uri="{FF2B5EF4-FFF2-40B4-BE49-F238E27FC236}">
-                <a16:creationId xmlns:a16="http://schemas.microsoft.com/office/drawing/2014/main" id="{6EB83094-D456-4E4C-BE7A-E056D6F995B1}"/>
+                <a16:creationId xmlns:a16="http://schemas.microsoft.com/office/drawing/2014/main" id="{1840D0A1-BAC3-47A7-AD4B-E17B2F8F212A}"/>
               </a:ext>
             </a:extLst>
           </p:cNvPr>
@@ -7057,7 +7057,7 @@
           <p:cNvPr id="2" name="">
             <a:extLst xmlns:a="http://schemas.openxmlformats.org/drawingml/2006/main">
               <a:ext uri="{FF2B5EF4-FFF2-40B4-BE49-F238E27FC236}">
-                <a16:creationId xmlns:a16="http://schemas.microsoft.com/office/drawing/2014/main" id="{B7FC84E2-1E50-4E7F-A5B0-B9DAD54BFE93}"/>
+                <a16:creationId xmlns:a16="http://schemas.microsoft.com/office/drawing/2014/main" id="{6888AD13-C90A-4E03-84F0-6DABFA901E4A}"/>
               </a:ext>
             </a:extLst>
           </p:cNvPr>
@@ -7114,7 +7114,7 @@
           <p:cNvPr id="3" name="">
             <a:extLst xmlns:a="http://schemas.openxmlformats.org/drawingml/2006/main">
               <a:ext uri="{FF2B5EF4-FFF2-40B4-BE49-F238E27FC236}">
-                <a16:creationId xmlns:a16="http://schemas.microsoft.com/office/drawing/2014/main" id="{82395CE2-7EB6-4D45-BADA-2A372134C827}"/>
+                <a16:creationId xmlns:a16="http://schemas.microsoft.com/office/drawing/2014/main" id="{5F56D04A-AFE4-42C3-9200-6180C3182111}"/>
               </a:ext>
             </a:extLst>
           </p:cNvPr>
@@ -7456,7 +7456,7 @@
           <p:cNvPr id="5" name="">
             <a:extLst xmlns:a="http://schemas.openxmlformats.org/drawingml/2006/main">
               <a:ext uri="{FF2B5EF4-FFF2-40B4-BE49-F238E27FC236}">
-                <a16:creationId xmlns:a16="http://schemas.microsoft.com/office/drawing/2014/main" id="{EDB2AAAA-C857-455E-9AB2-B3BE183E7E88}"/>
+                <a16:creationId xmlns:a16="http://schemas.microsoft.com/office/drawing/2014/main" id="{77AF1C82-B032-455A-BD30-4717D8F04B4E}"/>
               </a:ext>
             </a:extLst>
           </p:cNvPr>
@@ -7511,7 +7511,7 @@
     </p:spTree>
     <p:extLst>
       <p:ext uri="{BB962C8B-B14F-4D97-AF65-F5344CB8AC3E}">
-        <p14:creationId xmlns:p14="http://schemas.microsoft.com/office/powerpoint/2010/main" val="290541428"/>
+        <p14:creationId xmlns:p14="http://schemas.microsoft.com/office/powerpoint/2010/main" val="664473040"/>
       </p:ext>
     </p:extLst>
   </p:cSld>
@@ -7539,10 +7539,10 @@
       </p:grpSpPr>
       <p:sp>
         <p:nvSpPr>
-          <p:cNvPr id="7" name="">
+          <p:cNvPr id="9" name="">
             <a:extLst xmlns:a="http://schemas.openxmlformats.org/drawingml/2006/main">
               <a:ext uri="{FF2B5EF4-FFF2-40B4-BE49-F238E27FC236}">
-                <a16:creationId xmlns:a16="http://schemas.microsoft.com/office/drawing/2014/main" id="{B12AEF62-E37D-456D-B640-038CDAB8CAC0}"/>
+                <a16:creationId xmlns:a16="http://schemas.microsoft.com/office/drawing/2014/main" id="{C5A6B4B8-188F-4818-9B33-6D66B824F20D}"/>
               </a:ext>
             </a:extLst>
           </p:cNvPr>
@@ -7589,7 +7589,7 @@
                 <a:ea typeface="Apple SD Gothic Neo"/>
                 <a:cs typeface="Apple SD Gothic Neo"/>
               </a:rPr>
-              <a:t>구매 경로별 부분 견적</a:t>
+              <a:t>구매 경로별 비용 구성</a:t>
             </a:r>
           </a:p>
         </p:txBody>
@@ -7599,7 +7599,7 @@
           <p:cNvPr id="2" name="">
             <a:extLst xmlns:a="http://schemas.openxmlformats.org/drawingml/2006/main">
               <a:ext uri="{FF2B5EF4-FFF2-40B4-BE49-F238E27FC236}">
-                <a16:creationId xmlns:a16="http://schemas.microsoft.com/office/drawing/2014/main" id="{BBB00839-939E-4B69-BE02-EEF30EF9D60D}"/>
+                <a16:creationId xmlns:a16="http://schemas.microsoft.com/office/drawing/2014/main" id="{99A36C80-2506-4E87-A58E-38336B94F5DF}"/>
               </a:ext>
             </a:extLst>
           </p:cNvPr>
@@ -7646,7 +7646,7 @@
                 <a:ea typeface="Apple SD Gothic Neo"/>
                 <a:cs typeface="Apple SD Gothic Neo"/>
               </a:rPr>
-              <a:t>2026-09-21 · 영상 매체(Blu-ray) 1개를 기준으로 조사했습니다.</a:t>
+              <a:t>2026-10-06 확인 · 영상 매체(Blu-ray) 1개 · 원화 비교 환산</a:t>
             </a:r>
           </a:p>
         </p:txBody>
@@ -7656,7 +7656,7 @@
           <p:cNvPr id="3" name="">
             <a:extLst xmlns:a="http://schemas.openxmlformats.org/drawingml/2006/main">
               <a:ext uri="{FF2B5EF4-FFF2-40B4-BE49-F238E27FC236}">
-                <a16:creationId xmlns:a16="http://schemas.microsoft.com/office/drawing/2014/main" id="{B3E0DFA1-08E6-4194-A7B0-CFECB7E4926D}"/>
+                <a16:creationId xmlns:a16="http://schemas.microsoft.com/office/drawing/2014/main" id="{4A53B9B0-0E2A-4760-AEE6-DC0EBD54B194}"/>
               </a:ext>
             </a:extLst>
           </p:cNvPr>
@@ -7708,33 +7708,57 @@
           </a:p>
         </p:txBody>
       </p:sp>
+      <p:pic>
+        <p:nvPicPr>
+          <p:cNvPr id="12" name=""/>
+          <p:cNvPicPr>
+            <a:picLocks xmlns:a="http://schemas.openxmlformats.org/drawingml/2006/main" noChangeAspect="1"/>
+          </p:cNvPicPr>
+          <p:nvPr/>
+        </p:nvPicPr>
+        <p:blipFill>
+          <a:blip xmlns:r="http://schemas.openxmlformats.org/officeDocument/2006/relationships" xmlns:a="http://schemas.openxmlformats.org/drawingml/2006/main" r:embed="Rfa41460f95094426"/>
+          <a:stretch xmlns:a="http://schemas.openxmlformats.org/drawingml/2006/main"/>
+        </p:blipFill>
+        <p:spPr>
+          <a:xfrm xmlns:a="http://schemas.openxmlformats.org/drawingml/2006/main">
+            <a:off x="13006595" y="361950"/>
+            <a:ext cx="1371185" cy="1952625"/>
+          </a:xfrm>
+          <a:prstGeom xmlns:a="http://schemas.openxmlformats.org/drawingml/2006/main" prst="rect">
+            <a:avLst/>
+          </a:prstGeom>
+        </p:spPr>
+      </p:pic>
       <p:graphicFrame>
         <p:nvGraphicFramePr>
-          <p:cNvPr id="10" name=""/>
+          <p:cNvPr id="13" name=""/>
           <p:cNvGraphicFramePr/>
           <p:nvPr/>
         </p:nvGraphicFramePr>
         <p:xfrm>
-          <a:off xmlns:a="http://schemas.openxmlformats.org/drawingml/2006/main" x="819150" y="2686050"/>
-          <a:ext xmlns:a="http://schemas.openxmlformats.org/drawingml/2006/main" cx="13601700" cy="3619500"/>
+          <a:off xmlns:a="http://schemas.openxmlformats.org/drawingml/2006/main" x="819150" y="2638425"/>
+          <a:ext xmlns:a="http://schemas.openxmlformats.org/drawingml/2006/main" cx="13601700" cy="3810000"/>
         </p:xfrm>
         <a:graphic xmlns:a="http://schemas.openxmlformats.org/drawingml/2006/main">
           <a:graphicData uri="http://schemas.openxmlformats.org/drawingml/2006/table">
             <a:tbl>
               <a:tblPr/>
               <a:tblGrid>
-                <a:gridCol w="5048250"/>
-                <a:gridCol w="2762250"/>
-                <a:gridCol w="5791200"/>
+                <a:gridCol w="4095750"/>
+                <a:gridCol w="3000375"/>
+                <a:gridCol w="2476500"/>
+                <a:gridCol w="1809750"/>
+                <a:gridCol w="2219325"/>
               </a:tblGrid>
-              <a:tr h="723900">
+              <a:tr h="635000">
                 <a:tc>
                   <a:txBody>
                     <a:bodyPr/>
                     <a:lstStyle/>
                     <a:p>
                       <a:r>
-                        <a:rPr sz="1950" b="1">
+                        <a:rPr sz="1800" b="1">
                           <a:solidFill>
                             <a:srgbClr val="FFFFFF"/>
                           </a:solidFill>
@@ -7742,7 +7766,7 @@
                           <a:ea typeface="Apple SD Gothic Neo"/>
                           <a:cs typeface="Apple SD Gothic Neo"/>
                         </a:rPr>
-                        <a:t>경로</a:t>
+                        <a:t>구매 경로</a:t>
                       </a:r>
                     </a:p>
                   </a:txBody>
@@ -7758,7 +7782,7 @@
                     <a:lstStyle/>
                     <a:p>
                       <a:r>
-                        <a:rPr sz="1950" b="1">
+                        <a:rPr sz="1800" b="1">
                           <a:solidFill>
                             <a:srgbClr val="FFFFFF"/>
                           </a:solidFill>
@@ -7766,7 +7790,7 @@
                           <a:ea typeface="Apple SD Gothic Neo"/>
                           <a:cs typeface="Apple SD Gothic Neo"/>
                         </a:rPr>
-                        <a:t>확인 비용 합계</a:t>
+                        <a:t>커머스 구매 비용¹</a:t>
                       </a:r>
                     </a:p>
                   </a:txBody>
@@ -7782,7 +7806,7 @@
                     <a:lstStyle/>
                     <a:p>
                       <a:r>
-                        <a:rPr sz="1950" b="1">
+                        <a:rPr sz="1800" b="1">
                           <a:solidFill>
                             <a:srgbClr val="FFFFFF"/>
                           </a:solidFill>
@@ -7790,7 +7814,55 @@
                           <a:ea typeface="Apple SD Gothic Neo"/>
                           <a:cs typeface="Apple SD Gothic Neo"/>
                         </a:rPr>
-                        <a:t>조건</a:t>
+                        <a:t>배송 비용²</a:t>
+                      </a:r>
+                    </a:p>
+                  </a:txBody>
+                  <a:tcPr marL="91440" marR="91440" marT="45720" marB="45720">
+                    <a:solidFill>
+                      <a:srgbClr val="182C29"/>
+                    </a:solidFill>
+                  </a:tcPr>
+                </a:tc>
+                <a:tc>
+                  <a:txBody>
+                    <a:bodyPr/>
+                    <a:lstStyle/>
+                    <a:p>
+                      <a:r>
+                        <a:rPr sz="1800" b="1">
+                          <a:solidFill>
+                            <a:srgbClr val="FFFFFF"/>
+                          </a:solidFill>
+                          <a:latin typeface="Apple SD Gothic Neo"/>
+                          <a:ea typeface="Apple SD Gothic Neo"/>
+                          <a:cs typeface="Apple SD Gothic Neo"/>
+                        </a:rPr>
+                        <a:t>별도 표시</a:t>
+                      </a:r>
+                    </a:p>
+                  </a:txBody>
+                  <a:tcPr marL="91440" marR="91440" marT="45720" marB="45720">
+                    <a:solidFill>
+                      <a:srgbClr val="182C29"/>
+                    </a:solidFill>
+                  </a:tcPr>
+                </a:tc>
+                <a:tc>
+                  <a:txBody>
+                    <a:bodyPr/>
+                    <a:lstStyle/>
+                    <a:p>
+                      <a:r>
+                        <a:rPr sz="1800" b="1">
+                          <a:solidFill>
+                            <a:srgbClr val="FFFFFF"/>
+                          </a:solidFill>
+                          <a:latin typeface="Apple SD Gothic Neo"/>
+                          <a:ea typeface="Apple SD Gothic Neo"/>
+                          <a:cs typeface="Apple SD Gothic Neo"/>
+                        </a:rPr>
+                        <a:t>확인 소계</a:t>
                       </a:r>
                     </a:p>
                   </a:txBody>
@@ -7801,14 +7873,14 @@
                   </a:tcPr>
                 </a:tc>
               </a:tr>
-              <a:tr h="723900">
+              <a:tr h="635000">
                 <a:tc>
                   <a:txBody>
                     <a:bodyPr/>
                     <a:lstStyle/>
                     <a:p>
                       <a:r>
-                        <a:rPr sz="2025" b="0">
+                        <a:rPr sz="1800" b="0">
                           <a:solidFill>
                             <a:srgbClr val="182C29"/>
                           </a:solidFill>
@@ -7832,7 +7904,7 @@
                     <a:lstStyle/>
                     <a:p>
                       <a:r>
-                        <a:rPr sz="2025" b="0">
+                        <a:rPr sz="1800" b="0">
                           <a:solidFill>
                             <a:srgbClr val="182C29"/>
                           </a:solidFill>
@@ -7840,7 +7912,7 @@
                           <a:ea typeface="Apple SD Gothic Neo"/>
                           <a:cs typeface="Apple SD Gothic Neo"/>
                         </a:rPr>
-                        <a:t>약 7,228엔</a:t>
+                        <a:t>50,363원</a:t>
                       </a:r>
                     </a:p>
                   </a:txBody>
@@ -7856,7 +7928,7 @@
                     <a:lstStyle/>
                     <a:p>
                       <a:r>
-                        <a:rPr sz="2025" b="0">
+                        <a:rPr sz="1800" b="0">
                           <a:solidFill>
                             <a:srgbClr val="182C29"/>
                           </a:solidFill>
@@ -7864,7 +7936,55 @@
                           <a:ea typeface="Apple SD Gothic Neo"/>
                           <a:cs typeface="Apple SD Gothic Neo"/>
                         </a:rPr>
-                        <a:t>63,878원 환산 · 세부 조건 미확인</a:t>
+                        <a:t>7,715원</a:t>
+                      </a:r>
+                    </a:p>
+                  </a:txBody>
+                  <a:tcPr marL="91440" marR="91440" marT="45720" marB="45720">
+                    <a:solidFill>
+                      <a:srgbClr val="FFFFFF"/>
+                    </a:solidFill>
+                  </a:tcPr>
+                </a:tc>
+                <a:tc>
+                  <a:txBody>
+                    <a:bodyPr/>
+                    <a:lstStyle/>
+                    <a:p>
+                      <a:r>
+                        <a:rPr sz="1800" b="0">
+                          <a:solidFill>
+                            <a:srgbClr val="182C29"/>
+                          </a:solidFill>
+                          <a:latin typeface="Apple SD Gothic Neo"/>
+                          <a:ea typeface="Apple SD Gothic Neo"/>
+                          <a:cs typeface="Apple SD Gothic Neo"/>
+                        </a:rPr>
+                        <a:t>5,036원³</a:t>
+                      </a:r>
+                    </a:p>
+                  </a:txBody>
+                  <a:tcPr marL="91440" marR="91440" marT="45720" marB="45720">
+                    <a:solidFill>
+                      <a:srgbClr val="FFFFFF"/>
+                    </a:solidFill>
+                  </a:tcPr>
+                </a:tc>
+                <a:tc>
+                  <a:txBody>
+                    <a:bodyPr/>
+                    <a:lstStyle/>
+                    <a:p>
+                      <a:r>
+                        <a:rPr sz="1800" b="0">
+                          <a:solidFill>
+                            <a:srgbClr val="182C29"/>
+                          </a:solidFill>
+                          <a:latin typeface="Apple SD Gothic Neo"/>
+                          <a:ea typeface="Apple SD Gothic Neo"/>
+                          <a:cs typeface="Apple SD Gothic Neo"/>
+                        </a:rPr>
+                        <a:t>63,114원</a:t>
                       </a:r>
                     </a:p>
                   </a:txBody>
@@ -7875,14 +7995,14 @@
                   </a:tcPr>
                 </a:tc>
               </a:tr>
-              <a:tr h="723900">
+              <a:tr h="635000">
                 <a:tc>
                   <a:txBody>
                     <a:bodyPr/>
                     <a:lstStyle/>
                     <a:p>
                       <a:r>
-                        <a:rPr sz="2025" b="0">
+                        <a:rPr sz="1800" b="0">
                           <a:solidFill>
                             <a:srgbClr val="182C29"/>
                           </a:solidFill>
@@ -7906,7 +8026,7 @@
                     <a:lstStyle/>
                     <a:p>
                       <a:r>
-                        <a:rPr sz="2025" b="0">
+                        <a:rPr sz="1800" b="0">
                           <a:solidFill>
                             <a:srgbClr val="182C29"/>
                           </a:solidFill>
@@ -7914,7 +8034,20 @@
                           <a:ea typeface="Apple SD Gothic Neo"/>
                           <a:cs typeface="Apple SD Gothic Neo"/>
                         </a:rPr>
-                        <a:t>7,472엔</a:t>
+                        <a:t>약48,802원</a:t>
+                      </a:r>
+                    </a:p>
+                    <a:p>
+                      <a:r>
+                        <a:rPr sz="1800" b="0">
+                          <a:solidFill>
+                            <a:srgbClr val="182C29"/>
+                          </a:solidFill>
+                          <a:latin typeface="Apple SD Gothic Neo"/>
+                          <a:ea typeface="Apple SD Gothic Neo"/>
+                          <a:cs typeface="Apple SD Gothic Neo"/>
+                        </a:rPr>
+                        <a:t>(5,666엔)</a:t>
                       </a:r>
                     </a:p>
                   </a:txBody>
@@ -7930,7 +8063,7 @@
                     <a:lstStyle/>
                     <a:p>
                       <a:r>
-                        <a:rPr sz="2025" b="0">
+                        <a:rPr sz="1800" b="0">
                           <a:solidFill>
                             <a:srgbClr val="182C29"/>
                           </a:solidFill>
@@ -7938,7 +8071,68 @@
                           <a:ea typeface="Apple SD Gothic Neo"/>
                           <a:cs typeface="Apple SD Gothic Neo"/>
                         </a:rPr>
-                        <a:t>250g · 19×14×2cm 가정</a:t>
+                        <a:t>약15,504원</a:t>
+                      </a:r>
+                    </a:p>
+                    <a:p>
+                      <a:r>
+                        <a:rPr sz="1800" b="0">
+                          <a:solidFill>
+                            <a:srgbClr val="182C29"/>
+                          </a:solidFill>
+                          <a:latin typeface="Apple SD Gothic Neo"/>
+                          <a:ea typeface="Apple SD Gothic Neo"/>
+                          <a:cs typeface="Apple SD Gothic Neo"/>
+                        </a:rPr>
+                        <a:t>(1,800엔)</a:t>
+                      </a:r>
+                    </a:p>
+                  </a:txBody>
+                  <a:tcPr marL="91440" marR="91440" marT="45720" marB="45720">
+                    <a:solidFill>
+                      <a:srgbClr val="F8F8F3"/>
+                    </a:solidFill>
+                  </a:tcPr>
+                </a:tc>
+                <a:tc>
+                  <a:txBody>
+                    <a:bodyPr/>
+                    <a:lstStyle/>
+                    <a:p>
+                      <a:r>
+                        <a:rPr sz="1800" b="0">
+                          <a:solidFill>
+                            <a:srgbClr val="182C29"/>
+                          </a:solidFill>
+                          <a:latin typeface="Apple SD Gothic Neo"/>
+                          <a:ea typeface="Apple SD Gothic Neo"/>
+                          <a:cs typeface="Apple SD Gothic Neo"/>
+                        </a:rPr>
+                        <a:t>추가비 별도</a:t>
+                      </a:r>
+                    </a:p>
+                  </a:txBody>
+                  <a:tcPr marL="91440" marR="91440" marT="45720" marB="45720">
+                    <a:solidFill>
+                      <a:srgbClr val="F8F8F3"/>
+                    </a:solidFill>
+                  </a:tcPr>
+                </a:tc>
+                <a:tc>
+                  <a:txBody>
+                    <a:bodyPr/>
+                    <a:lstStyle/>
+                    <a:p>
+                      <a:r>
+                        <a:rPr sz="1800" b="0">
+                          <a:solidFill>
+                            <a:srgbClr val="182C29"/>
+                          </a:solidFill>
+                          <a:latin typeface="Apple SD Gothic Neo"/>
+                          <a:ea typeface="Apple SD Gothic Neo"/>
+                          <a:cs typeface="Apple SD Gothic Neo"/>
+                        </a:rPr>
+                        <a:t>약64,306원</a:t>
                       </a:r>
                     </a:p>
                   </a:txBody>
@@ -7949,14 +8143,14 @@
                   </a:tcPr>
                 </a:tc>
               </a:tr>
-              <a:tr h="723900">
+              <a:tr h="635000">
                 <a:tc>
                   <a:txBody>
                     <a:bodyPr/>
                     <a:lstStyle/>
                     <a:p>
                       <a:r>
-                        <a:rPr sz="2025" b="0">
+                        <a:rPr sz="1800" b="0">
                           <a:solidFill>
                             <a:srgbClr val="182C29"/>
                           </a:solidFill>
@@ -7964,7 +8158,7 @@
                           <a:ea typeface="Apple SD Gothic Neo"/>
                           <a:cs typeface="Apple SD Gothic Neo"/>
                         </a:rPr>
-                        <a:t>공식 스토어 + EMS</a:t>
+                        <a:t>라쿠텐 북스 + 몰테일 항공</a:t>
                       </a:r>
                     </a:p>
                   </a:txBody>
@@ -7980,7 +8174,7 @@
                     <a:lstStyle/>
                     <a:p>
                       <a:r>
-                        <a:rPr sz="2025" b="0">
+                        <a:rPr sz="1800" b="0">
                           <a:solidFill>
                             <a:srgbClr val="182C29"/>
                           </a:solidFill>
@@ -7988,7 +8182,20 @@
                           <a:ea typeface="Apple SD Gothic Neo"/>
                           <a:cs typeface="Apple SD Gothic Neo"/>
                         </a:rPr>
-                        <a:t>약 7,821엔</a:t>
+                        <a:t>약48,371원</a:t>
+                      </a:r>
+                    </a:p>
+                    <a:p>
+                      <a:r>
+                        <a:rPr sz="1800" b="0">
+                          <a:solidFill>
+                            <a:srgbClr val="182C29"/>
+                          </a:solidFill>
+                          <a:latin typeface="Apple SD Gothic Neo"/>
+                          <a:ea typeface="Apple SD Gothic Neo"/>
+                          <a:cs typeface="Apple SD Gothic Neo"/>
+                        </a:rPr>
+                        <a:t>(주문5,616엔)</a:t>
                       </a:r>
                     </a:p>
                   </a:txBody>
@@ -8004,7 +8211,7 @@
                     <a:lstStyle/>
                     <a:p>
                       <a:r>
-                        <a:rPr sz="2025" b="0">
+                        <a:rPr sz="1800" b="0">
                           <a:solidFill>
                             <a:srgbClr val="182C29"/>
                           </a:solidFill>
@@ -8012,7 +8219,68 @@
                           <a:ea typeface="Apple SD Gothic Neo"/>
                           <a:cs typeface="Apple SD Gothic Neo"/>
                         </a:rPr>
-                        <a:t>69,112원 환산 · 특전 차이 가능</a:t>
+                        <a:t>약21,212원</a:t>
+                      </a:r>
+                    </a:p>
+                    <a:p>
+                      <a:r>
+                        <a:rPr sz="1800" b="0">
+                          <a:solidFill>
+                            <a:srgbClr val="182C29"/>
+                          </a:solidFill>
+                          <a:latin typeface="Apple SD Gothic Neo"/>
+                          <a:ea typeface="Apple SD Gothic Neo"/>
+                          <a:cs typeface="Apple SD Gothic Neo"/>
+                        </a:rPr>
+                        <a:t>($15.63)</a:t>
+                      </a:r>
+                    </a:p>
+                  </a:txBody>
+                  <a:tcPr marL="91440" marR="91440" marT="45720" marB="45720">
+                    <a:solidFill>
+                      <a:srgbClr val="FFFFFF"/>
+                    </a:solidFill>
+                  </a:tcPr>
+                </a:tc>
+                <a:tc>
+                  <a:txBody>
+                    <a:bodyPr/>
+                    <a:lstStyle/>
+                    <a:p>
+                      <a:r>
+                        <a:rPr sz="1800" b="0">
+                          <a:solidFill>
+                            <a:srgbClr val="182C29"/>
+                          </a:solidFill>
+                          <a:latin typeface="Apple SD Gothic Neo"/>
+                          <a:ea typeface="Apple SD Gothic Neo"/>
+                          <a:cs typeface="Apple SD Gothic Neo"/>
+                        </a:rPr>
+                        <a:t>추가비 별도</a:t>
+                      </a:r>
+                    </a:p>
+                  </a:txBody>
+                  <a:tcPr marL="91440" marR="91440" marT="45720" marB="45720">
+                    <a:solidFill>
+                      <a:srgbClr val="FFFFFF"/>
+                    </a:solidFill>
+                  </a:tcPr>
+                </a:tc>
+                <a:tc>
+                  <a:txBody>
+                    <a:bodyPr/>
+                    <a:lstStyle/>
+                    <a:p>
+                      <a:r>
+                        <a:rPr sz="1800" b="0">
+                          <a:solidFill>
+                            <a:srgbClr val="182C29"/>
+                          </a:solidFill>
+                          <a:latin typeface="Apple SD Gothic Neo"/>
+                          <a:ea typeface="Apple SD Gothic Neo"/>
+                          <a:cs typeface="Apple SD Gothic Neo"/>
+                        </a:rPr>
+                        <a:t>약69,583원</a:t>
                       </a:r>
                     </a:p>
                   </a:txBody>
@@ -8023,14 +8291,14 @@
                   </a:tcPr>
                 </a:tc>
               </a:tr>
-              <a:tr h="723900">
+              <a:tr h="635000">
                 <a:tc>
                   <a:txBody>
                     <a:bodyPr/>
                     <a:lstStyle/>
                     <a:p>
                       <a:r>
-                        <a:rPr sz="2025" b="0">
+                        <a:rPr sz="1800" b="0">
                           <a:solidFill>
                             <a:srgbClr val="182C29"/>
                           </a:solidFill>
@@ -8054,7 +8322,7 @@
                     <a:lstStyle/>
                     <a:p>
                       <a:r>
-                        <a:rPr sz="2025" b="0">
+                        <a:rPr sz="1800" b="0">
                           <a:solidFill>
                             <a:srgbClr val="182C29"/>
                           </a:solidFill>
@@ -8062,7 +8330,20 @@
                           <a:ea typeface="Apple SD Gothic Neo"/>
                           <a:cs typeface="Apple SD Gothic Neo"/>
                         </a:rPr>
-                        <a:t>8,189엔</a:t>
+                        <a:t>약53,682원</a:t>
+                      </a:r>
+                    </a:p>
+                    <a:p>
+                      <a:r>
+                        <a:rPr sz="1800" b="0">
+                          <a:solidFill>
+                            <a:srgbClr val="182C29"/>
+                          </a:solidFill>
+                          <a:latin typeface="Apple SD Gothic Neo"/>
+                          <a:ea typeface="Apple SD Gothic Neo"/>
+                          <a:cs typeface="Apple SD Gothic Neo"/>
+                        </a:rPr>
+                        <a:t>(상품+대행료10%)</a:t>
                       </a:r>
                     </a:p>
                   </a:txBody>
@@ -8078,7 +8359,7 @@
                     <a:lstStyle/>
                     <a:p>
                       <a:r>
-                        <a:rPr sz="2025" b="0">
+                        <a:rPr sz="1800" b="0">
                           <a:solidFill>
                             <a:srgbClr val="182C29"/>
                           </a:solidFill>
@@ -8086,7 +8367,68 @@
                           <a:ea typeface="Apple SD Gothic Neo"/>
                           <a:cs typeface="Apple SD Gothic Neo"/>
                         </a:rPr>
-                        <a:t>250g 가정 · 대행료 포함</a:t>
+                        <a:t>약16,796원</a:t>
+                      </a:r>
+                    </a:p>
+                    <a:p>
+                      <a:r>
+                        <a:rPr sz="1800" b="0">
+                          <a:solidFill>
+                            <a:srgbClr val="182C29"/>
+                          </a:solidFill>
+                          <a:latin typeface="Apple SD Gothic Neo"/>
+                          <a:ea typeface="Apple SD Gothic Neo"/>
+                          <a:cs typeface="Apple SD Gothic Neo"/>
+                        </a:rPr>
+                        <a:t>(1,950엔)</a:t>
+                      </a:r>
+                    </a:p>
+                  </a:txBody>
+                  <a:tcPr marL="91440" marR="91440" marT="45720" marB="45720">
+                    <a:solidFill>
+                      <a:srgbClr val="F8F8F3"/>
+                    </a:solidFill>
+                  </a:tcPr>
+                </a:tc>
+                <a:tc>
+                  <a:txBody>
+                    <a:bodyPr/>
+                    <a:lstStyle/>
+                    <a:p>
+                      <a:r>
+                        <a:rPr sz="1800" b="0">
+                          <a:solidFill>
+                            <a:srgbClr val="182C29"/>
+                          </a:solidFill>
+                          <a:latin typeface="Apple SD Gothic Neo"/>
+                          <a:ea typeface="Apple SD Gothic Neo"/>
+                          <a:cs typeface="Apple SD Gothic Neo"/>
+                        </a:rPr>
+                        <a:t>추가비 별도</a:t>
+                      </a:r>
+                    </a:p>
+                  </a:txBody>
+                  <a:tcPr marL="91440" marR="91440" marT="45720" marB="45720">
+                    <a:solidFill>
+                      <a:srgbClr val="F8F8F3"/>
+                    </a:solidFill>
+                  </a:tcPr>
+                </a:tc>
+                <a:tc>
+                  <a:txBody>
+                    <a:bodyPr/>
+                    <a:lstStyle/>
+                    <a:p>
+                      <a:r>
+                        <a:rPr sz="1800" b="0">
+                          <a:solidFill>
+                            <a:srgbClr val="182C29"/>
+                          </a:solidFill>
+                          <a:latin typeface="Apple SD Gothic Neo"/>
+                          <a:ea typeface="Apple SD Gothic Neo"/>
+                          <a:cs typeface="Apple SD Gothic Neo"/>
+                        </a:rPr>
+                        <a:t>약70,478원</a:t>
                       </a:r>
                     </a:p>
                   </a:txBody>
@@ -8097,16 +8439,138 @@
                   </a:tcPr>
                 </a:tc>
               </a:tr>
+              <a:tr h="635000">
+                <a:tc>
+                  <a:txBody>
+                    <a:bodyPr/>
+                    <a:lstStyle/>
+                    <a:p>
+                      <a:r>
+                        <a:rPr sz="1800" b="0">
+                          <a:solidFill>
+                            <a:srgbClr val="182C29"/>
+                          </a:solidFill>
+                          <a:latin typeface="Apple SD Gothic Neo"/>
+                          <a:ea typeface="Apple SD Gothic Neo"/>
+                          <a:cs typeface="Apple SD Gothic Neo"/>
+                        </a:rPr>
+                        <a:t>공식 스토어 + 국제배송</a:t>
+                      </a:r>
+                    </a:p>
+                  </a:txBody>
+                  <a:tcPr marL="91440" marR="91440" marT="45720" marB="45720">
+                    <a:solidFill>
+                      <a:srgbClr val="FFFFFF"/>
+                    </a:solidFill>
+                  </a:tcPr>
+                </a:tc>
+                <a:tc>
+                  <a:txBody>
+                    <a:bodyPr/>
+                    <a:lstStyle/>
+                    <a:p>
+                      <a:r>
+                        <a:rPr sz="1800" b="0">
+                          <a:solidFill>
+                            <a:srgbClr val="182C29"/>
+                          </a:solidFill>
+                          <a:latin typeface="Apple SD Gothic Neo"/>
+                          <a:ea typeface="Apple SD Gothic Neo"/>
+                          <a:cs typeface="Apple SD Gothic Neo"/>
+                        </a:rPr>
+                        <a:t>51,868원</a:t>
+                      </a:r>
+                    </a:p>
+                  </a:txBody>
+                  <a:tcPr marL="91440" marR="91440" marT="45720" marB="45720">
+                    <a:solidFill>
+                      <a:srgbClr val="FFFFFF"/>
+                    </a:solidFill>
+                  </a:tcPr>
+                </a:tc>
+                <a:tc>
+                  <a:txBody>
+                    <a:bodyPr/>
+                    <a:lstStyle/>
+                    <a:p>
+                      <a:r>
+                        <a:rPr sz="1800" b="0">
+                          <a:solidFill>
+                            <a:srgbClr val="182C29"/>
+                          </a:solidFill>
+                          <a:latin typeface="Apple SD Gothic Neo"/>
+                          <a:ea typeface="Apple SD Gothic Neo"/>
+                          <a:cs typeface="Apple SD Gothic Neo"/>
+                        </a:rPr>
+                        <a:t>14,419원</a:t>
+                      </a:r>
+                    </a:p>
+                  </a:txBody>
+                  <a:tcPr marL="91440" marR="91440" marT="45720" marB="45720">
+                    <a:solidFill>
+                      <a:srgbClr val="FFFFFF"/>
+                    </a:solidFill>
+                  </a:tcPr>
+                </a:tc>
+                <a:tc>
+                  <a:txBody>
+                    <a:bodyPr/>
+                    <a:lstStyle/>
+                    <a:p>
+                      <a:r>
+                        <a:rPr sz="1800" b="0">
+                          <a:solidFill>
+                            <a:srgbClr val="182C29"/>
+                          </a:solidFill>
+                          <a:latin typeface="Apple SD Gothic Neo"/>
+                          <a:ea typeface="Apple SD Gothic Neo"/>
+                          <a:cs typeface="Apple SD Gothic Neo"/>
+                        </a:rPr>
+                        <a:t>추가비 별도</a:t>
+                      </a:r>
+                    </a:p>
+                  </a:txBody>
+                  <a:tcPr marL="91440" marR="91440" marT="45720" marB="45720">
+                    <a:solidFill>
+                      <a:srgbClr val="FFFFFF"/>
+                    </a:solidFill>
+                  </a:tcPr>
+                </a:tc>
+                <a:tc>
+                  <a:txBody>
+                    <a:bodyPr/>
+                    <a:lstStyle/>
+                    <a:p>
+                      <a:r>
+                        <a:rPr sz="1800" b="0">
+                          <a:solidFill>
+                            <a:srgbClr val="182C29"/>
+                          </a:solidFill>
+                          <a:latin typeface="Apple SD Gothic Neo"/>
+                          <a:ea typeface="Apple SD Gothic Neo"/>
+                          <a:cs typeface="Apple SD Gothic Neo"/>
+                        </a:rPr>
+                        <a:t>66,287원</a:t>
+                      </a:r>
+                    </a:p>
+                  </a:txBody>
+                  <a:tcPr marL="91440" marR="91440" marT="45720" marB="45720">
+                    <a:solidFill>
+                      <a:srgbClr val="FFFFFF"/>
+                    </a:solidFill>
+                  </a:tcPr>
+                </a:tc>
+              </a:tr>
             </a:tbl>
           </a:graphicData>
         </a:graphic>
       </p:graphicFrame>
       <p:sp>
         <p:nvSpPr>
-          <p:cNvPr id="5" name="">
+          <p:cNvPr id="6" name="">
             <a:extLst xmlns:a="http://schemas.openxmlformats.org/drawingml/2006/main">
               <a:ext uri="{FF2B5EF4-FFF2-40B4-BE49-F238E27FC236}">
-                <a16:creationId xmlns:a16="http://schemas.microsoft.com/office/drawing/2014/main" id="{E3291CC1-3124-4BFD-A243-43D3C2E70372}"/>
+                <a16:creationId xmlns:a16="http://schemas.microsoft.com/office/drawing/2014/main" id="{957FED69-D6F1-4505-B168-DF65E2605C90}"/>
               </a:ext>
             </a:extLst>
           </p:cNvPr>
@@ -8117,8 +8581,8 @@
         </p:nvSpPr>
         <p:spPr>
           <a:xfrm xmlns:a="http://schemas.openxmlformats.org/drawingml/2006/main">
-            <a:off x="819150" y="6762750"/>
-            <a:ext cx="13430250" cy="666750"/>
+            <a:off x="819150" y="6743700"/>
+            <a:ext cx="13525500" cy="371475"/>
           </a:xfrm>
           <a:prstGeom xmlns:a="http://schemas.openxmlformats.org/drawingml/2006/main" prst="rect">
             <a:avLst/>
@@ -8135,35 +8599,35 @@
           <a:lstStyle xmlns:a="http://schemas.openxmlformats.org/drawingml/2006/main"/>
           <a:p xmlns:a="http://schemas.openxmlformats.org/drawingml/2006/main">
             <a:pPr>
-              <a:defRPr sz="2250" b="0">
-                <a:solidFill>
-                  <a:srgbClr val="182C29"/>
-                </a:solidFill>
-                <a:latin typeface="Apple SD Gothic Neo"/>
-                <a:ea typeface="Apple SD Gothic Neo"/>
-                <a:cs typeface="Apple SD Gothic Neo"/>
-              </a:defRPr>
-            </a:pPr>
-            <a:r>
-              <a:rPr sz="2250" b="0">
-                <a:solidFill>
-                  <a:srgbClr val="182C29"/>
-                </a:solidFill>
-                <a:latin typeface="Apple SD Gothic Neo"/>
-                <a:ea typeface="Apple SD Gothic Neo"/>
-                <a:cs typeface="Apple SD Gothic Neo"/>
-              </a:rPr>
-              <a:t>비교 시 비용 합계뿐 아니라 포장·운송·특전 조건도 함께 확인해야 했습니다.</a:t>
-            </a:r>
-          </a:p>
-        </p:txBody>
-      </p:sp>
-      <p:sp>
-        <p:nvSpPr>
-          <p:cNvPr id="6" name="">
+              <a:defRPr sz="1650" b="0">
+                <a:solidFill>
+                  <a:srgbClr val="182C29"/>
+                </a:solidFill>
+                <a:latin typeface="Apple SD Gothic Neo"/>
+                <a:ea typeface="Apple SD Gothic Neo"/>
+                <a:cs typeface="Apple SD Gothic Neo"/>
+              </a:defRPr>
+            </a:pPr>
+            <a:r>
+              <a:rPr sz="1650" b="0">
+                <a:solidFill>
+                  <a:srgbClr val="182C29"/>
+                </a:solidFill>
+                <a:latin typeface="Apple SD Gothic Neo"/>
+                <a:ea typeface="Apple SD Gothic Neo"/>
+                <a:cs typeface="Apple SD Gothic Neo"/>
+              </a:rPr>
+              <a:t>¹ 몰테일 경로는50엔 쿠폰 적용 주문. WorldShopping은 대행료 포함. ² 운임·취급료 포함. 공식 스토어 운송사 미표기.</a:t>
+            </a:r>
+          </a:p>
+        </p:txBody>
+      </p:sp>
+      <p:sp>
+        <p:nvSpPr>
+          <p:cNvPr id="7" name="">
             <a:extLst xmlns:a="http://schemas.openxmlformats.org/drawingml/2006/main">
               <a:ext uri="{FF2B5EF4-FFF2-40B4-BE49-F238E27FC236}">
-                <a16:creationId xmlns:a16="http://schemas.microsoft.com/office/drawing/2014/main" id="{2675EABD-DED2-40AB-B900-A9C0BC46A784}"/>
+                <a16:creationId xmlns:a16="http://schemas.microsoft.com/office/drawing/2014/main" id="{EFD37F15-F0F6-45B5-8BE6-5A52A2C4065C}"/>
               </a:ext>
             </a:extLst>
           </p:cNvPr>
@@ -8174,8 +8638,8 @@
         </p:nvSpPr>
         <p:spPr>
           <a:xfrm xmlns:a="http://schemas.openxmlformats.org/drawingml/2006/main">
-            <a:off x="819150" y="7553325"/>
-            <a:ext cx="13525500" cy="342900"/>
+            <a:off x="819150" y="7172325"/>
+            <a:ext cx="13525500" cy="371475"/>
           </a:xfrm>
           <a:prstGeom xmlns:a="http://schemas.openxmlformats.org/drawingml/2006/main" prst="rect">
             <a:avLst/>
@@ -8192,7 +8656,64 @@
           <a:lstStyle xmlns:a="http://schemas.openxmlformats.org/drawingml/2006/main"/>
           <a:p xmlns:a="http://schemas.openxmlformats.org/drawingml/2006/main">
             <a:pPr>
-              <a:defRPr sz="1650" b="0">
+              <a:defRPr sz="1575" b="0">
+                <a:solidFill>
+                  <a:srgbClr val="182C29"/>
+                </a:solidFill>
+                <a:latin typeface="Apple SD Gothic Neo"/>
+                <a:ea typeface="Apple SD Gothic Neo"/>
+                <a:cs typeface="Apple SD Gothic Neo"/>
+              </a:defRPr>
+            </a:pPr>
+            <a:r>
+              <a:rPr sz="1575" b="0">
+                <a:solidFill>
+                  <a:srgbClr val="182C29"/>
+                </a:solidFill>
+                <a:latin typeface="Apple SD Gothic Neo"/>
+                <a:ea typeface="Apple SD Gothic Neo"/>
+                <a:cs typeface="Apple SD Gothic Neo"/>
+              </a:rPr>
+              <a:t>³ SAZO의 ‘통관·관세’ 표시 항목. tenso·WorldShopping은250g·19×14×2cm, 몰테일은0.5kg 최저 구간 가정.</a:t>
+            </a:r>
+          </a:p>
+        </p:txBody>
+      </p:sp>
+      <p:sp>
+        <p:nvSpPr>
+          <p:cNvPr id="8" name="">
+            <a:extLst xmlns:a="http://schemas.openxmlformats.org/drawingml/2006/main">
+              <a:ext uri="{FF2B5EF4-FFF2-40B4-BE49-F238E27FC236}">
+                <a16:creationId xmlns:a16="http://schemas.microsoft.com/office/drawing/2014/main" id="{3BA07CF2-D29B-4DF6-A07A-E45773F911E3}"/>
+              </a:ext>
+            </a:extLst>
+          </p:cNvPr>
+          <p:cNvSpPr>
+            <a:spLocks xmlns:a="http://schemas.openxmlformats.org/drawingml/2006/main" noGrp="1"/>
+          </p:cNvSpPr>
+          <p:nvPr/>
+        </p:nvSpPr>
+        <p:spPr>
+          <a:xfrm xmlns:a="http://schemas.openxmlformats.org/drawingml/2006/main">
+            <a:off x="819150" y="7610475"/>
+            <a:ext cx="13525500" cy="323850"/>
+          </a:xfrm>
+          <a:prstGeom xmlns:a="http://schemas.openxmlformats.org/drawingml/2006/main" prst="rect">
+            <a:avLst/>
+          </a:prstGeom>
+          <a:noFill xmlns:a="http://schemas.openxmlformats.org/drawingml/2006/main"/>
+          <a:ln xmlns:a="http://schemas.openxmlformats.org/drawingml/2006/main" w="0">
+            <a:noFill/>
+          </a:ln>
+        </p:spPr>
+        <p:txBody>
+          <a:bodyPr xmlns:a="http://schemas.openxmlformats.org/drawingml/2006/main" wrap="square" lIns="0" tIns="0" rIns="0" bIns="0">
+            <a:noAutofit/>
+          </a:bodyPr>
+          <a:lstStyle xmlns:a="http://schemas.openxmlformats.org/drawingml/2006/main"/>
+          <a:p xmlns:a="http://schemas.openxmlformats.org/drawingml/2006/main">
+            <a:pPr>
+              <a:defRPr sz="1575" b="0">
                 <a:solidFill>
                   <a:srgbClr val="5E706B"/>
                 </a:solidFill>
@@ -8202,7 +8723,7 @@
               </a:defRPr>
             </a:pPr>
             <a:r>
-              <a:rPr sz="1650" b="0">
+              <a:rPr sz="1575" b="0">
                 <a:solidFill>
                   <a:srgbClr val="5E706B"/>
                 </a:solidFill>
@@ -8210,7 +8731,7 @@
                 <a:ea typeface="Apple SD Gothic Neo"/>
                 <a:cs typeface="Apple SD Gothic Neo"/>
               </a:rPr>
-              <a:t>100엔=883.7원으로 환산. 당시 부분 견적이며 실측·카드 비용·세금 등은 미확정입니다.</a:t>
+              <a:t>환산: 1엔=8.6131원·1달러=1,357.14원(10/4~10 과세환율). 실측·보험·세금·카드비용에 따라 달라질 수 있습니다.</a:t>
             </a:r>
           </a:p>
         </p:txBody>
@@ -8218,7 +8739,7 @@
     </p:spTree>
     <p:extLst>
       <p:ext uri="{BB962C8B-B14F-4D97-AF65-F5344CB8AC3E}">
-        <p14:creationId xmlns:p14="http://schemas.microsoft.com/office/powerpoint/2010/main" val="1152281224"/>
+        <p14:creationId xmlns:p14="http://schemas.microsoft.com/office/powerpoint/2010/main" val="580010727"/>
       </p:ext>
     </p:extLst>
   </p:cSld>
@@ -8249,7 +8770,7 @@
           <p:cNvPr id="11" name="">
             <a:extLst xmlns:a="http://schemas.openxmlformats.org/drawingml/2006/main">
               <a:ext uri="{FF2B5EF4-FFF2-40B4-BE49-F238E27FC236}">
-                <a16:creationId xmlns:a16="http://schemas.microsoft.com/office/drawing/2014/main" id="{79A1C037-7E49-45C7-9C6E-A54E47D2C6C5}"/>
+                <a16:creationId xmlns:a16="http://schemas.microsoft.com/office/drawing/2014/main" id="{A4B238FC-806C-44B5-98EF-47B565B5EEB5}"/>
               </a:ext>
             </a:extLst>
           </p:cNvPr>
@@ -8306,7 +8827,7 @@
           <p:cNvPr id="2" name="">
             <a:extLst xmlns:a="http://schemas.openxmlformats.org/drawingml/2006/main">
               <a:ext uri="{FF2B5EF4-FFF2-40B4-BE49-F238E27FC236}">
-                <a16:creationId xmlns:a16="http://schemas.microsoft.com/office/drawing/2014/main" id="{E780916E-030F-4256-89FA-4187E5C6ED87}"/>
+                <a16:creationId xmlns:a16="http://schemas.microsoft.com/office/drawing/2014/main" id="{1AC20949-A8D1-4948-B773-551ECA76D97D}"/>
               </a:ext>
             </a:extLst>
           </p:cNvPr>
@@ -8363,7 +8884,7 @@
           <p:cNvPr id="3" name="">
             <a:extLst xmlns:a="http://schemas.openxmlformats.org/drawingml/2006/main">
               <a:ext uri="{FF2B5EF4-FFF2-40B4-BE49-F238E27FC236}">
-                <a16:creationId xmlns:a16="http://schemas.microsoft.com/office/drawing/2014/main" id="{4B2B89BD-AFC7-46BE-9395-16C58AEA413D}"/>
+                <a16:creationId xmlns:a16="http://schemas.microsoft.com/office/drawing/2014/main" id="{CA4341F5-64A0-490E-B721-B69C7D5D2EB5}"/>
               </a:ext>
             </a:extLst>
           </p:cNvPr>
@@ -8420,7 +8941,7 @@
           <p:cNvPr id="4" name="">
             <a:extLst xmlns:a="http://schemas.openxmlformats.org/drawingml/2006/main">
               <a:ext uri="{FF2B5EF4-FFF2-40B4-BE49-F238E27FC236}">
-                <a16:creationId xmlns:a16="http://schemas.microsoft.com/office/drawing/2014/main" id="{E9639473-58F4-4694-8831-1BBB16F048A3}"/>
+                <a16:creationId xmlns:a16="http://schemas.microsoft.com/office/drawing/2014/main" id="{77DCBC94-C34C-409A-BA0B-F60D637C74C0}"/>
               </a:ext>
             </a:extLst>
           </p:cNvPr>
@@ -8477,7 +8998,7 @@
           <p:cNvPr id="5" name="">
             <a:extLst xmlns:a="http://schemas.openxmlformats.org/drawingml/2006/main">
               <a:ext uri="{FF2B5EF4-FFF2-40B4-BE49-F238E27FC236}">
-                <a16:creationId xmlns:a16="http://schemas.microsoft.com/office/drawing/2014/main" id="{2FD0F615-C8EF-42EA-901C-6BEE1D8977AC}"/>
+                <a16:creationId xmlns:a16="http://schemas.microsoft.com/office/drawing/2014/main" id="{5F1916E5-C849-4BC0-8A99-DB04DBCF3649}"/>
               </a:ext>
             </a:extLst>
           </p:cNvPr>
@@ -8580,7 +9101,7 @@
           <p:cNvPr id="6" name="">
             <a:extLst xmlns:a="http://schemas.openxmlformats.org/drawingml/2006/main">
               <a:ext uri="{FF2B5EF4-FFF2-40B4-BE49-F238E27FC236}">
-                <a16:creationId xmlns:a16="http://schemas.microsoft.com/office/drawing/2014/main" id="{45EFE935-7CBD-4B44-8F00-12365F345630}"/>
+                <a16:creationId xmlns:a16="http://schemas.microsoft.com/office/drawing/2014/main" id="{04CDBE2B-3C7C-4971-9475-2F578F4D4F79}"/>
               </a:ext>
             </a:extLst>
           </p:cNvPr>
@@ -8660,7 +9181,7 @@
           <p:cNvPr id="7" name="">
             <a:extLst xmlns:a="http://schemas.openxmlformats.org/drawingml/2006/main">
               <a:ext uri="{FF2B5EF4-FFF2-40B4-BE49-F238E27FC236}">
-                <a16:creationId xmlns:a16="http://schemas.microsoft.com/office/drawing/2014/main" id="{F8BDC7F8-02C5-44E6-9567-1442CC3E5C2F}"/>
+                <a16:creationId xmlns:a16="http://schemas.microsoft.com/office/drawing/2014/main" id="{62D4E9BD-2231-4D61-9606-4BFC3A802447}"/>
               </a:ext>
             </a:extLst>
           </p:cNvPr>
@@ -8717,7 +9238,7 @@
           <p:cNvPr id="8" name="">
             <a:extLst xmlns:a="http://schemas.openxmlformats.org/drawingml/2006/main">
               <a:ext uri="{FF2B5EF4-FFF2-40B4-BE49-F238E27FC236}">
-                <a16:creationId xmlns:a16="http://schemas.microsoft.com/office/drawing/2014/main" id="{FD5A7353-67DC-4A44-8485-235CE64D3378}"/>
+                <a16:creationId xmlns:a16="http://schemas.microsoft.com/office/drawing/2014/main" id="{2B5008E2-260D-4FA4-B467-B6288498CC77}"/>
               </a:ext>
             </a:extLst>
           </p:cNvPr>
@@ -8820,7 +9341,7 @@
           <p:cNvPr id="9" name="">
             <a:extLst xmlns:a="http://schemas.openxmlformats.org/drawingml/2006/main">
               <a:ext uri="{FF2B5EF4-FFF2-40B4-BE49-F238E27FC236}">
-                <a16:creationId xmlns:a16="http://schemas.microsoft.com/office/drawing/2014/main" id="{4E6505A5-0C63-4785-9149-BB6512EFA6BC}"/>
+                <a16:creationId xmlns:a16="http://schemas.microsoft.com/office/drawing/2014/main" id="{D4AFE465-C82A-4E51-9DFC-9A13C01FECDD}"/>
               </a:ext>
             </a:extLst>
           </p:cNvPr>
@@ -8900,7 +9421,7 @@
           <p:cNvPr id="10" name="">
             <a:extLst xmlns:a="http://schemas.openxmlformats.org/drawingml/2006/main">
               <a:ext uri="{FF2B5EF4-FFF2-40B4-BE49-F238E27FC236}">
-                <a16:creationId xmlns:a16="http://schemas.microsoft.com/office/drawing/2014/main" id="{8E62E44F-85DF-413D-929B-21B6F2F13E0D}"/>
+                <a16:creationId xmlns:a16="http://schemas.microsoft.com/office/drawing/2014/main" id="{D60415C6-D797-4C1D-A747-39160FA71552}"/>
               </a:ext>
             </a:extLst>
           </p:cNvPr>
@@ -8955,7 +9476,7 @@
     </p:spTree>
     <p:extLst>
       <p:ext uri="{BB962C8B-B14F-4D97-AF65-F5344CB8AC3E}">
-        <p14:creationId xmlns:p14="http://schemas.microsoft.com/office/powerpoint/2010/main" val="1111449646"/>
+        <p14:creationId xmlns:p14="http://schemas.microsoft.com/office/powerpoint/2010/main" val="1348104874"/>
       </p:ext>
     </p:extLst>
   </p:cSld>
@@ -8986,7 +9507,7 @@
           <p:cNvPr id="11" name="">
             <a:extLst xmlns:a="http://schemas.openxmlformats.org/drawingml/2006/main">
               <a:ext uri="{FF2B5EF4-FFF2-40B4-BE49-F238E27FC236}">
-                <a16:creationId xmlns:a16="http://schemas.microsoft.com/office/drawing/2014/main" id="{91BBA79D-C77E-4BA7-A70C-673B418AA075}"/>
+                <a16:creationId xmlns:a16="http://schemas.microsoft.com/office/drawing/2014/main" id="{940CD8E2-6B88-46D4-8CE6-DACEDF0A64EA}"/>
               </a:ext>
             </a:extLst>
           </p:cNvPr>
@@ -9043,7 +9564,7 @@
           <p:cNvPr id="2" name="">
             <a:extLst xmlns:a="http://schemas.openxmlformats.org/drawingml/2006/main">
               <a:ext uri="{FF2B5EF4-FFF2-40B4-BE49-F238E27FC236}">
-                <a16:creationId xmlns:a16="http://schemas.microsoft.com/office/drawing/2014/main" id="{05F9A2B9-6A05-4082-A597-45C94F33F02C}"/>
+                <a16:creationId xmlns:a16="http://schemas.microsoft.com/office/drawing/2014/main" id="{3DEF6D19-FEF8-4EC6-B560-97203268D799}"/>
               </a:ext>
             </a:extLst>
           </p:cNvPr>
@@ -9100,7 +9621,7 @@
           <p:cNvPr id="3" name="">
             <a:extLst xmlns:a="http://schemas.openxmlformats.org/drawingml/2006/main">
               <a:ext uri="{FF2B5EF4-FFF2-40B4-BE49-F238E27FC236}">
-                <a16:creationId xmlns:a16="http://schemas.microsoft.com/office/drawing/2014/main" id="{6BA6CA1A-3838-4565-898A-66BE0448329C}"/>
+                <a16:creationId xmlns:a16="http://schemas.microsoft.com/office/drawing/2014/main" id="{574FDF17-8E81-4DD1-9B71-43EC1646BCB4}"/>
               </a:ext>
             </a:extLst>
           </p:cNvPr>
@@ -9157,7 +9678,7 @@
           <p:cNvPr id="4" name="">
             <a:extLst xmlns:a="http://schemas.openxmlformats.org/drawingml/2006/main">
               <a:ext uri="{FF2B5EF4-FFF2-40B4-BE49-F238E27FC236}">
-                <a16:creationId xmlns:a16="http://schemas.microsoft.com/office/drawing/2014/main" id="{DC613265-AAD8-4414-80AB-829C57B8343D}"/>
+                <a16:creationId xmlns:a16="http://schemas.microsoft.com/office/drawing/2014/main" id="{9E32E8E4-ADCF-4DD3-B0E9-E946A384E275}"/>
               </a:ext>
             </a:extLst>
           </p:cNvPr>
@@ -9214,7 +9735,7 @@
           <p:cNvPr id="5" name="">
             <a:extLst xmlns:a="http://schemas.openxmlformats.org/drawingml/2006/main">
               <a:ext uri="{FF2B5EF4-FFF2-40B4-BE49-F238E27FC236}">
-                <a16:creationId xmlns:a16="http://schemas.microsoft.com/office/drawing/2014/main" id="{04525C09-EAC7-4C2B-A8CD-4E8DC6BFBE7A}"/>
+                <a16:creationId xmlns:a16="http://schemas.microsoft.com/office/drawing/2014/main" id="{F647EB12-47F0-4FC8-A598-E5A100075D9A}"/>
               </a:ext>
             </a:extLst>
           </p:cNvPr>
@@ -9271,7 +9792,7 @@
           <p:cNvPr id="6" name="">
             <a:extLst xmlns:a="http://schemas.openxmlformats.org/drawingml/2006/main">
               <a:ext uri="{FF2B5EF4-FFF2-40B4-BE49-F238E27FC236}">
-                <a16:creationId xmlns:a16="http://schemas.microsoft.com/office/drawing/2014/main" id="{1BBC1B61-BD1A-4884-8DD1-1087F2CD1CBE}"/>
+                <a16:creationId xmlns:a16="http://schemas.microsoft.com/office/drawing/2014/main" id="{A73919F4-457E-4951-88AE-772DE755E1CF}"/>
               </a:ext>
             </a:extLst>
           </p:cNvPr>
@@ -9374,7 +9895,7 @@
           <p:cNvPr id="7" name="">
             <a:extLst xmlns:a="http://schemas.openxmlformats.org/drawingml/2006/main">
               <a:ext uri="{FF2B5EF4-FFF2-40B4-BE49-F238E27FC236}">
-                <a16:creationId xmlns:a16="http://schemas.microsoft.com/office/drawing/2014/main" id="{2A3FBCC7-D349-42AA-8D0D-20C8AD9A497E}"/>
+                <a16:creationId xmlns:a16="http://schemas.microsoft.com/office/drawing/2014/main" id="{30BD4D80-0F9C-410C-822D-0F21507BD12F}"/>
               </a:ext>
             </a:extLst>
           </p:cNvPr>
@@ -9431,7 +9952,7 @@
           <p:cNvPr id="8" name="">
             <a:extLst xmlns:a="http://schemas.openxmlformats.org/drawingml/2006/main">
               <a:ext uri="{FF2B5EF4-FFF2-40B4-BE49-F238E27FC236}">
-                <a16:creationId xmlns:a16="http://schemas.microsoft.com/office/drawing/2014/main" id="{212512A9-3E82-4559-A832-2500EFD8619B}"/>
+                <a16:creationId xmlns:a16="http://schemas.microsoft.com/office/drawing/2014/main" id="{4C2E0DA8-2F53-4013-BF90-3B3EE6CDA934}"/>
               </a:ext>
             </a:extLst>
           </p:cNvPr>
@@ -9488,7 +10009,7 @@
           <p:cNvPr id="9" name="">
             <a:extLst xmlns:a="http://schemas.openxmlformats.org/drawingml/2006/main">
               <a:ext uri="{FF2B5EF4-FFF2-40B4-BE49-F238E27FC236}">
-                <a16:creationId xmlns:a16="http://schemas.microsoft.com/office/drawing/2014/main" id="{5A1382D6-3877-4416-83FD-C7A9611E4225}"/>
+                <a16:creationId xmlns:a16="http://schemas.microsoft.com/office/drawing/2014/main" id="{F9284C0C-9946-4A8B-9A71-7A8E74FECD72}"/>
               </a:ext>
             </a:extLst>
           </p:cNvPr>
@@ -9591,7 +10112,7 @@
           <p:cNvPr id="10" name="">
             <a:extLst xmlns:a="http://schemas.openxmlformats.org/drawingml/2006/main">
               <a:ext uri="{FF2B5EF4-FFF2-40B4-BE49-F238E27FC236}">
-                <a16:creationId xmlns:a16="http://schemas.microsoft.com/office/drawing/2014/main" id="{6CB40835-4049-4B8A-8780-68F7D91EA14B}"/>
+                <a16:creationId xmlns:a16="http://schemas.microsoft.com/office/drawing/2014/main" id="{BD733A90-B866-4A31-ADD2-4B768966A21F}"/>
               </a:ext>
             </a:extLst>
           </p:cNvPr>
@@ -9646,7 +10167,7 @@
     </p:spTree>
     <p:extLst>
       <p:ext uri="{BB962C8B-B14F-4D97-AF65-F5344CB8AC3E}">
-        <p14:creationId xmlns:p14="http://schemas.microsoft.com/office/powerpoint/2010/main" val="693308255"/>
+        <p14:creationId xmlns:p14="http://schemas.microsoft.com/office/powerpoint/2010/main" val="581407392"/>
       </p:ext>
     </p:extLst>
   </p:cSld>
@@ -9677,7 +10198,7 @@
           <p:cNvPr id="20" name="">
             <a:extLst xmlns:a="http://schemas.openxmlformats.org/drawingml/2006/main">
               <a:ext uri="{FF2B5EF4-FFF2-40B4-BE49-F238E27FC236}">
-                <a16:creationId xmlns:a16="http://schemas.microsoft.com/office/drawing/2014/main" id="{1F9C0459-131F-43E6-A682-9F54720B5F1C}"/>
+                <a16:creationId xmlns:a16="http://schemas.microsoft.com/office/drawing/2014/main" id="{B77C614E-3F82-4D5B-A4CE-107EBEF048C4}"/>
               </a:ext>
             </a:extLst>
           </p:cNvPr>
@@ -9734,7 +10255,7 @@
           <p:cNvPr id="2" name="">
             <a:extLst xmlns:a="http://schemas.openxmlformats.org/drawingml/2006/main">
               <a:ext uri="{FF2B5EF4-FFF2-40B4-BE49-F238E27FC236}">
-                <a16:creationId xmlns:a16="http://schemas.microsoft.com/office/drawing/2014/main" id="{7D96DAD4-BBCB-4523-871A-2A08FFEE4C7F}"/>
+                <a16:creationId xmlns:a16="http://schemas.microsoft.com/office/drawing/2014/main" id="{6E72BFA9-9071-4231-87A8-715CDA50E34C}"/>
               </a:ext>
             </a:extLst>
           </p:cNvPr>
@@ -9791,7 +10312,7 @@
           <p:cNvPr id="3" name="">
             <a:extLst xmlns:a="http://schemas.openxmlformats.org/drawingml/2006/main">
               <a:ext uri="{FF2B5EF4-FFF2-40B4-BE49-F238E27FC236}">
-                <a16:creationId xmlns:a16="http://schemas.microsoft.com/office/drawing/2014/main" id="{9984F0F0-4397-458B-A682-60CCB7679B8D}"/>
+                <a16:creationId xmlns:a16="http://schemas.microsoft.com/office/drawing/2014/main" id="{9465CE9D-7C14-41E1-8C26-195EB1AC039E}"/>
               </a:ext>
             </a:extLst>
           </p:cNvPr>
@@ -9848,7 +10369,7 @@
           <p:cNvPr id="4" name="">
             <a:extLst xmlns:a="http://schemas.openxmlformats.org/drawingml/2006/main">
               <a:ext uri="{FF2B5EF4-FFF2-40B4-BE49-F238E27FC236}">
-                <a16:creationId xmlns:a16="http://schemas.microsoft.com/office/drawing/2014/main" id="{B6BF19B4-B71E-4E87-B477-313BCAFC6FE3}"/>
+                <a16:creationId xmlns:a16="http://schemas.microsoft.com/office/drawing/2014/main" id="{8F183669-6D46-444C-ABEA-798300754F9B}"/>
               </a:ext>
             </a:extLst>
           </p:cNvPr>
@@ -9907,7 +10428,7 @@
           <p:cNvPr id="5" name="">
             <a:extLst xmlns:a="http://schemas.openxmlformats.org/drawingml/2006/main">
               <a:ext uri="{FF2B5EF4-FFF2-40B4-BE49-F238E27FC236}">
-                <a16:creationId xmlns:a16="http://schemas.microsoft.com/office/drawing/2014/main" id="{8338CFE5-0E20-4CDF-996D-95DDB6C573D1}"/>
+                <a16:creationId xmlns:a16="http://schemas.microsoft.com/office/drawing/2014/main" id="{6C29E573-DC53-458A-B986-5E6CE5EDF793}"/>
               </a:ext>
             </a:extLst>
           </p:cNvPr>
@@ -9991,7 +10512,7 @@
           <p:cNvPr id="7" name="">
             <a:extLst xmlns:a="http://schemas.openxmlformats.org/drawingml/2006/main">
               <a:ext uri="{FF2B5EF4-FFF2-40B4-BE49-F238E27FC236}">
-                <a16:creationId xmlns:a16="http://schemas.microsoft.com/office/drawing/2014/main" id="{AE756101-E7E1-46E3-83A9-1D8030A3728C}"/>
+                <a16:creationId xmlns:a16="http://schemas.microsoft.com/office/drawing/2014/main" id="{FDF0E10B-2701-4395-8837-7F599B74EEA6}"/>
               </a:ext>
             </a:extLst>
           </p:cNvPr>
@@ -10075,7 +10596,7 @@
           <p:cNvPr id="9" name="">
             <a:extLst xmlns:a="http://schemas.openxmlformats.org/drawingml/2006/main">
               <a:ext uri="{FF2B5EF4-FFF2-40B4-BE49-F238E27FC236}">
-                <a16:creationId xmlns:a16="http://schemas.microsoft.com/office/drawing/2014/main" id="{FC73DD3C-3E47-475A-8EFD-19DEDF98CF59}"/>
+                <a16:creationId xmlns:a16="http://schemas.microsoft.com/office/drawing/2014/main" id="{3E43A420-328D-4FEC-902D-D85FBC543143}"/>
               </a:ext>
             </a:extLst>
           </p:cNvPr>
@@ -10159,7 +10680,7 @@
           <p:cNvPr id="11" name="">
             <a:extLst xmlns:a="http://schemas.openxmlformats.org/drawingml/2006/main">
               <a:ext uri="{FF2B5EF4-FFF2-40B4-BE49-F238E27FC236}">
-                <a16:creationId xmlns:a16="http://schemas.microsoft.com/office/drawing/2014/main" id="{66E699C2-E3C0-48DD-A9E2-2F030FE6A076}"/>
+                <a16:creationId xmlns:a16="http://schemas.microsoft.com/office/drawing/2014/main" id="{B773B048-7A63-4039-8EBE-0B39347BFE18}"/>
               </a:ext>
             </a:extLst>
           </p:cNvPr>
@@ -10243,7 +10764,7 @@
           <p:cNvPr id="13" name="">
             <a:extLst xmlns:a="http://schemas.openxmlformats.org/drawingml/2006/main">
               <a:ext uri="{FF2B5EF4-FFF2-40B4-BE49-F238E27FC236}">
-                <a16:creationId xmlns:a16="http://schemas.microsoft.com/office/drawing/2014/main" id="{1D02818C-7344-42FE-8A8C-79E8E5F2C647}"/>
+                <a16:creationId xmlns:a16="http://schemas.microsoft.com/office/drawing/2014/main" id="{F234BDE8-0B4D-4234-97FD-545D971ECFC2}"/>
               </a:ext>
             </a:extLst>
           </p:cNvPr>
@@ -10300,7 +10821,7 @@
           <p:cNvPr id="14" name="">
             <a:extLst xmlns:a="http://schemas.openxmlformats.org/drawingml/2006/main">
               <a:ext uri="{FF2B5EF4-FFF2-40B4-BE49-F238E27FC236}">
-                <a16:creationId xmlns:a16="http://schemas.microsoft.com/office/drawing/2014/main" id="{61D3E080-AD5F-4EA3-8DFB-C55EB9760E39}"/>
+                <a16:creationId xmlns:a16="http://schemas.microsoft.com/office/drawing/2014/main" id="{6FFED361-7FC4-454C-BEC8-195429E399D1}"/>
               </a:ext>
             </a:extLst>
           </p:cNvPr>
@@ -10357,7 +10878,7 @@
           <p:cNvPr id="15" name="">
             <a:extLst xmlns:a="http://schemas.openxmlformats.org/drawingml/2006/main">
               <a:ext uri="{FF2B5EF4-FFF2-40B4-BE49-F238E27FC236}">
-                <a16:creationId xmlns:a16="http://schemas.microsoft.com/office/drawing/2014/main" id="{267EDFA0-0BBE-47EE-B46E-D937C50FA9A0}"/>
+                <a16:creationId xmlns:a16="http://schemas.microsoft.com/office/drawing/2014/main" id="{51AD7DE1-7033-4938-9306-DE226A036224}"/>
               </a:ext>
             </a:extLst>
           </p:cNvPr>
@@ -10414,7 +10935,7 @@
           <p:cNvPr id="16" name="">
             <a:extLst xmlns:a="http://schemas.openxmlformats.org/drawingml/2006/main">
               <a:ext uri="{FF2B5EF4-FFF2-40B4-BE49-F238E27FC236}">
-                <a16:creationId xmlns:a16="http://schemas.microsoft.com/office/drawing/2014/main" id="{6347C9E9-4480-4AE7-B9F9-2F75BA18764A}"/>
+                <a16:creationId xmlns:a16="http://schemas.microsoft.com/office/drawing/2014/main" id="{822D44EE-11E5-4F0D-B8F4-9CBFFDB0ED49}"/>
               </a:ext>
             </a:extLst>
           </p:cNvPr>
@@ -10471,7 +10992,7 @@
           <p:cNvPr id="17" name="">
             <a:extLst xmlns:a="http://schemas.openxmlformats.org/drawingml/2006/main">
               <a:ext uri="{FF2B5EF4-FFF2-40B4-BE49-F238E27FC236}">
-                <a16:creationId xmlns:a16="http://schemas.microsoft.com/office/drawing/2014/main" id="{ED2C9DF2-E2CD-4961-9F9F-0B41AF12C897}"/>
+                <a16:creationId xmlns:a16="http://schemas.microsoft.com/office/drawing/2014/main" id="{10F98431-0E35-49D5-ABAC-B9D6B032561A}"/>
               </a:ext>
             </a:extLst>
           </p:cNvPr>
@@ -10528,7 +11049,7 @@
           <p:cNvPr id="18" name="">
             <a:extLst xmlns:a="http://schemas.openxmlformats.org/drawingml/2006/main">
               <a:ext uri="{FF2B5EF4-FFF2-40B4-BE49-F238E27FC236}">
-                <a16:creationId xmlns:a16="http://schemas.microsoft.com/office/drawing/2014/main" id="{6B03FA2C-016F-496D-8994-557A1C5E85E6}"/>
+                <a16:creationId xmlns:a16="http://schemas.microsoft.com/office/drawing/2014/main" id="{B5370CA5-AD6D-4E45-AAA7-40E984E2A53D}"/>
               </a:ext>
             </a:extLst>
           </p:cNvPr>
@@ -10585,7 +11106,7 @@
           <p:cNvPr id="19" name="">
             <a:extLst xmlns:a="http://schemas.openxmlformats.org/drawingml/2006/main">
               <a:ext uri="{FF2B5EF4-FFF2-40B4-BE49-F238E27FC236}">
-                <a16:creationId xmlns:a16="http://schemas.microsoft.com/office/drawing/2014/main" id="{AAEC3AEE-2284-45B1-961D-D9F6029FDDAC}"/>
+                <a16:creationId xmlns:a16="http://schemas.microsoft.com/office/drawing/2014/main" id="{09A662DA-8E8E-44C7-95E9-822A67DA102F}"/>
               </a:ext>
             </a:extLst>
           </p:cNvPr>
@@ -10640,7 +11161,7 @@
     </p:spTree>
     <p:extLst>
       <p:ext uri="{BB962C8B-B14F-4D97-AF65-F5344CB8AC3E}">
-        <p14:creationId xmlns:p14="http://schemas.microsoft.com/office/powerpoint/2010/main" val="2035622179"/>
+        <p14:creationId xmlns:p14="http://schemas.microsoft.com/office/powerpoint/2010/main" val="656478379"/>
       </p:ext>
     </p:extLst>
   </p:cSld>
@@ -10671,7 +11192,7 @@
           <p:cNvPr id="16" name="">
             <a:extLst xmlns:a="http://schemas.openxmlformats.org/drawingml/2006/main">
               <a:ext uri="{FF2B5EF4-FFF2-40B4-BE49-F238E27FC236}">
-                <a16:creationId xmlns:a16="http://schemas.microsoft.com/office/drawing/2014/main" id="{C8BF9139-E842-4027-B28B-72F0D512A990}"/>
+                <a16:creationId xmlns:a16="http://schemas.microsoft.com/office/drawing/2014/main" id="{BCF622E8-CCF8-4755-822B-F67751AABE6D}"/>
               </a:ext>
             </a:extLst>
           </p:cNvPr>
@@ -10728,7 +11249,7 @@
           <p:cNvPr id="2" name="">
             <a:extLst xmlns:a="http://schemas.openxmlformats.org/drawingml/2006/main">
               <a:ext uri="{FF2B5EF4-FFF2-40B4-BE49-F238E27FC236}">
-                <a16:creationId xmlns:a16="http://schemas.microsoft.com/office/drawing/2014/main" id="{7CD649E5-04F6-4870-856A-20D8C60284DF}"/>
+                <a16:creationId xmlns:a16="http://schemas.microsoft.com/office/drawing/2014/main" id="{5577E4B9-A945-4B5F-99FB-553BB3AFCCBF}"/>
               </a:ext>
             </a:extLst>
           </p:cNvPr>
@@ -10785,7 +11306,7 @@
           <p:cNvPr id="3" name="">
             <a:extLst xmlns:a="http://schemas.openxmlformats.org/drawingml/2006/main">
               <a:ext uri="{FF2B5EF4-FFF2-40B4-BE49-F238E27FC236}">
-                <a16:creationId xmlns:a16="http://schemas.microsoft.com/office/drawing/2014/main" id="{545DDE90-5006-4E6C-B87E-BD00B062F023}"/>
+                <a16:creationId xmlns:a16="http://schemas.microsoft.com/office/drawing/2014/main" id="{49C0BC28-7FE1-4EEB-8AB0-7A72AF0F8D69}"/>
               </a:ext>
             </a:extLst>
           </p:cNvPr>
@@ -10842,7 +11363,7 @@
           <p:cNvPr id="4" name="">
             <a:extLst xmlns:a="http://schemas.openxmlformats.org/drawingml/2006/main">
               <a:ext uri="{FF2B5EF4-FFF2-40B4-BE49-F238E27FC236}">
-                <a16:creationId xmlns:a16="http://schemas.microsoft.com/office/drawing/2014/main" id="{ECA6B866-6C80-459F-B909-6F94AEC76066}"/>
+                <a16:creationId xmlns:a16="http://schemas.microsoft.com/office/drawing/2014/main" id="{B6C4BC91-A076-4411-8719-DE708FA1FD00}"/>
               </a:ext>
             </a:extLst>
           </p:cNvPr>
@@ -10926,7 +11447,7 @@
           <p:cNvPr id="5" name="">
             <a:extLst xmlns:a="http://schemas.openxmlformats.org/drawingml/2006/main">
               <a:ext uri="{FF2B5EF4-FFF2-40B4-BE49-F238E27FC236}">
-                <a16:creationId xmlns:a16="http://schemas.microsoft.com/office/drawing/2014/main" id="{80EE7EA3-0695-492A-9A48-AC7A343E3F10}"/>
+                <a16:creationId xmlns:a16="http://schemas.microsoft.com/office/drawing/2014/main" id="{F5C4309E-CC0D-47B6-B46E-E205806F69A2}"/>
               </a:ext>
             </a:extLst>
           </p:cNvPr>
@@ -10983,7 +11504,7 @@
           <p:cNvPr id="6" name="">
             <a:extLst xmlns:a="http://schemas.openxmlformats.org/drawingml/2006/main">
               <a:ext uri="{FF2B5EF4-FFF2-40B4-BE49-F238E27FC236}">
-                <a16:creationId xmlns:a16="http://schemas.microsoft.com/office/drawing/2014/main" id="{67F5A090-C351-4036-BB77-C54F0BD0D4E7}"/>
+                <a16:creationId xmlns:a16="http://schemas.microsoft.com/office/drawing/2014/main" id="{0F84D975-14B7-4D4C-A0BE-DD6AF4DA754F}"/>
               </a:ext>
             </a:extLst>
           </p:cNvPr>
@@ -11067,7 +11588,7 @@
           <p:cNvPr id="7" name="">
             <a:extLst xmlns:a="http://schemas.openxmlformats.org/drawingml/2006/main">
               <a:ext uri="{FF2B5EF4-FFF2-40B4-BE49-F238E27FC236}">
-                <a16:creationId xmlns:a16="http://schemas.microsoft.com/office/drawing/2014/main" id="{3056F7DA-8A10-47E8-984E-3BF5E2B23243}"/>
+                <a16:creationId xmlns:a16="http://schemas.microsoft.com/office/drawing/2014/main" id="{F44EA5FC-9821-40C0-9333-0E846E193069}"/>
               </a:ext>
             </a:extLst>
           </p:cNvPr>
@@ -11124,7 +11645,7 @@
           <p:cNvPr id="8" name="">
             <a:extLst xmlns:a="http://schemas.openxmlformats.org/drawingml/2006/main">
               <a:ext uri="{FF2B5EF4-FFF2-40B4-BE49-F238E27FC236}">
-                <a16:creationId xmlns:a16="http://schemas.microsoft.com/office/drawing/2014/main" id="{7837E47E-F2DE-414E-8B85-B80BCBCFE5B8}"/>
+                <a16:creationId xmlns:a16="http://schemas.microsoft.com/office/drawing/2014/main" id="{2A795481-70B1-4070-9D0C-F49A58BACB91}"/>
               </a:ext>
             </a:extLst>
           </p:cNvPr>
@@ -11208,7 +11729,7 @@
           <p:cNvPr id="9" name="">
             <a:extLst xmlns:a="http://schemas.openxmlformats.org/drawingml/2006/main">
               <a:ext uri="{FF2B5EF4-FFF2-40B4-BE49-F238E27FC236}">
-                <a16:creationId xmlns:a16="http://schemas.microsoft.com/office/drawing/2014/main" id="{019EA250-8078-464C-B07B-2FB16C9C29E6}"/>
+                <a16:creationId xmlns:a16="http://schemas.microsoft.com/office/drawing/2014/main" id="{FB9E823B-4883-44D4-8AD8-94903ED73BC3}"/>
               </a:ext>
             </a:extLst>
           </p:cNvPr>
@@ -11265,7 +11786,7 @@
           <p:cNvPr id="10" name="">
             <a:extLst xmlns:a="http://schemas.openxmlformats.org/drawingml/2006/main">
               <a:ext uri="{FF2B5EF4-FFF2-40B4-BE49-F238E27FC236}">
-                <a16:creationId xmlns:a16="http://schemas.microsoft.com/office/drawing/2014/main" id="{69B8FAF9-333F-479B-8B96-6AA5F042DA82}"/>
+                <a16:creationId xmlns:a16="http://schemas.microsoft.com/office/drawing/2014/main" id="{4FA90B67-C69C-4211-AA4B-6D76A0D47108}"/>
               </a:ext>
             </a:extLst>
           </p:cNvPr>
@@ -11349,7 +11870,7 @@
           <p:cNvPr id="11" name="">
             <a:extLst xmlns:a="http://schemas.openxmlformats.org/drawingml/2006/main">
               <a:ext uri="{FF2B5EF4-FFF2-40B4-BE49-F238E27FC236}">
-                <a16:creationId xmlns:a16="http://schemas.microsoft.com/office/drawing/2014/main" id="{47127725-47F8-4BA2-B02E-62A57EA285D8}"/>
+                <a16:creationId xmlns:a16="http://schemas.microsoft.com/office/drawing/2014/main" id="{E6B133CB-A9AB-49AA-BFB6-94453BADA2C5}"/>
               </a:ext>
             </a:extLst>
           </p:cNvPr>
@@ -11406,7 +11927,7 @@
           <p:cNvPr id="12" name="">
             <a:extLst xmlns:a="http://schemas.openxmlformats.org/drawingml/2006/main">
               <a:ext uri="{FF2B5EF4-FFF2-40B4-BE49-F238E27FC236}">
-                <a16:creationId xmlns:a16="http://schemas.microsoft.com/office/drawing/2014/main" id="{195D72F1-2438-4F85-9E30-7162F716883C}"/>
+                <a16:creationId xmlns:a16="http://schemas.microsoft.com/office/drawing/2014/main" id="{D4EDE6E7-0F49-47F8-B2C1-C7906294DF8F}"/>
               </a:ext>
             </a:extLst>
           </p:cNvPr>
@@ -11467,7 +11988,7 @@
           <p:nvPr/>
         </p:nvPicPr>
         <p:blipFill>
-          <a:blip xmlns:r="http://schemas.openxmlformats.org/officeDocument/2006/relationships" xmlns:a="http://schemas.openxmlformats.org/drawingml/2006/main" r:embed="Ra55d066e92aa4cde"/>
+          <a:blip xmlns:r="http://schemas.openxmlformats.org/officeDocument/2006/relationships" xmlns:a="http://schemas.openxmlformats.org/drawingml/2006/main" r:embed="Rf18c41b441524723"/>
           <a:stretch xmlns:a="http://schemas.openxmlformats.org/drawingml/2006/main"/>
         </p:blipFill>
         <p:spPr>
@@ -11485,7 +12006,7 @@
           <p:cNvPr id="14" name="">
             <a:extLst xmlns:a="http://schemas.openxmlformats.org/drawingml/2006/main">
               <a:ext uri="{FF2B5EF4-FFF2-40B4-BE49-F238E27FC236}">
-                <a16:creationId xmlns:a16="http://schemas.microsoft.com/office/drawing/2014/main" id="{78DD3D94-F2B9-4223-B81C-8736505C0134}"/>
+                <a16:creationId xmlns:a16="http://schemas.microsoft.com/office/drawing/2014/main" id="{4E6E33A3-3292-4F4A-A444-A91F53FB8463}"/>
               </a:ext>
             </a:extLst>
           </p:cNvPr>
@@ -11542,7 +12063,7 @@
           <p:cNvPr id="15" name="">
             <a:extLst xmlns:a="http://schemas.openxmlformats.org/drawingml/2006/main">
               <a:ext uri="{FF2B5EF4-FFF2-40B4-BE49-F238E27FC236}">
-                <a16:creationId xmlns:a16="http://schemas.microsoft.com/office/drawing/2014/main" id="{A73E2C92-922D-4278-8D39-B51912FEBB53}"/>
+                <a16:creationId xmlns:a16="http://schemas.microsoft.com/office/drawing/2014/main" id="{0EEEE6A5-D0C0-4039-8D7B-AFB3A0BF8F5F}"/>
               </a:ext>
             </a:extLst>
           </p:cNvPr>
@@ -11597,7 +12118,7 @@
     </p:spTree>
     <p:extLst>
       <p:ext uri="{BB962C8B-B14F-4D97-AF65-F5344CB8AC3E}">
-        <p14:creationId xmlns:p14="http://schemas.microsoft.com/office/powerpoint/2010/main" val="30950051"/>
+        <p14:creationId xmlns:p14="http://schemas.microsoft.com/office/powerpoint/2010/main" val="1997799652"/>
       </p:ext>
     </p:extLst>
   </p:cSld>
@@ -11628,7 +12149,7 @@
           <p:cNvPr id="13" name="">
             <a:extLst xmlns:a="http://schemas.openxmlformats.org/drawingml/2006/main">
               <a:ext uri="{FF2B5EF4-FFF2-40B4-BE49-F238E27FC236}">
-                <a16:creationId xmlns:a16="http://schemas.microsoft.com/office/drawing/2014/main" id="{95825BA7-8985-43A2-BE88-CE07ECDC85F5}"/>
+                <a16:creationId xmlns:a16="http://schemas.microsoft.com/office/drawing/2014/main" id="{AE1BC463-8BB3-40D6-A429-EE81D8225F4C}"/>
               </a:ext>
             </a:extLst>
           </p:cNvPr>
@@ -11685,7 +12206,7 @@
           <p:cNvPr id="2" name="">
             <a:extLst xmlns:a="http://schemas.openxmlformats.org/drawingml/2006/main">
               <a:ext uri="{FF2B5EF4-FFF2-40B4-BE49-F238E27FC236}">
-                <a16:creationId xmlns:a16="http://schemas.microsoft.com/office/drawing/2014/main" id="{D4E3592A-677C-4281-8015-62F5BE6B78F7}"/>
+                <a16:creationId xmlns:a16="http://schemas.microsoft.com/office/drawing/2014/main" id="{7150F578-1C34-4413-8E58-0B6DF11D5DEB}"/>
               </a:ext>
             </a:extLst>
           </p:cNvPr>
@@ -11742,7 +12263,7 @@
           <p:cNvPr id="3" name="">
             <a:extLst xmlns:a="http://schemas.openxmlformats.org/drawingml/2006/main">
               <a:ext uri="{FF2B5EF4-FFF2-40B4-BE49-F238E27FC236}">
-                <a16:creationId xmlns:a16="http://schemas.microsoft.com/office/drawing/2014/main" id="{2716F421-0517-430C-BF98-9E1B82D8B89F}"/>
+                <a16:creationId xmlns:a16="http://schemas.microsoft.com/office/drawing/2014/main" id="{A891B4DF-02EC-450B-81FD-1D4D2EC802B1}"/>
               </a:ext>
             </a:extLst>
           </p:cNvPr>
@@ -11799,7 +12320,7 @@
           <p:cNvPr id="4" name="">
             <a:extLst xmlns:a="http://schemas.openxmlformats.org/drawingml/2006/main">
               <a:ext uri="{FF2B5EF4-FFF2-40B4-BE49-F238E27FC236}">
-                <a16:creationId xmlns:a16="http://schemas.microsoft.com/office/drawing/2014/main" id="{018DEDD6-F596-4BC9-814F-A36512CA94DA}"/>
+                <a16:creationId xmlns:a16="http://schemas.microsoft.com/office/drawing/2014/main" id="{2051B909-54A3-41C3-95AA-7BD044E6241D}"/>
               </a:ext>
             </a:extLst>
           </p:cNvPr>
@@ -11858,7 +12379,7 @@
           <p:cNvPr id="5" name="">
             <a:extLst xmlns:a="http://schemas.openxmlformats.org/drawingml/2006/main">
               <a:ext uri="{FF2B5EF4-FFF2-40B4-BE49-F238E27FC236}">
-                <a16:creationId xmlns:a16="http://schemas.microsoft.com/office/drawing/2014/main" id="{0AE60611-335F-4EA1-A8F6-6683C2509FAF}"/>
+                <a16:creationId xmlns:a16="http://schemas.microsoft.com/office/drawing/2014/main" id="{B2033D1B-322A-4799-B9EB-9D406B381FAC}"/>
               </a:ext>
             </a:extLst>
           </p:cNvPr>
@@ -11942,7 +12463,7 @@
           <p:cNvPr id="7" name="">
             <a:extLst xmlns:a="http://schemas.openxmlformats.org/drawingml/2006/main">
               <a:ext uri="{FF2B5EF4-FFF2-40B4-BE49-F238E27FC236}">
-                <a16:creationId xmlns:a16="http://schemas.microsoft.com/office/drawing/2014/main" id="{800C996B-AF70-488F-80B1-5E0C8D6D2241}"/>
+                <a16:creationId xmlns:a16="http://schemas.microsoft.com/office/drawing/2014/main" id="{B4FEF7B9-7553-4DC5-A105-D03E071C6350}"/>
               </a:ext>
             </a:extLst>
           </p:cNvPr>
@@ -12026,7 +12547,7 @@
           <p:cNvPr id="9" name="">
             <a:extLst xmlns:a="http://schemas.openxmlformats.org/drawingml/2006/main">
               <a:ext uri="{FF2B5EF4-FFF2-40B4-BE49-F238E27FC236}">
-                <a16:creationId xmlns:a16="http://schemas.microsoft.com/office/drawing/2014/main" id="{217408AC-8C39-4686-9F7E-3A886726691B}"/>
+                <a16:creationId xmlns:a16="http://schemas.microsoft.com/office/drawing/2014/main" id="{307F6075-7705-40DA-9D6B-0AE4E4B8D773}"/>
               </a:ext>
             </a:extLst>
           </p:cNvPr>
@@ -12106,7 +12627,7 @@
           <p:cNvPr id="10" name="">
             <a:extLst xmlns:a="http://schemas.openxmlformats.org/drawingml/2006/main">
               <a:ext uri="{FF2B5EF4-FFF2-40B4-BE49-F238E27FC236}">
-                <a16:creationId xmlns:a16="http://schemas.microsoft.com/office/drawing/2014/main" id="{5E091299-4683-4B7D-959E-05306FF0F892}"/>
+                <a16:creationId xmlns:a16="http://schemas.microsoft.com/office/drawing/2014/main" id="{E7CEDCA9-A882-4D8A-9271-8019BA1C7311}"/>
               </a:ext>
             </a:extLst>
           </p:cNvPr>
@@ -12186,7 +12707,7 @@
           <p:cNvPr id="11" name="">
             <a:extLst xmlns:a="http://schemas.openxmlformats.org/drawingml/2006/main">
               <a:ext uri="{FF2B5EF4-FFF2-40B4-BE49-F238E27FC236}">
-                <a16:creationId xmlns:a16="http://schemas.microsoft.com/office/drawing/2014/main" id="{8196F990-157F-4522-90F6-BDE43DEC5218}"/>
+                <a16:creationId xmlns:a16="http://schemas.microsoft.com/office/drawing/2014/main" id="{FC13C545-B012-4DCD-BD67-95E657C2C6A8}"/>
               </a:ext>
             </a:extLst>
           </p:cNvPr>
@@ -12266,7 +12787,7 @@
           <p:cNvPr id="12" name="">
             <a:extLst xmlns:a="http://schemas.openxmlformats.org/drawingml/2006/main">
               <a:ext uri="{FF2B5EF4-FFF2-40B4-BE49-F238E27FC236}">
-                <a16:creationId xmlns:a16="http://schemas.microsoft.com/office/drawing/2014/main" id="{50D1DEFD-3219-45C9-A9F8-0F58A41D52D0}"/>
+                <a16:creationId xmlns:a16="http://schemas.microsoft.com/office/drawing/2014/main" id="{2B7D9275-FA19-4AE0-AC08-CE5096A1027C}"/>
               </a:ext>
             </a:extLst>
           </p:cNvPr>
@@ -12344,7 +12865,7 @@
     </p:spTree>
     <p:extLst>
       <p:ext uri="{BB962C8B-B14F-4D97-AF65-F5344CB8AC3E}">
-        <p14:creationId xmlns:p14="http://schemas.microsoft.com/office/powerpoint/2010/main" val="105208061"/>
+        <p14:creationId xmlns:p14="http://schemas.microsoft.com/office/powerpoint/2010/main" val="999572438"/>
       </p:ext>
     </p:extLst>
   </p:cSld>

</xml_diff>

<commit_message>
docs: append Jev benchmark evidence and link product catalog experiments
</commit_message>
<xml_diff>
--- a/portfolio/crossborder-portfolio.pptx
+++ b/portfolio/crossborder-portfolio.pptx
@@ -2,27 +2,30 @@
 <file path=ppt/presentation.xml><?xml version="1.0" encoding="utf-8"?>
 <p:presentation xmlns:p="http://schemas.openxmlformats.org/presentationml/2006/main">
   <p:sldMasterIdLst>
-    <p:sldMasterId xmlns:r="http://schemas.openxmlformats.org/officeDocument/2006/relationships" id="2147483648" r:id="R3eef06e516fd4b31"/>
+    <p:sldMasterId xmlns:r="http://schemas.openxmlformats.org/officeDocument/2006/relationships" id="2147483648" r:id="R3157283dd8794a62"/>
   </p:sldMasterIdLst>
   <p:notesMasterIdLst>
-    <p:notesMasterId xmlns:r="http://schemas.openxmlformats.org/officeDocument/2006/relationships" r:id="Reeb47bd3e5c240b2"/>
+    <p:notesMasterId xmlns:r="http://schemas.openxmlformats.org/officeDocument/2006/relationships" r:id="R77263c22734d4965"/>
   </p:notesMasterIdLst>
   <p:sldIdLst>
-    <p:sldId xmlns:r="http://schemas.openxmlformats.org/officeDocument/2006/relationships" id="256" r:id="R23172851a2cd4aa2"/>
-    <p:sldId xmlns:r="http://schemas.openxmlformats.org/officeDocument/2006/relationships" id="257" r:id="Rcad3765695de462a"/>
-    <p:sldId xmlns:r="http://schemas.openxmlformats.org/officeDocument/2006/relationships" id="258" r:id="R8693631f82464c01"/>
-    <p:sldId xmlns:r="http://schemas.openxmlformats.org/officeDocument/2006/relationships" id="259" r:id="Rd2eda6f0e0fb4198"/>
-    <p:sldId xmlns:r="http://schemas.openxmlformats.org/officeDocument/2006/relationships" id="260" r:id="R1f3840cc4d034df2"/>
-    <p:sldId xmlns:r="http://schemas.openxmlformats.org/officeDocument/2006/relationships" id="261" r:id="R0ef7b146b4624635"/>
-    <p:sldId xmlns:r="http://schemas.openxmlformats.org/officeDocument/2006/relationships" id="262" r:id="R156b8dcd7e2b47ec"/>
-    <p:sldId xmlns:r="http://schemas.openxmlformats.org/officeDocument/2006/relationships" id="263" r:id="R96a3e5f9dcbf47a9"/>
-    <p:sldId xmlns:r="http://schemas.openxmlformats.org/officeDocument/2006/relationships" id="264" r:id="R2ec28832341f4940"/>
-    <p:sldId xmlns:r="http://schemas.openxmlformats.org/officeDocument/2006/relationships" id="265" r:id="Rbc4b679bb0584cac"/>
-    <p:sldId xmlns:r="http://schemas.openxmlformats.org/officeDocument/2006/relationships" id="266" r:id="R4ca18a9865274786"/>
-    <p:sldId xmlns:r="http://schemas.openxmlformats.org/officeDocument/2006/relationships" id="267" r:id="Rff4d19d975fe4873"/>
-    <p:sldId xmlns:r="http://schemas.openxmlformats.org/officeDocument/2006/relationships" id="268" r:id="Rbc509349d9544881"/>
-    <p:sldId xmlns:r="http://schemas.openxmlformats.org/officeDocument/2006/relationships" id="269" r:id="R6f75c481d24e4915"/>
-    <p:sldId xmlns:r="http://schemas.openxmlformats.org/officeDocument/2006/relationships" id="270" r:id="R4d5a51f2ba60420f"/>
+    <p:sldId xmlns:r="http://schemas.openxmlformats.org/officeDocument/2006/relationships" id="256" r:id="R862a2ca4f3004e36"/>
+    <p:sldId xmlns:r="http://schemas.openxmlformats.org/officeDocument/2006/relationships" id="257" r:id="R54971af92ee74dff"/>
+    <p:sldId xmlns:r="http://schemas.openxmlformats.org/officeDocument/2006/relationships" id="258" r:id="Ref203dc51db1464d"/>
+    <p:sldId xmlns:r="http://schemas.openxmlformats.org/officeDocument/2006/relationships" id="259" r:id="Rc1e2cf908d0144af"/>
+    <p:sldId xmlns:r="http://schemas.openxmlformats.org/officeDocument/2006/relationships" id="260" r:id="R59d81729e3b84d1b"/>
+    <p:sldId xmlns:r="http://schemas.openxmlformats.org/officeDocument/2006/relationships" id="261" r:id="Reb139b5876264df3"/>
+    <p:sldId xmlns:r="http://schemas.openxmlformats.org/officeDocument/2006/relationships" id="262" r:id="Raf99b9311bba41aa"/>
+    <p:sldId xmlns:r="http://schemas.openxmlformats.org/officeDocument/2006/relationships" id="263" r:id="R42f678bd30394e8f"/>
+    <p:sldId xmlns:r="http://schemas.openxmlformats.org/officeDocument/2006/relationships" id="264" r:id="R28c9c9e9ef8e4171"/>
+    <p:sldId xmlns:r="http://schemas.openxmlformats.org/officeDocument/2006/relationships" id="265" r:id="R73329b35ee9141f3"/>
+    <p:sldId xmlns:r="http://schemas.openxmlformats.org/officeDocument/2006/relationships" id="266" r:id="R74b38976f44548dc"/>
+    <p:sldId xmlns:r="http://schemas.openxmlformats.org/officeDocument/2006/relationships" id="267" r:id="Rb4398cbde8fe4d59"/>
+    <p:sldId xmlns:r="http://schemas.openxmlformats.org/officeDocument/2006/relationships" id="268" r:id="Ra3108d3f84084d8d"/>
+    <p:sldId xmlns:r="http://schemas.openxmlformats.org/officeDocument/2006/relationships" id="269" r:id="Ra86c9de4263f4b6e"/>
+    <p:sldId xmlns:r="http://schemas.openxmlformats.org/officeDocument/2006/relationships" id="270" r:id="R7dd9ca1ed5b043f4"/>
+    <p:sldId xmlns:r="http://schemas.openxmlformats.org/officeDocument/2006/relationships" id="271" r:id="R2fedfa829ac94987"/>
+    <p:sldId xmlns:r="http://schemas.openxmlformats.org/officeDocument/2006/relationships" id="272" r:id="Rce8bd3a6ae90499f"/>
+    <p:sldId xmlns:r="http://schemas.openxmlformats.org/officeDocument/2006/relationships" id="273" r:id="Rb603702e941f42c8"/>
   </p:sldIdLst>
   <p:sldSz cx="15240000" cy="8572500"/>
   <p:notesSz cx="6858000" cy="9144000"/>
@@ -906,6 +909,216 @@
 </p:notes>
 </file>
 
+<file path=ppt/notesSlides/notesSlide16.xml><?xml version="1.0" encoding="utf-8"?>
+<p:notes xmlns:p="http://schemas.openxmlformats.org/presentationml/2006/main">
+  <p:cSld>
+    <p:spTree>
+      <p:nvGrpSpPr>
+        <p:cNvPr id="1" name=""/>
+        <p:cNvGrpSpPr/>
+        <p:nvPr/>
+      </p:nvGrpSpPr>
+      <p:grpSpPr>
+        <a:xfrm xmlns:a="http://schemas.openxmlformats.org/drawingml/2006/main"/>
+      </p:grpSpPr>
+      <p:sp>
+        <p:nvSpPr>
+          <p:cNvPr id="2" name="Slide Image Placeholder 1"/>
+          <p:cNvSpPr>
+            <a:spLocks xmlns:a="http://schemas.openxmlformats.org/drawingml/2006/main" noGrp="1"/>
+          </p:cNvSpPr>
+          <p:nvPr>
+            <p:ph type="sldImg" idx="0"/>
+          </p:nvPr>
+        </p:nvSpPr>
+        <p:spPr/>
+      </p:sp>
+      <p:sp>
+        <p:nvSpPr>
+          <p:cNvPr id="3" name="Notes Placeholder 2"/>
+          <p:cNvSpPr>
+            <a:spLocks xmlns:a="http://schemas.openxmlformats.org/drawingml/2006/main" noGrp="1"/>
+          </p:cNvSpPr>
+          <p:nvPr>
+            <p:ph type="body" idx="1"/>
+          </p:nvPr>
+        </p:nvSpPr>
+        <p:spPr/>
+        <p:txBody>
+          <a:bodyPr xmlns:a="http://schemas.openxmlformats.org/drawingml/2006/main"/>
+          <a:lstStyle xmlns:a="http://schemas.openxmlformats.org/drawingml/2006/main"/>
+          <a:p xmlns:a="http://schemas.openxmlformats.org/drawingml/2006/main">
+            <a:r>
+              <a:t>https://github.com/y00nZZang/product-catalog/blob/main/docs/jev-experiment-2026-10-06.md ; https://github.com/y00nZZang/product-catalog/blob/main/notebooks/two-datasets-results-2026-10-06.json ; https://docs.typesafe.ai/primitives/choice ; https://huggingface.co/datasets/ATH-MaaS/HSCodeComp . 실험은 운영 서비스 변경이나 전체 URL 분석시간 비교가 아니다.</a:t>
+            </a:r>
+          </a:p>
+        </p:txBody>
+      </p:sp>
+      <p:sp>
+        <p:nvSpPr>
+          <p:cNvPr id="4" name="Slide Number Placeholder 3"/>
+          <p:cNvSpPr>
+            <a:spLocks xmlns:a="http://schemas.openxmlformats.org/drawingml/2006/main" noGrp="1"/>
+          </p:cNvSpPr>
+          <p:nvPr>
+            <p:ph type="sldNum" idx="5"/>
+          </p:nvPr>
+        </p:nvSpPr>
+        <p:spPr/>
+        <p:txBody>
+          <a:bodyPr xmlns:a="http://schemas.openxmlformats.org/drawingml/2006/main"/>
+          <a:lstStyle xmlns:a="http://schemas.openxmlformats.org/drawingml/2006/main"/>
+          <a:p xmlns:a="http://schemas.openxmlformats.org/drawingml/2006/main"/>
+        </p:txBody>
+      </p:sp>
+    </p:spTree>
+  </p:cSld>
+  <p:clrMapOvr>
+    <a:masterClrMapping xmlns:a="http://schemas.openxmlformats.org/drawingml/2006/main"/>
+  </p:clrMapOvr>
+</p:notes>
+</file>
+
+<file path=ppt/notesSlides/notesSlide17.xml><?xml version="1.0" encoding="utf-8"?>
+<p:notes xmlns:p="http://schemas.openxmlformats.org/presentationml/2006/main">
+  <p:cSld>
+    <p:spTree>
+      <p:nvGrpSpPr>
+        <p:cNvPr id="1" name=""/>
+        <p:cNvGrpSpPr/>
+        <p:nvPr/>
+      </p:nvGrpSpPr>
+      <p:grpSpPr>
+        <a:xfrm xmlns:a="http://schemas.openxmlformats.org/drawingml/2006/main"/>
+      </p:grpSpPr>
+      <p:sp>
+        <p:nvSpPr>
+          <p:cNvPr id="2" name="Slide Image Placeholder 1"/>
+          <p:cNvSpPr>
+            <a:spLocks xmlns:a="http://schemas.openxmlformats.org/drawingml/2006/main" noGrp="1"/>
+          </p:cNvSpPr>
+          <p:nvPr>
+            <p:ph type="sldImg" idx="0"/>
+          </p:nvPr>
+        </p:nvSpPr>
+        <p:spPr/>
+      </p:sp>
+      <p:sp>
+        <p:nvSpPr>
+          <p:cNvPr id="3" name="Notes Placeholder 2"/>
+          <p:cNvSpPr>
+            <a:spLocks xmlns:a="http://schemas.openxmlformats.org/drawingml/2006/main" noGrp="1"/>
+          </p:cNvSpPr>
+          <p:nvPr>
+            <p:ph type="body" idx="1"/>
+          </p:nvPr>
+        </p:nvSpPr>
+        <p:spPr/>
+        <p:txBody>
+          <a:bodyPr xmlns:a="http://schemas.openxmlformats.org/drawingml/2006/main"/>
+          <a:lstStyle xmlns:a="http://schemas.openxmlformats.org/drawingml/2006/main"/>
+          <a:p xmlns:a="http://schemas.openxmlformats.org/drawingml/2006/main">
+            <a:r>
+              <a:t>https://github.com/y00nZZang/product-catalog/blob/main/docs/jev-experiment-2026-10-06.md . HF94개: Jev0.6747679375초/Luna4.296453624초, 비용0.023445996/0.0544944USD. Mercari30개:0.6689978755/3.79168373초, 비용0.00719754/0.01560205USD. 시간은 각 순차 HTTP+파싱+검증 시간 합의 중앙값. 공급사2개 동시 실행, 단계는 순차. 수집·포장·세금 계산·큐 대기시간 제외. 비용은 usage기반 추정, 청구서 확정액 아님.</a:t>
+            </a:r>
+          </a:p>
+        </p:txBody>
+      </p:sp>
+      <p:sp>
+        <p:nvSpPr>
+          <p:cNvPr id="4" name="Slide Number Placeholder 3"/>
+          <p:cNvSpPr>
+            <a:spLocks xmlns:a="http://schemas.openxmlformats.org/drawingml/2006/main" noGrp="1"/>
+          </p:cNvSpPr>
+          <p:nvPr>
+            <p:ph type="sldNum" idx="5"/>
+          </p:nvPr>
+        </p:nvSpPr>
+        <p:spPr/>
+        <p:txBody>
+          <a:bodyPr xmlns:a="http://schemas.openxmlformats.org/drawingml/2006/main"/>
+          <a:lstStyle xmlns:a="http://schemas.openxmlformats.org/drawingml/2006/main"/>
+          <a:p xmlns:a="http://schemas.openxmlformats.org/drawingml/2006/main"/>
+        </p:txBody>
+      </p:sp>
+    </p:spTree>
+  </p:cSld>
+  <p:clrMapOvr>
+    <a:masterClrMapping xmlns:a="http://schemas.openxmlformats.org/drawingml/2006/main"/>
+  </p:clrMapOvr>
+</p:notes>
+</file>
+
+<file path=ppt/notesSlides/notesSlide18.xml><?xml version="1.0" encoding="utf-8"?>
+<p:notes xmlns:p="http://schemas.openxmlformats.org/presentationml/2006/main">
+  <p:cSld>
+    <p:spTree>
+      <p:nvGrpSpPr>
+        <p:cNvPr id="1" name=""/>
+        <p:cNvGrpSpPr/>
+        <p:nvPr/>
+      </p:nvGrpSpPr>
+      <p:grpSpPr>
+        <a:xfrm xmlns:a="http://schemas.openxmlformats.org/drawingml/2006/main"/>
+      </p:grpSpPr>
+      <p:sp>
+        <p:nvSpPr>
+          <p:cNvPr id="2" name="Slide Image Placeholder 1"/>
+          <p:cNvSpPr>
+            <a:spLocks xmlns:a="http://schemas.openxmlformats.org/drawingml/2006/main" noGrp="1"/>
+          </p:cNvSpPr>
+          <p:nvPr>
+            <p:ph type="sldImg" idx="0"/>
+          </p:nvPr>
+        </p:nvSpPr>
+        <p:spPr/>
+      </p:sp>
+      <p:sp>
+        <p:nvSpPr>
+          <p:cNvPr id="3" name="Notes Placeholder 2"/>
+          <p:cNvSpPr>
+            <a:spLocks xmlns:a="http://schemas.openxmlformats.org/drawingml/2006/main" noGrp="1"/>
+          </p:cNvSpPr>
+          <p:nvPr>
+            <p:ph type="body" idx="1"/>
+          </p:nvPr>
+        </p:nvSpPr>
+        <p:spPr/>
+        <p:txBody>
+          <a:bodyPr xmlns:a="http://schemas.openxmlformats.org/drawingml/2006/main"/>
+          <a:lstStyle xmlns:a="http://schemas.openxmlformats.org/drawingml/2006/main"/>
+          <a:p xmlns:a="http://schemas.openxmlformats.org/drawingml/2006/main">
+            <a:r>
+              <a:t>https://github.com/y00nZZang/product-catalog/blob/main/docs/jev-experiment-2026-10-06.md ; https://github.com/y00nZZang/product-catalog/blob/main/notebooks/two-datasets-results-2026-10-06.json . HF94개: Jev28/94(29.8%), Luna36/94(38.3%), 보류 포함. 답변 사례만:28/81(34.6%),36/65(55.4%). 독립 Sol이HS6를 선택한Mercari25개에서Jev21/25(84%),Luna19/25(76%). 보류 포함30개 전체판단은Jev21/30(70%),Luna23/30(76.7%). Sol은정답/사람검토아님, 공유모델군편향가능. 운영도입하지않았으며 제안은 실험 결과에 대한 해석이다.</a:t>
+            </a:r>
+          </a:p>
+        </p:txBody>
+      </p:sp>
+      <p:sp>
+        <p:nvSpPr>
+          <p:cNvPr id="4" name="Slide Number Placeholder 3"/>
+          <p:cNvSpPr>
+            <a:spLocks xmlns:a="http://schemas.openxmlformats.org/drawingml/2006/main" noGrp="1"/>
+          </p:cNvSpPr>
+          <p:nvPr>
+            <p:ph type="sldNum" idx="5"/>
+          </p:nvPr>
+        </p:nvSpPr>
+        <p:spPr/>
+        <p:txBody>
+          <a:bodyPr xmlns:a="http://schemas.openxmlformats.org/drawingml/2006/main"/>
+          <a:lstStyle xmlns:a="http://schemas.openxmlformats.org/drawingml/2006/main"/>
+          <a:p xmlns:a="http://schemas.openxmlformats.org/drawingml/2006/main"/>
+        </p:txBody>
+      </p:sp>
+    </p:spTree>
+  </p:cSld>
+  <p:clrMapOvr>
+    <a:masterClrMapping xmlns:a="http://schemas.openxmlformats.org/drawingml/2006/main"/>
+  </p:clrMapOvr>
+</p:notes>
+</file>
+
 <file path=ppt/notesSlides/notesSlide2.xml><?xml version="1.0" encoding="utf-8"?>
 <p:notes xmlns:p="http://schemas.openxmlformats.org/presentationml/2006/main">
   <p:cSld>
@@ -1504,7 +1717,7 @@
   </p:cSld>
   <p:clrMap bg1="lt1" tx1="dk1" bg2="lt2" tx2="dk2" accent1="accent1" accent2="accent2" accent3="accent3" accent4="accent4" accent5="accent5" accent6="accent6" hlink="hlink" folHlink="folHlink"/>
   <p:sldLayoutIdLst>
-    <p:sldLayoutId xmlns:r="http://schemas.openxmlformats.org/officeDocument/2006/relationships" id="2147483649" r:id="R0ba0212dbc844fbb"/>
+    <p:sldLayoutId xmlns:r="http://schemas.openxmlformats.org/officeDocument/2006/relationships" id="2147483649" r:id="R9b4a47241f8b4d6b"/>
   </p:sldLayoutIdLst>
   <p:txStyles>
     <p:titleStyle>
@@ -2031,6 +2244,280 @@
 </a:theme>
 </file>
 
+<file path=ppt/slides/charts/chart1.xml><?xml version="1.0" encoding="utf-8"?>
+<c:chartSpace xmlns:c="http://schemas.openxmlformats.org/drawingml/2006/chart" xmlns:r="http://schemas.openxmlformats.org/officeDocument/2006/relationships">
+  <c:lang val="en-US"/>
+  <c:chart>
+    <c:plotArea>
+      <c:barChart>
+        <c:barDir val="col"/>
+        <c:grouping val="clustered"/>
+        <c:varyColors val="0"/>
+        <c:ser>
+          <c:idx val="0"/>
+          <c:order val="0"/>
+          <c:tx>
+            <c:v>Jev</c:v>
+          </c:tx>
+          <c:spPr>
+            <a:solidFill xmlns:a="http://schemas.openxmlformats.org/drawingml/2006/main">
+              <a:srgbClr val="156E58"/>
+            </a:solidFill>
+          </c:spPr>
+          <c:cat>
+            <c:strRef>
+              <c:f>'Chart Data'!$A$2:$A$3</c:f>
+              <c:strCache>
+                <c:ptCount val="2"/>
+                <c:pt idx="0">
+                  <c:v>HF 표본94개</c:v>
+                </c:pt>
+                <c:pt idx="1">
+                  <c:v>메루카리30개</c:v>
+                </c:pt>
+              </c:strCache>
+            </c:strRef>
+          </c:cat>
+          <c:val>
+            <c:numRef>
+              <c:f>'Chart Data'!$B$2:$B$3</c:f>
+              <c:numCache>
+                <c:formatCode>General</c:formatCode>
+                <c:ptCount val="2"/>
+                <c:pt idx="0">
+                  <c:v>0.675</c:v>
+                </c:pt>
+                <c:pt idx="1">
+                  <c:v>0.669</c:v>
+                </c:pt>
+              </c:numCache>
+            </c:numRef>
+          </c:val>
+        </c:ser>
+        <c:ser>
+          <c:idx val="1"/>
+          <c:order val="1"/>
+          <c:tx>
+            <c:v>GPT-6 Luna</c:v>
+          </c:tx>
+          <c:spPr>
+            <a:solidFill xmlns:a="http://schemas.openxmlformats.org/drawingml/2006/main">
+              <a:srgbClr val="85948D"/>
+            </a:solidFill>
+          </c:spPr>
+          <c:cat>
+            <c:strRef>
+              <c:f>'Chart Data'!$C$2:$C$3</c:f>
+              <c:strCache>
+                <c:ptCount val="2"/>
+                <c:pt idx="0">
+                  <c:v>HF 표본94개</c:v>
+                </c:pt>
+                <c:pt idx="1">
+                  <c:v>메루카리30개</c:v>
+                </c:pt>
+              </c:strCache>
+            </c:strRef>
+          </c:cat>
+          <c:val>
+            <c:numRef>
+              <c:f>'Chart Data'!$D$2:$D$3</c:f>
+              <c:numCache>
+                <c:formatCode>General</c:formatCode>
+                <c:ptCount val="2"/>
+                <c:pt idx="0">
+                  <c:v>4.296</c:v>
+                </c:pt>
+                <c:pt idx="1">
+                  <c:v>3.792</c:v>
+                </c:pt>
+              </c:numCache>
+            </c:numRef>
+          </c:val>
+        </c:ser>
+        <c:dLbls>
+          <c:txPr>
+            <a:bodyPr xmlns:a="http://schemas.openxmlformats.org/drawingml/2006/main" anchorCtr="1"/>
+            <a:lstStyle xmlns:a="http://schemas.openxmlformats.org/drawingml/2006/main"/>
+            <a:p xmlns:a="http://schemas.openxmlformats.org/drawingml/2006/main">
+              <a:pPr>
+                <a:defRPr sz="1875">
+                  <a:solidFill>
+                    <a:srgbClr val="182C29"/>
+                  </a:solidFill>
+                  <a:latin typeface="Apple SD Gothic Neo"/>
+                  <a:ea typeface="Apple SD Gothic Neo"/>
+                  <a:cs typeface="Apple SD Gothic Neo"/>
+                </a:defRPr>
+              </a:pPr>
+            </a:p>
+          </c:txPr>
+          <c:dLblPos val="outEnd"/>
+          <c:showLegendKey val="0"/>
+          <c:showVal val="1"/>
+          <c:showCatName val="0"/>
+          <c:showSerName val="0"/>
+          <c:showPercent val="0"/>
+          <c:showBubbleSize val="0"/>
+          <c:showLeaderLines val="0"/>
+        </c:dLbls>
+        <c:gapWidth val="90"/>
+        <c:axId val="48650112"/>
+        <c:axId val="48672768"/>
+      </c:barChart>
+      <c:catAx>
+        <c:axId val="48650112"/>
+        <c:scaling>
+          <c:orientation val="minMax"/>
+        </c:scaling>
+        <c:delete val="0"/>
+        <c:axPos val="b"/>
+        <c:numFmt formatCode="General"/>
+        <c:majorTickMark val="none"/>
+        <c:minorTickMark val="none"/>
+        <c:spPr>
+          <a:ln xmlns:a="http://schemas.openxmlformats.org/drawingml/2006/main" w="9525">
+            <a:solidFill>
+              <a:srgbClr val="D4D4D4"/>
+            </a:solidFill>
+            <a:prstDash val="solid"/>
+          </a:ln>
+        </c:spPr>
+        <c:txPr>
+          <a:bodyPr xmlns:a="http://schemas.openxmlformats.org/drawingml/2006/main" anchorCtr="1"/>
+          <a:lstStyle xmlns:a="http://schemas.openxmlformats.org/drawingml/2006/main"/>
+          <a:p xmlns:a="http://schemas.openxmlformats.org/drawingml/2006/main">
+            <a:pPr>
+              <a:defRPr sz="1950">
+                <a:solidFill>
+                  <a:srgbClr val="182C29"/>
+                </a:solidFill>
+                <a:latin typeface="Apple SD Gothic Neo"/>
+                <a:ea typeface="Apple SD Gothic Neo"/>
+                <a:cs typeface="Apple SD Gothic Neo"/>
+              </a:defRPr>
+            </a:pPr>
+          </a:p>
+        </c:txPr>
+        <c:crossAx val="48672768"/>
+      </c:catAx>
+      <c:valAx>
+        <c:axId val="48672768"/>
+        <c:scaling>
+          <c:orientation val="minMax"/>
+          <c:max val="5"/>
+          <c:min val="0"/>
+        </c:scaling>
+        <c:delete val="0"/>
+        <c:axPos val="l"/>
+        <c:title>
+          <c:tx>
+            <c:rich>
+              <a:bodyPr xmlns:a="http://schemas.openxmlformats.org/drawingml/2006/main"/>
+              <a:lstStyle xmlns:a="http://schemas.openxmlformats.org/drawingml/2006/main"/>
+              <a:p xmlns:a="http://schemas.openxmlformats.org/drawingml/2006/main">
+                <a:r>
+                  <a:rPr sz="1950">
+                    <a:solidFill>
+                      <a:srgbClr val="182C29"/>
+                    </a:solidFill>
+                    <a:latin typeface="Apple SD Gothic Neo"/>
+                    <a:ea typeface="Apple SD Gothic Neo"/>
+                    <a:cs typeface="Apple SD Gothic Neo"/>
+                  </a:rPr>
+                  <a:t>중앙 처리시간 (초)</a:t>
+                </a:r>
+              </a:p>
+            </c:rich>
+          </c:tx>
+          <c:overlay val="0"/>
+          <c:txPr>
+            <a:bodyPr xmlns:a="http://schemas.openxmlformats.org/drawingml/2006/main" anchorCtr="1"/>
+            <a:lstStyle xmlns:a="http://schemas.openxmlformats.org/drawingml/2006/main"/>
+            <a:p xmlns:a="http://schemas.openxmlformats.org/drawingml/2006/main">
+              <a:pPr>
+                <a:defRPr sz="1950">
+                  <a:solidFill>
+                    <a:srgbClr val="182C29"/>
+                  </a:solidFill>
+                  <a:latin typeface="Apple SD Gothic Neo"/>
+                  <a:ea typeface="Apple SD Gothic Neo"/>
+                  <a:cs typeface="Apple SD Gothic Neo"/>
+                </a:defRPr>
+              </a:pPr>
+            </a:p>
+          </c:txPr>
+        </c:title>
+        <c:numFmt formatCode="General"/>
+        <c:majorTickMark val="none"/>
+        <c:minorTickMark val="none"/>
+        <c:spPr>
+          <a:ln xmlns:a="http://schemas.openxmlformats.org/drawingml/2006/main" w="9525">
+            <a:solidFill>
+              <a:srgbClr val="D4D4D4"/>
+            </a:solidFill>
+            <a:prstDash val="solid"/>
+          </a:ln>
+        </c:spPr>
+        <c:txPr>
+          <a:bodyPr xmlns:a="http://schemas.openxmlformats.org/drawingml/2006/main" anchorCtr="1"/>
+          <a:lstStyle xmlns:a="http://schemas.openxmlformats.org/drawingml/2006/main"/>
+          <a:p xmlns:a="http://schemas.openxmlformats.org/drawingml/2006/main">
+            <a:pPr>
+              <a:defRPr sz="1800">
+                <a:solidFill>
+                  <a:srgbClr val="5E706B"/>
+                </a:solidFill>
+                <a:latin typeface="Apple SD Gothic Neo"/>
+                <a:ea typeface="Apple SD Gothic Neo"/>
+                <a:cs typeface="Apple SD Gothic Neo"/>
+              </a:defRPr>
+            </a:pPr>
+          </a:p>
+        </c:txPr>
+        <c:crossAx val="48650112"/>
+        <c:crossBetween val="between"/>
+        <c:majorUnit val="1"/>
+      </c:valAx>
+      <c:spPr>
+        <a:solidFill xmlns:a="http://schemas.openxmlformats.org/drawingml/2006/main">
+          <a:srgbClr val="F8F8F3"/>
+        </a:solidFill>
+      </c:spPr>
+    </c:plotArea>
+    <c:legend>
+      <c:legendPos val="b"/>
+      <c:overlay val="0"/>
+      <c:txPr>
+        <a:bodyPr xmlns:a="http://schemas.openxmlformats.org/drawingml/2006/main" anchorCtr="1"/>
+        <a:lstStyle xmlns:a="http://schemas.openxmlformats.org/drawingml/2006/main"/>
+        <a:p xmlns:a="http://schemas.openxmlformats.org/drawingml/2006/main">
+          <a:pPr>
+            <a:defRPr sz="1950">
+              <a:solidFill>
+                <a:srgbClr val="182C29"/>
+              </a:solidFill>
+              <a:latin typeface="Apple SD Gothic Neo"/>
+              <a:ea typeface="Apple SD Gothic Neo"/>
+              <a:cs typeface="Apple SD Gothic Neo"/>
+            </a:defRPr>
+          </a:pPr>
+        </a:p>
+      </c:txPr>
+    </c:legend>
+    <c:plotVisOnly val="1"/>
+  </c:chart>
+  <c:spPr>
+    <a:solidFill xmlns:a="http://schemas.openxmlformats.org/drawingml/2006/main">
+      <a:srgbClr val="F8F8F3"/>
+    </a:solidFill>
+  </c:spPr>
+  <c:externalData r:id="rIdChartSnapshot1">
+    <c:autoUpdate val="0"/>
+  </c:externalData>
+</c:chartSpace>
+</file>
+
 <file path=ppt/slides/slide1.xml><?xml version="1.0" encoding="utf-8"?>
 <p:sld xmlns:p="http://schemas.openxmlformats.org/presentationml/2006/main">
   <p:cSld>
@@ -2123,6 +2610,7 @@
           <a:lstStyle xmlns:a="http://schemas.openxmlformats.org/drawingml/2006/main"/>
           <a:p xmlns:a="http://schemas.openxmlformats.org/drawingml/2006/main">
             <a:pPr>
+              <a:buNone/>
               <a:defRPr sz="1350" b="0">
                 <a:solidFill>
                   <a:srgbClr val="5E706B"/>
@@ -2180,6 +2668,7 @@
           <a:lstStyle xmlns:a="http://schemas.openxmlformats.org/drawingml/2006/main"/>
           <a:p xmlns:a="http://schemas.openxmlformats.org/drawingml/2006/main">
             <a:pPr>
+              <a:buNone/>
               <a:defRPr sz="2100" b="0">
                 <a:solidFill>
                   <a:srgbClr val="B8D9C9"/>
@@ -2237,6 +2726,7 @@
           <a:lstStyle xmlns:a="http://schemas.openxmlformats.org/drawingml/2006/main"/>
           <a:p xmlns:a="http://schemas.openxmlformats.org/drawingml/2006/main">
             <a:pPr>
+              <a:buNone/>
               <a:defRPr sz="5100" b="1">
                 <a:solidFill>
                   <a:srgbClr val="FFFFFF"/>
@@ -2260,6 +2750,7 @@
           </a:p>
           <a:p xmlns:a="http://schemas.openxmlformats.org/drawingml/2006/main">
             <a:pPr>
+              <a:buNone/>
               <a:defRPr sz="5100" b="1">
                 <a:solidFill>
                   <a:srgbClr val="FFFFFF"/>
@@ -2317,6 +2808,7 @@
           <a:lstStyle xmlns:a="http://schemas.openxmlformats.org/drawingml/2006/main"/>
           <a:p xmlns:a="http://schemas.openxmlformats.org/drawingml/2006/main">
             <a:pPr>
+              <a:buNone/>
               <a:defRPr sz="2700" b="0">
                 <a:solidFill>
                   <a:srgbClr val="D8E7DE"/>
@@ -2374,6 +2866,7 @@
           <a:lstStyle xmlns:a="http://schemas.openxmlformats.org/drawingml/2006/main"/>
           <a:p xmlns:a="http://schemas.openxmlformats.org/drawingml/2006/main">
             <a:pPr>
+              <a:buNone/>
               <a:defRPr sz="2025" b="0">
                 <a:solidFill>
                   <a:srgbClr val="B8D9C9"/>
@@ -2460,6 +2953,7 @@
           <a:lstStyle xmlns:a="http://schemas.openxmlformats.org/drawingml/2006/main"/>
           <a:p xmlns:a="http://schemas.openxmlformats.org/drawingml/2006/main">
             <a:pPr>
+              <a:buNone/>
               <a:defRPr sz="3675" b="1">
                 <a:solidFill>
                   <a:srgbClr val="182C29"/>
@@ -2517,6 +3011,7 @@
           <a:lstStyle xmlns:a="http://schemas.openxmlformats.org/drawingml/2006/main"/>
           <a:p xmlns:a="http://schemas.openxmlformats.org/drawingml/2006/main">
             <a:pPr>
+              <a:buNone/>
               <a:defRPr sz="2100" b="0">
                 <a:solidFill>
                   <a:srgbClr val="5E706B"/>
@@ -2574,6 +3069,7 @@
           <a:lstStyle xmlns:a="http://schemas.openxmlformats.org/drawingml/2006/main"/>
           <a:p xmlns:a="http://schemas.openxmlformats.org/drawingml/2006/main">
             <a:pPr>
+              <a:buNone/>
               <a:defRPr sz="1350" b="0">
                 <a:solidFill>
                   <a:srgbClr val="5E706B"/>
@@ -2631,14 +3127,14 @@
       </p:sp>
       <p:pic>
         <p:nvPicPr>
-          <p:cNvPr id="14" name=""/>
+          <p:cNvPr id="16" name=""/>
           <p:cNvPicPr>
             <a:picLocks xmlns:a="http://schemas.openxmlformats.org/drawingml/2006/main" noChangeAspect="1"/>
           </p:cNvPicPr>
           <p:nvPr/>
         </p:nvPicPr>
         <p:blipFill>
-          <a:blip xmlns:r="http://schemas.openxmlformats.org/officeDocument/2006/relationships" xmlns:a="http://schemas.openxmlformats.org/drawingml/2006/main" r:embed="R8c6b1be854324325"/>
+          <a:blip xmlns:r="http://schemas.openxmlformats.org/officeDocument/2006/relationships" xmlns:a="http://schemas.openxmlformats.org/drawingml/2006/main" r:embed="Ra655bc335cb84b21"/>
           <a:stretch xmlns:a="http://schemas.openxmlformats.org/drawingml/2006/main"/>
         </p:blipFill>
         <p:spPr>
@@ -2685,6 +3181,7 @@
           <a:lstStyle xmlns:a="http://schemas.openxmlformats.org/drawingml/2006/main"/>
           <a:p xmlns:a="http://schemas.openxmlformats.org/drawingml/2006/main">
             <a:pPr>
+              <a:buNone/>
               <a:defRPr sz="2550" b="1">
                 <a:solidFill>
                   <a:srgbClr val="156E58"/>
@@ -2742,6 +3239,7 @@
           <a:lstStyle xmlns:a="http://schemas.openxmlformats.org/drawingml/2006/main"/>
           <a:p xmlns:a="http://schemas.openxmlformats.org/drawingml/2006/main">
             <a:pPr>
+              <a:buNone/>
               <a:defRPr sz="2250" b="0">
                 <a:solidFill>
                   <a:srgbClr val="182C29"/>
@@ -2765,6 +3263,7 @@
           </a:p>
           <a:p xmlns:a="http://schemas.openxmlformats.org/drawingml/2006/main">
             <a:pPr>
+              <a:buNone/>
               <a:defRPr sz="2250" b="0">
                 <a:solidFill>
                   <a:srgbClr val="182C29"/>
@@ -2822,6 +3321,7 @@
           <a:lstStyle xmlns:a="http://schemas.openxmlformats.org/drawingml/2006/main"/>
           <a:p xmlns:a="http://schemas.openxmlformats.org/drawingml/2006/main">
             <a:pPr>
+              <a:buNone/>
               <a:defRPr sz="2550" b="1">
                 <a:solidFill>
                   <a:srgbClr val="156E58"/>
@@ -2879,6 +3379,7 @@
           <a:lstStyle xmlns:a="http://schemas.openxmlformats.org/drawingml/2006/main"/>
           <a:p xmlns:a="http://schemas.openxmlformats.org/drawingml/2006/main">
             <a:pPr>
+              <a:buNone/>
               <a:defRPr sz="2250" b="0">
                 <a:solidFill>
                   <a:srgbClr val="182C29"/>
@@ -2902,6 +3403,7 @@
           </a:p>
           <a:p xmlns:a="http://schemas.openxmlformats.org/drawingml/2006/main">
             <a:pPr>
+              <a:buNone/>
               <a:defRPr sz="2250" b="0">
                 <a:solidFill>
                   <a:srgbClr val="182C29"/>
@@ -2925,6 +3427,7 @@
           </a:p>
           <a:p xmlns:a="http://schemas.openxmlformats.org/drawingml/2006/main">
             <a:pPr>
+              <a:buNone/>
               <a:defRPr sz="2250" b="0">
                 <a:solidFill>
                   <a:srgbClr val="182C29"/>
@@ -3011,6 +3514,7 @@
           <a:lstStyle xmlns:a="http://schemas.openxmlformats.org/drawingml/2006/main"/>
           <a:p xmlns:a="http://schemas.openxmlformats.org/drawingml/2006/main">
             <a:pPr>
+              <a:buNone/>
               <a:defRPr sz="3675" b="1">
                 <a:solidFill>
                   <a:srgbClr val="182C29"/>
@@ -3068,6 +3572,7 @@
           <a:lstStyle xmlns:a="http://schemas.openxmlformats.org/drawingml/2006/main"/>
           <a:p xmlns:a="http://schemas.openxmlformats.org/drawingml/2006/main">
             <a:pPr>
+              <a:buNone/>
               <a:defRPr sz="2100" b="0">
                 <a:solidFill>
                   <a:srgbClr val="5E706B"/>
@@ -3125,6 +3630,7 @@
           <a:lstStyle xmlns:a="http://schemas.openxmlformats.org/drawingml/2006/main"/>
           <a:p xmlns:a="http://schemas.openxmlformats.org/drawingml/2006/main">
             <a:pPr>
+              <a:buNone/>
               <a:defRPr sz="1350" b="0">
                 <a:solidFill>
                   <a:srgbClr val="5E706B"/>
@@ -3184,6 +3690,7 @@
           <a:lstStyle xmlns:a="http://schemas.openxmlformats.org/drawingml/2006/main"/>
           <a:p xmlns:a="http://schemas.openxmlformats.org/drawingml/2006/main">
             <a:pPr algn="ctr">
+              <a:buNone/>
               <a:defRPr sz="2175" b="1">
                 <a:solidFill>
                   <a:srgbClr val="182C29"/>
@@ -3243,6 +3750,7 @@
           <a:lstStyle xmlns:a="http://schemas.openxmlformats.org/drawingml/2006/main"/>
           <a:p xmlns:a="http://schemas.openxmlformats.org/drawingml/2006/main">
             <a:pPr algn="ctr">
+              <a:buNone/>
               <a:defRPr sz="2175" b="1">
                 <a:solidFill>
                   <a:srgbClr val="182C29"/>
@@ -3268,7 +3776,7 @@
       </p:sp>
       <p:cxnSp>
         <p:nvCxnSpPr>
-          <p:cNvPr id="19" name=""/>
+          <p:cNvPr id="27" name=""/>
           <p:cNvCxnSpPr>
             <a:stCxn xmlns:a="http://schemas.openxmlformats.org/drawingml/2006/main" id="4" idx="3"/>
             <a:endCxn xmlns:a="http://schemas.openxmlformats.org/drawingml/2006/main" id="5" idx="1"/>
@@ -3327,6 +3835,7 @@
           <a:lstStyle xmlns:a="http://schemas.openxmlformats.org/drawingml/2006/main"/>
           <a:p xmlns:a="http://schemas.openxmlformats.org/drawingml/2006/main">
             <a:pPr algn="ctr">
+              <a:buNone/>
               <a:defRPr sz="2175" b="1">
                 <a:solidFill>
                   <a:srgbClr val="182C29"/>
@@ -3352,7 +3861,7 @@
       </p:sp>
       <p:cxnSp>
         <p:nvCxnSpPr>
-          <p:cNvPr id="21" name=""/>
+          <p:cNvPr id="29" name=""/>
           <p:cNvCxnSpPr>
             <a:stCxn xmlns:a="http://schemas.openxmlformats.org/drawingml/2006/main" id="5" idx="3"/>
             <a:endCxn xmlns:a="http://schemas.openxmlformats.org/drawingml/2006/main" id="7" idx="1"/>
@@ -3409,6 +3918,7 @@
           <a:lstStyle xmlns:a="http://schemas.openxmlformats.org/drawingml/2006/main"/>
           <a:p xmlns:a="http://schemas.openxmlformats.org/drawingml/2006/main">
             <a:pPr>
+              <a:buNone/>
               <a:defRPr sz="2325" b="0">
                 <a:solidFill>
                   <a:srgbClr val="182C29"/>
@@ -3432,6 +3942,7 @@
           </a:p>
           <a:p xmlns:a="http://schemas.openxmlformats.org/drawingml/2006/main">
             <a:pPr>
+              <a:buNone/>
               <a:defRPr sz="2325" b="0">
                 <a:solidFill>
                   <a:srgbClr val="182C29"/>
@@ -3489,6 +4000,7 @@
           <a:lstStyle xmlns:a="http://schemas.openxmlformats.org/drawingml/2006/main"/>
           <a:p xmlns:a="http://schemas.openxmlformats.org/drawingml/2006/main">
             <a:pPr>
+              <a:buNone/>
               <a:defRPr sz="2325" b="0">
                 <a:solidFill>
                   <a:srgbClr val="182C29"/>
@@ -3512,6 +4024,7 @@
           </a:p>
           <a:p xmlns:a="http://schemas.openxmlformats.org/drawingml/2006/main">
             <a:pPr>
+              <a:buNone/>
               <a:defRPr sz="2325" b="0">
                 <a:solidFill>
                   <a:srgbClr val="182C29"/>
@@ -3569,6 +4082,7 @@
           <a:lstStyle xmlns:a="http://schemas.openxmlformats.org/drawingml/2006/main"/>
           <a:p xmlns:a="http://schemas.openxmlformats.org/drawingml/2006/main">
             <a:pPr>
+              <a:buNone/>
               <a:defRPr sz="2175" b="0">
                 <a:solidFill>
                   <a:srgbClr val="182C29"/>
@@ -3592,6 +4106,7 @@
           </a:p>
           <a:p xmlns:a="http://schemas.openxmlformats.org/drawingml/2006/main">
             <a:pPr>
+              <a:buNone/>
               <a:defRPr sz="2175" b="0">
                 <a:solidFill>
                   <a:srgbClr val="182C29"/>
@@ -3649,6 +4164,7 @@
           <a:lstStyle xmlns:a="http://schemas.openxmlformats.org/drawingml/2006/main"/>
           <a:p xmlns:a="http://schemas.openxmlformats.org/drawingml/2006/main">
             <a:pPr>
+              <a:buNone/>
               <a:defRPr sz="2325" b="0">
                 <a:solidFill>
                   <a:srgbClr val="182C29"/>
@@ -3706,6 +4222,7 @@
           <a:lstStyle xmlns:a="http://schemas.openxmlformats.org/drawingml/2006/main"/>
           <a:p xmlns:a="http://schemas.openxmlformats.org/drawingml/2006/main">
             <a:pPr>
+              <a:buNone/>
               <a:defRPr sz="1800" b="0">
                 <a:solidFill>
                   <a:srgbClr val="5E706B"/>
@@ -3792,6 +4309,7 @@
           <a:lstStyle xmlns:a="http://schemas.openxmlformats.org/drawingml/2006/main"/>
           <a:p xmlns:a="http://schemas.openxmlformats.org/drawingml/2006/main">
             <a:pPr>
+              <a:buNone/>
               <a:defRPr sz="3675" b="1">
                 <a:solidFill>
                   <a:srgbClr val="182C29"/>
@@ -3849,6 +4367,7 @@
           <a:lstStyle xmlns:a="http://schemas.openxmlformats.org/drawingml/2006/main"/>
           <a:p xmlns:a="http://schemas.openxmlformats.org/drawingml/2006/main">
             <a:pPr>
+              <a:buNone/>
               <a:defRPr sz="2100" b="0">
                 <a:solidFill>
                   <a:srgbClr val="5E706B"/>
@@ -3906,6 +4425,7 @@
           <a:lstStyle xmlns:a="http://schemas.openxmlformats.org/drawingml/2006/main"/>
           <a:p xmlns:a="http://schemas.openxmlformats.org/drawingml/2006/main">
             <a:pPr>
+              <a:buNone/>
               <a:defRPr sz="1350" b="0">
                 <a:solidFill>
                   <a:srgbClr val="5E706B"/>
@@ -3931,7 +4451,7 @@
       </p:sp>
       <p:graphicFrame>
         <p:nvGraphicFramePr>
-          <p:cNvPr id="9" name=""/>
+          <p:cNvPr id="11" name=""/>
           <p:cNvGraphicFramePr/>
           <p:nvPr/>
         </p:nvGraphicFramePr>
@@ -4508,6 +5028,7 @@
           <a:lstStyle xmlns:a="http://schemas.openxmlformats.org/drawingml/2006/main"/>
           <a:p xmlns:a="http://schemas.openxmlformats.org/drawingml/2006/main">
             <a:pPr>
+              <a:buNone/>
               <a:defRPr sz="1725" b="0">
                 <a:solidFill>
                   <a:srgbClr val="5E706B"/>
@@ -4594,6 +5115,7 @@
           <a:lstStyle xmlns:a="http://schemas.openxmlformats.org/drawingml/2006/main"/>
           <a:p xmlns:a="http://schemas.openxmlformats.org/drawingml/2006/main">
             <a:pPr>
+              <a:buNone/>
               <a:defRPr sz="3675" b="1">
                 <a:solidFill>
                   <a:srgbClr val="182C29"/>
@@ -4651,6 +5173,7 @@
           <a:lstStyle xmlns:a="http://schemas.openxmlformats.org/drawingml/2006/main"/>
           <a:p xmlns:a="http://schemas.openxmlformats.org/drawingml/2006/main">
             <a:pPr>
+              <a:buNone/>
               <a:defRPr sz="2100" b="0">
                 <a:solidFill>
                   <a:srgbClr val="5E706B"/>
@@ -4708,6 +5231,7 @@
           <a:lstStyle xmlns:a="http://schemas.openxmlformats.org/drawingml/2006/main"/>
           <a:p xmlns:a="http://schemas.openxmlformats.org/drawingml/2006/main">
             <a:pPr>
+              <a:buNone/>
               <a:defRPr sz="1350" b="0">
                 <a:solidFill>
                   <a:srgbClr val="5E706B"/>
@@ -4733,7 +5257,7 @@
       </p:sp>
       <p:graphicFrame>
         <p:nvGraphicFramePr>
-          <p:cNvPr id="9" name=""/>
+          <p:cNvPr id="11" name=""/>
           <p:cNvGraphicFramePr/>
           <p:nvPr/>
         </p:nvGraphicFramePr>
@@ -4963,6 +5487,7 @@
           <a:lstStyle xmlns:a="http://schemas.openxmlformats.org/drawingml/2006/main"/>
           <a:p xmlns:a="http://schemas.openxmlformats.org/drawingml/2006/main">
             <a:pPr>
+              <a:buNone/>
               <a:defRPr sz="2100" b="0">
                 <a:solidFill>
                   <a:srgbClr val="182C29"/>
@@ -4986,6 +5511,7 @@
           </a:p>
           <a:p xmlns:a="http://schemas.openxmlformats.org/drawingml/2006/main">
             <a:pPr>
+              <a:buNone/>
               <a:defRPr sz="2100" b="0">
                 <a:solidFill>
                   <a:srgbClr val="182C29"/>
@@ -5072,6 +5598,7 @@
           <a:lstStyle xmlns:a="http://schemas.openxmlformats.org/drawingml/2006/main"/>
           <a:p xmlns:a="http://schemas.openxmlformats.org/drawingml/2006/main">
             <a:pPr>
+              <a:buNone/>
               <a:defRPr sz="3675" b="1">
                 <a:solidFill>
                   <a:srgbClr val="182C29"/>
@@ -5129,6 +5656,7 @@
           <a:lstStyle xmlns:a="http://schemas.openxmlformats.org/drawingml/2006/main"/>
           <a:p xmlns:a="http://schemas.openxmlformats.org/drawingml/2006/main">
             <a:pPr>
+              <a:buNone/>
               <a:defRPr sz="2100" b="0">
                 <a:solidFill>
                   <a:srgbClr val="5E706B"/>
@@ -5186,6 +5714,7 @@
           <a:lstStyle xmlns:a="http://schemas.openxmlformats.org/drawingml/2006/main"/>
           <a:p xmlns:a="http://schemas.openxmlformats.org/drawingml/2006/main">
             <a:pPr>
+              <a:buNone/>
               <a:defRPr sz="1350" b="0">
                 <a:solidFill>
                   <a:srgbClr val="5E706B"/>
@@ -5243,6 +5772,7 @@
           <a:lstStyle xmlns:a="http://schemas.openxmlformats.org/drawingml/2006/main"/>
           <a:p xmlns:a="http://schemas.openxmlformats.org/drawingml/2006/main">
             <a:pPr>
+              <a:buNone/>
               <a:defRPr sz="2700" b="1">
                 <a:solidFill>
                   <a:srgbClr val="156E58"/>
@@ -5300,6 +5830,7 @@
           <a:lstStyle xmlns:a="http://schemas.openxmlformats.org/drawingml/2006/main"/>
           <a:p xmlns:a="http://schemas.openxmlformats.org/drawingml/2006/main">
             <a:pPr>
+              <a:buNone/>
               <a:defRPr sz="2325" b="0">
                 <a:solidFill>
                   <a:srgbClr val="182C29"/>
@@ -5323,6 +5854,7 @@
           </a:p>
           <a:p xmlns:a="http://schemas.openxmlformats.org/drawingml/2006/main">
             <a:pPr>
+              <a:buNone/>
               <a:defRPr sz="2325" b="0">
                 <a:solidFill>
                   <a:srgbClr val="182C29"/>
@@ -5351,6 +5883,7 @@
           </a:p>
           <a:p xmlns:a="http://schemas.openxmlformats.org/drawingml/2006/main">
             <a:pPr>
+              <a:buNone/>
               <a:defRPr sz="2325" b="0">
                 <a:solidFill>
                   <a:srgbClr val="182C29"/>
@@ -5374,6 +5907,7 @@
           </a:p>
           <a:p xmlns:a="http://schemas.openxmlformats.org/drawingml/2006/main">
             <a:pPr>
+              <a:buNone/>
               <a:defRPr sz="2325" b="0">
                 <a:solidFill>
                   <a:srgbClr val="182C29"/>
@@ -5431,6 +5965,7 @@
           <a:lstStyle xmlns:a="http://schemas.openxmlformats.org/drawingml/2006/main"/>
           <a:p xmlns:a="http://schemas.openxmlformats.org/drawingml/2006/main">
             <a:pPr>
+              <a:buNone/>
               <a:defRPr sz="2700" b="1">
                 <a:solidFill>
                   <a:srgbClr val="156E58"/>
@@ -5488,6 +6023,7 @@
           <a:lstStyle xmlns:a="http://schemas.openxmlformats.org/drawingml/2006/main"/>
           <a:p xmlns:a="http://schemas.openxmlformats.org/drawingml/2006/main">
             <a:pPr>
+              <a:buNone/>
               <a:defRPr sz="2325" b="0">
                 <a:solidFill>
                   <a:srgbClr val="182C29"/>
@@ -5511,6 +6047,7 @@
           </a:p>
           <a:p xmlns:a="http://schemas.openxmlformats.org/drawingml/2006/main">
             <a:pPr>
+              <a:buNone/>
               <a:defRPr sz="2325" b="0">
                 <a:solidFill>
                   <a:srgbClr val="182C29"/>
@@ -5539,6 +6076,7 @@
           </a:p>
           <a:p xmlns:a="http://schemas.openxmlformats.org/drawingml/2006/main">
             <a:pPr>
+              <a:buNone/>
               <a:defRPr sz="2325" b="0">
                 <a:solidFill>
                   <a:srgbClr val="182C29"/>
@@ -5562,6 +6100,7 @@
           </a:p>
           <a:p xmlns:a="http://schemas.openxmlformats.org/drawingml/2006/main">
             <a:pPr>
+              <a:buNone/>
               <a:defRPr sz="2325" b="0">
                 <a:solidFill>
                   <a:srgbClr val="182C29"/>
@@ -5619,6 +6158,7 @@
           <a:lstStyle xmlns:a="http://schemas.openxmlformats.org/drawingml/2006/main"/>
           <a:p xmlns:a="http://schemas.openxmlformats.org/drawingml/2006/main">
             <a:pPr>
+              <a:buNone/>
               <a:defRPr sz="2100" b="0">
                 <a:solidFill>
                   <a:srgbClr val="182C29"/>
@@ -5642,6 +6182,7 @@
           </a:p>
           <a:p xmlns:a="http://schemas.openxmlformats.org/drawingml/2006/main">
             <a:pPr>
+              <a:buNone/>
               <a:defRPr sz="2100" b="0">
                 <a:solidFill>
                   <a:srgbClr val="182C29"/>
@@ -5699,6 +6240,7 @@
           <a:lstStyle xmlns:a="http://schemas.openxmlformats.org/drawingml/2006/main"/>
           <a:p xmlns:a="http://schemas.openxmlformats.org/drawingml/2006/main">
             <a:pPr>
+              <a:buNone/>
               <a:defRPr sz="1575" b="0">
                 <a:solidFill>
                   <a:srgbClr val="5E706B"/>
@@ -5785,6 +6327,7 @@
           <a:lstStyle xmlns:a="http://schemas.openxmlformats.org/drawingml/2006/main"/>
           <a:p xmlns:a="http://schemas.openxmlformats.org/drawingml/2006/main">
             <a:pPr>
+              <a:buNone/>
               <a:defRPr sz="3675" b="1">
                 <a:solidFill>
                   <a:srgbClr val="182C29"/>
@@ -5842,6 +6385,7 @@
           <a:lstStyle xmlns:a="http://schemas.openxmlformats.org/drawingml/2006/main"/>
           <a:p xmlns:a="http://schemas.openxmlformats.org/drawingml/2006/main">
             <a:pPr>
+              <a:buNone/>
               <a:defRPr sz="2100" b="0">
                 <a:solidFill>
                   <a:srgbClr val="5E706B"/>
@@ -5899,6 +6443,7 @@
           <a:lstStyle xmlns:a="http://schemas.openxmlformats.org/drawingml/2006/main"/>
           <a:p xmlns:a="http://schemas.openxmlformats.org/drawingml/2006/main">
             <a:pPr>
+              <a:buNone/>
               <a:defRPr sz="1350" b="0">
                 <a:solidFill>
                   <a:srgbClr val="5E706B"/>
@@ -5956,6 +6501,7 @@
           <a:lstStyle xmlns:a="http://schemas.openxmlformats.org/drawingml/2006/main"/>
           <a:p xmlns:a="http://schemas.openxmlformats.org/drawingml/2006/main">
             <a:pPr>
+              <a:buNone/>
               <a:defRPr sz="2475" b="0">
                 <a:solidFill>
                   <a:srgbClr val="182C29"/>
@@ -5979,6 +6525,7 @@
           </a:p>
           <a:p xmlns:a="http://schemas.openxmlformats.org/drawingml/2006/main">
             <a:pPr>
+              <a:buNone/>
               <a:defRPr sz="2475" b="0">
                 <a:solidFill>
                   <a:srgbClr val="182C29"/>
@@ -6038,6 +6585,7 @@
           <a:lstStyle xmlns:a="http://schemas.openxmlformats.org/drawingml/2006/main"/>
           <a:p xmlns:a="http://schemas.openxmlformats.org/drawingml/2006/main">
             <a:pPr algn="ctr">
+              <a:buNone/>
               <a:defRPr sz="2175" b="1">
                 <a:solidFill>
                   <a:srgbClr val="182C29"/>
@@ -6097,6 +6645,7 @@
           <a:lstStyle xmlns:a="http://schemas.openxmlformats.org/drawingml/2006/main"/>
           <a:p xmlns:a="http://schemas.openxmlformats.org/drawingml/2006/main">
             <a:pPr algn="ctr">
+              <a:buNone/>
               <a:defRPr sz="2175" b="1">
                 <a:solidFill>
                   <a:srgbClr val="182C29"/>
@@ -6122,7 +6671,7 @@
       </p:sp>
       <p:cxnSp>
         <p:nvCxnSpPr>
-          <p:cNvPr id="18" name=""/>
+          <p:cNvPr id="27" name=""/>
           <p:cNvCxnSpPr>
             <a:stCxn xmlns:a="http://schemas.openxmlformats.org/drawingml/2006/main" id="5" idx="3"/>
             <a:endCxn xmlns:a="http://schemas.openxmlformats.org/drawingml/2006/main" id="6" idx="1"/>
@@ -6181,6 +6730,7 @@
           <a:lstStyle xmlns:a="http://schemas.openxmlformats.org/drawingml/2006/main"/>
           <a:p xmlns:a="http://schemas.openxmlformats.org/drawingml/2006/main">
             <a:pPr algn="ctr">
+              <a:buNone/>
               <a:defRPr sz="2175" b="1">
                 <a:solidFill>
                   <a:srgbClr val="182C29"/>
@@ -6206,7 +6756,7 @@
       </p:sp>
       <p:cxnSp>
         <p:nvCxnSpPr>
-          <p:cNvPr id="20" name=""/>
+          <p:cNvPr id="29" name=""/>
           <p:cNvCxnSpPr>
             <a:stCxn xmlns:a="http://schemas.openxmlformats.org/drawingml/2006/main" id="6" idx="3"/>
             <a:endCxn xmlns:a="http://schemas.openxmlformats.org/drawingml/2006/main" id="8" idx="1"/>
@@ -6263,6 +6813,7 @@
           <a:lstStyle xmlns:a="http://schemas.openxmlformats.org/drawingml/2006/main"/>
           <a:p xmlns:a="http://schemas.openxmlformats.org/drawingml/2006/main">
             <a:pPr>
+              <a:buNone/>
               <a:defRPr sz="2475" b="0">
                 <a:solidFill>
                   <a:srgbClr val="182C29"/>
@@ -6286,6 +6837,7 @@
           </a:p>
           <a:p xmlns:a="http://schemas.openxmlformats.org/drawingml/2006/main">
             <a:pPr>
+              <a:buNone/>
               <a:defRPr sz="2475" b="0">
                 <a:solidFill>
                   <a:srgbClr val="182C29"/>
@@ -6309,6 +6861,7 @@
           </a:p>
           <a:p xmlns:a="http://schemas.openxmlformats.org/drawingml/2006/main">
             <a:pPr>
+              <a:buNone/>
               <a:defRPr sz="2475" b="0">
                 <a:solidFill>
                   <a:srgbClr val="182C29"/>
@@ -6366,6 +6919,7 @@
           <a:lstStyle xmlns:a="http://schemas.openxmlformats.org/drawingml/2006/main"/>
           <a:p xmlns:a="http://schemas.openxmlformats.org/drawingml/2006/main">
             <a:pPr>
+              <a:buNone/>
               <a:defRPr sz="1575" b="0">
                 <a:solidFill>
                   <a:srgbClr val="5E706B"/>
@@ -6393,6 +6947,1950 @@
     <p:extLst>
       <p:ext uri="{BB962C8B-B14F-4D97-AF65-F5344CB8AC3E}">
         <p14:creationId xmlns:p14="http://schemas.microsoft.com/office/powerpoint/2010/main" val="65866022"/>
+      </p:ext>
+    </p:extLst>
+  </p:cSld>
+</p:sld>
+</file>
+
+<file path=ppt/slides/slide16.xml><?xml version="1.0" encoding="utf-8"?>
+<p:sld xmlns:p="http://schemas.openxmlformats.org/presentationml/2006/main">
+  <p:cSld>
+    <p:bg>
+      <p:bgPr>
+        <a:solidFill xmlns:a="http://schemas.openxmlformats.org/drawingml/2006/main">
+          <a:srgbClr val="F8F8F3"/>
+        </a:solidFill>
+      </p:bgPr>
+    </p:bg>
+    <p:spTree>
+      <p:nvGrpSpPr>
+        <p:cNvPr id="1" name=""/>
+        <p:cNvGrpSpPr/>
+        <p:nvPr/>
+      </p:nvGrpSpPr>
+      <p:grpSpPr>
+        <a:xfrm xmlns:a="http://schemas.openxmlformats.org/drawingml/2006/main"/>
+      </p:grpSpPr>
+      <p:sp>
+        <p:nvSpPr>
+          <p:cNvPr id="8" name="">
+            <a:extLst xmlns:a="http://schemas.openxmlformats.org/drawingml/2006/main">
+              <a:ext uri="{FF2B5EF4-FFF2-40B4-BE49-F238E27FC236}">
+                <a16:creationId xmlns:a16="http://schemas.microsoft.com/office/drawing/2014/main" id="{32208E57-18E6-46B5-8C98-0B617BA6AF3E}"/>
+              </a:ext>
+            </a:extLst>
+          </p:cNvPr>
+          <p:cNvSpPr>
+            <a:spLocks xmlns:a="http://schemas.openxmlformats.org/drawingml/2006/main" noGrp="1"/>
+          </p:cNvSpPr>
+          <p:nvPr/>
+        </p:nvSpPr>
+        <p:spPr>
+          <a:xfrm xmlns:a="http://schemas.openxmlformats.org/drawingml/2006/main">
+            <a:off x="800100" y="609600"/>
+            <a:ext cx="13620750" cy="781050"/>
+          </a:xfrm>
+          <a:prstGeom xmlns:a="http://schemas.openxmlformats.org/drawingml/2006/main" prst="rect">
+            <a:avLst/>
+          </a:prstGeom>
+          <a:noFill xmlns:a="http://schemas.openxmlformats.org/drawingml/2006/main"/>
+          <a:ln xmlns:a="http://schemas.openxmlformats.org/drawingml/2006/main" w="0">
+            <a:noFill/>
+          </a:ln>
+        </p:spPr>
+        <p:txBody>
+          <a:bodyPr xmlns:a="http://schemas.openxmlformats.org/drawingml/2006/main" wrap="square" lIns="0" tIns="0" rIns="0" bIns="0">
+            <a:noAutofit/>
+          </a:bodyPr>
+          <a:lstStyle xmlns:a="http://schemas.openxmlformats.org/drawingml/2006/main"/>
+          <a:p xmlns:a="http://schemas.openxmlformats.org/drawingml/2006/main">
+            <a:pPr>
+              <a:defRPr sz="3675" b="1">
+                <a:solidFill>
+                  <a:srgbClr val="182C29"/>
+                </a:solidFill>
+                <a:latin typeface="Apple SD Gothic Neo"/>
+                <a:ea typeface="Apple SD Gothic Neo"/>
+                <a:cs typeface="Apple SD Gothic Neo"/>
+              </a:defRPr>
+            </a:pPr>
+            <a:r>
+              <a:rPr sz="3675" b="1">
+                <a:solidFill>
+                  <a:srgbClr val="182C29"/>
+                </a:solidFill>
+                <a:latin typeface="Apple SD Gothic Neo"/>
+                <a:ea typeface="Apple SD Gothic Neo"/>
+                <a:cs typeface="Apple SD Gothic Neo"/>
+              </a:rPr>
+              <a:t>부록 · Jev 판단 모델 비교 실험</a:t>
+            </a:r>
+          </a:p>
+        </p:txBody>
+      </p:sp>
+      <p:sp>
+        <p:nvSpPr>
+          <p:cNvPr id="2" name="">
+            <a:extLst xmlns:a="http://schemas.openxmlformats.org/drawingml/2006/main">
+              <a:ext uri="{FF2B5EF4-FFF2-40B4-BE49-F238E27FC236}">
+                <a16:creationId xmlns:a16="http://schemas.microsoft.com/office/drawing/2014/main" id="{EF7A26ED-E82B-4BBB-8FAA-EE00C720382B}"/>
+              </a:ext>
+            </a:extLst>
+          </p:cNvPr>
+          <p:cNvSpPr>
+            <a:spLocks xmlns:a="http://schemas.openxmlformats.org/drawingml/2006/main" noGrp="1"/>
+          </p:cNvSpPr>
+          <p:nvPr/>
+        </p:nvSpPr>
+        <p:spPr>
+          <a:xfrm xmlns:a="http://schemas.openxmlformats.org/drawingml/2006/main">
+            <a:off x="819150" y="1533525"/>
+            <a:ext cx="13525500" cy="781050"/>
+          </a:xfrm>
+          <a:prstGeom xmlns:a="http://schemas.openxmlformats.org/drawingml/2006/main" prst="rect">
+            <a:avLst/>
+          </a:prstGeom>
+          <a:noFill xmlns:a="http://schemas.openxmlformats.org/drawingml/2006/main"/>
+          <a:ln xmlns:a="http://schemas.openxmlformats.org/drawingml/2006/main" w="0">
+            <a:noFill/>
+          </a:ln>
+        </p:spPr>
+        <p:txBody>
+          <a:bodyPr xmlns:a="http://schemas.openxmlformats.org/drawingml/2006/main" wrap="square" lIns="0" tIns="0" rIns="0" bIns="0">
+            <a:noAutofit/>
+          </a:bodyPr>
+          <a:lstStyle xmlns:a="http://schemas.openxmlformats.org/drawingml/2006/main"/>
+          <a:p xmlns:a="http://schemas.openxmlformats.org/drawingml/2006/main">
+            <a:pPr>
+              <a:defRPr sz="2100" b="0">
+                <a:solidFill>
+                  <a:srgbClr val="5E706B"/>
+                </a:solidFill>
+                <a:latin typeface="Apple SD Gothic Neo"/>
+                <a:ea typeface="Apple SD Gothic Neo"/>
+                <a:cs typeface="Apple SD Gothic Neo"/>
+              </a:defRPr>
+            </a:pPr>
+            <a:r>
+              <a:rPr sz="2100" b="0">
+                <a:solidFill>
+                  <a:srgbClr val="5E706B"/>
+                </a:solidFill>
+                <a:latin typeface="Apple SD Gothic Neo"/>
+                <a:ea typeface="Apple SD Gothic Neo"/>
+                <a:cs typeface="Apple SD Gothic Neo"/>
+              </a:rPr>
+              <a:t>관세 후보 선택의 처리시간과 품질을 따로 측정했습니다.</a:t>
+            </a:r>
+          </a:p>
+        </p:txBody>
+      </p:sp>
+      <p:sp>
+        <p:nvSpPr>
+          <p:cNvPr id="3" name="">
+            <a:extLst xmlns:a="http://schemas.openxmlformats.org/drawingml/2006/main">
+              <a:ext uri="{FF2B5EF4-FFF2-40B4-BE49-F238E27FC236}">
+                <a16:creationId xmlns:a16="http://schemas.microsoft.com/office/drawing/2014/main" id="{C57488CA-0878-4414-A0DC-BE367E4438A7}"/>
+              </a:ext>
+            </a:extLst>
+          </p:cNvPr>
+          <p:cNvSpPr>
+            <a:spLocks xmlns:a="http://schemas.openxmlformats.org/drawingml/2006/main" noGrp="1"/>
+          </p:cNvSpPr>
+          <p:nvPr/>
+        </p:nvSpPr>
+        <p:spPr>
+          <a:xfrm xmlns:a="http://schemas.openxmlformats.org/drawingml/2006/main">
+            <a:off x="819150" y="8058150"/>
+            <a:ext cx="13620750" cy="285750"/>
+          </a:xfrm>
+          <a:prstGeom xmlns:a="http://schemas.openxmlformats.org/drawingml/2006/main" prst="rect">
+            <a:avLst/>
+          </a:prstGeom>
+          <a:noFill xmlns:a="http://schemas.openxmlformats.org/drawingml/2006/main"/>
+          <a:ln xmlns:a="http://schemas.openxmlformats.org/drawingml/2006/main" w="0">
+            <a:noFill/>
+          </a:ln>
+        </p:spPr>
+        <p:txBody>
+          <a:bodyPr xmlns:a="http://schemas.openxmlformats.org/drawingml/2006/main" wrap="square" lIns="0" tIns="0" rIns="0" bIns="0">
+            <a:noAutofit/>
+          </a:bodyPr>
+          <a:lstStyle xmlns:a="http://schemas.openxmlformats.org/drawingml/2006/main"/>
+          <a:p xmlns:a="http://schemas.openxmlformats.org/drawingml/2006/main">
+            <a:pPr>
+              <a:defRPr sz="1350" b="0">
+                <a:solidFill>
+                  <a:srgbClr val="5E706B"/>
+                </a:solidFill>
+                <a:latin typeface="Apple SD Gothic Neo"/>
+                <a:ea typeface="Apple SD Gothic Neo"/>
+                <a:cs typeface="Apple SD Gothic Neo"/>
+              </a:defRPr>
+            </a:pPr>
+            <a:r>
+              <a:rPr sz="1350" b="0">
+                <a:solidFill>
+                  <a:srgbClr val="5E706B"/>
+                </a:solidFill>
+                <a:latin typeface="Apple SD Gothic Neo"/>
+                <a:ea typeface="Apple SD Gothic Neo"/>
+                <a:cs typeface="Apple SD Gothic Neo"/>
+              </a:rPr>
+              <a:t>16   윤장한 · 직구 조사와 도구 구현 · 부록 · 2026.10.06</a:t>
+            </a:r>
+          </a:p>
+        </p:txBody>
+      </p:sp>
+      <p:sp>
+        <p:nvSpPr>
+          <p:cNvPr id="4" name="">
+            <a:extLst xmlns:a="http://schemas.openxmlformats.org/drawingml/2006/main">
+              <a:ext uri="{FF2B5EF4-FFF2-40B4-BE49-F238E27FC236}">
+                <a16:creationId xmlns:a16="http://schemas.microsoft.com/office/drawing/2014/main" id="{C3F5F128-AC86-473A-B614-3C28D06784FF}"/>
+              </a:ext>
+            </a:extLst>
+          </p:cNvPr>
+          <p:cNvSpPr>
+            <a:spLocks xmlns:a="http://schemas.openxmlformats.org/drawingml/2006/main" noGrp="1"/>
+          </p:cNvSpPr>
+          <p:nvPr/>
+        </p:nvSpPr>
+        <p:spPr>
+          <a:xfrm xmlns:a="http://schemas.openxmlformats.org/drawingml/2006/main">
+            <a:off x="819150" y="2638425"/>
+            <a:ext cx="13525500" cy="1095375"/>
+          </a:xfrm>
+          <a:prstGeom xmlns:a="http://schemas.openxmlformats.org/drawingml/2006/main" prst="rect">
+            <a:avLst/>
+          </a:prstGeom>
+          <a:noFill xmlns:a="http://schemas.openxmlformats.org/drawingml/2006/main"/>
+          <a:ln xmlns:a="http://schemas.openxmlformats.org/drawingml/2006/main" w="0">
+            <a:noFill/>
+          </a:ln>
+        </p:spPr>
+        <p:txBody>
+          <a:bodyPr xmlns:a="http://schemas.openxmlformats.org/drawingml/2006/main" wrap="square" lIns="0" tIns="0" rIns="0" bIns="0">
+            <a:noAutofit/>
+          </a:bodyPr>
+          <a:lstStyle xmlns:a="http://schemas.openxmlformats.org/drawingml/2006/main"/>
+          <a:p xmlns:a="http://schemas.openxmlformats.org/drawingml/2006/main">
+            <a:pPr>
+              <a:defRPr sz="2475" b="0">
+                <a:solidFill>
+                  <a:srgbClr val="182C29"/>
+                </a:solidFill>
+                <a:latin typeface="Apple SD Gothic Neo"/>
+                <a:ea typeface="Apple SD Gothic Neo"/>
+                <a:cs typeface="Apple SD Gothic Neo"/>
+              </a:defRPr>
+            </a:pPr>
+            <a:r>
+              <a:rPr sz="2475" b="0">
+                <a:solidFill>
+                  <a:srgbClr val="182C29"/>
+                </a:solidFill>
+                <a:latin typeface="Apple SD Gothic Neo"/>
+                <a:ea typeface="Apple SD Gothic Neo"/>
+                <a:cs typeface="Apple SD Gothic Neo"/>
+              </a:rPr>
+              <a:t>문장을 생성하는 LLM과, 정해진 후보·확률을 반환하는 Jev를 비교했습니다.</a:t>
+            </a:r>
+          </a:p>
+          <a:p xmlns:a="http://schemas.openxmlformats.org/drawingml/2006/main">
+            <a:pPr>
+              <a:defRPr sz="2475" b="0">
+                <a:solidFill>
+                  <a:srgbClr val="182C29"/>
+                </a:solidFill>
+                <a:latin typeface="Apple SD Gothic Neo"/>
+                <a:ea typeface="Apple SD Gothic Neo"/>
+                <a:cs typeface="Apple SD Gothic Neo"/>
+              </a:defRPr>
+            </a:pPr>
+            <a:r>
+              <a:rPr sz="2475" b="0">
+                <a:solidFill>
+                  <a:srgbClr val="182C29"/>
+                </a:solidFill>
+                <a:latin typeface="Apple SD Gothic Neo"/>
+                <a:ea typeface="Apple SD Gothic Neo"/>
+                <a:cs typeface="Apple SD Gothic Neo"/>
+              </a:rPr>
+              <a:t>상품 입력과 공식 HS 목록을 동일하게 제공해 2→4→6자리 경로를 선택했습니다.</a:t>
+            </a:r>
+          </a:p>
+        </p:txBody>
+      </p:sp>
+      <p:graphicFrame>
+        <p:nvGraphicFramePr>
+          <p:cNvPr id="12" name=""/>
+          <p:cNvGraphicFramePr/>
+          <p:nvPr/>
+        </p:nvGraphicFramePr>
+        <p:xfrm>
+          <a:off xmlns:a="http://schemas.openxmlformats.org/drawingml/2006/main" x="819150" y="4124325"/>
+          <a:ext xmlns:a="http://schemas.openxmlformats.org/drawingml/2006/main" cx="13601700" cy="2266950"/>
+        </p:xfrm>
+        <a:graphic xmlns:a="http://schemas.openxmlformats.org/drawingml/2006/main">
+          <a:graphicData uri="http://schemas.openxmlformats.org/drawingml/2006/table">
+            <a:tbl>
+              <a:tblPr/>
+              <a:tblGrid>
+                <a:gridCol w="3048000"/>
+                <a:gridCol w="4238625"/>
+                <a:gridCol w="6315075"/>
+              </a:tblGrid>
+              <a:tr h="755650">
+                <a:tc>
+                  <a:txBody>
+                    <a:bodyPr/>
+                    <a:lstStyle/>
+                    <a:p>
+                      <a:r>
+                        <a:rPr sz="2025" b="1">
+                          <a:solidFill>
+                            <a:srgbClr val="FFFFFF"/>
+                          </a:solidFill>
+                          <a:latin typeface="Apple SD Gothic Neo"/>
+                          <a:ea typeface="Apple SD Gothic Neo"/>
+                          <a:cs typeface="Apple SD Gothic Neo"/>
+                        </a:rPr>
+                        <a:t>데이터</a:t>
+                      </a:r>
+                    </a:p>
+                  </a:txBody>
+                  <a:tcPr marL="91440" marR="91440" marT="45720" marB="45720">
+                    <a:solidFill>
+                      <a:srgbClr val="182C29"/>
+                    </a:solidFill>
+                  </a:tcPr>
+                </a:tc>
+                <a:tc>
+                  <a:txBody>
+                    <a:bodyPr/>
+                    <a:lstStyle/>
+                    <a:p>
+                      <a:r>
+                        <a:rPr sz="2025" b="1">
+                          <a:solidFill>
+                            <a:srgbClr val="FFFFFF"/>
+                          </a:solidFill>
+                          <a:latin typeface="Apple SD Gothic Neo"/>
+                          <a:ea typeface="Apple SD Gothic Neo"/>
+                          <a:cs typeface="Apple SD Gothic Neo"/>
+                        </a:rPr>
+                        <a:t>실행 범위</a:t>
+                      </a:r>
+                    </a:p>
+                  </a:txBody>
+                  <a:tcPr marL="91440" marR="91440" marT="45720" marB="45720">
+                    <a:solidFill>
+                      <a:srgbClr val="182C29"/>
+                    </a:solidFill>
+                  </a:tcPr>
+                </a:tc>
+                <a:tc>
+                  <a:txBody>
+                    <a:bodyPr/>
+                    <a:lstStyle/>
+                    <a:p>
+                      <a:r>
+                        <a:rPr sz="2025" b="1">
+                          <a:solidFill>
+                            <a:srgbClr val="FFFFFF"/>
+                          </a:solidFill>
+                          <a:latin typeface="Apple SD Gothic Neo"/>
+                          <a:ea typeface="Apple SD Gothic Neo"/>
+                          <a:cs typeface="Apple SD Gothic Neo"/>
+                        </a:rPr>
+                        <a:t>품질 평가 기준</a:t>
+                      </a:r>
+                    </a:p>
+                  </a:txBody>
+                  <a:tcPr marL="91440" marR="91440" marT="45720" marB="45720">
+                    <a:solidFill>
+                      <a:srgbClr val="182C29"/>
+                    </a:solidFill>
+                  </a:tcPr>
+                </a:tc>
+              </a:tr>
+              <a:tr h="755650">
+                <a:tc>
+                  <a:txBody>
+                    <a:bodyPr/>
+                    <a:lstStyle/>
+                    <a:p>
+                      <a:r>
+                        <a:rPr sz="2175" b="0">
+                          <a:solidFill>
+                            <a:srgbClr val="182C29"/>
+                          </a:solidFill>
+                          <a:latin typeface="Apple SD Gothic Neo"/>
+                          <a:ea typeface="Apple SD Gothic Neo"/>
+                          <a:cs typeface="Apple SD Gothic Neo"/>
+                        </a:rPr>
+                        <a:t>HSCodeComp</a:t>
+                      </a:r>
+                    </a:p>
+                  </a:txBody>
+                  <a:tcPr marL="91440" marR="91440" marT="45720" marB="45720">
+                    <a:solidFill>
+                      <a:srgbClr val="FFFFFF"/>
+                    </a:solidFill>
+                  </a:tcPr>
+                </a:tc>
+                <a:tc>
+                  <a:txBody>
+                    <a:bodyPr/>
+                    <a:lstStyle/>
+                    <a:p>
+                      <a:r>
+                        <a:rPr sz="2175" b="0">
+                          <a:solidFill>
+                            <a:srgbClr val="182C29"/>
+                          </a:solidFill>
+                          <a:latin typeface="Apple SD Gothic Neo"/>
+                          <a:ea typeface="Apple SD Gothic Neo"/>
+                          <a:cs typeface="Apple SD Gothic Neo"/>
+                        </a:rPr>
+                        <a:t>94개 층화 표본 / 전체632개</a:t>
+                      </a:r>
+                    </a:p>
+                  </a:txBody>
+                  <a:tcPr marL="91440" marR="91440" marT="45720" marB="45720">
+                    <a:solidFill>
+                      <a:srgbClr val="FFFFFF"/>
+                    </a:solidFill>
+                  </a:tcPr>
+                </a:tc>
+                <a:tc>
+                  <a:txBody>
+                    <a:bodyPr/>
+                    <a:lstStyle/>
+                    <a:p>
+                      <a:r>
+                        <a:rPr sz="2175" b="0">
+                          <a:solidFill>
+                            <a:srgbClr val="182C29"/>
+                          </a:solidFill>
+                          <a:latin typeface="Apple SD Gothic Neo"/>
+                          <a:ea typeface="Apple SD Gothic Neo"/>
+                          <a:cs typeface="Apple SD Gothic Neo"/>
+                        </a:rPr>
+                        <a:t>공개 전문가 라벨과 HS6 일치</a:t>
+                      </a:r>
+                    </a:p>
+                  </a:txBody>
+                  <a:tcPr marL="91440" marR="91440" marT="45720" marB="45720">
+                    <a:solidFill>
+                      <a:srgbClr val="FFFFFF"/>
+                    </a:solidFill>
+                  </a:tcPr>
+                </a:tc>
+              </a:tr>
+              <a:tr h="755650">
+                <a:tc>
+                  <a:txBody>
+                    <a:bodyPr/>
+                    <a:lstStyle/>
+                    <a:p>
+                      <a:r>
+                        <a:rPr sz="2175" b="0">
+                          <a:solidFill>
+                            <a:srgbClr val="182C29"/>
+                          </a:solidFill>
+                          <a:latin typeface="Apple SD Gothic Neo"/>
+                          <a:ea typeface="Apple SD Gothic Neo"/>
+                          <a:cs typeface="Apple SD Gothic Neo"/>
+                        </a:rPr>
+                        <a:t>메루카리</a:t>
+                      </a:r>
+                    </a:p>
+                  </a:txBody>
+                  <a:tcPr marL="91440" marR="91440" marT="45720" marB="45720">
+                    <a:solidFill>
+                      <a:srgbClr val="F8F8F3"/>
+                    </a:solidFill>
+                  </a:tcPr>
+                </a:tc>
+                <a:tc>
+                  <a:txBody>
+                    <a:bodyPr/>
+                    <a:lstStyle/>
+                    <a:p>
+                      <a:r>
+                        <a:rPr sz="2175" b="0">
+                          <a:solidFill>
+                            <a:srgbClr val="182C29"/>
+                          </a:solidFill>
+                          <a:latin typeface="Apple SD Gothic Neo"/>
+                          <a:ea typeface="Apple SD Gothic Neo"/>
+                          <a:cs typeface="Apple SD Gothic Neo"/>
+                        </a:rPr>
+                        <a:t>실제 판매글30개 전체</a:t>
+                      </a:r>
+                    </a:p>
+                  </a:txBody>
+                  <a:tcPr marL="91440" marR="91440" marT="45720" marB="45720">
+                    <a:solidFill>
+                      <a:srgbClr val="F8F8F3"/>
+                    </a:solidFill>
+                  </a:tcPr>
+                </a:tc>
+                <a:tc>
+                  <a:txBody>
+                    <a:bodyPr/>
+                    <a:lstStyle/>
+                    <a:p>
+                      <a:r>
+                        <a:rPr sz="2175" b="0">
+                          <a:solidFill>
+                            <a:srgbClr val="182C29"/>
+                          </a:solidFill>
+                          <a:latin typeface="Apple SD Gothic Neo"/>
+                          <a:ea typeface="Apple SD Gothic Neo"/>
+                          <a:cs typeface="Apple SD Gothic Neo"/>
+                        </a:rPr>
+                        <a:t>독립 GPT-6 Sol 심사 결과와 일치</a:t>
+                      </a:r>
+                    </a:p>
+                  </a:txBody>
+                  <a:tcPr marL="91440" marR="91440" marT="45720" marB="45720">
+                    <a:solidFill>
+                      <a:srgbClr val="F8F8F3"/>
+                    </a:solidFill>
+                  </a:tcPr>
+                </a:tc>
+              </a:tr>
+            </a:tbl>
+          </a:graphicData>
+        </a:graphic>
+      </p:graphicFrame>
+      <p:sp>
+        <p:nvSpPr>
+          <p:cNvPr id="6" name="">
+            <a:extLst xmlns:a="http://schemas.openxmlformats.org/drawingml/2006/main">
+              <a:ext uri="{FF2B5EF4-FFF2-40B4-BE49-F238E27FC236}">
+                <a16:creationId xmlns:a16="http://schemas.microsoft.com/office/drawing/2014/main" id="{FFEE9D22-BAD4-4A19-979B-E83025455E69}"/>
+              </a:ext>
+            </a:extLst>
+          </p:cNvPr>
+          <p:cNvSpPr>
+            <a:spLocks xmlns:a="http://schemas.openxmlformats.org/drawingml/2006/main" noGrp="1"/>
+          </p:cNvSpPr>
+          <p:nvPr/>
+        </p:nvSpPr>
+        <p:spPr>
+          <a:xfrm xmlns:a="http://schemas.openxmlformats.org/drawingml/2006/main">
+            <a:off x="819150" y="6810375"/>
+            <a:ext cx="13525500" cy="571500"/>
+          </a:xfrm>
+          <a:prstGeom xmlns:a="http://schemas.openxmlformats.org/drawingml/2006/main" prst="rect">
+            <a:avLst/>
+          </a:prstGeom>
+          <a:noFill xmlns:a="http://schemas.openxmlformats.org/drawingml/2006/main"/>
+          <a:ln xmlns:a="http://schemas.openxmlformats.org/drawingml/2006/main" w="0">
+            <a:noFill/>
+          </a:ln>
+        </p:spPr>
+        <p:txBody>
+          <a:bodyPr xmlns:a="http://schemas.openxmlformats.org/drawingml/2006/main" wrap="square" lIns="0" tIns="0" rIns="0" bIns="0">
+            <a:noAutofit/>
+          </a:bodyPr>
+          <a:lstStyle xmlns:a="http://schemas.openxmlformats.org/drawingml/2006/main"/>
+          <a:p xmlns:a="http://schemas.openxmlformats.org/drawingml/2006/main">
+            <a:pPr>
+              <a:defRPr sz="2025" b="0">
+                <a:solidFill>
+                  <a:srgbClr val="182C29"/>
+                </a:solidFill>
+                <a:latin typeface="Apple SD Gothic Neo"/>
+                <a:ea typeface="Apple SD Gothic Neo"/>
+                <a:cs typeface="Apple SD Gothic Neo"/>
+              </a:defRPr>
+            </a:pPr>
+            <a:r>
+              <a:rPr sz="2025" b="0">
+                <a:solidFill>
+                  <a:srgbClr val="182C29"/>
+                </a:solidFill>
+                <a:latin typeface="Apple SD Gothic Neo"/>
+                <a:ea typeface="Apple SD Gothic Neo"/>
+                <a:cs typeface="Apple SD Gothic Neo"/>
+              </a:rPr>
+              <a:t>비교: Jev 1.13 ↔ GPT-6 Luna low. 심사자는 기존 예측과 공급사 이름을 보지 않았습니다.</a:t>
+            </a:r>
+          </a:p>
+        </p:txBody>
+      </p:sp>
+      <p:sp>
+        <p:nvSpPr>
+          <p:cNvPr id="7" name="">
+            <a:extLst xmlns:a="http://schemas.openxmlformats.org/drawingml/2006/main">
+              <a:ext uri="{FF2B5EF4-FFF2-40B4-BE49-F238E27FC236}">
+                <a16:creationId xmlns:a16="http://schemas.microsoft.com/office/drawing/2014/main" id="{4D396F42-9085-4613-962A-A2E6EC17D4F0}"/>
+              </a:ext>
+            </a:extLst>
+          </p:cNvPr>
+          <p:cNvSpPr>
+            <a:spLocks xmlns:a="http://schemas.openxmlformats.org/drawingml/2006/main" noGrp="1"/>
+          </p:cNvSpPr>
+          <p:nvPr/>
+        </p:nvSpPr>
+        <p:spPr>
+          <a:xfrm xmlns:a="http://schemas.openxmlformats.org/drawingml/2006/main">
+            <a:off x="819150" y="7524750"/>
+            <a:ext cx="13525500" cy="342900"/>
+          </a:xfrm>
+          <a:prstGeom xmlns:a="http://schemas.openxmlformats.org/drawingml/2006/main" prst="rect">
+            <a:avLst/>
+          </a:prstGeom>
+          <a:noFill xmlns:a="http://schemas.openxmlformats.org/drawingml/2006/main"/>
+          <a:ln xmlns:a="http://schemas.openxmlformats.org/drawingml/2006/main" w="0">
+            <a:noFill/>
+          </a:ln>
+        </p:spPr>
+        <p:txBody>
+          <a:bodyPr xmlns:a="http://schemas.openxmlformats.org/drawingml/2006/main" wrap="square" lIns="0" tIns="0" rIns="0" bIns="0">
+            <a:noAutofit/>
+          </a:bodyPr>
+          <a:lstStyle xmlns:a="http://schemas.openxmlformats.org/drawingml/2006/main"/>
+          <a:p xmlns:a="http://schemas.openxmlformats.org/drawingml/2006/main">
+            <a:pPr>
+              <a:defRPr sz="1725" b="0">
+                <a:solidFill>
+                  <a:srgbClr val="5E706B"/>
+                </a:solidFill>
+                <a:latin typeface="Apple SD Gothic Neo"/>
+                <a:ea typeface="Apple SD Gothic Neo"/>
+                <a:cs typeface="Apple SD Gothic Neo"/>
+              </a:defRPr>
+            </a:pPr>
+            <a:r>
+              <a:rPr sz="1725" b="0">
+                <a:solidFill>
+                  <a:srgbClr val="5E706B"/>
+                </a:solidFill>
+                <a:latin typeface="Apple SD Gothic Neo"/>
+                <a:ea typeface="Apple SD Gothic Neo"/>
+                <a:cs typeface="Apple SD Gothic Neo"/>
+              </a:rPr>
+              <a:t>텍스트만 사용한 단일 경로 실험입니다. 웹 검색·이미지 분석·정답으로 후보 축소는 하지 않았습니다.</a:t>
+            </a:r>
+          </a:p>
+        </p:txBody>
+      </p:sp>
+    </p:spTree>
+    <p:extLst>
+      <p:ext uri="{BB962C8B-B14F-4D97-AF65-F5344CB8AC3E}">
+        <p14:creationId xmlns:p14="http://schemas.microsoft.com/office/powerpoint/2010/main" val="1928326010"/>
+      </p:ext>
+    </p:extLst>
+  </p:cSld>
+</p:sld>
+</file>
+
+<file path=ppt/slides/slide17.xml><?xml version="1.0" encoding="utf-8"?>
+<p:sld xmlns:p="http://schemas.openxmlformats.org/presentationml/2006/main">
+  <p:cSld>
+    <p:bg>
+      <p:bgPr>
+        <a:solidFill xmlns:a="http://schemas.openxmlformats.org/drawingml/2006/main">
+          <a:srgbClr val="F8F8F3"/>
+        </a:solidFill>
+      </p:bgPr>
+    </p:bg>
+    <p:spTree>
+      <p:nvGrpSpPr>
+        <p:cNvPr id="1" name=""/>
+        <p:cNvGrpSpPr/>
+        <p:nvPr/>
+      </p:nvGrpSpPr>
+      <p:grpSpPr>
+        <a:xfrm xmlns:a="http://schemas.openxmlformats.org/drawingml/2006/main"/>
+      </p:grpSpPr>
+      <p:sp>
+        <p:nvSpPr>
+          <p:cNvPr id="12" name="">
+            <a:extLst xmlns:a="http://schemas.openxmlformats.org/drawingml/2006/main">
+              <a:ext uri="{FF2B5EF4-FFF2-40B4-BE49-F238E27FC236}">
+                <a16:creationId xmlns:a16="http://schemas.microsoft.com/office/drawing/2014/main" id="{76AFBD16-BB63-40AD-A67C-25EBF9EE0FE8}"/>
+              </a:ext>
+            </a:extLst>
+          </p:cNvPr>
+          <p:cNvSpPr>
+            <a:spLocks xmlns:a="http://schemas.openxmlformats.org/drawingml/2006/main" noGrp="1"/>
+          </p:cNvSpPr>
+          <p:nvPr/>
+        </p:nvSpPr>
+        <p:spPr>
+          <a:xfrm xmlns:a="http://schemas.openxmlformats.org/drawingml/2006/main">
+            <a:off x="800100" y="609600"/>
+            <a:ext cx="13620750" cy="781050"/>
+          </a:xfrm>
+          <a:prstGeom xmlns:a="http://schemas.openxmlformats.org/drawingml/2006/main" prst="rect">
+            <a:avLst/>
+          </a:prstGeom>
+          <a:noFill xmlns:a="http://schemas.openxmlformats.org/drawingml/2006/main"/>
+          <a:ln xmlns:a="http://schemas.openxmlformats.org/drawingml/2006/main" w="0">
+            <a:noFill/>
+          </a:ln>
+        </p:spPr>
+        <p:txBody>
+          <a:bodyPr xmlns:a="http://schemas.openxmlformats.org/drawingml/2006/main" wrap="square" lIns="0" tIns="0" rIns="0" bIns="0">
+            <a:noAutofit/>
+          </a:bodyPr>
+          <a:lstStyle xmlns:a="http://schemas.openxmlformats.org/drawingml/2006/main"/>
+          <a:p xmlns:a="http://schemas.openxmlformats.org/drawingml/2006/main">
+            <a:pPr>
+              <a:defRPr sz="3675" b="1">
+                <a:solidFill>
+                  <a:srgbClr val="182C29"/>
+                </a:solidFill>
+                <a:latin typeface="Apple SD Gothic Neo"/>
+                <a:ea typeface="Apple SD Gothic Neo"/>
+                <a:cs typeface="Apple SD Gothic Neo"/>
+              </a:defRPr>
+            </a:pPr>
+            <a:r>
+              <a:rPr sz="3675" b="1">
+                <a:solidFill>
+                  <a:srgbClr val="182C29"/>
+                </a:solidFill>
+                <a:latin typeface="Apple SD Gothic Neo"/>
+                <a:ea typeface="Apple SD Gothic Neo"/>
+                <a:cs typeface="Apple SD Gothic Neo"/>
+              </a:rPr>
+              <a:t>HS 후보 판단시간을 5~6배 줄였습니다</a:t>
+            </a:r>
+          </a:p>
+        </p:txBody>
+      </p:sp>
+      <p:sp>
+        <p:nvSpPr>
+          <p:cNvPr id="2" name="">
+            <a:extLst xmlns:a="http://schemas.openxmlformats.org/drawingml/2006/main">
+              <a:ext uri="{FF2B5EF4-FFF2-40B4-BE49-F238E27FC236}">
+                <a16:creationId xmlns:a16="http://schemas.microsoft.com/office/drawing/2014/main" id="{811E44A2-D536-469D-98DF-20510C7E28F6}"/>
+              </a:ext>
+            </a:extLst>
+          </p:cNvPr>
+          <p:cNvSpPr>
+            <a:spLocks xmlns:a="http://schemas.openxmlformats.org/drawingml/2006/main" noGrp="1"/>
+          </p:cNvSpPr>
+          <p:nvPr/>
+        </p:nvSpPr>
+        <p:spPr>
+          <a:xfrm xmlns:a="http://schemas.openxmlformats.org/drawingml/2006/main">
+            <a:off x="819150" y="1533525"/>
+            <a:ext cx="13525500" cy="781050"/>
+          </a:xfrm>
+          <a:prstGeom xmlns:a="http://schemas.openxmlformats.org/drawingml/2006/main" prst="rect">
+            <a:avLst/>
+          </a:prstGeom>
+          <a:noFill xmlns:a="http://schemas.openxmlformats.org/drawingml/2006/main"/>
+          <a:ln xmlns:a="http://schemas.openxmlformats.org/drawingml/2006/main" w="0">
+            <a:noFill/>
+          </a:ln>
+        </p:spPr>
+        <p:txBody>
+          <a:bodyPr xmlns:a="http://schemas.openxmlformats.org/drawingml/2006/main" wrap="square" lIns="0" tIns="0" rIns="0" bIns="0">
+            <a:noAutofit/>
+          </a:bodyPr>
+          <a:lstStyle xmlns:a="http://schemas.openxmlformats.org/drawingml/2006/main"/>
+          <a:p xmlns:a="http://schemas.openxmlformats.org/drawingml/2006/main">
+            <a:pPr>
+              <a:defRPr sz="2100" b="0">
+                <a:solidFill>
+                  <a:srgbClr val="5E706B"/>
+                </a:solidFill>
+                <a:latin typeface="Apple SD Gothic Neo"/>
+                <a:ea typeface="Apple SD Gothic Neo"/>
+                <a:cs typeface="Apple SD Gothic Neo"/>
+              </a:defRPr>
+            </a:pPr>
+            <a:r>
+              <a:rPr sz="2100" b="0">
+                <a:solidFill>
+                  <a:srgbClr val="5E706B"/>
+                </a:solidFill>
+                <a:latin typeface="Apple SD Gothic Neo"/>
+                <a:ea typeface="Apple SD Gothic Neo"/>
+                <a:cs typeface="Apple SD Gothic Neo"/>
+              </a:rPr>
+              <a:t>동일한 입력에서 Jev의 중앙 처리시간과 추정 비용이 더 낮았습니다.</a:t>
+            </a:r>
+          </a:p>
+        </p:txBody>
+      </p:sp>
+      <p:sp>
+        <p:nvSpPr>
+          <p:cNvPr id="3" name="">
+            <a:extLst xmlns:a="http://schemas.openxmlformats.org/drawingml/2006/main">
+              <a:ext uri="{FF2B5EF4-FFF2-40B4-BE49-F238E27FC236}">
+                <a16:creationId xmlns:a16="http://schemas.microsoft.com/office/drawing/2014/main" id="{E58BD48B-AC29-45F2-A860-07B1D6838A80}"/>
+              </a:ext>
+            </a:extLst>
+          </p:cNvPr>
+          <p:cNvSpPr>
+            <a:spLocks xmlns:a="http://schemas.openxmlformats.org/drawingml/2006/main" noGrp="1"/>
+          </p:cNvSpPr>
+          <p:nvPr/>
+        </p:nvSpPr>
+        <p:spPr>
+          <a:xfrm xmlns:a="http://schemas.openxmlformats.org/drawingml/2006/main">
+            <a:off x="819150" y="8058150"/>
+            <a:ext cx="13620750" cy="285750"/>
+          </a:xfrm>
+          <a:prstGeom xmlns:a="http://schemas.openxmlformats.org/drawingml/2006/main" prst="rect">
+            <a:avLst/>
+          </a:prstGeom>
+          <a:noFill xmlns:a="http://schemas.openxmlformats.org/drawingml/2006/main"/>
+          <a:ln xmlns:a="http://schemas.openxmlformats.org/drawingml/2006/main" w="0">
+            <a:noFill/>
+          </a:ln>
+        </p:spPr>
+        <p:txBody>
+          <a:bodyPr xmlns:a="http://schemas.openxmlformats.org/drawingml/2006/main" wrap="square" lIns="0" tIns="0" rIns="0" bIns="0">
+            <a:noAutofit/>
+          </a:bodyPr>
+          <a:lstStyle xmlns:a="http://schemas.openxmlformats.org/drawingml/2006/main"/>
+          <a:p xmlns:a="http://schemas.openxmlformats.org/drawingml/2006/main">
+            <a:pPr>
+              <a:defRPr sz="1350" b="0">
+                <a:solidFill>
+                  <a:srgbClr val="5E706B"/>
+                </a:solidFill>
+                <a:latin typeface="Apple SD Gothic Neo"/>
+                <a:ea typeface="Apple SD Gothic Neo"/>
+                <a:cs typeface="Apple SD Gothic Neo"/>
+              </a:defRPr>
+            </a:pPr>
+            <a:r>
+              <a:rPr sz="1350" b="0">
+                <a:solidFill>
+                  <a:srgbClr val="5E706B"/>
+                </a:solidFill>
+                <a:latin typeface="Apple SD Gothic Neo"/>
+                <a:ea typeface="Apple SD Gothic Neo"/>
+                <a:cs typeface="Apple SD Gothic Neo"/>
+              </a:rPr>
+              <a:t>17   윤장한 · 직구 조사와 도구 구현 · 부록 · 2026.10.06</a:t>
+            </a:r>
+          </a:p>
+        </p:txBody>
+      </p:sp>
+      <p:graphicFrame>
+        <p:nvGraphicFramePr>
+          <p:cNvPr id="15" name="Chart"/>
+          <p:cNvGraphicFramePr/>
+          <p:nvPr/>
+        </p:nvGraphicFramePr>
+        <p:xfrm>
+          <a:off xmlns:a="http://schemas.openxmlformats.org/drawingml/2006/main" x="819150" y="2647950"/>
+          <a:ext xmlns:a="http://schemas.openxmlformats.org/drawingml/2006/main" cx="8715375" cy="4000500"/>
+        </p:xfrm>
+        <a:graphic xmlns:a="http://schemas.openxmlformats.org/drawingml/2006/main">
+          <a:graphicData uri="http://schemas.openxmlformats.org/drawingml/2006/chart">
+            <c:chart xmlns:r="http://schemas.openxmlformats.org/officeDocument/2006/relationships" xmlns:c="http://schemas.openxmlformats.org/drawingml/2006/chart" r:id="Rf3f219ec14d3420b"/>
+          </a:graphicData>
+        </a:graphic>
+      </p:graphicFrame>
+      <p:sp>
+        <p:nvSpPr>
+          <p:cNvPr id="5" name="">
+            <a:extLst xmlns:a="http://schemas.openxmlformats.org/drawingml/2006/main">
+              <a:ext uri="{FF2B5EF4-FFF2-40B4-BE49-F238E27FC236}">
+                <a16:creationId xmlns:a16="http://schemas.microsoft.com/office/drawing/2014/main" id="{904456F5-EC6A-4EC9-B4F5-432C07FB1370}"/>
+              </a:ext>
+            </a:extLst>
+          </p:cNvPr>
+          <p:cNvSpPr>
+            <a:spLocks xmlns:a="http://schemas.openxmlformats.org/drawingml/2006/main" noGrp="1"/>
+          </p:cNvSpPr>
+          <p:nvPr/>
+        </p:nvSpPr>
+        <p:spPr>
+          <a:xfrm xmlns:a="http://schemas.openxmlformats.org/drawingml/2006/main">
+            <a:off x="10287000" y="2781300"/>
+            <a:ext cx="4000500" cy="476250"/>
+          </a:xfrm>
+          <a:prstGeom xmlns:a="http://schemas.openxmlformats.org/drawingml/2006/main" prst="rect">
+            <a:avLst/>
+          </a:prstGeom>
+          <a:noFill xmlns:a="http://schemas.openxmlformats.org/drawingml/2006/main"/>
+          <a:ln xmlns:a="http://schemas.openxmlformats.org/drawingml/2006/main" w="0">
+            <a:noFill/>
+          </a:ln>
+        </p:spPr>
+        <p:txBody>
+          <a:bodyPr xmlns:a="http://schemas.openxmlformats.org/drawingml/2006/main" wrap="square" lIns="0" tIns="0" rIns="0" bIns="0">
+            <a:noAutofit/>
+          </a:bodyPr>
+          <a:lstStyle xmlns:a="http://schemas.openxmlformats.org/drawingml/2006/main"/>
+          <a:p xmlns:a="http://schemas.openxmlformats.org/drawingml/2006/main">
+            <a:pPr>
+              <a:defRPr sz="2400" b="1">
+                <a:solidFill>
+                  <a:srgbClr val="156E58"/>
+                </a:solidFill>
+                <a:latin typeface="Apple SD Gothic Neo"/>
+                <a:ea typeface="Apple SD Gothic Neo"/>
+                <a:cs typeface="Apple SD Gothic Neo"/>
+              </a:defRPr>
+            </a:pPr>
+            <a:r>
+              <a:rPr sz="2400" b="1">
+                <a:solidFill>
+                  <a:srgbClr val="156E58"/>
+                </a:solidFill>
+                <a:latin typeface="Apple SD Gothic Neo"/>
+                <a:ea typeface="Apple SD Gothic Neo"/>
+                <a:cs typeface="Apple SD Gothic Neo"/>
+              </a:rPr>
+              <a:t>HF 표본</a:t>
+            </a:r>
+          </a:p>
+        </p:txBody>
+      </p:sp>
+      <p:sp>
+        <p:nvSpPr>
+          <p:cNvPr id="6" name="">
+            <a:extLst xmlns:a="http://schemas.openxmlformats.org/drawingml/2006/main">
+              <a:ext uri="{FF2B5EF4-FFF2-40B4-BE49-F238E27FC236}">
+                <a16:creationId xmlns:a16="http://schemas.microsoft.com/office/drawing/2014/main" id="{476D8F6E-DA11-4B04-8FF1-8241BA08D036}"/>
+              </a:ext>
+            </a:extLst>
+          </p:cNvPr>
+          <p:cNvSpPr>
+            <a:spLocks xmlns:a="http://schemas.openxmlformats.org/drawingml/2006/main" noGrp="1"/>
+          </p:cNvSpPr>
+          <p:nvPr/>
+        </p:nvSpPr>
+        <p:spPr>
+          <a:xfrm xmlns:a="http://schemas.openxmlformats.org/drawingml/2006/main">
+            <a:off x="10287000" y="3371850"/>
+            <a:ext cx="4000500" cy="619125"/>
+          </a:xfrm>
+          <a:prstGeom xmlns:a="http://schemas.openxmlformats.org/drawingml/2006/main" prst="rect">
+            <a:avLst/>
+          </a:prstGeom>
+          <a:noFill xmlns:a="http://schemas.openxmlformats.org/drawingml/2006/main"/>
+          <a:ln xmlns:a="http://schemas.openxmlformats.org/drawingml/2006/main" w="0">
+            <a:noFill/>
+          </a:ln>
+        </p:spPr>
+        <p:txBody>
+          <a:bodyPr xmlns:a="http://schemas.openxmlformats.org/drawingml/2006/main" wrap="square" lIns="0" tIns="0" rIns="0" bIns="0">
+            <a:noAutofit/>
+          </a:bodyPr>
+          <a:lstStyle xmlns:a="http://schemas.openxmlformats.org/drawingml/2006/main"/>
+          <a:p xmlns:a="http://schemas.openxmlformats.org/drawingml/2006/main">
+            <a:pPr>
+              <a:defRPr sz="3150" b="1">
+                <a:solidFill>
+                  <a:srgbClr val="182C29"/>
+                </a:solidFill>
+                <a:latin typeface="Apple SD Gothic Neo"/>
+                <a:ea typeface="Apple SD Gothic Neo"/>
+                <a:cs typeface="Apple SD Gothic Neo"/>
+              </a:defRPr>
+            </a:pPr>
+            <a:r>
+              <a:rPr sz="3150" b="1">
+                <a:solidFill>
+                  <a:srgbClr val="182C29"/>
+                </a:solidFill>
+                <a:latin typeface="Apple SD Gothic Neo"/>
+                <a:ea typeface="Apple SD Gothic Neo"/>
+                <a:cs typeface="Apple SD Gothic Neo"/>
+              </a:rPr>
+              <a:t>6.4배 빠르게</a:t>
+            </a:r>
+          </a:p>
+        </p:txBody>
+      </p:sp>
+      <p:sp>
+        <p:nvSpPr>
+          <p:cNvPr id="7" name="">
+            <a:extLst xmlns:a="http://schemas.openxmlformats.org/drawingml/2006/main">
+              <a:ext uri="{FF2B5EF4-FFF2-40B4-BE49-F238E27FC236}">
+                <a16:creationId xmlns:a16="http://schemas.microsoft.com/office/drawing/2014/main" id="{A22D3943-DD8F-4BFC-A707-D7FAAAE682F2}"/>
+              </a:ext>
+            </a:extLst>
+          </p:cNvPr>
+          <p:cNvSpPr>
+            <a:spLocks xmlns:a="http://schemas.openxmlformats.org/drawingml/2006/main" noGrp="1"/>
+          </p:cNvSpPr>
+          <p:nvPr/>
+        </p:nvSpPr>
+        <p:spPr>
+          <a:xfrm xmlns:a="http://schemas.openxmlformats.org/drawingml/2006/main">
+            <a:off x="10287000" y="4086225"/>
+            <a:ext cx="4000500" cy="523875"/>
+          </a:xfrm>
+          <a:prstGeom xmlns:a="http://schemas.openxmlformats.org/drawingml/2006/main" prst="rect">
+            <a:avLst/>
+          </a:prstGeom>
+          <a:noFill xmlns:a="http://schemas.openxmlformats.org/drawingml/2006/main"/>
+          <a:ln xmlns:a="http://schemas.openxmlformats.org/drawingml/2006/main" w="0">
+            <a:noFill/>
+          </a:ln>
+        </p:spPr>
+        <p:txBody>
+          <a:bodyPr xmlns:a="http://schemas.openxmlformats.org/drawingml/2006/main" wrap="square" lIns="0" tIns="0" rIns="0" bIns="0">
+            <a:noAutofit/>
+          </a:bodyPr>
+          <a:lstStyle xmlns:a="http://schemas.openxmlformats.org/drawingml/2006/main"/>
+          <a:p xmlns:a="http://schemas.openxmlformats.org/drawingml/2006/main">
+            <a:pPr>
+              <a:defRPr sz="2100" b="0">
+                <a:solidFill>
+                  <a:srgbClr val="182C29"/>
+                </a:solidFill>
+                <a:latin typeface="Apple SD Gothic Neo"/>
+                <a:ea typeface="Apple SD Gothic Neo"/>
+                <a:cs typeface="Apple SD Gothic Neo"/>
+              </a:defRPr>
+            </a:pPr>
+            <a:r>
+              <a:rPr sz="2100" b="0">
+                <a:solidFill>
+                  <a:srgbClr val="182C29"/>
+                </a:solidFill>
+                <a:latin typeface="Apple SD Gothic Neo"/>
+                <a:ea typeface="Apple SD Gothic Neo"/>
+                <a:cs typeface="Apple SD Gothic Neo"/>
+              </a:rPr>
+              <a:t>추정 비용57.0% 감소</a:t>
+            </a:r>
+          </a:p>
+        </p:txBody>
+      </p:sp>
+      <p:sp>
+        <p:nvSpPr>
+          <p:cNvPr id="8" name="">
+            <a:extLst xmlns:a="http://schemas.openxmlformats.org/drawingml/2006/main">
+              <a:ext uri="{FF2B5EF4-FFF2-40B4-BE49-F238E27FC236}">
+                <a16:creationId xmlns:a16="http://schemas.microsoft.com/office/drawing/2014/main" id="{4945892D-3F47-4E7B-BC70-D5DCD05FA923}"/>
+              </a:ext>
+            </a:extLst>
+          </p:cNvPr>
+          <p:cNvSpPr>
+            <a:spLocks xmlns:a="http://schemas.openxmlformats.org/drawingml/2006/main" noGrp="1"/>
+          </p:cNvSpPr>
+          <p:nvPr/>
+        </p:nvSpPr>
+        <p:spPr>
+          <a:xfrm xmlns:a="http://schemas.openxmlformats.org/drawingml/2006/main">
+            <a:off x="10287000" y="4953000"/>
+            <a:ext cx="4000500" cy="476250"/>
+          </a:xfrm>
+          <a:prstGeom xmlns:a="http://schemas.openxmlformats.org/drawingml/2006/main" prst="rect">
+            <a:avLst/>
+          </a:prstGeom>
+          <a:noFill xmlns:a="http://schemas.openxmlformats.org/drawingml/2006/main"/>
+          <a:ln xmlns:a="http://schemas.openxmlformats.org/drawingml/2006/main" w="0">
+            <a:noFill/>
+          </a:ln>
+        </p:spPr>
+        <p:txBody>
+          <a:bodyPr xmlns:a="http://schemas.openxmlformats.org/drawingml/2006/main" wrap="square" lIns="0" tIns="0" rIns="0" bIns="0">
+            <a:noAutofit/>
+          </a:bodyPr>
+          <a:lstStyle xmlns:a="http://schemas.openxmlformats.org/drawingml/2006/main"/>
+          <a:p xmlns:a="http://schemas.openxmlformats.org/drawingml/2006/main">
+            <a:pPr>
+              <a:defRPr sz="2400" b="1">
+                <a:solidFill>
+                  <a:srgbClr val="156E58"/>
+                </a:solidFill>
+                <a:latin typeface="Apple SD Gothic Neo"/>
+                <a:ea typeface="Apple SD Gothic Neo"/>
+                <a:cs typeface="Apple SD Gothic Neo"/>
+              </a:defRPr>
+            </a:pPr>
+            <a:r>
+              <a:rPr sz="2400" b="1">
+                <a:solidFill>
+                  <a:srgbClr val="156E58"/>
+                </a:solidFill>
+                <a:latin typeface="Apple SD Gothic Neo"/>
+                <a:ea typeface="Apple SD Gothic Neo"/>
+                <a:cs typeface="Apple SD Gothic Neo"/>
+              </a:rPr>
+              <a:t>메루카리</a:t>
+            </a:r>
+          </a:p>
+        </p:txBody>
+      </p:sp>
+      <p:sp>
+        <p:nvSpPr>
+          <p:cNvPr id="9" name="">
+            <a:extLst xmlns:a="http://schemas.openxmlformats.org/drawingml/2006/main">
+              <a:ext uri="{FF2B5EF4-FFF2-40B4-BE49-F238E27FC236}">
+                <a16:creationId xmlns:a16="http://schemas.microsoft.com/office/drawing/2014/main" id="{1833C4A1-62AA-4EDC-A677-F0E4BE2AFFC6}"/>
+              </a:ext>
+            </a:extLst>
+          </p:cNvPr>
+          <p:cNvSpPr>
+            <a:spLocks xmlns:a="http://schemas.openxmlformats.org/drawingml/2006/main" noGrp="1"/>
+          </p:cNvSpPr>
+          <p:nvPr/>
+        </p:nvSpPr>
+        <p:spPr>
+          <a:xfrm xmlns:a="http://schemas.openxmlformats.org/drawingml/2006/main">
+            <a:off x="10287000" y="5543550"/>
+            <a:ext cx="4000500" cy="619125"/>
+          </a:xfrm>
+          <a:prstGeom xmlns:a="http://schemas.openxmlformats.org/drawingml/2006/main" prst="rect">
+            <a:avLst/>
+          </a:prstGeom>
+          <a:noFill xmlns:a="http://schemas.openxmlformats.org/drawingml/2006/main"/>
+          <a:ln xmlns:a="http://schemas.openxmlformats.org/drawingml/2006/main" w="0">
+            <a:noFill/>
+          </a:ln>
+        </p:spPr>
+        <p:txBody>
+          <a:bodyPr xmlns:a="http://schemas.openxmlformats.org/drawingml/2006/main" wrap="square" lIns="0" tIns="0" rIns="0" bIns="0">
+            <a:noAutofit/>
+          </a:bodyPr>
+          <a:lstStyle xmlns:a="http://schemas.openxmlformats.org/drawingml/2006/main"/>
+          <a:p xmlns:a="http://schemas.openxmlformats.org/drawingml/2006/main">
+            <a:pPr>
+              <a:defRPr sz="3150" b="1">
+                <a:solidFill>
+                  <a:srgbClr val="182C29"/>
+                </a:solidFill>
+                <a:latin typeface="Apple SD Gothic Neo"/>
+                <a:ea typeface="Apple SD Gothic Neo"/>
+                <a:cs typeface="Apple SD Gothic Neo"/>
+              </a:defRPr>
+            </a:pPr>
+            <a:r>
+              <a:rPr sz="3150" b="1">
+                <a:solidFill>
+                  <a:srgbClr val="182C29"/>
+                </a:solidFill>
+                <a:latin typeface="Apple SD Gothic Neo"/>
+                <a:ea typeface="Apple SD Gothic Neo"/>
+                <a:cs typeface="Apple SD Gothic Neo"/>
+              </a:rPr>
+              <a:t>5.7배 빠르게</a:t>
+            </a:r>
+          </a:p>
+        </p:txBody>
+      </p:sp>
+      <p:sp>
+        <p:nvSpPr>
+          <p:cNvPr id="10" name="">
+            <a:extLst xmlns:a="http://schemas.openxmlformats.org/drawingml/2006/main">
+              <a:ext uri="{FF2B5EF4-FFF2-40B4-BE49-F238E27FC236}">
+                <a16:creationId xmlns:a16="http://schemas.microsoft.com/office/drawing/2014/main" id="{E85F53D6-3058-4200-A49A-1E71C9BA66B9}"/>
+              </a:ext>
+            </a:extLst>
+          </p:cNvPr>
+          <p:cNvSpPr>
+            <a:spLocks xmlns:a="http://schemas.openxmlformats.org/drawingml/2006/main" noGrp="1"/>
+          </p:cNvSpPr>
+          <p:nvPr/>
+        </p:nvSpPr>
+        <p:spPr>
+          <a:xfrm xmlns:a="http://schemas.openxmlformats.org/drawingml/2006/main">
+            <a:off x="10287000" y="6257925"/>
+            <a:ext cx="4000500" cy="523875"/>
+          </a:xfrm>
+          <a:prstGeom xmlns:a="http://schemas.openxmlformats.org/drawingml/2006/main" prst="rect">
+            <a:avLst/>
+          </a:prstGeom>
+          <a:noFill xmlns:a="http://schemas.openxmlformats.org/drawingml/2006/main"/>
+          <a:ln xmlns:a="http://schemas.openxmlformats.org/drawingml/2006/main" w="0">
+            <a:noFill/>
+          </a:ln>
+        </p:spPr>
+        <p:txBody>
+          <a:bodyPr xmlns:a="http://schemas.openxmlformats.org/drawingml/2006/main" wrap="square" lIns="0" tIns="0" rIns="0" bIns="0">
+            <a:noAutofit/>
+          </a:bodyPr>
+          <a:lstStyle xmlns:a="http://schemas.openxmlformats.org/drawingml/2006/main"/>
+          <a:p xmlns:a="http://schemas.openxmlformats.org/drawingml/2006/main">
+            <a:pPr>
+              <a:defRPr sz="2100" b="0">
+                <a:solidFill>
+                  <a:srgbClr val="182C29"/>
+                </a:solidFill>
+                <a:latin typeface="Apple SD Gothic Neo"/>
+                <a:ea typeface="Apple SD Gothic Neo"/>
+                <a:cs typeface="Apple SD Gothic Neo"/>
+              </a:defRPr>
+            </a:pPr>
+            <a:r>
+              <a:rPr sz="2100" b="0">
+                <a:solidFill>
+                  <a:srgbClr val="182C29"/>
+                </a:solidFill>
+                <a:latin typeface="Apple SD Gothic Neo"/>
+                <a:ea typeface="Apple SD Gothic Neo"/>
+                <a:cs typeface="Apple SD Gothic Neo"/>
+              </a:rPr>
+              <a:t>추정 비용53.9% 감소</a:t>
+            </a:r>
+          </a:p>
+        </p:txBody>
+      </p:sp>
+      <p:sp>
+        <p:nvSpPr>
+          <p:cNvPr id="11" name="">
+            <a:extLst xmlns:a="http://schemas.openxmlformats.org/drawingml/2006/main">
+              <a:ext uri="{FF2B5EF4-FFF2-40B4-BE49-F238E27FC236}">
+                <a16:creationId xmlns:a16="http://schemas.microsoft.com/office/drawing/2014/main" id="{15120C3A-8949-40DB-8D2F-14A2E8DA50D6}"/>
+              </a:ext>
+            </a:extLst>
+          </p:cNvPr>
+          <p:cNvSpPr>
+            <a:spLocks xmlns:a="http://schemas.openxmlformats.org/drawingml/2006/main" noGrp="1"/>
+          </p:cNvSpPr>
+          <p:nvPr/>
+        </p:nvSpPr>
+        <p:spPr>
+          <a:xfrm xmlns:a="http://schemas.openxmlformats.org/drawingml/2006/main">
+            <a:off x="819150" y="7258050"/>
+            <a:ext cx="13525500" cy="381000"/>
+          </a:xfrm>
+          <a:prstGeom xmlns:a="http://schemas.openxmlformats.org/drawingml/2006/main" prst="rect">
+            <a:avLst/>
+          </a:prstGeom>
+          <a:noFill xmlns:a="http://schemas.openxmlformats.org/drawingml/2006/main"/>
+          <a:ln xmlns:a="http://schemas.openxmlformats.org/drawingml/2006/main" w="0">
+            <a:noFill/>
+          </a:ln>
+        </p:spPr>
+        <p:txBody>
+          <a:bodyPr xmlns:a="http://schemas.openxmlformats.org/drawingml/2006/main" wrap="square" lIns="0" tIns="0" rIns="0" bIns="0">
+            <a:noAutofit/>
+          </a:bodyPr>
+          <a:lstStyle xmlns:a="http://schemas.openxmlformats.org/drawingml/2006/main"/>
+          <a:p xmlns:a="http://schemas.openxmlformats.org/drawingml/2006/main">
+            <a:pPr>
+              <a:defRPr sz="1875" b="0">
+                <a:solidFill>
+                  <a:srgbClr val="5E706B"/>
+                </a:solidFill>
+                <a:latin typeface="Apple SD Gothic Neo"/>
+                <a:ea typeface="Apple SD Gothic Neo"/>
+                <a:cs typeface="Apple SD Gothic Neo"/>
+              </a:defRPr>
+            </a:pPr>
+            <a:r>
+              <a:rPr sz="1875" b="0">
+                <a:solidFill>
+                  <a:srgbClr val="5E706B"/>
+                </a:solidFill>
+                <a:latin typeface="Apple SD Gothic Neo"/>
+                <a:ea typeface="Apple SD Gothic Neo"/>
+                <a:cs typeface="Apple SD Gothic Neo"/>
+              </a:rPr>
+              <a:t>HS 분류 단계만 비교했습니다. 전체 URL 분석시간이나 운영 SLA의 개선율이 아닙니다.</a:t>
+            </a:r>
+          </a:p>
+        </p:txBody>
+      </p:sp>
+    </p:spTree>
+    <p:extLst>
+      <p:ext uri="{BB962C8B-B14F-4D97-AF65-F5344CB8AC3E}">
+        <p14:creationId xmlns:p14="http://schemas.microsoft.com/office/powerpoint/2010/main" val="2062628700"/>
+      </p:ext>
+    </p:extLst>
+  </p:cSld>
+</p:sld>
+</file>
+
+<file path=ppt/slides/slide18.xml><?xml version="1.0" encoding="utf-8"?>
+<p:sld xmlns:p="http://schemas.openxmlformats.org/presentationml/2006/main">
+  <p:cSld>
+    <p:bg>
+      <p:bgPr>
+        <a:solidFill xmlns:a="http://schemas.openxmlformats.org/drawingml/2006/main">
+          <a:srgbClr val="F8F8F3"/>
+        </a:solidFill>
+      </p:bgPr>
+    </p:bg>
+    <p:spTree>
+      <p:nvGrpSpPr>
+        <p:cNvPr id="1" name=""/>
+        <p:cNvGrpSpPr/>
+        <p:nvPr/>
+      </p:nvGrpSpPr>
+      <p:grpSpPr>
+        <a:xfrm xmlns:a="http://schemas.openxmlformats.org/drawingml/2006/main"/>
+      </p:grpSpPr>
+      <p:sp>
+        <p:nvSpPr>
+          <p:cNvPr id="8" name="">
+            <a:extLst xmlns:a="http://schemas.openxmlformats.org/drawingml/2006/main">
+              <a:ext uri="{FF2B5EF4-FFF2-40B4-BE49-F238E27FC236}">
+                <a16:creationId xmlns:a16="http://schemas.microsoft.com/office/drawing/2014/main" id="{0BED836E-2E09-4737-8347-3EBAA0C1B807}"/>
+              </a:ext>
+            </a:extLst>
+          </p:cNvPr>
+          <p:cNvSpPr>
+            <a:spLocks xmlns:a="http://schemas.openxmlformats.org/drawingml/2006/main" noGrp="1"/>
+          </p:cNvSpPr>
+          <p:nvPr/>
+        </p:nvSpPr>
+        <p:spPr>
+          <a:xfrm xmlns:a="http://schemas.openxmlformats.org/drawingml/2006/main">
+            <a:off x="800100" y="609600"/>
+            <a:ext cx="13620750" cy="781050"/>
+          </a:xfrm>
+          <a:prstGeom xmlns:a="http://schemas.openxmlformats.org/drawingml/2006/main" prst="rect">
+            <a:avLst/>
+          </a:prstGeom>
+          <a:noFill xmlns:a="http://schemas.openxmlformats.org/drawingml/2006/main"/>
+          <a:ln xmlns:a="http://schemas.openxmlformats.org/drawingml/2006/main" w="0">
+            <a:noFill/>
+          </a:ln>
+        </p:spPr>
+        <p:txBody>
+          <a:bodyPr xmlns:a="http://schemas.openxmlformats.org/drawingml/2006/main" wrap="square" lIns="0" tIns="0" rIns="0" bIns="0">
+            <a:noAutofit/>
+          </a:bodyPr>
+          <a:lstStyle xmlns:a="http://schemas.openxmlformats.org/drawingml/2006/main"/>
+          <a:p xmlns:a="http://schemas.openxmlformats.org/drawingml/2006/main">
+            <a:pPr>
+              <a:defRPr sz="3675" b="1">
+                <a:solidFill>
+                  <a:srgbClr val="182C29"/>
+                </a:solidFill>
+                <a:latin typeface="Apple SD Gothic Neo"/>
+                <a:ea typeface="Apple SD Gothic Neo"/>
+                <a:cs typeface="Apple SD Gothic Neo"/>
+              </a:defRPr>
+            </a:pPr>
+            <a:r>
+              <a:rPr sz="3675" b="1">
+                <a:solidFill>
+                  <a:srgbClr val="182C29"/>
+                </a:solidFill>
+                <a:latin typeface="Apple SD Gothic Neo"/>
+                <a:ea typeface="Apple SD Gothic Neo"/>
+                <a:cs typeface="Apple SD Gothic Neo"/>
+              </a:rPr>
+              <a:t>품질은 평가 기준별로 구분했습니다</a:t>
+            </a:r>
+          </a:p>
+        </p:txBody>
+      </p:sp>
+      <p:sp>
+        <p:nvSpPr>
+          <p:cNvPr id="2" name="">
+            <a:extLst xmlns:a="http://schemas.openxmlformats.org/drawingml/2006/main">
+              <a:ext uri="{FF2B5EF4-FFF2-40B4-BE49-F238E27FC236}">
+                <a16:creationId xmlns:a16="http://schemas.microsoft.com/office/drawing/2014/main" id="{6AEFAC60-7114-4DA1-86BC-D3A68574D6B6}"/>
+              </a:ext>
+            </a:extLst>
+          </p:cNvPr>
+          <p:cNvSpPr>
+            <a:spLocks xmlns:a="http://schemas.openxmlformats.org/drawingml/2006/main" noGrp="1"/>
+          </p:cNvSpPr>
+          <p:nvPr/>
+        </p:nvSpPr>
+        <p:spPr>
+          <a:xfrm xmlns:a="http://schemas.openxmlformats.org/drawingml/2006/main">
+            <a:off x="819150" y="1533525"/>
+            <a:ext cx="13525500" cy="781050"/>
+          </a:xfrm>
+          <a:prstGeom xmlns:a="http://schemas.openxmlformats.org/drawingml/2006/main" prst="rect">
+            <a:avLst/>
+          </a:prstGeom>
+          <a:noFill xmlns:a="http://schemas.openxmlformats.org/drawingml/2006/main"/>
+          <a:ln xmlns:a="http://schemas.openxmlformats.org/drawingml/2006/main" w="0">
+            <a:noFill/>
+          </a:ln>
+        </p:spPr>
+        <p:txBody>
+          <a:bodyPr xmlns:a="http://schemas.openxmlformats.org/drawingml/2006/main" wrap="square" lIns="0" tIns="0" rIns="0" bIns="0">
+            <a:noAutofit/>
+          </a:bodyPr>
+          <a:lstStyle xmlns:a="http://schemas.openxmlformats.org/drawingml/2006/main"/>
+          <a:p xmlns:a="http://schemas.openxmlformats.org/drawingml/2006/main">
+            <a:pPr>
+              <a:defRPr sz="2100" b="0">
+                <a:solidFill>
+                  <a:srgbClr val="5E706B"/>
+                </a:solidFill>
+                <a:latin typeface="Apple SD Gothic Neo"/>
+                <a:ea typeface="Apple SD Gothic Neo"/>
+                <a:cs typeface="Apple SD Gothic Neo"/>
+              </a:defRPr>
+            </a:pPr>
+            <a:r>
+              <a:rPr sz="2100" b="0">
+                <a:solidFill>
+                  <a:srgbClr val="5E706B"/>
+                </a:solidFill>
+                <a:latin typeface="Apple SD Gothic Neo"/>
+                <a:ea typeface="Apple SD Gothic Neo"/>
+                <a:cs typeface="Apple SD Gothic Neo"/>
+              </a:rPr>
+              <a:t>메루카리의 상위 모델 HS6 일치율84%를 기록했고, HF 정확도 차이도 확인했습니다.</a:t>
+            </a:r>
+          </a:p>
+        </p:txBody>
+      </p:sp>
+      <p:sp>
+        <p:nvSpPr>
+          <p:cNvPr id="3" name="">
+            <a:extLst xmlns:a="http://schemas.openxmlformats.org/drawingml/2006/main">
+              <a:ext uri="{FF2B5EF4-FFF2-40B4-BE49-F238E27FC236}">
+                <a16:creationId xmlns:a16="http://schemas.microsoft.com/office/drawing/2014/main" id="{E248D299-3D70-4881-8335-A473265A68D3}"/>
+              </a:ext>
+            </a:extLst>
+          </p:cNvPr>
+          <p:cNvSpPr>
+            <a:spLocks xmlns:a="http://schemas.openxmlformats.org/drawingml/2006/main" noGrp="1"/>
+          </p:cNvSpPr>
+          <p:nvPr/>
+        </p:nvSpPr>
+        <p:spPr>
+          <a:xfrm xmlns:a="http://schemas.openxmlformats.org/drawingml/2006/main">
+            <a:off x="819150" y="8058150"/>
+            <a:ext cx="13620750" cy="285750"/>
+          </a:xfrm>
+          <a:prstGeom xmlns:a="http://schemas.openxmlformats.org/drawingml/2006/main" prst="rect">
+            <a:avLst/>
+          </a:prstGeom>
+          <a:noFill xmlns:a="http://schemas.openxmlformats.org/drawingml/2006/main"/>
+          <a:ln xmlns:a="http://schemas.openxmlformats.org/drawingml/2006/main" w="0">
+            <a:noFill/>
+          </a:ln>
+        </p:spPr>
+        <p:txBody>
+          <a:bodyPr xmlns:a="http://schemas.openxmlformats.org/drawingml/2006/main" wrap="square" lIns="0" tIns="0" rIns="0" bIns="0">
+            <a:noAutofit/>
+          </a:bodyPr>
+          <a:lstStyle xmlns:a="http://schemas.openxmlformats.org/drawingml/2006/main"/>
+          <a:p xmlns:a="http://schemas.openxmlformats.org/drawingml/2006/main">
+            <a:pPr>
+              <a:defRPr sz="1350" b="0">
+                <a:solidFill>
+                  <a:srgbClr val="5E706B"/>
+                </a:solidFill>
+                <a:latin typeface="Apple SD Gothic Neo"/>
+                <a:ea typeface="Apple SD Gothic Neo"/>
+                <a:cs typeface="Apple SD Gothic Neo"/>
+              </a:defRPr>
+            </a:pPr>
+            <a:r>
+              <a:rPr sz="1350" b="0">
+                <a:solidFill>
+                  <a:srgbClr val="5E706B"/>
+                </a:solidFill>
+                <a:latin typeface="Apple SD Gothic Neo"/>
+                <a:ea typeface="Apple SD Gothic Neo"/>
+                <a:cs typeface="Apple SD Gothic Neo"/>
+              </a:rPr>
+              <a:t>18   윤장한 · 직구 조사와 도구 구현 · 부록 · 2026.10.06</a:t>
+            </a:r>
+          </a:p>
+        </p:txBody>
+      </p:sp>
+      <p:graphicFrame>
+        <p:nvGraphicFramePr>
+          <p:cNvPr id="11" name=""/>
+          <p:cNvGraphicFramePr/>
+          <p:nvPr/>
+        </p:nvGraphicFramePr>
+        <p:xfrm>
+          <a:off xmlns:a="http://schemas.openxmlformats.org/drawingml/2006/main" x="819150" y="2695575"/>
+          <a:ext xmlns:a="http://schemas.openxmlformats.org/drawingml/2006/main" cx="13601700" cy="2781300"/>
+        </p:xfrm>
+        <a:graphic xmlns:a="http://schemas.openxmlformats.org/drawingml/2006/main">
+          <a:graphicData uri="http://schemas.openxmlformats.org/drawingml/2006/table">
+            <a:tbl>
+              <a:tblPr/>
+              <a:tblGrid>
+                <a:gridCol w="7734300"/>
+                <a:gridCol w="2933700"/>
+                <a:gridCol w="2933700"/>
+              </a:tblGrid>
+              <a:tr h="695325">
+                <a:tc>
+                  <a:txBody>
+                    <a:bodyPr/>
+                    <a:lstStyle/>
+                    <a:p>
+                      <a:r>
+                        <a:rPr sz="2025" b="1">
+                          <a:solidFill>
+                            <a:srgbClr val="FFFFFF"/>
+                          </a:solidFill>
+                          <a:latin typeface="Apple SD Gothic Neo"/>
+                          <a:ea typeface="Apple SD Gothic Neo"/>
+                          <a:cs typeface="Apple SD Gothic Neo"/>
+                        </a:rPr>
+                        <a:t>평가 기준</a:t>
+                      </a:r>
+                    </a:p>
+                  </a:txBody>
+                  <a:tcPr marL="91440" marR="91440" marT="45720" marB="45720">
+                    <a:solidFill>
+                      <a:srgbClr val="182C29"/>
+                    </a:solidFill>
+                  </a:tcPr>
+                </a:tc>
+                <a:tc>
+                  <a:txBody>
+                    <a:bodyPr/>
+                    <a:lstStyle/>
+                    <a:p>
+                      <a:r>
+                        <a:rPr sz="2025" b="1">
+                          <a:solidFill>
+                            <a:srgbClr val="FFFFFF"/>
+                          </a:solidFill>
+                          <a:latin typeface="Apple SD Gothic Neo"/>
+                          <a:ea typeface="Apple SD Gothic Neo"/>
+                          <a:cs typeface="Apple SD Gothic Neo"/>
+                        </a:rPr>
+                        <a:t>Jev</a:t>
+                      </a:r>
+                    </a:p>
+                  </a:txBody>
+                  <a:tcPr marL="91440" marR="91440" marT="45720" marB="45720">
+                    <a:solidFill>
+                      <a:srgbClr val="182C29"/>
+                    </a:solidFill>
+                  </a:tcPr>
+                </a:tc>
+                <a:tc>
+                  <a:txBody>
+                    <a:bodyPr/>
+                    <a:lstStyle/>
+                    <a:p>
+                      <a:r>
+                        <a:rPr sz="2025" b="1">
+                          <a:solidFill>
+                            <a:srgbClr val="FFFFFF"/>
+                          </a:solidFill>
+                          <a:latin typeface="Apple SD Gothic Neo"/>
+                          <a:ea typeface="Apple SD Gothic Neo"/>
+                          <a:cs typeface="Apple SD Gothic Neo"/>
+                        </a:rPr>
+                        <a:t>GPT-6 Luna</a:t>
+                      </a:r>
+                    </a:p>
+                  </a:txBody>
+                  <a:tcPr marL="91440" marR="91440" marT="45720" marB="45720">
+                    <a:solidFill>
+                      <a:srgbClr val="182C29"/>
+                    </a:solidFill>
+                  </a:tcPr>
+                </a:tc>
+              </a:tr>
+              <a:tr h="695325">
+                <a:tc>
+                  <a:txBody>
+                    <a:bodyPr/>
+                    <a:lstStyle/>
+                    <a:p>
+                      <a:r>
+                        <a:rPr sz="2175" b="0">
+                          <a:solidFill>
+                            <a:srgbClr val="182C29"/>
+                          </a:solidFill>
+                          <a:latin typeface="Apple SD Gothic Neo"/>
+                          <a:ea typeface="Apple SD Gothic Neo"/>
+                          <a:cs typeface="Apple SD Gothic Neo"/>
+                        </a:rPr>
+                        <a:t>HF 전문가 라벨 · 전체94개 HS6 정확도</a:t>
+                      </a:r>
+                    </a:p>
+                  </a:txBody>
+                  <a:tcPr marL="91440" marR="91440" marT="45720" marB="45720">
+                    <a:solidFill>
+                      <a:srgbClr val="FFFFFF"/>
+                    </a:solidFill>
+                  </a:tcPr>
+                </a:tc>
+                <a:tc>
+                  <a:txBody>
+                    <a:bodyPr/>
+                    <a:lstStyle/>
+                    <a:p>
+                      <a:r>
+                        <a:rPr sz="2175" b="0">
+                          <a:solidFill>
+                            <a:srgbClr val="182C29"/>
+                          </a:solidFill>
+                          <a:latin typeface="Apple SD Gothic Neo"/>
+                          <a:ea typeface="Apple SD Gothic Neo"/>
+                          <a:cs typeface="Apple SD Gothic Neo"/>
+                        </a:rPr>
+                        <a:t>29.8% (28/94)</a:t>
+                      </a:r>
+                    </a:p>
+                  </a:txBody>
+                  <a:tcPr marL="91440" marR="91440" marT="45720" marB="45720">
+                    <a:solidFill>
+                      <a:srgbClr val="FFFFFF"/>
+                    </a:solidFill>
+                  </a:tcPr>
+                </a:tc>
+                <a:tc>
+                  <a:txBody>
+                    <a:bodyPr/>
+                    <a:lstStyle/>
+                    <a:p>
+                      <a:r>
+                        <a:rPr sz="2175" b="0">
+                          <a:solidFill>
+                            <a:srgbClr val="182C29"/>
+                          </a:solidFill>
+                          <a:latin typeface="Apple SD Gothic Neo"/>
+                          <a:ea typeface="Apple SD Gothic Neo"/>
+                          <a:cs typeface="Apple SD Gothic Neo"/>
+                        </a:rPr>
+                        <a:t>38.3% (36/94)</a:t>
+                      </a:r>
+                    </a:p>
+                  </a:txBody>
+                  <a:tcPr marL="91440" marR="91440" marT="45720" marB="45720">
+                    <a:solidFill>
+                      <a:srgbClr val="FFFFFF"/>
+                    </a:solidFill>
+                  </a:tcPr>
+                </a:tc>
+              </a:tr>
+              <a:tr h="695325">
+                <a:tc>
+                  <a:txBody>
+                    <a:bodyPr/>
+                    <a:lstStyle/>
+                    <a:p>
+                      <a:r>
+                        <a:rPr sz="2175" b="0">
+                          <a:solidFill>
+                            <a:srgbClr val="182C29"/>
+                          </a:solidFill>
+                          <a:latin typeface="Apple SD Gothic Neo"/>
+                          <a:ea typeface="Apple SD Gothic Neo"/>
+                          <a:cs typeface="Apple SD Gothic Neo"/>
+                        </a:rPr>
+                        <a:t>메루카리 · 심사자 HS6 일치 (25개)</a:t>
+                      </a:r>
+                    </a:p>
+                  </a:txBody>
+                  <a:tcPr marL="91440" marR="91440" marT="45720" marB="45720">
+                    <a:solidFill>
+                      <a:srgbClr val="F8F8F3"/>
+                    </a:solidFill>
+                  </a:tcPr>
+                </a:tc>
+                <a:tc>
+                  <a:txBody>
+                    <a:bodyPr/>
+                    <a:lstStyle/>
+                    <a:p>
+                      <a:r>
+                        <a:rPr sz="2175" b="0">
+                          <a:solidFill>
+                            <a:srgbClr val="182C29"/>
+                          </a:solidFill>
+                          <a:latin typeface="Apple SD Gothic Neo"/>
+                          <a:ea typeface="Apple SD Gothic Neo"/>
+                          <a:cs typeface="Apple SD Gothic Neo"/>
+                        </a:rPr>
+                        <a:t>84.0% (21/25)</a:t>
+                      </a:r>
+                    </a:p>
+                  </a:txBody>
+                  <a:tcPr marL="91440" marR="91440" marT="45720" marB="45720">
+                    <a:solidFill>
+                      <a:srgbClr val="F8F8F3"/>
+                    </a:solidFill>
+                  </a:tcPr>
+                </a:tc>
+                <a:tc>
+                  <a:txBody>
+                    <a:bodyPr/>
+                    <a:lstStyle/>
+                    <a:p>
+                      <a:r>
+                        <a:rPr sz="2175" b="0">
+                          <a:solidFill>
+                            <a:srgbClr val="182C29"/>
+                          </a:solidFill>
+                          <a:latin typeface="Apple SD Gothic Neo"/>
+                          <a:ea typeface="Apple SD Gothic Neo"/>
+                          <a:cs typeface="Apple SD Gothic Neo"/>
+                        </a:rPr>
+                        <a:t>76.0% (19/25)</a:t>
+                      </a:r>
+                    </a:p>
+                  </a:txBody>
+                  <a:tcPr marL="91440" marR="91440" marT="45720" marB="45720">
+                    <a:solidFill>
+                      <a:srgbClr val="F8F8F3"/>
+                    </a:solidFill>
+                  </a:tcPr>
+                </a:tc>
+              </a:tr>
+              <a:tr h="695325">
+                <a:tc>
+                  <a:txBody>
+                    <a:bodyPr/>
+                    <a:lstStyle/>
+                    <a:p>
+                      <a:r>
+                        <a:rPr sz="2175" b="0">
+                          <a:solidFill>
+                            <a:srgbClr val="182C29"/>
+                          </a:solidFill>
+                          <a:latin typeface="Apple SD Gothic Neo"/>
+                          <a:ea typeface="Apple SD Gothic Neo"/>
+                          <a:cs typeface="Apple SD Gothic Neo"/>
+                        </a:rPr>
+                        <a:t>메루카리 · 보류 포함 전체 판단 일치</a:t>
+                      </a:r>
+                    </a:p>
+                  </a:txBody>
+                  <a:tcPr marL="91440" marR="91440" marT="45720" marB="45720">
+                    <a:solidFill>
+                      <a:srgbClr val="FFFFFF"/>
+                    </a:solidFill>
+                  </a:tcPr>
+                </a:tc>
+                <a:tc>
+                  <a:txBody>
+                    <a:bodyPr/>
+                    <a:lstStyle/>
+                    <a:p>
+                      <a:r>
+                        <a:rPr sz="2175" b="0">
+                          <a:solidFill>
+                            <a:srgbClr val="182C29"/>
+                          </a:solidFill>
+                          <a:latin typeface="Apple SD Gothic Neo"/>
+                          <a:ea typeface="Apple SD Gothic Neo"/>
+                          <a:cs typeface="Apple SD Gothic Neo"/>
+                        </a:rPr>
+                        <a:t>70.0% (21/30)</a:t>
+                      </a:r>
+                    </a:p>
+                  </a:txBody>
+                  <a:tcPr marL="91440" marR="91440" marT="45720" marB="45720">
+                    <a:solidFill>
+                      <a:srgbClr val="FFFFFF"/>
+                    </a:solidFill>
+                  </a:tcPr>
+                </a:tc>
+                <a:tc>
+                  <a:txBody>
+                    <a:bodyPr/>
+                    <a:lstStyle/>
+                    <a:p>
+                      <a:r>
+                        <a:rPr sz="2175" b="0">
+                          <a:solidFill>
+                            <a:srgbClr val="182C29"/>
+                          </a:solidFill>
+                          <a:latin typeface="Apple SD Gothic Neo"/>
+                          <a:ea typeface="Apple SD Gothic Neo"/>
+                          <a:cs typeface="Apple SD Gothic Neo"/>
+                        </a:rPr>
+                        <a:t>76.7% (23/30)</a:t>
+                      </a:r>
+                    </a:p>
+                  </a:txBody>
+                  <a:tcPr marL="91440" marR="91440" marT="45720" marB="45720">
+                    <a:solidFill>
+                      <a:srgbClr val="FFFFFF"/>
+                    </a:solidFill>
+                  </a:tcPr>
+                </a:tc>
+              </a:tr>
+            </a:tbl>
+          </a:graphicData>
+        </a:graphic>
+      </p:graphicFrame>
+      <p:sp>
+        <p:nvSpPr>
+          <p:cNvPr id="5" name="">
+            <a:extLst xmlns:a="http://schemas.openxmlformats.org/drawingml/2006/main">
+              <a:ext uri="{FF2B5EF4-FFF2-40B4-BE49-F238E27FC236}">
+                <a16:creationId xmlns:a16="http://schemas.microsoft.com/office/drawing/2014/main" id="{224A75FC-55E6-4362-9697-AAD1F7632591}"/>
+              </a:ext>
+            </a:extLst>
+          </p:cNvPr>
+          <p:cNvSpPr>
+            <a:spLocks xmlns:a="http://schemas.openxmlformats.org/drawingml/2006/main" noGrp="1"/>
+          </p:cNvSpPr>
+          <p:nvPr/>
+        </p:nvSpPr>
+        <p:spPr>
+          <a:xfrm xmlns:a="http://schemas.openxmlformats.org/drawingml/2006/main">
+            <a:off x="819150" y="5791200"/>
+            <a:ext cx="13525500" cy="523875"/>
+          </a:xfrm>
+          <a:prstGeom xmlns:a="http://schemas.openxmlformats.org/drawingml/2006/main" prst="rect">
+            <a:avLst/>
+          </a:prstGeom>
+          <a:noFill xmlns:a="http://schemas.openxmlformats.org/drawingml/2006/main"/>
+          <a:ln xmlns:a="http://schemas.openxmlformats.org/drawingml/2006/main" w="0">
+            <a:noFill/>
+          </a:ln>
+        </p:spPr>
+        <p:txBody>
+          <a:bodyPr xmlns:a="http://schemas.openxmlformats.org/drawingml/2006/main" wrap="square" lIns="0" tIns="0" rIns="0" bIns="0">
+            <a:noAutofit/>
+          </a:bodyPr>
+          <a:lstStyle xmlns:a="http://schemas.openxmlformats.org/drawingml/2006/main"/>
+          <a:p xmlns:a="http://schemas.openxmlformats.org/drawingml/2006/main">
+            <a:pPr>
+              <a:defRPr sz="2025" b="0">
+                <a:solidFill>
+                  <a:srgbClr val="5E706B"/>
+                </a:solidFill>
+                <a:latin typeface="Apple SD Gothic Neo"/>
+                <a:ea typeface="Apple SD Gothic Neo"/>
+                <a:cs typeface="Apple SD Gothic Neo"/>
+              </a:defRPr>
+            </a:pPr>
+            <a:r>
+              <a:rPr sz="2025" b="0">
+                <a:solidFill>
+                  <a:srgbClr val="5E706B"/>
+                </a:solidFill>
+                <a:latin typeface="Apple SD Gothic Neo"/>
+                <a:ea typeface="Apple SD Gothic Neo"/>
+                <a:cs typeface="Apple SD Gothic Neo"/>
+              </a:rPr>
+              <a:t>상위 모델과의 일치는 정답 정확도가 아닙니다. HF에서는 Jev의 정확도가 더 낮았습니다.</a:t>
+            </a:r>
+          </a:p>
+        </p:txBody>
+      </p:sp>
+      <p:sp>
+        <p:nvSpPr>
+          <p:cNvPr id="6" name="">
+            <a:extLst xmlns:a="http://schemas.openxmlformats.org/drawingml/2006/main">
+              <a:ext uri="{FF2B5EF4-FFF2-40B4-BE49-F238E27FC236}">
+                <a16:creationId xmlns:a16="http://schemas.microsoft.com/office/drawing/2014/main" id="{697E0B6D-485E-479C-BC00-9607A4BF7AE8}"/>
+              </a:ext>
+            </a:extLst>
+          </p:cNvPr>
+          <p:cNvSpPr>
+            <a:spLocks xmlns:a="http://schemas.openxmlformats.org/drawingml/2006/main" noGrp="1"/>
+          </p:cNvSpPr>
+          <p:nvPr/>
+        </p:nvSpPr>
+        <p:spPr>
+          <a:xfrm xmlns:a="http://schemas.openxmlformats.org/drawingml/2006/main">
+            <a:off x="819150" y="6477000"/>
+            <a:ext cx="13525500" cy="590550"/>
+          </a:xfrm>
+          <a:prstGeom xmlns:a="http://schemas.openxmlformats.org/drawingml/2006/main" prst="rect">
+            <a:avLst/>
+          </a:prstGeom>
+          <a:noFill xmlns:a="http://schemas.openxmlformats.org/drawingml/2006/main"/>
+          <a:ln xmlns:a="http://schemas.openxmlformats.org/drawingml/2006/main" w="0">
+            <a:noFill/>
+          </a:ln>
+        </p:spPr>
+        <p:txBody>
+          <a:bodyPr xmlns:a="http://schemas.openxmlformats.org/drawingml/2006/main" wrap="square" lIns="0" tIns="0" rIns="0" bIns="0">
+            <a:noAutofit/>
+          </a:bodyPr>
+          <a:lstStyle xmlns:a="http://schemas.openxmlformats.org/drawingml/2006/main"/>
+          <a:p xmlns:a="http://schemas.openxmlformats.org/drawingml/2006/main">
+            <a:pPr>
+              <a:defRPr sz="2250" b="1">
+                <a:solidFill>
+                  <a:srgbClr val="156E58"/>
+                </a:solidFill>
+                <a:latin typeface="Apple SD Gothic Neo"/>
+                <a:ea typeface="Apple SD Gothic Neo"/>
+                <a:cs typeface="Apple SD Gothic Neo"/>
+              </a:defRPr>
+            </a:pPr>
+            <a:r>
+              <a:rPr sz="2250" b="1">
+                <a:solidFill>
+                  <a:srgbClr val="156E58"/>
+                </a:solidFill>
+                <a:latin typeface="Apple SD Gothic Neo"/>
+                <a:ea typeface="Apple SD Gothic Neo"/>
+                <a:cs typeface="Apple SD Gothic Neo"/>
+              </a:rPr>
+              <a:t>도입 방향(제안): 초기 후보 판단을 빠르게 처리하고, 근거 부족·최종 분류는 추가 검토합니다.</a:t>
+            </a:r>
+          </a:p>
+        </p:txBody>
+      </p:sp>
+      <p:sp>
+        <p:nvSpPr>
+          <p:cNvPr id="7" name="">
+            <a:extLst xmlns:a="http://schemas.openxmlformats.org/drawingml/2006/main">
+              <a:ext uri="{FF2B5EF4-FFF2-40B4-BE49-F238E27FC236}">
+                <a16:creationId xmlns:a16="http://schemas.microsoft.com/office/drawing/2014/main" id="{0D8741C7-5AF5-4B15-B2C9-E7206E5AC3BB}"/>
+              </a:ext>
+            </a:extLst>
+          </p:cNvPr>
+          <p:cNvSpPr>
+            <a:spLocks xmlns:a="http://schemas.openxmlformats.org/drawingml/2006/main" noGrp="1"/>
+          </p:cNvSpPr>
+          <p:nvPr/>
+        </p:nvSpPr>
+        <p:spPr>
+          <a:xfrm xmlns:a="http://schemas.openxmlformats.org/drawingml/2006/main">
+            <a:off x="819150" y="7448550"/>
+            <a:ext cx="13525500" cy="371475"/>
+          </a:xfrm>
+          <a:prstGeom xmlns:a="http://schemas.openxmlformats.org/drawingml/2006/main" prst="rect">
+            <a:avLst/>
+          </a:prstGeom>
+          <a:noFill xmlns:a="http://schemas.openxmlformats.org/drawingml/2006/main"/>
+          <a:ln xmlns:a="http://schemas.openxmlformats.org/drawingml/2006/main" w="0">
+            <a:noFill/>
+          </a:ln>
+        </p:spPr>
+        <p:txBody>
+          <a:bodyPr xmlns:a="http://schemas.openxmlformats.org/drawingml/2006/main" wrap="square" lIns="0" tIns="0" rIns="0" bIns="0">
+            <a:noAutofit/>
+          </a:bodyPr>
+          <a:lstStyle xmlns:a="http://schemas.openxmlformats.org/drawingml/2006/main"/>
+          <a:p xmlns:a="http://schemas.openxmlformats.org/drawingml/2006/main">
+            <a:pPr>
+              <a:defRPr sz="1725" b="0">
+                <a:solidFill>
+                  <a:srgbClr val="5E706B"/>
+                </a:solidFill>
+                <a:latin typeface="Apple SD Gothic Neo"/>
+                <a:ea typeface="Apple SD Gothic Neo"/>
+                <a:cs typeface="Apple SD Gothic Neo"/>
+              </a:defRPr>
+            </a:pPr>
+            <a:r>
+              <a:rPr sz="1725" b="0">
+                <a:solidFill>
+                  <a:srgbClr val="5E706B"/>
+                </a:solidFill>
+                <a:latin typeface="Apple SD Gothic Neo"/>
+                <a:ea typeface="Apple SD Gothic Neo"/>
+                <a:cs typeface="Apple SD Gothic Neo"/>
+              </a:rPr>
+              <a:t>실험 코드·노트북·측정 결과: github.com/y00nZZang/product-catalog/tree/main/notebooks</a:t>
+            </a:r>
+          </a:p>
+        </p:txBody>
+      </p:sp>
+    </p:spTree>
+    <p:extLst>
+      <p:ext uri="{BB962C8B-B14F-4D97-AF65-F5344CB8AC3E}">
+        <p14:creationId xmlns:p14="http://schemas.microsoft.com/office/powerpoint/2010/main" val="1627327697"/>
       </p:ext>
     </p:extLst>
   </p:cSld>
@@ -6452,6 +8950,7 @@
           <a:lstStyle xmlns:a="http://schemas.openxmlformats.org/drawingml/2006/main"/>
           <a:p xmlns:a="http://schemas.openxmlformats.org/drawingml/2006/main">
             <a:pPr>
+              <a:buNone/>
               <a:defRPr sz="3675" b="1">
                 <a:solidFill>
                   <a:srgbClr val="182C29"/>
@@ -6509,6 +9008,7 @@
           <a:lstStyle xmlns:a="http://schemas.openxmlformats.org/drawingml/2006/main"/>
           <a:p xmlns:a="http://schemas.openxmlformats.org/drawingml/2006/main">
             <a:pPr>
+              <a:buNone/>
               <a:defRPr sz="2100" b="0">
                 <a:solidFill>
                   <a:srgbClr val="5E706B"/>
@@ -6566,6 +9066,7 @@
           <a:lstStyle xmlns:a="http://schemas.openxmlformats.org/drawingml/2006/main"/>
           <a:p xmlns:a="http://schemas.openxmlformats.org/drawingml/2006/main">
             <a:pPr>
+              <a:buNone/>
               <a:defRPr sz="1350" b="0">
                 <a:solidFill>
                   <a:srgbClr val="5E706B"/>
@@ -6623,6 +9124,7 @@
           <a:lstStyle xmlns:a="http://schemas.openxmlformats.org/drawingml/2006/main"/>
           <a:p xmlns:a="http://schemas.openxmlformats.org/drawingml/2006/main">
             <a:pPr>
+              <a:buNone/>
               <a:defRPr sz="2850" b="1">
                 <a:solidFill>
                   <a:srgbClr val="156E58"/>
@@ -6680,6 +9182,7 @@
           <a:lstStyle xmlns:a="http://schemas.openxmlformats.org/drawingml/2006/main"/>
           <a:p xmlns:a="http://schemas.openxmlformats.org/drawingml/2006/main">
             <a:pPr>
+              <a:buNone/>
               <a:defRPr sz="2775" b="0">
                 <a:solidFill>
                   <a:srgbClr val="182C29"/>
@@ -6703,6 +9206,7 @@
           </a:p>
           <a:p xmlns:a="http://schemas.openxmlformats.org/drawingml/2006/main">
             <a:pPr>
+              <a:buNone/>
               <a:defRPr sz="2775" b="0">
                 <a:solidFill>
                   <a:srgbClr val="182C29"/>
@@ -6726,6 +9230,7 @@
           </a:p>
           <a:p xmlns:a="http://schemas.openxmlformats.org/drawingml/2006/main">
             <a:pPr>
+              <a:buNone/>
               <a:defRPr sz="2775" b="0">
                 <a:solidFill>
                   <a:srgbClr val="182C29"/>
@@ -6783,6 +9288,7 @@
           <a:lstStyle xmlns:a="http://schemas.openxmlformats.org/drawingml/2006/main"/>
           <a:p xmlns:a="http://schemas.openxmlformats.org/drawingml/2006/main">
             <a:pPr>
+              <a:buNone/>
               <a:defRPr sz="2850" b="1">
                 <a:solidFill>
                   <a:srgbClr val="156E58"/>
@@ -6840,6 +9346,7 @@
           <a:lstStyle xmlns:a="http://schemas.openxmlformats.org/drawingml/2006/main"/>
           <a:p xmlns:a="http://schemas.openxmlformats.org/drawingml/2006/main">
             <a:pPr>
+              <a:buNone/>
               <a:defRPr sz="2700" b="0">
                 <a:solidFill>
                   <a:srgbClr val="182C29"/>
@@ -6863,6 +9370,7 @@
           </a:p>
           <a:p xmlns:a="http://schemas.openxmlformats.org/drawingml/2006/main">
             <a:pPr>
+              <a:buNone/>
               <a:defRPr sz="2700" b="0">
                 <a:solidFill>
                   <a:srgbClr val="182C29"/>
@@ -6886,6 +9394,7 @@
           </a:p>
           <a:p xmlns:a="http://schemas.openxmlformats.org/drawingml/2006/main">
             <a:pPr>
+              <a:buNone/>
               <a:defRPr sz="2700" b="0">
                 <a:solidFill>
                   <a:srgbClr val="182C29"/>
@@ -6943,6 +9452,7 @@
           <a:lstStyle xmlns:a="http://schemas.openxmlformats.org/drawingml/2006/main"/>
           <a:p xmlns:a="http://schemas.openxmlformats.org/drawingml/2006/main">
             <a:pPr>
+              <a:buNone/>
               <a:defRPr sz="2100" b="0">
                 <a:solidFill>
                   <a:srgbClr val="5E706B"/>
@@ -7029,6 +9539,7 @@
           <a:lstStyle xmlns:a="http://schemas.openxmlformats.org/drawingml/2006/main"/>
           <a:p xmlns:a="http://schemas.openxmlformats.org/drawingml/2006/main">
             <a:pPr>
+              <a:buNone/>
               <a:defRPr sz="3675" b="1">
                 <a:solidFill>
                   <a:srgbClr val="182C29"/>
@@ -7086,6 +9597,7 @@
           <a:lstStyle xmlns:a="http://schemas.openxmlformats.org/drawingml/2006/main"/>
           <a:p xmlns:a="http://schemas.openxmlformats.org/drawingml/2006/main">
             <a:pPr>
+              <a:buNone/>
               <a:defRPr sz="2100" b="0">
                 <a:solidFill>
                   <a:srgbClr val="5E706B"/>
@@ -7143,6 +9655,7 @@
           <a:lstStyle xmlns:a="http://schemas.openxmlformats.org/drawingml/2006/main"/>
           <a:p xmlns:a="http://schemas.openxmlformats.org/drawingml/2006/main">
             <a:pPr>
+              <a:buNone/>
               <a:defRPr sz="1350" b="0">
                 <a:solidFill>
                   <a:srgbClr val="5E706B"/>
@@ -7168,7 +9681,7 @@
       </p:sp>
       <p:graphicFrame>
         <p:nvGraphicFramePr>
-          <p:cNvPr id="9" name=""/>
+          <p:cNvPr id="11" name=""/>
           <p:cNvGraphicFramePr/>
           <p:nvPr/>
         </p:nvGraphicFramePr>
@@ -7485,6 +9998,7 @@
           <a:lstStyle xmlns:a="http://schemas.openxmlformats.org/drawingml/2006/main"/>
           <a:p xmlns:a="http://schemas.openxmlformats.org/drawingml/2006/main">
             <a:pPr>
+              <a:buNone/>
               <a:defRPr sz="2100" b="0">
                 <a:solidFill>
                   <a:srgbClr val="182C29"/>
@@ -7571,6 +10085,7 @@
           <a:lstStyle xmlns:a="http://schemas.openxmlformats.org/drawingml/2006/main"/>
           <a:p xmlns:a="http://schemas.openxmlformats.org/drawingml/2006/main">
             <a:pPr>
+              <a:buNone/>
               <a:defRPr sz="3675" b="1">
                 <a:solidFill>
                   <a:srgbClr val="182C29"/>
@@ -7628,6 +10143,7 @@
           <a:lstStyle xmlns:a="http://schemas.openxmlformats.org/drawingml/2006/main"/>
           <a:p xmlns:a="http://schemas.openxmlformats.org/drawingml/2006/main">
             <a:pPr>
+              <a:buNone/>
               <a:defRPr sz="2100" b="0">
                 <a:solidFill>
                   <a:srgbClr val="5E706B"/>
@@ -7685,6 +10201,7 @@
           <a:lstStyle xmlns:a="http://schemas.openxmlformats.org/drawingml/2006/main"/>
           <a:p xmlns:a="http://schemas.openxmlformats.org/drawingml/2006/main">
             <a:pPr>
+              <a:buNone/>
               <a:defRPr sz="1350" b="0">
                 <a:solidFill>
                   <a:srgbClr val="5E706B"/>
@@ -7710,14 +10227,14 @@
       </p:sp>
       <p:pic>
         <p:nvPicPr>
-          <p:cNvPr id="12" name=""/>
+          <p:cNvPr id="15" name=""/>
           <p:cNvPicPr>
             <a:picLocks xmlns:a="http://schemas.openxmlformats.org/drawingml/2006/main" noChangeAspect="1"/>
           </p:cNvPicPr>
           <p:nvPr/>
         </p:nvPicPr>
         <p:blipFill>
-          <a:blip xmlns:r="http://schemas.openxmlformats.org/officeDocument/2006/relationships" xmlns:a="http://schemas.openxmlformats.org/drawingml/2006/main" r:embed="Rfa41460f95094426"/>
+          <a:blip xmlns:r="http://schemas.openxmlformats.org/officeDocument/2006/relationships" xmlns:a="http://schemas.openxmlformats.org/drawingml/2006/main" r:embed="R5dd6ef231bbc4553"/>
           <a:stretch xmlns:a="http://schemas.openxmlformats.org/drawingml/2006/main"/>
         </p:blipFill>
         <p:spPr>
@@ -7732,7 +10249,7 @@
       </p:pic>
       <p:graphicFrame>
         <p:nvGraphicFramePr>
-          <p:cNvPr id="13" name=""/>
+          <p:cNvPr id="16" name=""/>
           <p:cNvGraphicFramePr/>
           <p:nvPr/>
         </p:nvGraphicFramePr>
@@ -8599,6 +11116,7 @@
           <a:lstStyle xmlns:a="http://schemas.openxmlformats.org/drawingml/2006/main"/>
           <a:p xmlns:a="http://schemas.openxmlformats.org/drawingml/2006/main">
             <a:pPr>
+              <a:buNone/>
               <a:defRPr sz="1650" b="0">
                 <a:solidFill>
                   <a:srgbClr val="182C29"/>
@@ -8656,6 +11174,7 @@
           <a:lstStyle xmlns:a="http://schemas.openxmlformats.org/drawingml/2006/main"/>
           <a:p xmlns:a="http://schemas.openxmlformats.org/drawingml/2006/main">
             <a:pPr>
+              <a:buNone/>
               <a:defRPr sz="1575" b="0">
                 <a:solidFill>
                   <a:srgbClr val="182C29"/>
@@ -8713,6 +11232,7 @@
           <a:lstStyle xmlns:a="http://schemas.openxmlformats.org/drawingml/2006/main"/>
           <a:p xmlns:a="http://schemas.openxmlformats.org/drawingml/2006/main">
             <a:pPr>
+              <a:buNone/>
               <a:defRPr sz="1575" b="0">
                 <a:solidFill>
                   <a:srgbClr val="5E706B"/>
@@ -8799,6 +11319,7 @@
           <a:lstStyle xmlns:a="http://schemas.openxmlformats.org/drawingml/2006/main"/>
           <a:p xmlns:a="http://schemas.openxmlformats.org/drawingml/2006/main">
             <a:pPr>
+              <a:buNone/>
               <a:defRPr sz="3675" b="1">
                 <a:solidFill>
                   <a:srgbClr val="182C29"/>
@@ -8856,6 +11377,7 @@
           <a:lstStyle xmlns:a="http://schemas.openxmlformats.org/drawingml/2006/main"/>
           <a:p xmlns:a="http://schemas.openxmlformats.org/drawingml/2006/main">
             <a:pPr>
+              <a:buNone/>
               <a:defRPr sz="2100" b="0">
                 <a:solidFill>
                   <a:srgbClr val="5E706B"/>
@@ -8913,6 +11435,7 @@
           <a:lstStyle xmlns:a="http://schemas.openxmlformats.org/drawingml/2006/main"/>
           <a:p xmlns:a="http://schemas.openxmlformats.org/drawingml/2006/main">
             <a:pPr>
+              <a:buNone/>
               <a:defRPr sz="1350" b="0">
                 <a:solidFill>
                   <a:srgbClr val="5E706B"/>
@@ -8970,6 +11493,7 @@
           <a:lstStyle xmlns:a="http://schemas.openxmlformats.org/drawingml/2006/main"/>
           <a:p xmlns:a="http://schemas.openxmlformats.org/drawingml/2006/main">
             <a:pPr>
+              <a:buNone/>
               <a:defRPr sz="2775" b="1">
                 <a:solidFill>
                   <a:srgbClr val="156E58"/>
@@ -9027,6 +11551,7 @@
           <a:lstStyle xmlns:a="http://schemas.openxmlformats.org/drawingml/2006/main"/>
           <a:p xmlns:a="http://schemas.openxmlformats.org/drawingml/2006/main">
             <a:pPr>
+              <a:buNone/>
               <a:defRPr sz="2400" b="0">
                 <a:solidFill>
                   <a:srgbClr val="182C29"/>
@@ -9050,6 +11575,7 @@
           </a:p>
           <a:p xmlns:a="http://schemas.openxmlformats.org/drawingml/2006/main">
             <a:pPr>
+              <a:buNone/>
               <a:defRPr sz="2400" b="0">
                 <a:solidFill>
                   <a:srgbClr val="182C29"/>
@@ -9073,6 +11599,7 @@
           </a:p>
           <a:p xmlns:a="http://schemas.openxmlformats.org/drawingml/2006/main">
             <a:pPr>
+              <a:buNone/>
               <a:defRPr sz="2400" b="0">
                 <a:solidFill>
                   <a:srgbClr val="182C29"/>
@@ -9130,6 +11657,7 @@
           <a:lstStyle xmlns:a="http://schemas.openxmlformats.org/drawingml/2006/main"/>
           <a:p xmlns:a="http://schemas.openxmlformats.org/drawingml/2006/main">
             <a:pPr>
+              <a:buNone/>
               <a:defRPr sz="2250" b="0">
                 <a:solidFill>
                   <a:srgbClr val="182C29"/>
@@ -9153,6 +11681,7 @@
           </a:p>
           <a:p xmlns:a="http://schemas.openxmlformats.org/drawingml/2006/main">
             <a:pPr>
+              <a:buNone/>
               <a:defRPr sz="2250" b="0">
                 <a:solidFill>
                   <a:srgbClr val="182C29"/>
@@ -9210,6 +11739,7 @@
           <a:lstStyle xmlns:a="http://schemas.openxmlformats.org/drawingml/2006/main"/>
           <a:p xmlns:a="http://schemas.openxmlformats.org/drawingml/2006/main">
             <a:pPr>
+              <a:buNone/>
               <a:defRPr sz="2775" b="1">
                 <a:solidFill>
                   <a:srgbClr val="156E58"/>
@@ -9267,6 +11797,7 @@
           <a:lstStyle xmlns:a="http://schemas.openxmlformats.org/drawingml/2006/main"/>
           <a:p xmlns:a="http://schemas.openxmlformats.org/drawingml/2006/main">
             <a:pPr>
+              <a:buNone/>
               <a:defRPr sz="2400" b="0">
                 <a:solidFill>
                   <a:srgbClr val="182C29"/>
@@ -9290,6 +11821,7 @@
           </a:p>
           <a:p xmlns:a="http://schemas.openxmlformats.org/drawingml/2006/main">
             <a:pPr>
+              <a:buNone/>
               <a:defRPr sz="2400" b="0">
                 <a:solidFill>
                   <a:srgbClr val="182C29"/>
@@ -9313,6 +11845,7 @@
           </a:p>
           <a:p xmlns:a="http://schemas.openxmlformats.org/drawingml/2006/main">
             <a:pPr>
+              <a:buNone/>
               <a:defRPr sz="2400" b="0">
                 <a:solidFill>
                   <a:srgbClr val="182C29"/>
@@ -9370,6 +11903,7 @@
           <a:lstStyle xmlns:a="http://schemas.openxmlformats.org/drawingml/2006/main"/>
           <a:p xmlns:a="http://schemas.openxmlformats.org/drawingml/2006/main">
             <a:pPr>
+              <a:buNone/>
               <a:defRPr sz="2250" b="0">
                 <a:solidFill>
                   <a:srgbClr val="182C29"/>
@@ -9393,6 +11927,7 @@
           </a:p>
           <a:p xmlns:a="http://schemas.openxmlformats.org/drawingml/2006/main">
             <a:pPr>
+              <a:buNone/>
               <a:defRPr sz="2250" b="0">
                 <a:solidFill>
                   <a:srgbClr val="182C29"/>
@@ -9450,6 +11985,7 @@
           <a:lstStyle xmlns:a="http://schemas.openxmlformats.org/drawingml/2006/main"/>
           <a:p xmlns:a="http://schemas.openxmlformats.org/drawingml/2006/main">
             <a:pPr>
+              <a:buNone/>
               <a:defRPr sz="1725" b="0">
                 <a:solidFill>
                   <a:srgbClr val="5E706B"/>
@@ -9536,6 +12072,7 @@
           <a:lstStyle xmlns:a="http://schemas.openxmlformats.org/drawingml/2006/main"/>
           <a:p xmlns:a="http://schemas.openxmlformats.org/drawingml/2006/main">
             <a:pPr>
+              <a:buNone/>
               <a:defRPr sz="3675" b="1">
                 <a:solidFill>
                   <a:srgbClr val="182C29"/>
@@ -9593,6 +12130,7 @@
           <a:lstStyle xmlns:a="http://schemas.openxmlformats.org/drawingml/2006/main"/>
           <a:p xmlns:a="http://schemas.openxmlformats.org/drawingml/2006/main">
             <a:pPr>
+              <a:buNone/>
               <a:defRPr sz="2100" b="0">
                 <a:solidFill>
                   <a:srgbClr val="5E706B"/>
@@ -9650,6 +12188,7 @@
           <a:lstStyle xmlns:a="http://schemas.openxmlformats.org/drawingml/2006/main"/>
           <a:p xmlns:a="http://schemas.openxmlformats.org/drawingml/2006/main">
             <a:pPr>
+              <a:buNone/>
               <a:defRPr sz="1350" b="0">
                 <a:solidFill>
                   <a:srgbClr val="5E706B"/>
@@ -9707,6 +12246,7 @@
           <a:lstStyle xmlns:a="http://schemas.openxmlformats.org/drawingml/2006/main"/>
           <a:p xmlns:a="http://schemas.openxmlformats.org/drawingml/2006/main">
             <a:pPr>
+              <a:buNone/>
               <a:defRPr sz="3150" b="1">
                 <a:solidFill>
                   <a:srgbClr val="156E58"/>
@@ -9764,6 +12304,7 @@
           <a:lstStyle xmlns:a="http://schemas.openxmlformats.org/drawingml/2006/main"/>
           <a:p xmlns:a="http://schemas.openxmlformats.org/drawingml/2006/main">
             <a:pPr>
+              <a:buNone/>
               <a:defRPr sz="2475" b="1">
                 <a:solidFill>
                   <a:srgbClr val="182C29"/>
@@ -9821,6 +12362,7 @@
           <a:lstStyle xmlns:a="http://schemas.openxmlformats.org/drawingml/2006/main"/>
           <a:p xmlns:a="http://schemas.openxmlformats.org/drawingml/2006/main">
             <a:pPr>
+              <a:buNone/>
               <a:defRPr sz="2325" b="0">
                 <a:solidFill>
                   <a:srgbClr val="182C29"/>
@@ -9844,6 +12386,7 @@
           </a:p>
           <a:p xmlns:a="http://schemas.openxmlformats.org/drawingml/2006/main">
             <a:pPr>
+              <a:buNone/>
               <a:defRPr sz="2325" b="0">
                 <a:solidFill>
                   <a:srgbClr val="182C29"/>
@@ -9867,6 +12410,7 @@
           </a:p>
           <a:p xmlns:a="http://schemas.openxmlformats.org/drawingml/2006/main">
             <a:pPr>
+              <a:buNone/>
               <a:defRPr sz="2325" b="0">
                 <a:solidFill>
                   <a:srgbClr val="182C29"/>
@@ -9924,6 +12468,7 @@
           <a:lstStyle xmlns:a="http://schemas.openxmlformats.org/drawingml/2006/main"/>
           <a:p xmlns:a="http://schemas.openxmlformats.org/drawingml/2006/main">
             <a:pPr>
+              <a:buNone/>
               <a:defRPr sz="3150" b="1">
                 <a:solidFill>
                   <a:srgbClr val="156E58"/>
@@ -9981,6 +12526,7 @@
           <a:lstStyle xmlns:a="http://schemas.openxmlformats.org/drawingml/2006/main"/>
           <a:p xmlns:a="http://schemas.openxmlformats.org/drawingml/2006/main">
             <a:pPr>
+              <a:buNone/>
               <a:defRPr sz="2475" b="1">
                 <a:solidFill>
                   <a:srgbClr val="182C29"/>
@@ -10038,6 +12584,7 @@
           <a:lstStyle xmlns:a="http://schemas.openxmlformats.org/drawingml/2006/main"/>
           <a:p xmlns:a="http://schemas.openxmlformats.org/drawingml/2006/main">
             <a:pPr>
+              <a:buNone/>
               <a:defRPr sz="2325" b="0">
                 <a:solidFill>
                   <a:srgbClr val="182C29"/>
@@ -10061,6 +12608,7 @@
           </a:p>
           <a:p xmlns:a="http://schemas.openxmlformats.org/drawingml/2006/main">
             <a:pPr>
+              <a:buNone/>
               <a:defRPr sz="2325" b="0">
                 <a:solidFill>
                   <a:srgbClr val="182C29"/>
@@ -10084,6 +12632,7 @@
           </a:p>
           <a:p xmlns:a="http://schemas.openxmlformats.org/drawingml/2006/main">
             <a:pPr>
+              <a:buNone/>
               <a:defRPr sz="2325" b="0">
                 <a:solidFill>
                   <a:srgbClr val="182C29"/>
@@ -10141,6 +12690,7 @@
           <a:lstStyle xmlns:a="http://schemas.openxmlformats.org/drawingml/2006/main"/>
           <a:p xmlns:a="http://schemas.openxmlformats.org/drawingml/2006/main">
             <a:pPr>
+              <a:buNone/>
               <a:defRPr sz="1950" b="0">
                 <a:solidFill>
                   <a:srgbClr val="5E706B"/>
@@ -10227,6 +12777,7 @@
           <a:lstStyle xmlns:a="http://schemas.openxmlformats.org/drawingml/2006/main"/>
           <a:p xmlns:a="http://schemas.openxmlformats.org/drawingml/2006/main">
             <a:pPr>
+              <a:buNone/>
               <a:defRPr sz="3675" b="1">
                 <a:solidFill>
                   <a:srgbClr val="182C29"/>
@@ -10284,6 +12835,7 @@
           <a:lstStyle xmlns:a="http://schemas.openxmlformats.org/drawingml/2006/main"/>
           <a:p xmlns:a="http://schemas.openxmlformats.org/drawingml/2006/main">
             <a:pPr>
+              <a:buNone/>
               <a:defRPr sz="2100" b="0">
                 <a:solidFill>
                   <a:srgbClr val="5E706B"/>
@@ -10341,6 +12893,7 @@
           <a:lstStyle xmlns:a="http://schemas.openxmlformats.org/drawingml/2006/main"/>
           <a:p xmlns:a="http://schemas.openxmlformats.org/drawingml/2006/main">
             <a:pPr>
+              <a:buNone/>
               <a:defRPr sz="1350" b="0">
                 <a:solidFill>
                   <a:srgbClr val="5E706B"/>
@@ -10400,6 +12953,7 @@
           <a:lstStyle xmlns:a="http://schemas.openxmlformats.org/drawingml/2006/main"/>
           <a:p xmlns:a="http://schemas.openxmlformats.org/drawingml/2006/main">
             <a:pPr algn="ctr">
+              <a:buNone/>
               <a:defRPr sz="2175" b="1">
                 <a:solidFill>
                   <a:srgbClr val="182C29"/>
@@ -10459,6 +13013,7 @@
           <a:lstStyle xmlns:a="http://schemas.openxmlformats.org/drawingml/2006/main"/>
           <a:p xmlns:a="http://schemas.openxmlformats.org/drawingml/2006/main">
             <a:pPr algn="ctr">
+              <a:buNone/>
               <a:defRPr sz="2175" b="1">
                 <a:solidFill>
                   <a:srgbClr val="182C29"/>
@@ -10484,7 +13039,7 @@
       </p:sp>
       <p:cxnSp>
         <p:nvCxnSpPr>
-          <p:cNvPr id="25" name=""/>
+          <p:cNvPr id="37" name=""/>
           <p:cNvCxnSpPr>
             <a:stCxn xmlns:a="http://schemas.openxmlformats.org/drawingml/2006/main" id="4" idx="3"/>
             <a:endCxn xmlns:a="http://schemas.openxmlformats.org/drawingml/2006/main" id="5" idx="1"/>
@@ -10543,6 +13098,7 @@
           <a:lstStyle xmlns:a="http://schemas.openxmlformats.org/drawingml/2006/main"/>
           <a:p xmlns:a="http://schemas.openxmlformats.org/drawingml/2006/main">
             <a:pPr algn="ctr">
+              <a:buNone/>
               <a:defRPr sz="2175" b="1">
                 <a:solidFill>
                   <a:srgbClr val="182C29"/>
@@ -10568,7 +13124,7 @@
       </p:sp>
       <p:cxnSp>
         <p:nvCxnSpPr>
-          <p:cNvPr id="27" name=""/>
+          <p:cNvPr id="39" name=""/>
           <p:cNvCxnSpPr>
             <a:stCxn xmlns:a="http://schemas.openxmlformats.org/drawingml/2006/main" id="5" idx="3"/>
             <a:endCxn xmlns:a="http://schemas.openxmlformats.org/drawingml/2006/main" id="7" idx="1"/>
@@ -10627,6 +13183,7 @@
           <a:lstStyle xmlns:a="http://schemas.openxmlformats.org/drawingml/2006/main"/>
           <a:p xmlns:a="http://schemas.openxmlformats.org/drawingml/2006/main">
             <a:pPr algn="ctr">
+              <a:buNone/>
               <a:defRPr sz="2175" b="1">
                 <a:solidFill>
                   <a:srgbClr val="182C29"/>
@@ -10652,7 +13209,7 @@
       </p:sp>
       <p:cxnSp>
         <p:nvCxnSpPr>
-          <p:cNvPr id="29" name=""/>
+          <p:cNvPr id="41" name=""/>
           <p:cNvCxnSpPr>
             <a:stCxn xmlns:a="http://schemas.openxmlformats.org/drawingml/2006/main" id="7" idx="3"/>
             <a:endCxn xmlns:a="http://schemas.openxmlformats.org/drawingml/2006/main" id="9" idx="1"/>
@@ -10711,6 +13268,7 @@
           <a:lstStyle xmlns:a="http://schemas.openxmlformats.org/drawingml/2006/main"/>
           <a:p xmlns:a="http://schemas.openxmlformats.org/drawingml/2006/main">
             <a:pPr algn="ctr">
+              <a:buNone/>
               <a:defRPr sz="2175" b="1">
                 <a:solidFill>
                   <a:srgbClr val="182C29"/>
@@ -10736,7 +13294,7 @@
       </p:sp>
       <p:cxnSp>
         <p:nvCxnSpPr>
-          <p:cNvPr id="31" name=""/>
+          <p:cNvPr id="43" name=""/>
           <p:cNvCxnSpPr>
             <a:stCxn xmlns:a="http://schemas.openxmlformats.org/drawingml/2006/main" id="9" idx="3"/>
             <a:endCxn xmlns:a="http://schemas.openxmlformats.org/drawingml/2006/main" id="11" idx="1"/>
@@ -10793,6 +13351,7 @@
           <a:lstStyle xmlns:a="http://schemas.openxmlformats.org/drawingml/2006/main"/>
           <a:p xmlns:a="http://schemas.openxmlformats.org/drawingml/2006/main">
             <a:pPr>
+              <a:buNone/>
               <a:defRPr sz="2475" b="1">
                 <a:solidFill>
                   <a:srgbClr val="156E58"/>
@@ -10850,6 +13409,7 @@
           <a:lstStyle xmlns:a="http://schemas.openxmlformats.org/drawingml/2006/main"/>
           <a:p xmlns:a="http://schemas.openxmlformats.org/drawingml/2006/main">
             <a:pPr>
+              <a:buNone/>
               <a:defRPr sz="2325" b="0">
                 <a:solidFill>
                   <a:srgbClr val="182C29"/>
@@ -10907,6 +13467,7 @@
           <a:lstStyle xmlns:a="http://schemas.openxmlformats.org/drawingml/2006/main"/>
           <a:p xmlns:a="http://schemas.openxmlformats.org/drawingml/2006/main">
             <a:pPr>
+              <a:buNone/>
               <a:defRPr sz="2475" b="1">
                 <a:solidFill>
                   <a:srgbClr val="156E58"/>
@@ -10964,6 +13525,7 @@
           <a:lstStyle xmlns:a="http://schemas.openxmlformats.org/drawingml/2006/main"/>
           <a:p xmlns:a="http://schemas.openxmlformats.org/drawingml/2006/main">
             <a:pPr>
+              <a:buNone/>
               <a:defRPr sz="2325" b="0">
                 <a:solidFill>
                   <a:srgbClr val="182C29"/>
@@ -11021,6 +13583,7 @@
           <a:lstStyle xmlns:a="http://schemas.openxmlformats.org/drawingml/2006/main"/>
           <a:p xmlns:a="http://schemas.openxmlformats.org/drawingml/2006/main">
             <a:pPr>
+              <a:buNone/>
               <a:defRPr sz="2475" b="1">
                 <a:solidFill>
                   <a:srgbClr val="156E58"/>
@@ -11078,6 +13641,7 @@
           <a:lstStyle xmlns:a="http://schemas.openxmlformats.org/drawingml/2006/main"/>
           <a:p xmlns:a="http://schemas.openxmlformats.org/drawingml/2006/main">
             <a:pPr>
+              <a:buNone/>
               <a:defRPr sz="2325" b="0">
                 <a:solidFill>
                   <a:srgbClr val="182C29"/>
@@ -11135,6 +13699,7 @@
           <a:lstStyle xmlns:a="http://schemas.openxmlformats.org/drawingml/2006/main"/>
           <a:p xmlns:a="http://schemas.openxmlformats.org/drawingml/2006/main">
             <a:pPr>
+              <a:buNone/>
               <a:defRPr sz="1725" b="0">
                 <a:solidFill>
                   <a:srgbClr val="5E706B"/>
@@ -11221,6 +13786,7 @@
           <a:lstStyle xmlns:a="http://schemas.openxmlformats.org/drawingml/2006/main"/>
           <a:p xmlns:a="http://schemas.openxmlformats.org/drawingml/2006/main">
             <a:pPr>
+              <a:buNone/>
               <a:defRPr sz="3675" b="1">
                 <a:solidFill>
                   <a:srgbClr val="182C29"/>
@@ -11278,6 +13844,7 @@
           <a:lstStyle xmlns:a="http://schemas.openxmlformats.org/drawingml/2006/main"/>
           <a:p xmlns:a="http://schemas.openxmlformats.org/drawingml/2006/main">
             <a:pPr>
+              <a:buNone/>
               <a:defRPr sz="2100" b="0">
                 <a:solidFill>
                   <a:srgbClr val="5E706B"/>
@@ -11335,6 +13902,7 @@
           <a:lstStyle xmlns:a="http://schemas.openxmlformats.org/drawingml/2006/main"/>
           <a:p xmlns:a="http://schemas.openxmlformats.org/drawingml/2006/main">
             <a:pPr>
+              <a:buNone/>
               <a:defRPr sz="1350" b="0">
                 <a:solidFill>
                   <a:srgbClr val="5E706B"/>
@@ -11396,6 +13964,7 @@
           <a:lstStyle xmlns:a="http://schemas.openxmlformats.org/drawingml/2006/main"/>
           <a:p xmlns:a="http://schemas.openxmlformats.org/drawingml/2006/main">
             <a:pPr>
+              <a:buNone/>
               <a:defRPr sz="2100">
                 <a:solidFill>
                   <a:srgbClr val="FFFFFF"/>
@@ -11419,6 +13988,7 @@
           </a:p>
           <a:p xmlns:a="http://schemas.openxmlformats.org/drawingml/2006/main">
             <a:pPr>
+              <a:buNone/>
               <a:defRPr sz="2100">
                 <a:solidFill>
                   <a:srgbClr val="FFFFFF"/>
@@ -11476,6 +14046,7 @@
           <a:lstStyle xmlns:a="http://schemas.openxmlformats.org/drawingml/2006/main"/>
           <a:p xmlns:a="http://schemas.openxmlformats.org/drawingml/2006/main">
             <a:pPr>
+              <a:buNone/>
               <a:defRPr sz="1800" b="1">
                 <a:solidFill>
                   <a:srgbClr val="156E58"/>
@@ -11537,6 +14108,7 @@
           <a:lstStyle xmlns:a="http://schemas.openxmlformats.org/drawingml/2006/main"/>
           <a:p xmlns:a="http://schemas.openxmlformats.org/drawingml/2006/main">
             <a:pPr>
+              <a:buNone/>
               <a:defRPr sz="2100">
                 <a:solidFill>
                   <a:srgbClr val="182C29"/>
@@ -11560,6 +14132,7 @@
           </a:p>
           <a:p xmlns:a="http://schemas.openxmlformats.org/drawingml/2006/main">
             <a:pPr>
+              <a:buNone/>
               <a:defRPr sz="2100">
                 <a:solidFill>
                   <a:srgbClr val="182C29"/>
@@ -11617,6 +14190,7 @@
           <a:lstStyle xmlns:a="http://schemas.openxmlformats.org/drawingml/2006/main"/>
           <a:p xmlns:a="http://schemas.openxmlformats.org/drawingml/2006/main">
             <a:pPr>
+              <a:buNone/>
               <a:defRPr sz="1800" b="1">
                 <a:solidFill>
                   <a:srgbClr val="156E58"/>
@@ -11678,6 +14252,7 @@
           <a:lstStyle xmlns:a="http://schemas.openxmlformats.org/drawingml/2006/main"/>
           <a:p xmlns:a="http://schemas.openxmlformats.org/drawingml/2006/main">
             <a:pPr>
+              <a:buNone/>
               <a:defRPr sz="2100">
                 <a:solidFill>
                   <a:srgbClr val="FFFFFF"/>
@@ -11701,6 +14276,7 @@
           </a:p>
           <a:p xmlns:a="http://schemas.openxmlformats.org/drawingml/2006/main">
             <a:pPr>
+              <a:buNone/>
               <a:defRPr sz="2100">
                 <a:solidFill>
                   <a:srgbClr val="FFFFFF"/>
@@ -11758,6 +14334,7 @@
           <a:lstStyle xmlns:a="http://schemas.openxmlformats.org/drawingml/2006/main"/>
           <a:p xmlns:a="http://schemas.openxmlformats.org/drawingml/2006/main">
             <a:pPr>
+              <a:buNone/>
               <a:defRPr sz="1800" b="1">
                 <a:solidFill>
                   <a:srgbClr val="156E58"/>
@@ -11819,6 +14396,7 @@
           <a:lstStyle xmlns:a="http://schemas.openxmlformats.org/drawingml/2006/main"/>
           <a:p xmlns:a="http://schemas.openxmlformats.org/drawingml/2006/main">
             <a:pPr>
+              <a:buNone/>
               <a:defRPr sz="2100">
                 <a:solidFill>
                   <a:srgbClr val="182C29"/>
@@ -11842,6 +14420,7 @@
           </a:p>
           <a:p xmlns:a="http://schemas.openxmlformats.org/drawingml/2006/main">
             <a:pPr>
+              <a:buNone/>
               <a:defRPr sz="2100">
                 <a:solidFill>
                   <a:srgbClr val="182C29"/>
@@ -11899,6 +14478,7 @@
           <a:lstStyle xmlns:a="http://schemas.openxmlformats.org/drawingml/2006/main"/>
           <a:p xmlns:a="http://schemas.openxmlformats.org/drawingml/2006/main">
             <a:pPr>
+              <a:buNone/>
               <a:defRPr sz="1800" b="1">
                 <a:solidFill>
                   <a:srgbClr val="156E58"/>
@@ -11956,6 +14536,7 @@
           <a:lstStyle xmlns:a="http://schemas.openxmlformats.org/drawingml/2006/main"/>
           <a:p xmlns:a="http://schemas.openxmlformats.org/drawingml/2006/main">
             <a:pPr>
+              <a:buNone/>
               <a:defRPr sz="2400" b="1">
                 <a:solidFill>
                   <a:srgbClr val="156E58"/>
@@ -11981,14 +14562,14 @@
       </p:sp>
       <p:pic>
         <p:nvPicPr>
-          <p:cNvPr id="28" name=""/>
+          <p:cNvPr id="30" name=""/>
           <p:cNvPicPr>
             <a:picLocks xmlns:a="http://schemas.openxmlformats.org/drawingml/2006/main" noChangeAspect="1"/>
           </p:cNvPicPr>
           <p:nvPr/>
         </p:nvPicPr>
         <p:blipFill>
-          <a:blip xmlns:r="http://schemas.openxmlformats.org/officeDocument/2006/relationships" xmlns:a="http://schemas.openxmlformats.org/drawingml/2006/main" r:embed="Rf18c41b441524723"/>
+          <a:blip xmlns:r="http://schemas.openxmlformats.org/officeDocument/2006/relationships" xmlns:a="http://schemas.openxmlformats.org/drawingml/2006/main" r:embed="Rfb0b81b56d264eff"/>
           <a:stretch xmlns:a="http://schemas.openxmlformats.org/drawingml/2006/main"/>
         </p:blipFill>
         <p:spPr>
@@ -12035,6 +14616,7 @@
           <a:lstStyle xmlns:a="http://schemas.openxmlformats.org/drawingml/2006/main"/>
           <a:p xmlns:a="http://schemas.openxmlformats.org/drawingml/2006/main">
             <a:pPr>
+              <a:buNone/>
               <a:defRPr sz="1725" b="0">
                 <a:solidFill>
                   <a:srgbClr val="5E706B"/>
@@ -12092,6 +14674,7 @@
           <a:lstStyle xmlns:a="http://schemas.openxmlformats.org/drawingml/2006/main"/>
           <a:p xmlns:a="http://schemas.openxmlformats.org/drawingml/2006/main">
             <a:pPr>
+              <a:buNone/>
               <a:defRPr sz="1500" b="0">
                 <a:solidFill>
                   <a:srgbClr val="5E706B"/>
@@ -12178,6 +14761,7 @@
           <a:lstStyle xmlns:a="http://schemas.openxmlformats.org/drawingml/2006/main"/>
           <a:p xmlns:a="http://schemas.openxmlformats.org/drawingml/2006/main">
             <a:pPr>
+              <a:buNone/>
               <a:defRPr sz="3675" b="1">
                 <a:solidFill>
                   <a:srgbClr val="182C29"/>
@@ -12235,6 +14819,7 @@
           <a:lstStyle xmlns:a="http://schemas.openxmlformats.org/drawingml/2006/main"/>
           <a:p xmlns:a="http://schemas.openxmlformats.org/drawingml/2006/main">
             <a:pPr>
+              <a:buNone/>
               <a:defRPr sz="2100" b="0">
                 <a:solidFill>
                   <a:srgbClr val="5E706B"/>
@@ -12292,6 +14877,7 @@
           <a:lstStyle xmlns:a="http://schemas.openxmlformats.org/drawingml/2006/main"/>
           <a:p xmlns:a="http://schemas.openxmlformats.org/drawingml/2006/main">
             <a:pPr>
+              <a:buNone/>
               <a:defRPr sz="1350" b="0">
                 <a:solidFill>
                   <a:srgbClr val="5E706B"/>
@@ -12351,6 +14937,7 @@
           <a:lstStyle xmlns:a="http://schemas.openxmlformats.org/drawingml/2006/main"/>
           <a:p xmlns:a="http://schemas.openxmlformats.org/drawingml/2006/main">
             <a:pPr algn="ctr">
+              <a:buNone/>
               <a:defRPr sz="2175" b="1">
                 <a:solidFill>
                   <a:srgbClr val="182C29"/>
@@ -12410,6 +14997,7 @@
           <a:lstStyle xmlns:a="http://schemas.openxmlformats.org/drawingml/2006/main"/>
           <a:p xmlns:a="http://schemas.openxmlformats.org/drawingml/2006/main">
             <a:pPr algn="ctr">
+              <a:buNone/>
               <a:defRPr sz="2175" b="1">
                 <a:solidFill>
                   <a:srgbClr val="182C29"/>
@@ -12435,7 +15023,7 @@
       </p:sp>
       <p:cxnSp>
         <p:nvCxnSpPr>
-          <p:cNvPr id="18" name=""/>
+          <p:cNvPr id="26" name=""/>
           <p:cNvCxnSpPr>
             <a:stCxn xmlns:a="http://schemas.openxmlformats.org/drawingml/2006/main" id="4" idx="3"/>
             <a:endCxn xmlns:a="http://schemas.openxmlformats.org/drawingml/2006/main" id="5" idx="1"/>
@@ -12494,6 +15082,7 @@
           <a:lstStyle xmlns:a="http://schemas.openxmlformats.org/drawingml/2006/main"/>
           <a:p xmlns:a="http://schemas.openxmlformats.org/drawingml/2006/main">
             <a:pPr algn="ctr">
+              <a:buNone/>
               <a:defRPr sz="2175" b="1">
                 <a:solidFill>
                   <a:srgbClr val="182C29"/>
@@ -12519,7 +15108,7 @@
       </p:sp>
       <p:cxnSp>
         <p:nvCxnSpPr>
-          <p:cNvPr id="20" name=""/>
+          <p:cNvPr id="28" name=""/>
           <p:cNvCxnSpPr>
             <a:stCxn xmlns:a="http://schemas.openxmlformats.org/drawingml/2006/main" id="5" idx="3"/>
             <a:endCxn xmlns:a="http://schemas.openxmlformats.org/drawingml/2006/main" id="7" idx="1"/>
@@ -12576,6 +15165,7 @@
           <a:lstStyle xmlns:a="http://schemas.openxmlformats.org/drawingml/2006/main"/>
           <a:p xmlns:a="http://schemas.openxmlformats.org/drawingml/2006/main">
             <a:pPr>
+              <a:buNone/>
               <a:defRPr sz="2250" b="0">
                 <a:solidFill>
                   <a:srgbClr val="182C29"/>
@@ -12599,6 +15189,7 @@
           </a:p>
           <a:p xmlns:a="http://schemas.openxmlformats.org/drawingml/2006/main">
             <a:pPr>
+              <a:buNone/>
               <a:defRPr sz="2250" b="0">
                 <a:solidFill>
                   <a:srgbClr val="182C29"/>
@@ -12656,6 +15247,7 @@
           <a:lstStyle xmlns:a="http://schemas.openxmlformats.org/drawingml/2006/main"/>
           <a:p xmlns:a="http://schemas.openxmlformats.org/drawingml/2006/main">
             <a:pPr>
+              <a:buNone/>
               <a:defRPr sz="2175" b="0">
                 <a:solidFill>
                   <a:srgbClr val="182C29"/>
@@ -12679,6 +15271,7 @@
           </a:p>
           <a:p xmlns:a="http://schemas.openxmlformats.org/drawingml/2006/main">
             <a:pPr>
+              <a:buNone/>
               <a:defRPr sz="2175" b="0">
                 <a:solidFill>
                   <a:srgbClr val="182C29"/>
@@ -12736,6 +15329,7 @@
           <a:lstStyle xmlns:a="http://schemas.openxmlformats.org/drawingml/2006/main"/>
           <a:p xmlns:a="http://schemas.openxmlformats.org/drawingml/2006/main">
             <a:pPr>
+              <a:buNone/>
               <a:defRPr sz="2100" b="0">
                 <a:solidFill>
                   <a:srgbClr val="182C29"/>
@@ -12759,6 +15353,7 @@
           </a:p>
           <a:p xmlns:a="http://schemas.openxmlformats.org/drawingml/2006/main">
             <a:pPr>
+              <a:buNone/>
               <a:defRPr sz="2100" b="0">
                 <a:solidFill>
                   <a:srgbClr val="182C29"/>
@@ -12816,6 +15411,7 @@
           <a:lstStyle xmlns:a="http://schemas.openxmlformats.org/drawingml/2006/main"/>
           <a:p xmlns:a="http://schemas.openxmlformats.org/drawingml/2006/main">
             <a:pPr>
+              <a:buNone/>
               <a:defRPr sz="2250" b="0">
                 <a:solidFill>
                   <a:srgbClr val="182C29"/>
@@ -12839,6 +15435,7 @@
           </a:p>
           <a:p xmlns:a="http://schemas.openxmlformats.org/drawingml/2006/main">
             <a:pPr>
+              <a:buNone/>
               <a:defRPr sz="2250" b="0">
                 <a:solidFill>
                   <a:srgbClr val="182C29"/>

</xml_diff>

<commit_message>
docs: add HSCodeComp definition and dataset hyperlink
</commit_message>
<xml_diff>
--- a/portfolio/crossborder-portfolio.pptx
+++ b/portfolio/crossborder-portfolio.pptx
@@ -2,30 +2,30 @@
 <file path=ppt/presentation.xml><?xml version="1.0" encoding="utf-8"?>
 <p:presentation xmlns:p="http://schemas.openxmlformats.org/presentationml/2006/main">
   <p:sldMasterIdLst>
-    <p:sldMasterId xmlns:r="http://schemas.openxmlformats.org/officeDocument/2006/relationships" id="2147483648" r:id="R3157283dd8794a62"/>
+    <p:sldMasterId xmlns:r="http://schemas.openxmlformats.org/officeDocument/2006/relationships" id="2147483648" r:id="Rfc73e56126214a4d"/>
   </p:sldMasterIdLst>
   <p:notesMasterIdLst>
-    <p:notesMasterId xmlns:r="http://schemas.openxmlformats.org/officeDocument/2006/relationships" r:id="R77263c22734d4965"/>
+    <p:notesMasterId xmlns:r="http://schemas.openxmlformats.org/officeDocument/2006/relationships" r:id="R6620ae9930944070"/>
   </p:notesMasterIdLst>
   <p:sldIdLst>
-    <p:sldId xmlns:r="http://schemas.openxmlformats.org/officeDocument/2006/relationships" id="256" r:id="R862a2ca4f3004e36"/>
-    <p:sldId xmlns:r="http://schemas.openxmlformats.org/officeDocument/2006/relationships" id="257" r:id="R54971af92ee74dff"/>
-    <p:sldId xmlns:r="http://schemas.openxmlformats.org/officeDocument/2006/relationships" id="258" r:id="Ref203dc51db1464d"/>
-    <p:sldId xmlns:r="http://schemas.openxmlformats.org/officeDocument/2006/relationships" id="259" r:id="Rc1e2cf908d0144af"/>
-    <p:sldId xmlns:r="http://schemas.openxmlformats.org/officeDocument/2006/relationships" id="260" r:id="R59d81729e3b84d1b"/>
-    <p:sldId xmlns:r="http://schemas.openxmlformats.org/officeDocument/2006/relationships" id="261" r:id="Reb139b5876264df3"/>
-    <p:sldId xmlns:r="http://schemas.openxmlformats.org/officeDocument/2006/relationships" id="262" r:id="Raf99b9311bba41aa"/>
-    <p:sldId xmlns:r="http://schemas.openxmlformats.org/officeDocument/2006/relationships" id="263" r:id="R42f678bd30394e8f"/>
-    <p:sldId xmlns:r="http://schemas.openxmlformats.org/officeDocument/2006/relationships" id="264" r:id="R28c9c9e9ef8e4171"/>
-    <p:sldId xmlns:r="http://schemas.openxmlformats.org/officeDocument/2006/relationships" id="265" r:id="R73329b35ee9141f3"/>
-    <p:sldId xmlns:r="http://schemas.openxmlformats.org/officeDocument/2006/relationships" id="266" r:id="R74b38976f44548dc"/>
-    <p:sldId xmlns:r="http://schemas.openxmlformats.org/officeDocument/2006/relationships" id="267" r:id="Rb4398cbde8fe4d59"/>
-    <p:sldId xmlns:r="http://schemas.openxmlformats.org/officeDocument/2006/relationships" id="268" r:id="Ra3108d3f84084d8d"/>
-    <p:sldId xmlns:r="http://schemas.openxmlformats.org/officeDocument/2006/relationships" id="269" r:id="Ra86c9de4263f4b6e"/>
-    <p:sldId xmlns:r="http://schemas.openxmlformats.org/officeDocument/2006/relationships" id="270" r:id="R7dd9ca1ed5b043f4"/>
-    <p:sldId xmlns:r="http://schemas.openxmlformats.org/officeDocument/2006/relationships" id="271" r:id="R2fedfa829ac94987"/>
-    <p:sldId xmlns:r="http://schemas.openxmlformats.org/officeDocument/2006/relationships" id="272" r:id="Rce8bd3a6ae90499f"/>
-    <p:sldId xmlns:r="http://schemas.openxmlformats.org/officeDocument/2006/relationships" id="273" r:id="Rb603702e941f42c8"/>
+    <p:sldId xmlns:r="http://schemas.openxmlformats.org/officeDocument/2006/relationships" id="256" r:id="R4620abbc58554d17"/>
+    <p:sldId xmlns:r="http://schemas.openxmlformats.org/officeDocument/2006/relationships" id="257" r:id="R2ab673175a354639"/>
+    <p:sldId xmlns:r="http://schemas.openxmlformats.org/officeDocument/2006/relationships" id="258" r:id="R8ca2ada2006344a6"/>
+    <p:sldId xmlns:r="http://schemas.openxmlformats.org/officeDocument/2006/relationships" id="259" r:id="R71d6a37f70814a9a"/>
+    <p:sldId xmlns:r="http://schemas.openxmlformats.org/officeDocument/2006/relationships" id="260" r:id="R797e253fc39e47b8"/>
+    <p:sldId xmlns:r="http://schemas.openxmlformats.org/officeDocument/2006/relationships" id="261" r:id="Raafd823886724e21"/>
+    <p:sldId xmlns:r="http://schemas.openxmlformats.org/officeDocument/2006/relationships" id="262" r:id="Reda0ddb6f15345fa"/>
+    <p:sldId xmlns:r="http://schemas.openxmlformats.org/officeDocument/2006/relationships" id="263" r:id="Rd82faf79885e4808"/>
+    <p:sldId xmlns:r="http://schemas.openxmlformats.org/officeDocument/2006/relationships" id="264" r:id="R14b781f27b6a4565"/>
+    <p:sldId xmlns:r="http://schemas.openxmlformats.org/officeDocument/2006/relationships" id="265" r:id="R26ff4dc103e84640"/>
+    <p:sldId xmlns:r="http://schemas.openxmlformats.org/officeDocument/2006/relationships" id="266" r:id="R4772e337f96f45e0"/>
+    <p:sldId xmlns:r="http://schemas.openxmlformats.org/officeDocument/2006/relationships" id="267" r:id="Ra2fb7ba48b654043"/>
+    <p:sldId xmlns:r="http://schemas.openxmlformats.org/officeDocument/2006/relationships" id="268" r:id="Rd523a707c0284741"/>
+    <p:sldId xmlns:r="http://schemas.openxmlformats.org/officeDocument/2006/relationships" id="269" r:id="R5c6686d4688c4b21"/>
+    <p:sldId xmlns:r="http://schemas.openxmlformats.org/officeDocument/2006/relationships" id="270" r:id="R904f62015ba6407d"/>
+    <p:sldId xmlns:r="http://schemas.openxmlformats.org/officeDocument/2006/relationships" id="271" r:id="R81acc5ce41114022"/>
+    <p:sldId xmlns:r="http://schemas.openxmlformats.org/officeDocument/2006/relationships" id="272" r:id="Rd6d16cc6f8014e6f"/>
+    <p:sldId xmlns:r="http://schemas.openxmlformats.org/officeDocument/2006/relationships" id="273" r:id="Rd18ecd584ff941d3"/>
   </p:sldIdLst>
   <p:sldSz cx="15240000" cy="8572500"/>
   <p:notesSz cx="6858000" cy="9144000"/>
@@ -949,7 +949,7 @@
           <a:lstStyle xmlns:a="http://schemas.openxmlformats.org/drawingml/2006/main"/>
           <a:p xmlns:a="http://schemas.openxmlformats.org/drawingml/2006/main">
             <a:r>
-              <a:t>https://github.com/y00nZZang/product-catalog/blob/main/docs/jev-experiment-2026-10-06.md ; https://github.com/y00nZZang/product-catalog/blob/main/notebooks/two-datasets-results-2026-10-06.json ; https://docs.typesafe.ai/primitives/choice ; https://huggingface.co/datasets/ATH-MaaS/HSCodeComp . 실험은 운영 서비스 변경이나 전체 URL 분석시간 비교가 아니다.</a:t>
+              <a:t>HSCodeComp: 실제 전자상거래 상품632개,32개 대분류에 전문가가 미국 기준10자리 코드를 주석한 공개 벤치마크. 본 실험은94개 표본의 앞6자리HS6와 비교. https://huggingface.co/datasets/ATH-MaaS/HSCodeComp ; https://arxiv.org/abs/2510.19631 ; https://github.com/y00nZZang/product-catalog/blob/main/docs/jev-experiment-2026-10-06.md . 공식 한국 HSK 결정문이나 사람의 현지 재검토로 간주하지 않는다.</a:t>
             </a:r>
           </a:p>
         </p:txBody>
@@ -1717,7 +1717,7 @@
   </p:cSld>
   <p:clrMap bg1="lt1" tx1="dk1" bg2="lt2" tx2="dk2" accent1="accent1" accent2="accent2" accent3="accent3" accent4="accent4" accent5="accent5" accent6="accent6" hlink="hlink" folHlink="folHlink"/>
   <p:sldLayoutIdLst>
-    <p:sldLayoutId xmlns:r="http://schemas.openxmlformats.org/officeDocument/2006/relationships" id="2147483649" r:id="R9b4a47241f8b4d6b"/>
+    <p:sldLayoutId xmlns:r="http://schemas.openxmlformats.org/officeDocument/2006/relationships" id="2147483649" r:id="R55975cbe5f7e467a"/>
   </p:sldLayoutIdLst>
   <p:txStyles>
     <p:titleStyle>
@@ -3134,7 +3134,7 @@
           <p:nvPr/>
         </p:nvPicPr>
         <p:blipFill>
-          <a:blip xmlns:r="http://schemas.openxmlformats.org/officeDocument/2006/relationships" xmlns:a="http://schemas.openxmlformats.org/drawingml/2006/main" r:embed="Ra655bc335cb84b21"/>
+          <a:blip xmlns:r="http://schemas.openxmlformats.org/officeDocument/2006/relationships" xmlns:a="http://schemas.openxmlformats.org/drawingml/2006/main" r:embed="R9cf8175e2ec14e4d"/>
           <a:stretch xmlns:a="http://schemas.openxmlformats.org/drawingml/2006/main"/>
         </p:blipFill>
         <p:spPr>
@@ -3776,7 +3776,7 @@
       </p:sp>
       <p:cxnSp>
         <p:nvCxnSpPr>
-          <p:cNvPr id="27" name=""/>
+          <p:cNvPr id="35" name=""/>
           <p:cNvCxnSpPr>
             <a:stCxn xmlns:a="http://schemas.openxmlformats.org/drawingml/2006/main" id="4" idx="3"/>
             <a:endCxn xmlns:a="http://schemas.openxmlformats.org/drawingml/2006/main" id="5" idx="1"/>
@@ -3861,7 +3861,7 @@
       </p:sp>
       <p:cxnSp>
         <p:nvCxnSpPr>
-          <p:cNvPr id="29" name=""/>
+          <p:cNvPr id="37" name=""/>
           <p:cNvCxnSpPr>
             <a:stCxn xmlns:a="http://schemas.openxmlformats.org/drawingml/2006/main" id="5" idx="3"/>
             <a:endCxn xmlns:a="http://schemas.openxmlformats.org/drawingml/2006/main" id="7" idx="1"/>
@@ -6671,7 +6671,7 @@
       </p:sp>
       <p:cxnSp>
         <p:nvCxnSpPr>
-          <p:cNvPr id="27" name=""/>
+          <p:cNvPr id="36" name=""/>
           <p:cNvCxnSpPr>
             <a:stCxn xmlns:a="http://schemas.openxmlformats.org/drawingml/2006/main" id="5" idx="3"/>
             <a:endCxn xmlns:a="http://schemas.openxmlformats.org/drawingml/2006/main" id="6" idx="1"/>
@@ -6756,7 +6756,7 @@
       </p:sp>
       <p:cxnSp>
         <p:nvCxnSpPr>
-          <p:cNvPr id="29" name=""/>
+          <p:cNvPr id="38" name=""/>
           <p:cNvCxnSpPr>
             <a:stCxn xmlns:a="http://schemas.openxmlformats.org/drawingml/2006/main" id="6" idx="3"/>
             <a:endCxn xmlns:a="http://schemas.openxmlformats.org/drawingml/2006/main" id="8" idx="1"/>
@@ -7006,6 +7006,7 @@
           <a:lstStyle xmlns:a="http://schemas.openxmlformats.org/drawingml/2006/main"/>
           <a:p xmlns:a="http://schemas.openxmlformats.org/drawingml/2006/main">
             <a:pPr>
+              <a:buNone/>
               <a:defRPr sz="3675" b="1">
                 <a:solidFill>
                   <a:srgbClr val="182C29"/>
@@ -7063,6 +7064,7 @@
           <a:lstStyle xmlns:a="http://schemas.openxmlformats.org/drawingml/2006/main"/>
           <a:p xmlns:a="http://schemas.openxmlformats.org/drawingml/2006/main">
             <a:pPr>
+              <a:buNone/>
               <a:defRPr sz="2100" b="0">
                 <a:solidFill>
                   <a:srgbClr val="5E706B"/>
@@ -7120,6 +7122,7 @@
           <a:lstStyle xmlns:a="http://schemas.openxmlformats.org/drawingml/2006/main"/>
           <a:p xmlns:a="http://schemas.openxmlformats.org/drawingml/2006/main">
             <a:pPr>
+              <a:buNone/>
               <a:defRPr sz="1350" b="0">
                 <a:solidFill>
                   <a:srgbClr val="5E706B"/>
@@ -7177,55 +7180,57 @@
           <a:lstStyle xmlns:a="http://schemas.openxmlformats.org/drawingml/2006/main"/>
           <a:p xmlns:a="http://schemas.openxmlformats.org/drawingml/2006/main">
             <a:pPr>
-              <a:defRPr sz="2475" b="0">
-                <a:solidFill>
-                  <a:srgbClr val="182C29"/>
-                </a:solidFill>
-                <a:latin typeface="Apple SD Gothic Neo"/>
-                <a:ea typeface="Apple SD Gothic Neo"/>
-                <a:cs typeface="Apple SD Gothic Neo"/>
-              </a:defRPr>
-            </a:pPr>
-            <a:r>
-              <a:rPr sz="2475" b="0">
-                <a:solidFill>
-                  <a:srgbClr val="182C29"/>
-                </a:solidFill>
-                <a:latin typeface="Apple SD Gothic Neo"/>
-                <a:ea typeface="Apple SD Gothic Neo"/>
-                <a:cs typeface="Apple SD Gothic Neo"/>
-              </a:rPr>
-              <a:t>문장을 생성하는 LLM과, 정해진 후보·확률을 반환하는 Jev를 비교했습니다.</a:t>
-            </a:r>
-          </a:p>
-          <a:p xmlns:a="http://schemas.openxmlformats.org/drawingml/2006/main">
-            <a:pPr>
-              <a:defRPr sz="2475" b="0">
-                <a:solidFill>
-                  <a:srgbClr val="182C29"/>
-                </a:solidFill>
-                <a:latin typeface="Apple SD Gothic Neo"/>
-                <a:ea typeface="Apple SD Gothic Neo"/>
-                <a:cs typeface="Apple SD Gothic Neo"/>
-              </a:defRPr>
-            </a:pPr>
-            <a:r>
-              <a:rPr sz="2475" b="0">
-                <a:solidFill>
-                  <a:srgbClr val="182C29"/>
-                </a:solidFill>
-                <a:latin typeface="Apple SD Gothic Neo"/>
-                <a:ea typeface="Apple SD Gothic Neo"/>
-                <a:cs typeface="Apple SD Gothic Neo"/>
-              </a:rPr>
-              <a:t>상품 입력과 공식 HS 목록을 동일하게 제공해 2→4→6자리 경로를 선택했습니다.</a:t>
+              <a:buNone/>
+              <a:defRPr sz="2250" b="0">
+                <a:solidFill>
+                  <a:srgbClr val="182C29"/>
+                </a:solidFill>
+                <a:latin typeface="Apple SD Gothic Neo"/>
+                <a:ea typeface="Apple SD Gothic Neo"/>
+                <a:cs typeface="Apple SD Gothic Neo"/>
+              </a:defRPr>
+            </a:pPr>
+            <a:r>
+              <a:rPr sz="2250" b="0">
+                <a:solidFill>
+                  <a:srgbClr val="182C29"/>
+                </a:solidFill>
+                <a:latin typeface="Apple SD Gothic Neo"/>
+                <a:ea typeface="Apple SD Gothic Neo"/>
+                <a:cs typeface="Apple SD Gothic Neo"/>
+              </a:rPr>
+              <a:t>HSCodeComp는 실제 전자상거래 상품632개에 전문가가 HS 코드를 붙인 공개 평가셋입니다.</a:t>
+            </a:r>
+          </a:p>
+          <a:p xmlns:a="http://schemas.openxmlformats.org/drawingml/2006/main">
+            <a:pPr>
+              <a:buNone/>
+              <a:defRPr sz="2250" b="0">
+                <a:solidFill>
+                  <a:srgbClr val="182C29"/>
+                </a:solidFill>
+                <a:latin typeface="Apple SD Gothic Neo"/>
+                <a:ea typeface="Apple SD Gothic Neo"/>
+                <a:cs typeface="Apple SD Gothic Neo"/>
+              </a:defRPr>
+            </a:pPr>
+            <a:r>
+              <a:rPr sz="2250" b="0">
+                <a:solidFill>
+                  <a:srgbClr val="182C29"/>
+                </a:solidFill>
+                <a:latin typeface="Apple SD Gothic Neo"/>
+                <a:ea typeface="Apple SD Gothic Neo"/>
+                <a:cs typeface="Apple SD Gothic Neo"/>
+              </a:rPr>
+              <a:t>상품명·속성·카테고리를 제공하며, 이번에는94개 표본의 HS6 정답과 비교했습니다.</a:t>
             </a:r>
           </a:p>
         </p:txBody>
       </p:sp>
       <p:graphicFrame>
         <p:nvGraphicFramePr>
-          <p:cNvPr id="12" name=""/>
+          <p:cNvPr id="14" name=""/>
           <p:cNvGraphicFramePr/>
           <p:nvPr/>
         </p:nvGraphicFramePr>
@@ -7484,8 +7489,8 @@
         </p:nvSpPr>
         <p:spPr>
           <a:xfrm xmlns:a="http://schemas.openxmlformats.org/drawingml/2006/main">
-            <a:off x="819150" y="6810375"/>
-            <a:ext cx="13525500" cy="571500"/>
+            <a:off x="819150" y="6734175"/>
+            <a:ext cx="13525500" cy="685800"/>
           </a:xfrm>
           <a:prstGeom xmlns:a="http://schemas.openxmlformats.org/drawingml/2006/main" prst="rect">
             <a:avLst/>
@@ -7502,25 +7507,50 @@
           <a:lstStyle xmlns:a="http://schemas.openxmlformats.org/drawingml/2006/main"/>
           <a:p xmlns:a="http://schemas.openxmlformats.org/drawingml/2006/main">
             <a:pPr>
-              <a:defRPr sz="2025" b="0">
-                <a:solidFill>
-                  <a:srgbClr val="182C29"/>
-                </a:solidFill>
-                <a:latin typeface="Apple SD Gothic Neo"/>
-                <a:ea typeface="Apple SD Gothic Neo"/>
-                <a:cs typeface="Apple SD Gothic Neo"/>
-              </a:defRPr>
-            </a:pPr>
-            <a:r>
-              <a:rPr sz="2025" b="0">
-                <a:solidFill>
-                  <a:srgbClr val="182C29"/>
-                </a:solidFill>
-                <a:latin typeface="Apple SD Gothic Neo"/>
-                <a:ea typeface="Apple SD Gothic Neo"/>
-                <a:cs typeface="Apple SD Gothic Neo"/>
-              </a:rPr>
-              <a:t>비교: Jev 1.13 ↔ GPT-6 Luna low. 심사자는 기존 예측과 공급사 이름을 보지 않았습니다.</a:t>
+              <a:buNone/>
+              <a:defRPr sz="1875" b="0">
+                <a:solidFill>
+                  <a:srgbClr val="5E706B"/>
+                </a:solidFill>
+                <a:latin typeface="Apple SD Gothic Neo"/>
+                <a:ea typeface="Apple SD Gothic Neo"/>
+                <a:cs typeface="Apple SD Gothic Neo"/>
+              </a:defRPr>
+            </a:pPr>
+            <a:r>
+              <a:rPr sz="1875" b="0">
+                <a:solidFill>
+                  <a:srgbClr val="5E706B"/>
+                </a:solidFill>
+                <a:latin typeface="Apple SD Gothic Neo"/>
+                <a:ea typeface="Apple SD Gothic Neo"/>
+                <a:cs typeface="Apple SD Gothic Neo"/>
+              </a:rPr>
+              <a:t>비교: Jev1.13 ↔ GPT-6 Luna low. 심사자는 기존 예측·공급사 이름을 보지 않았습니다.</a:t>
+            </a:r>
+          </a:p>
+          <a:p xmlns:a="http://schemas.openxmlformats.org/drawingml/2006/main">
+            <a:pPr>
+              <a:buNone/>
+              <a:defRPr sz="1875" b="0">
+                <a:solidFill>
+                  <a:srgbClr val="5E706B"/>
+                </a:solidFill>
+                <a:latin typeface="Apple SD Gothic Neo"/>
+                <a:ea typeface="Apple SD Gothic Neo"/>
+                <a:cs typeface="Apple SD Gothic Neo"/>
+              </a:defRPr>
+            </a:pPr>
+            <a:r>
+              <a:rPr sz="1875" b="0">
+                <a:solidFill>
+                  <a:srgbClr val="5E706B"/>
+                </a:solidFill>
+                <a:latin typeface="Apple SD Gothic Neo"/>
+                <a:ea typeface="Apple SD Gothic Neo"/>
+                <a:cs typeface="Apple SD Gothic Neo"/>
+              </a:rPr>
+              <a:t>텍스트만 사용한 단일 경로 비교이며 웹 검색·이미지 분석을 제외했습니다.</a:t>
             </a:r>
           </a:p>
         </p:txBody>
@@ -7559,9 +7589,10 @@
           <a:lstStyle xmlns:a="http://schemas.openxmlformats.org/drawingml/2006/main"/>
           <a:p xmlns:a="http://schemas.openxmlformats.org/drawingml/2006/main">
             <a:pPr>
+              <a:buNone/>
               <a:defRPr sz="1725" b="0">
                 <a:solidFill>
-                  <a:srgbClr val="5E706B"/>
+                  <a:srgbClr val="156E58"/>
                 </a:solidFill>
                 <a:latin typeface="Apple SD Gothic Neo"/>
                 <a:ea typeface="Apple SD Gothic Neo"/>
@@ -7571,13 +7602,25 @@
             <a:r>
               <a:rPr sz="1725" b="0">
                 <a:solidFill>
-                  <a:srgbClr val="5E706B"/>
-                </a:solidFill>
-                <a:latin typeface="Apple SD Gothic Neo"/>
-                <a:ea typeface="Apple SD Gothic Neo"/>
-                <a:cs typeface="Apple SD Gothic Neo"/>
-              </a:rPr>
-              <a:t>텍스트만 사용한 단일 경로 실험입니다. 웹 검색·이미지 분석·정답으로 후보 축소는 하지 않았습니다.</a:t>
+                  <a:srgbClr val="156E58"/>
+                </a:solidFill>
+                <a:latin typeface="Apple SD Gothic Neo"/>
+                <a:ea typeface="Apple SD Gothic Neo"/>
+                <a:cs typeface="Apple SD Gothic Neo"/>
+              </a:rPr>
+              <a:t>데이터셋 원본: </a:t>
+            </a:r>
+            <a:r>
+              <a:rPr sz="1725" b="0">
+                <a:solidFill>
+                  <a:srgbClr val="156E58"/>
+                </a:solidFill>
+                <a:latin typeface="Apple SD Gothic Neo"/>
+                <a:ea typeface="Apple SD Gothic Neo"/>
+                <a:cs typeface="Apple SD Gothic Neo"/>
+                <a:hlinkClick xmlns:r="http://schemas.openxmlformats.org/officeDocument/2006/relationships" r:id="Rafd9e5ae71504e74"/>
+              </a:rPr>
+              <a:t>huggingface.co/datasets/ATH-MaaS/HSCodeComp</a:t>
             </a:r>
           </a:p>
         </p:txBody>
@@ -7645,6 +7688,7 @@
           <a:lstStyle xmlns:a="http://schemas.openxmlformats.org/drawingml/2006/main"/>
           <a:p xmlns:a="http://schemas.openxmlformats.org/drawingml/2006/main">
             <a:pPr>
+              <a:buNone/>
               <a:defRPr sz="3675" b="1">
                 <a:solidFill>
                   <a:srgbClr val="182C29"/>
@@ -7702,6 +7746,7 @@
           <a:lstStyle xmlns:a="http://schemas.openxmlformats.org/drawingml/2006/main"/>
           <a:p xmlns:a="http://schemas.openxmlformats.org/drawingml/2006/main">
             <a:pPr>
+              <a:buNone/>
               <a:defRPr sz="2100" b="0">
                 <a:solidFill>
                   <a:srgbClr val="5E706B"/>
@@ -7759,6 +7804,7 @@
           <a:lstStyle xmlns:a="http://schemas.openxmlformats.org/drawingml/2006/main"/>
           <a:p xmlns:a="http://schemas.openxmlformats.org/drawingml/2006/main">
             <a:pPr>
+              <a:buNone/>
               <a:defRPr sz="1350" b="0">
                 <a:solidFill>
                   <a:srgbClr val="5E706B"/>
@@ -7784,7 +7830,7 @@
       </p:sp>
       <p:graphicFrame>
         <p:nvGraphicFramePr>
-          <p:cNvPr id="15" name="Chart"/>
+          <p:cNvPr id="17" name="Chart"/>
           <p:cNvGraphicFramePr/>
           <p:nvPr/>
         </p:nvGraphicFramePr>
@@ -7794,7 +7840,7 @@
         </p:xfrm>
         <a:graphic xmlns:a="http://schemas.openxmlformats.org/drawingml/2006/main">
           <a:graphicData uri="http://schemas.openxmlformats.org/drawingml/2006/chart">
-            <c:chart xmlns:r="http://schemas.openxmlformats.org/officeDocument/2006/relationships" xmlns:c="http://schemas.openxmlformats.org/drawingml/2006/chart" r:id="Rf3f219ec14d3420b"/>
+            <c:chart xmlns:r="http://schemas.openxmlformats.org/officeDocument/2006/relationships" xmlns:c="http://schemas.openxmlformats.org/drawingml/2006/chart" r:id="R8867b879a4614beb"/>
           </a:graphicData>
         </a:graphic>
       </p:graphicFrame>
@@ -7832,6 +7878,7 @@
           <a:lstStyle xmlns:a="http://schemas.openxmlformats.org/drawingml/2006/main"/>
           <a:p xmlns:a="http://schemas.openxmlformats.org/drawingml/2006/main">
             <a:pPr>
+              <a:buNone/>
               <a:defRPr sz="2400" b="1">
                 <a:solidFill>
                   <a:srgbClr val="156E58"/>
@@ -7889,6 +7936,7 @@
           <a:lstStyle xmlns:a="http://schemas.openxmlformats.org/drawingml/2006/main"/>
           <a:p xmlns:a="http://schemas.openxmlformats.org/drawingml/2006/main">
             <a:pPr>
+              <a:buNone/>
               <a:defRPr sz="3150" b="1">
                 <a:solidFill>
                   <a:srgbClr val="182C29"/>
@@ -7946,6 +7994,7 @@
           <a:lstStyle xmlns:a="http://schemas.openxmlformats.org/drawingml/2006/main"/>
           <a:p xmlns:a="http://schemas.openxmlformats.org/drawingml/2006/main">
             <a:pPr>
+              <a:buNone/>
               <a:defRPr sz="2100" b="0">
                 <a:solidFill>
                   <a:srgbClr val="182C29"/>
@@ -8003,6 +8052,7 @@
           <a:lstStyle xmlns:a="http://schemas.openxmlformats.org/drawingml/2006/main"/>
           <a:p xmlns:a="http://schemas.openxmlformats.org/drawingml/2006/main">
             <a:pPr>
+              <a:buNone/>
               <a:defRPr sz="2400" b="1">
                 <a:solidFill>
                   <a:srgbClr val="156E58"/>
@@ -8060,6 +8110,7 @@
           <a:lstStyle xmlns:a="http://schemas.openxmlformats.org/drawingml/2006/main"/>
           <a:p xmlns:a="http://schemas.openxmlformats.org/drawingml/2006/main">
             <a:pPr>
+              <a:buNone/>
               <a:defRPr sz="3150" b="1">
                 <a:solidFill>
                   <a:srgbClr val="182C29"/>
@@ -8117,6 +8168,7 @@
           <a:lstStyle xmlns:a="http://schemas.openxmlformats.org/drawingml/2006/main"/>
           <a:p xmlns:a="http://schemas.openxmlformats.org/drawingml/2006/main">
             <a:pPr>
+              <a:buNone/>
               <a:defRPr sz="2100" b="0">
                 <a:solidFill>
                   <a:srgbClr val="182C29"/>
@@ -8174,6 +8226,7 @@
           <a:lstStyle xmlns:a="http://schemas.openxmlformats.org/drawingml/2006/main"/>
           <a:p xmlns:a="http://schemas.openxmlformats.org/drawingml/2006/main">
             <a:pPr>
+              <a:buNone/>
               <a:defRPr sz="1875" b="0">
                 <a:solidFill>
                   <a:srgbClr val="5E706B"/>
@@ -8260,6 +8313,7 @@
           <a:lstStyle xmlns:a="http://schemas.openxmlformats.org/drawingml/2006/main"/>
           <a:p xmlns:a="http://schemas.openxmlformats.org/drawingml/2006/main">
             <a:pPr>
+              <a:buNone/>
               <a:defRPr sz="3675" b="1">
                 <a:solidFill>
                   <a:srgbClr val="182C29"/>
@@ -8317,6 +8371,7 @@
           <a:lstStyle xmlns:a="http://schemas.openxmlformats.org/drawingml/2006/main"/>
           <a:p xmlns:a="http://schemas.openxmlformats.org/drawingml/2006/main">
             <a:pPr>
+              <a:buNone/>
               <a:defRPr sz="2100" b="0">
                 <a:solidFill>
                   <a:srgbClr val="5E706B"/>
@@ -8374,6 +8429,7 @@
           <a:lstStyle xmlns:a="http://schemas.openxmlformats.org/drawingml/2006/main"/>
           <a:p xmlns:a="http://schemas.openxmlformats.org/drawingml/2006/main">
             <a:pPr>
+              <a:buNone/>
               <a:defRPr sz="1350" b="0">
                 <a:solidFill>
                   <a:srgbClr val="5E706B"/>
@@ -8399,7 +8455,7 @@
       </p:sp>
       <p:graphicFrame>
         <p:nvGraphicFramePr>
-          <p:cNvPr id="11" name=""/>
+          <p:cNvPr id="13" name=""/>
           <p:cNvGraphicFramePr/>
           <p:nvPr/>
         </p:nvGraphicFramePr>
@@ -8750,6 +8806,7 @@
           <a:lstStyle xmlns:a="http://schemas.openxmlformats.org/drawingml/2006/main"/>
           <a:p xmlns:a="http://schemas.openxmlformats.org/drawingml/2006/main">
             <a:pPr>
+              <a:buNone/>
               <a:defRPr sz="2025" b="0">
                 <a:solidFill>
                   <a:srgbClr val="5E706B"/>
@@ -8807,6 +8864,7 @@
           <a:lstStyle xmlns:a="http://schemas.openxmlformats.org/drawingml/2006/main"/>
           <a:p xmlns:a="http://schemas.openxmlformats.org/drawingml/2006/main">
             <a:pPr>
+              <a:buNone/>
               <a:defRPr sz="2250" b="1">
                 <a:solidFill>
                   <a:srgbClr val="156E58"/>
@@ -8864,6 +8922,7 @@
           <a:lstStyle xmlns:a="http://schemas.openxmlformats.org/drawingml/2006/main"/>
           <a:p xmlns:a="http://schemas.openxmlformats.org/drawingml/2006/main">
             <a:pPr>
+              <a:buNone/>
               <a:defRPr sz="1725" b="0">
                 <a:solidFill>
                   <a:srgbClr val="5E706B"/>
@@ -10234,7 +10293,7 @@
           <p:nvPr/>
         </p:nvPicPr>
         <p:blipFill>
-          <a:blip xmlns:r="http://schemas.openxmlformats.org/officeDocument/2006/relationships" xmlns:a="http://schemas.openxmlformats.org/drawingml/2006/main" r:embed="R5dd6ef231bbc4553"/>
+          <a:blip xmlns:r="http://schemas.openxmlformats.org/officeDocument/2006/relationships" xmlns:a="http://schemas.openxmlformats.org/drawingml/2006/main" r:embed="R222b191908ff469c"/>
           <a:stretch xmlns:a="http://schemas.openxmlformats.org/drawingml/2006/main"/>
         </p:blipFill>
         <p:spPr>
@@ -13039,7 +13098,7 @@
       </p:sp>
       <p:cxnSp>
         <p:nvCxnSpPr>
-          <p:cNvPr id="37" name=""/>
+          <p:cNvPr id="49" name=""/>
           <p:cNvCxnSpPr>
             <a:stCxn xmlns:a="http://schemas.openxmlformats.org/drawingml/2006/main" id="4" idx="3"/>
             <a:endCxn xmlns:a="http://schemas.openxmlformats.org/drawingml/2006/main" id="5" idx="1"/>
@@ -13124,7 +13183,7 @@
       </p:sp>
       <p:cxnSp>
         <p:nvCxnSpPr>
-          <p:cNvPr id="39" name=""/>
+          <p:cNvPr id="51" name=""/>
           <p:cNvCxnSpPr>
             <a:stCxn xmlns:a="http://schemas.openxmlformats.org/drawingml/2006/main" id="5" idx="3"/>
             <a:endCxn xmlns:a="http://schemas.openxmlformats.org/drawingml/2006/main" id="7" idx="1"/>
@@ -13209,7 +13268,7 @@
       </p:sp>
       <p:cxnSp>
         <p:nvCxnSpPr>
-          <p:cNvPr id="41" name=""/>
+          <p:cNvPr id="53" name=""/>
           <p:cNvCxnSpPr>
             <a:stCxn xmlns:a="http://schemas.openxmlformats.org/drawingml/2006/main" id="7" idx="3"/>
             <a:endCxn xmlns:a="http://schemas.openxmlformats.org/drawingml/2006/main" id="9" idx="1"/>
@@ -13294,7 +13353,7 @@
       </p:sp>
       <p:cxnSp>
         <p:nvCxnSpPr>
-          <p:cNvPr id="43" name=""/>
+          <p:cNvPr id="55" name=""/>
           <p:cNvCxnSpPr>
             <a:stCxn xmlns:a="http://schemas.openxmlformats.org/drawingml/2006/main" id="9" idx="3"/>
             <a:endCxn xmlns:a="http://schemas.openxmlformats.org/drawingml/2006/main" id="11" idx="1"/>
@@ -14569,7 +14628,7 @@
           <p:nvPr/>
         </p:nvPicPr>
         <p:blipFill>
-          <a:blip xmlns:r="http://schemas.openxmlformats.org/officeDocument/2006/relationships" xmlns:a="http://schemas.openxmlformats.org/drawingml/2006/main" r:embed="Rfb0b81b56d264eff"/>
+          <a:blip xmlns:r="http://schemas.openxmlformats.org/officeDocument/2006/relationships" xmlns:a="http://schemas.openxmlformats.org/drawingml/2006/main" r:embed="R24eaa77ad35f4beb"/>
           <a:stretch xmlns:a="http://schemas.openxmlformats.org/drawingml/2006/main"/>
         </p:blipFill>
         <p:spPr>
@@ -15023,7 +15082,7 @@
       </p:sp>
       <p:cxnSp>
         <p:nvCxnSpPr>
-          <p:cNvPr id="26" name=""/>
+          <p:cNvPr id="34" name=""/>
           <p:cNvCxnSpPr>
             <a:stCxn xmlns:a="http://schemas.openxmlformats.org/drawingml/2006/main" id="4" idx="3"/>
             <a:endCxn xmlns:a="http://schemas.openxmlformats.org/drawingml/2006/main" id="5" idx="1"/>
@@ -15108,7 +15167,7 @@
       </p:sp>
       <p:cxnSp>
         <p:nvCxnSpPr>
-          <p:cNvPr id="28" name=""/>
+          <p:cNvPr id="36" name=""/>
           <p:cNvCxnSpPr>
             <a:stCxn xmlns:a="http://schemas.openxmlformats.org/drawingml/2006/main" id="5" idx="3"/>
             <a:endCxn xmlns:a="http://schemas.openxmlformats.org/drawingml/2006/main" id="7" idx="1"/>

</xml_diff>

<commit_message>
Update Jev appendix with service-scoped time and cost evidence
</commit_message>
<xml_diff>
--- a/portfolio/crossborder-portfolio.pptx
+++ b/portfolio/crossborder-portfolio.pptx
@@ -2,30 +2,30 @@
 <file path=ppt/presentation.xml><?xml version="1.0" encoding="utf-8"?>
 <p:presentation xmlns:p="http://schemas.openxmlformats.org/presentationml/2006/main">
   <p:sldMasterIdLst>
-    <p:sldMasterId xmlns:r="http://schemas.openxmlformats.org/officeDocument/2006/relationships" id="2147483648" r:id="Rfc73e56126214a4d"/>
+    <p:sldMasterId xmlns:r="http://schemas.openxmlformats.org/officeDocument/2006/relationships" id="2147483648" r:id="Ra56d68c42fbb43a4"/>
   </p:sldMasterIdLst>
   <p:notesMasterIdLst>
-    <p:notesMasterId xmlns:r="http://schemas.openxmlformats.org/officeDocument/2006/relationships" r:id="R6620ae9930944070"/>
+    <p:notesMasterId xmlns:r="http://schemas.openxmlformats.org/officeDocument/2006/relationships" r:id="R58e65546b5ec41dc"/>
   </p:notesMasterIdLst>
   <p:sldIdLst>
-    <p:sldId xmlns:r="http://schemas.openxmlformats.org/officeDocument/2006/relationships" id="256" r:id="R4620abbc58554d17"/>
-    <p:sldId xmlns:r="http://schemas.openxmlformats.org/officeDocument/2006/relationships" id="257" r:id="R2ab673175a354639"/>
-    <p:sldId xmlns:r="http://schemas.openxmlformats.org/officeDocument/2006/relationships" id="258" r:id="R8ca2ada2006344a6"/>
-    <p:sldId xmlns:r="http://schemas.openxmlformats.org/officeDocument/2006/relationships" id="259" r:id="R71d6a37f70814a9a"/>
-    <p:sldId xmlns:r="http://schemas.openxmlformats.org/officeDocument/2006/relationships" id="260" r:id="R797e253fc39e47b8"/>
-    <p:sldId xmlns:r="http://schemas.openxmlformats.org/officeDocument/2006/relationships" id="261" r:id="Raafd823886724e21"/>
-    <p:sldId xmlns:r="http://schemas.openxmlformats.org/officeDocument/2006/relationships" id="262" r:id="Reda0ddb6f15345fa"/>
-    <p:sldId xmlns:r="http://schemas.openxmlformats.org/officeDocument/2006/relationships" id="263" r:id="Rd82faf79885e4808"/>
-    <p:sldId xmlns:r="http://schemas.openxmlformats.org/officeDocument/2006/relationships" id="264" r:id="R14b781f27b6a4565"/>
-    <p:sldId xmlns:r="http://schemas.openxmlformats.org/officeDocument/2006/relationships" id="265" r:id="R26ff4dc103e84640"/>
-    <p:sldId xmlns:r="http://schemas.openxmlformats.org/officeDocument/2006/relationships" id="266" r:id="R4772e337f96f45e0"/>
-    <p:sldId xmlns:r="http://schemas.openxmlformats.org/officeDocument/2006/relationships" id="267" r:id="Ra2fb7ba48b654043"/>
-    <p:sldId xmlns:r="http://schemas.openxmlformats.org/officeDocument/2006/relationships" id="268" r:id="Rd523a707c0284741"/>
-    <p:sldId xmlns:r="http://schemas.openxmlformats.org/officeDocument/2006/relationships" id="269" r:id="R5c6686d4688c4b21"/>
-    <p:sldId xmlns:r="http://schemas.openxmlformats.org/officeDocument/2006/relationships" id="270" r:id="R904f62015ba6407d"/>
-    <p:sldId xmlns:r="http://schemas.openxmlformats.org/officeDocument/2006/relationships" id="271" r:id="R81acc5ce41114022"/>
-    <p:sldId xmlns:r="http://schemas.openxmlformats.org/officeDocument/2006/relationships" id="272" r:id="Rd6d16cc6f8014e6f"/>
-    <p:sldId xmlns:r="http://schemas.openxmlformats.org/officeDocument/2006/relationships" id="273" r:id="Rd18ecd584ff941d3"/>
+    <p:sldId xmlns:r="http://schemas.openxmlformats.org/officeDocument/2006/relationships" id="256" r:id="Ra4f0161fb4fd45e3"/>
+    <p:sldId xmlns:r="http://schemas.openxmlformats.org/officeDocument/2006/relationships" id="257" r:id="R93324130f41847b2"/>
+    <p:sldId xmlns:r="http://schemas.openxmlformats.org/officeDocument/2006/relationships" id="258" r:id="Raa59b28199364315"/>
+    <p:sldId xmlns:r="http://schemas.openxmlformats.org/officeDocument/2006/relationships" id="259" r:id="R8b357fa08a984173"/>
+    <p:sldId xmlns:r="http://schemas.openxmlformats.org/officeDocument/2006/relationships" id="260" r:id="R54383c14146d4815"/>
+    <p:sldId xmlns:r="http://schemas.openxmlformats.org/officeDocument/2006/relationships" id="261" r:id="R717176e21e0946bb"/>
+    <p:sldId xmlns:r="http://schemas.openxmlformats.org/officeDocument/2006/relationships" id="262" r:id="R0503203391ae4767"/>
+    <p:sldId xmlns:r="http://schemas.openxmlformats.org/officeDocument/2006/relationships" id="263" r:id="Rcb5688d1376243b7"/>
+    <p:sldId xmlns:r="http://schemas.openxmlformats.org/officeDocument/2006/relationships" id="264" r:id="R4953180543214287"/>
+    <p:sldId xmlns:r="http://schemas.openxmlformats.org/officeDocument/2006/relationships" id="265" r:id="Rd6bd13580fc54007"/>
+    <p:sldId xmlns:r="http://schemas.openxmlformats.org/officeDocument/2006/relationships" id="266" r:id="R047d32cdd79c4b7a"/>
+    <p:sldId xmlns:r="http://schemas.openxmlformats.org/officeDocument/2006/relationships" id="267" r:id="R52b493f1e3b54f86"/>
+    <p:sldId xmlns:r="http://schemas.openxmlformats.org/officeDocument/2006/relationships" id="268" r:id="Rf5024eb4406c4c88"/>
+    <p:sldId xmlns:r="http://schemas.openxmlformats.org/officeDocument/2006/relationships" id="269" r:id="R25e688f042b142e9"/>
+    <p:sldId xmlns:r="http://schemas.openxmlformats.org/officeDocument/2006/relationships" id="270" r:id="R0bf3e0af4376485f"/>
+    <p:sldId xmlns:r="http://schemas.openxmlformats.org/officeDocument/2006/relationships" id="271" r:id="Rddfa3c180f964570"/>
+    <p:sldId xmlns:r="http://schemas.openxmlformats.org/officeDocument/2006/relationships" id="272" r:id="R4268af0c7dd643d0"/>
+    <p:sldId xmlns:r="http://schemas.openxmlformats.org/officeDocument/2006/relationships" id="273" r:id="R0f43f7c3c6cd44e1"/>
   </p:sldIdLst>
   <p:sldSz cx="15240000" cy="8572500"/>
   <p:notesSz cx="6858000" cy="9144000"/>
@@ -949,7 +949,7 @@
           <a:lstStyle xmlns:a="http://schemas.openxmlformats.org/drawingml/2006/main"/>
           <a:p xmlns:a="http://schemas.openxmlformats.org/drawingml/2006/main">
             <a:r>
-              <a:t>HSCodeComp: 실제 전자상거래 상품632개,32개 대분류에 전문가가 미국 기준10자리 코드를 주석한 공개 벤치마크. 본 실험은94개 표본의 앞6자리HS6와 비교. https://huggingface.co/datasets/ATH-MaaS/HSCodeComp ; https://arxiv.org/abs/2510.19631 ; https://github.com/y00nZZang/product-catalog/blob/main/docs/jev-experiment-2026-10-06.md . 공식 한국 HSK 결정문이나 사람의 현지 재검토로 간주하지 않는다.</a:t>
+              <a:t>https://github.com/y00nZZang/product-catalog/blob/main/docs/service-scope-jev-experiment-2026-10-07.md ; https://huggingface.co/datasets/ATH-MaaS/HSCodeComp ; https://docs.typesafe.ai/primitives/choice . 서비스 범위는 연구 초안으로 사조의 검증된 정책이 아니다. 기존 단일 경로 Jev와 Luna만 비교. 정답/보류/실패는 공개 레포에서 확인.</a:t>
             </a:r>
           </a:p>
         </p:txBody>
@@ -1019,7 +1019,7 @@
           <a:lstStyle xmlns:a="http://schemas.openxmlformats.org/drawingml/2006/main"/>
           <a:p xmlns:a="http://schemas.openxmlformats.org/drawingml/2006/main">
             <a:r>
-              <a:t>https://github.com/y00nZZang/product-catalog/blob/main/docs/jev-experiment-2026-10-06.md . HF94개: Jev0.6747679375초/Luna4.296453624초, 비용0.023445996/0.0544944USD. Mercari30개:0.6689978755/3.79168373초, 비용0.00719754/0.01560205USD. 시간은 각 순차 HTTP+파싱+검증 시간 합의 중앙값. 공급사2개 동시 실행, 단계는 순차. 수집·포장·세금 계산·큐 대기시간 제외. 비용은 usage기반 추정, 청구서 확정액 아님.</a:t>
+              <a:t>https://github.com/y00nZZang/product-catalog/blob/main/docs/service-scope-jev-experiment-2026-10-07.md ; https://github.com/y00nZZang/product-catalog/blob/main/notebooks/service-scope-results-2026-10-07.json . 새로운93개 단일 경로 계층 탐색. Jev중앙0.6449865829199553초/Luna4.510487750987522초(반올림값, 상세JSON참조). 비용0.022579830000000002/0.052664375USD. 시간은 순차 HTTP+파싱+검증 합. 두 제공자는 같은 상품에서 동시 실행. 수집·큐·배송·세금 단계 제외. 비용usage기반 추정으로 실제 청구서 확정 아님. 품질/답변률/실패는 공개 레포에 별도기록, 비용이 판단품질을 의미하지 않는다.</a:t>
             </a:r>
           </a:p>
         </p:txBody>
@@ -1089,7 +1089,7 @@
           <a:lstStyle xmlns:a="http://schemas.openxmlformats.org/drawingml/2006/main"/>
           <a:p xmlns:a="http://schemas.openxmlformats.org/drawingml/2006/main">
             <a:r>
-              <a:t>https://github.com/y00nZZang/product-catalog/blob/main/docs/jev-experiment-2026-10-06.md ; https://github.com/y00nZZang/product-catalog/blob/main/notebooks/two-datasets-results-2026-10-06.json . HF94개: Jev28/94(29.8%), Luna36/94(38.3%), 보류 포함. 답변 사례만:28/81(34.6%),36/65(55.4%). 독립 Sol이HS6를 선택한Mercari25개에서Jev21/25(84%),Luna19/25(76%). 보류 포함30개 전체판단은Jev21/30(70%),Luna23/30(76.7%). Sol은정답/사람검토아님, 공유모델군편향가능. 운영도입하지않았으며 제안은 실험 결과에 대한 해석이다.</a:t>
+              <a:t>https://github.com/y00nZZang/product-catalog/blob/main/docs/service-scope-jev-experiment-2026-10-07.md ; https://github.com/y00nZZang/product-catalog/blob/main/notebooks/service-scope-failures-2026-10-07.json . 판단 품질의 동일성을 입증한 실험이 아니다. 후보 판단 단계 적용은 제안이며 서비스운영도입 아님. 과거전체94개, 범위안78개, 새93개를 레포에 구분 보존. 신규모델·복수경로·혼합방법은 후속실험에서 제외.</a:t>
             </a:r>
           </a:p>
         </p:txBody>
@@ -1717,7 +1717,7 @@
   </p:cSld>
   <p:clrMap bg1="lt1" tx1="dk1" bg2="lt2" tx2="dk2" accent1="accent1" accent2="accent2" accent3="accent3" accent4="accent4" accent5="accent5" accent6="accent6" hlink="hlink" folHlink="folHlink"/>
   <p:sldLayoutIdLst>
-    <p:sldLayoutId xmlns:r="http://schemas.openxmlformats.org/officeDocument/2006/relationships" id="2147483649" r:id="R55975cbe5f7e467a"/>
+    <p:sldLayoutId xmlns:r="http://schemas.openxmlformats.org/officeDocument/2006/relationships" id="2147483649" r:id="Rfe025f4721fd4067"/>
   </p:sldLayoutIdLst>
   <p:txStyles>
     <p:titleStyle>
@@ -2266,29 +2266,23 @@
           </c:spPr>
           <c:cat>
             <c:strRef>
-              <c:f>'Chart Data'!$A$2:$A$3</c:f>
+              <c:f>'Chart Data'!$A$2:$A$2</c:f>
               <c:strCache>
-                <c:ptCount val="2"/>
+                <c:ptCount val="1"/>
                 <c:pt idx="0">
-                  <c:v>HF 표본94개</c:v>
-                </c:pt>
-                <c:pt idx="1">
-                  <c:v>메루카리30개</c:v>
+                  <c:v>새 서비스 범위93개</c:v>
                 </c:pt>
               </c:strCache>
             </c:strRef>
           </c:cat>
           <c:val>
             <c:numRef>
-              <c:f>'Chart Data'!$B$2:$B$3</c:f>
+              <c:f>'Chart Data'!$B$2:$B$2</c:f>
               <c:numCache>
                 <c:formatCode>General</c:formatCode>
-                <c:ptCount val="2"/>
+                <c:ptCount val="1"/>
                 <c:pt idx="0">
-                  <c:v>0.675</c:v>
-                </c:pt>
-                <c:pt idx="1">
-                  <c:v>0.669</c:v>
+                  <c:v>0.645</c:v>
                 </c:pt>
               </c:numCache>
             </c:numRef>
@@ -2307,29 +2301,23 @@
           </c:spPr>
           <c:cat>
             <c:strRef>
-              <c:f>'Chart Data'!$C$2:$C$3</c:f>
+              <c:f>'Chart Data'!$C$2:$C$2</c:f>
               <c:strCache>
-                <c:ptCount val="2"/>
+                <c:ptCount val="1"/>
                 <c:pt idx="0">
-                  <c:v>HF 표본94개</c:v>
-                </c:pt>
-                <c:pt idx="1">
-                  <c:v>메루카리30개</c:v>
+                  <c:v>새 서비스 범위93개</c:v>
                 </c:pt>
               </c:strCache>
             </c:strRef>
           </c:cat>
           <c:val>
             <c:numRef>
-              <c:f>'Chart Data'!$D$2:$D$3</c:f>
+              <c:f>'Chart Data'!$D$2:$D$2</c:f>
               <c:numCache>
                 <c:formatCode>General</c:formatCode>
-                <c:ptCount val="2"/>
+                <c:ptCount val="1"/>
                 <c:pt idx="0">
-                  <c:v>4.296</c:v>
-                </c:pt>
-                <c:pt idx="1">
-                  <c:v>3.792</c:v>
+                  <c:v>4.51</c:v>
                 </c:pt>
               </c:numCache>
             </c:numRef>
@@ -2361,7 +2349,7 @@
           <c:showBubbleSize val="0"/>
           <c:showLeaderLines val="0"/>
         </c:dLbls>
-        <c:gapWidth val="90"/>
+        <c:gapWidth val="110"/>
         <c:axId val="48650112"/>
         <c:axId val="48672768"/>
       </c:barChart>
@@ -3134,7 +3122,7 @@
           <p:nvPr/>
         </p:nvPicPr>
         <p:blipFill>
-          <a:blip xmlns:r="http://schemas.openxmlformats.org/officeDocument/2006/relationships" xmlns:a="http://schemas.openxmlformats.org/drawingml/2006/main" r:embed="R9cf8175e2ec14e4d"/>
+          <a:blip xmlns:r="http://schemas.openxmlformats.org/officeDocument/2006/relationships" xmlns:a="http://schemas.openxmlformats.org/drawingml/2006/main" r:embed="R28a6c3b97fa147f7"/>
           <a:stretch xmlns:a="http://schemas.openxmlformats.org/drawingml/2006/main"/>
         </p:blipFill>
         <p:spPr>
@@ -3776,7 +3764,7 @@
       </p:sp>
       <p:cxnSp>
         <p:nvCxnSpPr>
-          <p:cNvPr id="35" name=""/>
+          <p:cNvPr id="27" name=""/>
           <p:cNvCxnSpPr>
             <a:stCxn xmlns:a="http://schemas.openxmlformats.org/drawingml/2006/main" id="4" idx="3"/>
             <a:endCxn xmlns:a="http://schemas.openxmlformats.org/drawingml/2006/main" id="5" idx="1"/>
@@ -3861,7 +3849,7 @@
       </p:sp>
       <p:cxnSp>
         <p:nvCxnSpPr>
-          <p:cNvPr id="37" name=""/>
+          <p:cNvPr id="29" name=""/>
           <p:cNvCxnSpPr>
             <a:stCxn xmlns:a="http://schemas.openxmlformats.org/drawingml/2006/main" id="5" idx="3"/>
             <a:endCxn xmlns:a="http://schemas.openxmlformats.org/drawingml/2006/main" id="7" idx="1"/>
@@ -6671,7 +6659,7 @@
       </p:sp>
       <p:cxnSp>
         <p:nvCxnSpPr>
-          <p:cNvPr id="36" name=""/>
+          <p:cNvPr id="27" name=""/>
           <p:cNvCxnSpPr>
             <a:stCxn xmlns:a="http://schemas.openxmlformats.org/drawingml/2006/main" id="5" idx="3"/>
             <a:endCxn xmlns:a="http://schemas.openxmlformats.org/drawingml/2006/main" id="6" idx="1"/>
@@ -6756,7 +6744,7 @@
       </p:sp>
       <p:cxnSp>
         <p:nvCxnSpPr>
-          <p:cNvPr id="38" name=""/>
+          <p:cNvPr id="29" name=""/>
           <p:cNvCxnSpPr>
             <a:stCxn xmlns:a="http://schemas.openxmlformats.org/drawingml/2006/main" id="6" idx="3"/>
             <a:endCxn xmlns:a="http://schemas.openxmlformats.org/drawingml/2006/main" id="8" idx="1"/>
@@ -6977,7 +6965,7 @@
           <p:cNvPr id="8" name="">
             <a:extLst xmlns:a="http://schemas.openxmlformats.org/drawingml/2006/main">
               <a:ext uri="{FF2B5EF4-FFF2-40B4-BE49-F238E27FC236}">
-                <a16:creationId xmlns:a16="http://schemas.microsoft.com/office/drawing/2014/main" id="{32208E57-18E6-46B5-8C98-0B617BA6AF3E}"/>
+                <a16:creationId xmlns:a16="http://schemas.microsoft.com/office/drawing/2014/main" id="{257E9C89-36F8-44F5-9A6D-3FA9FE32B6EE}"/>
               </a:ext>
             </a:extLst>
           </p:cNvPr>
@@ -7006,7 +6994,6 @@
           <a:lstStyle xmlns:a="http://schemas.openxmlformats.org/drawingml/2006/main"/>
           <a:p xmlns:a="http://schemas.openxmlformats.org/drawingml/2006/main">
             <a:pPr>
-              <a:buNone/>
               <a:defRPr sz="3675" b="1">
                 <a:solidFill>
                   <a:srgbClr val="182C29"/>
@@ -7035,7 +7022,7 @@
           <p:cNvPr id="2" name="">
             <a:extLst xmlns:a="http://schemas.openxmlformats.org/drawingml/2006/main">
               <a:ext uri="{FF2B5EF4-FFF2-40B4-BE49-F238E27FC236}">
-                <a16:creationId xmlns:a16="http://schemas.microsoft.com/office/drawing/2014/main" id="{EF7A26ED-E82B-4BBB-8FAA-EE00C720382B}"/>
+                <a16:creationId xmlns:a16="http://schemas.microsoft.com/office/drawing/2014/main" id="{CC463259-6DB3-4276-946A-81F3A6C6913F}"/>
               </a:ext>
             </a:extLst>
           </p:cNvPr>
@@ -7064,7 +7051,6 @@
           <a:lstStyle xmlns:a="http://schemas.openxmlformats.org/drawingml/2006/main"/>
           <a:p xmlns:a="http://schemas.openxmlformats.org/drawingml/2006/main">
             <a:pPr>
-              <a:buNone/>
               <a:defRPr sz="2100" b="0">
                 <a:solidFill>
                   <a:srgbClr val="5E706B"/>
@@ -7083,7 +7069,7 @@
                 <a:ea typeface="Apple SD Gothic Neo"/>
                 <a:cs typeface="Apple SD Gothic Neo"/>
               </a:rPr>
-              <a:t>관세 후보 선택의 처리시간과 품질을 따로 측정했습니다.</a:t>
+              <a:t>가정용·취미 상품의 HS 후보 선택시간과 비용을 비교했습니다.</a:t>
             </a:r>
           </a:p>
         </p:txBody>
@@ -7093,7 +7079,7 @@
           <p:cNvPr id="3" name="">
             <a:extLst xmlns:a="http://schemas.openxmlformats.org/drawingml/2006/main">
               <a:ext uri="{FF2B5EF4-FFF2-40B4-BE49-F238E27FC236}">
-                <a16:creationId xmlns:a16="http://schemas.microsoft.com/office/drawing/2014/main" id="{C57488CA-0878-4414-A0DC-BE367E4438A7}"/>
+                <a16:creationId xmlns:a16="http://schemas.microsoft.com/office/drawing/2014/main" id="{43BC3CF6-1C90-41B1-B0A3-F0B83D628E76}"/>
               </a:ext>
             </a:extLst>
           </p:cNvPr>
@@ -7122,7 +7108,6 @@
           <a:lstStyle xmlns:a="http://schemas.openxmlformats.org/drawingml/2006/main"/>
           <a:p xmlns:a="http://schemas.openxmlformats.org/drawingml/2006/main">
             <a:pPr>
-              <a:buNone/>
               <a:defRPr sz="1350" b="0">
                 <a:solidFill>
                   <a:srgbClr val="5E706B"/>
@@ -7141,7 +7126,7 @@
                 <a:ea typeface="Apple SD Gothic Neo"/>
                 <a:cs typeface="Apple SD Gothic Neo"/>
               </a:rPr>
-              <a:t>16   윤장한 · 직구 조사와 도구 구현 · 부록 · 2026.10.06</a:t>
+              <a:t>16   윤장한 · 직구 조사와 도구 구현 · 부록 · 2026.10.07</a:t>
             </a:r>
           </a:p>
         </p:txBody>
@@ -7151,7 +7136,7 @@
           <p:cNvPr id="4" name="">
             <a:extLst xmlns:a="http://schemas.openxmlformats.org/drawingml/2006/main">
               <a:ext uri="{FF2B5EF4-FFF2-40B4-BE49-F238E27FC236}">
-                <a16:creationId xmlns:a16="http://schemas.microsoft.com/office/drawing/2014/main" id="{C3F5F128-AC86-473A-B614-3C28D06784FF}"/>
+                <a16:creationId xmlns:a16="http://schemas.microsoft.com/office/drawing/2014/main" id="{184A043A-B990-499F-B282-A1D59D3ED6A8}"/>
               </a:ext>
             </a:extLst>
           </p:cNvPr>
@@ -7180,7 +7165,6 @@
           <a:lstStyle xmlns:a="http://schemas.openxmlformats.org/drawingml/2006/main"/>
           <a:p xmlns:a="http://schemas.openxmlformats.org/drawingml/2006/main">
             <a:pPr>
-              <a:buNone/>
               <a:defRPr sz="2250" b="0">
                 <a:solidFill>
                   <a:srgbClr val="182C29"/>
@@ -7204,7 +7188,6 @@
           </a:p>
           <a:p xmlns:a="http://schemas.openxmlformats.org/drawingml/2006/main">
             <a:pPr>
-              <a:buNone/>
               <a:defRPr sz="2250" b="0">
                 <a:solidFill>
                   <a:srgbClr val="182C29"/>
@@ -7223,14 +7206,14 @@
                 <a:ea typeface="Apple SD Gothic Neo"/>
                 <a:cs typeface="Apple SD Gothic Neo"/>
               </a:rPr>
-              <a:t>상품명·속성·카테고리를 제공하며, 이번에는94개 표본의 HS6 정답과 비교했습니다.</a:t>
+              <a:t>가정용·취미 범위에서 이전 실험과 겹치지 않는 새 상품93개를 평가했습니다.</a:t>
             </a:r>
           </a:p>
         </p:txBody>
       </p:sp>
       <p:graphicFrame>
         <p:nvGraphicFramePr>
-          <p:cNvPr id="14" name=""/>
+          <p:cNvPr id="12" name=""/>
           <p:cNvGraphicFramePr/>
           <p:nvPr/>
         </p:nvGraphicFramePr>
@@ -7243,11 +7226,11 @@
             <a:tbl>
               <a:tblPr/>
               <a:tblGrid>
-                <a:gridCol w="3048000"/>
-                <a:gridCol w="4238625"/>
-                <a:gridCol w="6315075"/>
+                <a:gridCol w="2667000"/>
+                <a:gridCol w="5143500"/>
+                <a:gridCol w="5791200"/>
               </a:tblGrid>
-              <a:tr h="755650">
+              <a:tr h="566738">
                 <a:tc>
                   <a:txBody>
                     <a:bodyPr/>
@@ -7262,7 +7245,7 @@
                           <a:ea typeface="Apple SD Gothic Neo"/>
                           <a:cs typeface="Apple SD Gothic Neo"/>
                         </a:rPr>
-                        <a:t>데이터</a:t>
+                        <a:t>구분</a:t>
                       </a:r>
                     </a:p>
                   </a:txBody>
@@ -7286,7 +7269,7 @@
                           <a:ea typeface="Apple SD Gothic Neo"/>
                           <a:cs typeface="Apple SD Gothic Neo"/>
                         </a:rPr>
-                        <a:t>실행 범위</a:t>
+                        <a:t>실험 조건</a:t>
                       </a:r>
                     </a:p>
                   </a:txBody>
@@ -7310,7 +7293,7 @@
                           <a:ea typeface="Apple SD Gothic Neo"/>
                           <a:cs typeface="Apple SD Gothic Neo"/>
                         </a:rPr>
-                        <a:t>품질 평가 기준</a:t>
+                        <a:t>선별·평가 원칙</a:t>
                       </a:r>
                     </a:p>
                   </a:txBody>
@@ -7321,7 +7304,7 @@
                   </a:tcPr>
                 </a:tc>
               </a:tr>
-              <a:tr h="755650">
+              <a:tr h="566738">
                 <a:tc>
                   <a:txBody>
                     <a:bodyPr/>
@@ -7336,7 +7319,7 @@
                           <a:ea typeface="Apple SD Gothic Neo"/>
                           <a:cs typeface="Apple SD Gothic Neo"/>
                         </a:rPr>
-                        <a:t>HSCodeComp</a:t>
+                        <a:t>대상</a:t>
                       </a:r>
                     </a:p>
                   </a:txBody>
@@ -7360,7 +7343,7 @@
                           <a:ea typeface="Apple SD Gothic Neo"/>
                           <a:cs typeface="Apple SD Gothic Neo"/>
                         </a:rPr>
-                        <a:t>94개 층화 표본 / 전체632개</a:t>
+                        <a:t>생활·주방 / 의류 / 취미 / 전자기기</a:t>
                       </a:r>
                     </a:p>
                   </a:txBody>
@@ -7384,7 +7367,7 @@
                           <a:ea typeface="Apple SD Gothic Neo"/>
                           <a:cs typeface="Apple SD Gothic Neo"/>
                         </a:rPr>
-                        <a:t>공개 전문가 라벨과 HS6 일치</a:t>
+                        <a:t>상품 용도를 기준으로 선별</a:t>
                       </a:r>
                     </a:p>
                   </a:txBody>
@@ -7395,7 +7378,7 @@
                   </a:tcPr>
                 </a:tc>
               </a:tr>
-              <a:tr h="755650">
+              <a:tr h="566738">
                 <a:tc>
                   <a:txBody>
                     <a:bodyPr/>
@@ -7410,7 +7393,7 @@
                           <a:ea typeface="Apple SD Gothic Neo"/>
                           <a:cs typeface="Apple SD Gothic Neo"/>
                         </a:rPr>
-                        <a:t>메루카리</a:t>
+                        <a:t>비교</a:t>
                       </a:r>
                     </a:p>
                   </a:txBody>
@@ -7434,7 +7417,7 @@
                           <a:ea typeface="Apple SD Gothic Neo"/>
                           <a:cs typeface="Apple SD Gothic Neo"/>
                         </a:rPr>
-                        <a:t>실제 판매글30개 전체</a:t>
+                        <a:t>Jev1.13 ↔ GPT-6 Luna low</a:t>
                       </a:r>
                     </a:p>
                   </a:txBody>
@@ -7458,7 +7441,7 @@
                           <a:ea typeface="Apple SD Gothic Neo"/>
                           <a:cs typeface="Apple SD Gothic Neo"/>
                         </a:rPr>
-                        <a:t>독립 GPT-6 Sol 심사 결과와 일치</a:t>
+                        <a:t>동일한 상품명·속성·HS 목록</a:t>
                       </a:r>
                     </a:p>
                   </a:txBody>
@@ -7469,6 +7452,80 @@
                   </a:tcPr>
                 </a:tc>
               </a:tr>
+              <a:tr h="566738">
+                <a:tc>
+                  <a:txBody>
+                    <a:bodyPr/>
+                    <a:lstStyle/>
+                    <a:p>
+                      <a:r>
+                        <a:rPr sz="2175" b="0">
+                          <a:solidFill>
+                            <a:srgbClr val="182C29"/>
+                          </a:solidFill>
+                          <a:latin typeface="Apple SD Gothic Neo"/>
+                          <a:ea typeface="Apple SD Gothic Neo"/>
+                          <a:cs typeface="Apple SD Gothic Neo"/>
+                        </a:rPr>
+                        <a:t>방식</a:t>
+                      </a:r>
+                    </a:p>
+                  </a:txBody>
+                  <a:tcPr marL="91440" marR="91440" marT="45720" marB="45720">
+                    <a:solidFill>
+                      <a:srgbClr val="FFFFFF"/>
+                    </a:solidFill>
+                  </a:tcPr>
+                </a:tc>
+                <a:tc>
+                  <a:txBody>
+                    <a:bodyPr/>
+                    <a:lstStyle/>
+                    <a:p>
+                      <a:r>
+                        <a:rPr sz="2175" b="0">
+                          <a:solidFill>
+                            <a:srgbClr val="182C29"/>
+                          </a:solidFill>
+                          <a:latin typeface="Apple SD Gothic Neo"/>
+                          <a:ea typeface="Apple SD Gothic Neo"/>
+                          <a:cs typeface="Apple SD Gothic Neo"/>
+                        </a:rPr>
+                        <a:t>단일 경로 HS2 → HS4 → HS6</a:t>
+                      </a:r>
+                    </a:p>
+                  </a:txBody>
+                  <a:tcPr marL="91440" marR="91440" marT="45720" marB="45720">
+                    <a:solidFill>
+                      <a:srgbClr val="FFFFFF"/>
+                    </a:solidFill>
+                  </a:tcPr>
+                </a:tc>
+                <a:tc>
+                  <a:txBody>
+                    <a:bodyPr/>
+                    <a:lstStyle/>
+                    <a:p>
+                      <a:r>
+                        <a:rPr sz="2175" b="0">
+                          <a:solidFill>
+                            <a:srgbClr val="182C29"/>
+                          </a:solidFill>
+                          <a:latin typeface="Apple SD Gothic Neo"/>
+                          <a:ea typeface="Apple SD Gothic Neo"/>
+                          <a:cs typeface="Apple SD Gothic Neo"/>
+                        </a:rPr>
+                        <a:t>정보 부족·복합 재질·세트 유지</a:t>
+                      </a:r>
+                    </a:p>
+                  </a:txBody>
+                  <a:tcPr marL="91440" marR="91440" marT="45720" marB="45720">
+                    <a:solidFill>
+                      <a:srgbClr val="FFFFFF"/>
+                    </a:solidFill>
+                  </a:tcPr>
+                </a:tc>
+              </a:tr>
             </a:tbl>
           </a:graphicData>
         </a:graphic>
@@ -7478,7 +7535,7 @@
           <p:cNvPr id="6" name="">
             <a:extLst xmlns:a="http://schemas.openxmlformats.org/drawingml/2006/main">
               <a:ext uri="{FF2B5EF4-FFF2-40B4-BE49-F238E27FC236}">
-                <a16:creationId xmlns:a16="http://schemas.microsoft.com/office/drawing/2014/main" id="{FFEE9D22-BAD4-4A19-979B-E83025455E69}"/>
+                <a16:creationId xmlns:a16="http://schemas.microsoft.com/office/drawing/2014/main" id="{E44A524F-98D4-4099-9EF4-56CADF8D8408}"/>
               </a:ext>
             </a:extLst>
           </p:cNvPr>
@@ -7489,8 +7546,8 @@
         </p:nvSpPr>
         <p:spPr>
           <a:xfrm xmlns:a="http://schemas.openxmlformats.org/drawingml/2006/main">
-            <a:off x="819150" y="6734175"/>
-            <a:ext cx="13525500" cy="685800"/>
+            <a:off x="819150" y="6829425"/>
+            <a:ext cx="13525500" cy="428625"/>
           </a:xfrm>
           <a:prstGeom xmlns:a="http://schemas.openxmlformats.org/drawingml/2006/main" prst="rect">
             <a:avLst/>
@@ -7507,10 +7564,9 @@
           <a:lstStyle xmlns:a="http://schemas.openxmlformats.org/drawingml/2006/main"/>
           <a:p xmlns:a="http://schemas.openxmlformats.org/drawingml/2006/main">
             <a:pPr>
-              <a:buNone/>
               <a:defRPr sz="1875" b="0">
                 <a:solidFill>
-                  <a:srgbClr val="5E706B"/>
+                  <a:srgbClr val="156E58"/>
                 </a:solidFill>
                 <a:latin typeface="Apple SD Gothic Neo"/>
                 <a:ea typeface="Apple SD Gothic Neo"/>
@@ -7520,37 +7576,25 @@
             <a:r>
               <a:rPr sz="1875" b="0">
                 <a:solidFill>
-                  <a:srgbClr val="5E706B"/>
-                </a:solidFill>
-                <a:latin typeface="Apple SD Gothic Neo"/>
-                <a:ea typeface="Apple SD Gothic Neo"/>
-                <a:cs typeface="Apple SD Gothic Neo"/>
-              </a:rPr>
-              <a:t>비교: Jev1.13 ↔ GPT-6 Luna low. 심사자는 기존 예측·공급사 이름을 보지 않았습니다.</a:t>
-            </a:r>
-          </a:p>
-          <a:p xmlns:a="http://schemas.openxmlformats.org/drawingml/2006/main">
-            <a:pPr>
-              <a:buNone/>
-              <a:defRPr sz="1875" b="0">
-                <a:solidFill>
-                  <a:srgbClr val="5E706B"/>
-                </a:solidFill>
-                <a:latin typeface="Apple SD Gothic Neo"/>
-                <a:ea typeface="Apple SD Gothic Neo"/>
-                <a:cs typeface="Apple SD Gothic Neo"/>
-              </a:defRPr>
-            </a:pPr>
+                  <a:srgbClr val="156E58"/>
+                </a:solidFill>
+                <a:latin typeface="Apple SD Gothic Neo"/>
+                <a:ea typeface="Apple SD Gothic Neo"/>
+                <a:cs typeface="Apple SD Gothic Neo"/>
+              </a:rPr>
+              <a:t>HSCodeComp 원본: </a:t>
+            </a:r>
             <a:r>
               <a:rPr sz="1875" b="0">
                 <a:solidFill>
-                  <a:srgbClr val="5E706B"/>
-                </a:solidFill>
-                <a:latin typeface="Apple SD Gothic Neo"/>
-                <a:ea typeface="Apple SD Gothic Neo"/>
-                <a:cs typeface="Apple SD Gothic Neo"/>
-              </a:rPr>
-              <a:t>텍스트만 사용한 단일 경로 비교이며 웹 검색·이미지 분석을 제외했습니다.</a:t>
+                  <a:srgbClr val="156E58"/>
+                </a:solidFill>
+                <a:latin typeface="Apple SD Gothic Neo"/>
+                <a:ea typeface="Apple SD Gothic Neo"/>
+                <a:cs typeface="Apple SD Gothic Neo"/>
+                <a:hlinkClick xmlns:r="http://schemas.openxmlformats.org/officeDocument/2006/relationships" r:id="R50a12f88ed144c3b"/>
+              </a:rPr>
+              <a:t>huggingface.co/datasets/ATH-MaaS/HSCodeComp</a:t>
             </a:r>
           </a:p>
         </p:txBody>
@@ -7560,7 +7604,7 @@
           <p:cNvPr id="7" name="">
             <a:extLst xmlns:a="http://schemas.openxmlformats.org/drawingml/2006/main">
               <a:ext uri="{FF2B5EF4-FFF2-40B4-BE49-F238E27FC236}">
-                <a16:creationId xmlns:a16="http://schemas.microsoft.com/office/drawing/2014/main" id="{4D396F42-9085-4613-962A-A2E6EC17D4F0}"/>
+                <a16:creationId xmlns:a16="http://schemas.microsoft.com/office/drawing/2014/main" id="{1591DE84-6F71-428E-B7A9-03E9308EC3B0}"/>
               </a:ext>
             </a:extLst>
           </p:cNvPr>
@@ -7589,10 +7633,9 @@
           <a:lstStyle xmlns:a="http://schemas.openxmlformats.org/drawingml/2006/main"/>
           <a:p xmlns:a="http://schemas.openxmlformats.org/drawingml/2006/main">
             <a:pPr>
-              <a:buNone/>
               <a:defRPr sz="1725" b="0">
                 <a:solidFill>
-                  <a:srgbClr val="156E58"/>
+                  <a:srgbClr val="5E706B"/>
                 </a:solidFill>
                 <a:latin typeface="Apple SD Gothic Neo"/>
                 <a:ea typeface="Apple SD Gothic Neo"/>
@@ -7602,25 +7645,13 @@
             <a:r>
               <a:rPr sz="1725" b="0">
                 <a:solidFill>
-                  <a:srgbClr val="156E58"/>
-                </a:solidFill>
-                <a:latin typeface="Apple SD Gothic Neo"/>
-                <a:ea typeface="Apple SD Gothic Neo"/>
-                <a:cs typeface="Apple SD Gothic Neo"/>
-              </a:rPr>
-              <a:t>데이터셋 원본: </a:t>
-            </a:r>
-            <a:r>
-              <a:rPr sz="1725" b="0">
-                <a:solidFill>
-                  <a:srgbClr val="156E58"/>
-                </a:solidFill>
-                <a:latin typeface="Apple SD Gothic Neo"/>
-                <a:ea typeface="Apple SD Gothic Neo"/>
-                <a:cs typeface="Apple SD Gothic Neo"/>
-                <a:hlinkClick xmlns:r="http://schemas.openxmlformats.org/officeDocument/2006/relationships" r:id="Rafd9e5ae71504e74"/>
-              </a:rPr>
-              <a:t>huggingface.co/datasets/ATH-MaaS/HSCodeComp</a:t>
+                  <a:srgbClr val="5E706B"/>
+                </a:solidFill>
+                <a:latin typeface="Apple SD Gothic Neo"/>
+                <a:ea typeface="Apple SD Gothic Neo"/>
+                <a:cs typeface="Apple SD Gothic Neo"/>
+              </a:rPr>
+              <a:t>텍스트만 사용했습니다. 웹 검색·이미지 분석·복수 경로 재선택은 이번 비교에서 제외했습니다.</a:t>
             </a:r>
           </a:p>
         </p:txBody>
@@ -7628,7 +7659,7 @@
     </p:spTree>
     <p:extLst>
       <p:ext uri="{BB962C8B-B14F-4D97-AF65-F5344CB8AC3E}">
-        <p14:creationId xmlns:p14="http://schemas.microsoft.com/office/powerpoint/2010/main" val="1928326010"/>
+        <p14:creationId xmlns:p14="http://schemas.microsoft.com/office/powerpoint/2010/main" val="1753230773"/>
       </p:ext>
     </p:extLst>
   </p:cSld>
@@ -7659,7 +7690,7 @@
           <p:cNvPr id="12" name="">
             <a:extLst xmlns:a="http://schemas.openxmlformats.org/drawingml/2006/main">
               <a:ext uri="{FF2B5EF4-FFF2-40B4-BE49-F238E27FC236}">
-                <a16:creationId xmlns:a16="http://schemas.microsoft.com/office/drawing/2014/main" id="{76AFBD16-BB63-40AD-A67C-25EBF9EE0FE8}"/>
+                <a16:creationId xmlns:a16="http://schemas.microsoft.com/office/drawing/2014/main" id="{D80A9B6B-FFBE-4769-8FD8-78C260F3E315}"/>
               </a:ext>
             </a:extLst>
           </p:cNvPr>
@@ -7688,7 +7719,6 @@
           <a:lstStyle xmlns:a="http://schemas.openxmlformats.org/drawingml/2006/main"/>
           <a:p xmlns:a="http://schemas.openxmlformats.org/drawingml/2006/main">
             <a:pPr>
-              <a:buNone/>
               <a:defRPr sz="3675" b="1">
                 <a:solidFill>
                   <a:srgbClr val="182C29"/>
@@ -7707,7 +7737,7 @@
                 <a:ea typeface="Apple SD Gothic Neo"/>
                 <a:cs typeface="Apple SD Gothic Neo"/>
               </a:rPr>
-              <a:t>HS 후보 판단시간을 5~6배 줄였습니다</a:t>
+              <a:t>HS 후보 판단시간을 약7배 줄였습니다</a:t>
             </a:r>
           </a:p>
         </p:txBody>
@@ -7717,7 +7747,7 @@
           <p:cNvPr id="2" name="">
             <a:extLst xmlns:a="http://schemas.openxmlformats.org/drawingml/2006/main">
               <a:ext uri="{FF2B5EF4-FFF2-40B4-BE49-F238E27FC236}">
-                <a16:creationId xmlns:a16="http://schemas.microsoft.com/office/drawing/2014/main" id="{811E44A2-D536-469D-98DF-20510C7E28F6}"/>
+                <a16:creationId xmlns:a16="http://schemas.microsoft.com/office/drawing/2014/main" id="{B95B1DE0-2524-4100-8CF6-7BEE21F1EC68}"/>
               </a:ext>
             </a:extLst>
           </p:cNvPr>
@@ -7746,7 +7776,6 @@
           <a:lstStyle xmlns:a="http://schemas.openxmlformats.org/drawingml/2006/main"/>
           <a:p xmlns:a="http://schemas.openxmlformats.org/drawingml/2006/main">
             <a:pPr>
-              <a:buNone/>
               <a:defRPr sz="2100" b="0">
                 <a:solidFill>
                   <a:srgbClr val="5E706B"/>
@@ -7765,7 +7794,7 @@
                 <a:ea typeface="Apple SD Gothic Neo"/>
                 <a:cs typeface="Apple SD Gothic Neo"/>
               </a:rPr>
-              <a:t>동일한 입력에서 Jev의 중앙 처리시간과 추정 비용이 더 낮았습니다.</a:t>
+              <a:t>새 서비스 범위93개에서 Jev의 중앙 처리시간과 추정 비용이 더 낮았습니다.</a:t>
             </a:r>
           </a:p>
         </p:txBody>
@@ -7775,7 +7804,7 @@
           <p:cNvPr id="3" name="">
             <a:extLst xmlns:a="http://schemas.openxmlformats.org/drawingml/2006/main">
               <a:ext uri="{FF2B5EF4-FFF2-40B4-BE49-F238E27FC236}">
-                <a16:creationId xmlns:a16="http://schemas.microsoft.com/office/drawing/2014/main" id="{E58BD48B-AC29-45F2-A860-07B1D6838A80}"/>
+                <a16:creationId xmlns:a16="http://schemas.microsoft.com/office/drawing/2014/main" id="{54C1D405-F07D-43A3-962D-4374BD2D1545}"/>
               </a:ext>
             </a:extLst>
           </p:cNvPr>
@@ -7804,7 +7833,6 @@
           <a:lstStyle xmlns:a="http://schemas.openxmlformats.org/drawingml/2006/main"/>
           <a:p xmlns:a="http://schemas.openxmlformats.org/drawingml/2006/main">
             <a:pPr>
-              <a:buNone/>
               <a:defRPr sz="1350" b="0">
                 <a:solidFill>
                   <a:srgbClr val="5E706B"/>
@@ -7823,14 +7851,14 @@
                 <a:ea typeface="Apple SD Gothic Neo"/>
                 <a:cs typeface="Apple SD Gothic Neo"/>
               </a:rPr>
-              <a:t>17   윤장한 · 직구 조사와 도구 구현 · 부록 · 2026.10.06</a:t>
+              <a:t>17   윤장한 · 직구 조사와 도구 구현 · 부록 · 2026.10.07</a:t>
             </a:r>
           </a:p>
         </p:txBody>
       </p:sp>
       <p:graphicFrame>
         <p:nvGraphicFramePr>
-          <p:cNvPr id="17" name="Chart"/>
+          <p:cNvPr id="15" name="Chart"/>
           <p:cNvGraphicFramePr/>
           <p:nvPr/>
         </p:nvGraphicFramePr>
@@ -7840,7 +7868,7 @@
         </p:xfrm>
         <a:graphic xmlns:a="http://schemas.openxmlformats.org/drawingml/2006/main">
           <a:graphicData uri="http://schemas.openxmlformats.org/drawingml/2006/chart">
-            <c:chart xmlns:r="http://schemas.openxmlformats.org/officeDocument/2006/relationships" xmlns:c="http://schemas.openxmlformats.org/drawingml/2006/chart" r:id="R8867b879a4614beb"/>
+            <c:chart xmlns:r="http://schemas.openxmlformats.org/officeDocument/2006/relationships" xmlns:c="http://schemas.openxmlformats.org/drawingml/2006/chart" r:id="R774ca97f29534967"/>
           </a:graphicData>
         </a:graphic>
       </p:graphicFrame>
@@ -7849,7 +7877,7 @@
           <p:cNvPr id="5" name="">
             <a:extLst xmlns:a="http://schemas.openxmlformats.org/drawingml/2006/main">
               <a:ext uri="{FF2B5EF4-FFF2-40B4-BE49-F238E27FC236}">
-                <a16:creationId xmlns:a16="http://schemas.microsoft.com/office/drawing/2014/main" id="{904456F5-EC6A-4EC9-B4F5-432C07FB1370}"/>
+                <a16:creationId xmlns:a16="http://schemas.microsoft.com/office/drawing/2014/main" id="{89D8A43C-DB18-4CEA-99D3-90D9037E320C}"/>
               </a:ext>
             </a:extLst>
           </p:cNvPr>
@@ -7878,7 +7906,6 @@
           <a:lstStyle xmlns:a="http://schemas.openxmlformats.org/drawingml/2006/main"/>
           <a:p xmlns:a="http://schemas.openxmlformats.org/drawingml/2006/main">
             <a:pPr>
-              <a:buNone/>
               <a:defRPr sz="2400" b="1">
                 <a:solidFill>
                   <a:srgbClr val="156E58"/>
@@ -7897,7 +7924,7 @@
                 <a:ea typeface="Apple SD Gothic Neo"/>
                 <a:cs typeface="Apple SD Gothic Neo"/>
               </a:rPr>
-              <a:t>HF 표본</a:t>
+              <a:t>판단시간</a:t>
             </a:r>
           </a:p>
         </p:txBody>
@@ -7907,7 +7934,7 @@
           <p:cNvPr id="6" name="">
             <a:extLst xmlns:a="http://schemas.openxmlformats.org/drawingml/2006/main">
               <a:ext uri="{FF2B5EF4-FFF2-40B4-BE49-F238E27FC236}">
-                <a16:creationId xmlns:a16="http://schemas.microsoft.com/office/drawing/2014/main" id="{476D8F6E-DA11-4B04-8FF1-8241BA08D036}"/>
+                <a16:creationId xmlns:a16="http://schemas.microsoft.com/office/drawing/2014/main" id="{A6E35CC9-F8DD-48F2-AE0B-DD732F7AF5A7}"/>
               </a:ext>
             </a:extLst>
           </p:cNvPr>
@@ -7936,7 +7963,6 @@
           <a:lstStyle xmlns:a="http://schemas.openxmlformats.org/drawingml/2006/main"/>
           <a:p xmlns:a="http://schemas.openxmlformats.org/drawingml/2006/main">
             <a:pPr>
-              <a:buNone/>
               <a:defRPr sz="3150" b="1">
                 <a:solidFill>
                   <a:srgbClr val="182C29"/>
@@ -7955,7 +7981,7 @@
                 <a:ea typeface="Apple SD Gothic Neo"/>
                 <a:cs typeface="Apple SD Gothic Neo"/>
               </a:rPr>
-              <a:t>6.4배 빠르게</a:t>
+              <a:t>약7배 빠르게</a:t>
             </a:r>
           </a:p>
         </p:txBody>
@@ -7965,7 +7991,7 @@
           <p:cNvPr id="7" name="">
             <a:extLst xmlns:a="http://schemas.openxmlformats.org/drawingml/2006/main">
               <a:ext uri="{FF2B5EF4-FFF2-40B4-BE49-F238E27FC236}">
-                <a16:creationId xmlns:a16="http://schemas.microsoft.com/office/drawing/2014/main" id="{A22D3943-DD8F-4BFC-A707-D7FAAAE682F2}"/>
+                <a16:creationId xmlns:a16="http://schemas.microsoft.com/office/drawing/2014/main" id="{02201935-53BF-405C-8716-1867321D6B85}"/>
               </a:ext>
             </a:extLst>
           </p:cNvPr>
@@ -7994,7 +8020,6 @@
           <a:lstStyle xmlns:a="http://schemas.openxmlformats.org/drawingml/2006/main"/>
           <a:p xmlns:a="http://schemas.openxmlformats.org/drawingml/2006/main">
             <a:pPr>
-              <a:buNone/>
               <a:defRPr sz="2100" b="0">
                 <a:solidFill>
                   <a:srgbClr val="182C29"/>
@@ -8013,7 +8038,7 @@
                 <a:ea typeface="Apple SD Gothic Neo"/>
                 <a:cs typeface="Apple SD Gothic Neo"/>
               </a:rPr>
-              <a:t>추정 비용57.0% 감소</a:t>
+              <a:t>0.645초 ↔ 4.510초</a:t>
             </a:r>
           </a:p>
         </p:txBody>
@@ -8023,7 +8048,7 @@
           <p:cNvPr id="8" name="">
             <a:extLst xmlns:a="http://schemas.openxmlformats.org/drawingml/2006/main">
               <a:ext uri="{FF2B5EF4-FFF2-40B4-BE49-F238E27FC236}">
-                <a16:creationId xmlns:a16="http://schemas.microsoft.com/office/drawing/2014/main" id="{4945892D-3F47-4E7B-BC70-D5DCD05FA923}"/>
+                <a16:creationId xmlns:a16="http://schemas.microsoft.com/office/drawing/2014/main" id="{3253A803-5A86-42C3-A064-71C775ABA443}"/>
               </a:ext>
             </a:extLst>
           </p:cNvPr>
@@ -8052,7 +8077,6 @@
           <a:lstStyle xmlns:a="http://schemas.openxmlformats.org/drawingml/2006/main"/>
           <a:p xmlns:a="http://schemas.openxmlformats.org/drawingml/2006/main">
             <a:pPr>
-              <a:buNone/>
               <a:defRPr sz="2400" b="1">
                 <a:solidFill>
                   <a:srgbClr val="156E58"/>
@@ -8071,7 +8095,7 @@
                 <a:ea typeface="Apple SD Gothic Neo"/>
                 <a:cs typeface="Apple SD Gothic Neo"/>
               </a:rPr>
-              <a:t>메루카리</a:t>
+              <a:t>추정 API 비용</a:t>
             </a:r>
           </a:p>
         </p:txBody>
@@ -8081,7 +8105,7 @@
           <p:cNvPr id="9" name="">
             <a:extLst xmlns:a="http://schemas.openxmlformats.org/drawingml/2006/main">
               <a:ext uri="{FF2B5EF4-FFF2-40B4-BE49-F238E27FC236}">
-                <a16:creationId xmlns:a16="http://schemas.microsoft.com/office/drawing/2014/main" id="{1833C4A1-62AA-4EDC-A677-F0E4BE2AFFC6}"/>
+                <a16:creationId xmlns:a16="http://schemas.microsoft.com/office/drawing/2014/main" id="{9774D6CB-1B40-40E6-9B2A-5AAB85B4746A}"/>
               </a:ext>
             </a:extLst>
           </p:cNvPr>
@@ -8110,7 +8134,6 @@
           <a:lstStyle xmlns:a="http://schemas.openxmlformats.org/drawingml/2006/main"/>
           <a:p xmlns:a="http://schemas.openxmlformats.org/drawingml/2006/main">
             <a:pPr>
-              <a:buNone/>
               <a:defRPr sz="3150" b="1">
                 <a:solidFill>
                   <a:srgbClr val="182C29"/>
@@ -8129,7 +8152,7 @@
                 <a:ea typeface="Apple SD Gothic Neo"/>
                 <a:cs typeface="Apple SD Gothic Neo"/>
               </a:rPr>
-              <a:t>5.7배 빠르게</a:t>
+              <a:t>57.1% 감소</a:t>
             </a:r>
           </a:p>
         </p:txBody>
@@ -8139,7 +8162,7 @@
           <p:cNvPr id="10" name="">
             <a:extLst xmlns:a="http://schemas.openxmlformats.org/drawingml/2006/main">
               <a:ext uri="{FF2B5EF4-FFF2-40B4-BE49-F238E27FC236}">
-                <a16:creationId xmlns:a16="http://schemas.microsoft.com/office/drawing/2014/main" id="{E85F53D6-3058-4200-A49A-1E71C9BA66B9}"/>
+                <a16:creationId xmlns:a16="http://schemas.microsoft.com/office/drawing/2014/main" id="{441321F8-FCBF-4850-9DD8-96507F6D142E}"/>
               </a:ext>
             </a:extLst>
           </p:cNvPr>
@@ -8168,26 +8191,25 @@
           <a:lstStyle xmlns:a="http://schemas.openxmlformats.org/drawingml/2006/main"/>
           <a:p xmlns:a="http://schemas.openxmlformats.org/drawingml/2006/main">
             <a:pPr>
-              <a:buNone/>
-              <a:defRPr sz="2100" b="0">
-                <a:solidFill>
-                  <a:srgbClr val="182C29"/>
-                </a:solidFill>
-                <a:latin typeface="Apple SD Gothic Neo"/>
-                <a:ea typeface="Apple SD Gothic Neo"/>
-                <a:cs typeface="Apple SD Gothic Neo"/>
-              </a:defRPr>
-            </a:pPr>
-            <a:r>
-              <a:rPr sz="2100" b="0">
-                <a:solidFill>
-                  <a:srgbClr val="182C29"/>
-                </a:solidFill>
-                <a:latin typeface="Apple SD Gothic Neo"/>
-                <a:ea typeface="Apple SD Gothic Neo"/>
-                <a:cs typeface="Apple SD Gothic Neo"/>
-              </a:rPr>
-              <a:t>추정 비용53.9% 감소</a:t>
+              <a:defRPr sz="1800" b="0">
+                <a:solidFill>
+                  <a:srgbClr val="182C29"/>
+                </a:solidFill>
+                <a:latin typeface="Apple SD Gothic Neo"/>
+                <a:ea typeface="Apple SD Gothic Neo"/>
+                <a:cs typeface="Apple SD Gothic Neo"/>
+              </a:defRPr>
+            </a:pPr>
+            <a:r>
+              <a:rPr sz="1800" b="0">
+                <a:solidFill>
+                  <a:srgbClr val="182C29"/>
+                </a:solidFill>
+                <a:latin typeface="Apple SD Gothic Neo"/>
+                <a:ea typeface="Apple SD Gothic Neo"/>
+                <a:cs typeface="Apple SD Gothic Neo"/>
+              </a:rPr>
+              <a:t>93개 합계 $0.0226 ↔ $0.0527</a:t>
             </a:r>
           </a:p>
         </p:txBody>
@@ -8197,7 +8219,7 @@
           <p:cNvPr id="11" name="">
             <a:extLst xmlns:a="http://schemas.openxmlformats.org/drawingml/2006/main">
               <a:ext uri="{FF2B5EF4-FFF2-40B4-BE49-F238E27FC236}">
-                <a16:creationId xmlns:a16="http://schemas.microsoft.com/office/drawing/2014/main" id="{15120C3A-8949-40DB-8D2F-14A2E8DA50D6}"/>
+                <a16:creationId xmlns:a16="http://schemas.microsoft.com/office/drawing/2014/main" id="{9065420C-E203-4A55-AD94-948D72BA346B}"/>
               </a:ext>
             </a:extLst>
           </p:cNvPr>
@@ -8226,7 +8248,6 @@
           <a:lstStyle xmlns:a="http://schemas.openxmlformats.org/drawingml/2006/main"/>
           <a:p xmlns:a="http://schemas.openxmlformats.org/drawingml/2006/main">
             <a:pPr>
-              <a:buNone/>
               <a:defRPr sz="1875" b="0">
                 <a:solidFill>
                   <a:srgbClr val="5E706B"/>
@@ -8245,7 +8266,7 @@
                 <a:ea typeface="Apple SD Gothic Neo"/>
                 <a:cs typeface="Apple SD Gothic Neo"/>
               </a:rPr>
-              <a:t>HS 분류 단계만 비교했습니다. 전체 URL 분석시간이나 운영 SLA의 개선율이 아닙니다.</a:t>
+              <a:t>분류 단계의 실험 수치입니다. 전체 URL 분석시간이나 운영 서비스 개선율이 아닙니다.</a:t>
             </a:r>
           </a:p>
         </p:txBody>
@@ -8253,7 +8274,7 @@
     </p:spTree>
     <p:extLst>
       <p:ext uri="{BB962C8B-B14F-4D97-AF65-F5344CB8AC3E}">
-        <p14:creationId xmlns:p14="http://schemas.microsoft.com/office/powerpoint/2010/main" val="2062628700"/>
+        <p14:creationId xmlns:p14="http://schemas.microsoft.com/office/powerpoint/2010/main" val="1755162290"/>
       </p:ext>
     </p:extLst>
   </p:cSld>
@@ -8284,7 +8305,7 @@
           <p:cNvPr id="8" name="">
             <a:extLst xmlns:a="http://schemas.openxmlformats.org/drawingml/2006/main">
               <a:ext uri="{FF2B5EF4-FFF2-40B4-BE49-F238E27FC236}">
-                <a16:creationId xmlns:a16="http://schemas.microsoft.com/office/drawing/2014/main" id="{0BED836E-2E09-4737-8347-3EBAA0C1B807}"/>
+                <a16:creationId xmlns:a16="http://schemas.microsoft.com/office/drawing/2014/main" id="{DD082C56-FD94-4B62-B649-C3276BB957FD}"/>
               </a:ext>
             </a:extLst>
           </p:cNvPr>
@@ -8313,7 +8334,6 @@
           <a:lstStyle xmlns:a="http://schemas.openxmlformats.org/drawingml/2006/main"/>
           <a:p xmlns:a="http://schemas.openxmlformats.org/drawingml/2006/main">
             <a:pPr>
-              <a:buNone/>
               <a:defRPr sz="3675" b="1">
                 <a:solidFill>
                   <a:srgbClr val="182C29"/>
@@ -8332,7 +8352,7 @@
                 <a:ea typeface="Apple SD Gothic Neo"/>
                 <a:cs typeface="Apple SD Gothic Neo"/>
               </a:rPr>
-              <a:t>품질은 평가 기준별로 구분했습니다</a:t>
+              <a:t>빠른 후보 판단과 최종 검토를 구분했습니다</a:t>
             </a:r>
           </a:p>
         </p:txBody>
@@ -8342,7 +8362,7 @@
           <p:cNvPr id="2" name="">
             <a:extLst xmlns:a="http://schemas.openxmlformats.org/drawingml/2006/main">
               <a:ext uri="{FF2B5EF4-FFF2-40B4-BE49-F238E27FC236}">
-                <a16:creationId xmlns:a16="http://schemas.microsoft.com/office/drawing/2014/main" id="{6AEFAC60-7114-4DA1-86BC-D3A68574D6B6}"/>
+                <a16:creationId xmlns:a16="http://schemas.microsoft.com/office/drawing/2014/main" id="{BD4ED953-A43C-4932-A8AA-B0CBA276972D}"/>
               </a:ext>
             </a:extLst>
           </p:cNvPr>
@@ -8371,7 +8391,6 @@
           <a:lstStyle xmlns:a="http://schemas.openxmlformats.org/drawingml/2006/main"/>
           <a:p xmlns:a="http://schemas.openxmlformats.org/drawingml/2006/main">
             <a:pPr>
-              <a:buNone/>
               <a:defRPr sz="2100" b="0">
                 <a:solidFill>
                   <a:srgbClr val="5E706B"/>
@@ -8390,7 +8409,7 @@
                 <a:ea typeface="Apple SD Gothic Neo"/>
                 <a:cs typeface="Apple SD Gothic Neo"/>
               </a:rPr>
-              <a:t>메루카리의 상위 모델 HS6 일치율84%를 기록했고, HF 정확도 차이도 확인했습니다.</a:t>
+              <a:t>처리시간·비용 이점과 함께, 재질·용도·정보 부족에 따른 판단 한계를 확인했습니다.</a:t>
             </a:r>
           </a:p>
         </p:txBody>
@@ -8400,7 +8419,7 @@
           <p:cNvPr id="3" name="">
             <a:extLst xmlns:a="http://schemas.openxmlformats.org/drawingml/2006/main">
               <a:ext uri="{FF2B5EF4-FFF2-40B4-BE49-F238E27FC236}">
-                <a16:creationId xmlns:a16="http://schemas.microsoft.com/office/drawing/2014/main" id="{E248D299-3D70-4881-8335-A473265A68D3}"/>
+                <a16:creationId xmlns:a16="http://schemas.microsoft.com/office/drawing/2014/main" id="{CD762081-D92A-45D5-ABA9-2207BC89C8C9}"/>
               </a:ext>
             </a:extLst>
           </p:cNvPr>
@@ -8429,7 +8448,6 @@
           <a:lstStyle xmlns:a="http://schemas.openxmlformats.org/drawingml/2006/main"/>
           <a:p xmlns:a="http://schemas.openxmlformats.org/drawingml/2006/main">
             <a:pPr>
-              <a:buNone/>
               <a:defRPr sz="1350" b="0">
                 <a:solidFill>
                   <a:srgbClr val="5E706B"/>
@@ -8448,14 +8466,14 @@
                 <a:ea typeface="Apple SD Gothic Neo"/>
                 <a:cs typeface="Apple SD Gothic Neo"/>
               </a:rPr>
-              <a:t>18   윤장한 · 직구 조사와 도구 구현 · 부록 · 2026.10.06</a:t>
+              <a:t>18   윤장한 · 직구 조사와 도구 구현 · 부록 · 2026.10.07</a:t>
             </a:r>
           </a:p>
         </p:txBody>
       </p:sp>
       <p:graphicFrame>
         <p:nvGraphicFramePr>
-          <p:cNvPr id="13" name=""/>
+          <p:cNvPr id="11" name=""/>
           <p:cNvGraphicFramePr/>
           <p:nvPr/>
         </p:nvGraphicFramePr>
@@ -8468,9 +8486,9 @@
             <a:tbl>
               <a:tblPr/>
               <a:tblGrid>
-                <a:gridCol w="7734300"/>
-                <a:gridCol w="2933700"/>
-                <a:gridCol w="2933700"/>
+                <a:gridCol w="3238500"/>
+                <a:gridCol w="5048250"/>
+                <a:gridCol w="5314950"/>
               </a:tblGrid>
               <a:tr h="695325">
                 <a:tc>
@@ -8487,7 +8505,7 @@
                           <a:ea typeface="Apple SD Gothic Neo"/>
                           <a:cs typeface="Apple SD Gothic Neo"/>
                         </a:rPr>
-                        <a:t>평가 기준</a:t>
+                        <a:t>검토 항목</a:t>
                       </a:r>
                     </a:p>
                   </a:txBody>
@@ -8511,7 +8529,7 @@
                           <a:ea typeface="Apple SD Gothic Neo"/>
                           <a:cs typeface="Apple SD Gothic Neo"/>
                         </a:rPr>
-                        <a:t>Jev</a:t>
+                        <a:t>관찰한 사례</a:t>
                       </a:r>
                     </a:p>
                   </a:txBody>
@@ -8535,7 +8553,7 @@
                           <a:ea typeface="Apple SD Gothic Neo"/>
                           <a:cs typeface="Apple SD Gothic Neo"/>
                         </a:rPr>
-                        <a:t>GPT-6 Luna</a:t>
+                        <a:t>적용 범위 (제안)</a:t>
                       </a:r>
                     </a:p>
                   </a:txBody>
@@ -8561,7 +8579,7 @@
                           <a:ea typeface="Apple SD Gothic Neo"/>
                           <a:cs typeface="Apple SD Gothic Neo"/>
                         </a:rPr>
-                        <a:t>HF 전문가 라벨 · 전체94개 HS6 정확도</a:t>
+                        <a:t>재질·제품 용도</a:t>
                       </a:r>
                     </a:p>
                   </a:txBody>
@@ -8585,7 +8603,7 @@
                           <a:ea typeface="Apple SD Gothic Neo"/>
                           <a:cs typeface="Apple SD Gothic Neo"/>
                         </a:rPr>
-                        <a:t>29.8% (28/94)</a:t>
+                        <a:t>PU 인조가죽 / 인형용 모자</a:t>
                       </a:r>
                     </a:p>
                   </a:txBody>
@@ -8609,7 +8627,7 @@
                           <a:ea typeface="Apple SD Gothic Neo"/>
                           <a:cs typeface="Apple SD Gothic Neo"/>
                         </a:rPr>
-                        <a:t>38.3% (36/94)</a:t>
+                        <a:t>추가 근거를 확인해 분류</a:t>
                       </a:r>
                     </a:p>
                   </a:txBody>
@@ -8635,7 +8653,7 @@
                           <a:ea typeface="Apple SD Gothic Neo"/>
                           <a:cs typeface="Apple SD Gothic Neo"/>
                         </a:rPr>
-                        <a:t>메루카리 · 심사자 HS6 일치 (25개)</a:t>
+                        <a:t>복합 재질·세트·부품</a:t>
                       </a:r>
                     </a:p>
                   </a:txBody>
@@ -8659,7 +8677,7 @@
                           <a:ea typeface="Apple SD Gothic Neo"/>
                           <a:cs typeface="Apple SD Gothic Neo"/>
                         </a:rPr>
-                        <a:t>84.0% (21/25)</a:t>
+                        <a:t>제목·속성·용도가 서로 충돌</a:t>
                       </a:r>
                     </a:p>
                   </a:txBody>
@@ -8683,7 +8701,7 @@
                           <a:ea typeface="Apple SD Gothic Neo"/>
                           <a:cs typeface="Apple SD Gothic Neo"/>
                         </a:rPr>
-                        <a:t>76.0% (19/25)</a:t>
+                        <a:t>불충분한 정보는 보류</a:t>
                       </a:r>
                     </a:p>
                   </a:txBody>
@@ -8709,7 +8727,7 @@
                           <a:ea typeface="Apple SD Gothic Neo"/>
                           <a:cs typeface="Apple SD Gothic Neo"/>
                         </a:rPr>
-                        <a:t>메루카리 · 보류 포함 전체 판단 일치</a:t>
+                        <a:t>입력과 참조 라벨</a:t>
                       </a:r>
                     </a:p>
                   </a:txBody>
@@ -8733,7 +8751,7 @@
                           <a:ea typeface="Apple SD Gothic Neo"/>
                           <a:cs typeface="Apple SD Gothic Neo"/>
                         </a:rPr>
-                        <a:t>70.0% (21/30)</a:t>
+                        <a:t>상품 정보와 라벨의 불일치</a:t>
                       </a:r>
                     </a:p>
                   </a:txBody>
@@ -8757,7 +8775,7 @@
                           <a:ea typeface="Apple SD Gothic Neo"/>
                           <a:cs typeface="Apple SD Gothic Neo"/>
                         </a:rPr>
-                        <a:t>76.7% (23/30)</a:t>
+                        <a:t>분류 결과와 데이터 함께 검토</a:t>
                       </a:r>
                     </a:p>
                   </a:txBody>
@@ -8777,7 +8795,7 @@
           <p:cNvPr id="5" name="">
             <a:extLst xmlns:a="http://schemas.openxmlformats.org/drawingml/2006/main">
               <a:ext uri="{FF2B5EF4-FFF2-40B4-BE49-F238E27FC236}">
-                <a16:creationId xmlns:a16="http://schemas.microsoft.com/office/drawing/2014/main" id="{224A75FC-55E6-4362-9697-AAD1F7632591}"/>
+                <a16:creationId xmlns:a16="http://schemas.microsoft.com/office/drawing/2014/main" id="{1DE8C92F-5FCE-4341-9265-E987EBAA192E}"/>
               </a:ext>
             </a:extLst>
           </p:cNvPr>
@@ -8789,7 +8807,7 @@
         <p:spPr>
           <a:xfrm xmlns:a="http://schemas.openxmlformats.org/drawingml/2006/main">
             <a:off x="819150" y="5791200"/>
-            <a:ext cx="13525500" cy="523875"/>
+            <a:ext cx="13525500" cy="619125"/>
           </a:xfrm>
           <a:prstGeom xmlns:a="http://schemas.openxmlformats.org/drawingml/2006/main" prst="rect">
             <a:avLst/>
@@ -8806,7 +8824,6 @@
           <a:lstStyle xmlns:a="http://schemas.openxmlformats.org/drawingml/2006/main"/>
           <a:p xmlns:a="http://schemas.openxmlformats.org/drawingml/2006/main">
             <a:pPr>
-              <a:buNone/>
               <a:defRPr sz="2025" b="0">
                 <a:solidFill>
                   <a:srgbClr val="5E706B"/>
@@ -8825,7 +8842,7 @@
                 <a:ea typeface="Apple SD Gothic Neo"/>
                 <a:cs typeface="Apple SD Gothic Neo"/>
               </a:rPr>
-              <a:t>상위 모델과의 일치는 정답 정확도가 아닙니다. HF에서는 Jev의 정확도가 더 낮았습니다.</a:t>
+              <a:t>판단 품질과 답변률에는 차이가 있습니다. 최종 관세 분류를 자동 확정하는 근거로 쓰지 않습니다.</a:t>
             </a:r>
           </a:p>
         </p:txBody>
@@ -8835,7 +8852,7 @@
           <p:cNvPr id="6" name="">
             <a:extLst xmlns:a="http://schemas.openxmlformats.org/drawingml/2006/main">
               <a:ext uri="{FF2B5EF4-FFF2-40B4-BE49-F238E27FC236}">
-                <a16:creationId xmlns:a16="http://schemas.microsoft.com/office/drawing/2014/main" id="{697E0B6D-485E-479C-BC00-9607A4BF7AE8}"/>
+                <a16:creationId xmlns:a16="http://schemas.microsoft.com/office/drawing/2014/main" id="{0EEC2F91-F13D-4AE3-B727-98FFA5623C84}"/>
               </a:ext>
             </a:extLst>
           </p:cNvPr>
@@ -8846,8 +8863,8 @@
         </p:nvSpPr>
         <p:spPr>
           <a:xfrm xmlns:a="http://schemas.openxmlformats.org/drawingml/2006/main">
-            <a:off x="819150" y="6477000"/>
-            <a:ext cx="13525500" cy="590550"/>
+            <a:off x="819150" y="6648450"/>
+            <a:ext cx="13525500" cy="495300"/>
           </a:xfrm>
           <a:prstGeom xmlns:a="http://schemas.openxmlformats.org/drawingml/2006/main" prst="rect">
             <a:avLst/>
@@ -8864,8 +8881,7 @@
           <a:lstStyle xmlns:a="http://schemas.openxmlformats.org/drawingml/2006/main"/>
           <a:p xmlns:a="http://schemas.openxmlformats.org/drawingml/2006/main">
             <a:pPr>
-              <a:buNone/>
-              <a:defRPr sz="2250" b="1">
+              <a:defRPr sz="2100" b="1">
                 <a:solidFill>
                   <a:srgbClr val="156E58"/>
                 </a:solidFill>
@@ -8875,7 +8891,7 @@
               </a:defRPr>
             </a:pPr>
             <a:r>
-              <a:rPr sz="2250" b="1">
+              <a:rPr sz="2100" b="1">
                 <a:solidFill>
                   <a:srgbClr val="156E58"/>
                 </a:solidFill>
@@ -8883,7 +8899,7 @@
                 <a:ea typeface="Apple SD Gothic Neo"/>
                 <a:cs typeface="Apple SD Gothic Neo"/>
               </a:rPr>
-              <a:t>도입 방향(제안): 초기 후보 판단을 빠르게 처리하고, 근거 부족·최종 분류는 추가 검토합니다.</a:t>
+              <a:t>검증 결과: 정확도·답변률·토큰·실패 사례를 공개 레포에서 확인할 수 있습니다.</a:t>
             </a:r>
           </a:p>
         </p:txBody>
@@ -8893,7 +8909,7 @@
           <p:cNvPr id="7" name="">
             <a:extLst xmlns:a="http://schemas.openxmlformats.org/drawingml/2006/main">
               <a:ext uri="{FF2B5EF4-FFF2-40B4-BE49-F238E27FC236}">
-                <a16:creationId xmlns:a16="http://schemas.microsoft.com/office/drawing/2014/main" id="{0D8741C7-5AF5-4B15-B2C9-E7206E5AC3BB}"/>
+                <a16:creationId xmlns:a16="http://schemas.microsoft.com/office/drawing/2014/main" id="{9965D73E-900A-49F2-B93C-95B6BCA8DC04}"/>
               </a:ext>
             </a:extLst>
           </p:cNvPr>
@@ -8904,8 +8920,8 @@
         </p:nvSpPr>
         <p:spPr>
           <a:xfrm xmlns:a="http://schemas.openxmlformats.org/drawingml/2006/main">
-            <a:off x="819150" y="7448550"/>
-            <a:ext cx="13525500" cy="371475"/>
+            <a:off x="819150" y="7429500"/>
+            <a:ext cx="13525500" cy="381000"/>
           </a:xfrm>
           <a:prstGeom xmlns:a="http://schemas.openxmlformats.org/drawingml/2006/main" prst="rect">
             <a:avLst/>
@@ -8922,26 +8938,37 @@
           <a:lstStyle xmlns:a="http://schemas.openxmlformats.org/drawingml/2006/main"/>
           <a:p xmlns:a="http://schemas.openxmlformats.org/drawingml/2006/main">
             <a:pPr>
-              <a:buNone/>
-              <a:defRPr sz="1725" b="0">
-                <a:solidFill>
-                  <a:srgbClr val="5E706B"/>
-                </a:solidFill>
-                <a:latin typeface="Apple SD Gothic Neo"/>
-                <a:ea typeface="Apple SD Gothic Neo"/>
-                <a:cs typeface="Apple SD Gothic Neo"/>
-              </a:defRPr>
-            </a:pPr>
-            <a:r>
-              <a:rPr sz="1725" b="0">
-                <a:solidFill>
-                  <a:srgbClr val="5E706B"/>
-                </a:solidFill>
-                <a:latin typeface="Apple SD Gothic Neo"/>
-                <a:ea typeface="Apple SD Gothic Neo"/>
-                <a:cs typeface="Apple SD Gothic Neo"/>
-              </a:rPr>
-              <a:t>실험 코드·노트북·측정 결과: github.com/y00nZZang/product-catalog/tree/main/notebooks</a:t>
+              <a:defRPr sz="1875" b="0">
+                <a:solidFill>
+                  <a:srgbClr val="156E58"/>
+                </a:solidFill>
+                <a:latin typeface="Apple SD Gothic Neo"/>
+                <a:ea typeface="Apple SD Gothic Neo"/>
+                <a:cs typeface="Apple SD Gothic Neo"/>
+              </a:defRPr>
+            </a:pPr>
+            <a:r>
+              <a:rPr sz="1875" b="0">
+                <a:solidFill>
+                  <a:srgbClr val="156E58"/>
+                </a:solidFill>
+                <a:latin typeface="Apple SD Gothic Neo"/>
+                <a:ea typeface="Apple SD Gothic Neo"/>
+                <a:cs typeface="Apple SD Gothic Neo"/>
+              </a:rPr>
+              <a:t>공개 실험 기록 · </a:t>
+            </a:r>
+            <a:r>
+              <a:rPr sz="1875" b="0">
+                <a:solidFill>
+                  <a:srgbClr val="156E58"/>
+                </a:solidFill>
+                <a:latin typeface="Apple SD Gothic Neo"/>
+                <a:ea typeface="Apple SD Gothic Neo"/>
+                <a:cs typeface="Apple SD Gothic Neo"/>
+                <a:hlinkClick xmlns:r="http://schemas.openxmlformats.org/officeDocument/2006/relationships" r:id="Raf335aa5e8c24561"/>
+              </a:rPr>
+              <a:t>github.com/y00nZZang/product-catalog</a:t>
             </a:r>
           </a:p>
         </p:txBody>
@@ -8949,7 +8976,7 @@
     </p:spTree>
     <p:extLst>
       <p:ext uri="{BB962C8B-B14F-4D97-AF65-F5344CB8AC3E}">
-        <p14:creationId xmlns:p14="http://schemas.microsoft.com/office/powerpoint/2010/main" val="1627327697"/>
+        <p14:creationId xmlns:p14="http://schemas.microsoft.com/office/powerpoint/2010/main" val="1964270569"/>
       </p:ext>
     </p:extLst>
   </p:cSld>
@@ -10293,7 +10320,7 @@
           <p:nvPr/>
         </p:nvPicPr>
         <p:blipFill>
-          <a:blip xmlns:r="http://schemas.openxmlformats.org/officeDocument/2006/relationships" xmlns:a="http://schemas.openxmlformats.org/drawingml/2006/main" r:embed="R222b191908ff469c"/>
+          <a:blip xmlns:r="http://schemas.openxmlformats.org/officeDocument/2006/relationships" xmlns:a="http://schemas.openxmlformats.org/drawingml/2006/main" r:embed="Rc867388c9d57432b"/>
           <a:stretch xmlns:a="http://schemas.openxmlformats.org/drawingml/2006/main"/>
         </p:blipFill>
         <p:spPr>
@@ -13098,7 +13125,7 @@
       </p:sp>
       <p:cxnSp>
         <p:nvCxnSpPr>
-          <p:cNvPr id="49" name=""/>
+          <p:cNvPr id="37" name=""/>
           <p:cNvCxnSpPr>
             <a:stCxn xmlns:a="http://schemas.openxmlformats.org/drawingml/2006/main" id="4" idx="3"/>
             <a:endCxn xmlns:a="http://schemas.openxmlformats.org/drawingml/2006/main" id="5" idx="1"/>
@@ -13183,7 +13210,7 @@
       </p:sp>
       <p:cxnSp>
         <p:nvCxnSpPr>
-          <p:cNvPr id="51" name=""/>
+          <p:cNvPr id="39" name=""/>
           <p:cNvCxnSpPr>
             <a:stCxn xmlns:a="http://schemas.openxmlformats.org/drawingml/2006/main" id="5" idx="3"/>
             <a:endCxn xmlns:a="http://schemas.openxmlformats.org/drawingml/2006/main" id="7" idx="1"/>
@@ -13268,7 +13295,7 @@
       </p:sp>
       <p:cxnSp>
         <p:nvCxnSpPr>
-          <p:cNvPr id="53" name=""/>
+          <p:cNvPr id="41" name=""/>
           <p:cNvCxnSpPr>
             <a:stCxn xmlns:a="http://schemas.openxmlformats.org/drawingml/2006/main" id="7" idx="3"/>
             <a:endCxn xmlns:a="http://schemas.openxmlformats.org/drawingml/2006/main" id="9" idx="1"/>
@@ -13353,7 +13380,7 @@
       </p:sp>
       <p:cxnSp>
         <p:nvCxnSpPr>
-          <p:cNvPr id="55" name=""/>
+          <p:cNvPr id="43" name=""/>
           <p:cNvCxnSpPr>
             <a:stCxn xmlns:a="http://schemas.openxmlformats.org/drawingml/2006/main" id="9" idx="3"/>
             <a:endCxn xmlns:a="http://schemas.openxmlformats.org/drawingml/2006/main" id="11" idx="1"/>
@@ -14628,7 +14655,7 @@
           <p:nvPr/>
         </p:nvPicPr>
         <p:blipFill>
-          <a:blip xmlns:r="http://schemas.openxmlformats.org/officeDocument/2006/relationships" xmlns:a="http://schemas.openxmlformats.org/drawingml/2006/main" r:embed="R24eaa77ad35f4beb"/>
+          <a:blip xmlns:r="http://schemas.openxmlformats.org/officeDocument/2006/relationships" xmlns:a="http://schemas.openxmlformats.org/drawingml/2006/main" r:embed="Reae30a489f91448a"/>
           <a:stretch xmlns:a="http://schemas.openxmlformats.org/drawingml/2006/main"/>
         </p:blipFill>
         <p:spPr>
@@ -15082,7 +15109,7 @@
       </p:sp>
       <p:cxnSp>
         <p:nvCxnSpPr>
-          <p:cNvPr id="34" name=""/>
+          <p:cNvPr id="26" name=""/>
           <p:cNvCxnSpPr>
             <a:stCxn xmlns:a="http://schemas.openxmlformats.org/drawingml/2006/main" id="4" idx="3"/>
             <a:endCxn xmlns:a="http://schemas.openxmlformats.org/drawingml/2006/main" id="5" idx="1"/>
@@ -15167,7 +15194,7 @@
       </p:sp>
       <p:cxnSp>
         <p:nvCxnSpPr>
-          <p:cNvPr id="36" name=""/>
+          <p:cNvPr id="28" name=""/>
           <p:cNvCxnSpPr>
             <a:stCxn xmlns:a="http://schemas.openxmlformats.org/drawingml/2006/main" id="5" idx="3"/>
             <a:endCxn xmlns:a="http://schemas.openxmlformats.org/drawingml/2006/main" id="7" idx="1"/>

</xml_diff>

<commit_message>
Add Jev introduction and experiment motivation to appendix
</commit_message>
<xml_diff>
--- a/portfolio/crossborder-portfolio.pptx
+++ b/portfolio/crossborder-portfolio.pptx
@@ -2,30 +2,30 @@
 <file path=ppt/presentation.xml><?xml version="1.0" encoding="utf-8"?>
 <p:presentation xmlns:p="http://schemas.openxmlformats.org/presentationml/2006/main">
   <p:sldMasterIdLst>
-    <p:sldMasterId xmlns:r="http://schemas.openxmlformats.org/officeDocument/2006/relationships" id="2147483648" r:id="Ra56d68c42fbb43a4"/>
+    <p:sldMasterId xmlns:r="http://schemas.openxmlformats.org/officeDocument/2006/relationships" id="2147483648" r:id="R5bd7558566b34a75"/>
   </p:sldMasterIdLst>
   <p:notesMasterIdLst>
-    <p:notesMasterId xmlns:r="http://schemas.openxmlformats.org/officeDocument/2006/relationships" r:id="R58e65546b5ec41dc"/>
+    <p:notesMasterId xmlns:r="http://schemas.openxmlformats.org/officeDocument/2006/relationships" r:id="R1ca19feec93d4778"/>
   </p:notesMasterIdLst>
   <p:sldIdLst>
-    <p:sldId xmlns:r="http://schemas.openxmlformats.org/officeDocument/2006/relationships" id="256" r:id="Ra4f0161fb4fd45e3"/>
-    <p:sldId xmlns:r="http://schemas.openxmlformats.org/officeDocument/2006/relationships" id="257" r:id="R93324130f41847b2"/>
-    <p:sldId xmlns:r="http://schemas.openxmlformats.org/officeDocument/2006/relationships" id="258" r:id="Raa59b28199364315"/>
-    <p:sldId xmlns:r="http://schemas.openxmlformats.org/officeDocument/2006/relationships" id="259" r:id="R8b357fa08a984173"/>
-    <p:sldId xmlns:r="http://schemas.openxmlformats.org/officeDocument/2006/relationships" id="260" r:id="R54383c14146d4815"/>
-    <p:sldId xmlns:r="http://schemas.openxmlformats.org/officeDocument/2006/relationships" id="261" r:id="R717176e21e0946bb"/>
-    <p:sldId xmlns:r="http://schemas.openxmlformats.org/officeDocument/2006/relationships" id="262" r:id="R0503203391ae4767"/>
-    <p:sldId xmlns:r="http://schemas.openxmlformats.org/officeDocument/2006/relationships" id="263" r:id="Rcb5688d1376243b7"/>
-    <p:sldId xmlns:r="http://schemas.openxmlformats.org/officeDocument/2006/relationships" id="264" r:id="R4953180543214287"/>
-    <p:sldId xmlns:r="http://schemas.openxmlformats.org/officeDocument/2006/relationships" id="265" r:id="Rd6bd13580fc54007"/>
-    <p:sldId xmlns:r="http://schemas.openxmlformats.org/officeDocument/2006/relationships" id="266" r:id="R047d32cdd79c4b7a"/>
-    <p:sldId xmlns:r="http://schemas.openxmlformats.org/officeDocument/2006/relationships" id="267" r:id="R52b493f1e3b54f86"/>
-    <p:sldId xmlns:r="http://schemas.openxmlformats.org/officeDocument/2006/relationships" id="268" r:id="Rf5024eb4406c4c88"/>
-    <p:sldId xmlns:r="http://schemas.openxmlformats.org/officeDocument/2006/relationships" id="269" r:id="R25e688f042b142e9"/>
-    <p:sldId xmlns:r="http://schemas.openxmlformats.org/officeDocument/2006/relationships" id="270" r:id="R0bf3e0af4376485f"/>
-    <p:sldId xmlns:r="http://schemas.openxmlformats.org/officeDocument/2006/relationships" id="271" r:id="Rddfa3c180f964570"/>
-    <p:sldId xmlns:r="http://schemas.openxmlformats.org/officeDocument/2006/relationships" id="272" r:id="R4268af0c7dd643d0"/>
-    <p:sldId xmlns:r="http://schemas.openxmlformats.org/officeDocument/2006/relationships" id="273" r:id="R0f43f7c3c6cd44e1"/>
+    <p:sldId xmlns:r="http://schemas.openxmlformats.org/officeDocument/2006/relationships" id="256" r:id="Rf814da61dcd74b6f"/>
+    <p:sldId xmlns:r="http://schemas.openxmlformats.org/officeDocument/2006/relationships" id="257" r:id="R491bd7e7b0284f9d"/>
+    <p:sldId xmlns:r="http://schemas.openxmlformats.org/officeDocument/2006/relationships" id="258" r:id="R82b668be0dfa4f54"/>
+    <p:sldId xmlns:r="http://schemas.openxmlformats.org/officeDocument/2006/relationships" id="259" r:id="Rf2ab83515cda4666"/>
+    <p:sldId xmlns:r="http://schemas.openxmlformats.org/officeDocument/2006/relationships" id="260" r:id="R56b463af0ce74596"/>
+    <p:sldId xmlns:r="http://schemas.openxmlformats.org/officeDocument/2006/relationships" id="261" r:id="R509751778c324cbd"/>
+    <p:sldId xmlns:r="http://schemas.openxmlformats.org/officeDocument/2006/relationships" id="262" r:id="R96dec3ab60514f3f"/>
+    <p:sldId xmlns:r="http://schemas.openxmlformats.org/officeDocument/2006/relationships" id="263" r:id="Re022e4fb9c9a4a2f"/>
+    <p:sldId xmlns:r="http://schemas.openxmlformats.org/officeDocument/2006/relationships" id="264" r:id="R2d02fd27abda4ad1"/>
+    <p:sldId xmlns:r="http://schemas.openxmlformats.org/officeDocument/2006/relationships" id="265" r:id="R89ae46e3537e49ed"/>
+    <p:sldId xmlns:r="http://schemas.openxmlformats.org/officeDocument/2006/relationships" id="266" r:id="R7b8eb2193a7b46ec"/>
+    <p:sldId xmlns:r="http://schemas.openxmlformats.org/officeDocument/2006/relationships" id="267" r:id="R907fc0063b0f47f8"/>
+    <p:sldId xmlns:r="http://schemas.openxmlformats.org/officeDocument/2006/relationships" id="268" r:id="R48f6787eaaca428b"/>
+    <p:sldId xmlns:r="http://schemas.openxmlformats.org/officeDocument/2006/relationships" id="269" r:id="Rfe6fcd32a2a24478"/>
+    <p:sldId xmlns:r="http://schemas.openxmlformats.org/officeDocument/2006/relationships" id="270" r:id="Rcf7dbc1d04364416"/>
+    <p:sldId xmlns:r="http://schemas.openxmlformats.org/officeDocument/2006/relationships" id="271" r:id="R1c134b966d9a43b0"/>
+    <p:sldId xmlns:r="http://schemas.openxmlformats.org/officeDocument/2006/relationships" id="272" r:id="R70ed73d8e7774ce5"/>
+    <p:sldId xmlns:r="http://schemas.openxmlformats.org/officeDocument/2006/relationships" id="273" r:id="R63386d9aabce4293"/>
   </p:sldIdLst>
   <p:sldSz cx="15240000" cy="8572500"/>
   <p:notesSz cx="6858000" cy="9144000"/>
@@ -949,7 +949,7 @@
           <a:lstStyle xmlns:a="http://schemas.openxmlformats.org/drawingml/2006/main"/>
           <a:p xmlns:a="http://schemas.openxmlformats.org/drawingml/2006/main">
             <a:r>
-              <a:t>https://github.com/y00nZZang/product-catalog/blob/main/docs/service-scope-jev-experiment-2026-10-07.md ; https://huggingface.co/datasets/ATH-MaaS/HSCodeComp ; https://docs.typesafe.ai/primitives/choice . 서비스 범위는 연구 초안으로 사조의 검증된 정책이 아니다. 기존 단일 경로 Jev와 Luna만 비교. 정답/보류/실패는 공개 레포에서 확인.</a:t>
+              <a:t>https://github.com/y00nZZang/product-catalog/blob/main/docs/service-scope-jev-experiment-2026-10-07.md ; https://typesafe.ai/blog/introducing-system-one-models-and-jev ; https://huggingface.co/datasets/ATH-MaaS/HSCodeComp ; https://docs.typesafe.ai/primitives/choice . 서비스 범위는 연구 초안으로 사조의 검증된 정책이 아니다. 기존 단일 경로 Jev와 Luna만 비교. 정답/보류/실패는 공개 레포에서 확인.</a:t>
             </a:r>
           </a:p>
         </p:txBody>
@@ -1717,7 +1717,7 @@
   </p:cSld>
   <p:clrMap bg1="lt1" tx1="dk1" bg2="lt2" tx2="dk2" accent1="accent1" accent2="accent2" accent3="accent3" accent4="accent4" accent5="accent5" accent6="accent6" hlink="hlink" folHlink="folHlink"/>
   <p:sldLayoutIdLst>
-    <p:sldLayoutId xmlns:r="http://schemas.openxmlformats.org/officeDocument/2006/relationships" id="2147483649" r:id="Rfe025f4721fd4067"/>
+    <p:sldLayoutId xmlns:r="http://schemas.openxmlformats.org/officeDocument/2006/relationships" id="2147483649" r:id="Re0776635f88449a6"/>
   </p:sldLayoutIdLst>
   <p:txStyles>
     <p:titleStyle>
@@ -3122,7 +3122,7 @@
           <p:nvPr/>
         </p:nvPicPr>
         <p:blipFill>
-          <a:blip xmlns:r="http://schemas.openxmlformats.org/officeDocument/2006/relationships" xmlns:a="http://schemas.openxmlformats.org/drawingml/2006/main" r:embed="R28a6c3b97fa147f7"/>
+          <a:blip xmlns:r="http://schemas.openxmlformats.org/officeDocument/2006/relationships" xmlns:a="http://schemas.openxmlformats.org/drawingml/2006/main" r:embed="Rffb6d602995c4d5f"/>
           <a:stretch xmlns:a="http://schemas.openxmlformats.org/drawingml/2006/main"/>
         </p:blipFill>
         <p:spPr>
@@ -6962,10 +6962,10 @@
       </p:grpSpPr>
       <p:sp>
         <p:nvSpPr>
-          <p:cNvPr id="8" name="">
+          <p:cNvPr id="10" name="">
             <a:extLst xmlns:a="http://schemas.openxmlformats.org/drawingml/2006/main">
               <a:ext uri="{FF2B5EF4-FFF2-40B4-BE49-F238E27FC236}">
-                <a16:creationId xmlns:a16="http://schemas.microsoft.com/office/drawing/2014/main" id="{257E9C89-36F8-44F5-9A6D-3FA9FE32B6EE}"/>
+                <a16:creationId xmlns:a16="http://schemas.microsoft.com/office/drawing/2014/main" id="{316806A6-F786-4B6E-BDFB-378080108CAF}"/>
               </a:ext>
             </a:extLst>
           </p:cNvPr>
@@ -7022,7 +7022,7 @@
           <p:cNvPr id="2" name="">
             <a:extLst xmlns:a="http://schemas.openxmlformats.org/drawingml/2006/main">
               <a:ext uri="{FF2B5EF4-FFF2-40B4-BE49-F238E27FC236}">
-                <a16:creationId xmlns:a16="http://schemas.microsoft.com/office/drawing/2014/main" id="{CC463259-6DB3-4276-946A-81F3A6C6913F}"/>
+                <a16:creationId xmlns:a16="http://schemas.microsoft.com/office/drawing/2014/main" id="{66E38F28-9B54-42B0-8C13-AD4F0AA927AC}"/>
               </a:ext>
             </a:extLst>
           </p:cNvPr>
@@ -7079,7 +7079,7 @@
           <p:cNvPr id="3" name="">
             <a:extLst xmlns:a="http://schemas.openxmlformats.org/drawingml/2006/main">
               <a:ext uri="{FF2B5EF4-FFF2-40B4-BE49-F238E27FC236}">
-                <a16:creationId xmlns:a16="http://schemas.microsoft.com/office/drawing/2014/main" id="{43BC3CF6-1C90-41B1-B0A3-F0B83D628E76}"/>
+                <a16:creationId xmlns:a16="http://schemas.microsoft.com/office/drawing/2014/main" id="{18ABA3E3-8AAD-466E-9ECE-58D1D538D6E5}"/>
               </a:ext>
             </a:extLst>
           </p:cNvPr>
@@ -7136,7 +7136,7 @@
           <p:cNvPr id="4" name="">
             <a:extLst xmlns:a="http://schemas.openxmlformats.org/drawingml/2006/main">
               <a:ext uri="{FF2B5EF4-FFF2-40B4-BE49-F238E27FC236}">
-                <a16:creationId xmlns:a16="http://schemas.microsoft.com/office/drawing/2014/main" id="{184A043A-B990-499F-B282-A1D59D3ED6A8}"/>
+                <a16:creationId xmlns:a16="http://schemas.microsoft.com/office/drawing/2014/main" id="{A2395409-DF95-4667-8EF3-535E724111E4}"/>
               </a:ext>
             </a:extLst>
           </p:cNvPr>
@@ -7147,8 +7147,8 @@
         </p:nvSpPr>
         <p:spPr>
           <a:xfrm xmlns:a="http://schemas.openxmlformats.org/drawingml/2006/main">
-            <a:off x="819150" y="2638425"/>
-            <a:ext cx="13525500" cy="1095375"/>
+            <a:off x="819150" y="2543175"/>
+            <a:ext cx="13525500" cy="857250"/>
           </a:xfrm>
           <a:prstGeom xmlns:a="http://schemas.openxmlformats.org/drawingml/2006/main" prst="rect">
             <a:avLst/>
@@ -7183,7 +7183,7 @@
                 <a:ea typeface="Apple SD Gothic Neo"/>
                 <a:cs typeface="Apple SD Gothic Neo"/>
               </a:rPr>
-              <a:t>HSCodeComp는 실제 전자상거래 상품632개에 전문가가 HS 코드를 붙인 공개 평가셋입니다.</a:t>
+              <a:t>Jev는 TypeSafe AI가 만든 선택·분류 중심의 판단 모델입니다.</a:t>
             </a:r>
           </a:p>
           <a:p xmlns:a="http://schemas.openxmlformats.org/drawingml/2006/main">
@@ -7206,20 +7206,157 @@
                 <a:ea typeface="Apple SD Gothic Neo"/>
                 <a:cs typeface="Apple SD Gothic Neo"/>
               </a:rPr>
-              <a:t>가정용·취미 범위에서 이전 실험과 겹치지 않는 새 상품93개를 평가했습니다.</a:t>
+              <a:t>설명문 대신 미리 정한 후보에서 선택하고, 후보별 확률을 반환합니다.</a:t>
+            </a:r>
+          </a:p>
+        </p:txBody>
+      </p:sp>
+      <p:sp>
+        <p:nvSpPr>
+          <p:cNvPr id="5" name="">
+            <a:extLst xmlns:a="http://schemas.openxmlformats.org/drawingml/2006/main">
+              <a:ext uri="{FF2B5EF4-FFF2-40B4-BE49-F238E27FC236}">
+                <a16:creationId xmlns:a16="http://schemas.microsoft.com/office/drawing/2014/main" id="{36923EE0-E4ED-442F-BCF0-3EF96DDF64DF}"/>
+              </a:ext>
+            </a:extLst>
+          </p:cNvPr>
+          <p:cNvSpPr>
+            <a:spLocks xmlns:a="http://schemas.openxmlformats.org/drawingml/2006/main" noGrp="1"/>
+          </p:cNvSpPr>
+          <p:nvPr/>
+        </p:nvSpPr>
+        <p:spPr>
+          <a:xfrm xmlns:a="http://schemas.openxmlformats.org/drawingml/2006/main">
+            <a:off x="819150" y="3638550"/>
+            <a:ext cx="13525500" cy="828675"/>
+          </a:xfrm>
+          <a:prstGeom xmlns:a="http://schemas.openxmlformats.org/drawingml/2006/main" prst="rect">
+            <a:avLst/>
+          </a:prstGeom>
+          <a:noFill xmlns:a="http://schemas.openxmlformats.org/drawingml/2006/main"/>
+          <a:ln xmlns:a="http://schemas.openxmlformats.org/drawingml/2006/main" w="0">
+            <a:noFill/>
+          </a:ln>
+        </p:spPr>
+        <p:txBody>
+          <a:bodyPr xmlns:a="http://schemas.openxmlformats.org/drawingml/2006/main" wrap="square" lIns="0" tIns="0" rIns="0" bIns="0">
+            <a:noAutofit/>
+          </a:bodyPr>
+          <a:lstStyle xmlns:a="http://schemas.openxmlformats.org/drawingml/2006/main"/>
+          <a:p xmlns:a="http://schemas.openxmlformats.org/drawingml/2006/main">
+            <a:pPr>
+              <a:defRPr sz="2100" b="0">
+                <a:solidFill>
+                  <a:srgbClr val="156E58"/>
+                </a:solidFill>
+                <a:latin typeface="Apple SD Gothic Neo"/>
+                <a:ea typeface="Apple SD Gothic Neo"/>
+                <a:cs typeface="Apple SD Gothic Neo"/>
+              </a:defRPr>
+            </a:pPr>
+            <a:r>
+              <a:rPr sz="2100" b="0">
+                <a:solidFill>
+                  <a:srgbClr val="156E58"/>
+                </a:solidFill>
+                <a:latin typeface="Apple SD Gothic Neo"/>
+                <a:ea typeface="Apple SD Gothic Neo"/>
+                <a:cs typeface="Apple SD Gothic Neo"/>
+              </a:rPr>
+              <a:t>HS 코드 추론도 정해진 코드 중에서 고르는 작업이므로,</a:t>
+            </a:r>
+          </a:p>
+          <a:p xmlns:a="http://schemas.openxmlformats.org/drawingml/2006/main">
+            <a:pPr>
+              <a:defRPr sz="2100" b="0">
+                <a:solidFill>
+                  <a:srgbClr val="156E58"/>
+                </a:solidFill>
+                <a:latin typeface="Apple SD Gothic Neo"/>
+                <a:ea typeface="Apple SD Gothic Neo"/>
+                <a:cs typeface="Apple SD Gothic Neo"/>
+              </a:defRPr>
+            </a:pPr>
+            <a:r>
+              <a:rPr sz="2100" b="0">
+                <a:solidFill>
+                  <a:srgbClr val="156E58"/>
+                </a:solidFill>
+                <a:latin typeface="Apple SD Gothic Neo"/>
+                <a:ea typeface="Apple SD Gothic Neo"/>
+                <a:cs typeface="Apple SD Gothic Neo"/>
+              </a:rPr>
+              <a:t>LLM 대신 Jev를 쓰면 판단시간과 비용을 줄일 수 있는지 확인했습니다.</a:t>
+            </a:r>
+          </a:p>
+        </p:txBody>
+      </p:sp>
+      <p:sp>
+        <p:nvSpPr>
+          <p:cNvPr id="6" name="">
+            <a:extLst xmlns:a="http://schemas.openxmlformats.org/drawingml/2006/main">
+              <a:ext uri="{FF2B5EF4-FFF2-40B4-BE49-F238E27FC236}">
+                <a16:creationId xmlns:a16="http://schemas.microsoft.com/office/drawing/2014/main" id="{BDF34998-7140-4FE5-AD09-945F9BF38B7B}"/>
+              </a:ext>
+            </a:extLst>
+          </p:cNvPr>
+          <p:cNvSpPr>
+            <a:spLocks xmlns:a="http://schemas.openxmlformats.org/drawingml/2006/main" noGrp="1"/>
+          </p:cNvSpPr>
+          <p:nvPr/>
+        </p:nvSpPr>
+        <p:spPr>
+          <a:xfrm xmlns:a="http://schemas.openxmlformats.org/drawingml/2006/main">
+            <a:off x="819150" y="4638675"/>
+            <a:ext cx="13525500" cy="381000"/>
+          </a:xfrm>
+          <a:prstGeom xmlns:a="http://schemas.openxmlformats.org/drawingml/2006/main" prst="rect">
+            <a:avLst/>
+          </a:prstGeom>
+          <a:noFill xmlns:a="http://schemas.openxmlformats.org/drawingml/2006/main"/>
+          <a:ln xmlns:a="http://schemas.openxmlformats.org/drawingml/2006/main" w="0">
+            <a:noFill/>
+          </a:ln>
+        </p:spPr>
+        <p:txBody>
+          <a:bodyPr xmlns:a="http://schemas.openxmlformats.org/drawingml/2006/main" wrap="square" lIns="0" tIns="0" rIns="0" bIns="0">
+            <a:noAutofit/>
+          </a:bodyPr>
+          <a:lstStyle xmlns:a="http://schemas.openxmlformats.org/drawingml/2006/main"/>
+          <a:p xmlns:a="http://schemas.openxmlformats.org/drawingml/2006/main">
+            <a:pPr>
+              <a:defRPr sz="1725" b="0">
+                <a:solidFill>
+                  <a:srgbClr val="5E706B"/>
+                </a:solidFill>
+                <a:latin typeface="Apple SD Gothic Neo"/>
+                <a:ea typeface="Apple SD Gothic Neo"/>
+                <a:cs typeface="Apple SD Gothic Neo"/>
+              </a:defRPr>
+            </a:pPr>
+            <a:r>
+              <a:rPr sz="1725" b="0">
+                <a:solidFill>
+                  <a:srgbClr val="5E706B"/>
+                </a:solidFill>
+                <a:latin typeface="Apple SD Gothic Neo"/>
+                <a:ea typeface="Apple SD Gothic Neo"/>
+                <a:cs typeface="Apple SD Gothic Neo"/>
+              </a:rPr>
+              <a:t>평가: HSCodeComp(전자상거래 상품632개·전문가 라벨)에서 이전과 겹치지 않는 새93개 선별</a:t>
             </a:r>
           </a:p>
         </p:txBody>
       </p:sp>
       <p:graphicFrame>
         <p:nvGraphicFramePr>
-          <p:cNvPr id="12" name=""/>
+          <p:cNvPr id="16" name=""/>
           <p:cNvGraphicFramePr/>
           <p:nvPr/>
         </p:nvGraphicFramePr>
         <p:xfrm>
-          <a:off xmlns:a="http://schemas.openxmlformats.org/drawingml/2006/main" x="819150" y="4124325"/>
-          <a:ext xmlns:a="http://schemas.openxmlformats.org/drawingml/2006/main" cx="13601700" cy="2266950"/>
+          <a:off xmlns:a="http://schemas.openxmlformats.org/drawingml/2006/main" x="819150" y="5238750"/>
+          <a:ext xmlns:a="http://schemas.openxmlformats.org/drawingml/2006/main" cx="13601700" cy="1352550"/>
         </p:xfrm>
         <a:graphic xmlns:a="http://schemas.openxmlformats.org/drawingml/2006/main">
           <a:graphicData uri="http://schemas.openxmlformats.org/drawingml/2006/table">
@@ -7230,14 +7367,14 @@
                 <a:gridCol w="5143500"/>
                 <a:gridCol w="5791200"/>
               </a:tblGrid>
-              <a:tr h="566738">
+              <a:tr h="338138">
                 <a:tc>
                   <a:txBody>
                     <a:bodyPr/>
                     <a:lstStyle/>
                     <a:p>
                       <a:r>
-                        <a:rPr sz="2025" b="1">
+                        <a:rPr sz="1800" b="1">
                           <a:solidFill>
                             <a:srgbClr val="FFFFFF"/>
                           </a:solidFill>
@@ -7261,7 +7398,7 @@
                     <a:lstStyle/>
                     <a:p>
                       <a:r>
-                        <a:rPr sz="2025" b="1">
+                        <a:rPr sz="1800" b="1">
                           <a:solidFill>
                             <a:srgbClr val="FFFFFF"/>
                           </a:solidFill>
@@ -7285,7 +7422,7 @@
                     <a:lstStyle/>
                     <a:p>
                       <a:r>
-                        <a:rPr sz="2025" b="1">
+                        <a:rPr sz="1800" b="1">
                           <a:solidFill>
                             <a:srgbClr val="FFFFFF"/>
                           </a:solidFill>
@@ -7304,14 +7441,14 @@
                   </a:tcPr>
                 </a:tc>
               </a:tr>
-              <a:tr h="566738">
+              <a:tr h="338138">
                 <a:tc>
                   <a:txBody>
                     <a:bodyPr/>
                     <a:lstStyle/>
                     <a:p>
                       <a:r>
-                        <a:rPr sz="2175" b="0">
+                        <a:rPr sz="1800" b="0">
                           <a:solidFill>
                             <a:srgbClr val="182C29"/>
                           </a:solidFill>
@@ -7335,7 +7472,7 @@
                     <a:lstStyle/>
                     <a:p>
                       <a:r>
-                        <a:rPr sz="2175" b="0">
+                        <a:rPr sz="1800" b="0">
                           <a:solidFill>
                             <a:srgbClr val="182C29"/>
                           </a:solidFill>
@@ -7359,7 +7496,7 @@
                     <a:lstStyle/>
                     <a:p>
                       <a:r>
-                        <a:rPr sz="2175" b="0">
+                        <a:rPr sz="1800" b="0">
                           <a:solidFill>
                             <a:srgbClr val="182C29"/>
                           </a:solidFill>
@@ -7378,14 +7515,14 @@
                   </a:tcPr>
                 </a:tc>
               </a:tr>
-              <a:tr h="566738">
+              <a:tr h="338138">
                 <a:tc>
                   <a:txBody>
                     <a:bodyPr/>
                     <a:lstStyle/>
                     <a:p>
                       <a:r>
-                        <a:rPr sz="2175" b="0">
+                        <a:rPr sz="1800" b="0">
                           <a:solidFill>
                             <a:srgbClr val="182C29"/>
                           </a:solidFill>
@@ -7409,7 +7546,7 @@
                     <a:lstStyle/>
                     <a:p>
                       <a:r>
-                        <a:rPr sz="2175" b="0">
+                        <a:rPr sz="1800" b="0">
                           <a:solidFill>
                             <a:srgbClr val="182C29"/>
                           </a:solidFill>
@@ -7433,7 +7570,7 @@
                     <a:lstStyle/>
                     <a:p>
                       <a:r>
-                        <a:rPr sz="2175" b="0">
+                        <a:rPr sz="1800" b="0">
                           <a:solidFill>
                             <a:srgbClr val="182C29"/>
                           </a:solidFill>
@@ -7452,14 +7589,14 @@
                   </a:tcPr>
                 </a:tc>
               </a:tr>
-              <a:tr h="566738">
+              <a:tr h="338138">
                 <a:tc>
                   <a:txBody>
                     <a:bodyPr/>
                     <a:lstStyle/>
                     <a:p>
                       <a:r>
-                        <a:rPr sz="2175" b="0">
+                        <a:rPr sz="1800" b="0">
                           <a:solidFill>
                             <a:srgbClr val="182C29"/>
                           </a:solidFill>
@@ -7483,7 +7620,7 @@
                     <a:lstStyle/>
                     <a:p>
                       <a:r>
-                        <a:rPr sz="2175" b="0">
+                        <a:rPr sz="1800" b="0">
                           <a:solidFill>
                             <a:srgbClr val="182C29"/>
                           </a:solidFill>
@@ -7507,7 +7644,7 @@
                     <a:lstStyle/>
                     <a:p>
                       <a:r>
-                        <a:rPr sz="2175" b="0">
+                        <a:rPr sz="1800" b="0">
                           <a:solidFill>
                             <a:srgbClr val="182C29"/>
                           </a:solidFill>
@@ -7532,10 +7669,10 @@
       </p:graphicFrame>
       <p:sp>
         <p:nvSpPr>
-          <p:cNvPr id="6" name="">
+          <p:cNvPr id="8" name="">
             <a:extLst xmlns:a="http://schemas.openxmlformats.org/drawingml/2006/main">
               <a:ext uri="{FF2B5EF4-FFF2-40B4-BE49-F238E27FC236}">
-                <a16:creationId xmlns:a16="http://schemas.microsoft.com/office/drawing/2014/main" id="{E44A524F-98D4-4099-9EF4-56CADF8D8408}"/>
+                <a16:creationId xmlns:a16="http://schemas.microsoft.com/office/drawing/2014/main" id="{F37F75C3-77F2-4358-8190-891113A0B851}"/>
               </a:ext>
             </a:extLst>
           </p:cNvPr>
@@ -7592,7 +7729,7 @@
                 <a:latin typeface="Apple SD Gothic Neo"/>
                 <a:ea typeface="Apple SD Gothic Neo"/>
                 <a:cs typeface="Apple SD Gothic Neo"/>
-                <a:hlinkClick xmlns:r="http://schemas.openxmlformats.org/officeDocument/2006/relationships" r:id="R50a12f88ed144c3b"/>
+                <a:hlinkClick xmlns:r="http://schemas.openxmlformats.org/officeDocument/2006/relationships" r:id="R757a087ce54845ce"/>
               </a:rPr>
               <a:t>huggingface.co/datasets/ATH-MaaS/HSCodeComp</a:t>
             </a:r>
@@ -7601,10 +7738,10 @@
       </p:sp>
       <p:sp>
         <p:nvSpPr>
-          <p:cNvPr id="7" name="">
+          <p:cNvPr id="9" name="">
             <a:extLst xmlns:a="http://schemas.openxmlformats.org/drawingml/2006/main">
               <a:ext uri="{FF2B5EF4-FFF2-40B4-BE49-F238E27FC236}">
-                <a16:creationId xmlns:a16="http://schemas.microsoft.com/office/drawing/2014/main" id="{1591DE84-6F71-428E-B7A9-03E9308EC3B0}"/>
+                <a16:creationId xmlns:a16="http://schemas.microsoft.com/office/drawing/2014/main" id="{43C7C9F7-B097-41FD-8B4E-C49478311751}"/>
               </a:ext>
             </a:extLst>
           </p:cNvPr>
@@ -7659,7 +7796,7 @@
     </p:spTree>
     <p:extLst>
       <p:ext uri="{BB962C8B-B14F-4D97-AF65-F5344CB8AC3E}">
-        <p14:creationId xmlns:p14="http://schemas.microsoft.com/office/powerpoint/2010/main" val="1753230773"/>
+        <p14:creationId xmlns:p14="http://schemas.microsoft.com/office/powerpoint/2010/main" val="1798917796"/>
       </p:ext>
     </p:extLst>
   </p:cSld>
@@ -7690,7 +7827,7 @@
           <p:cNvPr id="12" name="">
             <a:extLst xmlns:a="http://schemas.openxmlformats.org/drawingml/2006/main">
               <a:ext uri="{FF2B5EF4-FFF2-40B4-BE49-F238E27FC236}">
-                <a16:creationId xmlns:a16="http://schemas.microsoft.com/office/drawing/2014/main" id="{D80A9B6B-FFBE-4769-8FD8-78C260F3E315}"/>
+                <a16:creationId xmlns:a16="http://schemas.microsoft.com/office/drawing/2014/main" id="{B9B284BC-558D-48EF-AAFC-9802195FD924}"/>
               </a:ext>
             </a:extLst>
           </p:cNvPr>
@@ -7747,7 +7884,7 @@
           <p:cNvPr id="2" name="">
             <a:extLst xmlns:a="http://schemas.openxmlformats.org/drawingml/2006/main">
               <a:ext uri="{FF2B5EF4-FFF2-40B4-BE49-F238E27FC236}">
-                <a16:creationId xmlns:a16="http://schemas.microsoft.com/office/drawing/2014/main" id="{B95B1DE0-2524-4100-8CF6-7BEE21F1EC68}"/>
+                <a16:creationId xmlns:a16="http://schemas.microsoft.com/office/drawing/2014/main" id="{1C9AE6E5-BF83-4A46-8B14-15C4EC058083}"/>
               </a:ext>
             </a:extLst>
           </p:cNvPr>
@@ -7804,7 +7941,7 @@
           <p:cNvPr id="3" name="">
             <a:extLst xmlns:a="http://schemas.openxmlformats.org/drawingml/2006/main">
               <a:ext uri="{FF2B5EF4-FFF2-40B4-BE49-F238E27FC236}">
-                <a16:creationId xmlns:a16="http://schemas.microsoft.com/office/drawing/2014/main" id="{54C1D405-F07D-43A3-962D-4374BD2D1545}"/>
+                <a16:creationId xmlns:a16="http://schemas.microsoft.com/office/drawing/2014/main" id="{02F1044C-C249-4C72-A7A2-FB90BE217D99}"/>
               </a:ext>
             </a:extLst>
           </p:cNvPr>
@@ -7868,7 +8005,7 @@
         </p:xfrm>
         <a:graphic xmlns:a="http://schemas.openxmlformats.org/drawingml/2006/main">
           <a:graphicData uri="http://schemas.openxmlformats.org/drawingml/2006/chart">
-            <c:chart xmlns:r="http://schemas.openxmlformats.org/officeDocument/2006/relationships" xmlns:c="http://schemas.openxmlformats.org/drawingml/2006/chart" r:id="R774ca97f29534967"/>
+            <c:chart xmlns:r="http://schemas.openxmlformats.org/officeDocument/2006/relationships" xmlns:c="http://schemas.openxmlformats.org/drawingml/2006/chart" r:id="R94bf9dced78d4785"/>
           </a:graphicData>
         </a:graphic>
       </p:graphicFrame>
@@ -7877,7 +8014,7 @@
           <p:cNvPr id="5" name="">
             <a:extLst xmlns:a="http://schemas.openxmlformats.org/drawingml/2006/main">
               <a:ext uri="{FF2B5EF4-FFF2-40B4-BE49-F238E27FC236}">
-                <a16:creationId xmlns:a16="http://schemas.microsoft.com/office/drawing/2014/main" id="{89D8A43C-DB18-4CEA-99D3-90D9037E320C}"/>
+                <a16:creationId xmlns:a16="http://schemas.microsoft.com/office/drawing/2014/main" id="{E2D91EE4-61DC-4071-B64F-45A83EC089D3}"/>
               </a:ext>
             </a:extLst>
           </p:cNvPr>
@@ -7934,7 +8071,7 @@
           <p:cNvPr id="6" name="">
             <a:extLst xmlns:a="http://schemas.openxmlformats.org/drawingml/2006/main">
               <a:ext uri="{FF2B5EF4-FFF2-40B4-BE49-F238E27FC236}">
-                <a16:creationId xmlns:a16="http://schemas.microsoft.com/office/drawing/2014/main" id="{A6E35CC9-F8DD-48F2-AE0B-DD732F7AF5A7}"/>
+                <a16:creationId xmlns:a16="http://schemas.microsoft.com/office/drawing/2014/main" id="{C9B02663-9758-4045-B18D-4D138A2DDAC3}"/>
               </a:ext>
             </a:extLst>
           </p:cNvPr>
@@ -7991,7 +8128,7 @@
           <p:cNvPr id="7" name="">
             <a:extLst xmlns:a="http://schemas.openxmlformats.org/drawingml/2006/main">
               <a:ext uri="{FF2B5EF4-FFF2-40B4-BE49-F238E27FC236}">
-                <a16:creationId xmlns:a16="http://schemas.microsoft.com/office/drawing/2014/main" id="{02201935-53BF-405C-8716-1867321D6B85}"/>
+                <a16:creationId xmlns:a16="http://schemas.microsoft.com/office/drawing/2014/main" id="{2103D890-A168-44BF-B04D-42104B0FEBB7}"/>
               </a:ext>
             </a:extLst>
           </p:cNvPr>
@@ -8048,7 +8185,7 @@
           <p:cNvPr id="8" name="">
             <a:extLst xmlns:a="http://schemas.openxmlformats.org/drawingml/2006/main">
               <a:ext uri="{FF2B5EF4-FFF2-40B4-BE49-F238E27FC236}">
-                <a16:creationId xmlns:a16="http://schemas.microsoft.com/office/drawing/2014/main" id="{3253A803-5A86-42C3-A064-71C775ABA443}"/>
+                <a16:creationId xmlns:a16="http://schemas.microsoft.com/office/drawing/2014/main" id="{AAC6CCC4-C53A-4AE7-B2E5-96BEFF0C985F}"/>
               </a:ext>
             </a:extLst>
           </p:cNvPr>
@@ -8105,7 +8242,7 @@
           <p:cNvPr id="9" name="">
             <a:extLst xmlns:a="http://schemas.openxmlformats.org/drawingml/2006/main">
               <a:ext uri="{FF2B5EF4-FFF2-40B4-BE49-F238E27FC236}">
-                <a16:creationId xmlns:a16="http://schemas.microsoft.com/office/drawing/2014/main" id="{9774D6CB-1B40-40E6-9B2A-5AAB85B4746A}"/>
+                <a16:creationId xmlns:a16="http://schemas.microsoft.com/office/drawing/2014/main" id="{E5EDB073-8AC7-41CA-BD65-BAE93548E6AC}"/>
               </a:ext>
             </a:extLst>
           </p:cNvPr>
@@ -8162,7 +8299,7 @@
           <p:cNvPr id="10" name="">
             <a:extLst xmlns:a="http://schemas.openxmlformats.org/drawingml/2006/main">
               <a:ext uri="{FF2B5EF4-FFF2-40B4-BE49-F238E27FC236}">
-                <a16:creationId xmlns:a16="http://schemas.microsoft.com/office/drawing/2014/main" id="{441321F8-FCBF-4850-9DD8-96507F6D142E}"/>
+                <a16:creationId xmlns:a16="http://schemas.microsoft.com/office/drawing/2014/main" id="{8DC95117-CCD6-4A33-8726-CC589C2C5A3E}"/>
               </a:ext>
             </a:extLst>
           </p:cNvPr>
@@ -8219,7 +8356,7 @@
           <p:cNvPr id="11" name="">
             <a:extLst xmlns:a="http://schemas.openxmlformats.org/drawingml/2006/main">
               <a:ext uri="{FF2B5EF4-FFF2-40B4-BE49-F238E27FC236}">
-                <a16:creationId xmlns:a16="http://schemas.microsoft.com/office/drawing/2014/main" id="{9065420C-E203-4A55-AD94-948D72BA346B}"/>
+                <a16:creationId xmlns:a16="http://schemas.microsoft.com/office/drawing/2014/main" id="{EC718635-1D1B-4495-A8ED-5473D30D4CC1}"/>
               </a:ext>
             </a:extLst>
           </p:cNvPr>
@@ -8274,7 +8411,7 @@
     </p:spTree>
     <p:extLst>
       <p:ext uri="{BB962C8B-B14F-4D97-AF65-F5344CB8AC3E}">
-        <p14:creationId xmlns:p14="http://schemas.microsoft.com/office/powerpoint/2010/main" val="1755162290"/>
+        <p14:creationId xmlns:p14="http://schemas.microsoft.com/office/powerpoint/2010/main" val="642437264"/>
       </p:ext>
     </p:extLst>
   </p:cSld>
@@ -8305,7 +8442,7 @@
           <p:cNvPr id="8" name="">
             <a:extLst xmlns:a="http://schemas.openxmlformats.org/drawingml/2006/main">
               <a:ext uri="{FF2B5EF4-FFF2-40B4-BE49-F238E27FC236}">
-                <a16:creationId xmlns:a16="http://schemas.microsoft.com/office/drawing/2014/main" id="{DD082C56-FD94-4B62-B649-C3276BB957FD}"/>
+                <a16:creationId xmlns:a16="http://schemas.microsoft.com/office/drawing/2014/main" id="{E359D3C5-7ED1-47A0-BD6D-B8639247FD6D}"/>
               </a:ext>
             </a:extLst>
           </p:cNvPr>
@@ -8362,7 +8499,7 @@
           <p:cNvPr id="2" name="">
             <a:extLst xmlns:a="http://schemas.openxmlformats.org/drawingml/2006/main">
               <a:ext uri="{FF2B5EF4-FFF2-40B4-BE49-F238E27FC236}">
-                <a16:creationId xmlns:a16="http://schemas.microsoft.com/office/drawing/2014/main" id="{BD4ED953-A43C-4932-A8AA-B0CBA276972D}"/>
+                <a16:creationId xmlns:a16="http://schemas.microsoft.com/office/drawing/2014/main" id="{E547C8DE-80AC-4CFC-8FCB-C0211D4B5D47}"/>
               </a:ext>
             </a:extLst>
           </p:cNvPr>
@@ -8419,7 +8556,7 @@
           <p:cNvPr id="3" name="">
             <a:extLst xmlns:a="http://schemas.openxmlformats.org/drawingml/2006/main">
               <a:ext uri="{FF2B5EF4-FFF2-40B4-BE49-F238E27FC236}">
-                <a16:creationId xmlns:a16="http://schemas.microsoft.com/office/drawing/2014/main" id="{CD762081-D92A-45D5-ABA9-2207BC89C8C9}"/>
+                <a16:creationId xmlns:a16="http://schemas.microsoft.com/office/drawing/2014/main" id="{E7ED515F-05C8-4D3B-9C52-6FFADD79ABDC}"/>
               </a:ext>
             </a:extLst>
           </p:cNvPr>
@@ -8795,7 +8932,7 @@
           <p:cNvPr id="5" name="">
             <a:extLst xmlns:a="http://schemas.openxmlformats.org/drawingml/2006/main">
               <a:ext uri="{FF2B5EF4-FFF2-40B4-BE49-F238E27FC236}">
-                <a16:creationId xmlns:a16="http://schemas.microsoft.com/office/drawing/2014/main" id="{1DE8C92F-5FCE-4341-9265-E987EBAA192E}"/>
+                <a16:creationId xmlns:a16="http://schemas.microsoft.com/office/drawing/2014/main" id="{A5EFBBB2-6052-4D62-950C-419678F792E5}"/>
               </a:ext>
             </a:extLst>
           </p:cNvPr>
@@ -8852,7 +8989,7 @@
           <p:cNvPr id="6" name="">
             <a:extLst xmlns:a="http://schemas.openxmlformats.org/drawingml/2006/main">
               <a:ext uri="{FF2B5EF4-FFF2-40B4-BE49-F238E27FC236}">
-                <a16:creationId xmlns:a16="http://schemas.microsoft.com/office/drawing/2014/main" id="{0EEC2F91-F13D-4AE3-B727-98FFA5623C84}"/>
+                <a16:creationId xmlns:a16="http://schemas.microsoft.com/office/drawing/2014/main" id="{B4BDCF6B-56D0-4305-9DA3-E3CBEC109804}"/>
               </a:ext>
             </a:extLst>
           </p:cNvPr>
@@ -8909,7 +9046,7 @@
           <p:cNvPr id="7" name="">
             <a:extLst xmlns:a="http://schemas.openxmlformats.org/drawingml/2006/main">
               <a:ext uri="{FF2B5EF4-FFF2-40B4-BE49-F238E27FC236}">
-                <a16:creationId xmlns:a16="http://schemas.microsoft.com/office/drawing/2014/main" id="{9965D73E-900A-49F2-B93C-95B6BCA8DC04}"/>
+                <a16:creationId xmlns:a16="http://schemas.microsoft.com/office/drawing/2014/main" id="{A88FF3A2-44F7-46AF-9D2F-70D7D12619F0}"/>
               </a:ext>
             </a:extLst>
           </p:cNvPr>
@@ -8966,7 +9103,7 @@
                 <a:latin typeface="Apple SD Gothic Neo"/>
                 <a:ea typeface="Apple SD Gothic Neo"/>
                 <a:cs typeface="Apple SD Gothic Neo"/>
-                <a:hlinkClick xmlns:r="http://schemas.openxmlformats.org/officeDocument/2006/relationships" r:id="Raf335aa5e8c24561"/>
+                <a:hlinkClick xmlns:r="http://schemas.openxmlformats.org/officeDocument/2006/relationships" r:id="Ra1f44fc0758a43fe"/>
               </a:rPr>
               <a:t>github.com/y00nZZang/product-catalog</a:t>
             </a:r>
@@ -8976,7 +9113,7 @@
     </p:spTree>
     <p:extLst>
       <p:ext uri="{BB962C8B-B14F-4D97-AF65-F5344CB8AC3E}">
-        <p14:creationId xmlns:p14="http://schemas.microsoft.com/office/powerpoint/2010/main" val="1964270569"/>
+        <p14:creationId xmlns:p14="http://schemas.microsoft.com/office/powerpoint/2010/main" val="2038980969"/>
       </p:ext>
     </p:extLst>
   </p:cSld>
@@ -10320,7 +10457,7 @@
           <p:nvPr/>
         </p:nvPicPr>
         <p:blipFill>
-          <a:blip xmlns:r="http://schemas.openxmlformats.org/officeDocument/2006/relationships" xmlns:a="http://schemas.openxmlformats.org/drawingml/2006/main" r:embed="Rc867388c9d57432b"/>
+          <a:blip xmlns:r="http://schemas.openxmlformats.org/officeDocument/2006/relationships" xmlns:a="http://schemas.openxmlformats.org/drawingml/2006/main" r:embed="Rec4f853f77264a7b"/>
           <a:stretch xmlns:a="http://schemas.openxmlformats.org/drawingml/2006/main"/>
         </p:blipFill>
         <p:spPr>
@@ -14655,7 +14792,7 @@
           <p:nvPr/>
         </p:nvPicPr>
         <p:blipFill>
-          <a:blip xmlns:r="http://schemas.openxmlformats.org/officeDocument/2006/relationships" xmlns:a="http://schemas.openxmlformats.org/drawingml/2006/main" r:embed="Reae30a489f91448a"/>
+          <a:blip xmlns:r="http://schemas.openxmlformats.org/officeDocument/2006/relationships" xmlns:a="http://schemas.openxmlformats.org/drawingml/2006/main" r:embed="R1e34c2d461b34ae7"/>
           <a:stretch xmlns:a="http://schemas.openxmlformats.org/drawingml/2006/main"/>
         </p:blipFill>
         <p:spPr>

</xml_diff>